<commit_message>
Simplify weekly slides and show area percentages with mean latency bars
</commit_message>
<xml_diff>
--- a/presentations/weekly_20261029/weekly_20261029_english_30w.pptx
+++ b/presentations/weekly_20261029/weekly_20261029_english_30w.pptx
@@ -2,21 +2,21 @@
 <file path=ppt/presentation.xml><?xml version="1.0" encoding="utf-8"?>
 <p:presentation xmlns:p="http://schemas.openxmlformats.org/presentationml/2006/main">
   <p:sldMasterIdLst>
-    <p:sldMasterId xmlns:r="http://schemas.openxmlformats.org/officeDocument/2006/relationships" id="2147483648" r:id="R7e6e1a9f761947aa"/>
+    <p:sldMasterId xmlns:r="http://schemas.openxmlformats.org/officeDocument/2006/relationships" id="2147483648" r:id="Ra41cd06139b74b1f"/>
   </p:sldMasterIdLst>
   <p:notesMasterIdLst>
-    <p:notesMasterId xmlns:r="http://schemas.openxmlformats.org/officeDocument/2006/relationships" r:id="R4c792623bc724edb"/>
+    <p:notesMasterId xmlns:r="http://schemas.openxmlformats.org/officeDocument/2006/relationships" r:id="Rfcd6c3d41c2540ee"/>
   </p:notesMasterIdLst>
   <p:sldIdLst>
-    <p:sldId xmlns:r="http://schemas.openxmlformats.org/officeDocument/2006/relationships" id="256" r:id="Re97485de793b46a6"/>
-    <p:sldId xmlns:r="http://schemas.openxmlformats.org/officeDocument/2006/relationships" id="257" r:id="Ra26363bb1fbb4efa"/>
-    <p:sldId xmlns:r="http://schemas.openxmlformats.org/officeDocument/2006/relationships" id="258" r:id="R6caedfeb9b554efa"/>
-    <p:sldId xmlns:r="http://schemas.openxmlformats.org/officeDocument/2006/relationships" id="259" r:id="R744812f2f0e145e3"/>
-    <p:sldId xmlns:r="http://schemas.openxmlformats.org/officeDocument/2006/relationships" id="260" r:id="Rb0a937bb13f144d0"/>
-    <p:sldId xmlns:r="http://schemas.openxmlformats.org/officeDocument/2006/relationships" id="261" r:id="R22a8fc44dfb54c2a"/>
-    <p:sldId xmlns:r="http://schemas.openxmlformats.org/officeDocument/2006/relationships" id="262" r:id="R4a17a091a18145d4"/>
-    <p:sldId xmlns:r="http://schemas.openxmlformats.org/officeDocument/2006/relationships" id="263" r:id="R016f54ccdb9b46a6"/>
-    <p:sldId xmlns:r="http://schemas.openxmlformats.org/officeDocument/2006/relationships" id="264" r:id="R91e3a3a91d9b4748"/>
+    <p:sldId xmlns:r="http://schemas.openxmlformats.org/officeDocument/2006/relationships" id="256" r:id="Rcc37a2e4cbf74d8d"/>
+    <p:sldId xmlns:r="http://schemas.openxmlformats.org/officeDocument/2006/relationships" id="257" r:id="R1b812de2334e4600"/>
+    <p:sldId xmlns:r="http://schemas.openxmlformats.org/officeDocument/2006/relationships" id="258" r:id="R7cedae5321d645d2"/>
+    <p:sldId xmlns:r="http://schemas.openxmlformats.org/officeDocument/2006/relationships" id="259" r:id="Rac71f7bd83e342f1"/>
+    <p:sldId xmlns:r="http://schemas.openxmlformats.org/officeDocument/2006/relationships" id="260" r:id="R1e283448a22a402a"/>
+    <p:sldId xmlns:r="http://schemas.openxmlformats.org/officeDocument/2006/relationships" id="261" r:id="R5b0d5928b7d4412f"/>
+    <p:sldId xmlns:r="http://schemas.openxmlformats.org/officeDocument/2006/relationships" id="262" r:id="R4c020822a9de44f6"/>
+    <p:sldId xmlns:r="http://schemas.openxmlformats.org/officeDocument/2006/relationships" id="263" r:id="R609d868a1ccb4945"/>
+    <p:sldId xmlns:r="http://schemas.openxmlformats.org/officeDocument/2006/relationships" id="264" r:id="R1f0e556895bd4741"/>
   </p:sldIdLst>
   <p:sldSz cx="12192000" cy="6858000"/>
   <p:notesSz cx="6858000" cy="9144000"/>
@@ -590,7 +590,7 @@
           <a:lstStyle xmlns:a="http://schemas.openxmlformats.org/drawingml/2006/main"/>
           <a:p xmlns:a="http://schemas.openxmlformats.org/drawingml/2006/main">
             <a:r>
-              <a:t>Proposed scheduler, not implemented/validated. t_ready denotes decoded reconstruction inputs ready. T_display and safety margin must be measured/reserved. Current implementation covers fixed-center ROI reconstruction and latency profiles.</a:t>
+              <a:t>Proposed adaptive mechanism, not implemented/validated. After inputs are ready, more remaining reconstruction time allows a larger full-resolution region; less time calls for a smaller region. The half-resolution base still covers the full image. Region sizes in this schematic are illustrative, not quantitative. Current implementation covers a fixed-center FOV sweep and latency profiles.</a:t>
             </a:r>
           </a:p>
         </p:txBody>
@@ -660,7 +660,7 @@
           <a:lstStyle xmlns:a="http://schemas.openxmlformats.org/drawingml/2006/main"/>
           <a:p xmlns:a="http://schemas.openxmlformats.org/drawingml/2006/main">
             <a:r>
-              <a:t>Source: results/fov_levels_xavier_full_20261027/README.md; overview.csv; summary.csv. Commit 0f1506c. Date 2026-10-27. Raw evidence: evidence.tar.gz. Mechanism reflects current half base + padded full-resolution ROI + feather overlay. ROI dimensions are pixels, not angles.</a:t>
+              <a:t>Source: results/fov_levels_xavier_full_20261027/README.md; overview.csv; summary.csv. Commit 0f1506c. Date 2026-10-27. Raw evidence: evidence.tar.gz. Mechanism: half-resolution base + padded full-resolution ROI + feather overlay. Region percentages are spatial coverage of a 960x540 image: 80x46=0.7098765%, 160x90=2.7777778%, 320x180=11.1111111%, 480x270=25%, 640x360=44.4444444%. The base samples at 50% width and 50% height, giving 25% as many pixels (480x270), while covering the entire image. Region coverage and sampling resolution are different quantities.</a:t>
             </a:r>
           </a:p>
         </p:txBody>
@@ -800,7 +800,7 @@
           <a:lstStyle xmlns:a="http://schemas.openxmlformats.org/drawingml/2006/main"/>
           <a:p xmlns:a="http://schemas.openxmlformats.org/drawingml/2006/main">
             <a:r>
-              <a:t>Source: results/fov_levels_xavier_full_20261027/README.md; overview.csv; summary.csv. Commit 0f1506c. Date 2026-10-27. Raw evidence: evidence.tar.gz. Chart uses pooled timing medians. Full baseline is separately measured per level. Fast resample enabled. Each series value corresponds to all 1068 supported frames.</a:t>
+              <a:t>Source: results/fov_levels_xavier_full_20261027/README.md; overview.csv; summary.csv. Commit 0f1506c. Date 2026-10-27. Raw evidence: evidence.tar.gz. Arithmetic means of all 5340 timing samples in each level/timing/mode group, computed by compute_means.py into mean_timings.json. No sample trimming. Full baseline measured separately per level. Fast resample enabled. Each value covers all 1068 supported frames. Speedup is mean(full resident)/mean(FOV resident) at the same region level. Region labels are image-area coverage, not sampling resolution.</a:t>
             </a:r>
           </a:p>
         </p:txBody>
@@ -940,7 +940,7 @@
           <a:lstStyle xmlns:a="http://schemas.openxmlformats.org/drawingml/2006/main"/>
           <a:p xmlns:a="http://schemas.openxmlformats.org/drawingml/2006/main">
             <a:r>
-              <a:t>Sources: results/numba_xavier_20261029/mode7_15w/result.json and results/numba_xavier_20261029/mode5_30w/result.json. Four workloads, frame39 only, 100 samples per method. Same Numba implementation and inputs. Preallocated resident timing includes launch/synchronization; excludes JIT, allocation, transfers, I/O. Power modes: 15W Desktop mode7 and 30W 4CORE mode5. Dynamic clocks, same four CPU cores. The 30W mode raises GPU/EMC limits but lowers the CPU maximum. Original generate_right includes allocation/transfer and startup drift; it is not the resident path shown. Numba upsampling differs from optimized CUDA C++.</a:t>
+              <a:t>Sources: results/numba_xavier_20261029/mode7_15w/result.json and results/numba_xavier_20261029/mode5_30w/result.json. Arithmetic means from mean_timings.json of all 100 samples per method, four workloads, frame39 only. 15W was measured before 30W. No confidence intervals. Some startup drift remains. Same Numba implementation and inputs. Preallocated resident timing includes launch/synchronization; excludes JIT, allocation, transfers, I/O. Power modes: 15W Desktop mode7 and 30W 4CORE mode5. Dynamic clocks, same four CPU cores. The 30W mode raises GPU/EMC limits but lowers the CPU maximum. Original generate_right includes allocation/transfer and startup drift; it is not the resident path shown. Numba upsampling differs from optimized CUDA C++.</a:t>
             </a:r>
           </a:p>
         </p:txBody>
@@ -1057,7 +1057,7 @@
           <p:cNvPr id="3" name="Title">
             <a:extLst xmlns:a="http://schemas.openxmlformats.org/drawingml/2006/main">
               <a:ext uri="{FF2B5EF4-FFF2-40B4-BE49-F238E27FC236}">
-                <a16:creationId xmlns:a16="http://schemas.microsoft.com/office/drawing/2014/main" id="{78BC570A-06B2-4379-A0C3-46ADECA69767}"/>
+                <a16:creationId xmlns:a16="http://schemas.microsoft.com/office/drawing/2014/main" id="{53B0F3CA-B995-43B8-BCF6-5BF198EDE2DA}"/>
               </a:ext>
             </a:extLst>
           </p:cNvPr>
@@ -1286,7 +1286,7 @@
           <p:cNvPr id="2" name="Subtitle">
             <a:extLst xmlns:a="http://schemas.openxmlformats.org/drawingml/2006/main">
               <a:ext uri="{FF2B5EF4-FFF2-40B4-BE49-F238E27FC236}">
-                <a16:creationId xmlns:a16="http://schemas.microsoft.com/office/drawing/2014/main" id="{72441310-D5F2-4931-8106-611632EB9D08}"/>
+                <a16:creationId xmlns:a16="http://schemas.microsoft.com/office/drawing/2014/main" id="{5D4776D7-7636-467C-95F6-7EE027CDD7B8}"/>
               </a:ext>
             </a:extLst>
           </p:cNvPr>
@@ -1532,7 +1532,7 @@
           <p:cNvPr id="2" name="Section title">
             <a:extLst xmlns:a="http://schemas.openxmlformats.org/drawingml/2006/main">
               <a:ext uri="{FF2B5EF4-FFF2-40B4-BE49-F238E27FC236}">
-                <a16:creationId xmlns:a16="http://schemas.microsoft.com/office/drawing/2014/main" id="{C82450E7-AF67-41F9-BC69-6B4FA637A492}"/>
+                <a16:creationId xmlns:a16="http://schemas.microsoft.com/office/drawing/2014/main" id="{24266225-5591-4159-AB0E-7FECC30AD65A}"/>
               </a:ext>
             </a:extLst>
           </p:cNvPr>
@@ -1778,7 +1778,7 @@
           <p:cNvPr id="3" name="Title">
             <a:extLst xmlns:a="http://schemas.openxmlformats.org/drawingml/2006/main">
               <a:ext uri="{FF2B5EF4-FFF2-40B4-BE49-F238E27FC236}">
-                <a16:creationId xmlns:a16="http://schemas.microsoft.com/office/drawing/2014/main" id="{8A60F4EB-690F-44C8-A601-FA46F5368D37}"/>
+                <a16:creationId xmlns:a16="http://schemas.microsoft.com/office/drawing/2014/main" id="{A27CBAF5-30DB-4AEE-AF4C-096A620272B3}"/>
               </a:ext>
             </a:extLst>
           </p:cNvPr>
@@ -2007,7 +2007,7 @@
           <p:cNvPr id="2" name="Body">
             <a:extLst xmlns:a="http://schemas.openxmlformats.org/drawingml/2006/main">
               <a:ext uri="{FF2B5EF4-FFF2-40B4-BE49-F238E27FC236}">
-                <a16:creationId xmlns:a16="http://schemas.microsoft.com/office/drawing/2014/main" id="{6240CDF1-B497-4E88-947F-5BCC02FB8F11}"/>
+                <a16:creationId xmlns:a16="http://schemas.microsoft.com/office/drawing/2014/main" id="{39770540-F628-4A6F-95D9-37531F553B89}"/>
               </a:ext>
             </a:extLst>
           </p:cNvPr>
@@ -2253,7 +2253,7 @@
           <p:cNvPr id="4" name="Title">
             <a:extLst xmlns:a="http://schemas.openxmlformats.org/drawingml/2006/main">
               <a:ext uri="{FF2B5EF4-FFF2-40B4-BE49-F238E27FC236}">
-                <a16:creationId xmlns:a16="http://schemas.microsoft.com/office/drawing/2014/main" id="{00B5711C-B390-474D-83A2-97928D74A6FB}"/>
+                <a16:creationId xmlns:a16="http://schemas.microsoft.com/office/drawing/2014/main" id="{08EDB771-31F3-4BDC-9480-480A0777D1BA}"/>
               </a:ext>
             </a:extLst>
           </p:cNvPr>
@@ -2482,7 +2482,7 @@
           <p:cNvPr id="2" name="Left column">
             <a:extLst xmlns:a="http://schemas.openxmlformats.org/drawingml/2006/main">
               <a:ext uri="{FF2B5EF4-FFF2-40B4-BE49-F238E27FC236}">
-                <a16:creationId xmlns:a16="http://schemas.microsoft.com/office/drawing/2014/main" id="{85DB771F-F692-4DBF-8BBA-90D73A1F5466}"/>
+                <a16:creationId xmlns:a16="http://schemas.microsoft.com/office/drawing/2014/main" id="{6A36DC38-3016-46D9-ABE0-7A12A0E62F48}"/>
               </a:ext>
             </a:extLst>
           </p:cNvPr>
@@ -2711,7 +2711,7 @@
           <p:cNvPr id="3" name="Right column">
             <a:extLst xmlns:a="http://schemas.openxmlformats.org/drawingml/2006/main">
               <a:ext uri="{FF2B5EF4-FFF2-40B4-BE49-F238E27FC236}">
-                <a16:creationId xmlns:a16="http://schemas.microsoft.com/office/drawing/2014/main" id="{039F12C8-405B-4A6C-B57C-8A9F2434E26F}"/>
+                <a16:creationId xmlns:a16="http://schemas.microsoft.com/office/drawing/2014/main" id="{7705E406-60B8-49C4-8F4F-2856FE65AFCD}"/>
               </a:ext>
             </a:extLst>
           </p:cNvPr>
@@ -2957,7 +2957,7 @@
           <p:cNvPr id="3" name="Title">
             <a:extLst xmlns:a="http://schemas.openxmlformats.org/drawingml/2006/main">
               <a:ext uri="{FF2B5EF4-FFF2-40B4-BE49-F238E27FC236}">
-                <a16:creationId xmlns:a16="http://schemas.microsoft.com/office/drawing/2014/main" id="{4B18AD23-796F-457E-B2A3-0F162C67FFC7}"/>
+                <a16:creationId xmlns:a16="http://schemas.microsoft.com/office/drawing/2014/main" id="{B3FC98C5-77A7-4B03-BF0A-612F54A39D56}"/>
               </a:ext>
             </a:extLst>
           </p:cNvPr>
@@ -3186,7 +3186,7 @@
           <p:cNvPr id="2" name="Left column">
             <a:extLst xmlns:a="http://schemas.openxmlformats.org/drawingml/2006/main">
               <a:ext uri="{FF2B5EF4-FFF2-40B4-BE49-F238E27FC236}">
-                <a16:creationId xmlns:a16="http://schemas.microsoft.com/office/drawing/2014/main" id="{9A084983-2AF0-4DD0-AFAD-EDA8FCC4CC73}"/>
+                <a16:creationId xmlns:a16="http://schemas.microsoft.com/office/drawing/2014/main" id="{AC931137-9332-4C46-B79A-D2D447FA2BE8}"/>
               </a:ext>
             </a:extLst>
           </p:cNvPr>
@@ -3453,12 +3453,12 @@
   </p:cSld>
   <p:clrMap bg1="lt1" tx1="dk1" bg2="lt2" tx2="dk2" accent1="accent1" accent2="accent2" accent3="accent3" accent4="accent4" accent5="accent5" accent6="accent6" hlink="hlink" folHlink="folHlink"/>
   <p:sldLayoutIdLst>
-    <p:sldLayoutId xmlns:r="http://schemas.openxmlformats.org/officeDocument/2006/relationships" id="2147483649" r:id="Rda5bc57e517649c0"/>
-    <p:sldLayoutId xmlns:r="http://schemas.openxmlformats.org/officeDocument/2006/relationships" id="2147483650" r:id="R887a4036287148b1"/>
-    <p:sldLayoutId xmlns:r="http://schemas.openxmlformats.org/officeDocument/2006/relationships" id="2147483651" r:id="R69bb8ef3fa9b479f"/>
-    <p:sldLayoutId xmlns:r="http://schemas.openxmlformats.org/officeDocument/2006/relationships" id="2147483652" r:id="R9e7e612c86984304"/>
-    <p:sldLayoutId xmlns:r="http://schemas.openxmlformats.org/officeDocument/2006/relationships" id="2147483653" r:id="R38c9499a8e5e4bbb"/>
-    <p:sldLayoutId xmlns:r="http://schemas.openxmlformats.org/officeDocument/2006/relationships" id="2147483654" r:id="R3ffb674900d04cb3"/>
+    <p:sldLayoutId xmlns:r="http://schemas.openxmlformats.org/officeDocument/2006/relationships" id="2147483649" r:id="Rce3332a056fc4918"/>
+    <p:sldLayoutId xmlns:r="http://schemas.openxmlformats.org/officeDocument/2006/relationships" id="2147483650" r:id="R179c12af6dcf47fe"/>
+    <p:sldLayoutId xmlns:r="http://schemas.openxmlformats.org/officeDocument/2006/relationships" id="2147483651" r:id="R6cea72e1a5974a7c"/>
+    <p:sldLayoutId xmlns:r="http://schemas.openxmlformats.org/officeDocument/2006/relationships" id="2147483652" r:id="R0a834c8fcb26412b"/>
+    <p:sldLayoutId xmlns:r="http://schemas.openxmlformats.org/officeDocument/2006/relationships" id="2147483653" r:id="Rbc2ffeada08c464f"/>
+    <p:sldLayoutId xmlns:r="http://schemas.openxmlformats.org/officeDocument/2006/relationships" id="2147483654" r:id="R676f6aa6a4884b23"/>
   </p:sldLayoutIdLst>
   <p:txStyles>
     <p:titleStyle>
@@ -3990,8 +3990,9 @@
   <c:lang val="en-US"/>
   <c:chart>
     <c:plotArea>
-      <c:lineChart>
-        <c:grouping val="standard"/>
+      <c:barChart>
+        <c:barDir val="col"/>
+        <c:grouping val="clustered"/>
         <c:varyColors val="0"/>
         <c:ser>
           <c:idx val="0"/>
@@ -4004,28 +4005,26 @@
               <a:srgbClr val="086B93"/>
             </a:solidFill>
           </c:spPr>
-          <c:marker>
-            <c:symbol val="none"/>
-          </c:marker>
+          <c:invertIfNegative val="0"/>
           <c:cat>
             <c:strRef>
               <c:f>'Chart Data'!$A$2:$A$6</c:f>
               <c:strCache>
                 <c:ptCount val="5"/>
                 <c:pt idx="0">
-                  <c:v>80×46</c:v>
+                  <c:v>0.7%</c:v>
                 </c:pt>
                 <c:pt idx="1">
-                  <c:v>160×90</c:v>
+                  <c:v>2.8%</c:v>
                 </c:pt>
                 <c:pt idx="2">
-                  <c:v>320×180</c:v>
+                  <c:v>11.1%</c:v>
                 </c:pt>
                 <c:pt idx="3">
-                  <c:v>480×270</c:v>
+                  <c:v>25.0%</c:v>
                 </c:pt>
                 <c:pt idx="4">
-                  <c:v>640×360</c:v>
+                  <c:v>44.4%</c:v>
                 </c:pt>
               </c:strCache>
             </c:strRef>
@@ -4037,19 +4036,19 @@
                 <c:formatCode>General</c:formatCode>
                 <c:ptCount val="5"/>
                 <c:pt idx="0">
-                  <c:v>4.367</c:v>
+                  <c:v>4.562</c:v>
                 </c:pt>
                 <c:pt idx="1">
-                  <c:v>4.637</c:v>
+                  <c:v>4.77</c:v>
                 </c:pt>
                 <c:pt idx="2">
-                  <c:v>5.788</c:v>
+                  <c:v>5.998</c:v>
                 </c:pt>
                 <c:pt idx="3">
-                  <c:v>7.582</c:v>
+                  <c:v>7.772</c:v>
                 </c:pt>
                 <c:pt idx="4">
-                  <c:v>10.142</c:v>
+                  <c:v>10.425</c:v>
                 </c:pt>
               </c:numCache>
             </c:numRef>
@@ -4066,28 +4065,26 @@
               <a:srgbClr val="D17B28"/>
             </a:solidFill>
           </c:spPr>
-          <c:marker>
-            <c:symbol val="none"/>
-          </c:marker>
+          <c:invertIfNegative val="0"/>
           <c:cat>
             <c:strRef>
               <c:f>'Chart Data'!$C$2:$C$6</c:f>
               <c:strCache>
                 <c:ptCount val="5"/>
                 <c:pt idx="0">
-                  <c:v>80×46</c:v>
+                  <c:v>0.7%</c:v>
                 </c:pt>
                 <c:pt idx="1">
-                  <c:v>160×90</c:v>
+                  <c:v>2.8%</c:v>
                 </c:pt>
                 <c:pt idx="2">
-                  <c:v>320×180</c:v>
+                  <c:v>11.1%</c:v>
                 </c:pt>
                 <c:pt idx="3">
-                  <c:v>480×270</c:v>
+                  <c:v>25.0%</c:v>
                 </c:pt>
                 <c:pt idx="4">
-                  <c:v>640×360</c:v>
+                  <c:v>44.4%</c:v>
                 </c:pt>
               </c:strCache>
             </c:strRef>
@@ -4099,19 +4096,19 @@
                 <c:formatCode>General</c:formatCode>
                 <c:ptCount val="5"/>
                 <c:pt idx="0">
-                  <c:v>6.285</c:v>
+                  <c:v>6.364</c:v>
                 </c:pt>
                 <c:pt idx="1">
-                  <c:v>6.557</c:v>
+                  <c:v>6.728</c:v>
                 </c:pt>
                 <c:pt idx="2">
-                  <c:v>7.717</c:v>
+                  <c:v>7.839</c:v>
                 </c:pt>
                 <c:pt idx="3">
-                  <c:v>9.519</c:v>
+                  <c:v>9.655</c:v>
                 </c:pt>
                 <c:pt idx="4">
-                  <c:v>12.09</c:v>
+                  <c:v>12.193</c:v>
                 </c:pt>
               </c:numCache>
             </c:numRef>
@@ -4128,28 +4125,26 @@
               <a:srgbClr val="536675"/>
             </a:solidFill>
           </c:spPr>
-          <c:marker>
-            <c:symbol val="none"/>
-          </c:marker>
+          <c:invertIfNegative val="0"/>
           <c:cat>
             <c:strRef>
               <c:f>'Chart Data'!$E$2:$E$6</c:f>
               <c:strCache>
                 <c:ptCount val="5"/>
                 <c:pt idx="0">
-                  <c:v>80×46</c:v>
+                  <c:v>0.7%</c:v>
                 </c:pt>
                 <c:pt idx="1">
-                  <c:v>160×90</c:v>
+                  <c:v>2.8%</c:v>
                 </c:pt>
                 <c:pt idx="2">
-                  <c:v>320×180</c:v>
+                  <c:v>11.1%</c:v>
                 </c:pt>
                 <c:pt idx="3">
-                  <c:v>480×270</c:v>
+                  <c:v>25.0%</c:v>
                 </c:pt>
                 <c:pt idx="4">
-                  <c:v>640×360</c:v>
+                  <c:v>44.4%</c:v>
                 </c:pt>
               </c:strCache>
             </c:strRef>
@@ -4161,19 +4156,19 @@
                 <c:formatCode>General</c:formatCode>
                 <c:ptCount val="5"/>
                 <c:pt idx="0">
-                  <c:v>10.763</c:v>
+                  <c:v>11.187</c:v>
                 </c:pt>
                 <c:pt idx="1">
-                  <c:v>10.764</c:v>
+                  <c:v>11.022</c:v>
                 </c:pt>
                 <c:pt idx="2">
-                  <c:v>10.774</c:v>
+                  <c:v>11.144</c:v>
                 </c:pt>
                 <c:pt idx="3">
-                  <c:v>10.771</c:v>
+                  <c:v>11.042</c:v>
                 </c:pt>
                 <c:pt idx="4">
-                  <c:v>10.774</c:v>
+                  <c:v>11.087</c:v>
                 </c:pt>
               </c:numCache>
             </c:numRef>
@@ -4201,9 +4196,11 @@
           <c:showBubbleSize val="0"/>
           <c:showLeaderLines val="0"/>
         </c:dLbls>
+        <c:gapWidth val="75"/>
+        <c:overlap val="0"/>
         <c:axId val="48650112"/>
         <c:axId val="48672768"/>
-      </c:lineChart>
+      </c:barChart>
       <c:catAx>
         <c:axId val="48650112"/>
         <c:scaling>
@@ -4270,7 +4267,7 @@
                     <a:ea typeface="Arial"/>
                     <a:cs typeface="Arial"/>
                   </a:rPr>
-                  <a:t>p50 latency (ms)</a:t>
+                  <a:t>Mean latency (ms)</a:t>
                 </a:r>
               </a:p>
             </c:rich>
@@ -4381,7 +4378,7 @@
           <p:cNvPr id="5" name="">
             <a:extLst xmlns:a="http://schemas.openxmlformats.org/drawingml/2006/main">
               <a:ext uri="{FF2B5EF4-FFF2-40B4-BE49-F238E27FC236}">
-                <a16:creationId xmlns:a16="http://schemas.microsoft.com/office/drawing/2014/main" id="{EA62858D-A490-41B7-B93F-B157B0E76C09}"/>
+                <a16:creationId xmlns:a16="http://schemas.microsoft.com/office/drawing/2014/main" id="{DDB2A384-FF04-4046-A5ED-115DB2333568}"/>
               </a:ext>
             </a:extLst>
           </p:cNvPr>
@@ -4439,7 +4436,7 @@
           <p:cNvPr id="2" name="">
             <a:extLst xmlns:a="http://schemas.openxmlformats.org/drawingml/2006/main">
               <a:ext uri="{FF2B5EF4-FFF2-40B4-BE49-F238E27FC236}">
-                <a16:creationId xmlns:a16="http://schemas.microsoft.com/office/drawing/2014/main" id="{C55CDA53-1857-4493-8D50-82A9EE0E134E}"/>
+                <a16:creationId xmlns:a16="http://schemas.microsoft.com/office/drawing/2014/main" id="{8661B8C9-E005-4110-A057-69C5DC76FA8F}"/>
               </a:ext>
             </a:extLst>
           </p:cNvPr>
@@ -4484,7 +4481,7 @@
           <p:cNvPr id="3" name="">
             <a:extLst xmlns:a="http://schemas.openxmlformats.org/drawingml/2006/main">
               <a:ext uri="{FF2B5EF4-FFF2-40B4-BE49-F238E27FC236}">
-                <a16:creationId xmlns:a16="http://schemas.microsoft.com/office/drawing/2014/main" id="{BEF6244B-56F8-4D11-BD54-6BE580CAAB95}"/>
+                <a16:creationId xmlns:a16="http://schemas.microsoft.com/office/drawing/2014/main" id="{B8A586E8-9C59-42B0-9F19-B213110E2AF2}"/>
               </a:ext>
             </a:extLst>
           </p:cNvPr>
@@ -4529,7 +4526,7 @@
           <p:cNvPr id="4" name="">
             <a:extLst xmlns:a="http://schemas.openxmlformats.org/drawingml/2006/main">
               <a:ext uri="{FF2B5EF4-FFF2-40B4-BE49-F238E27FC236}">
-                <a16:creationId xmlns:a16="http://schemas.microsoft.com/office/drawing/2014/main" id="{36761E0F-3045-42DE-9037-3694679F27D5}"/>
+                <a16:creationId xmlns:a16="http://schemas.microsoft.com/office/drawing/2014/main" id="{A8B87511-E3EE-44CD-9D8B-84822E917FF5}"/>
               </a:ext>
             </a:extLst>
           </p:cNvPr>
@@ -4572,7 +4569,7 @@
     </p:spTree>
     <p:extLst>
       <p:ext uri="{BB962C8B-B14F-4D97-AF65-F5344CB8AC3E}">
-        <p14:creationId xmlns:p14="http://schemas.microsoft.com/office/powerpoint/2010/main" val="1949842194"/>
+        <p14:creationId xmlns:p14="http://schemas.microsoft.com/office/powerpoint/2010/main" val="2961831"/>
       </p:ext>
     </p:extLst>
   </p:cSld>
@@ -4603,7 +4600,7 @@
           <p:cNvPr id="29" name="">
             <a:extLst xmlns:a="http://schemas.openxmlformats.org/drawingml/2006/main">
               <a:ext uri="{FF2B5EF4-FFF2-40B4-BE49-F238E27FC236}">
-                <a16:creationId xmlns:a16="http://schemas.microsoft.com/office/drawing/2014/main" id="{B47CA339-F123-4575-AEAB-6916CAF7748F}"/>
+                <a16:creationId xmlns:a16="http://schemas.microsoft.com/office/drawing/2014/main" id="{2E063392-741F-4F85-A5DC-6719BC43EA14}"/>
               </a:ext>
             </a:extLst>
           </p:cNvPr>
@@ -4648,7 +4645,7 @@
           <p:cNvPr id="2" name="">
             <a:extLst xmlns:a="http://schemas.openxmlformats.org/drawingml/2006/main">
               <a:ext uri="{FF2B5EF4-FFF2-40B4-BE49-F238E27FC236}">
-                <a16:creationId xmlns:a16="http://schemas.microsoft.com/office/drawing/2014/main" id="{10327BB8-03D2-4146-8C86-6A581742C7F3}"/>
+                <a16:creationId xmlns:a16="http://schemas.microsoft.com/office/drawing/2014/main" id="{81CDF089-028D-40B1-B4E3-61B4BA70CA52}"/>
               </a:ext>
             </a:extLst>
           </p:cNvPr>
@@ -4678,7 +4675,7 @@
           <p:cNvPr id="3" name="">
             <a:extLst xmlns:a="http://schemas.openxmlformats.org/drawingml/2006/main">
               <a:ext uri="{FF2B5EF4-FFF2-40B4-BE49-F238E27FC236}">
-                <a16:creationId xmlns:a16="http://schemas.microsoft.com/office/drawing/2014/main" id="{80E2E8CA-9BAA-4FF0-BD69-1FC738E21062}"/>
+                <a16:creationId xmlns:a16="http://schemas.microsoft.com/office/drawing/2014/main" id="{3292FC01-CB3D-4515-8C7E-C4465174AC00}"/>
               </a:ext>
             </a:extLst>
           </p:cNvPr>
@@ -4723,7 +4720,7 @@
           <p:cNvPr id="4" name="">
             <a:extLst xmlns:a="http://schemas.openxmlformats.org/drawingml/2006/main">
               <a:ext uri="{FF2B5EF4-FFF2-40B4-BE49-F238E27FC236}">
-                <a16:creationId xmlns:a16="http://schemas.microsoft.com/office/drawing/2014/main" id="{B8F12E84-F0E3-4592-9EBD-72EF8F5FB140}"/>
+                <a16:creationId xmlns:a16="http://schemas.microsoft.com/office/drawing/2014/main" id="{0E76FE23-6168-4F52-8230-4984F9930120}"/>
               </a:ext>
             </a:extLst>
           </p:cNvPr>
@@ -4768,7 +4765,7 @@
           <p:cNvPr id="5" name="">
             <a:extLst xmlns:a="http://schemas.openxmlformats.org/drawingml/2006/main">
               <a:ext uri="{FF2B5EF4-FFF2-40B4-BE49-F238E27FC236}">
-                <a16:creationId xmlns:a16="http://schemas.microsoft.com/office/drawing/2014/main" id="{20011E05-3FD3-4B0F-9F3A-1CBD2C02DFB1}"/>
+                <a16:creationId xmlns:a16="http://schemas.microsoft.com/office/drawing/2014/main" id="{4C8FDB8A-61CB-4851-8B11-2B17EB125AB4}"/>
               </a:ext>
             </a:extLst>
           </p:cNvPr>
@@ -4813,7 +4810,7 @@
           <p:cNvPr id="6" name="">
             <a:extLst xmlns:a="http://schemas.openxmlformats.org/drawingml/2006/main">
               <a:ext uri="{FF2B5EF4-FFF2-40B4-BE49-F238E27FC236}">
-                <a16:creationId xmlns:a16="http://schemas.microsoft.com/office/drawing/2014/main" id="{AE4BE979-E80E-4F2B-9CF6-6102B2362349}"/>
+                <a16:creationId xmlns:a16="http://schemas.microsoft.com/office/drawing/2014/main" id="{1CF9A359-62B2-419D-98DF-0D6C04D8E557}"/>
               </a:ext>
             </a:extLst>
           </p:cNvPr>
@@ -4845,7 +4842,7 @@
           <p:cNvPr id="7" name="">
             <a:extLst xmlns:a="http://schemas.openxmlformats.org/drawingml/2006/main">
               <a:ext uri="{FF2B5EF4-FFF2-40B4-BE49-F238E27FC236}">
-                <a16:creationId xmlns:a16="http://schemas.microsoft.com/office/drawing/2014/main" id="{2046BD0C-8B4E-445A-89B3-D01A8492392D}"/>
+                <a16:creationId xmlns:a16="http://schemas.microsoft.com/office/drawing/2014/main" id="{11E522F5-1882-47DD-B69D-2EE29EEA3378}"/>
               </a:ext>
             </a:extLst>
           </p:cNvPr>
@@ -4877,7 +4874,7 @@
           <p:cNvPr id="8" name="">
             <a:extLst xmlns:a="http://schemas.openxmlformats.org/drawingml/2006/main">
               <a:ext uri="{FF2B5EF4-FFF2-40B4-BE49-F238E27FC236}">
-                <a16:creationId xmlns:a16="http://schemas.microsoft.com/office/drawing/2014/main" id="{5FD2DCDD-6B3B-43C7-97C8-51406688EC93}"/>
+                <a16:creationId xmlns:a16="http://schemas.microsoft.com/office/drawing/2014/main" id="{AB8C1874-3339-4177-83EA-31474ACE3026}"/>
               </a:ext>
             </a:extLst>
           </p:cNvPr>
@@ -4909,7 +4906,7 @@
           <p:cNvPr id="9" name="">
             <a:extLst xmlns:a="http://schemas.openxmlformats.org/drawingml/2006/main">
               <a:ext uri="{FF2B5EF4-FFF2-40B4-BE49-F238E27FC236}">
-                <a16:creationId xmlns:a16="http://schemas.microsoft.com/office/drawing/2014/main" id="{70F409C9-1F21-499F-B424-8B1EF3A7C869}"/>
+                <a16:creationId xmlns:a16="http://schemas.microsoft.com/office/drawing/2014/main" id="{B308A967-AB33-41A2-98AA-9D046C9C2F7F}"/>
               </a:ext>
             </a:extLst>
           </p:cNvPr>
@@ -4954,7 +4951,7 @@
           <p:cNvPr id="10" name="">
             <a:extLst xmlns:a="http://schemas.openxmlformats.org/drawingml/2006/main">
               <a:ext uri="{FF2B5EF4-FFF2-40B4-BE49-F238E27FC236}">
-                <a16:creationId xmlns:a16="http://schemas.microsoft.com/office/drawing/2014/main" id="{B081759A-0D85-4261-9974-E50975128265}"/>
+                <a16:creationId xmlns:a16="http://schemas.microsoft.com/office/drawing/2014/main" id="{2F4D20C9-35C4-48B3-8101-B9F3BB514504}"/>
               </a:ext>
             </a:extLst>
           </p:cNvPr>
@@ -4984,7 +4981,7 @@
           <p:cNvPr id="11" name="">
             <a:extLst xmlns:a="http://schemas.openxmlformats.org/drawingml/2006/main">
               <a:ext uri="{FF2B5EF4-FFF2-40B4-BE49-F238E27FC236}">
-                <a16:creationId xmlns:a16="http://schemas.microsoft.com/office/drawing/2014/main" id="{17242367-66B9-48BA-988B-734D3BE676C6}"/>
+                <a16:creationId xmlns:a16="http://schemas.microsoft.com/office/drawing/2014/main" id="{184350B4-FC84-45C3-A863-A3DCC1F07340}"/>
               </a:ext>
             </a:extLst>
           </p:cNvPr>
@@ -5029,7 +5026,7 @@
           <p:cNvPr id="12" name="">
             <a:extLst xmlns:a="http://schemas.openxmlformats.org/drawingml/2006/main">
               <a:ext uri="{FF2B5EF4-FFF2-40B4-BE49-F238E27FC236}">
-                <a16:creationId xmlns:a16="http://schemas.microsoft.com/office/drawing/2014/main" id="{A2F7B120-544D-474D-90B2-F08F0F6D4F3E}"/>
+                <a16:creationId xmlns:a16="http://schemas.microsoft.com/office/drawing/2014/main" id="{9E522627-D36D-40D1-A0C1-32118F372968}"/>
               </a:ext>
             </a:extLst>
           </p:cNvPr>
@@ -5061,7 +5058,7 @@
           <p:cNvPr id="13" name="">
             <a:extLst xmlns:a="http://schemas.openxmlformats.org/drawingml/2006/main">
               <a:ext uri="{FF2B5EF4-FFF2-40B4-BE49-F238E27FC236}">
-                <a16:creationId xmlns:a16="http://schemas.microsoft.com/office/drawing/2014/main" id="{F328B690-2EAE-4C32-8487-79DE8C5B6FBB}"/>
+                <a16:creationId xmlns:a16="http://schemas.microsoft.com/office/drawing/2014/main" id="{35D999D8-1538-4789-9DC3-C68C414EA56D}"/>
               </a:ext>
             </a:extLst>
           </p:cNvPr>
@@ -5093,7 +5090,7 @@
           <p:cNvPr id="14" name="">
             <a:extLst xmlns:a="http://schemas.openxmlformats.org/drawingml/2006/main">
               <a:ext uri="{FF2B5EF4-FFF2-40B4-BE49-F238E27FC236}">
-                <a16:creationId xmlns:a16="http://schemas.microsoft.com/office/drawing/2014/main" id="{CEE9BD0C-B328-48B4-8AD6-D1C8A139266D}"/>
+                <a16:creationId xmlns:a16="http://schemas.microsoft.com/office/drawing/2014/main" id="{5BC558EB-01D8-4BB7-B54B-20038F09277C}"/>
               </a:ext>
             </a:extLst>
           </p:cNvPr>
@@ -5125,7 +5122,7 @@
           <p:cNvPr id="15" name="">
             <a:extLst xmlns:a="http://schemas.openxmlformats.org/drawingml/2006/main">
               <a:ext uri="{FF2B5EF4-FFF2-40B4-BE49-F238E27FC236}">
-                <a16:creationId xmlns:a16="http://schemas.microsoft.com/office/drawing/2014/main" id="{1969FDD5-BAF5-4D2F-9F1E-772EF293CE5A}"/>
+                <a16:creationId xmlns:a16="http://schemas.microsoft.com/office/drawing/2014/main" id="{410EBEEE-009C-472B-BB20-8BB9C57B4A40}"/>
               </a:ext>
             </a:extLst>
           </p:cNvPr>
@@ -5170,7 +5167,7 @@
           <p:cNvPr id="16" name="">
             <a:extLst xmlns:a="http://schemas.openxmlformats.org/drawingml/2006/main">
               <a:ext uri="{FF2B5EF4-FFF2-40B4-BE49-F238E27FC236}">
-                <a16:creationId xmlns:a16="http://schemas.microsoft.com/office/drawing/2014/main" id="{C6B39AEA-16E9-4856-B06E-8F765F90CC20}"/>
+                <a16:creationId xmlns:a16="http://schemas.microsoft.com/office/drawing/2014/main" id="{BE695C71-40B7-4C27-86FF-E50F1F0CAFAD}"/>
               </a:ext>
             </a:extLst>
           </p:cNvPr>
@@ -5200,7 +5197,7 @@
           <p:cNvPr id="17" name="">
             <a:extLst xmlns:a="http://schemas.openxmlformats.org/drawingml/2006/main">
               <a:ext uri="{FF2B5EF4-FFF2-40B4-BE49-F238E27FC236}">
-                <a16:creationId xmlns:a16="http://schemas.microsoft.com/office/drawing/2014/main" id="{E888E92A-587A-497B-9769-E04C7805E461}"/>
+                <a16:creationId xmlns:a16="http://schemas.microsoft.com/office/drawing/2014/main" id="{97305A18-1F82-47EE-B864-7E1D4714C13F}"/>
               </a:ext>
             </a:extLst>
           </p:cNvPr>
@@ -5245,7 +5242,7 @@
           <p:cNvPr id="18" name="">
             <a:extLst xmlns:a="http://schemas.openxmlformats.org/drawingml/2006/main">
               <a:ext uri="{FF2B5EF4-FFF2-40B4-BE49-F238E27FC236}">
-                <a16:creationId xmlns:a16="http://schemas.microsoft.com/office/drawing/2014/main" id="{60129F8E-E7D9-438E-8FC9-8D8E9305B903}"/>
+                <a16:creationId xmlns:a16="http://schemas.microsoft.com/office/drawing/2014/main" id="{9FC688D0-F317-47AF-B4D4-64F95544E8C6}"/>
               </a:ext>
             </a:extLst>
           </p:cNvPr>
@@ -5277,7 +5274,7 @@
           <p:cNvPr id="19" name="">
             <a:extLst xmlns:a="http://schemas.openxmlformats.org/drawingml/2006/main">
               <a:ext uri="{FF2B5EF4-FFF2-40B4-BE49-F238E27FC236}">
-                <a16:creationId xmlns:a16="http://schemas.microsoft.com/office/drawing/2014/main" id="{1B6FDD27-2834-46C1-994F-6BE645D4F9A8}"/>
+                <a16:creationId xmlns:a16="http://schemas.microsoft.com/office/drawing/2014/main" id="{DAAE2591-6C85-4DA1-B085-971A30D67D51}"/>
               </a:ext>
             </a:extLst>
           </p:cNvPr>
@@ -5309,7 +5306,7 @@
           <p:cNvPr id="20" name="">
             <a:extLst xmlns:a="http://schemas.openxmlformats.org/drawingml/2006/main">
               <a:ext uri="{FF2B5EF4-FFF2-40B4-BE49-F238E27FC236}">
-                <a16:creationId xmlns:a16="http://schemas.microsoft.com/office/drawing/2014/main" id="{3B554B61-8D21-4E81-8181-79CAFB8C5A1B}"/>
+                <a16:creationId xmlns:a16="http://schemas.microsoft.com/office/drawing/2014/main" id="{A3D7A1B3-B30F-40DF-9C2F-C0F5F64A99BC}"/>
               </a:ext>
             </a:extLst>
           </p:cNvPr>
@@ -5341,7 +5338,7 @@
           <p:cNvPr id="21" name="">
             <a:extLst xmlns:a="http://schemas.openxmlformats.org/drawingml/2006/main">
               <a:ext uri="{FF2B5EF4-FFF2-40B4-BE49-F238E27FC236}">
-                <a16:creationId xmlns:a16="http://schemas.microsoft.com/office/drawing/2014/main" id="{FBC319D7-7DDD-4F74-971F-74C8FC7286EE}"/>
+                <a16:creationId xmlns:a16="http://schemas.microsoft.com/office/drawing/2014/main" id="{AA9D8C4A-4E43-4376-99F9-9FDB7E78B40D}"/>
               </a:ext>
             </a:extLst>
           </p:cNvPr>
@@ -5386,7 +5383,7 @@
           <p:cNvPr id="22" name="">
             <a:extLst xmlns:a="http://schemas.openxmlformats.org/drawingml/2006/main">
               <a:ext uri="{FF2B5EF4-FFF2-40B4-BE49-F238E27FC236}">
-                <a16:creationId xmlns:a16="http://schemas.microsoft.com/office/drawing/2014/main" id="{C7C4BFC3-04D2-4540-86FA-ECAAEF46639A}"/>
+                <a16:creationId xmlns:a16="http://schemas.microsoft.com/office/drawing/2014/main" id="{62591B25-423D-45DF-B386-1B2FE1785354}"/>
               </a:ext>
             </a:extLst>
           </p:cNvPr>
@@ -5416,7 +5413,7 @@
           <p:cNvPr id="23" name="">
             <a:extLst xmlns:a="http://schemas.openxmlformats.org/drawingml/2006/main">
               <a:ext uri="{FF2B5EF4-FFF2-40B4-BE49-F238E27FC236}">
-                <a16:creationId xmlns:a16="http://schemas.microsoft.com/office/drawing/2014/main" id="{9F2C1E83-0C64-4D30-8E5D-35A7B8F7B9CE}"/>
+                <a16:creationId xmlns:a16="http://schemas.microsoft.com/office/drawing/2014/main" id="{6634655C-4D7B-4FE0-877E-6700866BE581}"/>
               </a:ext>
             </a:extLst>
           </p:cNvPr>
@@ -5446,7 +5443,7 @@
           <p:cNvPr id="24" name="">
             <a:extLst xmlns:a="http://schemas.openxmlformats.org/drawingml/2006/main">
               <a:ext uri="{FF2B5EF4-FFF2-40B4-BE49-F238E27FC236}">
-                <a16:creationId xmlns:a16="http://schemas.microsoft.com/office/drawing/2014/main" id="{FE30BEC4-8214-4657-B290-60E8E983BEA3}"/>
+                <a16:creationId xmlns:a16="http://schemas.microsoft.com/office/drawing/2014/main" id="{0DD2E6B6-02C5-4A3F-B387-153315FAD169}"/>
               </a:ext>
             </a:extLst>
           </p:cNvPr>
@@ -5491,7 +5488,7 @@
           <p:cNvPr id="25" name="">
             <a:extLst xmlns:a="http://schemas.openxmlformats.org/drawingml/2006/main">
               <a:ext uri="{FF2B5EF4-FFF2-40B4-BE49-F238E27FC236}">
-                <a16:creationId xmlns:a16="http://schemas.microsoft.com/office/drawing/2014/main" id="{F7FA8828-D930-4157-BE20-86A6753808B4}"/>
+                <a16:creationId xmlns:a16="http://schemas.microsoft.com/office/drawing/2014/main" id="{F69680EB-96B8-4A72-904D-F2F823E457CC}"/>
               </a:ext>
             </a:extLst>
           </p:cNvPr>
@@ -5536,7 +5533,7 @@
           <p:cNvPr id="26" name="">
             <a:extLst xmlns:a="http://schemas.openxmlformats.org/drawingml/2006/main">
               <a:ext uri="{FF2B5EF4-FFF2-40B4-BE49-F238E27FC236}">
-                <a16:creationId xmlns:a16="http://schemas.microsoft.com/office/drawing/2014/main" id="{43532525-97BB-4DFC-8028-4770A7DE9AC8}"/>
+                <a16:creationId xmlns:a16="http://schemas.microsoft.com/office/drawing/2014/main" id="{2730D76E-EDFF-4020-93DE-811F40BCC058}"/>
               </a:ext>
             </a:extLst>
           </p:cNvPr>
@@ -5581,7 +5578,7 @@
           <p:cNvPr id="27" name="">
             <a:extLst xmlns:a="http://schemas.openxmlformats.org/drawingml/2006/main">
               <a:ext uri="{FF2B5EF4-FFF2-40B4-BE49-F238E27FC236}">
-                <a16:creationId xmlns:a16="http://schemas.microsoft.com/office/drawing/2014/main" id="{763A4442-9BE9-4133-BBDA-D2EABB7A18BD}"/>
+                <a16:creationId xmlns:a16="http://schemas.microsoft.com/office/drawing/2014/main" id="{CA735592-6A12-4863-AE16-C93931024812}"/>
               </a:ext>
             </a:extLst>
           </p:cNvPr>
@@ -5626,7 +5623,7 @@
           <p:cNvPr id="28" name="">
             <a:extLst xmlns:a="http://schemas.openxmlformats.org/drawingml/2006/main">
               <a:ext uri="{FF2B5EF4-FFF2-40B4-BE49-F238E27FC236}">
-                <a16:creationId xmlns:a16="http://schemas.microsoft.com/office/drawing/2014/main" id="{03293ECC-B703-4637-BB18-D8D19E834E18}"/>
+                <a16:creationId xmlns:a16="http://schemas.microsoft.com/office/drawing/2014/main" id="{9CED6A45-CD50-4694-82E8-D872D517EDBB}"/>
               </a:ext>
             </a:extLst>
           </p:cNvPr>
@@ -5669,7 +5666,7 @@
     </p:spTree>
     <p:extLst>
       <p:ext uri="{BB962C8B-B14F-4D97-AF65-F5344CB8AC3E}">
-        <p14:creationId xmlns:p14="http://schemas.microsoft.com/office/powerpoint/2010/main" val="639733933"/>
+        <p14:creationId xmlns:p14="http://schemas.microsoft.com/office/powerpoint/2010/main" val="2062102666"/>
       </p:ext>
     </p:extLst>
   </p:cSld>
@@ -5697,10 +5694,10 @@
       </p:grpSpPr>
       <p:sp>
         <p:nvSpPr>
-          <p:cNvPr id="22" name="">
-            <a:extLst xmlns:a="http://schemas.openxmlformats.org/drawingml/2006/main">
-              <a:ext uri="{FF2B5EF4-FFF2-40B4-BE49-F238E27FC236}">
-                <a16:creationId xmlns:a16="http://schemas.microsoft.com/office/drawing/2014/main" id="{BE549948-4DC2-4FC1-BCB8-4F431CF0A57A}"/>
+          <p:cNvPr id="15" name="">
+            <a:extLst xmlns:a="http://schemas.openxmlformats.org/drawingml/2006/main">
+              <a:ext uri="{FF2B5EF4-FFF2-40B4-BE49-F238E27FC236}">
+                <a16:creationId xmlns:a16="http://schemas.microsoft.com/office/drawing/2014/main" id="{FECE25B3-EA91-46C9-BA2F-885CFC473553}"/>
               </a:ext>
             </a:extLst>
           </p:cNvPr>
@@ -5735,7 +5732,7 @@
                 <a:ea typeface="Arial"/>
                 <a:cs typeface="Arial"/>
               </a:rPr>
-              <a:t>Budget-based reconstruction selection</a:t>
+              <a:t>Adapt the full-resolution region to available time</a:t>
             </a:r>
           </a:p>
         </p:txBody>
@@ -5745,7 +5742,7 @@
           <p:cNvPr id="2" name="">
             <a:extLst xmlns:a="http://schemas.openxmlformats.org/drawingml/2006/main">
               <a:ext uri="{FF2B5EF4-FFF2-40B4-BE49-F238E27FC236}">
-                <a16:creationId xmlns:a16="http://schemas.microsoft.com/office/drawing/2014/main" id="{FB02FD78-78AC-486A-B2D2-B4379C0BA45C}"/>
+                <a16:creationId xmlns:a16="http://schemas.microsoft.com/office/drawing/2014/main" id="{1992ED6E-33E7-40CF-B909-8CC55A0C4730}"/>
               </a:ext>
             </a:extLst>
           </p:cNvPr>
@@ -5775,7 +5772,7 @@
           <p:cNvPr id="3" name="">
             <a:extLst xmlns:a="http://schemas.openxmlformats.org/drawingml/2006/main">
               <a:ext uri="{FF2B5EF4-FFF2-40B4-BE49-F238E27FC236}">
-                <a16:creationId xmlns:a16="http://schemas.microsoft.com/office/drawing/2014/main" id="{12A12563-E7A9-4515-80FD-B5AC4ABB207C}"/>
+                <a16:creationId xmlns:a16="http://schemas.microsoft.com/office/drawing/2014/main" id="{4C4B68CD-6C11-4985-960E-AC7D20599983}"/>
               </a:ext>
             </a:extLst>
           </p:cNvPr>
@@ -5820,7 +5817,7 @@
           <p:cNvPr id="4" name="">
             <a:extLst xmlns:a="http://schemas.openxmlformats.org/drawingml/2006/main">
               <a:ext uri="{FF2B5EF4-FFF2-40B4-BE49-F238E27FC236}">
-                <a16:creationId xmlns:a16="http://schemas.microsoft.com/office/drawing/2014/main" id="{615CA994-079E-4252-9532-937E0BA86C07}"/>
+                <a16:creationId xmlns:a16="http://schemas.microsoft.com/office/drawing/2014/main" id="{DED681BD-EFC1-4572-8FD3-465FA69AFBCD}"/>
               </a:ext>
             </a:extLst>
           </p:cNvPr>
@@ -5831,8 +5828,117 @@
         </p:nvSpPr>
         <p:spPr>
           <a:xfrm xmlns:a="http://schemas.openxmlformats.org/drawingml/2006/main">
-            <a:off x="609600" y="2171700"/>
-            <a:ext cx="1943100" cy="1219200"/>
+            <a:off x="609600" y="2219325"/>
+            <a:ext cx="3333750" cy="552450"/>
+          </a:xfrm>
+          <a:prstGeom xmlns:a="http://schemas.openxmlformats.org/drawingml/2006/main" prst="rect">
+            <a:avLst/>
+          </a:prstGeom>
+          <a:noFill xmlns:a="http://schemas.openxmlformats.org/drawingml/2006/main"/>
+          <a:ln xmlns:a="http://schemas.openxmlformats.org/drawingml/2006/main" w="0">
+            <a:noFill/>
+          </a:ln>
+        </p:spPr>
+        <p:txBody>
+          <a:bodyPr xmlns:a="http://schemas.openxmlformats.org/drawingml/2006/main" lIns="0" tIns="0" rIns="0" bIns="0"/>
+          <a:lstStyle xmlns:a="http://schemas.openxmlformats.org/drawingml/2006/main"/>
+          <a:p xmlns:a="http://schemas.openxmlformats.org/drawingml/2006/main">
+            <a:r>
+              <a:rPr sz="2925" b="1">
+                <a:solidFill>
+                  <a:srgbClr val="086B93"/>
+                </a:solidFill>
+                <a:latin typeface="Arial"/>
+                <a:ea typeface="Arial"/>
+                <a:cs typeface="Arial"/>
+              </a:rPr>
+              <a:t>More time</a:t>
+            </a:r>
+          </a:p>
+        </p:txBody>
+      </p:sp>
+      <p:sp>
+        <p:nvSpPr>
+          <p:cNvPr id="5" name="">
+            <a:extLst xmlns:a="http://schemas.openxmlformats.org/drawingml/2006/main">
+              <a:ext uri="{FF2B5EF4-FFF2-40B4-BE49-F238E27FC236}">
+                <a16:creationId xmlns:a16="http://schemas.microsoft.com/office/drawing/2014/main" id="{C69E7F0D-8077-4629-ABBC-A90F907A6F94}"/>
+              </a:ext>
+            </a:extLst>
+          </p:cNvPr>
+          <p:cNvSpPr>
+            <a:spLocks xmlns:a="http://schemas.openxmlformats.org/drawingml/2006/main" noGrp="1"/>
+          </p:cNvSpPr>
+          <p:nvPr/>
+        </p:nvSpPr>
+        <p:spPr>
+          <a:xfrm xmlns:a="http://schemas.openxmlformats.org/drawingml/2006/main">
+            <a:off x="3238500" y="2362200"/>
+            <a:ext cx="1333500" cy="238125"/>
+          </a:xfrm>
+          <a:prstGeom xmlns:a="http://schemas.openxmlformats.org/drawingml/2006/main" prst="rightArrow">
+            <a:avLst/>
+          </a:prstGeom>
+          <a:solidFill xmlns:a="http://schemas.openxmlformats.org/drawingml/2006/main">
+            <a:srgbClr val="086B93"/>
+          </a:solidFill>
+          <a:ln xmlns:a="http://schemas.openxmlformats.org/drawingml/2006/main" w="0">
+            <a:solidFill>
+              <a:srgbClr val="086B93"/>
+            </a:solidFill>
+          </a:ln>
+        </p:spPr>
+      </p:sp>
+      <p:sp>
+        <p:nvSpPr>
+          <p:cNvPr id="6" name="">
+            <a:extLst xmlns:a="http://schemas.openxmlformats.org/drawingml/2006/main">
+              <a:ext uri="{FF2B5EF4-FFF2-40B4-BE49-F238E27FC236}">
+                <a16:creationId xmlns:a16="http://schemas.microsoft.com/office/drawing/2014/main" id="{F7D02B66-0BE3-4C09-8BE4-7D6285CCA98D}"/>
+              </a:ext>
+            </a:extLst>
+          </p:cNvPr>
+          <p:cNvSpPr>
+            <a:spLocks xmlns:a="http://schemas.openxmlformats.org/drawingml/2006/main" noGrp="1"/>
+          </p:cNvSpPr>
+          <p:nvPr/>
+        </p:nvSpPr>
+        <p:spPr>
+          <a:xfrm xmlns:a="http://schemas.openxmlformats.org/drawingml/2006/main">
+            <a:off x="5095875" y="1714500"/>
+            <a:ext cx="6191250" cy="1476375"/>
+          </a:xfrm>
+          <a:prstGeom xmlns:a="http://schemas.openxmlformats.org/drawingml/2006/main" prst="rect">
+            <a:avLst/>
+          </a:prstGeom>
+          <a:solidFill xmlns:a="http://schemas.openxmlformats.org/drawingml/2006/main">
+            <a:srgbClr val="EAF3F6"/>
+          </a:solidFill>
+          <a:ln xmlns:a="http://schemas.openxmlformats.org/drawingml/2006/main" w="14288">
+            <a:solidFill>
+              <a:srgbClr val="D7DFE5"/>
+            </a:solidFill>
+          </a:ln>
+        </p:spPr>
+      </p:sp>
+      <p:sp>
+        <p:nvSpPr>
+          <p:cNvPr id="7" name="">
+            <a:extLst xmlns:a="http://schemas.openxmlformats.org/drawingml/2006/main">
+              <a:ext uri="{FF2B5EF4-FFF2-40B4-BE49-F238E27FC236}">
+                <a16:creationId xmlns:a16="http://schemas.microsoft.com/office/drawing/2014/main" id="{81410DC1-E3A8-42CC-B843-2123B3FB3EE9}"/>
+              </a:ext>
+            </a:extLst>
+          </p:cNvPr>
+          <p:cNvSpPr>
+            <a:spLocks xmlns:a="http://schemas.openxmlformats.org/drawingml/2006/main" noGrp="1"/>
+          </p:cNvSpPr>
+          <p:nvPr/>
+        </p:nvSpPr>
+        <p:spPr>
+          <a:xfrm xmlns:a="http://schemas.openxmlformats.org/drawingml/2006/main">
+            <a:off x="6381750" y="1905000"/>
+            <a:ext cx="3619500" cy="1095375"/>
           </a:xfrm>
           <a:prstGeom xmlns:a="http://schemas.openxmlformats.org/drawingml/2006/main" prst="rect">
             <a:avLst/>
@@ -5849,10 +5955,10 @@
       </p:sp>
       <p:sp>
         <p:nvSpPr>
-          <p:cNvPr id="5" name="">
-            <a:extLst xmlns:a="http://schemas.openxmlformats.org/drawingml/2006/main">
-              <a:ext uri="{FF2B5EF4-FFF2-40B4-BE49-F238E27FC236}">
-                <a16:creationId xmlns:a16="http://schemas.microsoft.com/office/drawing/2014/main" id="{F5A5948F-22A1-4D9C-8536-1FFAA33669BB}"/>
+          <p:cNvPr id="8" name="">
+            <a:extLst xmlns:a="http://schemas.openxmlformats.org/drawingml/2006/main">
+              <a:ext uri="{FF2B5EF4-FFF2-40B4-BE49-F238E27FC236}">
+                <a16:creationId xmlns:a16="http://schemas.microsoft.com/office/drawing/2014/main" id="{2A7E3BCB-0C34-4D83-AA4D-EEDE9D593551}"/>
               </a:ext>
             </a:extLst>
           </p:cNvPr>
@@ -5863,8 +5969,8 @@
         </p:nvSpPr>
         <p:spPr>
           <a:xfrm xmlns:a="http://schemas.openxmlformats.org/drawingml/2006/main">
-            <a:off x="742950" y="2438400"/>
-            <a:ext cx="1676400" cy="857250"/>
+            <a:off x="6153150" y="3333750"/>
+            <a:ext cx="5286375" cy="428625"/>
           </a:xfrm>
           <a:prstGeom xmlns:a="http://schemas.openxmlformats.org/drawingml/2006/main" prst="rect">
             <a:avLst/>
@@ -5879,38 +5985,25 @@
           <a:lstStyle xmlns:a="http://schemas.openxmlformats.org/drawingml/2006/main"/>
           <a:p xmlns:a="http://schemas.openxmlformats.org/drawingml/2006/main">
             <a:r>
-              <a:rPr sz="1875" b="1">
-                <a:solidFill>
-                  <a:srgbClr val="152D43"/>
+              <a:rPr sz="2175" b="1">
+                <a:solidFill>
+                  <a:srgbClr val="086B93"/>
                 </a:solidFill>
                 <a:latin typeface="Arial"/>
                 <a:ea typeface="Arial"/>
                 <a:cs typeface="Arial"/>
               </a:rPr>
-              <a:t>Inputs ready</a:t>
-            </a:r>
-          </a:p>
-          <a:p xmlns:a="http://schemas.openxmlformats.org/drawingml/2006/main">
-            <a:r>
-              <a:rPr sz="1875" b="1">
-                <a:solidFill>
-                  <a:srgbClr val="152D43"/>
-                </a:solidFill>
-                <a:latin typeface="Arial"/>
-                <a:ea typeface="Arial"/>
-                <a:cs typeface="Arial"/>
-              </a:rPr>
-              <a:t>(after decode)</a:t>
+              <a:t>Larger full-resolution region</a:t>
             </a:r>
           </a:p>
         </p:txBody>
       </p:sp>
       <p:sp>
         <p:nvSpPr>
-          <p:cNvPr id="6" name="">
-            <a:extLst xmlns:a="http://schemas.openxmlformats.org/drawingml/2006/main">
-              <a:ext uri="{FF2B5EF4-FFF2-40B4-BE49-F238E27FC236}">
-                <a16:creationId xmlns:a16="http://schemas.microsoft.com/office/drawing/2014/main" id="{AFAB0510-0383-4D52-90A2-D4B517352E4F}"/>
+          <p:cNvPr id="9" name="">
+            <a:extLst xmlns:a="http://schemas.openxmlformats.org/drawingml/2006/main">
+              <a:ext uri="{FF2B5EF4-FFF2-40B4-BE49-F238E27FC236}">
+                <a16:creationId xmlns:a16="http://schemas.microsoft.com/office/drawing/2014/main" id="{B5CEB872-5FCB-483A-A1C2-DF2926CFE0C9}"/>
               </a:ext>
             </a:extLst>
           </p:cNvPr>
@@ -5921,72 +6014,8 @@
         </p:nvSpPr>
         <p:spPr>
           <a:xfrm xmlns:a="http://schemas.openxmlformats.org/drawingml/2006/main">
-            <a:off x="2590800" y="2686050"/>
-            <a:ext cx="219075" cy="171450"/>
-          </a:xfrm>
-          <a:prstGeom xmlns:a="http://schemas.openxmlformats.org/drawingml/2006/main" prst="rightArrow">
-            <a:avLst/>
-          </a:prstGeom>
-          <a:solidFill xmlns:a="http://schemas.openxmlformats.org/drawingml/2006/main">
-            <a:srgbClr val="086B93"/>
-          </a:solidFill>
-          <a:ln xmlns:a="http://schemas.openxmlformats.org/drawingml/2006/main" w="0">
-            <a:solidFill>
-              <a:srgbClr val="086B93"/>
-            </a:solidFill>
-          </a:ln>
-        </p:spPr>
-      </p:sp>
-      <p:sp>
-        <p:nvSpPr>
-          <p:cNvPr id="7" name="">
-            <a:extLst xmlns:a="http://schemas.openxmlformats.org/drawingml/2006/main">
-              <a:ext uri="{FF2B5EF4-FFF2-40B4-BE49-F238E27FC236}">
-                <a16:creationId xmlns:a16="http://schemas.microsoft.com/office/drawing/2014/main" id="{DA3A97F7-7DEC-4C4A-85E1-586BCEC75354}"/>
-              </a:ext>
-            </a:extLst>
-          </p:cNvPr>
-          <p:cNvSpPr>
-            <a:spLocks xmlns:a="http://schemas.openxmlformats.org/drawingml/2006/main" noGrp="1"/>
-          </p:cNvSpPr>
-          <p:nvPr/>
-        </p:nvSpPr>
-        <p:spPr>
-          <a:xfrm xmlns:a="http://schemas.openxmlformats.org/drawingml/2006/main">
-            <a:off x="2819400" y="2171700"/>
-            <a:ext cx="1943100" cy="1219200"/>
-          </a:xfrm>
-          <a:prstGeom xmlns:a="http://schemas.openxmlformats.org/drawingml/2006/main" prst="rect">
-            <a:avLst/>
-          </a:prstGeom>
-          <a:solidFill xmlns:a="http://schemas.openxmlformats.org/drawingml/2006/main">
-            <a:srgbClr val="FFFFFF"/>
-          </a:solidFill>
-          <a:ln xmlns:a="http://schemas.openxmlformats.org/drawingml/2006/main" w="14288">
-            <a:solidFill>
-              <a:srgbClr val="086B93"/>
-            </a:solidFill>
-          </a:ln>
-        </p:spPr>
-      </p:sp>
-      <p:sp>
-        <p:nvSpPr>
-          <p:cNvPr id="8" name="">
-            <a:extLst xmlns:a="http://schemas.openxmlformats.org/drawingml/2006/main">
-              <a:ext uri="{FF2B5EF4-FFF2-40B4-BE49-F238E27FC236}">
-                <a16:creationId xmlns:a16="http://schemas.microsoft.com/office/drawing/2014/main" id="{C967F145-2DE6-4A52-8AD6-D19B393C7B03}"/>
-              </a:ext>
-            </a:extLst>
-          </p:cNvPr>
-          <p:cNvSpPr>
-            <a:spLocks xmlns:a="http://schemas.openxmlformats.org/drawingml/2006/main" noGrp="1"/>
-          </p:cNvSpPr>
-          <p:nvPr/>
-        </p:nvSpPr>
-        <p:spPr>
-          <a:xfrm xmlns:a="http://schemas.openxmlformats.org/drawingml/2006/main">
-            <a:off x="2952750" y="2438400"/>
-            <a:ext cx="1676400" cy="857250"/>
+            <a:off x="609600" y="4248150"/>
+            <a:ext cx="3333750" cy="552450"/>
           </a:xfrm>
           <a:prstGeom xmlns:a="http://schemas.openxmlformats.org/drawingml/2006/main" prst="rect">
             <a:avLst/>
@@ -6001,38 +6030,25 @@
           <a:lstStyle xmlns:a="http://schemas.openxmlformats.org/drawingml/2006/main"/>
           <a:p xmlns:a="http://schemas.openxmlformats.org/drawingml/2006/main">
             <a:r>
-              <a:rPr sz="1875" b="1">
-                <a:solidFill>
-                  <a:srgbClr val="152D43"/>
+              <a:rPr sz="2925" b="1">
+                <a:solidFill>
+                  <a:srgbClr val="148B83"/>
                 </a:solidFill>
                 <a:latin typeface="Arial"/>
                 <a:ea typeface="Arial"/>
                 <a:cs typeface="Arial"/>
               </a:rPr>
-              <a:t>Estimate</a:t>
-            </a:r>
-          </a:p>
-          <a:p xmlns:a="http://schemas.openxmlformats.org/drawingml/2006/main">
-            <a:r>
-              <a:rPr sz="1875" b="1">
-                <a:solidFill>
-                  <a:srgbClr val="152D43"/>
-                </a:solidFill>
-                <a:latin typeface="Arial"/>
-                <a:ea typeface="Arial"/>
-                <a:cs typeface="Arial"/>
-              </a:rPr>
-              <a:t>budget B</a:t>
+              <a:t>Less time</a:t>
             </a:r>
           </a:p>
         </p:txBody>
       </p:sp>
       <p:sp>
         <p:nvSpPr>
-          <p:cNvPr id="9" name="">
-            <a:extLst xmlns:a="http://schemas.openxmlformats.org/drawingml/2006/main">
-              <a:ext uri="{FF2B5EF4-FFF2-40B4-BE49-F238E27FC236}">
-                <a16:creationId xmlns:a16="http://schemas.microsoft.com/office/drawing/2014/main" id="{1F1F936A-34DF-4B7B-A638-856463CCCB63}"/>
+          <p:cNvPr id="10" name="">
+            <a:extLst xmlns:a="http://schemas.openxmlformats.org/drawingml/2006/main">
+              <a:ext uri="{FF2B5EF4-FFF2-40B4-BE49-F238E27FC236}">
+                <a16:creationId xmlns:a16="http://schemas.microsoft.com/office/drawing/2014/main" id="{6D8AE9A6-9964-4F55-A13D-F87955F66BDB}"/>
               </a:ext>
             </a:extLst>
           </p:cNvPr>
@@ -6043,28 +6059,28 @@
         </p:nvSpPr>
         <p:spPr>
           <a:xfrm xmlns:a="http://schemas.openxmlformats.org/drawingml/2006/main">
-            <a:off x="4800600" y="2686050"/>
-            <a:ext cx="219075" cy="171450"/>
+            <a:off x="3238500" y="4391025"/>
+            <a:ext cx="1333500" cy="238125"/>
           </a:xfrm>
           <a:prstGeom xmlns:a="http://schemas.openxmlformats.org/drawingml/2006/main" prst="rightArrow">
             <a:avLst/>
           </a:prstGeom>
           <a:solidFill xmlns:a="http://schemas.openxmlformats.org/drawingml/2006/main">
-            <a:srgbClr val="086B93"/>
+            <a:srgbClr val="148B83"/>
           </a:solidFill>
           <a:ln xmlns:a="http://schemas.openxmlformats.org/drawingml/2006/main" w="0">
             <a:solidFill>
-              <a:srgbClr val="086B93"/>
+              <a:srgbClr val="148B83"/>
             </a:solidFill>
           </a:ln>
         </p:spPr>
       </p:sp>
       <p:sp>
         <p:nvSpPr>
-          <p:cNvPr id="10" name="">
-            <a:extLst xmlns:a="http://schemas.openxmlformats.org/drawingml/2006/main">
-              <a:ext uri="{FF2B5EF4-FFF2-40B4-BE49-F238E27FC236}">
-                <a16:creationId xmlns:a16="http://schemas.microsoft.com/office/drawing/2014/main" id="{6D741F67-A959-49D1-96F4-E23E52DE2244}"/>
+          <p:cNvPr id="11" name="">
+            <a:extLst xmlns:a="http://schemas.openxmlformats.org/drawingml/2006/main">
+              <a:ext uri="{FF2B5EF4-FFF2-40B4-BE49-F238E27FC236}">
+                <a16:creationId xmlns:a16="http://schemas.microsoft.com/office/drawing/2014/main" id="{DD7C5BD7-B00C-4A09-9F85-B1FE3533122A}"/>
               </a:ext>
             </a:extLst>
           </p:cNvPr>
@@ -6075,28 +6091,28 @@
         </p:nvSpPr>
         <p:spPr>
           <a:xfrm xmlns:a="http://schemas.openxmlformats.org/drawingml/2006/main">
-            <a:off x="5029200" y="2171700"/>
-            <a:ext cx="1943100" cy="1219200"/>
+            <a:off x="5095875" y="3857625"/>
+            <a:ext cx="6191250" cy="1476375"/>
           </a:xfrm>
           <a:prstGeom xmlns:a="http://schemas.openxmlformats.org/drawingml/2006/main" prst="rect">
             <a:avLst/>
           </a:prstGeom>
           <a:solidFill xmlns:a="http://schemas.openxmlformats.org/drawingml/2006/main">
-            <a:srgbClr val="FFFFFF"/>
+            <a:srgbClr val="EAF3F6"/>
           </a:solidFill>
           <a:ln xmlns:a="http://schemas.openxmlformats.org/drawingml/2006/main" w="14288">
             <a:solidFill>
-              <a:srgbClr val="086B93"/>
+              <a:srgbClr val="D7DFE5"/>
             </a:solidFill>
           </a:ln>
         </p:spPr>
       </p:sp>
       <p:sp>
         <p:nvSpPr>
-          <p:cNvPr id="11" name="">
-            <a:extLst xmlns:a="http://schemas.openxmlformats.org/drawingml/2006/main">
-              <a:ext uri="{FF2B5EF4-FFF2-40B4-BE49-F238E27FC236}">
-                <a16:creationId xmlns:a16="http://schemas.microsoft.com/office/drawing/2014/main" id="{0C8C299D-E820-4140-AB67-0BA8CB2D2684}"/>
+          <p:cNvPr id="12" name="">
+            <a:extLst xmlns:a="http://schemas.openxmlformats.org/drawingml/2006/main">
+              <a:ext uri="{FF2B5EF4-FFF2-40B4-BE49-F238E27FC236}">
+                <a16:creationId xmlns:a16="http://schemas.microsoft.com/office/drawing/2014/main" id="{38EB2678-6646-4863-872B-00FD2DC9862B}"/>
               </a:ext>
             </a:extLst>
           </p:cNvPr>
@@ -6107,104 +6123,14 @@
         </p:nvSpPr>
         <p:spPr>
           <a:xfrm xmlns:a="http://schemas.openxmlformats.org/drawingml/2006/main">
-            <a:off x="5162550" y="2438400"/>
-            <a:ext cx="1676400" cy="857250"/>
+            <a:off x="7667625" y="4305300"/>
+            <a:ext cx="1047750" cy="590550"/>
           </a:xfrm>
           <a:prstGeom xmlns:a="http://schemas.openxmlformats.org/drawingml/2006/main" prst="rect">
             <a:avLst/>
           </a:prstGeom>
-          <a:noFill xmlns:a="http://schemas.openxmlformats.org/drawingml/2006/main"/>
-          <a:ln xmlns:a="http://schemas.openxmlformats.org/drawingml/2006/main" w="0">
-            <a:noFill/>
-          </a:ln>
-        </p:spPr>
-        <p:txBody>
-          <a:bodyPr xmlns:a="http://schemas.openxmlformats.org/drawingml/2006/main" lIns="0" tIns="0" rIns="0" bIns="0"/>
-          <a:lstStyle xmlns:a="http://schemas.openxmlformats.org/drawingml/2006/main"/>
-          <a:p xmlns:a="http://schemas.openxmlformats.org/drawingml/2006/main">
-            <a:r>
-              <a:rPr sz="1875" b="1">
-                <a:solidFill>
-                  <a:srgbClr val="152D43"/>
-                </a:solidFill>
-                <a:latin typeface="Arial"/>
-                <a:ea typeface="Arial"/>
-                <a:cs typeface="Arial"/>
-              </a:rPr>
-              <a:t>Latency profile</a:t>
-            </a:r>
-          </a:p>
-          <a:p xmlns:a="http://schemas.openxmlformats.org/drawingml/2006/main">
-            <a:r>
-              <a:rPr sz="1875" b="1">
-                <a:solidFill>
-                  <a:srgbClr val="152D43"/>
-                </a:solidFill>
-                <a:latin typeface="Arial"/>
-                <a:ea typeface="Arial"/>
-                <a:cs typeface="Arial"/>
-              </a:rPr>
-              <a:t>ROI selection</a:t>
-            </a:r>
-          </a:p>
-        </p:txBody>
-      </p:sp>
-      <p:sp>
-        <p:nvSpPr>
-          <p:cNvPr id="12" name="">
-            <a:extLst xmlns:a="http://schemas.openxmlformats.org/drawingml/2006/main">
-              <a:ext uri="{FF2B5EF4-FFF2-40B4-BE49-F238E27FC236}">
-                <a16:creationId xmlns:a16="http://schemas.microsoft.com/office/drawing/2014/main" id="{A0382B64-8E2E-4D24-B118-ECA7CA494834}"/>
-              </a:ext>
-            </a:extLst>
-          </p:cNvPr>
-          <p:cNvSpPr>
-            <a:spLocks xmlns:a="http://schemas.openxmlformats.org/drawingml/2006/main" noGrp="1"/>
-          </p:cNvSpPr>
-          <p:nvPr/>
-        </p:nvSpPr>
-        <p:spPr>
-          <a:xfrm xmlns:a="http://schemas.openxmlformats.org/drawingml/2006/main">
-            <a:off x="7010400" y="2686050"/>
-            <a:ext cx="219075" cy="171450"/>
-          </a:xfrm>
-          <a:prstGeom xmlns:a="http://schemas.openxmlformats.org/drawingml/2006/main" prst="rightArrow">
-            <a:avLst/>
-          </a:prstGeom>
           <a:solidFill xmlns:a="http://schemas.openxmlformats.org/drawingml/2006/main">
-            <a:srgbClr val="086B93"/>
-          </a:solidFill>
-          <a:ln xmlns:a="http://schemas.openxmlformats.org/drawingml/2006/main" w="0">
-            <a:solidFill>
-              <a:srgbClr val="086B93"/>
-            </a:solidFill>
-          </a:ln>
-        </p:spPr>
-      </p:sp>
-      <p:sp>
-        <p:nvSpPr>
-          <p:cNvPr id="13" name="">
-            <a:extLst xmlns:a="http://schemas.openxmlformats.org/drawingml/2006/main">
-              <a:ext uri="{FF2B5EF4-FFF2-40B4-BE49-F238E27FC236}">
-                <a16:creationId xmlns:a16="http://schemas.microsoft.com/office/drawing/2014/main" id="{564E81CA-B850-4AAA-8524-98E041A83BA7}"/>
-              </a:ext>
-            </a:extLst>
-          </p:cNvPr>
-          <p:cNvSpPr>
-            <a:spLocks xmlns:a="http://schemas.openxmlformats.org/drawingml/2006/main" noGrp="1"/>
-          </p:cNvSpPr>
-          <p:nvPr/>
-        </p:nvSpPr>
-        <p:spPr>
-          <a:xfrm xmlns:a="http://schemas.openxmlformats.org/drawingml/2006/main">
-            <a:off x="7239000" y="2171700"/>
-            <a:ext cx="1943100" cy="1219200"/>
-          </a:xfrm>
-          <a:prstGeom xmlns:a="http://schemas.openxmlformats.org/drawingml/2006/main" prst="rect">
-            <a:avLst/>
-          </a:prstGeom>
-          <a:solidFill xmlns:a="http://schemas.openxmlformats.org/drawingml/2006/main">
-            <a:srgbClr val="EAF3F6"/>
+            <a:srgbClr val="FFFFFF"/>
           </a:solidFill>
           <a:ln xmlns:a="http://schemas.openxmlformats.org/drawingml/2006/main" w="14288">
             <a:solidFill>
@@ -6215,10 +6141,10 @@
       </p:sp>
       <p:sp>
         <p:nvSpPr>
-          <p:cNvPr id="14" name="">
-            <a:extLst xmlns:a="http://schemas.openxmlformats.org/drawingml/2006/main">
-              <a:ext uri="{FF2B5EF4-FFF2-40B4-BE49-F238E27FC236}">
-                <a16:creationId xmlns:a16="http://schemas.microsoft.com/office/drawing/2014/main" id="{D825F5EC-7B98-4925-90EE-2D5B2E518ECA}"/>
+          <p:cNvPr id="13" name="">
+            <a:extLst xmlns:a="http://schemas.openxmlformats.org/drawingml/2006/main">
+              <a:ext uri="{FF2B5EF4-FFF2-40B4-BE49-F238E27FC236}">
+                <a16:creationId xmlns:a16="http://schemas.microsoft.com/office/drawing/2014/main" id="{F08CE3DA-6AED-4B93-B1BE-3045ABAAD628}"/>
               </a:ext>
             </a:extLst>
           </p:cNvPr>
@@ -6229,188 +6155,8 @@
         </p:nvSpPr>
         <p:spPr>
           <a:xfrm xmlns:a="http://schemas.openxmlformats.org/drawingml/2006/main">
-            <a:off x="7372350" y="2438400"/>
-            <a:ext cx="1676400" cy="857250"/>
-          </a:xfrm>
-          <a:prstGeom xmlns:a="http://schemas.openxmlformats.org/drawingml/2006/main" prst="rect">
-            <a:avLst/>
-          </a:prstGeom>
-          <a:noFill xmlns:a="http://schemas.openxmlformats.org/drawingml/2006/main"/>
-          <a:ln xmlns:a="http://schemas.openxmlformats.org/drawingml/2006/main" w="0">
-            <a:noFill/>
-          </a:ln>
-        </p:spPr>
-        <p:txBody>
-          <a:bodyPr xmlns:a="http://schemas.openxmlformats.org/drawingml/2006/main" lIns="0" tIns="0" rIns="0" bIns="0"/>
-          <a:lstStyle xmlns:a="http://schemas.openxmlformats.org/drawingml/2006/main"/>
-          <a:p xmlns:a="http://schemas.openxmlformats.org/drawingml/2006/main">
-            <a:r>
-              <a:rPr sz="1875" b="1">
-                <a:solidFill>
-                  <a:srgbClr val="152D43"/>
-                </a:solidFill>
-                <a:latin typeface="Arial"/>
-                <a:ea typeface="Arial"/>
-                <a:cs typeface="Arial"/>
-              </a:rPr>
-              <a:t>Reconstruct</a:t>
-            </a:r>
-          </a:p>
-          <a:p xmlns:a="http://schemas.openxmlformats.org/drawingml/2006/main">
-            <a:r>
-              <a:rPr sz="1875" b="1">
-                <a:solidFill>
-                  <a:srgbClr val="152D43"/>
-                </a:solidFill>
-                <a:latin typeface="Arial"/>
-                <a:ea typeface="Arial"/>
-                <a:cs typeface="Arial"/>
-              </a:rPr>
-              <a:t>and blend</a:t>
-            </a:r>
-          </a:p>
-        </p:txBody>
-      </p:sp>
-      <p:sp>
-        <p:nvSpPr>
-          <p:cNvPr id="15" name="">
-            <a:extLst xmlns:a="http://schemas.openxmlformats.org/drawingml/2006/main">
-              <a:ext uri="{FF2B5EF4-FFF2-40B4-BE49-F238E27FC236}">
-                <a16:creationId xmlns:a16="http://schemas.microsoft.com/office/drawing/2014/main" id="{A3C59A66-1F56-4520-8B94-E0A6CCF33167}"/>
-              </a:ext>
-            </a:extLst>
-          </p:cNvPr>
-          <p:cNvSpPr>
-            <a:spLocks xmlns:a="http://schemas.openxmlformats.org/drawingml/2006/main" noGrp="1"/>
-          </p:cNvSpPr>
-          <p:nvPr/>
-        </p:nvSpPr>
-        <p:spPr>
-          <a:xfrm xmlns:a="http://schemas.openxmlformats.org/drawingml/2006/main">
-            <a:off x="9220200" y="2686050"/>
-            <a:ext cx="219075" cy="171450"/>
-          </a:xfrm>
-          <a:prstGeom xmlns:a="http://schemas.openxmlformats.org/drawingml/2006/main" prst="rightArrow">
-            <a:avLst/>
-          </a:prstGeom>
-          <a:solidFill xmlns:a="http://schemas.openxmlformats.org/drawingml/2006/main">
-            <a:srgbClr val="086B93"/>
-          </a:solidFill>
-          <a:ln xmlns:a="http://schemas.openxmlformats.org/drawingml/2006/main" w="0">
-            <a:solidFill>
-              <a:srgbClr val="086B93"/>
-            </a:solidFill>
-          </a:ln>
-        </p:spPr>
-      </p:sp>
-      <p:sp>
-        <p:nvSpPr>
-          <p:cNvPr id="16" name="">
-            <a:extLst xmlns:a="http://schemas.openxmlformats.org/drawingml/2006/main">
-              <a:ext uri="{FF2B5EF4-FFF2-40B4-BE49-F238E27FC236}">
-                <a16:creationId xmlns:a16="http://schemas.microsoft.com/office/drawing/2014/main" id="{B2E24E21-3689-4369-B26D-ADC2CAA7BE52}"/>
-              </a:ext>
-            </a:extLst>
-          </p:cNvPr>
-          <p:cNvSpPr>
-            <a:spLocks xmlns:a="http://schemas.openxmlformats.org/drawingml/2006/main" noGrp="1"/>
-          </p:cNvSpPr>
-          <p:nvPr/>
-        </p:nvSpPr>
-        <p:spPr>
-          <a:xfrm xmlns:a="http://schemas.openxmlformats.org/drawingml/2006/main">
-            <a:off x="9448800" y="2171700"/>
-            <a:ext cx="1943100" cy="1219200"/>
-          </a:xfrm>
-          <a:prstGeom xmlns:a="http://schemas.openxmlformats.org/drawingml/2006/main" prst="rect">
-            <a:avLst/>
-          </a:prstGeom>
-          <a:solidFill xmlns:a="http://schemas.openxmlformats.org/drawingml/2006/main">
-            <a:srgbClr val="FFFFFF"/>
-          </a:solidFill>
-          <a:ln xmlns:a="http://schemas.openxmlformats.org/drawingml/2006/main" w="14288">
-            <a:solidFill>
-              <a:srgbClr val="086B93"/>
-            </a:solidFill>
-          </a:ln>
-        </p:spPr>
-      </p:sp>
-      <p:sp>
-        <p:nvSpPr>
-          <p:cNvPr id="17" name="">
-            <a:extLst xmlns:a="http://schemas.openxmlformats.org/drawingml/2006/main">
-              <a:ext uri="{FF2B5EF4-FFF2-40B4-BE49-F238E27FC236}">
-                <a16:creationId xmlns:a16="http://schemas.microsoft.com/office/drawing/2014/main" id="{9E58039D-BAA1-488A-81DB-C62A5733C114}"/>
-              </a:ext>
-            </a:extLst>
-          </p:cNvPr>
-          <p:cNvSpPr>
-            <a:spLocks xmlns:a="http://schemas.openxmlformats.org/drawingml/2006/main" noGrp="1"/>
-          </p:cNvSpPr>
-          <p:nvPr/>
-        </p:nvSpPr>
-        <p:spPr>
-          <a:xfrm xmlns:a="http://schemas.openxmlformats.org/drawingml/2006/main">
-            <a:off x="9582150" y="2438400"/>
-            <a:ext cx="1676400" cy="857250"/>
-          </a:xfrm>
-          <a:prstGeom xmlns:a="http://schemas.openxmlformats.org/drawingml/2006/main" prst="rect">
-            <a:avLst/>
-          </a:prstGeom>
-          <a:noFill xmlns:a="http://schemas.openxmlformats.org/drawingml/2006/main"/>
-          <a:ln xmlns:a="http://schemas.openxmlformats.org/drawingml/2006/main" w="0">
-            <a:noFill/>
-          </a:ln>
-        </p:spPr>
-        <p:txBody>
-          <a:bodyPr xmlns:a="http://schemas.openxmlformats.org/drawingml/2006/main" lIns="0" tIns="0" rIns="0" bIns="0"/>
-          <a:lstStyle xmlns:a="http://schemas.openxmlformats.org/drawingml/2006/main"/>
-          <a:p xmlns:a="http://schemas.openxmlformats.org/drawingml/2006/main">
-            <a:r>
-              <a:rPr sz="1875" b="1">
-                <a:solidFill>
-                  <a:srgbClr val="152D43"/>
-                </a:solidFill>
-                <a:latin typeface="Arial"/>
-                <a:ea typeface="Arial"/>
-                <a:cs typeface="Arial"/>
-              </a:rPr>
-              <a:t>Submit</a:t>
-            </a:r>
-          </a:p>
-          <a:p xmlns:a="http://schemas.openxmlformats.org/drawingml/2006/main">
-            <a:r>
-              <a:rPr sz="1875" b="1">
-                <a:solidFill>
-                  <a:srgbClr val="152D43"/>
-                </a:solidFill>
-                <a:latin typeface="Arial"/>
-                <a:ea typeface="Arial"/>
-                <a:cs typeface="Arial"/>
-              </a:rPr>
-              <a:t>for display</a:t>
-            </a:r>
-          </a:p>
-        </p:txBody>
-      </p:sp>
-      <p:sp>
-        <p:nvSpPr>
-          <p:cNvPr id="18" name="">
-            <a:extLst xmlns:a="http://schemas.openxmlformats.org/drawingml/2006/main">
-              <a:ext uri="{FF2B5EF4-FFF2-40B4-BE49-F238E27FC236}">
-                <a16:creationId xmlns:a16="http://schemas.microsoft.com/office/drawing/2014/main" id="{EA7FED07-03DE-4AC2-9B83-73F1BEB1462D}"/>
-              </a:ext>
-            </a:extLst>
-          </p:cNvPr>
-          <p:cNvSpPr>
-            <a:spLocks xmlns:a="http://schemas.openxmlformats.org/drawingml/2006/main" noGrp="1"/>
-          </p:cNvSpPr>
-          <p:nvPr/>
-        </p:nvSpPr>
-        <p:spPr>
-          <a:xfrm xmlns:a="http://schemas.openxmlformats.org/drawingml/2006/main">
-            <a:off x="609600" y="4010025"/>
-            <a:ext cx="2000250" cy="428625"/>
+            <a:off x="5953125" y="5476875"/>
+            <a:ext cx="5524500" cy="381000"/>
           </a:xfrm>
           <a:prstGeom xmlns:a="http://schemas.openxmlformats.org/drawingml/2006/main" prst="rect">
             <a:avLst/>
@@ -6427,113 +6173,23 @@
             <a:r>
               <a:rPr sz="2175" b="1">
                 <a:solidFill>
-                  <a:srgbClr val="086B93"/>
+                  <a:srgbClr val="148B83"/>
                 </a:solidFill>
                 <a:latin typeface="Arial"/>
                 <a:ea typeface="Arial"/>
                 <a:cs typeface="Arial"/>
               </a:rPr>
-              <a:t>Proposed rule</a:t>
+              <a:t>Smaller full-resolution region</a:t>
             </a:r>
           </a:p>
         </p:txBody>
       </p:sp>
       <p:sp>
         <p:nvSpPr>
-          <p:cNvPr id="19" name="">
-            <a:extLst xmlns:a="http://schemas.openxmlformats.org/drawingml/2006/main">
-              <a:ext uri="{FF2B5EF4-FFF2-40B4-BE49-F238E27FC236}">
-                <a16:creationId xmlns:a16="http://schemas.microsoft.com/office/drawing/2014/main" id="{D9C6995A-6B15-4676-B427-FC686BB44AC1}"/>
-              </a:ext>
-            </a:extLst>
-          </p:cNvPr>
-          <p:cNvSpPr>
-            <a:spLocks xmlns:a="http://schemas.openxmlformats.org/drawingml/2006/main" noGrp="1"/>
-          </p:cNvSpPr>
-          <p:nvPr/>
-        </p:nvSpPr>
-        <p:spPr>
-          <a:xfrm xmlns:a="http://schemas.openxmlformats.org/drawingml/2006/main">
-            <a:off x="2667000" y="4010025"/>
-            <a:ext cx="8810625" cy="457200"/>
-          </a:xfrm>
-          <a:prstGeom xmlns:a="http://schemas.openxmlformats.org/drawingml/2006/main" prst="rect">
-            <a:avLst/>
-          </a:prstGeom>
-          <a:noFill xmlns:a="http://schemas.openxmlformats.org/drawingml/2006/main"/>
-          <a:ln xmlns:a="http://schemas.openxmlformats.org/drawingml/2006/main" w="0">
-            <a:noFill/>
-          </a:ln>
-        </p:spPr>
-        <p:txBody>
-          <a:bodyPr xmlns:a="http://schemas.openxmlformats.org/drawingml/2006/main" lIns="0" tIns="0" rIns="0" bIns="0"/>
-          <a:lstStyle xmlns:a="http://schemas.openxmlformats.org/drawingml/2006/main"/>
-          <a:p xmlns:a="http://schemas.openxmlformats.org/drawingml/2006/main">
-            <a:r>
-              <a:rPr sz="2400" b="1">
-                <a:solidFill>
-                  <a:srgbClr val="152D43"/>
-                </a:solidFill>
-                <a:latin typeface="Arial"/>
-                <a:ea typeface="Arial"/>
-                <a:cs typeface="Arial"/>
-              </a:rPr>
-              <a:t>Choose the highest-quality level with T̂(level) ≤ B</a:t>
-            </a:r>
-          </a:p>
-        </p:txBody>
-      </p:sp>
-      <p:sp>
-        <p:nvSpPr>
-          <p:cNvPr id="20" name="">
-            <a:extLst xmlns:a="http://schemas.openxmlformats.org/drawingml/2006/main">
-              <a:ext uri="{FF2B5EF4-FFF2-40B4-BE49-F238E27FC236}">
-                <a16:creationId xmlns:a16="http://schemas.microsoft.com/office/drawing/2014/main" id="{31FEFCE9-9DB7-4CB4-9ABE-A85C4AA2AAEB}"/>
-              </a:ext>
-            </a:extLst>
-          </p:cNvPr>
-          <p:cNvSpPr>
-            <a:spLocks xmlns:a="http://schemas.openxmlformats.org/drawingml/2006/main" noGrp="1"/>
-          </p:cNvSpPr>
-          <p:nvPr/>
-        </p:nvSpPr>
-        <p:spPr>
-          <a:xfrm xmlns:a="http://schemas.openxmlformats.org/drawingml/2006/main">
-            <a:off x="2667000" y="4572000"/>
-            <a:ext cx="8810625" cy="438150"/>
-          </a:xfrm>
-          <a:prstGeom xmlns:a="http://schemas.openxmlformats.org/drawingml/2006/main" prst="rect">
-            <a:avLst/>
-          </a:prstGeom>
-          <a:noFill xmlns:a="http://schemas.openxmlformats.org/drawingml/2006/main"/>
-          <a:ln xmlns:a="http://schemas.openxmlformats.org/drawingml/2006/main" w="0">
-            <a:noFill/>
-          </a:ln>
-        </p:spPr>
-        <p:txBody>
-          <a:bodyPr xmlns:a="http://schemas.openxmlformats.org/drawingml/2006/main" lIns="0" tIns="0" rIns="0" bIns="0"/>
-          <a:lstStyle xmlns:a="http://schemas.openxmlformats.org/drawingml/2006/main"/>
-          <a:p xmlns:a="http://schemas.openxmlformats.org/drawingml/2006/main">
-            <a:r>
-              <a:rPr sz="2025" b="0">
-                <a:solidFill>
-                  <a:srgbClr val="536675"/>
-                </a:solidFill>
-                <a:latin typeface="Arial"/>
-                <a:ea typeface="Arial"/>
-                <a:cs typeface="Arial"/>
-              </a:rPr>
-              <a:t>Use a conservative latency percentile. Validate prediction error and margin.</a:t>
-            </a:r>
-          </a:p>
-        </p:txBody>
-      </p:sp>
-      <p:sp>
-        <p:nvSpPr>
-          <p:cNvPr id="21" name="">
-            <a:extLst xmlns:a="http://schemas.openxmlformats.org/drawingml/2006/main">
-              <a:ext uri="{FF2B5EF4-FFF2-40B4-BE49-F238E27FC236}">
-                <a16:creationId xmlns:a16="http://schemas.microsoft.com/office/drawing/2014/main" id="{2DF3BE3C-6167-46C9-B207-7D8CEB5811FA}"/>
+          <p:cNvPr id="14" name="">
+            <a:extLst xmlns:a="http://schemas.openxmlformats.org/drawingml/2006/main">
+              <a:ext uri="{FF2B5EF4-FFF2-40B4-BE49-F238E27FC236}">
+                <a16:creationId xmlns:a16="http://schemas.microsoft.com/office/drawing/2014/main" id="{EBA2ADD1-64A5-46F5-AEBB-58E21F878AFE}"/>
               </a:ext>
             </a:extLst>
           </p:cNvPr>
@@ -6568,7 +6224,7 @@
                 <a:ea typeface="Arial"/>
                 <a:cs typeface="Arial"/>
               </a:rPr>
-              <a:t>Implemented: fixed-center FOV sweep and latency profiles. Dynamic scheduling and deadline-miss reduction remain unverified.</a:t>
+              <a:t>Proposed adaptation. Fixed-center levels are measured; scheduling and deadline-miss reduction remain unverified.</a:t>
             </a:r>
           </a:p>
         </p:txBody>
@@ -6576,7 +6232,7 @@
     </p:spTree>
     <p:extLst>
       <p:ext uri="{BB962C8B-B14F-4D97-AF65-F5344CB8AC3E}">
-        <p14:creationId xmlns:p14="http://schemas.microsoft.com/office/powerpoint/2010/main" val="935349963"/>
+        <p14:creationId xmlns:p14="http://schemas.microsoft.com/office/powerpoint/2010/main" val="632385214"/>
       </p:ext>
     </p:extLst>
   </p:cSld>
@@ -6607,7 +6263,7 @@
           <p:cNvPr id="20" name="">
             <a:extLst xmlns:a="http://schemas.openxmlformats.org/drawingml/2006/main">
               <a:ext uri="{FF2B5EF4-FFF2-40B4-BE49-F238E27FC236}">
-                <a16:creationId xmlns:a16="http://schemas.microsoft.com/office/drawing/2014/main" id="{93DC9B51-41DD-4F57-B924-92BC1F88E57A}"/>
+                <a16:creationId xmlns:a16="http://schemas.microsoft.com/office/drawing/2014/main" id="{CB7B59D6-AB28-4B82-8E5E-15B53F607AF6}"/>
               </a:ext>
             </a:extLst>
           </p:cNvPr>
@@ -6652,7 +6308,7 @@
           <p:cNvPr id="2" name="">
             <a:extLst xmlns:a="http://schemas.openxmlformats.org/drawingml/2006/main">
               <a:ext uri="{FF2B5EF4-FFF2-40B4-BE49-F238E27FC236}">
-                <a16:creationId xmlns:a16="http://schemas.microsoft.com/office/drawing/2014/main" id="{BC356941-43BB-4415-9269-506125083264}"/>
+                <a16:creationId xmlns:a16="http://schemas.microsoft.com/office/drawing/2014/main" id="{B1AA939F-E8F2-46ED-AFA9-966AC5C8EB09}"/>
               </a:ext>
             </a:extLst>
           </p:cNvPr>
@@ -6682,7 +6338,7 @@
           <p:cNvPr id="3" name="">
             <a:extLst xmlns:a="http://schemas.openxmlformats.org/drawingml/2006/main">
               <a:ext uri="{FF2B5EF4-FFF2-40B4-BE49-F238E27FC236}">
-                <a16:creationId xmlns:a16="http://schemas.microsoft.com/office/drawing/2014/main" id="{E5C30BB4-5128-455D-A3A5-344942C51064}"/>
+                <a16:creationId xmlns:a16="http://schemas.microsoft.com/office/drawing/2014/main" id="{62F2B2F1-675A-4604-9DC2-CF577233B175}"/>
               </a:ext>
             </a:extLst>
           </p:cNvPr>
@@ -6727,7 +6383,7 @@
           <p:cNvPr id="4" name="">
             <a:extLst xmlns:a="http://schemas.openxmlformats.org/drawingml/2006/main">
               <a:ext uri="{FF2B5EF4-FFF2-40B4-BE49-F238E27FC236}">
-                <a16:creationId xmlns:a16="http://schemas.microsoft.com/office/drawing/2014/main" id="{706CB8D0-5C58-45C0-A04B-F7E23489BB86}"/>
+                <a16:creationId xmlns:a16="http://schemas.microsoft.com/office/drawing/2014/main" id="{094708FB-6C37-40F9-877E-925E027174D8}"/>
               </a:ext>
             </a:extLst>
           </p:cNvPr>
@@ -6772,7 +6428,7 @@
           <p:cNvPr id="5" name="">
             <a:extLst xmlns:a="http://schemas.openxmlformats.org/drawingml/2006/main">
               <a:ext uri="{FF2B5EF4-FFF2-40B4-BE49-F238E27FC236}">
-                <a16:creationId xmlns:a16="http://schemas.microsoft.com/office/drawing/2014/main" id="{6796FD32-AFD6-42A9-9622-53997209D1E4}"/>
+                <a16:creationId xmlns:a16="http://schemas.microsoft.com/office/drawing/2014/main" id="{F60318F3-DC4F-46F8-92E5-FE1B083BE947}"/>
               </a:ext>
             </a:extLst>
           </p:cNvPr>
@@ -6804,7 +6460,7 @@
           <p:cNvPr id="6" name="">
             <a:extLst xmlns:a="http://schemas.openxmlformats.org/drawingml/2006/main">
               <a:ext uri="{FF2B5EF4-FFF2-40B4-BE49-F238E27FC236}">
-                <a16:creationId xmlns:a16="http://schemas.microsoft.com/office/drawing/2014/main" id="{BAD79347-8C32-4323-841C-917B258F7E9F}"/>
+                <a16:creationId xmlns:a16="http://schemas.microsoft.com/office/drawing/2014/main" id="{F2C4BEEA-FB8E-4188-81F6-4E7F24A5EAC2}"/>
               </a:ext>
             </a:extLst>
           </p:cNvPr>
@@ -6815,8 +6471,8 @@
         </p:nvSpPr>
         <p:spPr>
           <a:xfrm xmlns:a="http://schemas.openxmlformats.org/drawingml/2006/main">
-            <a:off x="1352550" y="2762250"/>
-            <a:ext cx="2238375" cy="762000"/>
+            <a:off x="1066800" y="2667000"/>
+            <a:ext cx="2667000" cy="1066800"/>
           </a:xfrm>
           <a:prstGeom xmlns:a="http://schemas.openxmlformats.org/drawingml/2006/main" prst="rect">
             <a:avLst/>
@@ -6831,7 +6487,7 @@
           <a:lstStyle xmlns:a="http://schemas.openxmlformats.org/drawingml/2006/main"/>
           <a:p xmlns:a="http://schemas.openxmlformats.org/drawingml/2006/main">
             <a:r>
-              <a:rPr sz="2100" b="1">
+              <a:rPr sz="1950" b="1">
                 <a:solidFill>
                   <a:srgbClr val="086B93"/>
                 </a:solidFill>
@@ -6839,12 +6495,12 @@
                 <a:ea typeface="Arial"/>
                 <a:cs typeface="Arial"/>
               </a:rPr>
-              <a:t>Full-image base</a:t>
+              <a:t>Base sampling</a:t>
             </a:r>
           </a:p>
           <a:p xmlns:a="http://schemas.openxmlformats.org/drawingml/2006/main">
             <a:r>
-              <a:rPr sz="2100" b="1">
+              <a:rPr sz="1950" b="1">
                 <a:solidFill>
                   <a:srgbClr val="086B93"/>
                 </a:solidFill>
@@ -6852,7 +6508,20 @@
                 <a:ea typeface="Arial"/>
                 <a:cs typeface="Arial"/>
               </a:rPr>
-              <a:t>480 × 270</a:t>
+              <a:t>50% W × 50% H</a:t>
+            </a:r>
+          </a:p>
+          <a:p xmlns:a="http://schemas.openxmlformats.org/drawingml/2006/main">
+            <a:r>
+              <a:rPr sz="1950" b="1">
+                <a:solidFill>
+                  <a:srgbClr val="086B93"/>
+                </a:solidFill>
+                <a:latin typeface="Arial"/>
+                <a:ea typeface="Arial"/>
+                <a:cs typeface="Arial"/>
+              </a:rPr>
+              <a:t>(25% of pixels)</a:t>
             </a:r>
           </a:p>
         </p:txBody>
@@ -6862,7 +6531,7 @@
           <p:cNvPr id="7" name="">
             <a:extLst xmlns:a="http://schemas.openxmlformats.org/drawingml/2006/main">
               <a:ext uri="{FF2B5EF4-FFF2-40B4-BE49-F238E27FC236}">
-                <a16:creationId xmlns:a16="http://schemas.microsoft.com/office/drawing/2014/main" id="{839BED52-D043-4F59-B5C9-12E71F6C7D69}"/>
+                <a16:creationId xmlns:a16="http://schemas.microsoft.com/office/drawing/2014/main" id="{8ED5298F-FDDF-48D4-B678-7E34CBE0BCC4}"/>
               </a:ext>
             </a:extLst>
           </p:cNvPr>
@@ -6897,7 +6566,7 @@
                 <a:ea typeface="Arial"/>
                 <a:cs typeface="Arial"/>
               </a:rPr>
-              <a:t>Half resolution in the periphery</a:t>
+              <a:t>Base covers the whole image</a:t>
             </a:r>
           </a:p>
         </p:txBody>
@@ -6907,7 +6576,7 @@
           <p:cNvPr id="8" name="">
             <a:extLst xmlns:a="http://schemas.openxmlformats.org/drawingml/2006/main">
               <a:ext uri="{FF2B5EF4-FFF2-40B4-BE49-F238E27FC236}">
-                <a16:creationId xmlns:a16="http://schemas.microsoft.com/office/drawing/2014/main" id="{3CA436ED-584C-4112-851E-A55A9CD1EFFE}"/>
+                <a16:creationId xmlns:a16="http://schemas.microsoft.com/office/drawing/2014/main" id="{ECB42779-4993-4CA4-B660-5BEFD241EC89}"/>
               </a:ext>
             </a:extLst>
           </p:cNvPr>
@@ -6939,7 +6608,7 @@
           <p:cNvPr id="9" name="">
             <a:extLst xmlns:a="http://schemas.openxmlformats.org/drawingml/2006/main">
               <a:ext uri="{FF2B5EF4-FFF2-40B4-BE49-F238E27FC236}">
-                <a16:creationId xmlns:a16="http://schemas.microsoft.com/office/drawing/2014/main" id="{9D938BB9-9E48-4211-A9BF-0D08E5F1FE87}"/>
+                <a16:creationId xmlns:a16="http://schemas.microsoft.com/office/drawing/2014/main" id="{94BA456E-40D1-469A-817A-4D46628369FB}"/>
               </a:ext>
             </a:extLst>
           </p:cNvPr>
@@ -6971,7 +6640,7 @@
           <p:cNvPr id="10" name="">
             <a:extLst xmlns:a="http://schemas.openxmlformats.org/drawingml/2006/main">
               <a:ext uri="{FF2B5EF4-FFF2-40B4-BE49-F238E27FC236}">
-                <a16:creationId xmlns:a16="http://schemas.microsoft.com/office/drawing/2014/main" id="{48B553D8-883B-441A-B911-421ECE3AD8CD}"/>
+                <a16:creationId xmlns:a16="http://schemas.microsoft.com/office/drawing/2014/main" id="{E3E14705-A0CD-4820-9575-9B9017CE9589}"/>
               </a:ext>
             </a:extLst>
           </p:cNvPr>
@@ -7016,7 +6685,7 @@
           <p:cNvPr id="11" name="">
             <a:extLst xmlns:a="http://schemas.openxmlformats.org/drawingml/2006/main">
               <a:ext uri="{FF2B5EF4-FFF2-40B4-BE49-F238E27FC236}">
-                <a16:creationId xmlns:a16="http://schemas.microsoft.com/office/drawing/2014/main" id="{631C3249-E8A1-44DD-AF9B-84541FB1BED5}"/>
+                <a16:creationId xmlns:a16="http://schemas.microsoft.com/office/drawing/2014/main" id="{732033DC-81A6-46A7-B1CC-54F3EFE01970}"/>
               </a:ext>
             </a:extLst>
           </p:cNvPr>
@@ -7061,7 +6730,7 @@
           <p:cNvPr id="12" name="">
             <a:extLst xmlns:a="http://schemas.openxmlformats.org/drawingml/2006/main">
               <a:ext uri="{FF2B5EF4-FFF2-40B4-BE49-F238E27FC236}">
-                <a16:creationId xmlns:a16="http://schemas.microsoft.com/office/drawing/2014/main" id="{05B842FE-82F1-481E-BDDF-117BE94169FC}"/>
+                <a16:creationId xmlns:a16="http://schemas.microsoft.com/office/drawing/2014/main" id="{ABAA87BE-28E1-426F-BC95-1EA3DB7AECB1}"/>
               </a:ext>
             </a:extLst>
           </p:cNvPr>
@@ -7106,7 +6775,7 @@
           <p:cNvPr id="13" name="">
             <a:extLst xmlns:a="http://schemas.openxmlformats.org/drawingml/2006/main">
               <a:ext uri="{FF2B5EF4-FFF2-40B4-BE49-F238E27FC236}">
-                <a16:creationId xmlns:a16="http://schemas.microsoft.com/office/drawing/2014/main" id="{0D157194-DAB4-4D40-86DD-CDEF2CE49737}"/>
+                <a16:creationId xmlns:a16="http://schemas.microsoft.com/office/drawing/2014/main" id="{BAE18F72-BCE6-4B3E-BD61-A69B9A6CEB76}"/>
               </a:ext>
             </a:extLst>
           </p:cNvPr>
@@ -7138,7 +6807,7 @@
           <p:cNvPr id="14" name="">
             <a:extLst xmlns:a="http://schemas.openxmlformats.org/drawingml/2006/main">
               <a:ext uri="{FF2B5EF4-FFF2-40B4-BE49-F238E27FC236}">
-                <a16:creationId xmlns:a16="http://schemas.microsoft.com/office/drawing/2014/main" id="{7DE77B97-3964-4207-BF64-A228AA9902F4}"/>
+                <a16:creationId xmlns:a16="http://schemas.microsoft.com/office/drawing/2014/main" id="{0CD4D0A8-241B-4DCF-8914-45C778AC35B4}"/>
               </a:ext>
             </a:extLst>
           </p:cNvPr>
@@ -7170,7 +6839,7 @@
           <p:cNvPr id="15" name="">
             <a:extLst xmlns:a="http://schemas.openxmlformats.org/drawingml/2006/main">
               <a:ext uri="{FF2B5EF4-FFF2-40B4-BE49-F238E27FC236}">
-                <a16:creationId xmlns:a16="http://schemas.microsoft.com/office/drawing/2014/main" id="{97368412-AEF6-4121-AF48-CE616484D8BB}"/>
+                <a16:creationId xmlns:a16="http://schemas.microsoft.com/office/drawing/2014/main" id="{0CC647A2-A56F-41AB-B67F-D87BF3CAAFDE}"/>
               </a:ext>
             </a:extLst>
           </p:cNvPr>
@@ -7202,7 +6871,7 @@
           <p:cNvPr id="16" name="">
             <a:extLst xmlns:a="http://schemas.openxmlformats.org/drawingml/2006/main">
               <a:ext uri="{FF2B5EF4-FFF2-40B4-BE49-F238E27FC236}">
-                <a16:creationId xmlns:a16="http://schemas.microsoft.com/office/drawing/2014/main" id="{93E8175B-36F4-4A62-ADD5-843B9A3041D8}"/>
+                <a16:creationId xmlns:a16="http://schemas.microsoft.com/office/drawing/2014/main" id="{995D563E-1A69-4535-BA9C-6AEF2BE17AC2}"/>
               </a:ext>
             </a:extLst>
           </p:cNvPr>
@@ -7247,7 +6916,7 @@
           <p:cNvPr id="17" name="">
             <a:extLst xmlns:a="http://schemas.openxmlformats.org/drawingml/2006/main">
               <a:ext uri="{FF2B5EF4-FFF2-40B4-BE49-F238E27FC236}">
-                <a16:creationId xmlns:a16="http://schemas.microsoft.com/office/drawing/2014/main" id="{CB4703F3-26F7-447A-BA74-97735A7DEBF8}"/>
+                <a16:creationId xmlns:a16="http://schemas.microsoft.com/office/drawing/2014/main" id="{DEAB27A3-7508-4C64-A6AC-96DB70EC858B}"/>
               </a:ext>
             </a:extLst>
           </p:cNvPr>
@@ -7292,7 +6961,7 @@
           <p:cNvPr id="18" name="">
             <a:extLst xmlns:a="http://schemas.openxmlformats.org/drawingml/2006/main">
               <a:ext uri="{FF2B5EF4-FFF2-40B4-BE49-F238E27FC236}">
-                <a16:creationId xmlns:a16="http://schemas.microsoft.com/office/drawing/2014/main" id="{AE2745C7-30C0-42AF-8CF6-0AEE241D4764}"/>
+                <a16:creationId xmlns:a16="http://schemas.microsoft.com/office/drawing/2014/main" id="{E6BB7C8C-8A0F-4371-918C-D6A80E29CC10}"/>
               </a:ext>
             </a:extLst>
           </p:cNvPr>
@@ -7327,7 +6996,7 @@
                 <a:ea typeface="Arial"/>
                 <a:cs typeface="Arial"/>
               </a:rPr>
-              <a:t>ROI sizes: 80×46, 160×90, 320×180, 480×270, 640×360</a:t>
+              <a:t>Full-resolution region: 0.7%, 2.8%, 11.1%, 25.0%, 44.4% of image</a:t>
             </a:r>
           </a:p>
         </p:txBody>
@@ -7337,7 +7006,7 @@
           <p:cNvPr id="19" name="">
             <a:extLst xmlns:a="http://schemas.openxmlformats.org/drawingml/2006/main">
               <a:ext uri="{FF2B5EF4-FFF2-40B4-BE49-F238E27FC236}">
-                <a16:creationId xmlns:a16="http://schemas.microsoft.com/office/drawing/2014/main" id="{6F3849FB-AD73-4A78-A7F9-76DC7580FD55}"/>
+                <a16:creationId xmlns:a16="http://schemas.microsoft.com/office/drawing/2014/main" id="{0DEB3FE0-5247-4CA4-BB80-E0E636E4FEAA}"/>
               </a:ext>
             </a:extLst>
           </p:cNvPr>
@@ -7372,7 +7041,7 @@
                 <a:ea typeface="Arial"/>
                 <a:cs typeface="Arial"/>
               </a:rPr>
-              <a:t>Fixed center, 3 px halo, and edge blending. Diagram not to scale. Eye tracking is not integrated.</a:t>
+              <a:t>Region % means image-area coverage; base sampling is separate. Fixed center, 3 px halo; no eye tracking.</a:t>
             </a:r>
           </a:p>
         </p:txBody>
@@ -7380,7 +7049,7 @@
     </p:spTree>
     <p:extLst>
       <p:ext uri="{BB962C8B-B14F-4D97-AF65-F5344CB8AC3E}">
-        <p14:creationId xmlns:p14="http://schemas.microsoft.com/office/powerpoint/2010/main" val="1537219987"/>
+        <p14:creationId xmlns:p14="http://schemas.microsoft.com/office/powerpoint/2010/main" val="1695536243"/>
       </p:ext>
     </p:extLst>
   </p:cSld>
@@ -7411,7 +7080,7 @@
           <p:cNvPr id="9" name="">
             <a:extLst xmlns:a="http://schemas.openxmlformats.org/drawingml/2006/main">
               <a:ext uri="{FF2B5EF4-FFF2-40B4-BE49-F238E27FC236}">
-                <a16:creationId xmlns:a16="http://schemas.microsoft.com/office/drawing/2014/main" id="{F7A14EF3-2B14-46F4-A0F8-69B1422F40B3}"/>
+                <a16:creationId xmlns:a16="http://schemas.microsoft.com/office/drawing/2014/main" id="{F444464D-4A80-4EB4-9AF2-0D893A075CAA}"/>
               </a:ext>
             </a:extLst>
           </p:cNvPr>
@@ -7456,7 +7125,7 @@
           <p:cNvPr id="2" name="">
             <a:extLst xmlns:a="http://schemas.openxmlformats.org/drawingml/2006/main">
               <a:ext uri="{FF2B5EF4-FFF2-40B4-BE49-F238E27FC236}">
-                <a16:creationId xmlns:a16="http://schemas.microsoft.com/office/drawing/2014/main" id="{53179AE6-CE2C-4F2F-9622-8EF353EB234A}"/>
+                <a16:creationId xmlns:a16="http://schemas.microsoft.com/office/drawing/2014/main" id="{3B20A77E-9E30-49CB-A380-B82713C893FD}"/>
               </a:ext>
             </a:extLst>
           </p:cNvPr>
@@ -7486,7 +7155,7 @@
           <p:cNvPr id="3" name="">
             <a:extLst xmlns:a="http://schemas.openxmlformats.org/drawingml/2006/main">
               <a:ext uri="{FF2B5EF4-FFF2-40B4-BE49-F238E27FC236}">
-                <a16:creationId xmlns:a16="http://schemas.microsoft.com/office/drawing/2014/main" id="{8E7ADFB6-11AA-4A8F-8E9D-4B10115850A2}"/>
+                <a16:creationId xmlns:a16="http://schemas.microsoft.com/office/drawing/2014/main" id="{0B248448-63BB-494A-9AEB-BC93F31A60DE}"/>
               </a:ext>
             </a:extLst>
           </p:cNvPr>
@@ -7531,7 +7200,7 @@
           <p:cNvPr id="4" name="">
             <a:extLst xmlns:a="http://schemas.openxmlformats.org/drawingml/2006/main">
               <a:ext uri="{FF2B5EF4-FFF2-40B4-BE49-F238E27FC236}">
-                <a16:creationId xmlns:a16="http://schemas.microsoft.com/office/drawing/2014/main" id="{7FF698A5-09EE-4C42-BBF2-61DBAEEDB58D}"/>
+                <a16:creationId xmlns:a16="http://schemas.microsoft.com/office/drawing/2014/main" id="{549792D3-3B2B-4290-BAB9-3295CD76CEEF}"/>
               </a:ext>
             </a:extLst>
           </p:cNvPr>
@@ -8158,7 +7827,7 @@
           <p:cNvPr id="5" name="">
             <a:extLst xmlns:a="http://schemas.openxmlformats.org/drawingml/2006/main">
               <a:ext uri="{FF2B5EF4-FFF2-40B4-BE49-F238E27FC236}">
-                <a16:creationId xmlns:a16="http://schemas.microsoft.com/office/drawing/2014/main" id="{D8EDFBFC-0A3E-4827-A999-D294C3E37769}"/>
+                <a16:creationId xmlns:a16="http://schemas.microsoft.com/office/drawing/2014/main" id="{4CC59F9B-38E6-4638-95A5-AD767CB63951}"/>
               </a:ext>
             </a:extLst>
           </p:cNvPr>
@@ -8203,7 +7872,7 @@
           <p:cNvPr id="6" name="">
             <a:extLst xmlns:a="http://schemas.openxmlformats.org/drawingml/2006/main">
               <a:ext uri="{FF2B5EF4-FFF2-40B4-BE49-F238E27FC236}">
-                <a16:creationId xmlns:a16="http://schemas.microsoft.com/office/drawing/2014/main" id="{346E119D-547E-48BB-BBFE-66EC4F298227}"/>
+                <a16:creationId xmlns:a16="http://schemas.microsoft.com/office/drawing/2014/main" id="{E024E966-6F8A-4424-A464-BB691D98978E}"/>
               </a:ext>
             </a:extLst>
           </p:cNvPr>
@@ -8287,7 +7956,7 @@
           <p:cNvPr id="7" name="">
             <a:extLst xmlns:a="http://schemas.openxmlformats.org/drawingml/2006/main">
               <a:ext uri="{FF2B5EF4-FFF2-40B4-BE49-F238E27FC236}">
-                <a16:creationId xmlns:a16="http://schemas.microsoft.com/office/drawing/2014/main" id="{7B8BA39B-9E80-411A-B4D8-5C891185EB75}"/>
+                <a16:creationId xmlns:a16="http://schemas.microsoft.com/office/drawing/2014/main" id="{1618F05A-0E3F-45B1-BB2F-70A5C1D03BA9}"/>
               </a:ext>
             </a:extLst>
           </p:cNvPr>
@@ -8345,7 +8014,7 @@
           <p:cNvPr id="8" name="">
             <a:extLst xmlns:a="http://schemas.openxmlformats.org/drawingml/2006/main">
               <a:ext uri="{FF2B5EF4-FFF2-40B4-BE49-F238E27FC236}">
-                <a16:creationId xmlns:a16="http://schemas.microsoft.com/office/drawing/2014/main" id="{3CD4A78B-9E55-4015-898F-29BA2CE961F2}"/>
+                <a16:creationId xmlns:a16="http://schemas.microsoft.com/office/drawing/2014/main" id="{A34703C5-B2D6-47DB-95BF-F5F0FA953EDE}"/>
               </a:ext>
             </a:extLst>
           </p:cNvPr>
@@ -8388,7 +8057,7 @@
     </p:spTree>
     <p:extLst>
       <p:ext uri="{BB962C8B-B14F-4D97-AF65-F5344CB8AC3E}">
-        <p14:creationId xmlns:p14="http://schemas.microsoft.com/office/powerpoint/2010/main" val="186933198"/>
+        <p14:creationId xmlns:p14="http://schemas.microsoft.com/office/powerpoint/2010/main" val="1306227738"/>
       </p:ext>
     </p:extLst>
   </p:cSld>
@@ -8419,7 +8088,7 @@
           <p:cNvPr id="11" name="">
             <a:extLst xmlns:a="http://schemas.openxmlformats.org/drawingml/2006/main">
               <a:ext uri="{FF2B5EF4-FFF2-40B4-BE49-F238E27FC236}">
-                <a16:creationId xmlns:a16="http://schemas.microsoft.com/office/drawing/2014/main" id="{48017034-61C8-467E-B202-000F2C9345BD}"/>
+                <a16:creationId xmlns:a16="http://schemas.microsoft.com/office/drawing/2014/main" id="{0D349209-5F36-4F67-8E19-F6EF68ECFDF9}"/>
               </a:ext>
             </a:extLst>
           </p:cNvPr>
@@ -8454,7 +8123,7 @@
                 <a:ea typeface="Arial"/>
                 <a:cs typeface="Arial"/>
               </a:rPr>
-              <a:t>Smaller ROIs reduce reconstruction latency</a:t>
+              <a:t>Smaller regions reduce mean reconstruction latency</a:t>
             </a:r>
           </a:p>
         </p:txBody>
@@ -8464,7 +8133,7 @@
           <p:cNvPr id="2" name="">
             <a:extLst xmlns:a="http://schemas.openxmlformats.org/drawingml/2006/main">
               <a:ext uri="{FF2B5EF4-FFF2-40B4-BE49-F238E27FC236}">
-                <a16:creationId xmlns:a16="http://schemas.microsoft.com/office/drawing/2014/main" id="{4CFE33BA-2DD4-4920-8A8E-3BF4DEF6168A}"/>
+                <a16:creationId xmlns:a16="http://schemas.microsoft.com/office/drawing/2014/main" id="{EA0BBD74-C6F0-44E2-8A70-0C9C409ACCD8}"/>
               </a:ext>
             </a:extLst>
           </p:cNvPr>
@@ -8494,7 +8163,7 @@
           <p:cNvPr id="3" name="">
             <a:extLst xmlns:a="http://schemas.openxmlformats.org/drawingml/2006/main">
               <a:ext uri="{FF2B5EF4-FFF2-40B4-BE49-F238E27FC236}">
-                <a16:creationId xmlns:a16="http://schemas.microsoft.com/office/drawing/2014/main" id="{F0DFAD48-15D1-4997-BEBF-A293491299EB}"/>
+                <a16:creationId xmlns:a16="http://schemas.microsoft.com/office/drawing/2014/main" id="{F1D49EF4-C83F-45AA-9935-10A6C83FE3E4}"/>
               </a:ext>
             </a:extLst>
           </p:cNvPr>
@@ -8539,7 +8208,7 @@
           <p:cNvPr id="4" name="Chart">
             <a:extLst xmlns:a="http://schemas.openxmlformats.org/drawingml/2006/main">
               <a:ext uri="{FF2B5EF4-FFF2-40B4-BE49-F238E27FC236}">
-                <a16:creationId xmlns:a16="http://schemas.microsoft.com/office/drawing/2014/main" id="{1DC4B560-459E-4EB8-A5F1-F3A3461B312A}"/>
+                <a16:creationId xmlns:a16="http://schemas.microsoft.com/office/drawing/2014/main" id="{6A59F450-9386-4F87-BF4A-9667777191BF}"/>
               </a:ext>
             </a:extLst>
           </p:cNvPr>
@@ -8552,7 +8221,7 @@
         </p:xfrm>
         <a:graphic xmlns:a="http://schemas.openxmlformats.org/drawingml/2006/main">
           <a:graphicData uri="http://schemas.openxmlformats.org/drawingml/2006/chart">
-            <c:chart xmlns:r="http://schemas.openxmlformats.org/officeDocument/2006/relationships" xmlns:c="http://schemas.openxmlformats.org/drawingml/2006/chart" r:id="Rfbcdd481ebc44f2e"/>
+            <c:chart xmlns:r="http://schemas.openxmlformats.org/officeDocument/2006/relationships" xmlns:c="http://schemas.openxmlformats.org/drawingml/2006/chart" r:id="R0d17e04ab7ce4564"/>
           </a:graphicData>
         </a:graphic>
       </p:graphicFrame>
@@ -8561,7 +8230,7 @@
           <p:cNvPr id="5" name="">
             <a:extLst xmlns:a="http://schemas.openxmlformats.org/drawingml/2006/main">
               <a:ext uri="{FF2B5EF4-FFF2-40B4-BE49-F238E27FC236}">
-                <a16:creationId xmlns:a16="http://schemas.microsoft.com/office/drawing/2014/main" id="{F77B259D-D2E0-45A9-8D1C-B7522A52C130}"/>
+                <a16:creationId xmlns:a16="http://schemas.microsoft.com/office/drawing/2014/main" id="{75EAA6B4-68FC-4153-A7F1-6E5EF2211F7D}"/>
               </a:ext>
             </a:extLst>
           </p:cNvPr>
@@ -8596,7 +8265,7 @@
                 <a:ea typeface="Arial"/>
                 <a:cs typeface="Arial"/>
               </a:rPr>
-              <a:t>160 × 90</a:t>
+              <a:t>2.8% region</a:t>
             </a:r>
           </a:p>
         </p:txBody>
@@ -8606,7 +8275,7 @@
           <p:cNvPr id="6" name="">
             <a:extLst xmlns:a="http://schemas.openxmlformats.org/drawingml/2006/main">
               <a:ext uri="{FF2B5EF4-FFF2-40B4-BE49-F238E27FC236}">
-                <a16:creationId xmlns:a16="http://schemas.microsoft.com/office/drawing/2014/main" id="{94F5296C-C08C-4FC2-B471-2C1A739DA8D1}"/>
+                <a16:creationId xmlns:a16="http://schemas.microsoft.com/office/drawing/2014/main" id="{CF8A1F16-6F0A-4A63-BD81-BF0C4F58569D}"/>
               </a:ext>
             </a:extLst>
           </p:cNvPr>
@@ -8641,7 +8310,7 @@
                 <a:ea typeface="Arial"/>
                 <a:cs typeface="Arial"/>
               </a:rPr>
-              <a:t>4.637 ms</a:t>
+              <a:t>4.770 ms</a:t>
             </a:r>
           </a:p>
         </p:txBody>
@@ -8651,7 +8320,7 @@
           <p:cNvPr id="7" name="">
             <a:extLst xmlns:a="http://schemas.openxmlformats.org/drawingml/2006/main">
               <a:ext uri="{FF2B5EF4-FFF2-40B4-BE49-F238E27FC236}">
-                <a16:creationId xmlns:a16="http://schemas.microsoft.com/office/drawing/2014/main" id="{4E474AAD-D1AF-4556-8FBA-19640227CD17}"/>
+                <a16:creationId xmlns:a16="http://schemas.microsoft.com/office/drawing/2014/main" id="{C65FF544-D589-4D88-A422-6422096B33C1}"/>
               </a:ext>
             </a:extLst>
           </p:cNvPr>
@@ -8686,7 +8355,7 @@
                 <a:ea typeface="Arial"/>
                 <a:cs typeface="Arial"/>
               </a:rPr>
-              <a:t>resident p50</a:t>
+              <a:t>resident mean</a:t>
             </a:r>
           </a:p>
         </p:txBody>
@@ -8696,7 +8365,7 @@
           <p:cNvPr id="8" name="">
             <a:extLst xmlns:a="http://schemas.openxmlformats.org/drawingml/2006/main">
               <a:ext uri="{FF2B5EF4-FFF2-40B4-BE49-F238E27FC236}">
-                <a16:creationId xmlns:a16="http://schemas.microsoft.com/office/drawing/2014/main" id="{7D72D769-8D10-4C92-8389-5BDC9C6F9ECC}"/>
+                <a16:creationId xmlns:a16="http://schemas.microsoft.com/office/drawing/2014/main" id="{9AF714CF-ECAB-4D8A-93B5-2BDCBB99F5CF}"/>
               </a:ext>
             </a:extLst>
           </p:cNvPr>
@@ -8731,7 +8400,7 @@
                 <a:ea typeface="Arial"/>
                 <a:cs typeface="Arial"/>
               </a:rPr>
-              <a:t>2.32×</a:t>
+              <a:t>2.31×</a:t>
             </a:r>
           </a:p>
         </p:txBody>
@@ -8741,7 +8410,7 @@
           <p:cNvPr id="9" name="">
             <a:extLst xmlns:a="http://schemas.openxmlformats.org/drawingml/2006/main">
               <a:ext uri="{FF2B5EF4-FFF2-40B4-BE49-F238E27FC236}">
-                <a16:creationId xmlns:a16="http://schemas.microsoft.com/office/drawing/2014/main" id="{C1DF79C7-AB26-48FD-B654-4A3EBDBC4BFD}"/>
+                <a16:creationId xmlns:a16="http://schemas.microsoft.com/office/drawing/2014/main" id="{57BBE320-2FA8-4F92-A25B-334356CECDD6}"/>
               </a:ext>
             </a:extLst>
           </p:cNvPr>
@@ -8786,7 +8455,7 @@
           <p:cNvPr id="10" name="">
             <a:extLst xmlns:a="http://schemas.openxmlformats.org/drawingml/2006/main">
               <a:ext uri="{FF2B5EF4-FFF2-40B4-BE49-F238E27FC236}">
-                <a16:creationId xmlns:a16="http://schemas.microsoft.com/office/drawing/2014/main" id="{96B1D508-825B-4FDC-A400-D8845F0619A2}"/>
+                <a16:creationId xmlns:a16="http://schemas.microsoft.com/office/drawing/2014/main" id="{FD2DC3F3-656A-46C1-A888-B8A920EF614A}"/>
               </a:ext>
             </a:extLst>
           </p:cNvPr>
@@ -8829,7 +8498,7 @@
     </p:spTree>
     <p:extLst>
       <p:ext uri="{BB962C8B-B14F-4D97-AF65-F5344CB8AC3E}">
-        <p14:creationId xmlns:p14="http://schemas.microsoft.com/office/powerpoint/2010/main" val="595662565"/>
+        <p14:creationId xmlns:p14="http://schemas.microsoft.com/office/powerpoint/2010/main" val="850097204"/>
       </p:ext>
     </p:extLst>
   </p:cSld>
@@ -8860,7 +8529,7 @@
           <p:cNvPr id="8" name="">
             <a:extLst xmlns:a="http://schemas.openxmlformats.org/drawingml/2006/main">
               <a:ext uri="{FF2B5EF4-FFF2-40B4-BE49-F238E27FC236}">
-                <a16:creationId xmlns:a16="http://schemas.microsoft.com/office/drawing/2014/main" id="{6BDF265D-6928-4E6B-8EEF-0AEF5A54A0B0}"/>
+                <a16:creationId xmlns:a16="http://schemas.microsoft.com/office/drawing/2014/main" id="{00A42D32-4F2E-4135-A51F-C27D2424754C}"/>
               </a:ext>
             </a:extLst>
           </p:cNvPr>
@@ -8905,7 +8574,7 @@
           <p:cNvPr id="2" name="">
             <a:extLst xmlns:a="http://schemas.openxmlformats.org/drawingml/2006/main">
               <a:ext uri="{FF2B5EF4-FFF2-40B4-BE49-F238E27FC236}">
-                <a16:creationId xmlns:a16="http://schemas.microsoft.com/office/drawing/2014/main" id="{C4D51E72-D92D-4519-BEC3-B7A79EA8E5C8}"/>
+                <a16:creationId xmlns:a16="http://schemas.microsoft.com/office/drawing/2014/main" id="{E063F2EC-A8F6-41F8-A102-DB79F7C0336D}"/>
               </a:ext>
             </a:extLst>
           </p:cNvPr>
@@ -8935,7 +8604,7 @@
           <p:cNvPr id="3" name="">
             <a:extLst xmlns:a="http://schemas.openxmlformats.org/drawingml/2006/main">
               <a:ext uri="{FF2B5EF4-FFF2-40B4-BE49-F238E27FC236}">
-                <a16:creationId xmlns:a16="http://schemas.microsoft.com/office/drawing/2014/main" id="{78611105-F92A-47CF-AF93-8164D037F112}"/>
+                <a16:creationId xmlns:a16="http://schemas.microsoft.com/office/drawing/2014/main" id="{B0C6CA2D-4FD8-48DC-BF76-00A75C2A61CD}"/>
               </a:ext>
             </a:extLst>
           </p:cNvPr>
@@ -8980,7 +8649,7 @@
           <p:cNvPr id="4" name="">
             <a:extLst xmlns:a="http://schemas.openxmlformats.org/drawingml/2006/main">
               <a:ext uri="{FF2B5EF4-FFF2-40B4-BE49-F238E27FC236}">
-                <a16:creationId xmlns:a16="http://schemas.microsoft.com/office/drawing/2014/main" id="{4E7AB0F1-812B-48A2-B612-DFE5D2402C80}"/>
+                <a16:creationId xmlns:a16="http://schemas.microsoft.com/office/drawing/2014/main" id="{56A635C5-93B8-4B43-8C6E-E8480D69C337}"/>
               </a:ext>
             </a:extLst>
           </p:cNvPr>
@@ -8996,8 +8665,8 @@
             <a:tbl>
               <a:tblPr/>
               <a:tblGrid>
-                <a:gridCol w="1857375"/>
-                <a:gridCol w="3286125"/>
+                <a:gridCol w="2524125"/>
+                <a:gridCol w="2619375"/>
                 <a:gridCol w="2724150"/>
                 <a:gridCol w="3105150"/>
               </a:tblGrid>
@@ -9016,7 +8685,7 @@
                           <a:ea typeface="Arial"/>
                           <a:cs typeface="Arial"/>
                         </a:rPr>
-                        <a:t>ROI</a:t>
+                        <a:t>Region (% of image)</a:t>
                       </a:r>
                     </a:p>
                   </a:txBody>
@@ -9064,7 +8733,7 @@
                           <a:ea typeface="Arial"/>
                           <a:cs typeface="Arial"/>
                         </a:rPr>
-                        <a:t>resident p50 / p95</a:t>
+                        <a:t>Mean latency</a:t>
                       </a:r>
                     </a:p>
                   </a:txBody>
@@ -9192,7 +8861,7 @@
                           <a:ea typeface="Arial"/>
                           <a:cs typeface="Arial"/>
                         </a:rPr>
-                        <a:t>80×46</a:t>
+                        <a:t>0.7%</a:t>
                       </a:r>
                     </a:p>
                   </a:txBody>
@@ -9234,7 +8903,7 @@
                           <a:ea typeface="Arial"/>
                           <a:cs typeface="Arial"/>
                         </a:rPr>
-                        <a:t>4.367 / 4.782 ms</a:t>
+                        <a:t>4.562 ms</a:t>
                       </a:r>
                     </a:p>
                   </a:txBody>
@@ -9344,7 +9013,7 @@
                           <a:ea typeface="Arial"/>
                           <a:cs typeface="Arial"/>
                         </a:rPr>
-                        <a:t>160×90</a:t>
+                        <a:t>2.8%</a:t>
                       </a:r>
                     </a:p>
                   </a:txBody>
@@ -9386,7 +9055,7 @@
                           <a:ea typeface="Arial"/>
                           <a:cs typeface="Arial"/>
                         </a:rPr>
-                        <a:t>4.637 / 5.016 ms</a:t>
+                        <a:t>4.770 ms</a:t>
                       </a:r>
                     </a:p>
                   </a:txBody>
@@ -9496,7 +9165,7 @@
                           <a:ea typeface="Arial"/>
                           <a:cs typeface="Arial"/>
                         </a:rPr>
-                        <a:t>320×180</a:t>
+                        <a:t>11.1%</a:t>
                       </a:r>
                     </a:p>
                   </a:txBody>
@@ -9538,7 +9207,7 @@
                           <a:ea typeface="Arial"/>
                           <a:cs typeface="Arial"/>
                         </a:rPr>
-                        <a:t>5.788 / 6.220 ms</a:t>
+                        <a:t>5.998 ms</a:t>
                       </a:r>
                     </a:p>
                   </a:txBody>
@@ -9648,7 +9317,7 @@
                           <a:ea typeface="Arial"/>
                           <a:cs typeface="Arial"/>
                         </a:rPr>
-                        <a:t>480×270</a:t>
+                        <a:t>25.0%</a:t>
                       </a:r>
                     </a:p>
                   </a:txBody>
@@ -9690,7 +9359,7 @@
                           <a:ea typeface="Arial"/>
                           <a:cs typeface="Arial"/>
                         </a:rPr>
-                        <a:t>7.582 / 8.009 ms</a:t>
+                        <a:t>7.772 ms</a:t>
                       </a:r>
                     </a:p>
                   </a:txBody>
@@ -9800,7 +9469,7 @@
                           <a:ea typeface="Arial"/>
                           <a:cs typeface="Arial"/>
                         </a:rPr>
-                        <a:t>640×360</a:t>
+                        <a:t>44.4%</a:t>
                       </a:r>
                     </a:p>
                   </a:txBody>
@@ -9842,7 +9511,7 @@
                           <a:ea typeface="Arial"/>
                           <a:cs typeface="Arial"/>
                         </a:rPr>
-                        <a:t>10.142 / 10.633 ms</a:t>
+                        <a:t>10.425 ms</a:t>
                       </a:r>
                     </a:p>
                   </a:txBody>
@@ -9946,7 +9615,7 @@
           <p:cNvPr id="5" name="">
             <a:extLst xmlns:a="http://schemas.openxmlformats.org/drawingml/2006/main">
               <a:ext uri="{FF2B5EF4-FFF2-40B4-BE49-F238E27FC236}">
-                <a16:creationId xmlns:a16="http://schemas.microsoft.com/office/drawing/2014/main" id="{45271EF5-13E6-4AE2-A2E3-5AC775101D13}"/>
+                <a16:creationId xmlns:a16="http://schemas.microsoft.com/office/drawing/2014/main" id="{EA0548C4-3A51-4DAE-9BAE-414198D10628}"/>
               </a:ext>
             </a:extLst>
           </p:cNvPr>
@@ -9991,7 +9660,7 @@
           <p:cNvPr id="6" name="">
             <a:extLst xmlns:a="http://schemas.openxmlformats.org/drawingml/2006/main">
               <a:ext uri="{FF2B5EF4-FFF2-40B4-BE49-F238E27FC236}">
-                <a16:creationId xmlns:a16="http://schemas.microsoft.com/office/drawing/2014/main" id="{7BAF61D7-5D6A-48BB-8DB3-E3277449F863}"/>
+                <a16:creationId xmlns:a16="http://schemas.microsoft.com/office/drawing/2014/main" id="{8C3CF272-0BE1-4233-8F64-CC920083DFA4}"/>
               </a:ext>
             </a:extLst>
           </p:cNvPr>
@@ -10036,7 +9705,7 @@
           <p:cNvPr id="7" name="">
             <a:extLst xmlns:a="http://schemas.openxmlformats.org/drawingml/2006/main">
               <a:ext uri="{FF2B5EF4-FFF2-40B4-BE49-F238E27FC236}">
-                <a16:creationId xmlns:a16="http://schemas.microsoft.com/office/drawing/2014/main" id="{C9D23BBA-A27D-437D-92F7-33E57F8865EB}"/>
+                <a16:creationId xmlns:a16="http://schemas.microsoft.com/office/drawing/2014/main" id="{77949391-9B3F-44DD-942F-7C4F743150F3}"/>
               </a:ext>
             </a:extLst>
           </p:cNvPr>
@@ -10079,7 +9748,7 @@
     </p:spTree>
     <p:extLst>
       <p:ext uri="{BB962C8B-B14F-4D97-AF65-F5344CB8AC3E}">
-        <p14:creationId xmlns:p14="http://schemas.microsoft.com/office/powerpoint/2010/main" val="65152342"/>
+        <p14:creationId xmlns:p14="http://schemas.microsoft.com/office/powerpoint/2010/main" val="2077063432"/>
       </p:ext>
     </p:extLst>
   </p:cSld>
@@ -10110,7 +9779,7 @@
           <p:cNvPr id="8" name="">
             <a:extLst xmlns:a="http://schemas.openxmlformats.org/drawingml/2006/main">
               <a:ext uri="{FF2B5EF4-FFF2-40B4-BE49-F238E27FC236}">
-                <a16:creationId xmlns:a16="http://schemas.microsoft.com/office/drawing/2014/main" id="{D29EF5BD-8997-4578-BE12-01B666DCA60F}"/>
+                <a16:creationId xmlns:a16="http://schemas.microsoft.com/office/drawing/2014/main" id="{AB438DC6-C4A4-4DC0-AE91-C85E95108CAD}"/>
               </a:ext>
             </a:extLst>
           </p:cNvPr>
@@ -10155,7 +9824,7 @@
           <p:cNvPr id="2" name="">
             <a:extLst xmlns:a="http://schemas.openxmlformats.org/drawingml/2006/main">
               <a:ext uri="{FF2B5EF4-FFF2-40B4-BE49-F238E27FC236}">
-                <a16:creationId xmlns:a16="http://schemas.microsoft.com/office/drawing/2014/main" id="{3072C9C8-CC63-495E-8689-E2022F88A9CC}"/>
+                <a16:creationId xmlns:a16="http://schemas.microsoft.com/office/drawing/2014/main" id="{1E3FDC43-829D-42ED-BDD7-D6F92CE1D166}"/>
               </a:ext>
             </a:extLst>
           </p:cNvPr>
@@ -10185,7 +9854,7 @@
           <p:cNvPr id="3" name="">
             <a:extLst xmlns:a="http://schemas.openxmlformats.org/drawingml/2006/main">
               <a:ext uri="{FF2B5EF4-FFF2-40B4-BE49-F238E27FC236}">
-                <a16:creationId xmlns:a16="http://schemas.microsoft.com/office/drawing/2014/main" id="{B4A42B74-B48D-400A-8A8B-97DB78F1A31F}"/>
+                <a16:creationId xmlns:a16="http://schemas.microsoft.com/office/drawing/2014/main" id="{468606E0-4C4F-43A5-94E1-5487F8A416F7}"/>
               </a:ext>
             </a:extLst>
           </p:cNvPr>
@@ -10230,7 +9899,7 @@
           <p:cNvPr id="4" name="">
             <a:extLst xmlns:a="http://schemas.openxmlformats.org/drawingml/2006/main">
               <a:ext uri="{FF2B5EF4-FFF2-40B4-BE49-F238E27FC236}">
-                <a16:creationId xmlns:a16="http://schemas.microsoft.com/office/drawing/2014/main" id="{1FFC186F-471F-42B2-8111-6F4A879E187A}"/>
+                <a16:creationId xmlns:a16="http://schemas.microsoft.com/office/drawing/2014/main" id="{99D71048-5F6D-4005-8479-A4E2550574A1}"/>
               </a:ext>
             </a:extLst>
           </p:cNvPr>
@@ -10527,7 +10196,7 @@
                           <a:ea typeface="Arial"/>
                           <a:cs typeface="Arial"/>
                         </a:rPr>
-                        <a:t>14.653</a:t>
+                        <a:t>14.661</a:t>
                       </a:r>
                     </a:p>
                   </a:txBody>
@@ -10563,7 +10232,7 @@
                           <a:ea typeface="Arial"/>
                           <a:cs typeface="Arial"/>
                         </a:rPr>
-                        <a:t>11.003</a:t>
+                        <a:t>11.039</a:t>
                       </a:r>
                     </a:p>
                   </a:txBody>
@@ -10599,7 +10268,7 @@
                           <a:ea typeface="Arial"/>
                           <a:cs typeface="Arial"/>
                         </a:rPr>
-                        <a:t>8.923</a:t>
+                        <a:t>8.924</a:t>
                       </a:r>
                     </a:p>
                   </a:txBody>
@@ -10635,7 +10304,7 @@
                           <a:ea typeface="Arial"/>
                           <a:cs typeface="Arial"/>
                         </a:rPr>
-                        <a:t>6.775</a:t>
+                        <a:t>6.803</a:t>
                       </a:r>
                     </a:p>
                   </a:txBody>
@@ -10715,7 +10384,7 @@
                           <a:ea typeface="Arial"/>
                           <a:cs typeface="Arial"/>
                         </a:rPr>
-                        <a:t>14.421</a:t>
+                        <a:t>14.433</a:t>
                       </a:r>
                     </a:p>
                   </a:txBody>
@@ -10751,7 +10420,7 @@
                           <a:ea typeface="Arial"/>
                           <a:cs typeface="Arial"/>
                         </a:rPr>
-                        <a:t>10.847</a:t>
+                        <a:t>10.870</a:t>
                       </a:r>
                     </a:p>
                   </a:txBody>
@@ -10787,7 +10456,7 @@
                           <a:ea typeface="Arial"/>
                           <a:cs typeface="Arial"/>
                         </a:rPr>
-                        <a:t>8.900</a:t>
+                        <a:t>8.910</a:t>
                       </a:r>
                     </a:p>
                   </a:txBody>
@@ -10823,7 +10492,7 @@
                           <a:ea typeface="Arial"/>
                           <a:cs typeface="Arial"/>
                         </a:rPr>
-                        <a:t>6.772</a:t>
+                        <a:t>6.784</a:t>
                       </a:r>
                     </a:p>
                   </a:txBody>
@@ -10903,7 +10572,7 @@
                           <a:ea typeface="Arial"/>
                           <a:cs typeface="Arial"/>
                         </a:rPr>
-                        <a:t>14.536</a:t>
+                        <a:t>14.537</a:t>
                       </a:r>
                     </a:p>
                   </a:txBody>
@@ -10939,7 +10608,7 @@
                           <a:ea typeface="Arial"/>
                           <a:cs typeface="Arial"/>
                         </a:rPr>
-                        <a:t>10.889</a:t>
+                        <a:t>10.914</a:t>
                       </a:r>
                     </a:p>
                   </a:txBody>
@@ -10975,7 +10644,7 @@
                           <a:ea typeface="Arial"/>
                           <a:cs typeface="Arial"/>
                         </a:rPr>
-                        <a:t>8.910</a:t>
+                        <a:t>8.911</a:t>
                       </a:r>
                     </a:p>
                   </a:txBody>
@@ -11091,7 +10760,7 @@
                           <a:ea typeface="Arial"/>
                           <a:cs typeface="Arial"/>
                         </a:rPr>
-                        <a:t>14.534</a:t>
+                        <a:t>14.567</a:t>
                       </a:r>
                     </a:p>
                   </a:txBody>
@@ -11127,7 +10796,7 @@
                           <a:ea typeface="Arial"/>
                           <a:cs typeface="Arial"/>
                         </a:rPr>
-                        <a:t>10.974</a:t>
+                        <a:t>11.045</a:t>
                       </a:r>
                     </a:p>
                   </a:txBody>
@@ -11163,7 +10832,7 @@
                           <a:ea typeface="Arial"/>
                           <a:cs typeface="Arial"/>
                         </a:rPr>
-                        <a:t>8.936</a:t>
+                        <a:t>8.959</a:t>
                       </a:r>
                     </a:p>
                   </a:txBody>
@@ -11199,7 +10868,7 @@
                           <a:ea typeface="Arial"/>
                           <a:cs typeface="Arial"/>
                         </a:rPr>
-                        <a:t>6.811</a:t>
+                        <a:t>6.841</a:t>
                       </a:r>
                     </a:p>
                   </a:txBody>
@@ -11231,7 +10900,7 @@
           <p:cNvPr id="5" name="">
             <a:extLst xmlns:a="http://schemas.openxmlformats.org/drawingml/2006/main">
               <a:ext uri="{FF2B5EF4-FFF2-40B4-BE49-F238E27FC236}">
-                <a16:creationId xmlns:a16="http://schemas.microsoft.com/office/drawing/2014/main" id="{D71BAC99-2D0F-4B89-9D62-F0B14DF4FF52}"/>
+                <a16:creationId xmlns:a16="http://schemas.microsoft.com/office/drawing/2014/main" id="{DB3058CF-31CD-481E-9980-BFA1B36AB4AD}"/>
               </a:ext>
             </a:extLst>
           </p:cNvPr>
@@ -11266,7 +10935,7 @@
                 <a:ea typeface="Arial"/>
                 <a:cs typeface="Arial"/>
               </a:rPr>
-              <a:t>Frame 39 per sequence, 100 repeats. Resident p50 in ms. ROI = 160×90.</a:t>
+              <a:t>Frame 39 per sequence, 100 repeats. Resident mean in ms. Region = 2.8% of image.</a:t>
             </a:r>
           </a:p>
         </p:txBody>
@@ -11276,7 +10945,7 @@
           <p:cNvPr id="6" name="">
             <a:extLst xmlns:a="http://schemas.openxmlformats.org/drawingml/2006/main">
               <a:ext uri="{FF2B5EF4-FFF2-40B4-BE49-F238E27FC236}">
-                <a16:creationId xmlns:a16="http://schemas.microsoft.com/office/drawing/2014/main" id="{251008B0-E90C-4E0B-905C-7740109780C2}"/>
+                <a16:creationId xmlns:a16="http://schemas.microsoft.com/office/drawing/2014/main" id="{B4CCCA0A-3121-4CE3-89BA-B5A15C519141}"/>
               </a:ext>
             </a:extLst>
           </p:cNvPr>
@@ -11334,7 +11003,7 @@
           <p:cNvPr id="7" name="">
             <a:extLst xmlns:a="http://schemas.openxmlformats.org/drawingml/2006/main">
               <a:ext uri="{FF2B5EF4-FFF2-40B4-BE49-F238E27FC236}">
-                <a16:creationId xmlns:a16="http://schemas.microsoft.com/office/drawing/2014/main" id="{B1D6CC80-30D0-45FB-B8F5-E2CE61178EDA}"/>
+                <a16:creationId xmlns:a16="http://schemas.microsoft.com/office/drawing/2014/main" id="{18A5A26D-61D8-44DF-B3A7-B8B966E5E98A}"/>
               </a:ext>
             </a:extLst>
           </p:cNvPr>
@@ -11377,7 +11046,7 @@
     </p:spTree>
     <p:extLst>
       <p:ext uri="{BB962C8B-B14F-4D97-AF65-F5344CB8AC3E}">
-        <p14:creationId xmlns:p14="http://schemas.microsoft.com/office/powerpoint/2010/main" val="1678418824"/>
+        <p14:creationId xmlns:p14="http://schemas.microsoft.com/office/powerpoint/2010/main" val="1169531929"/>
       </p:ext>
     </p:extLst>
   </p:cSld>
@@ -11408,7 +11077,7 @@
           <p:cNvPr id="14" name="">
             <a:extLst xmlns:a="http://schemas.openxmlformats.org/drawingml/2006/main">
               <a:ext uri="{FF2B5EF4-FFF2-40B4-BE49-F238E27FC236}">
-                <a16:creationId xmlns:a16="http://schemas.microsoft.com/office/drawing/2014/main" id="{158BA8DD-B169-46A7-A2F9-194C12F4DC1B}"/>
+                <a16:creationId xmlns:a16="http://schemas.microsoft.com/office/drawing/2014/main" id="{30E56511-8BC0-47E4-A0F0-626054C5D59E}"/>
               </a:ext>
             </a:extLst>
           </p:cNvPr>
@@ -11453,7 +11122,7 @@
           <p:cNvPr id="2" name="">
             <a:extLst xmlns:a="http://schemas.openxmlformats.org/drawingml/2006/main">
               <a:ext uri="{FF2B5EF4-FFF2-40B4-BE49-F238E27FC236}">
-                <a16:creationId xmlns:a16="http://schemas.microsoft.com/office/drawing/2014/main" id="{A807E76C-D1CC-47FE-9C36-B3772095B7D0}"/>
+                <a16:creationId xmlns:a16="http://schemas.microsoft.com/office/drawing/2014/main" id="{9E2F31D0-B66F-4253-97CA-32F799962EE2}"/>
               </a:ext>
             </a:extLst>
           </p:cNvPr>
@@ -11483,7 +11152,7 @@
           <p:cNvPr id="3" name="">
             <a:extLst xmlns:a="http://schemas.openxmlformats.org/drawingml/2006/main">
               <a:ext uri="{FF2B5EF4-FFF2-40B4-BE49-F238E27FC236}">
-                <a16:creationId xmlns:a16="http://schemas.microsoft.com/office/drawing/2014/main" id="{A06DDCFC-9F5D-4EFF-B3E0-224F8DEB4B33}"/>
+                <a16:creationId xmlns:a16="http://schemas.microsoft.com/office/drawing/2014/main" id="{3EF1A6EC-BC4E-41C9-8148-CCCCDE2CA85F}"/>
               </a:ext>
             </a:extLst>
           </p:cNvPr>
@@ -11528,7 +11197,7 @@
           <p:cNvPr id="4" name="">
             <a:extLst xmlns:a="http://schemas.openxmlformats.org/drawingml/2006/main">
               <a:ext uri="{FF2B5EF4-FFF2-40B4-BE49-F238E27FC236}">
-                <a16:creationId xmlns:a16="http://schemas.microsoft.com/office/drawing/2014/main" id="{9420C76F-697E-4142-9895-A6351002C10D}"/>
+                <a16:creationId xmlns:a16="http://schemas.microsoft.com/office/drawing/2014/main" id="{DB4214EB-DC24-47EB-B010-264099852640}"/>
               </a:ext>
             </a:extLst>
           </p:cNvPr>
@@ -11573,7 +11242,7 @@
           <p:cNvPr id="5" name="">
             <a:extLst xmlns:a="http://schemas.openxmlformats.org/drawingml/2006/main">
               <a:ext uri="{FF2B5EF4-FFF2-40B4-BE49-F238E27FC236}">
-                <a16:creationId xmlns:a16="http://schemas.microsoft.com/office/drawing/2014/main" id="{BD4BBEDA-BB2E-478D-8848-0E2105C9E1B6}"/>
+                <a16:creationId xmlns:a16="http://schemas.microsoft.com/office/drawing/2014/main" id="{AD2ADF7A-00C8-4287-A210-E3D200980AD8}"/>
               </a:ext>
             </a:extLst>
           </p:cNvPr>
@@ -11618,7 +11287,7 @@
           <p:cNvPr id="6" name="">
             <a:extLst xmlns:a="http://schemas.openxmlformats.org/drawingml/2006/main">
               <a:ext uri="{FF2B5EF4-FFF2-40B4-BE49-F238E27FC236}">
-                <a16:creationId xmlns:a16="http://schemas.microsoft.com/office/drawing/2014/main" id="{2842C4E6-DF06-419D-836F-EBF4EF6C7345}"/>
+                <a16:creationId xmlns:a16="http://schemas.microsoft.com/office/drawing/2014/main" id="{AE0907DA-4A6C-4756-A336-992C49546AAE}"/>
               </a:ext>
             </a:extLst>
           </p:cNvPr>
@@ -11663,7 +11332,7 @@
           <p:cNvPr id="7" name="">
             <a:extLst xmlns:a="http://schemas.openxmlformats.org/drawingml/2006/main">
               <a:ext uri="{FF2B5EF4-FFF2-40B4-BE49-F238E27FC236}">
-                <a16:creationId xmlns:a16="http://schemas.microsoft.com/office/drawing/2014/main" id="{40620432-7622-40D8-BC5C-BF27755380D2}"/>
+                <a16:creationId xmlns:a16="http://schemas.microsoft.com/office/drawing/2014/main" id="{2D270DE4-99F1-49CA-9906-5A20BF97644A}"/>
               </a:ext>
             </a:extLst>
           </p:cNvPr>
@@ -11708,7 +11377,7 @@
           <p:cNvPr id="8" name="">
             <a:extLst xmlns:a="http://schemas.openxmlformats.org/drawingml/2006/main">
               <a:ext uri="{FF2B5EF4-FFF2-40B4-BE49-F238E27FC236}">
-                <a16:creationId xmlns:a16="http://schemas.microsoft.com/office/drawing/2014/main" id="{9302FA1C-BC86-4200-80AB-9E12D67601F7}"/>
+                <a16:creationId xmlns:a16="http://schemas.microsoft.com/office/drawing/2014/main" id="{A6A309C6-0282-490F-8901-048A3F9EFBFD}"/>
               </a:ext>
             </a:extLst>
           </p:cNvPr>
@@ -11753,7 +11422,7 @@
           <p:cNvPr id="9" name="">
             <a:extLst xmlns:a="http://schemas.openxmlformats.org/drawingml/2006/main">
               <a:ext uri="{FF2B5EF4-FFF2-40B4-BE49-F238E27FC236}">
-                <a16:creationId xmlns:a16="http://schemas.microsoft.com/office/drawing/2014/main" id="{ADEA23DF-3530-4B00-B6B7-72D2E655B4EB}"/>
+                <a16:creationId xmlns:a16="http://schemas.microsoft.com/office/drawing/2014/main" id="{FDD88703-B323-4612-AF87-F9289AB94734}"/>
               </a:ext>
             </a:extLst>
           </p:cNvPr>
@@ -11798,7 +11467,7 @@
           <p:cNvPr id="10" name="">
             <a:extLst xmlns:a="http://schemas.openxmlformats.org/drawingml/2006/main">
               <a:ext uri="{FF2B5EF4-FFF2-40B4-BE49-F238E27FC236}">
-                <a16:creationId xmlns:a16="http://schemas.microsoft.com/office/drawing/2014/main" id="{03C792D1-6AD3-4595-9EF3-B6958BB0E24E}"/>
+                <a16:creationId xmlns:a16="http://schemas.microsoft.com/office/drawing/2014/main" id="{5EAF3A52-C2B6-44EB-B845-96B2BBBCAF6E}"/>
               </a:ext>
             </a:extLst>
           </p:cNvPr>
@@ -11843,7 +11512,7 @@
           <p:cNvPr id="11" name="">
             <a:extLst xmlns:a="http://schemas.openxmlformats.org/drawingml/2006/main">
               <a:ext uri="{FF2B5EF4-FFF2-40B4-BE49-F238E27FC236}">
-                <a16:creationId xmlns:a16="http://schemas.microsoft.com/office/drawing/2014/main" id="{89430E20-D7D1-48E2-8513-B891D0AD9B4D}"/>
+                <a16:creationId xmlns:a16="http://schemas.microsoft.com/office/drawing/2014/main" id="{1D60AADD-23A8-47CF-9D1F-FF8D2CC6FCC3}"/>
               </a:ext>
             </a:extLst>
           </p:cNvPr>
@@ -11888,7 +11557,7 @@
           <p:cNvPr id="12" name="">
             <a:extLst xmlns:a="http://schemas.openxmlformats.org/drawingml/2006/main">
               <a:ext uri="{FF2B5EF4-FFF2-40B4-BE49-F238E27FC236}">
-                <a16:creationId xmlns:a16="http://schemas.microsoft.com/office/drawing/2014/main" id="{C003A30F-8D17-449B-9256-0E31971E95D4}"/>
+                <a16:creationId xmlns:a16="http://schemas.microsoft.com/office/drawing/2014/main" id="{9A0F6887-5D65-4634-BE05-1052EAA0F537}"/>
               </a:ext>
             </a:extLst>
           </p:cNvPr>
@@ -11933,7 +11602,7 @@
           <p:cNvPr id="13" name="">
             <a:extLst xmlns:a="http://schemas.openxmlformats.org/drawingml/2006/main">
               <a:ext uri="{FF2B5EF4-FFF2-40B4-BE49-F238E27FC236}">
-                <a16:creationId xmlns:a16="http://schemas.microsoft.com/office/drawing/2014/main" id="{864BEFCF-D50B-4BB3-89CE-2B6DF7F63B6E}"/>
+                <a16:creationId xmlns:a16="http://schemas.microsoft.com/office/drawing/2014/main" id="{86333480-6F3B-44D0-AC48-9AFF4B40B7B3}"/>
               </a:ext>
             </a:extLst>
           </p:cNvPr>
@@ -11976,7 +11645,7 @@
     </p:spTree>
     <p:extLst>
       <p:ext uri="{BB962C8B-B14F-4D97-AF65-F5344CB8AC3E}">
-        <p14:creationId xmlns:p14="http://schemas.microsoft.com/office/powerpoint/2010/main" val="820065709"/>
+        <p14:creationId xmlns:p14="http://schemas.microsoft.com/office/powerpoint/2010/main" val="1445548751"/>
       </p:ext>
     </p:extLst>
   </p:cSld>

</xml_diff>

<commit_message>
Apply fixed 2 ms decoding budget across FOV levels and record map decode tests
</commit_message>
<xml_diff>
--- a/presentations/weekly_20261029/weekly_20261029_english_30w.pptx
+++ b/presentations/weekly_20261029/weekly_20261029_english_30w.pptx
@@ -2,21 +2,21 @@
 <file path=ppt/presentation.xml><?xml version="1.0" encoding="utf-8"?>
 <p:presentation xmlns:p="http://schemas.openxmlformats.org/presentationml/2006/main">
   <p:sldMasterIdLst>
-    <p:sldMasterId xmlns:r="http://schemas.openxmlformats.org/officeDocument/2006/relationships" id="2147483648" r:id="Ra41cd06139b74b1f"/>
+    <p:sldMasterId xmlns:r="http://schemas.openxmlformats.org/officeDocument/2006/relationships" id="2147483648" r:id="R09c16da95f79494d"/>
   </p:sldMasterIdLst>
   <p:notesMasterIdLst>
-    <p:notesMasterId xmlns:r="http://schemas.openxmlformats.org/officeDocument/2006/relationships" r:id="Rfcd6c3d41c2540ee"/>
+    <p:notesMasterId xmlns:r="http://schemas.openxmlformats.org/officeDocument/2006/relationships" r:id="R4b0ad371359c4011"/>
   </p:notesMasterIdLst>
   <p:sldIdLst>
-    <p:sldId xmlns:r="http://schemas.openxmlformats.org/officeDocument/2006/relationships" id="256" r:id="Rcc37a2e4cbf74d8d"/>
-    <p:sldId xmlns:r="http://schemas.openxmlformats.org/officeDocument/2006/relationships" id="257" r:id="R1b812de2334e4600"/>
-    <p:sldId xmlns:r="http://schemas.openxmlformats.org/officeDocument/2006/relationships" id="258" r:id="R7cedae5321d645d2"/>
-    <p:sldId xmlns:r="http://schemas.openxmlformats.org/officeDocument/2006/relationships" id="259" r:id="Rac71f7bd83e342f1"/>
-    <p:sldId xmlns:r="http://schemas.openxmlformats.org/officeDocument/2006/relationships" id="260" r:id="R1e283448a22a402a"/>
-    <p:sldId xmlns:r="http://schemas.openxmlformats.org/officeDocument/2006/relationships" id="261" r:id="R5b0d5928b7d4412f"/>
-    <p:sldId xmlns:r="http://schemas.openxmlformats.org/officeDocument/2006/relationships" id="262" r:id="R4c020822a9de44f6"/>
-    <p:sldId xmlns:r="http://schemas.openxmlformats.org/officeDocument/2006/relationships" id="263" r:id="R609d868a1ccb4945"/>
-    <p:sldId xmlns:r="http://schemas.openxmlformats.org/officeDocument/2006/relationships" id="264" r:id="R1f0e556895bd4741"/>
+    <p:sldId xmlns:r="http://schemas.openxmlformats.org/officeDocument/2006/relationships" id="256" r:id="R1bae078953534c2b"/>
+    <p:sldId xmlns:r="http://schemas.openxmlformats.org/officeDocument/2006/relationships" id="257" r:id="R3da9a5646f56409f"/>
+    <p:sldId xmlns:r="http://schemas.openxmlformats.org/officeDocument/2006/relationships" id="258" r:id="R4a3d9075b8804c72"/>
+    <p:sldId xmlns:r="http://schemas.openxmlformats.org/officeDocument/2006/relationships" id="259" r:id="Rfdf522f93e3c4443"/>
+    <p:sldId xmlns:r="http://schemas.openxmlformats.org/officeDocument/2006/relationships" id="260" r:id="Re211ad38b3184873"/>
+    <p:sldId xmlns:r="http://schemas.openxmlformats.org/officeDocument/2006/relationships" id="261" r:id="R068da9d99cb54720"/>
+    <p:sldId xmlns:r="http://schemas.openxmlformats.org/officeDocument/2006/relationships" id="262" r:id="Ra875afc61dc941a5"/>
+    <p:sldId xmlns:r="http://schemas.openxmlformats.org/officeDocument/2006/relationships" id="263" r:id="R60666f7c4dbf4417"/>
+    <p:sldId xmlns:r="http://schemas.openxmlformats.org/officeDocument/2006/relationships" id="264" r:id="Rba26559cd1ce497b"/>
   </p:sldIdLst>
   <p:sldSz cx="12192000" cy="6858000"/>
   <p:notesSz cx="6858000" cy="9144000"/>
@@ -730,7 +730,7 @@
           <a:lstStyle xmlns:a="http://schemas.openxmlformats.org/drawingml/2006/main"/>
           <a:p xmlns:a="http://schemas.openxmlformats.org/drawingml/2006/main">
             <a:r>
-              <a:t>Source: results/fov_levels_xavier_full_20261027/README.md; overview.csv; summary.csv. Commit 0f1506c. Date 2026-10-27. Raw evidence: evidence.tar.gz.</a:t>
+              <a:t>Source: results/fov_levels_xavier_full_20261027/README.md; overview.csv; summary.csv. Commit 0f1506c. Date 2026-10-27. Raw evidence: evidence.tar.gz. Measured timing excludes decoding. Slides 6 and 7 add one fixed 2 ms decoding budget per frame to measured means; derived budget totals are not measured end-to-end latency. No joint RGB, depth and flow decoding measurement is claimed.</a:t>
             </a:r>
           </a:p>
         </p:txBody>
@@ -800,7 +800,7 @@
           <a:lstStyle xmlns:a="http://schemas.openxmlformats.org/drawingml/2006/main"/>
           <a:p xmlns:a="http://schemas.openxmlformats.org/drawingml/2006/main">
             <a:r>
-              <a:t>Source: results/fov_levels_xavier_full_20261027/README.md; overview.csv; summary.csv. Commit 0f1506c. Date 2026-10-27. Raw evidence: evidence.tar.gz. Arithmetic means of all 5340 timing samples in each level/timing/mode group, computed by compute_means.py into mean_timings.json. No sample trimming. Full baseline measured separately per level. Fast resample enabled. Each value covers all 1068 supported frames. Speedup is mean(full resident)/mean(FOV resident) at the same region level. Region labels are image-area coverage, not sampling resolution.</a:t>
+              <a:t>Source: results/fov_levels_xavier_full_20261027/README.md; overview.csv; summary.csv. Commit 0f1506c. Date 2026-10-27. Raw evidence: evidence.tar.gz. Arithmetic means of all 5340 timing samples in each level/timing/mode group, computed by compute_means.py into mean_timings.json. No sample trimming. Full baseline measured separately per level. Fast resample enabled. Each value covers all 1068 supported frames. Adds a fixed 2 ms decode budget once per frame. Speedup is (2 + mean(full resident))/(2 + mean(FOV resident)) at the same region level. This is a derived budget, not measured end-to-end timing or measured joint RGB/depth/flow decoding. See results/fov_decode_budget_2ms_20261029/README.md and summary.csv. Region labels are image-area coverage, not sampling resolution.</a:t>
             </a:r>
           </a:p>
         </p:txBody>
@@ -870,7 +870,7 @@
           <a:lstStyle xmlns:a="http://schemas.openxmlformats.org/drawingml/2006/main"/>
           <a:p xmlns:a="http://schemas.openxmlformats.org/drawingml/2006/main">
             <a:r>
-              <a:t>Source: results/fov_levels_xavier_full_20261027/README.md; overview.csv; summary.csv. Commit 0f1506c. Date 2026-10-27. Raw evidence: evidence.tar.gz. Original uint8-overflow PSNR preserved. Stereo delta is derived only if left eye remains unchanged and per-eye PSNR dB is averaged. Timing is never divided by two.</a:t>
+              <a:t>Source: results/fov_levels_xavier_full_20261027/README.md; overview.csv; summary.csv. Commit 0f1506c. Date 2026-10-27. Raw evidence: evidence.tar.gz. Original uint8-overflow PSNR preserved. Stereo delta is derived only if left eye remains unchanged and per-eye PSNR dB is averaged. Timing is never divided by two. Latency adds a fixed 2 ms per-frame decode budget once, not measured decoding or end-to-end latency. Source: results/fov_decode_budget_2ms_20261029/summary.csv.</a:t>
             </a:r>
           </a:p>
         </p:txBody>
@@ -1010,7 +1010,7 @@
           <a:lstStyle xmlns:a="http://schemas.openxmlformats.org/drawingml/2006/main"/>
           <a:p xmlns:a="http://schemas.openxmlformats.org/drawingml/2006/main">
             <a:r>
-              <a:t>Proposed future work; no measured jitter trace or deadline-miss reduction exists in the current experiment. All values on earlier slides are local reconstruction measurements, not end-to-end VR results.</a:t>
+              <a:t>Proposed future work; no measured jitter trace or deadline-miss reduction exists in the current experiment. Slides 6–7 add a fixed 2 ms decode budget to local reconstruction means. Other timing values are local reconstruction measurements. None are measured end-to-end VR results.</a:t>
             </a:r>
           </a:p>
         </p:txBody>
@@ -1057,7 +1057,7 @@
           <p:cNvPr id="3" name="Title">
             <a:extLst xmlns:a="http://schemas.openxmlformats.org/drawingml/2006/main">
               <a:ext uri="{FF2B5EF4-FFF2-40B4-BE49-F238E27FC236}">
-                <a16:creationId xmlns:a16="http://schemas.microsoft.com/office/drawing/2014/main" id="{53B0F3CA-B995-43B8-BCF6-5BF198EDE2DA}"/>
+                <a16:creationId xmlns:a16="http://schemas.microsoft.com/office/drawing/2014/main" id="{24DF9F45-FC59-43A7-8E20-E0E17B5E435A}"/>
               </a:ext>
             </a:extLst>
           </p:cNvPr>
@@ -1286,7 +1286,7 @@
           <p:cNvPr id="2" name="Subtitle">
             <a:extLst xmlns:a="http://schemas.openxmlformats.org/drawingml/2006/main">
               <a:ext uri="{FF2B5EF4-FFF2-40B4-BE49-F238E27FC236}">
-                <a16:creationId xmlns:a16="http://schemas.microsoft.com/office/drawing/2014/main" id="{5D4776D7-7636-467C-95F6-7EE027CDD7B8}"/>
+                <a16:creationId xmlns:a16="http://schemas.microsoft.com/office/drawing/2014/main" id="{E99F5678-E9E6-48B0-A2A6-8F11D7BCEFEB}"/>
               </a:ext>
             </a:extLst>
           </p:cNvPr>
@@ -1532,7 +1532,7 @@
           <p:cNvPr id="2" name="Section title">
             <a:extLst xmlns:a="http://schemas.openxmlformats.org/drawingml/2006/main">
               <a:ext uri="{FF2B5EF4-FFF2-40B4-BE49-F238E27FC236}">
-                <a16:creationId xmlns:a16="http://schemas.microsoft.com/office/drawing/2014/main" id="{24266225-5591-4159-AB0E-7FECC30AD65A}"/>
+                <a16:creationId xmlns:a16="http://schemas.microsoft.com/office/drawing/2014/main" id="{F85F409A-9725-4520-880C-43858F3CCC07}"/>
               </a:ext>
             </a:extLst>
           </p:cNvPr>
@@ -1778,7 +1778,7 @@
           <p:cNvPr id="3" name="Title">
             <a:extLst xmlns:a="http://schemas.openxmlformats.org/drawingml/2006/main">
               <a:ext uri="{FF2B5EF4-FFF2-40B4-BE49-F238E27FC236}">
-                <a16:creationId xmlns:a16="http://schemas.microsoft.com/office/drawing/2014/main" id="{A27CBAF5-30DB-4AEE-AF4C-096A620272B3}"/>
+                <a16:creationId xmlns:a16="http://schemas.microsoft.com/office/drawing/2014/main" id="{3DB4891D-6C48-476F-9DFA-0DD275715DA0}"/>
               </a:ext>
             </a:extLst>
           </p:cNvPr>
@@ -2007,7 +2007,7 @@
           <p:cNvPr id="2" name="Body">
             <a:extLst xmlns:a="http://schemas.openxmlformats.org/drawingml/2006/main">
               <a:ext uri="{FF2B5EF4-FFF2-40B4-BE49-F238E27FC236}">
-                <a16:creationId xmlns:a16="http://schemas.microsoft.com/office/drawing/2014/main" id="{39770540-F628-4A6F-95D9-37531F553B89}"/>
+                <a16:creationId xmlns:a16="http://schemas.microsoft.com/office/drawing/2014/main" id="{6F2B9A86-1DC6-4234-9BB9-8A94BB7626BC}"/>
               </a:ext>
             </a:extLst>
           </p:cNvPr>
@@ -2253,7 +2253,7 @@
           <p:cNvPr id="4" name="Title">
             <a:extLst xmlns:a="http://schemas.openxmlformats.org/drawingml/2006/main">
               <a:ext uri="{FF2B5EF4-FFF2-40B4-BE49-F238E27FC236}">
-                <a16:creationId xmlns:a16="http://schemas.microsoft.com/office/drawing/2014/main" id="{08EDB771-31F3-4BDC-9480-480A0777D1BA}"/>
+                <a16:creationId xmlns:a16="http://schemas.microsoft.com/office/drawing/2014/main" id="{8FB57DEF-1DC9-46FC-80AD-1F83CEDAE962}"/>
               </a:ext>
             </a:extLst>
           </p:cNvPr>
@@ -2482,7 +2482,7 @@
           <p:cNvPr id="2" name="Left column">
             <a:extLst xmlns:a="http://schemas.openxmlformats.org/drawingml/2006/main">
               <a:ext uri="{FF2B5EF4-FFF2-40B4-BE49-F238E27FC236}">
-                <a16:creationId xmlns:a16="http://schemas.microsoft.com/office/drawing/2014/main" id="{6A36DC38-3016-46D9-ABE0-7A12A0E62F48}"/>
+                <a16:creationId xmlns:a16="http://schemas.microsoft.com/office/drawing/2014/main" id="{F7A954F3-244F-4933-99CC-2270647BE5FE}"/>
               </a:ext>
             </a:extLst>
           </p:cNvPr>
@@ -2711,7 +2711,7 @@
           <p:cNvPr id="3" name="Right column">
             <a:extLst xmlns:a="http://schemas.openxmlformats.org/drawingml/2006/main">
               <a:ext uri="{FF2B5EF4-FFF2-40B4-BE49-F238E27FC236}">
-                <a16:creationId xmlns:a16="http://schemas.microsoft.com/office/drawing/2014/main" id="{7705E406-60B8-49C4-8F4F-2856FE65AFCD}"/>
+                <a16:creationId xmlns:a16="http://schemas.microsoft.com/office/drawing/2014/main" id="{FB6F6A27-07DD-40F4-B345-988849EE497E}"/>
               </a:ext>
             </a:extLst>
           </p:cNvPr>
@@ -2957,7 +2957,7 @@
           <p:cNvPr id="3" name="Title">
             <a:extLst xmlns:a="http://schemas.openxmlformats.org/drawingml/2006/main">
               <a:ext uri="{FF2B5EF4-FFF2-40B4-BE49-F238E27FC236}">
-                <a16:creationId xmlns:a16="http://schemas.microsoft.com/office/drawing/2014/main" id="{B3FC98C5-77A7-4B03-BF0A-612F54A39D56}"/>
+                <a16:creationId xmlns:a16="http://schemas.microsoft.com/office/drawing/2014/main" id="{F77423CC-3184-40D3-A01C-7E2DB3BE8CFD}"/>
               </a:ext>
             </a:extLst>
           </p:cNvPr>
@@ -3186,7 +3186,7 @@
           <p:cNvPr id="2" name="Left column">
             <a:extLst xmlns:a="http://schemas.openxmlformats.org/drawingml/2006/main">
               <a:ext uri="{FF2B5EF4-FFF2-40B4-BE49-F238E27FC236}">
-                <a16:creationId xmlns:a16="http://schemas.microsoft.com/office/drawing/2014/main" id="{AC931137-9332-4C46-B79A-D2D447FA2BE8}"/>
+                <a16:creationId xmlns:a16="http://schemas.microsoft.com/office/drawing/2014/main" id="{967BE377-8895-46AC-933F-8318019C8710}"/>
               </a:ext>
             </a:extLst>
           </p:cNvPr>
@@ -3453,12 +3453,12 @@
   </p:cSld>
   <p:clrMap bg1="lt1" tx1="dk1" bg2="lt2" tx2="dk2" accent1="accent1" accent2="accent2" accent3="accent3" accent4="accent4" accent5="accent5" accent6="accent6" hlink="hlink" folHlink="folHlink"/>
   <p:sldLayoutIdLst>
-    <p:sldLayoutId xmlns:r="http://schemas.openxmlformats.org/officeDocument/2006/relationships" id="2147483649" r:id="Rce3332a056fc4918"/>
-    <p:sldLayoutId xmlns:r="http://schemas.openxmlformats.org/officeDocument/2006/relationships" id="2147483650" r:id="R179c12af6dcf47fe"/>
-    <p:sldLayoutId xmlns:r="http://schemas.openxmlformats.org/officeDocument/2006/relationships" id="2147483651" r:id="R6cea72e1a5974a7c"/>
-    <p:sldLayoutId xmlns:r="http://schemas.openxmlformats.org/officeDocument/2006/relationships" id="2147483652" r:id="R0a834c8fcb26412b"/>
-    <p:sldLayoutId xmlns:r="http://schemas.openxmlformats.org/officeDocument/2006/relationships" id="2147483653" r:id="Rbc2ffeada08c464f"/>
-    <p:sldLayoutId xmlns:r="http://schemas.openxmlformats.org/officeDocument/2006/relationships" id="2147483654" r:id="R676f6aa6a4884b23"/>
+    <p:sldLayoutId xmlns:r="http://schemas.openxmlformats.org/officeDocument/2006/relationships" id="2147483649" r:id="R522db64f52a64598"/>
+    <p:sldLayoutId xmlns:r="http://schemas.openxmlformats.org/officeDocument/2006/relationships" id="2147483650" r:id="Rd8360840e281494a"/>
+    <p:sldLayoutId xmlns:r="http://schemas.openxmlformats.org/officeDocument/2006/relationships" id="2147483651" r:id="Rfcbd20d874ba4662"/>
+    <p:sldLayoutId xmlns:r="http://schemas.openxmlformats.org/officeDocument/2006/relationships" id="2147483652" r:id="R349cd0d644c14c22"/>
+    <p:sldLayoutId xmlns:r="http://schemas.openxmlformats.org/officeDocument/2006/relationships" id="2147483653" r:id="R6a93088c717a4517"/>
+    <p:sldLayoutId xmlns:r="http://schemas.openxmlformats.org/officeDocument/2006/relationships" id="2147483654" r:id="R9264f88eb0ff4dea"/>
   </p:sldLayoutIdLst>
   <p:txStyles>
     <p:titleStyle>
@@ -3998,7 +3998,7 @@
           <c:idx val="0"/>
           <c:order val="0"/>
           <c:tx>
-            <c:v>FOV resident</c:v>
+            <c:v>FOV resident + decode</c:v>
           </c:tx>
           <c:spPr>
             <a:solidFill xmlns:a="http://schemas.openxmlformats.org/drawingml/2006/main">
@@ -4036,19 +4036,19 @@
                 <c:formatCode>General</c:formatCode>
                 <c:ptCount val="5"/>
                 <c:pt idx="0">
-                  <c:v>4.562</c:v>
+                  <c:v>6.562</c:v>
                 </c:pt>
                 <c:pt idx="1">
-                  <c:v>4.77</c:v>
+                  <c:v>6.77</c:v>
                 </c:pt>
                 <c:pt idx="2">
-                  <c:v>5.998</c:v>
+                  <c:v>7.998</c:v>
                 </c:pt>
                 <c:pt idx="3">
-                  <c:v>7.772</c:v>
+                  <c:v>9.772</c:v>
                 </c:pt>
                 <c:pt idx="4">
-                  <c:v>10.425</c:v>
+                  <c:v>12.425</c:v>
                 </c:pt>
               </c:numCache>
             </c:numRef>
@@ -4058,7 +4058,7 @@
           <c:idx val="1"/>
           <c:order val="1"/>
           <c:tx>
-            <c:v>FOV stream</c:v>
+            <c:v>FOV stream + decode</c:v>
           </c:tx>
           <c:spPr>
             <a:solidFill xmlns:a="http://schemas.openxmlformats.org/drawingml/2006/main">
@@ -4096,19 +4096,19 @@
                 <c:formatCode>General</c:formatCode>
                 <c:ptCount val="5"/>
                 <c:pt idx="0">
-                  <c:v>6.364</c:v>
+                  <c:v>8.364</c:v>
                 </c:pt>
                 <c:pt idx="1">
-                  <c:v>6.728</c:v>
+                  <c:v>8.728</c:v>
                 </c:pt>
                 <c:pt idx="2">
-                  <c:v>7.839</c:v>
+                  <c:v>9.839</c:v>
                 </c:pt>
                 <c:pt idx="3">
-                  <c:v>9.655</c:v>
+                  <c:v>11.655</c:v>
                 </c:pt>
                 <c:pt idx="4">
-                  <c:v>12.193</c:v>
+                  <c:v>14.193</c:v>
                 </c:pt>
               </c:numCache>
             </c:numRef>
@@ -4118,7 +4118,7 @@
           <c:idx val="2"/>
           <c:order val="2"/>
           <c:tx>
-            <c:v>Full resident</c:v>
+            <c:v>Full resident + decode</c:v>
           </c:tx>
           <c:spPr>
             <a:solidFill xmlns:a="http://schemas.openxmlformats.org/drawingml/2006/main">
@@ -4156,19 +4156,19 @@
                 <c:formatCode>General</c:formatCode>
                 <c:ptCount val="5"/>
                 <c:pt idx="0">
-                  <c:v>11.187</c:v>
+                  <c:v>13.187</c:v>
                 </c:pt>
                 <c:pt idx="1">
-                  <c:v>11.022</c:v>
+                  <c:v>13.022</c:v>
                 </c:pt>
                 <c:pt idx="2">
-                  <c:v>11.144</c:v>
+                  <c:v>13.144</c:v>
                 </c:pt>
                 <c:pt idx="3">
-                  <c:v>11.042</c:v>
+                  <c:v>13.042</c:v>
                 </c:pt>
                 <c:pt idx="4">
-                  <c:v>11.087</c:v>
+                  <c:v>13.087</c:v>
                 </c:pt>
               </c:numCache>
             </c:numRef>
@@ -4241,7 +4241,7 @@
         <c:axId val="48672768"/>
         <c:scaling>
           <c:orientation val="minMax"/>
-          <c:max val="14"/>
+          <c:max val="16"/>
           <c:min val="0"/>
         </c:scaling>
         <c:delete val="0"/>
@@ -4267,7 +4267,7 @@
                     <a:ea typeface="Arial"/>
                     <a:cs typeface="Arial"/>
                   </a:rPr>
-                  <a:t>Mean latency (ms)</a:t>
+                  <a:t>Decode + recon mean (ms)</a:t>
                 </a:r>
               </a:p>
             </c:rich>
@@ -4332,7 +4332,7 @@
         <a:lstStyle xmlns:a="http://schemas.openxmlformats.org/drawingml/2006/main"/>
         <a:p xmlns:a="http://schemas.openxmlformats.org/drawingml/2006/main">
           <a:pPr>
-            <a:defRPr sz="1650">
+            <a:defRPr sz="1350">
               <a:latin typeface="Arial"/>
               <a:ea typeface="Arial"/>
               <a:cs typeface="Arial"/>
@@ -4378,7 +4378,7 @@
           <p:cNvPr id="5" name="">
             <a:extLst xmlns:a="http://schemas.openxmlformats.org/drawingml/2006/main">
               <a:ext uri="{FF2B5EF4-FFF2-40B4-BE49-F238E27FC236}">
-                <a16:creationId xmlns:a16="http://schemas.microsoft.com/office/drawing/2014/main" id="{DDB2A384-FF04-4046-A5ED-115DB2333568}"/>
+                <a16:creationId xmlns:a16="http://schemas.microsoft.com/office/drawing/2014/main" id="{18A92686-69A8-404D-BF9C-906CB70FF613}"/>
               </a:ext>
             </a:extLst>
           </p:cNvPr>
@@ -4436,7 +4436,7 @@
           <p:cNvPr id="2" name="">
             <a:extLst xmlns:a="http://schemas.openxmlformats.org/drawingml/2006/main">
               <a:ext uri="{FF2B5EF4-FFF2-40B4-BE49-F238E27FC236}">
-                <a16:creationId xmlns:a16="http://schemas.microsoft.com/office/drawing/2014/main" id="{8661B8C9-E005-4110-A057-69C5DC76FA8F}"/>
+                <a16:creationId xmlns:a16="http://schemas.microsoft.com/office/drawing/2014/main" id="{EDF7C31D-EE95-4DF4-9708-AA0E667A0BDF}"/>
               </a:ext>
             </a:extLst>
           </p:cNvPr>
@@ -4481,7 +4481,7 @@
           <p:cNvPr id="3" name="">
             <a:extLst xmlns:a="http://schemas.openxmlformats.org/drawingml/2006/main">
               <a:ext uri="{FF2B5EF4-FFF2-40B4-BE49-F238E27FC236}">
-                <a16:creationId xmlns:a16="http://schemas.microsoft.com/office/drawing/2014/main" id="{B8A586E8-9C59-42B0-9F19-B213110E2AF2}"/>
+                <a16:creationId xmlns:a16="http://schemas.microsoft.com/office/drawing/2014/main" id="{DEFC9F8B-EC62-464A-B627-673AD38115F3}"/>
               </a:ext>
             </a:extLst>
           </p:cNvPr>
@@ -4526,7 +4526,7 @@
           <p:cNvPr id="4" name="">
             <a:extLst xmlns:a="http://schemas.openxmlformats.org/drawingml/2006/main">
               <a:ext uri="{FF2B5EF4-FFF2-40B4-BE49-F238E27FC236}">
-                <a16:creationId xmlns:a16="http://schemas.microsoft.com/office/drawing/2014/main" id="{A8B87511-E3EE-44CD-9D8B-84822E917FF5}"/>
+                <a16:creationId xmlns:a16="http://schemas.microsoft.com/office/drawing/2014/main" id="{6D2C45ED-149A-4E57-A1F9-C5AD2D9A2456}"/>
               </a:ext>
             </a:extLst>
           </p:cNvPr>
@@ -4569,7 +4569,7 @@
     </p:spTree>
     <p:extLst>
       <p:ext uri="{BB962C8B-B14F-4D97-AF65-F5344CB8AC3E}">
-        <p14:creationId xmlns:p14="http://schemas.microsoft.com/office/powerpoint/2010/main" val="2961831"/>
+        <p14:creationId xmlns:p14="http://schemas.microsoft.com/office/powerpoint/2010/main" val="1115952735"/>
       </p:ext>
     </p:extLst>
   </p:cSld>
@@ -4600,7 +4600,7 @@
           <p:cNvPr id="29" name="">
             <a:extLst xmlns:a="http://schemas.openxmlformats.org/drawingml/2006/main">
               <a:ext uri="{FF2B5EF4-FFF2-40B4-BE49-F238E27FC236}">
-                <a16:creationId xmlns:a16="http://schemas.microsoft.com/office/drawing/2014/main" id="{2E063392-741F-4F85-A5DC-6719BC43EA14}"/>
+                <a16:creationId xmlns:a16="http://schemas.microsoft.com/office/drawing/2014/main" id="{CFACBA5B-61E3-47F2-B03F-9BCA5C521B64}"/>
               </a:ext>
             </a:extLst>
           </p:cNvPr>
@@ -4645,7 +4645,7 @@
           <p:cNvPr id="2" name="">
             <a:extLst xmlns:a="http://schemas.openxmlformats.org/drawingml/2006/main">
               <a:ext uri="{FF2B5EF4-FFF2-40B4-BE49-F238E27FC236}">
-                <a16:creationId xmlns:a16="http://schemas.microsoft.com/office/drawing/2014/main" id="{81CDF089-028D-40B1-B4E3-61B4BA70CA52}"/>
+                <a16:creationId xmlns:a16="http://schemas.microsoft.com/office/drawing/2014/main" id="{1D927697-DC3B-4E3B-B8D4-98A7D8C8C334}"/>
               </a:ext>
             </a:extLst>
           </p:cNvPr>
@@ -4675,7 +4675,7 @@
           <p:cNvPr id="3" name="">
             <a:extLst xmlns:a="http://schemas.openxmlformats.org/drawingml/2006/main">
               <a:ext uri="{FF2B5EF4-FFF2-40B4-BE49-F238E27FC236}">
-                <a16:creationId xmlns:a16="http://schemas.microsoft.com/office/drawing/2014/main" id="{3292FC01-CB3D-4515-8C7E-C4465174AC00}"/>
+                <a16:creationId xmlns:a16="http://schemas.microsoft.com/office/drawing/2014/main" id="{9AE51353-61A1-4D91-9F51-0DE8D3514082}"/>
               </a:ext>
             </a:extLst>
           </p:cNvPr>
@@ -4720,7 +4720,7 @@
           <p:cNvPr id="4" name="">
             <a:extLst xmlns:a="http://schemas.openxmlformats.org/drawingml/2006/main">
               <a:ext uri="{FF2B5EF4-FFF2-40B4-BE49-F238E27FC236}">
-                <a16:creationId xmlns:a16="http://schemas.microsoft.com/office/drawing/2014/main" id="{0E76FE23-6168-4F52-8230-4984F9930120}"/>
+                <a16:creationId xmlns:a16="http://schemas.microsoft.com/office/drawing/2014/main" id="{717DEF9D-440C-4ED1-B077-9B2F49B5D2A2}"/>
               </a:ext>
             </a:extLst>
           </p:cNvPr>
@@ -4765,7 +4765,7 @@
           <p:cNvPr id="5" name="">
             <a:extLst xmlns:a="http://schemas.openxmlformats.org/drawingml/2006/main">
               <a:ext uri="{FF2B5EF4-FFF2-40B4-BE49-F238E27FC236}">
-                <a16:creationId xmlns:a16="http://schemas.microsoft.com/office/drawing/2014/main" id="{4C8FDB8A-61CB-4851-8B11-2B17EB125AB4}"/>
+                <a16:creationId xmlns:a16="http://schemas.microsoft.com/office/drawing/2014/main" id="{48DFAA68-2115-4444-96DC-62CE0473F8D5}"/>
               </a:ext>
             </a:extLst>
           </p:cNvPr>
@@ -4810,7 +4810,7 @@
           <p:cNvPr id="6" name="">
             <a:extLst xmlns:a="http://schemas.openxmlformats.org/drawingml/2006/main">
               <a:ext uri="{FF2B5EF4-FFF2-40B4-BE49-F238E27FC236}">
-                <a16:creationId xmlns:a16="http://schemas.microsoft.com/office/drawing/2014/main" id="{1CF9A359-62B2-419D-98DF-0D6C04D8E557}"/>
+                <a16:creationId xmlns:a16="http://schemas.microsoft.com/office/drawing/2014/main" id="{4956E592-2F82-44C5-9469-995AE73843C2}"/>
               </a:ext>
             </a:extLst>
           </p:cNvPr>
@@ -4842,7 +4842,7 @@
           <p:cNvPr id="7" name="">
             <a:extLst xmlns:a="http://schemas.openxmlformats.org/drawingml/2006/main">
               <a:ext uri="{FF2B5EF4-FFF2-40B4-BE49-F238E27FC236}">
-                <a16:creationId xmlns:a16="http://schemas.microsoft.com/office/drawing/2014/main" id="{11E522F5-1882-47DD-B69D-2EE29EEA3378}"/>
+                <a16:creationId xmlns:a16="http://schemas.microsoft.com/office/drawing/2014/main" id="{7675879B-9EE6-4BB0-8A64-41A02C8D7FB1}"/>
               </a:ext>
             </a:extLst>
           </p:cNvPr>
@@ -4874,7 +4874,7 @@
           <p:cNvPr id="8" name="">
             <a:extLst xmlns:a="http://schemas.openxmlformats.org/drawingml/2006/main">
               <a:ext uri="{FF2B5EF4-FFF2-40B4-BE49-F238E27FC236}">
-                <a16:creationId xmlns:a16="http://schemas.microsoft.com/office/drawing/2014/main" id="{AB8C1874-3339-4177-83EA-31474ACE3026}"/>
+                <a16:creationId xmlns:a16="http://schemas.microsoft.com/office/drawing/2014/main" id="{23D579B2-D07D-4DB3-A782-E5C591B4FE97}"/>
               </a:ext>
             </a:extLst>
           </p:cNvPr>
@@ -4906,7 +4906,7 @@
           <p:cNvPr id="9" name="">
             <a:extLst xmlns:a="http://schemas.openxmlformats.org/drawingml/2006/main">
               <a:ext uri="{FF2B5EF4-FFF2-40B4-BE49-F238E27FC236}">
-                <a16:creationId xmlns:a16="http://schemas.microsoft.com/office/drawing/2014/main" id="{B308A967-AB33-41A2-98AA-9D046C9C2F7F}"/>
+                <a16:creationId xmlns:a16="http://schemas.microsoft.com/office/drawing/2014/main" id="{2D39941B-E404-40D0-8F56-CE9C8D36764A}"/>
               </a:ext>
             </a:extLst>
           </p:cNvPr>
@@ -4951,7 +4951,7 @@
           <p:cNvPr id="10" name="">
             <a:extLst xmlns:a="http://schemas.openxmlformats.org/drawingml/2006/main">
               <a:ext uri="{FF2B5EF4-FFF2-40B4-BE49-F238E27FC236}">
-                <a16:creationId xmlns:a16="http://schemas.microsoft.com/office/drawing/2014/main" id="{2F4D20C9-35C4-48B3-8101-B9F3BB514504}"/>
+                <a16:creationId xmlns:a16="http://schemas.microsoft.com/office/drawing/2014/main" id="{E9C0D35C-CAA1-4A01-A44E-8F6E279ABF78}"/>
               </a:ext>
             </a:extLst>
           </p:cNvPr>
@@ -4981,7 +4981,7 @@
           <p:cNvPr id="11" name="">
             <a:extLst xmlns:a="http://schemas.openxmlformats.org/drawingml/2006/main">
               <a:ext uri="{FF2B5EF4-FFF2-40B4-BE49-F238E27FC236}">
-                <a16:creationId xmlns:a16="http://schemas.microsoft.com/office/drawing/2014/main" id="{184350B4-FC84-45C3-A863-A3DCC1F07340}"/>
+                <a16:creationId xmlns:a16="http://schemas.microsoft.com/office/drawing/2014/main" id="{D4BBE91A-B035-4303-B58B-D935DDAC270A}"/>
               </a:ext>
             </a:extLst>
           </p:cNvPr>
@@ -5026,7 +5026,7 @@
           <p:cNvPr id="12" name="">
             <a:extLst xmlns:a="http://schemas.openxmlformats.org/drawingml/2006/main">
               <a:ext uri="{FF2B5EF4-FFF2-40B4-BE49-F238E27FC236}">
-                <a16:creationId xmlns:a16="http://schemas.microsoft.com/office/drawing/2014/main" id="{9E522627-D36D-40D1-A0C1-32118F372968}"/>
+                <a16:creationId xmlns:a16="http://schemas.microsoft.com/office/drawing/2014/main" id="{D73934C4-E1F2-48C0-9BC6-8239FCE3D153}"/>
               </a:ext>
             </a:extLst>
           </p:cNvPr>
@@ -5058,7 +5058,7 @@
           <p:cNvPr id="13" name="">
             <a:extLst xmlns:a="http://schemas.openxmlformats.org/drawingml/2006/main">
               <a:ext uri="{FF2B5EF4-FFF2-40B4-BE49-F238E27FC236}">
-                <a16:creationId xmlns:a16="http://schemas.microsoft.com/office/drawing/2014/main" id="{35D999D8-1538-4789-9DC3-C68C414EA56D}"/>
+                <a16:creationId xmlns:a16="http://schemas.microsoft.com/office/drawing/2014/main" id="{329CE209-3F3F-4EA7-BEE0-C33B656BDE2D}"/>
               </a:ext>
             </a:extLst>
           </p:cNvPr>
@@ -5090,7 +5090,7 @@
           <p:cNvPr id="14" name="">
             <a:extLst xmlns:a="http://schemas.openxmlformats.org/drawingml/2006/main">
               <a:ext uri="{FF2B5EF4-FFF2-40B4-BE49-F238E27FC236}">
-                <a16:creationId xmlns:a16="http://schemas.microsoft.com/office/drawing/2014/main" id="{5BC558EB-01D8-4BB7-B54B-20038F09277C}"/>
+                <a16:creationId xmlns:a16="http://schemas.microsoft.com/office/drawing/2014/main" id="{E49D505D-1576-4936-B9BE-22345E10BBC7}"/>
               </a:ext>
             </a:extLst>
           </p:cNvPr>
@@ -5122,7 +5122,7 @@
           <p:cNvPr id="15" name="">
             <a:extLst xmlns:a="http://schemas.openxmlformats.org/drawingml/2006/main">
               <a:ext uri="{FF2B5EF4-FFF2-40B4-BE49-F238E27FC236}">
-                <a16:creationId xmlns:a16="http://schemas.microsoft.com/office/drawing/2014/main" id="{410EBEEE-009C-472B-BB20-8BB9C57B4A40}"/>
+                <a16:creationId xmlns:a16="http://schemas.microsoft.com/office/drawing/2014/main" id="{A5AA3B68-26C2-44A4-941C-92E5B4F81156}"/>
               </a:ext>
             </a:extLst>
           </p:cNvPr>
@@ -5167,7 +5167,7 @@
           <p:cNvPr id="16" name="">
             <a:extLst xmlns:a="http://schemas.openxmlformats.org/drawingml/2006/main">
               <a:ext uri="{FF2B5EF4-FFF2-40B4-BE49-F238E27FC236}">
-                <a16:creationId xmlns:a16="http://schemas.microsoft.com/office/drawing/2014/main" id="{BE695C71-40B7-4C27-86FF-E50F1F0CAFAD}"/>
+                <a16:creationId xmlns:a16="http://schemas.microsoft.com/office/drawing/2014/main" id="{94CD312C-F2C4-4FE4-A897-31C4A1587F37}"/>
               </a:ext>
             </a:extLst>
           </p:cNvPr>
@@ -5197,7 +5197,7 @@
           <p:cNvPr id="17" name="">
             <a:extLst xmlns:a="http://schemas.openxmlformats.org/drawingml/2006/main">
               <a:ext uri="{FF2B5EF4-FFF2-40B4-BE49-F238E27FC236}">
-                <a16:creationId xmlns:a16="http://schemas.microsoft.com/office/drawing/2014/main" id="{97305A18-1F82-47EE-B864-7E1D4714C13F}"/>
+                <a16:creationId xmlns:a16="http://schemas.microsoft.com/office/drawing/2014/main" id="{D8166C1B-F7E0-40A8-AFAF-3F7052F3478E}"/>
               </a:ext>
             </a:extLst>
           </p:cNvPr>
@@ -5242,7 +5242,7 @@
           <p:cNvPr id="18" name="">
             <a:extLst xmlns:a="http://schemas.openxmlformats.org/drawingml/2006/main">
               <a:ext uri="{FF2B5EF4-FFF2-40B4-BE49-F238E27FC236}">
-                <a16:creationId xmlns:a16="http://schemas.microsoft.com/office/drawing/2014/main" id="{9FC688D0-F317-47AF-B4D4-64F95544E8C6}"/>
+                <a16:creationId xmlns:a16="http://schemas.microsoft.com/office/drawing/2014/main" id="{EE17512B-AB56-40E4-9032-A24F7AFC336E}"/>
               </a:ext>
             </a:extLst>
           </p:cNvPr>
@@ -5274,7 +5274,7 @@
           <p:cNvPr id="19" name="">
             <a:extLst xmlns:a="http://schemas.openxmlformats.org/drawingml/2006/main">
               <a:ext uri="{FF2B5EF4-FFF2-40B4-BE49-F238E27FC236}">
-                <a16:creationId xmlns:a16="http://schemas.microsoft.com/office/drawing/2014/main" id="{DAAE2591-6C85-4DA1-B085-971A30D67D51}"/>
+                <a16:creationId xmlns:a16="http://schemas.microsoft.com/office/drawing/2014/main" id="{C71BB703-B3F8-42D3-9070-6D6CCD5D3E83}"/>
               </a:ext>
             </a:extLst>
           </p:cNvPr>
@@ -5306,7 +5306,7 @@
           <p:cNvPr id="20" name="">
             <a:extLst xmlns:a="http://schemas.openxmlformats.org/drawingml/2006/main">
               <a:ext uri="{FF2B5EF4-FFF2-40B4-BE49-F238E27FC236}">
-                <a16:creationId xmlns:a16="http://schemas.microsoft.com/office/drawing/2014/main" id="{A3D7A1B3-B30F-40DF-9C2F-C0F5F64A99BC}"/>
+                <a16:creationId xmlns:a16="http://schemas.microsoft.com/office/drawing/2014/main" id="{22D73F84-4B01-4BE5-8854-F9621405F3D2}"/>
               </a:ext>
             </a:extLst>
           </p:cNvPr>
@@ -5338,7 +5338,7 @@
           <p:cNvPr id="21" name="">
             <a:extLst xmlns:a="http://schemas.openxmlformats.org/drawingml/2006/main">
               <a:ext uri="{FF2B5EF4-FFF2-40B4-BE49-F238E27FC236}">
-                <a16:creationId xmlns:a16="http://schemas.microsoft.com/office/drawing/2014/main" id="{AA9D8C4A-4E43-4376-99F9-9FDB7E78B40D}"/>
+                <a16:creationId xmlns:a16="http://schemas.microsoft.com/office/drawing/2014/main" id="{FE8BDCF4-1BDC-4FB5-9D2B-1FC26B0E90E6}"/>
               </a:ext>
             </a:extLst>
           </p:cNvPr>
@@ -5383,7 +5383,7 @@
           <p:cNvPr id="22" name="">
             <a:extLst xmlns:a="http://schemas.openxmlformats.org/drawingml/2006/main">
               <a:ext uri="{FF2B5EF4-FFF2-40B4-BE49-F238E27FC236}">
-                <a16:creationId xmlns:a16="http://schemas.microsoft.com/office/drawing/2014/main" id="{62591B25-423D-45DF-B386-1B2FE1785354}"/>
+                <a16:creationId xmlns:a16="http://schemas.microsoft.com/office/drawing/2014/main" id="{B919BD31-FCED-4FC8-85CA-9CD710E4E1B9}"/>
               </a:ext>
             </a:extLst>
           </p:cNvPr>
@@ -5413,7 +5413,7 @@
           <p:cNvPr id="23" name="">
             <a:extLst xmlns:a="http://schemas.openxmlformats.org/drawingml/2006/main">
               <a:ext uri="{FF2B5EF4-FFF2-40B4-BE49-F238E27FC236}">
-                <a16:creationId xmlns:a16="http://schemas.microsoft.com/office/drawing/2014/main" id="{6634655C-4D7B-4FE0-877E-6700866BE581}"/>
+                <a16:creationId xmlns:a16="http://schemas.microsoft.com/office/drawing/2014/main" id="{0EA1022C-05F1-41DC-9737-CB8FFCBFD135}"/>
               </a:ext>
             </a:extLst>
           </p:cNvPr>
@@ -5443,7 +5443,7 @@
           <p:cNvPr id="24" name="">
             <a:extLst xmlns:a="http://schemas.openxmlformats.org/drawingml/2006/main">
               <a:ext uri="{FF2B5EF4-FFF2-40B4-BE49-F238E27FC236}">
-                <a16:creationId xmlns:a16="http://schemas.microsoft.com/office/drawing/2014/main" id="{0DD2E6B6-02C5-4A3F-B387-153315FAD169}"/>
+                <a16:creationId xmlns:a16="http://schemas.microsoft.com/office/drawing/2014/main" id="{6CE8ED73-E5FD-47F8-BBB3-FF8128194A21}"/>
               </a:ext>
             </a:extLst>
           </p:cNvPr>
@@ -5488,7 +5488,7 @@
           <p:cNvPr id="25" name="">
             <a:extLst xmlns:a="http://schemas.openxmlformats.org/drawingml/2006/main">
               <a:ext uri="{FF2B5EF4-FFF2-40B4-BE49-F238E27FC236}">
-                <a16:creationId xmlns:a16="http://schemas.microsoft.com/office/drawing/2014/main" id="{F69680EB-96B8-4A72-904D-F2F823E457CC}"/>
+                <a16:creationId xmlns:a16="http://schemas.microsoft.com/office/drawing/2014/main" id="{432615EE-953F-4D41-98FF-81B2F3B59F80}"/>
               </a:ext>
             </a:extLst>
           </p:cNvPr>
@@ -5533,7 +5533,7 @@
           <p:cNvPr id="26" name="">
             <a:extLst xmlns:a="http://schemas.openxmlformats.org/drawingml/2006/main">
               <a:ext uri="{FF2B5EF4-FFF2-40B4-BE49-F238E27FC236}">
-                <a16:creationId xmlns:a16="http://schemas.microsoft.com/office/drawing/2014/main" id="{2730D76E-EDFF-4020-93DE-811F40BCC058}"/>
+                <a16:creationId xmlns:a16="http://schemas.microsoft.com/office/drawing/2014/main" id="{E7090F4F-6A13-401E-88AA-5D2D26BDE2C6}"/>
               </a:ext>
             </a:extLst>
           </p:cNvPr>
@@ -5578,7 +5578,7 @@
           <p:cNvPr id="27" name="">
             <a:extLst xmlns:a="http://schemas.openxmlformats.org/drawingml/2006/main">
               <a:ext uri="{FF2B5EF4-FFF2-40B4-BE49-F238E27FC236}">
-                <a16:creationId xmlns:a16="http://schemas.microsoft.com/office/drawing/2014/main" id="{CA735592-6A12-4863-AE16-C93931024812}"/>
+                <a16:creationId xmlns:a16="http://schemas.microsoft.com/office/drawing/2014/main" id="{DC95FF47-4A38-452E-949E-41BCD2D49EC3}"/>
               </a:ext>
             </a:extLst>
           </p:cNvPr>
@@ -5623,7 +5623,7 @@
           <p:cNvPr id="28" name="">
             <a:extLst xmlns:a="http://schemas.openxmlformats.org/drawingml/2006/main">
               <a:ext uri="{FF2B5EF4-FFF2-40B4-BE49-F238E27FC236}">
-                <a16:creationId xmlns:a16="http://schemas.microsoft.com/office/drawing/2014/main" id="{9CED6A45-CD50-4694-82E8-D872D517EDBB}"/>
+                <a16:creationId xmlns:a16="http://schemas.microsoft.com/office/drawing/2014/main" id="{E1E987A0-055A-4AF1-B6FC-89F53AF18379}"/>
               </a:ext>
             </a:extLst>
           </p:cNvPr>
@@ -5666,7 +5666,7 @@
     </p:spTree>
     <p:extLst>
       <p:ext uri="{BB962C8B-B14F-4D97-AF65-F5344CB8AC3E}">
-        <p14:creationId xmlns:p14="http://schemas.microsoft.com/office/powerpoint/2010/main" val="2062102666"/>
+        <p14:creationId xmlns:p14="http://schemas.microsoft.com/office/powerpoint/2010/main" val="1772143501"/>
       </p:ext>
     </p:extLst>
   </p:cSld>
@@ -5697,7 +5697,7 @@
           <p:cNvPr id="15" name="">
             <a:extLst xmlns:a="http://schemas.openxmlformats.org/drawingml/2006/main">
               <a:ext uri="{FF2B5EF4-FFF2-40B4-BE49-F238E27FC236}">
-                <a16:creationId xmlns:a16="http://schemas.microsoft.com/office/drawing/2014/main" id="{FECE25B3-EA91-46C9-BA2F-885CFC473553}"/>
+                <a16:creationId xmlns:a16="http://schemas.microsoft.com/office/drawing/2014/main" id="{48314488-95F5-4A89-8254-28504070AEC4}"/>
               </a:ext>
             </a:extLst>
           </p:cNvPr>
@@ -5742,7 +5742,7 @@
           <p:cNvPr id="2" name="">
             <a:extLst xmlns:a="http://schemas.openxmlformats.org/drawingml/2006/main">
               <a:ext uri="{FF2B5EF4-FFF2-40B4-BE49-F238E27FC236}">
-                <a16:creationId xmlns:a16="http://schemas.microsoft.com/office/drawing/2014/main" id="{1992ED6E-33E7-40CF-B909-8CC55A0C4730}"/>
+                <a16:creationId xmlns:a16="http://schemas.microsoft.com/office/drawing/2014/main" id="{E37F8AF4-6809-4482-ABDE-A956CF01A1F2}"/>
               </a:ext>
             </a:extLst>
           </p:cNvPr>
@@ -5772,7 +5772,7 @@
           <p:cNvPr id="3" name="">
             <a:extLst xmlns:a="http://schemas.openxmlformats.org/drawingml/2006/main">
               <a:ext uri="{FF2B5EF4-FFF2-40B4-BE49-F238E27FC236}">
-                <a16:creationId xmlns:a16="http://schemas.microsoft.com/office/drawing/2014/main" id="{4C4B68CD-6C11-4985-960E-AC7D20599983}"/>
+                <a16:creationId xmlns:a16="http://schemas.microsoft.com/office/drawing/2014/main" id="{949D0F0D-9A1F-4622-843D-15752C163B25}"/>
               </a:ext>
             </a:extLst>
           </p:cNvPr>
@@ -5817,7 +5817,7 @@
           <p:cNvPr id="4" name="">
             <a:extLst xmlns:a="http://schemas.openxmlformats.org/drawingml/2006/main">
               <a:ext uri="{FF2B5EF4-FFF2-40B4-BE49-F238E27FC236}">
-                <a16:creationId xmlns:a16="http://schemas.microsoft.com/office/drawing/2014/main" id="{DED681BD-EFC1-4572-8FD3-465FA69AFBCD}"/>
+                <a16:creationId xmlns:a16="http://schemas.microsoft.com/office/drawing/2014/main" id="{54F45F1E-AF93-434A-A128-03E7F0FE12AA}"/>
               </a:ext>
             </a:extLst>
           </p:cNvPr>
@@ -5862,7 +5862,7 @@
           <p:cNvPr id="5" name="">
             <a:extLst xmlns:a="http://schemas.openxmlformats.org/drawingml/2006/main">
               <a:ext uri="{FF2B5EF4-FFF2-40B4-BE49-F238E27FC236}">
-                <a16:creationId xmlns:a16="http://schemas.microsoft.com/office/drawing/2014/main" id="{C69E7F0D-8077-4629-ABBC-A90F907A6F94}"/>
+                <a16:creationId xmlns:a16="http://schemas.microsoft.com/office/drawing/2014/main" id="{67369606-E028-46D9-8868-903DFD15430F}"/>
               </a:ext>
             </a:extLst>
           </p:cNvPr>
@@ -5894,7 +5894,7 @@
           <p:cNvPr id="6" name="">
             <a:extLst xmlns:a="http://schemas.openxmlformats.org/drawingml/2006/main">
               <a:ext uri="{FF2B5EF4-FFF2-40B4-BE49-F238E27FC236}">
-                <a16:creationId xmlns:a16="http://schemas.microsoft.com/office/drawing/2014/main" id="{F7D02B66-0BE3-4C09-8BE4-7D6285CCA98D}"/>
+                <a16:creationId xmlns:a16="http://schemas.microsoft.com/office/drawing/2014/main" id="{945721C7-F459-4F06-AEF1-4DB2416DB582}"/>
               </a:ext>
             </a:extLst>
           </p:cNvPr>
@@ -5926,7 +5926,7 @@
           <p:cNvPr id="7" name="">
             <a:extLst xmlns:a="http://schemas.openxmlformats.org/drawingml/2006/main">
               <a:ext uri="{FF2B5EF4-FFF2-40B4-BE49-F238E27FC236}">
-                <a16:creationId xmlns:a16="http://schemas.microsoft.com/office/drawing/2014/main" id="{81410DC1-E3A8-42CC-B843-2123B3FB3EE9}"/>
+                <a16:creationId xmlns:a16="http://schemas.microsoft.com/office/drawing/2014/main" id="{1BCF0B65-24E1-40D5-8BE1-26397FC0DD3C}"/>
               </a:ext>
             </a:extLst>
           </p:cNvPr>
@@ -5958,7 +5958,7 @@
           <p:cNvPr id="8" name="">
             <a:extLst xmlns:a="http://schemas.openxmlformats.org/drawingml/2006/main">
               <a:ext uri="{FF2B5EF4-FFF2-40B4-BE49-F238E27FC236}">
-                <a16:creationId xmlns:a16="http://schemas.microsoft.com/office/drawing/2014/main" id="{2A7E3BCB-0C34-4D83-AA4D-EEDE9D593551}"/>
+                <a16:creationId xmlns:a16="http://schemas.microsoft.com/office/drawing/2014/main" id="{DF164F27-6195-4D55-925C-B8C3774314BD}"/>
               </a:ext>
             </a:extLst>
           </p:cNvPr>
@@ -6003,7 +6003,7 @@
           <p:cNvPr id="9" name="">
             <a:extLst xmlns:a="http://schemas.openxmlformats.org/drawingml/2006/main">
               <a:ext uri="{FF2B5EF4-FFF2-40B4-BE49-F238E27FC236}">
-                <a16:creationId xmlns:a16="http://schemas.microsoft.com/office/drawing/2014/main" id="{B5CEB872-5FCB-483A-A1C2-DF2926CFE0C9}"/>
+                <a16:creationId xmlns:a16="http://schemas.microsoft.com/office/drawing/2014/main" id="{5904871F-AFF8-4475-8D9D-73415AD2C852}"/>
               </a:ext>
             </a:extLst>
           </p:cNvPr>
@@ -6048,7 +6048,7 @@
           <p:cNvPr id="10" name="">
             <a:extLst xmlns:a="http://schemas.openxmlformats.org/drawingml/2006/main">
               <a:ext uri="{FF2B5EF4-FFF2-40B4-BE49-F238E27FC236}">
-                <a16:creationId xmlns:a16="http://schemas.microsoft.com/office/drawing/2014/main" id="{6D8AE9A6-9964-4F55-A13D-F87955F66BDB}"/>
+                <a16:creationId xmlns:a16="http://schemas.microsoft.com/office/drawing/2014/main" id="{9E9FF4C9-3B3D-4243-AE2B-A77DE38A4ADB}"/>
               </a:ext>
             </a:extLst>
           </p:cNvPr>
@@ -6080,7 +6080,7 @@
           <p:cNvPr id="11" name="">
             <a:extLst xmlns:a="http://schemas.openxmlformats.org/drawingml/2006/main">
               <a:ext uri="{FF2B5EF4-FFF2-40B4-BE49-F238E27FC236}">
-                <a16:creationId xmlns:a16="http://schemas.microsoft.com/office/drawing/2014/main" id="{DD7C5BD7-B00C-4A09-9F85-B1FE3533122A}"/>
+                <a16:creationId xmlns:a16="http://schemas.microsoft.com/office/drawing/2014/main" id="{CE88174E-7E5A-4433-AAB6-44E2B2869984}"/>
               </a:ext>
             </a:extLst>
           </p:cNvPr>
@@ -6112,7 +6112,7 @@
           <p:cNvPr id="12" name="">
             <a:extLst xmlns:a="http://schemas.openxmlformats.org/drawingml/2006/main">
               <a:ext uri="{FF2B5EF4-FFF2-40B4-BE49-F238E27FC236}">
-                <a16:creationId xmlns:a16="http://schemas.microsoft.com/office/drawing/2014/main" id="{38EB2678-6646-4863-872B-00FD2DC9862B}"/>
+                <a16:creationId xmlns:a16="http://schemas.microsoft.com/office/drawing/2014/main" id="{1217363F-B071-4FF4-8C04-72A3F84CAFFB}"/>
               </a:ext>
             </a:extLst>
           </p:cNvPr>
@@ -6144,7 +6144,7 @@
           <p:cNvPr id="13" name="">
             <a:extLst xmlns:a="http://schemas.openxmlformats.org/drawingml/2006/main">
               <a:ext uri="{FF2B5EF4-FFF2-40B4-BE49-F238E27FC236}">
-                <a16:creationId xmlns:a16="http://schemas.microsoft.com/office/drawing/2014/main" id="{F08CE3DA-6AED-4B93-B1BE-3045ABAAD628}"/>
+                <a16:creationId xmlns:a16="http://schemas.microsoft.com/office/drawing/2014/main" id="{FE88A4C2-F210-4103-84F5-FA660E99F2B8}"/>
               </a:ext>
             </a:extLst>
           </p:cNvPr>
@@ -6189,7 +6189,7 @@
           <p:cNvPr id="14" name="">
             <a:extLst xmlns:a="http://schemas.openxmlformats.org/drawingml/2006/main">
               <a:ext uri="{FF2B5EF4-FFF2-40B4-BE49-F238E27FC236}">
-                <a16:creationId xmlns:a16="http://schemas.microsoft.com/office/drawing/2014/main" id="{EBA2ADD1-64A5-46F5-AEBB-58E21F878AFE}"/>
+                <a16:creationId xmlns:a16="http://schemas.microsoft.com/office/drawing/2014/main" id="{3ADAFE3C-26D3-4C3D-A814-C8120791612E}"/>
               </a:ext>
             </a:extLst>
           </p:cNvPr>
@@ -6232,7 +6232,7 @@
     </p:spTree>
     <p:extLst>
       <p:ext uri="{BB962C8B-B14F-4D97-AF65-F5344CB8AC3E}">
-        <p14:creationId xmlns:p14="http://schemas.microsoft.com/office/powerpoint/2010/main" val="632385214"/>
+        <p14:creationId xmlns:p14="http://schemas.microsoft.com/office/powerpoint/2010/main" val="88162140"/>
       </p:ext>
     </p:extLst>
   </p:cSld>
@@ -6263,7 +6263,7 @@
           <p:cNvPr id="20" name="">
             <a:extLst xmlns:a="http://schemas.openxmlformats.org/drawingml/2006/main">
               <a:ext uri="{FF2B5EF4-FFF2-40B4-BE49-F238E27FC236}">
-                <a16:creationId xmlns:a16="http://schemas.microsoft.com/office/drawing/2014/main" id="{CB7B59D6-AB28-4B82-8E5E-15B53F607AF6}"/>
+                <a16:creationId xmlns:a16="http://schemas.microsoft.com/office/drawing/2014/main" id="{577A2CD6-9CCA-4F70-8E75-A69F20B3ADE0}"/>
               </a:ext>
             </a:extLst>
           </p:cNvPr>
@@ -6308,7 +6308,7 @@
           <p:cNvPr id="2" name="">
             <a:extLst xmlns:a="http://schemas.openxmlformats.org/drawingml/2006/main">
               <a:ext uri="{FF2B5EF4-FFF2-40B4-BE49-F238E27FC236}">
-                <a16:creationId xmlns:a16="http://schemas.microsoft.com/office/drawing/2014/main" id="{B1AA939F-E8F2-46ED-AFA9-966AC5C8EB09}"/>
+                <a16:creationId xmlns:a16="http://schemas.microsoft.com/office/drawing/2014/main" id="{DCF012B0-4761-40C7-9003-6393ECED7B99}"/>
               </a:ext>
             </a:extLst>
           </p:cNvPr>
@@ -6338,7 +6338,7 @@
           <p:cNvPr id="3" name="">
             <a:extLst xmlns:a="http://schemas.openxmlformats.org/drawingml/2006/main">
               <a:ext uri="{FF2B5EF4-FFF2-40B4-BE49-F238E27FC236}">
-                <a16:creationId xmlns:a16="http://schemas.microsoft.com/office/drawing/2014/main" id="{62F2B2F1-675A-4604-9DC2-CF577233B175}"/>
+                <a16:creationId xmlns:a16="http://schemas.microsoft.com/office/drawing/2014/main" id="{A7A9EA71-E746-477E-B3CA-BBB6CB62D408}"/>
               </a:ext>
             </a:extLst>
           </p:cNvPr>
@@ -6383,7 +6383,7 @@
           <p:cNvPr id="4" name="">
             <a:extLst xmlns:a="http://schemas.openxmlformats.org/drawingml/2006/main">
               <a:ext uri="{FF2B5EF4-FFF2-40B4-BE49-F238E27FC236}">
-                <a16:creationId xmlns:a16="http://schemas.microsoft.com/office/drawing/2014/main" id="{094708FB-6C37-40F9-877E-925E027174D8}"/>
+                <a16:creationId xmlns:a16="http://schemas.microsoft.com/office/drawing/2014/main" id="{7FAE07CA-C534-4BF5-BAC7-AF0C4C69778B}"/>
               </a:ext>
             </a:extLst>
           </p:cNvPr>
@@ -6428,7 +6428,7 @@
           <p:cNvPr id="5" name="">
             <a:extLst xmlns:a="http://schemas.openxmlformats.org/drawingml/2006/main">
               <a:ext uri="{FF2B5EF4-FFF2-40B4-BE49-F238E27FC236}">
-                <a16:creationId xmlns:a16="http://schemas.microsoft.com/office/drawing/2014/main" id="{F60318F3-DC4F-46F8-92E5-FE1B083BE947}"/>
+                <a16:creationId xmlns:a16="http://schemas.microsoft.com/office/drawing/2014/main" id="{A810392A-9967-4924-9C27-39603114A1A5}"/>
               </a:ext>
             </a:extLst>
           </p:cNvPr>
@@ -6460,7 +6460,7 @@
           <p:cNvPr id="6" name="">
             <a:extLst xmlns:a="http://schemas.openxmlformats.org/drawingml/2006/main">
               <a:ext uri="{FF2B5EF4-FFF2-40B4-BE49-F238E27FC236}">
-                <a16:creationId xmlns:a16="http://schemas.microsoft.com/office/drawing/2014/main" id="{F2C4BEEA-FB8E-4188-81F6-4E7F24A5EAC2}"/>
+                <a16:creationId xmlns:a16="http://schemas.microsoft.com/office/drawing/2014/main" id="{505D8F2E-01E1-4DF6-871A-1378E7BF0A1B}"/>
               </a:ext>
             </a:extLst>
           </p:cNvPr>
@@ -6531,7 +6531,7 @@
           <p:cNvPr id="7" name="">
             <a:extLst xmlns:a="http://schemas.openxmlformats.org/drawingml/2006/main">
               <a:ext uri="{FF2B5EF4-FFF2-40B4-BE49-F238E27FC236}">
-                <a16:creationId xmlns:a16="http://schemas.microsoft.com/office/drawing/2014/main" id="{8ED5298F-FDDF-48D4-B678-7E34CBE0BCC4}"/>
+                <a16:creationId xmlns:a16="http://schemas.microsoft.com/office/drawing/2014/main" id="{B2291553-3643-4492-9D76-6F42600A5AA8}"/>
               </a:ext>
             </a:extLst>
           </p:cNvPr>
@@ -6576,7 +6576,7 @@
           <p:cNvPr id="8" name="">
             <a:extLst xmlns:a="http://schemas.openxmlformats.org/drawingml/2006/main">
               <a:ext uri="{FF2B5EF4-FFF2-40B4-BE49-F238E27FC236}">
-                <a16:creationId xmlns:a16="http://schemas.microsoft.com/office/drawing/2014/main" id="{ECB42779-4993-4CA4-B660-5BEFD241EC89}"/>
+                <a16:creationId xmlns:a16="http://schemas.microsoft.com/office/drawing/2014/main" id="{6538C425-72B7-4683-A882-7EB441F302E7}"/>
               </a:ext>
             </a:extLst>
           </p:cNvPr>
@@ -6608,7 +6608,7 @@
           <p:cNvPr id="9" name="">
             <a:extLst xmlns:a="http://schemas.openxmlformats.org/drawingml/2006/main">
               <a:ext uri="{FF2B5EF4-FFF2-40B4-BE49-F238E27FC236}">
-                <a16:creationId xmlns:a16="http://schemas.microsoft.com/office/drawing/2014/main" id="{94BA456E-40D1-469A-817A-4D46628369FB}"/>
+                <a16:creationId xmlns:a16="http://schemas.microsoft.com/office/drawing/2014/main" id="{21158988-E577-41D8-88E1-6CE53B01029A}"/>
               </a:ext>
             </a:extLst>
           </p:cNvPr>
@@ -6640,7 +6640,7 @@
           <p:cNvPr id="10" name="">
             <a:extLst xmlns:a="http://schemas.openxmlformats.org/drawingml/2006/main">
               <a:ext uri="{FF2B5EF4-FFF2-40B4-BE49-F238E27FC236}">
-                <a16:creationId xmlns:a16="http://schemas.microsoft.com/office/drawing/2014/main" id="{E3E14705-A0CD-4820-9575-9B9017CE9589}"/>
+                <a16:creationId xmlns:a16="http://schemas.microsoft.com/office/drawing/2014/main" id="{E539C618-3801-411B-A00B-36C5D4D02533}"/>
               </a:ext>
             </a:extLst>
           </p:cNvPr>
@@ -6685,7 +6685,7 @@
           <p:cNvPr id="11" name="">
             <a:extLst xmlns:a="http://schemas.openxmlformats.org/drawingml/2006/main">
               <a:ext uri="{FF2B5EF4-FFF2-40B4-BE49-F238E27FC236}">
-                <a16:creationId xmlns:a16="http://schemas.microsoft.com/office/drawing/2014/main" id="{732033DC-81A6-46A7-B1CC-54F3EFE01970}"/>
+                <a16:creationId xmlns:a16="http://schemas.microsoft.com/office/drawing/2014/main" id="{A1C9F0C8-A8F1-4A01-B9D9-61A316C825AA}"/>
               </a:ext>
             </a:extLst>
           </p:cNvPr>
@@ -6730,7 +6730,7 @@
           <p:cNvPr id="12" name="">
             <a:extLst xmlns:a="http://schemas.openxmlformats.org/drawingml/2006/main">
               <a:ext uri="{FF2B5EF4-FFF2-40B4-BE49-F238E27FC236}">
-                <a16:creationId xmlns:a16="http://schemas.microsoft.com/office/drawing/2014/main" id="{ABAA87BE-28E1-426F-BC95-1EA3DB7AECB1}"/>
+                <a16:creationId xmlns:a16="http://schemas.microsoft.com/office/drawing/2014/main" id="{729384C7-536F-4347-BB1E-B3FFBBE295DE}"/>
               </a:ext>
             </a:extLst>
           </p:cNvPr>
@@ -6775,7 +6775,7 @@
           <p:cNvPr id="13" name="">
             <a:extLst xmlns:a="http://schemas.openxmlformats.org/drawingml/2006/main">
               <a:ext uri="{FF2B5EF4-FFF2-40B4-BE49-F238E27FC236}">
-                <a16:creationId xmlns:a16="http://schemas.microsoft.com/office/drawing/2014/main" id="{BAE18F72-BCE6-4B3E-BD61-A69B9A6CEB76}"/>
+                <a16:creationId xmlns:a16="http://schemas.microsoft.com/office/drawing/2014/main" id="{41C87B5D-40AB-4CAB-9EDA-14C71ADE667C}"/>
               </a:ext>
             </a:extLst>
           </p:cNvPr>
@@ -6807,7 +6807,7 @@
           <p:cNvPr id="14" name="">
             <a:extLst xmlns:a="http://schemas.openxmlformats.org/drawingml/2006/main">
               <a:ext uri="{FF2B5EF4-FFF2-40B4-BE49-F238E27FC236}">
-                <a16:creationId xmlns:a16="http://schemas.microsoft.com/office/drawing/2014/main" id="{0CD4D0A8-241B-4DCF-8914-45C778AC35B4}"/>
+                <a16:creationId xmlns:a16="http://schemas.microsoft.com/office/drawing/2014/main" id="{45AEE0A7-30F0-4D6A-86AB-81EE30300A3C}"/>
               </a:ext>
             </a:extLst>
           </p:cNvPr>
@@ -6839,7 +6839,7 @@
           <p:cNvPr id="15" name="">
             <a:extLst xmlns:a="http://schemas.openxmlformats.org/drawingml/2006/main">
               <a:ext uri="{FF2B5EF4-FFF2-40B4-BE49-F238E27FC236}">
-                <a16:creationId xmlns:a16="http://schemas.microsoft.com/office/drawing/2014/main" id="{0CC647A2-A56F-41AB-B67F-D87BF3CAAFDE}"/>
+                <a16:creationId xmlns:a16="http://schemas.microsoft.com/office/drawing/2014/main" id="{5CBD4861-3C39-4768-A4ED-2C311C9A41B0}"/>
               </a:ext>
             </a:extLst>
           </p:cNvPr>
@@ -6871,7 +6871,7 @@
           <p:cNvPr id="16" name="">
             <a:extLst xmlns:a="http://schemas.openxmlformats.org/drawingml/2006/main">
               <a:ext uri="{FF2B5EF4-FFF2-40B4-BE49-F238E27FC236}">
-                <a16:creationId xmlns:a16="http://schemas.microsoft.com/office/drawing/2014/main" id="{995D563E-1A69-4535-BA9C-6AEF2BE17AC2}"/>
+                <a16:creationId xmlns:a16="http://schemas.microsoft.com/office/drawing/2014/main" id="{F65ED315-533A-4FA1-9300-498275C3D24F}"/>
               </a:ext>
             </a:extLst>
           </p:cNvPr>
@@ -6916,7 +6916,7 @@
           <p:cNvPr id="17" name="">
             <a:extLst xmlns:a="http://schemas.openxmlformats.org/drawingml/2006/main">
               <a:ext uri="{FF2B5EF4-FFF2-40B4-BE49-F238E27FC236}">
-                <a16:creationId xmlns:a16="http://schemas.microsoft.com/office/drawing/2014/main" id="{DEAB27A3-7508-4C64-A6AC-96DB70EC858B}"/>
+                <a16:creationId xmlns:a16="http://schemas.microsoft.com/office/drawing/2014/main" id="{F5722ABB-22DB-475C-9A0E-D7D974BF44B3}"/>
               </a:ext>
             </a:extLst>
           </p:cNvPr>
@@ -6961,7 +6961,7 @@
           <p:cNvPr id="18" name="">
             <a:extLst xmlns:a="http://schemas.openxmlformats.org/drawingml/2006/main">
               <a:ext uri="{FF2B5EF4-FFF2-40B4-BE49-F238E27FC236}">
-                <a16:creationId xmlns:a16="http://schemas.microsoft.com/office/drawing/2014/main" id="{E6BB7C8C-8A0F-4371-918C-D6A80E29CC10}"/>
+                <a16:creationId xmlns:a16="http://schemas.microsoft.com/office/drawing/2014/main" id="{8FB91103-69AB-4F45-9E54-4A217FECF29C}"/>
               </a:ext>
             </a:extLst>
           </p:cNvPr>
@@ -7006,7 +7006,7 @@
           <p:cNvPr id="19" name="">
             <a:extLst xmlns:a="http://schemas.openxmlformats.org/drawingml/2006/main">
               <a:ext uri="{FF2B5EF4-FFF2-40B4-BE49-F238E27FC236}">
-                <a16:creationId xmlns:a16="http://schemas.microsoft.com/office/drawing/2014/main" id="{0DEB3FE0-5247-4CA4-BB80-E0E636E4FEAA}"/>
+                <a16:creationId xmlns:a16="http://schemas.microsoft.com/office/drawing/2014/main" id="{C4D6A980-3477-40B1-AB54-4CDC71A5B911}"/>
               </a:ext>
             </a:extLst>
           </p:cNvPr>
@@ -7049,7 +7049,7 @@
     </p:spTree>
     <p:extLst>
       <p:ext uri="{BB962C8B-B14F-4D97-AF65-F5344CB8AC3E}">
-        <p14:creationId xmlns:p14="http://schemas.microsoft.com/office/powerpoint/2010/main" val="1695536243"/>
+        <p14:creationId xmlns:p14="http://schemas.microsoft.com/office/powerpoint/2010/main" val="979343789"/>
       </p:ext>
     </p:extLst>
   </p:cSld>
@@ -7080,7 +7080,7 @@
           <p:cNvPr id="9" name="">
             <a:extLst xmlns:a="http://schemas.openxmlformats.org/drawingml/2006/main">
               <a:ext uri="{FF2B5EF4-FFF2-40B4-BE49-F238E27FC236}">
-                <a16:creationId xmlns:a16="http://schemas.microsoft.com/office/drawing/2014/main" id="{F444464D-4A80-4EB4-9AF2-0D893A075CAA}"/>
+                <a16:creationId xmlns:a16="http://schemas.microsoft.com/office/drawing/2014/main" id="{B713F3BE-EB0F-46A2-A664-7ED9CE922A51}"/>
               </a:ext>
             </a:extLst>
           </p:cNvPr>
@@ -7125,7 +7125,7 @@
           <p:cNvPr id="2" name="">
             <a:extLst xmlns:a="http://schemas.openxmlformats.org/drawingml/2006/main">
               <a:ext uri="{FF2B5EF4-FFF2-40B4-BE49-F238E27FC236}">
-                <a16:creationId xmlns:a16="http://schemas.microsoft.com/office/drawing/2014/main" id="{3B20A77E-9E30-49CB-A380-B82713C893FD}"/>
+                <a16:creationId xmlns:a16="http://schemas.microsoft.com/office/drawing/2014/main" id="{82BC5469-4B7F-49F3-ACF0-F830AF617BD2}"/>
               </a:ext>
             </a:extLst>
           </p:cNvPr>
@@ -7155,7 +7155,7 @@
           <p:cNvPr id="3" name="">
             <a:extLst xmlns:a="http://schemas.openxmlformats.org/drawingml/2006/main">
               <a:ext uri="{FF2B5EF4-FFF2-40B4-BE49-F238E27FC236}">
-                <a16:creationId xmlns:a16="http://schemas.microsoft.com/office/drawing/2014/main" id="{0B248448-63BB-494A-9AEB-BC93F31A60DE}"/>
+                <a16:creationId xmlns:a16="http://schemas.microsoft.com/office/drawing/2014/main" id="{DE552A5F-1849-4ED4-85F8-479C43DBFA0D}"/>
               </a:ext>
             </a:extLst>
           </p:cNvPr>
@@ -7200,7 +7200,7 @@
           <p:cNvPr id="4" name="">
             <a:extLst xmlns:a="http://schemas.openxmlformats.org/drawingml/2006/main">
               <a:ext uri="{FF2B5EF4-FFF2-40B4-BE49-F238E27FC236}">
-                <a16:creationId xmlns:a16="http://schemas.microsoft.com/office/drawing/2014/main" id="{549792D3-3B2B-4290-BAB9-3295CD76CEEF}"/>
+                <a16:creationId xmlns:a16="http://schemas.microsoft.com/office/drawing/2014/main" id="{FEE9F5E2-F819-4E51-9CC7-AD56E59F1B06}"/>
               </a:ext>
             </a:extLst>
           </p:cNvPr>
@@ -7827,7 +7827,7 @@
           <p:cNvPr id="5" name="">
             <a:extLst xmlns:a="http://schemas.openxmlformats.org/drawingml/2006/main">
               <a:ext uri="{FF2B5EF4-FFF2-40B4-BE49-F238E27FC236}">
-                <a16:creationId xmlns:a16="http://schemas.microsoft.com/office/drawing/2014/main" id="{4CC59F9B-38E6-4638-95A5-AD767CB63951}"/>
+                <a16:creationId xmlns:a16="http://schemas.microsoft.com/office/drawing/2014/main" id="{2A81CA77-6C27-4F2C-AC60-DF328124A0F9}"/>
               </a:ext>
             </a:extLst>
           </p:cNvPr>
@@ -7872,7 +7872,7 @@
           <p:cNvPr id="6" name="">
             <a:extLst xmlns:a="http://schemas.openxmlformats.org/drawingml/2006/main">
               <a:ext uri="{FF2B5EF4-FFF2-40B4-BE49-F238E27FC236}">
-                <a16:creationId xmlns:a16="http://schemas.microsoft.com/office/drawing/2014/main" id="{E024E966-6F8A-4424-A464-BB691D98978E}"/>
+                <a16:creationId xmlns:a16="http://schemas.microsoft.com/office/drawing/2014/main" id="{F03D4A5E-10FC-400D-974D-6CECACCB772A}"/>
               </a:ext>
             </a:extLst>
           </p:cNvPr>
@@ -7956,7 +7956,7 @@
           <p:cNvPr id="7" name="">
             <a:extLst xmlns:a="http://schemas.openxmlformats.org/drawingml/2006/main">
               <a:ext uri="{FF2B5EF4-FFF2-40B4-BE49-F238E27FC236}">
-                <a16:creationId xmlns:a16="http://schemas.microsoft.com/office/drawing/2014/main" id="{1618F05A-0E3F-45B1-BB2F-70A5C1D03BA9}"/>
+                <a16:creationId xmlns:a16="http://schemas.microsoft.com/office/drawing/2014/main" id="{DBEC9474-8C8B-4729-8063-1AC73BC5EBC8}"/>
               </a:ext>
             </a:extLst>
           </p:cNvPr>
@@ -7967,8 +7967,8 @@
         </p:nvSpPr>
         <p:spPr>
           <a:xfrm xmlns:a="http://schemas.openxmlformats.org/drawingml/2006/main">
-            <a:off x="609600" y="5010150"/>
-            <a:ext cx="10810875" cy="742950"/>
+            <a:off x="609600" y="4905375"/>
+            <a:ext cx="10810875" cy="942975"/>
           </a:xfrm>
           <a:prstGeom xmlns:a="http://schemas.openxmlformats.org/drawingml/2006/main" prst="rect">
             <a:avLst/>
@@ -7983,7 +7983,7 @@
           <a:lstStyle xmlns:a="http://schemas.openxmlformats.org/drawingml/2006/main"/>
           <a:p xmlns:a="http://schemas.openxmlformats.org/drawingml/2006/main">
             <a:r>
-              <a:rPr sz="2025" b="0">
+              <a:rPr sz="1800" b="0">
                 <a:solidFill>
                   <a:srgbClr val="152D43"/>
                 </a:solidFill>
@@ -7996,7 +7996,7 @@
           </a:p>
           <a:p xmlns:a="http://schemas.openxmlformats.org/drawingml/2006/main">
             <a:r>
-              <a:rPr sz="2025" b="0">
+              <a:rPr sz="1800" b="0">
                 <a:solidFill>
                   <a:srgbClr val="152D43"/>
                 </a:solidFill>
@@ -8007,6 +8007,19 @@
               <a:t>Stream: also includes input upload and output download</a:t>
             </a:r>
           </a:p>
+          <a:p xmlns:a="http://schemas.openxmlformats.org/drawingml/2006/main">
+            <a:r>
+              <a:rPr sz="1800" b="0">
+                <a:solidFill>
+                  <a:srgbClr val="152D43"/>
+                </a:solidFill>
+                <a:latin typeface="Arial"/>
+                <a:ea typeface="Arial"/>
+                <a:cs typeface="Arial"/>
+              </a:rPr>
+              <a:t>Slides 6–7 add a fixed 2 ms/frame decode budget; not measured end-to-end.</a:t>
+            </a:r>
+          </a:p>
         </p:txBody>
       </p:sp>
       <p:sp>
@@ -8014,7 +8027,7 @@
           <p:cNvPr id="8" name="">
             <a:extLst xmlns:a="http://schemas.openxmlformats.org/drawingml/2006/main">
               <a:ext uri="{FF2B5EF4-FFF2-40B4-BE49-F238E27FC236}">
-                <a16:creationId xmlns:a16="http://schemas.microsoft.com/office/drawing/2014/main" id="{A34703C5-B2D6-47DB-95BF-F5F0FA953EDE}"/>
+                <a16:creationId xmlns:a16="http://schemas.microsoft.com/office/drawing/2014/main" id="{97E31DD2-707D-424E-B054-983B1743D06A}"/>
               </a:ext>
             </a:extLst>
           </p:cNvPr>
@@ -8057,7 +8070,7 @@
     </p:spTree>
     <p:extLst>
       <p:ext uri="{BB962C8B-B14F-4D97-AF65-F5344CB8AC3E}">
-        <p14:creationId xmlns:p14="http://schemas.microsoft.com/office/powerpoint/2010/main" val="1306227738"/>
+        <p14:creationId xmlns:p14="http://schemas.microsoft.com/office/powerpoint/2010/main" val="135584366"/>
       </p:ext>
     </p:extLst>
   </p:cSld>
@@ -8085,10 +8098,10 @@
       </p:grpSpPr>
       <p:sp>
         <p:nvSpPr>
-          <p:cNvPr id="11" name="">
-            <a:extLst xmlns:a="http://schemas.openxmlformats.org/drawingml/2006/main">
-              <a:ext uri="{FF2B5EF4-FFF2-40B4-BE49-F238E27FC236}">
-                <a16:creationId xmlns:a16="http://schemas.microsoft.com/office/drawing/2014/main" id="{0D349209-5F36-4F67-8E19-F6EF68ECFDF9}"/>
+          <p:cNvPr id="12" name="">
+            <a:extLst xmlns:a="http://schemas.openxmlformats.org/drawingml/2006/main">
+              <a:ext uri="{FF2B5EF4-FFF2-40B4-BE49-F238E27FC236}">
+                <a16:creationId xmlns:a16="http://schemas.microsoft.com/office/drawing/2014/main" id="{0C18236E-9365-4ECB-B77D-FF26FF34AEFA}"/>
               </a:ext>
             </a:extLst>
           </p:cNvPr>
@@ -8123,7 +8136,7 @@
                 <a:ea typeface="Arial"/>
                 <a:cs typeface="Arial"/>
               </a:rPr>
-              <a:t>Smaller regions reduce mean reconstruction latency</a:t>
+              <a:t>Decode budget + reconstruction across FOV levels</a:t>
             </a:r>
           </a:p>
         </p:txBody>
@@ -8133,7 +8146,7 @@
           <p:cNvPr id="2" name="">
             <a:extLst xmlns:a="http://schemas.openxmlformats.org/drawingml/2006/main">
               <a:ext uri="{FF2B5EF4-FFF2-40B4-BE49-F238E27FC236}">
-                <a16:creationId xmlns:a16="http://schemas.microsoft.com/office/drawing/2014/main" id="{EA0BBD74-C6F0-44E2-8A70-0C9C409ACCD8}"/>
+                <a16:creationId xmlns:a16="http://schemas.microsoft.com/office/drawing/2014/main" id="{002E7BB7-F8D1-41CF-BCAE-E9C278B5A9C3}"/>
               </a:ext>
             </a:extLst>
           </p:cNvPr>
@@ -8163,7 +8176,7 @@
           <p:cNvPr id="3" name="">
             <a:extLst xmlns:a="http://schemas.openxmlformats.org/drawingml/2006/main">
               <a:ext uri="{FF2B5EF4-FFF2-40B4-BE49-F238E27FC236}">
-                <a16:creationId xmlns:a16="http://schemas.microsoft.com/office/drawing/2014/main" id="{F1D49EF4-C83F-45AA-9935-10A6C83FE3E4}"/>
+                <a16:creationId xmlns:a16="http://schemas.microsoft.com/office/drawing/2014/main" id="{0C71149C-B1C7-43C9-A920-4E95536D9A63}"/>
               </a:ext>
             </a:extLst>
           </p:cNvPr>
@@ -8208,7 +8221,7 @@
           <p:cNvPr id="4" name="Chart">
             <a:extLst xmlns:a="http://schemas.openxmlformats.org/drawingml/2006/main">
               <a:ext uri="{FF2B5EF4-FFF2-40B4-BE49-F238E27FC236}">
-                <a16:creationId xmlns:a16="http://schemas.microsoft.com/office/drawing/2014/main" id="{6A59F450-9386-4F87-BF4A-9667777191BF}"/>
+                <a16:creationId xmlns:a16="http://schemas.microsoft.com/office/drawing/2014/main" id="{1DC04A79-CA80-4A38-A015-59BF3E53FB09}"/>
               </a:ext>
             </a:extLst>
           </p:cNvPr>
@@ -8221,7 +8234,7 @@
         </p:xfrm>
         <a:graphic xmlns:a="http://schemas.openxmlformats.org/drawingml/2006/main">
           <a:graphicData uri="http://schemas.openxmlformats.org/drawingml/2006/chart">
-            <c:chart xmlns:r="http://schemas.openxmlformats.org/officeDocument/2006/relationships" xmlns:c="http://schemas.openxmlformats.org/drawingml/2006/chart" r:id="R0d17e04ab7ce4564"/>
+            <c:chart xmlns:r="http://schemas.openxmlformats.org/officeDocument/2006/relationships" xmlns:c="http://schemas.openxmlformats.org/drawingml/2006/chart" r:id="R249ff02d47294aaa"/>
           </a:graphicData>
         </a:graphic>
       </p:graphicFrame>
@@ -8230,7 +8243,7 @@
           <p:cNvPr id="5" name="">
             <a:extLst xmlns:a="http://schemas.openxmlformats.org/drawingml/2006/main">
               <a:ext uri="{FF2B5EF4-FFF2-40B4-BE49-F238E27FC236}">
-                <a16:creationId xmlns:a16="http://schemas.microsoft.com/office/drawing/2014/main" id="{75EAA6B4-68FC-4153-A7F1-6E5EF2211F7D}"/>
+                <a16:creationId xmlns:a16="http://schemas.microsoft.com/office/drawing/2014/main" id="{6D51D4F5-FF15-4D7F-AA90-F015DBBC8816}"/>
               </a:ext>
             </a:extLst>
           </p:cNvPr>
@@ -8275,7 +8288,7 @@
           <p:cNvPr id="6" name="">
             <a:extLst xmlns:a="http://schemas.openxmlformats.org/drawingml/2006/main">
               <a:ext uri="{FF2B5EF4-FFF2-40B4-BE49-F238E27FC236}">
-                <a16:creationId xmlns:a16="http://schemas.microsoft.com/office/drawing/2014/main" id="{CF8A1F16-6F0A-4A63-BD81-BF0C4F58569D}"/>
+                <a16:creationId xmlns:a16="http://schemas.microsoft.com/office/drawing/2014/main" id="{45826A59-AC24-426D-898F-306B3D538DEB}"/>
               </a:ext>
             </a:extLst>
           </p:cNvPr>
@@ -8310,7 +8323,7 @@
                 <a:ea typeface="Arial"/>
                 <a:cs typeface="Arial"/>
               </a:rPr>
-              <a:t>4.770 ms</a:t>
+              <a:t>6.770 ms</a:t>
             </a:r>
           </a:p>
         </p:txBody>
@@ -8320,7 +8333,7 @@
           <p:cNvPr id="7" name="">
             <a:extLst xmlns:a="http://schemas.openxmlformats.org/drawingml/2006/main">
               <a:ext uri="{FF2B5EF4-FFF2-40B4-BE49-F238E27FC236}">
-                <a16:creationId xmlns:a16="http://schemas.microsoft.com/office/drawing/2014/main" id="{C65FF544-D589-4D88-A422-6422096B33C1}"/>
+                <a16:creationId xmlns:a16="http://schemas.microsoft.com/office/drawing/2014/main" id="{0343FACC-B7B1-4BD0-8894-69A4B9600937}"/>
               </a:ext>
             </a:extLst>
           </p:cNvPr>
@@ -8355,7 +8368,7 @@
                 <a:ea typeface="Arial"/>
                 <a:cs typeface="Arial"/>
               </a:rPr>
-              <a:t>resident mean</a:t>
+              <a:t>decode + resident</a:t>
             </a:r>
           </a:p>
         </p:txBody>
@@ -8365,7 +8378,7 @@
           <p:cNvPr id="8" name="">
             <a:extLst xmlns:a="http://schemas.openxmlformats.org/drawingml/2006/main">
               <a:ext uri="{FF2B5EF4-FFF2-40B4-BE49-F238E27FC236}">
-                <a16:creationId xmlns:a16="http://schemas.microsoft.com/office/drawing/2014/main" id="{9AF714CF-ECAB-4D8A-93B5-2BDCBB99F5CF}"/>
+                <a16:creationId xmlns:a16="http://schemas.microsoft.com/office/drawing/2014/main" id="{A925B8A5-655E-46E4-9ECE-27E6008D55F7}"/>
               </a:ext>
             </a:extLst>
           </p:cNvPr>
@@ -8400,7 +8413,7 @@
                 <a:ea typeface="Arial"/>
                 <a:cs typeface="Arial"/>
               </a:rPr>
-              <a:t>2.31×</a:t>
+              <a:t>1.92×</a:t>
             </a:r>
           </a:p>
         </p:txBody>
@@ -8410,7 +8423,7 @@
           <p:cNvPr id="9" name="">
             <a:extLst xmlns:a="http://schemas.openxmlformats.org/drawingml/2006/main">
               <a:ext uri="{FF2B5EF4-FFF2-40B4-BE49-F238E27FC236}">
-                <a16:creationId xmlns:a16="http://schemas.microsoft.com/office/drawing/2014/main" id="{57BBE320-2FA8-4F92-A25B-334356CECDD6}"/>
+                <a16:creationId xmlns:a16="http://schemas.microsoft.com/office/drawing/2014/main" id="{513A9FBF-C677-4F9D-AA41-C0FF619E2AD3}"/>
               </a:ext>
             </a:extLst>
           </p:cNvPr>
@@ -8445,7 +8458,7 @@
                 <a:ea typeface="Arial"/>
                 <a:cs typeface="Arial"/>
               </a:rPr>
-              <a:t>versus measured full</a:t>
+              <a:t>versus full + decode</a:t>
             </a:r>
           </a:p>
         </p:txBody>
@@ -8455,7 +8468,52 @@
           <p:cNvPr id="10" name="">
             <a:extLst xmlns:a="http://schemas.openxmlformats.org/drawingml/2006/main">
               <a:ext uri="{FF2B5EF4-FFF2-40B4-BE49-F238E27FC236}">
-                <a16:creationId xmlns:a16="http://schemas.microsoft.com/office/drawing/2014/main" id="{FD2DC3F3-656A-46C1-A888-B8A920EF614A}"/>
+                <a16:creationId xmlns:a16="http://schemas.microsoft.com/office/drawing/2014/main" id="{FF106BD9-5C08-4560-9F54-8C1C4937BE48}"/>
+              </a:ext>
+            </a:extLst>
+          </p:cNvPr>
+          <p:cNvSpPr>
+            <a:spLocks xmlns:a="http://schemas.openxmlformats.org/drawingml/2006/main" noGrp="1"/>
+          </p:cNvSpPr>
+          <p:nvPr/>
+        </p:nvSpPr>
+        <p:spPr>
+          <a:xfrm xmlns:a="http://schemas.openxmlformats.org/drawingml/2006/main">
+            <a:off x="609600" y="1381125"/>
+            <a:ext cx="10906125" cy="295275"/>
+          </a:xfrm>
+          <a:prstGeom xmlns:a="http://schemas.openxmlformats.org/drawingml/2006/main" prst="rect">
+            <a:avLst/>
+          </a:prstGeom>
+          <a:noFill xmlns:a="http://schemas.openxmlformats.org/drawingml/2006/main"/>
+          <a:ln xmlns:a="http://schemas.openxmlformats.org/drawingml/2006/main" w="0">
+            <a:noFill/>
+          </a:ln>
+        </p:spPr>
+        <p:txBody>
+          <a:bodyPr xmlns:a="http://schemas.openxmlformats.org/drawingml/2006/main" lIns="0" tIns="0" rIns="0" bIns="0"/>
+          <a:lstStyle xmlns:a="http://schemas.openxmlformats.org/drawingml/2006/main"/>
+          <a:p xmlns:a="http://schemas.openxmlformats.org/drawingml/2006/main">
+            <a:r>
+              <a:rPr sz="1725" b="1">
+                <a:solidFill>
+                  <a:srgbClr val="086B93"/>
+                </a:solidFill>
+                <a:latin typeface="Arial"/>
+                <a:ea typeface="Arial"/>
+                <a:cs typeface="Arial"/>
+              </a:rPr>
+              <a:t>Fixed decode budget: 2 ms/frame + measured reconstruction; stream also includes copies.</a:t>
+            </a:r>
+          </a:p>
+        </p:txBody>
+      </p:sp>
+      <p:sp>
+        <p:nvSpPr>
+          <p:cNvPr id="11" name="">
+            <a:extLst xmlns:a="http://schemas.openxmlformats.org/drawingml/2006/main">
+              <a:ext uri="{FF2B5EF4-FFF2-40B4-BE49-F238E27FC236}">
+                <a16:creationId xmlns:a16="http://schemas.microsoft.com/office/drawing/2014/main" id="{D6091BB4-A2B5-46C6-B0DC-E9CAC62CA47E}"/>
               </a:ext>
             </a:extLst>
           </p:cNvPr>
@@ -8490,7 +8548,7 @@
                 <a:ea typeface="Arial"/>
                 <a:cs typeface="Arial"/>
               </a:rPr>
-              <a:t>Fast resampling enabled. Cross-implementation gains also include upsampling changes, not only FOV. No claim of an optimal full baseline.</a:t>
+              <a:t>Derived budget, not measured end-to-end. Fast resampling enabled; gains also include upsampling changes. No optimal-baseline claim.</a:t>
             </a:r>
           </a:p>
         </p:txBody>
@@ -8498,7 +8556,7 @@
     </p:spTree>
     <p:extLst>
       <p:ext uri="{BB962C8B-B14F-4D97-AF65-F5344CB8AC3E}">
-        <p14:creationId xmlns:p14="http://schemas.microsoft.com/office/powerpoint/2010/main" val="850097204"/>
+        <p14:creationId xmlns:p14="http://schemas.microsoft.com/office/powerpoint/2010/main" val="1995950216"/>
       </p:ext>
     </p:extLst>
   </p:cSld>
@@ -8529,7 +8587,7 @@
           <p:cNvPr id="8" name="">
             <a:extLst xmlns:a="http://schemas.openxmlformats.org/drawingml/2006/main">
               <a:ext uri="{FF2B5EF4-FFF2-40B4-BE49-F238E27FC236}">
-                <a16:creationId xmlns:a16="http://schemas.microsoft.com/office/drawing/2014/main" id="{00A42D32-4F2E-4135-A51F-C27D2424754C}"/>
+                <a16:creationId xmlns:a16="http://schemas.microsoft.com/office/drawing/2014/main" id="{4E36535A-3D76-44ED-BEC0-AC83455960C2}"/>
               </a:ext>
             </a:extLst>
           </p:cNvPr>
@@ -8574,7 +8632,7 @@
           <p:cNvPr id="2" name="">
             <a:extLst xmlns:a="http://schemas.openxmlformats.org/drawingml/2006/main">
               <a:ext uri="{FF2B5EF4-FFF2-40B4-BE49-F238E27FC236}">
-                <a16:creationId xmlns:a16="http://schemas.microsoft.com/office/drawing/2014/main" id="{E063F2EC-A8F6-41F8-A102-DB79F7C0336D}"/>
+                <a16:creationId xmlns:a16="http://schemas.microsoft.com/office/drawing/2014/main" id="{7EE8DD29-BFFD-43DF-8F3F-6719BC4AB9E5}"/>
               </a:ext>
             </a:extLst>
           </p:cNvPr>
@@ -8604,7 +8662,7 @@
           <p:cNvPr id="3" name="">
             <a:extLst xmlns:a="http://schemas.openxmlformats.org/drawingml/2006/main">
               <a:ext uri="{FF2B5EF4-FFF2-40B4-BE49-F238E27FC236}">
-                <a16:creationId xmlns:a16="http://schemas.microsoft.com/office/drawing/2014/main" id="{B0C6CA2D-4FD8-48DC-BF76-00A75C2A61CD}"/>
+                <a16:creationId xmlns:a16="http://schemas.microsoft.com/office/drawing/2014/main" id="{F78D41F6-AA25-42AD-9C2A-CAEC0375D007}"/>
               </a:ext>
             </a:extLst>
           </p:cNvPr>
@@ -8649,7 +8707,7 @@
           <p:cNvPr id="4" name="">
             <a:extLst xmlns:a="http://schemas.openxmlformats.org/drawingml/2006/main">
               <a:ext uri="{FF2B5EF4-FFF2-40B4-BE49-F238E27FC236}">
-                <a16:creationId xmlns:a16="http://schemas.microsoft.com/office/drawing/2014/main" id="{56A635C5-93B8-4B43-8C6E-E8480D69C337}"/>
+                <a16:creationId xmlns:a16="http://schemas.microsoft.com/office/drawing/2014/main" id="{B75FF649-0591-4B21-82A1-8E2FDB533548}"/>
               </a:ext>
             </a:extLst>
           </p:cNvPr>
@@ -8733,7 +8791,7 @@
                           <a:ea typeface="Arial"/>
                           <a:cs typeface="Arial"/>
                         </a:rPr>
-                        <a:t>Mean latency</a:t>
+                        <a:t>Decode + recon mean</a:t>
                       </a:r>
                     </a:p>
                   </a:txBody>
@@ -8903,7 +8961,7 @@
                           <a:ea typeface="Arial"/>
                           <a:cs typeface="Arial"/>
                         </a:rPr>
-                        <a:t>4.562 ms</a:t>
+                        <a:t>6.562 ms</a:t>
                       </a:r>
                     </a:p>
                   </a:txBody>
@@ -9055,7 +9113,7 @@
                           <a:ea typeface="Arial"/>
                           <a:cs typeface="Arial"/>
                         </a:rPr>
-                        <a:t>4.770 ms</a:t>
+                        <a:t>6.770 ms</a:t>
                       </a:r>
                     </a:p>
                   </a:txBody>
@@ -9207,7 +9265,7 @@
                           <a:ea typeface="Arial"/>
                           <a:cs typeface="Arial"/>
                         </a:rPr>
-                        <a:t>5.998 ms</a:t>
+                        <a:t>7.998 ms</a:t>
                       </a:r>
                     </a:p>
                   </a:txBody>
@@ -9359,7 +9417,7 @@
                           <a:ea typeface="Arial"/>
                           <a:cs typeface="Arial"/>
                         </a:rPr>
-                        <a:t>7.772 ms</a:t>
+                        <a:t>9.772 ms</a:t>
                       </a:r>
                     </a:p>
                   </a:txBody>
@@ -9511,7 +9569,7 @@
                           <a:ea typeface="Arial"/>
                           <a:cs typeface="Arial"/>
                         </a:rPr>
-                        <a:t>10.425 ms</a:t>
+                        <a:t>12.425 ms</a:t>
                       </a:r>
                     </a:p>
                   </a:txBody>
@@ -9615,7 +9673,7 @@
           <p:cNvPr id="5" name="">
             <a:extLst xmlns:a="http://schemas.openxmlformats.org/drawingml/2006/main">
               <a:ext uri="{FF2B5EF4-FFF2-40B4-BE49-F238E27FC236}">
-                <a16:creationId xmlns:a16="http://schemas.microsoft.com/office/drawing/2014/main" id="{EA0548C4-3A51-4DAE-9BAE-414198D10628}"/>
+                <a16:creationId xmlns:a16="http://schemas.microsoft.com/office/drawing/2014/main" id="{4914DFD3-DFC4-4708-A964-7A92AEFEEE1E}"/>
               </a:ext>
             </a:extLst>
           </p:cNvPr>
@@ -9660,7 +9718,7 @@
           <p:cNvPr id="6" name="">
             <a:extLst xmlns:a="http://schemas.openxmlformats.org/drawingml/2006/main">
               <a:ext uri="{FF2B5EF4-FFF2-40B4-BE49-F238E27FC236}">
-                <a16:creationId xmlns:a16="http://schemas.microsoft.com/office/drawing/2014/main" id="{8C3CF272-0BE1-4233-8F64-CC920083DFA4}"/>
+                <a16:creationId xmlns:a16="http://schemas.microsoft.com/office/drawing/2014/main" id="{82977264-1EAE-4303-8E85-688E562E2C16}"/>
               </a:ext>
             </a:extLst>
           </p:cNvPr>
@@ -9705,7 +9763,7 @@
           <p:cNvPr id="7" name="">
             <a:extLst xmlns:a="http://schemas.openxmlformats.org/drawingml/2006/main">
               <a:ext uri="{FF2B5EF4-FFF2-40B4-BE49-F238E27FC236}">
-                <a16:creationId xmlns:a16="http://schemas.microsoft.com/office/drawing/2014/main" id="{77949391-9B3F-44DD-942F-7C4F743150F3}"/>
+                <a16:creationId xmlns:a16="http://schemas.microsoft.com/office/drawing/2014/main" id="{91AC4755-FD96-4E1C-853B-93C0830B7EA9}"/>
               </a:ext>
             </a:extLst>
           </p:cNvPr>
@@ -9740,7 +9798,7 @@
                 <a:ea typeface="Arial"/>
                 <a:cs typeface="Arial"/>
               </a:rPr>
-              <a:t>Stereo values are derived; latency is not halved. Non-atomic writes remain. SSIM/LPIPS are not measured.</a:t>
+              <a:t>Fixed 2 ms decode budget + resident reconstruction. Stereo values derived; non-atomic writes remain. No SSIM/LPIPS.</a:t>
             </a:r>
           </a:p>
         </p:txBody>
@@ -9748,7 +9806,7 @@
     </p:spTree>
     <p:extLst>
       <p:ext uri="{BB962C8B-B14F-4D97-AF65-F5344CB8AC3E}">
-        <p14:creationId xmlns:p14="http://schemas.microsoft.com/office/powerpoint/2010/main" val="2077063432"/>
+        <p14:creationId xmlns:p14="http://schemas.microsoft.com/office/powerpoint/2010/main" val="1659209527"/>
       </p:ext>
     </p:extLst>
   </p:cSld>
@@ -9779,7 +9837,7 @@
           <p:cNvPr id="8" name="">
             <a:extLst xmlns:a="http://schemas.openxmlformats.org/drawingml/2006/main">
               <a:ext uri="{FF2B5EF4-FFF2-40B4-BE49-F238E27FC236}">
-                <a16:creationId xmlns:a16="http://schemas.microsoft.com/office/drawing/2014/main" id="{AB438DC6-C4A4-4DC0-AE91-C85E95108CAD}"/>
+                <a16:creationId xmlns:a16="http://schemas.microsoft.com/office/drawing/2014/main" id="{8F621FE3-20C2-401B-A41C-25EC71F084D5}"/>
               </a:ext>
             </a:extLst>
           </p:cNvPr>
@@ -9824,7 +9882,7 @@
           <p:cNvPr id="2" name="">
             <a:extLst xmlns:a="http://schemas.openxmlformats.org/drawingml/2006/main">
               <a:ext uri="{FF2B5EF4-FFF2-40B4-BE49-F238E27FC236}">
-                <a16:creationId xmlns:a16="http://schemas.microsoft.com/office/drawing/2014/main" id="{1E3FDC43-829D-42ED-BDD7-D6F92CE1D166}"/>
+                <a16:creationId xmlns:a16="http://schemas.microsoft.com/office/drawing/2014/main" id="{0F308A0D-3F13-43E0-A2A9-770DEEB953F6}"/>
               </a:ext>
             </a:extLst>
           </p:cNvPr>
@@ -9854,7 +9912,7 @@
           <p:cNvPr id="3" name="">
             <a:extLst xmlns:a="http://schemas.openxmlformats.org/drawingml/2006/main">
               <a:ext uri="{FF2B5EF4-FFF2-40B4-BE49-F238E27FC236}">
-                <a16:creationId xmlns:a16="http://schemas.microsoft.com/office/drawing/2014/main" id="{468606E0-4C4F-43A5-94E1-5487F8A416F7}"/>
+                <a16:creationId xmlns:a16="http://schemas.microsoft.com/office/drawing/2014/main" id="{6D155053-AEB3-4185-939B-3B9088D18B22}"/>
               </a:ext>
             </a:extLst>
           </p:cNvPr>
@@ -9899,7 +9957,7 @@
           <p:cNvPr id="4" name="">
             <a:extLst xmlns:a="http://schemas.openxmlformats.org/drawingml/2006/main">
               <a:ext uri="{FF2B5EF4-FFF2-40B4-BE49-F238E27FC236}">
-                <a16:creationId xmlns:a16="http://schemas.microsoft.com/office/drawing/2014/main" id="{99D71048-5F6D-4005-8479-A4E2550574A1}"/>
+                <a16:creationId xmlns:a16="http://schemas.microsoft.com/office/drawing/2014/main" id="{F8496523-C573-4179-8249-43DF223E69DE}"/>
               </a:ext>
             </a:extLst>
           </p:cNvPr>
@@ -10900,7 +10958,7 @@
           <p:cNvPr id="5" name="">
             <a:extLst xmlns:a="http://schemas.openxmlformats.org/drawingml/2006/main">
               <a:ext uri="{FF2B5EF4-FFF2-40B4-BE49-F238E27FC236}">
-                <a16:creationId xmlns:a16="http://schemas.microsoft.com/office/drawing/2014/main" id="{DB3058CF-31CD-481E-9980-BFA1B36AB4AD}"/>
+                <a16:creationId xmlns:a16="http://schemas.microsoft.com/office/drawing/2014/main" id="{48786C31-37F4-480F-9C34-F3EAAA7EFCBF}"/>
               </a:ext>
             </a:extLst>
           </p:cNvPr>
@@ -10935,7 +10993,7 @@
                 <a:ea typeface="Arial"/>
                 <a:cs typeface="Arial"/>
               </a:rPr>
-              <a:t>Frame 39 per sequence, 100 repeats. Resident mean in ms. Region = 2.8% of image.</a:t>
+              <a:t>Frame 39 per sequence, 100 repeats. Reconstruction means (ms); no decode. Region = 2.8%.</a:t>
             </a:r>
           </a:p>
         </p:txBody>
@@ -10945,7 +11003,7 @@
           <p:cNvPr id="6" name="">
             <a:extLst xmlns:a="http://schemas.openxmlformats.org/drawingml/2006/main">
               <a:ext uri="{FF2B5EF4-FFF2-40B4-BE49-F238E27FC236}">
-                <a16:creationId xmlns:a16="http://schemas.microsoft.com/office/drawing/2014/main" id="{B4CCCA0A-3121-4CE3-89BA-B5A15C519141}"/>
+                <a16:creationId xmlns:a16="http://schemas.microsoft.com/office/drawing/2014/main" id="{FE2651F4-E1A4-4591-94B4-57DFD0BD8457}"/>
               </a:ext>
             </a:extLst>
           </p:cNvPr>
@@ -11003,7 +11061,7 @@
           <p:cNvPr id="7" name="">
             <a:extLst xmlns:a="http://schemas.openxmlformats.org/drawingml/2006/main">
               <a:ext uri="{FF2B5EF4-FFF2-40B4-BE49-F238E27FC236}">
-                <a16:creationId xmlns:a16="http://schemas.microsoft.com/office/drawing/2014/main" id="{18A5A26D-61D8-44DF-B3A7-B8B966E5E98A}"/>
+                <a16:creationId xmlns:a16="http://schemas.microsoft.com/office/drawing/2014/main" id="{39919E23-0D6B-4BC6-8924-43CB6446DCA7}"/>
               </a:ext>
             </a:extLst>
           </p:cNvPr>
@@ -11046,7 +11104,7 @@
     </p:spTree>
     <p:extLst>
       <p:ext uri="{BB962C8B-B14F-4D97-AF65-F5344CB8AC3E}">
-        <p14:creationId xmlns:p14="http://schemas.microsoft.com/office/powerpoint/2010/main" val="1169531929"/>
+        <p14:creationId xmlns:p14="http://schemas.microsoft.com/office/powerpoint/2010/main" val="1164191138"/>
       </p:ext>
     </p:extLst>
   </p:cSld>
@@ -11077,7 +11135,7 @@
           <p:cNvPr id="14" name="">
             <a:extLst xmlns:a="http://schemas.openxmlformats.org/drawingml/2006/main">
               <a:ext uri="{FF2B5EF4-FFF2-40B4-BE49-F238E27FC236}">
-                <a16:creationId xmlns:a16="http://schemas.microsoft.com/office/drawing/2014/main" id="{30E56511-8BC0-47E4-A0F0-626054C5D59E}"/>
+                <a16:creationId xmlns:a16="http://schemas.microsoft.com/office/drawing/2014/main" id="{9C2FE9EB-1B78-4E3F-8F19-3869B02541E8}"/>
               </a:ext>
             </a:extLst>
           </p:cNvPr>
@@ -11122,7 +11180,7 @@
           <p:cNvPr id="2" name="">
             <a:extLst xmlns:a="http://schemas.openxmlformats.org/drawingml/2006/main">
               <a:ext uri="{FF2B5EF4-FFF2-40B4-BE49-F238E27FC236}">
-                <a16:creationId xmlns:a16="http://schemas.microsoft.com/office/drawing/2014/main" id="{9E2F31D0-B66F-4253-97CA-32F799962EE2}"/>
+                <a16:creationId xmlns:a16="http://schemas.microsoft.com/office/drawing/2014/main" id="{7672AA85-BA9E-4405-96C5-5E002AFCDEF8}"/>
               </a:ext>
             </a:extLst>
           </p:cNvPr>
@@ -11152,7 +11210,7 @@
           <p:cNvPr id="3" name="">
             <a:extLst xmlns:a="http://schemas.openxmlformats.org/drawingml/2006/main">
               <a:ext uri="{FF2B5EF4-FFF2-40B4-BE49-F238E27FC236}">
-                <a16:creationId xmlns:a16="http://schemas.microsoft.com/office/drawing/2014/main" id="{3EF1A6EC-BC4E-41C9-8148-CCCCDE2CA85F}"/>
+                <a16:creationId xmlns:a16="http://schemas.microsoft.com/office/drawing/2014/main" id="{DD409307-5C55-46DB-B7DD-5B787E395489}"/>
               </a:ext>
             </a:extLst>
           </p:cNvPr>
@@ -11197,7 +11255,7 @@
           <p:cNvPr id="4" name="">
             <a:extLst xmlns:a="http://schemas.openxmlformats.org/drawingml/2006/main">
               <a:ext uri="{FF2B5EF4-FFF2-40B4-BE49-F238E27FC236}">
-                <a16:creationId xmlns:a16="http://schemas.microsoft.com/office/drawing/2014/main" id="{DB4214EB-DC24-47EB-B010-264099852640}"/>
+                <a16:creationId xmlns:a16="http://schemas.microsoft.com/office/drawing/2014/main" id="{96E05C6B-EDD7-4C8A-A0BD-EDF5359F0685}"/>
               </a:ext>
             </a:extLst>
           </p:cNvPr>
@@ -11242,7 +11300,7 @@
           <p:cNvPr id="5" name="">
             <a:extLst xmlns:a="http://schemas.openxmlformats.org/drawingml/2006/main">
               <a:ext uri="{FF2B5EF4-FFF2-40B4-BE49-F238E27FC236}">
-                <a16:creationId xmlns:a16="http://schemas.microsoft.com/office/drawing/2014/main" id="{AD2ADF7A-00C8-4287-A210-E3D200980AD8}"/>
+                <a16:creationId xmlns:a16="http://schemas.microsoft.com/office/drawing/2014/main" id="{01F14804-78B2-494E-BC92-16E3A164BFF9}"/>
               </a:ext>
             </a:extLst>
           </p:cNvPr>
@@ -11287,7 +11345,7 @@
           <p:cNvPr id="6" name="">
             <a:extLst xmlns:a="http://schemas.openxmlformats.org/drawingml/2006/main">
               <a:ext uri="{FF2B5EF4-FFF2-40B4-BE49-F238E27FC236}">
-                <a16:creationId xmlns:a16="http://schemas.microsoft.com/office/drawing/2014/main" id="{AE0907DA-4A6C-4756-A336-992C49546AAE}"/>
+                <a16:creationId xmlns:a16="http://schemas.microsoft.com/office/drawing/2014/main" id="{26332308-6FF3-4049-BA00-66041711FDB3}"/>
               </a:ext>
             </a:extLst>
           </p:cNvPr>
@@ -11332,7 +11390,7 @@
           <p:cNvPr id="7" name="">
             <a:extLst xmlns:a="http://schemas.openxmlformats.org/drawingml/2006/main">
               <a:ext uri="{FF2B5EF4-FFF2-40B4-BE49-F238E27FC236}">
-                <a16:creationId xmlns:a16="http://schemas.microsoft.com/office/drawing/2014/main" id="{2D270DE4-99F1-49CA-9906-5A20BF97644A}"/>
+                <a16:creationId xmlns:a16="http://schemas.microsoft.com/office/drawing/2014/main" id="{4E2D6B02-A981-4473-88DA-D712017B07FC}"/>
               </a:ext>
             </a:extLst>
           </p:cNvPr>
@@ -11377,7 +11435,7 @@
           <p:cNvPr id="8" name="">
             <a:extLst xmlns:a="http://schemas.openxmlformats.org/drawingml/2006/main">
               <a:ext uri="{FF2B5EF4-FFF2-40B4-BE49-F238E27FC236}">
-                <a16:creationId xmlns:a16="http://schemas.microsoft.com/office/drawing/2014/main" id="{A6A309C6-0282-490F-8901-048A3F9EFBFD}"/>
+                <a16:creationId xmlns:a16="http://schemas.microsoft.com/office/drawing/2014/main" id="{FDF60FD4-F107-4299-8040-179FEC0A0182}"/>
               </a:ext>
             </a:extLst>
           </p:cNvPr>
@@ -11422,7 +11480,7 @@
           <p:cNvPr id="9" name="">
             <a:extLst xmlns:a="http://schemas.openxmlformats.org/drawingml/2006/main">
               <a:ext uri="{FF2B5EF4-FFF2-40B4-BE49-F238E27FC236}">
-                <a16:creationId xmlns:a16="http://schemas.microsoft.com/office/drawing/2014/main" id="{FDD88703-B323-4612-AF87-F9289AB94734}"/>
+                <a16:creationId xmlns:a16="http://schemas.microsoft.com/office/drawing/2014/main" id="{6F29AAA9-1CA3-4346-BEBA-A1AADF94360F}"/>
               </a:ext>
             </a:extLst>
           </p:cNvPr>
@@ -11467,7 +11525,7 @@
           <p:cNvPr id="10" name="">
             <a:extLst xmlns:a="http://schemas.openxmlformats.org/drawingml/2006/main">
               <a:ext uri="{FF2B5EF4-FFF2-40B4-BE49-F238E27FC236}">
-                <a16:creationId xmlns:a16="http://schemas.microsoft.com/office/drawing/2014/main" id="{5EAF3A52-C2B6-44EB-B845-96B2BBBCAF6E}"/>
+                <a16:creationId xmlns:a16="http://schemas.microsoft.com/office/drawing/2014/main" id="{F14697C4-3C2E-4DC0-8DEE-0EFE18D2B9D8}"/>
               </a:ext>
             </a:extLst>
           </p:cNvPr>
@@ -11512,7 +11570,7 @@
           <p:cNvPr id="11" name="">
             <a:extLst xmlns:a="http://schemas.openxmlformats.org/drawingml/2006/main">
               <a:ext uri="{FF2B5EF4-FFF2-40B4-BE49-F238E27FC236}">
-                <a16:creationId xmlns:a16="http://schemas.microsoft.com/office/drawing/2014/main" id="{1D60AADD-23A8-47CF-9D1F-FF8D2CC6FCC3}"/>
+                <a16:creationId xmlns:a16="http://schemas.microsoft.com/office/drawing/2014/main" id="{C48ECCB3-9045-499D-9A24-9D752C1CA228}"/>
               </a:ext>
             </a:extLst>
           </p:cNvPr>
@@ -11557,7 +11615,7 @@
           <p:cNvPr id="12" name="">
             <a:extLst xmlns:a="http://schemas.openxmlformats.org/drawingml/2006/main">
               <a:ext uri="{FF2B5EF4-FFF2-40B4-BE49-F238E27FC236}">
-                <a16:creationId xmlns:a16="http://schemas.microsoft.com/office/drawing/2014/main" id="{9A0F6887-5D65-4634-BE05-1052EAA0F537}"/>
+                <a16:creationId xmlns:a16="http://schemas.microsoft.com/office/drawing/2014/main" id="{0F517856-ED5F-4933-B1D5-4973CA97E1A6}"/>
               </a:ext>
             </a:extLst>
           </p:cNvPr>
@@ -11602,7 +11660,7 @@
           <p:cNvPr id="13" name="">
             <a:extLst xmlns:a="http://schemas.openxmlformats.org/drawingml/2006/main">
               <a:ext uri="{FF2B5EF4-FFF2-40B4-BE49-F238E27FC236}">
-                <a16:creationId xmlns:a16="http://schemas.microsoft.com/office/drawing/2014/main" id="{86333480-6F3B-44D0-AC48-9AFF4B40B7B3}"/>
+                <a16:creationId xmlns:a16="http://schemas.microsoft.com/office/drawing/2014/main" id="{AD1D3B16-4456-46F4-8761-28DCD18AF82C}"/>
               </a:ext>
             </a:extLst>
           </p:cNvPr>
@@ -11645,7 +11703,7 @@
     </p:spTree>
     <p:extLst>
       <p:ext uri="{BB962C8B-B14F-4D97-AF65-F5344CB8AC3E}">
-        <p14:creationId xmlns:p14="http://schemas.microsoft.com/office/powerpoint/2010/main" val="1445548751"/>
+        <p14:creationId xmlns:p14="http://schemas.microsoft.com/office/powerpoint/2010/main" val="1824263573"/>
       </p:ext>
     </p:extLst>
   </p:cSld>

</xml_diff>

<commit_message>
Use latest 30W CUDA FOV timings and remove Numba slides
</commit_message>
<xml_diff>
--- a/presentations/weekly_20261029/weekly_20261029_english_30w.pptx
+++ b/presentations/weekly_20261029/weekly_20261029_english_30w.pptx
@@ -2,21 +2,20 @@
 <file path=ppt/presentation.xml><?xml version="1.0" encoding="utf-8"?>
 <p:presentation xmlns:p="http://schemas.openxmlformats.org/presentationml/2006/main">
   <p:sldMasterIdLst>
-    <p:sldMasterId xmlns:r="http://schemas.openxmlformats.org/officeDocument/2006/relationships" id="2147483648" r:id="R09c16da95f79494d"/>
+    <p:sldMasterId xmlns:r="http://schemas.openxmlformats.org/officeDocument/2006/relationships" id="2147483648" r:id="R7ca1053cbf0c485f"/>
   </p:sldMasterIdLst>
   <p:notesMasterIdLst>
-    <p:notesMasterId xmlns:r="http://schemas.openxmlformats.org/officeDocument/2006/relationships" r:id="R4b0ad371359c4011"/>
+    <p:notesMasterId xmlns:r="http://schemas.openxmlformats.org/officeDocument/2006/relationships" r:id="Rde2cca9fd979416c"/>
   </p:notesMasterIdLst>
   <p:sldIdLst>
-    <p:sldId xmlns:r="http://schemas.openxmlformats.org/officeDocument/2006/relationships" id="256" r:id="R1bae078953534c2b"/>
-    <p:sldId xmlns:r="http://schemas.openxmlformats.org/officeDocument/2006/relationships" id="257" r:id="R3da9a5646f56409f"/>
-    <p:sldId xmlns:r="http://schemas.openxmlformats.org/officeDocument/2006/relationships" id="258" r:id="R4a3d9075b8804c72"/>
-    <p:sldId xmlns:r="http://schemas.openxmlformats.org/officeDocument/2006/relationships" id="259" r:id="Rfdf522f93e3c4443"/>
-    <p:sldId xmlns:r="http://schemas.openxmlformats.org/officeDocument/2006/relationships" id="260" r:id="Re211ad38b3184873"/>
-    <p:sldId xmlns:r="http://schemas.openxmlformats.org/officeDocument/2006/relationships" id="261" r:id="R068da9d99cb54720"/>
-    <p:sldId xmlns:r="http://schemas.openxmlformats.org/officeDocument/2006/relationships" id="262" r:id="Ra875afc61dc941a5"/>
-    <p:sldId xmlns:r="http://schemas.openxmlformats.org/officeDocument/2006/relationships" id="263" r:id="R60666f7c4dbf4417"/>
-    <p:sldId xmlns:r="http://schemas.openxmlformats.org/officeDocument/2006/relationships" id="264" r:id="Rba26559cd1ce497b"/>
+    <p:sldId xmlns:r="http://schemas.openxmlformats.org/officeDocument/2006/relationships" id="256" r:id="Rc44a82475b684fc6"/>
+    <p:sldId xmlns:r="http://schemas.openxmlformats.org/officeDocument/2006/relationships" id="257" r:id="Re391d4f25ddb4bba"/>
+    <p:sldId xmlns:r="http://schemas.openxmlformats.org/officeDocument/2006/relationships" id="258" r:id="Recac69d6359c4db1"/>
+    <p:sldId xmlns:r="http://schemas.openxmlformats.org/officeDocument/2006/relationships" id="259" r:id="R5b46e918a1164032"/>
+    <p:sldId xmlns:r="http://schemas.openxmlformats.org/officeDocument/2006/relationships" id="260" r:id="R158a05bf337b4ffd"/>
+    <p:sldId xmlns:r="http://schemas.openxmlformats.org/officeDocument/2006/relationships" id="261" r:id="Rda2e366a379d4fe3"/>
+    <p:sldId xmlns:r="http://schemas.openxmlformats.org/officeDocument/2006/relationships" id="262" r:id="R095801c8aa8e474b"/>
+    <p:sldId xmlns:r="http://schemas.openxmlformats.org/officeDocument/2006/relationships" id="263" r:id="R3b354d18e76c4f09"/>
   </p:sldIdLst>
   <p:sldSz cx="12192000" cy="6858000"/>
   <p:notesSz cx="6858000" cy="9144000"/>
@@ -730,7 +729,7 @@
           <a:lstStyle xmlns:a="http://schemas.openxmlformats.org/drawingml/2006/main"/>
           <a:p xmlns:a="http://schemas.openxmlformats.org/drawingml/2006/main">
             <a:r>
-              <a:t>Source: results/fov_levels_xavier_full_20261027/README.md; overview.csv; summary.csv. Commit 0f1506c. Date 2026-10-27. Raw evidence: evidence.tar.gz. Measured timing excludes decoding. Slides 6 and 7 add one fixed 2 ms decoding budget per frame to measured means; derived budget totals are not measured end-to-end latency. No joint RGB, depth and flow decoding measurement is claimed.</a:t>
+              <a:t>Source: results/fov_levels_xavier_full_20261027/README.md; overview.csv; summary.csv. Commit 0f1506c. Date 2026-10-27. Raw evidence: evidence.tar.gz. Timing source: results/cu_breakdown_xavier_20261029/README.md and results/fov_decode_budget_2ms_20261029/summary.csv. Timing: 30W 4CORE mode5, unlocked clocks, four driving workloads each frame39, 10 warmups and 100 timed repetitions per path. Staged CUDA-event GPU timeline, not wall time; events can include launch gaps. Quality: previous 15W evaluation, 1068 valid forward odd frames, one quality output per configuration and frame. These are separate experiments, not jointly measured quality-latency pairs.</a:t>
             </a:r>
           </a:p>
         </p:txBody>
@@ -800,7 +799,7 @@
           <a:lstStyle xmlns:a="http://schemas.openxmlformats.org/drawingml/2006/main"/>
           <a:p xmlns:a="http://schemas.openxmlformats.org/drawingml/2006/main">
             <a:r>
-              <a:t>Source: results/fov_levels_xavier_full_20261027/README.md; overview.csv; summary.csv. Commit 0f1506c. Date 2026-10-27. Raw evidence: evidence.tar.gz. Arithmetic means of all 5340 timing samples in each level/timing/mode group, computed by compute_means.py into mean_timings.json. No sample trimming. Full baseline measured separately per level. Fast resample enabled. Each value covers all 1068 supported frames. Adds a fixed 2 ms decode budget once per frame. Speedup is (2 + mean(full resident))/(2 + mean(FOV resident)) at the same region level. This is a derived budget, not measured end-to-end timing or measured joint RGB/depth/flow decoding. See results/fov_decode_budget_2ms_20261029/README.md and summary.csv. Region labels are image-area coverage, not sampling resolution.</a:t>
+              <a:t>Sources: results/cu_breakdown_xavier_20261029/README.md; results/fov_decode_budget_2ms_20261029/summary.csv. Four workloads, each frame39; 10 warmups and 100 timed runs per path. Arithmetic means of staged resident GPU timelines, not wall time. Full uses the paired baseline from the 2.8% configuration. Fixed decode budget is 2 ms once per frame, not measured joint RGB/depth/flow decoding or measured end-to-end timing. No input/output copies, network or display. Fast resampling enabled. Clearing dominates Full and accounts for about 58% of the Full-to-2.8% reconstruction saving, so the gain cannot be attributed entirely to reduced reprojection computation. No claim of an optimal Full baseline.</a:t>
             </a:r>
           </a:p>
         </p:txBody>
@@ -870,7 +869,7 @@
           <a:lstStyle xmlns:a="http://schemas.openxmlformats.org/drawingml/2006/main"/>
           <a:p xmlns:a="http://schemas.openxmlformats.org/drawingml/2006/main">
             <a:r>
-              <a:t>Source: results/fov_levels_xavier_full_20261027/README.md; overview.csv; summary.csv. Commit 0f1506c. Date 2026-10-27. Raw evidence: evidence.tar.gz. Original uint8-overflow PSNR preserved. Stereo delta is derived only if left eye remains unchanged and per-eye PSNR dB is averaged. Timing is never divided by two. Latency adds a fixed 2 ms per-frame decode budget once, not measured decoding or end-to-end latency. Source: results/fov_decode_budget_2ms_20261029/summary.csv.</a:t>
+              <a:t>Source: results/fov_levels_xavier_full_20261027/README.md; overview.csv; summary.csv. Commit 0f1506c. Date 2026-10-27. Raw evidence: evidence.tar.gz. Original uint8-overflow PSNR preserved. Stereo delta is derived only if left eye remains unchanged and per-eye PSNR dB is averaged. Quality: 15W, 1068 frames. Timing: separate 30W four-frame CUDA staged GPU experiment; not joint measurements and no new quality equivalence verified. Timing is never divided by two. Latency adds a fixed 2 ms per-frame decode budget once, not measured decoding or end-to-end latency. Source: results/fov_decode_budget_2ms_20261029/summary.csv.</a:t>
             </a:r>
           </a:p>
         </p:txBody>
@@ -940,76 +939,6 @@
           <a:lstStyle xmlns:a="http://schemas.openxmlformats.org/drawingml/2006/main"/>
           <a:p xmlns:a="http://schemas.openxmlformats.org/drawingml/2006/main">
             <a:r>
-              <a:t>Sources: results/numba_xavier_20261029/mode7_15w/result.json and results/numba_xavier_20261029/mode5_30w/result.json. Arithmetic means from mean_timings.json of all 100 samples per method, four workloads, frame39 only. 15W was measured before 30W. No confidence intervals. Some startup drift remains. Same Numba implementation and inputs. Preallocated resident timing includes launch/synchronization; excludes JIT, allocation, transfers, I/O. Power modes: 15W Desktop mode7 and 30W 4CORE mode5. Dynamic clocks, same four CPU cores. The 30W mode raises GPU/EMC limits but lowers the CPU maximum. Original generate_right includes allocation/transfer and startup drift; it is not the resident path shown. Numba upsampling differs from optimized CUDA C++.</a:t>
-            </a:r>
-          </a:p>
-        </p:txBody>
-      </p:sp>
-      <p:sp>
-        <p:nvSpPr>
-          <p:cNvPr id="4" name="Slide Number Placeholder 3"/>
-          <p:cNvSpPr>
-            <a:spLocks xmlns:a="http://schemas.openxmlformats.org/drawingml/2006/main" noGrp="1"/>
-          </p:cNvSpPr>
-          <p:nvPr>
-            <p:ph type="sldNum" idx="5"/>
-          </p:nvPr>
-        </p:nvSpPr>
-        <p:spPr/>
-        <p:txBody>
-          <a:bodyPr xmlns:a="http://schemas.openxmlformats.org/drawingml/2006/main"/>
-          <a:lstStyle xmlns:a="http://schemas.openxmlformats.org/drawingml/2006/main"/>
-          <a:p xmlns:a="http://schemas.openxmlformats.org/drawingml/2006/main"/>
-        </p:txBody>
-      </p:sp>
-    </p:spTree>
-  </p:cSld>
-  <p:clrMapOvr>
-    <a:masterClrMapping xmlns:a="http://schemas.openxmlformats.org/drawingml/2006/main"/>
-  </p:clrMapOvr>
-</p:notes>
-</file>
-
-<file path=ppt/notesSlides/notesSlide9.xml><?xml version="1.0" encoding="utf-8"?>
-<p:notes xmlns:p="http://schemas.openxmlformats.org/presentationml/2006/main">
-  <p:cSld>
-    <p:spTree>
-      <p:nvGrpSpPr>
-        <p:cNvPr id="1" name=""/>
-        <p:cNvGrpSpPr/>
-        <p:nvPr/>
-      </p:nvGrpSpPr>
-      <p:grpSpPr>
-        <a:xfrm xmlns:a="http://schemas.openxmlformats.org/drawingml/2006/main"/>
-      </p:grpSpPr>
-      <p:sp>
-        <p:nvSpPr>
-          <p:cNvPr id="2" name="Slide Image Placeholder 1"/>
-          <p:cNvSpPr>
-            <a:spLocks xmlns:a="http://schemas.openxmlformats.org/drawingml/2006/main" noGrp="1"/>
-          </p:cNvSpPr>
-          <p:nvPr>
-            <p:ph type="sldImg" idx="0"/>
-          </p:nvPr>
-        </p:nvSpPr>
-        <p:spPr/>
-      </p:sp>
-      <p:sp>
-        <p:nvSpPr>
-          <p:cNvPr id="3" name="Notes Placeholder 2"/>
-          <p:cNvSpPr>
-            <a:spLocks xmlns:a="http://schemas.openxmlformats.org/drawingml/2006/main" noGrp="1"/>
-          </p:cNvSpPr>
-          <p:nvPr>
-            <p:ph type="body" idx="1"/>
-          </p:nvPr>
-        </p:nvSpPr>
-        <p:spPr/>
-        <p:txBody>
-          <a:bodyPr xmlns:a="http://schemas.openxmlformats.org/drawingml/2006/main"/>
-          <a:lstStyle xmlns:a="http://schemas.openxmlformats.org/drawingml/2006/main"/>
-          <a:p xmlns:a="http://schemas.openxmlformats.org/drawingml/2006/main">
-            <a:r>
               <a:t>Proposed future work; no measured jitter trace or deadline-miss reduction exists in the current experiment. Slides 6–7 add a fixed 2 ms decode budget to local reconstruction means. Other timing values are local reconstruction measurements. None are measured end-to-end VR results.</a:t>
             </a:r>
           </a:p>
@@ -1057,7 +986,7 @@
           <p:cNvPr id="3" name="Title">
             <a:extLst xmlns:a="http://schemas.openxmlformats.org/drawingml/2006/main">
               <a:ext uri="{FF2B5EF4-FFF2-40B4-BE49-F238E27FC236}">
-                <a16:creationId xmlns:a16="http://schemas.microsoft.com/office/drawing/2014/main" id="{24DF9F45-FC59-43A7-8E20-E0E17B5E435A}"/>
+                <a16:creationId xmlns:a16="http://schemas.microsoft.com/office/drawing/2014/main" id="{9FEE180B-B391-4566-B228-D1E047002823}"/>
               </a:ext>
             </a:extLst>
           </p:cNvPr>
@@ -1286,7 +1215,7 @@
           <p:cNvPr id="2" name="Subtitle">
             <a:extLst xmlns:a="http://schemas.openxmlformats.org/drawingml/2006/main">
               <a:ext uri="{FF2B5EF4-FFF2-40B4-BE49-F238E27FC236}">
-                <a16:creationId xmlns:a16="http://schemas.microsoft.com/office/drawing/2014/main" id="{E99F5678-E9E6-48B0-A2A6-8F11D7BCEFEB}"/>
+                <a16:creationId xmlns:a16="http://schemas.microsoft.com/office/drawing/2014/main" id="{951D5504-1335-4E57-B3C8-C1B0E480ACF5}"/>
               </a:ext>
             </a:extLst>
           </p:cNvPr>
@@ -1532,7 +1461,7 @@
           <p:cNvPr id="2" name="Section title">
             <a:extLst xmlns:a="http://schemas.openxmlformats.org/drawingml/2006/main">
               <a:ext uri="{FF2B5EF4-FFF2-40B4-BE49-F238E27FC236}">
-                <a16:creationId xmlns:a16="http://schemas.microsoft.com/office/drawing/2014/main" id="{F85F409A-9725-4520-880C-43858F3CCC07}"/>
+                <a16:creationId xmlns:a16="http://schemas.microsoft.com/office/drawing/2014/main" id="{6DB74584-9611-4101-98B6-85A7848539A9}"/>
               </a:ext>
             </a:extLst>
           </p:cNvPr>
@@ -1778,7 +1707,7 @@
           <p:cNvPr id="3" name="Title">
             <a:extLst xmlns:a="http://schemas.openxmlformats.org/drawingml/2006/main">
               <a:ext uri="{FF2B5EF4-FFF2-40B4-BE49-F238E27FC236}">
-                <a16:creationId xmlns:a16="http://schemas.microsoft.com/office/drawing/2014/main" id="{3DB4891D-6C48-476F-9DFA-0DD275715DA0}"/>
+                <a16:creationId xmlns:a16="http://schemas.microsoft.com/office/drawing/2014/main" id="{664199E0-B7F2-4DB6-AFC4-ECA2793DE071}"/>
               </a:ext>
             </a:extLst>
           </p:cNvPr>
@@ -2007,7 +1936,7 @@
           <p:cNvPr id="2" name="Body">
             <a:extLst xmlns:a="http://schemas.openxmlformats.org/drawingml/2006/main">
               <a:ext uri="{FF2B5EF4-FFF2-40B4-BE49-F238E27FC236}">
-                <a16:creationId xmlns:a16="http://schemas.microsoft.com/office/drawing/2014/main" id="{6F2B9A86-1DC6-4234-9BB9-8A94BB7626BC}"/>
+                <a16:creationId xmlns:a16="http://schemas.microsoft.com/office/drawing/2014/main" id="{55D6F6FE-A9BA-4DAC-8EAD-90FA03099A33}"/>
               </a:ext>
             </a:extLst>
           </p:cNvPr>
@@ -2253,7 +2182,7 @@
           <p:cNvPr id="4" name="Title">
             <a:extLst xmlns:a="http://schemas.openxmlformats.org/drawingml/2006/main">
               <a:ext uri="{FF2B5EF4-FFF2-40B4-BE49-F238E27FC236}">
-                <a16:creationId xmlns:a16="http://schemas.microsoft.com/office/drawing/2014/main" id="{8FB57DEF-1DC9-46FC-80AD-1F83CEDAE962}"/>
+                <a16:creationId xmlns:a16="http://schemas.microsoft.com/office/drawing/2014/main" id="{3484D47D-1E5D-4F41-9C39-4DEAB53DC7B9}"/>
               </a:ext>
             </a:extLst>
           </p:cNvPr>
@@ -2482,7 +2411,7 @@
           <p:cNvPr id="2" name="Left column">
             <a:extLst xmlns:a="http://schemas.openxmlformats.org/drawingml/2006/main">
               <a:ext uri="{FF2B5EF4-FFF2-40B4-BE49-F238E27FC236}">
-                <a16:creationId xmlns:a16="http://schemas.microsoft.com/office/drawing/2014/main" id="{F7A954F3-244F-4933-99CC-2270647BE5FE}"/>
+                <a16:creationId xmlns:a16="http://schemas.microsoft.com/office/drawing/2014/main" id="{C707FB4C-70BE-4CB6-96D0-9FE41028427E}"/>
               </a:ext>
             </a:extLst>
           </p:cNvPr>
@@ -2711,7 +2640,7 @@
           <p:cNvPr id="3" name="Right column">
             <a:extLst xmlns:a="http://schemas.openxmlformats.org/drawingml/2006/main">
               <a:ext uri="{FF2B5EF4-FFF2-40B4-BE49-F238E27FC236}">
-                <a16:creationId xmlns:a16="http://schemas.microsoft.com/office/drawing/2014/main" id="{FB6F6A27-07DD-40F4-B345-988849EE497E}"/>
+                <a16:creationId xmlns:a16="http://schemas.microsoft.com/office/drawing/2014/main" id="{BF24391E-9A9A-4004-AECC-7A5BAEB90E50}"/>
               </a:ext>
             </a:extLst>
           </p:cNvPr>
@@ -2957,7 +2886,7 @@
           <p:cNvPr id="3" name="Title">
             <a:extLst xmlns:a="http://schemas.openxmlformats.org/drawingml/2006/main">
               <a:ext uri="{FF2B5EF4-FFF2-40B4-BE49-F238E27FC236}">
-                <a16:creationId xmlns:a16="http://schemas.microsoft.com/office/drawing/2014/main" id="{F77423CC-3184-40D3-A01C-7E2DB3BE8CFD}"/>
+                <a16:creationId xmlns:a16="http://schemas.microsoft.com/office/drawing/2014/main" id="{68E062D7-29BF-4D64-899A-3E9C73ABE2B5}"/>
               </a:ext>
             </a:extLst>
           </p:cNvPr>
@@ -3186,7 +3115,7 @@
           <p:cNvPr id="2" name="Left column">
             <a:extLst xmlns:a="http://schemas.openxmlformats.org/drawingml/2006/main">
               <a:ext uri="{FF2B5EF4-FFF2-40B4-BE49-F238E27FC236}">
-                <a16:creationId xmlns:a16="http://schemas.microsoft.com/office/drawing/2014/main" id="{967BE377-8895-46AC-933F-8318019C8710}"/>
+                <a16:creationId xmlns:a16="http://schemas.microsoft.com/office/drawing/2014/main" id="{2B3C3C8F-20C3-4776-8576-5E1973D9C271}"/>
               </a:ext>
             </a:extLst>
           </p:cNvPr>
@@ -3453,12 +3382,12 @@
   </p:cSld>
   <p:clrMap bg1="lt1" tx1="dk1" bg2="lt2" tx2="dk2" accent1="accent1" accent2="accent2" accent3="accent3" accent4="accent4" accent5="accent5" accent6="accent6" hlink="hlink" folHlink="folHlink"/>
   <p:sldLayoutIdLst>
-    <p:sldLayoutId xmlns:r="http://schemas.openxmlformats.org/officeDocument/2006/relationships" id="2147483649" r:id="R522db64f52a64598"/>
-    <p:sldLayoutId xmlns:r="http://schemas.openxmlformats.org/officeDocument/2006/relationships" id="2147483650" r:id="Rd8360840e281494a"/>
-    <p:sldLayoutId xmlns:r="http://schemas.openxmlformats.org/officeDocument/2006/relationships" id="2147483651" r:id="Rfcbd20d874ba4662"/>
-    <p:sldLayoutId xmlns:r="http://schemas.openxmlformats.org/officeDocument/2006/relationships" id="2147483652" r:id="R349cd0d644c14c22"/>
-    <p:sldLayoutId xmlns:r="http://schemas.openxmlformats.org/officeDocument/2006/relationships" id="2147483653" r:id="R6a93088c717a4517"/>
-    <p:sldLayoutId xmlns:r="http://schemas.openxmlformats.org/officeDocument/2006/relationships" id="2147483654" r:id="R9264f88eb0ff4dea"/>
+    <p:sldLayoutId xmlns:r="http://schemas.openxmlformats.org/officeDocument/2006/relationships" id="2147483649" r:id="Rf13116748e6548c0"/>
+    <p:sldLayoutId xmlns:r="http://schemas.openxmlformats.org/officeDocument/2006/relationships" id="2147483650" r:id="Rad1425ba87424009"/>
+    <p:sldLayoutId xmlns:r="http://schemas.openxmlformats.org/officeDocument/2006/relationships" id="2147483651" r:id="R3fb2548c22854566"/>
+    <p:sldLayoutId xmlns:r="http://schemas.openxmlformats.org/officeDocument/2006/relationships" id="2147483652" r:id="Ra6657312b3214369"/>
+    <p:sldLayoutId xmlns:r="http://schemas.openxmlformats.org/officeDocument/2006/relationships" id="2147483653" r:id="R4dcaf2e14cb44152"/>
+    <p:sldLayoutId xmlns:r="http://schemas.openxmlformats.org/officeDocument/2006/relationships" id="2147483654" r:id="Re59bd741f9e343e0"/>
   </p:sldLayoutIdLst>
   <p:txStyles>
     <p:titleStyle>
@@ -3992,13 +3921,13 @@
     <c:plotArea>
       <c:barChart>
         <c:barDir val="col"/>
-        <c:grouping val="clustered"/>
+        <c:grouping val="stacked"/>
         <c:varyColors val="0"/>
         <c:ser>
           <c:idx val="0"/>
           <c:order val="0"/>
           <c:tx>
-            <c:v>FOV resident + decode</c:v>
+            <c:v>Measured reconstruction</c:v>
           </c:tx>
           <c:spPr>
             <a:solidFill xmlns:a="http://schemas.openxmlformats.org/drawingml/2006/main">
@@ -4008,22 +3937,25 @@
           <c:invertIfNegative val="0"/>
           <c:cat>
             <c:strRef>
-              <c:f>'Chart Data'!$A$2:$A$6</c:f>
+              <c:f>'Chart Data'!$A$2:$A$7</c:f>
               <c:strCache>
-                <c:ptCount val="5"/>
+                <c:ptCount val="6"/>
                 <c:pt idx="0">
+                  <c:v>Full</c:v>
+                </c:pt>
+                <c:pt idx="1">
                   <c:v>0.7%</c:v>
                 </c:pt>
-                <c:pt idx="1">
+                <c:pt idx="2">
                   <c:v>2.8%</c:v>
                 </c:pt>
-                <c:pt idx="2">
+                <c:pt idx="3">
                   <c:v>11.1%</c:v>
                 </c:pt>
-                <c:pt idx="3">
+                <c:pt idx="4">
                   <c:v>25.0%</c:v>
                 </c:pt>
-                <c:pt idx="4">
+                <c:pt idx="5">
                   <c:v>44.4%</c:v>
                 </c:pt>
               </c:strCache>
@@ -4031,24 +3963,27 @@
           </c:cat>
           <c:val>
             <c:numRef>
-              <c:f>'Chart Data'!$B$2:$B$6</c:f>
+              <c:f>'Chart Data'!$B$2:$B$7</c:f>
               <c:numCache>
                 <c:formatCode>General</c:formatCode>
-                <c:ptCount val="5"/>
+                <c:ptCount val="6"/>
                 <c:pt idx="0">
-                  <c:v>6.562</c:v>
+                  <c:v>7.996</c:v>
                 </c:pt>
                 <c:pt idx="1">
-                  <c:v>6.77</c:v>
+                  <c:v>3.248</c:v>
                 </c:pt>
                 <c:pt idx="2">
-                  <c:v>7.998</c:v>
+                  <c:v>3.462</c:v>
                 </c:pt>
                 <c:pt idx="3">
-                  <c:v>9.772</c:v>
+                  <c:v>4.318</c:v>
                 </c:pt>
                 <c:pt idx="4">
-                  <c:v>12.425</c:v>
+                  <c:v>5.637</c:v>
+                </c:pt>
+                <c:pt idx="5">
+                  <c:v>7.543</c:v>
                 </c:pt>
               </c:numCache>
             </c:numRef>
@@ -4058,7 +3993,7 @@
           <c:idx val="1"/>
           <c:order val="1"/>
           <c:tx>
-            <c:v>FOV stream + decode</c:v>
+            <c:v>Fixed decode budget (2 ms)</c:v>
           </c:tx>
           <c:spPr>
             <a:solidFill xmlns:a="http://schemas.openxmlformats.org/drawingml/2006/main">
@@ -4068,22 +4003,25 @@
           <c:invertIfNegative val="0"/>
           <c:cat>
             <c:strRef>
-              <c:f>'Chart Data'!$C$2:$C$6</c:f>
+              <c:f>'Chart Data'!$C$2:$C$7</c:f>
               <c:strCache>
-                <c:ptCount val="5"/>
+                <c:ptCount val="6"/>
                 <c:pt idx="0">
+                  <c:v>Full</c:v>
+                </c:pt>
+                <c:pt idx="1">
                   <c:v>0.7%</c:v>
                 </c:pt>
-                <c:pt idx="1">
+                <c:pt idx="2">
                   <c:v>2.8%</c:v>
                 </c:pt>
-                <c:pt idx="2">
+                <c:pt idx="3">
                   <c:v>11.1%</c:v>
                 </c:pt>
-                <c:pt idx="3">
+                <c:pt idx="4">
                   <c:v>25.0%</c:v>
                 </c:pt>
-                <c:pt idx="4">
+                <c:pt idx="5">
                   <c:v>44.4%</c:v>
                 </c:pt>
               </c:strCache>
@@ -4091,84 +4029,27 @@
           </c:cat>
           <c:val>
             <c:numRef>
-              <c:f>'Chart Data'!$D$2:$D$6</c:f>
+              <c:f>'Chart Data'!$D$2:$D$7</c:f>
               <c:numCache>
                 <c:formatCode>General</c:formatCode>
-                <c:ptCount val="5"/>
+                <c:ptCount val="6"/>
                 <c:pt idx="0">
-                  <c:v>8.364</c:v>
+                  <c:v>2</c:v>
                 </c:pt>
                 <c:pt idx="1">
-                  <c:v>8.728</c:v>
+                  <c:v>2</c:v>
                 </c:pt>
                 <c:pt idx="2">
-                  <c:v>9.839</c:v>
+                  <c:v>2</c:v>
                 </c:pt>
                 <c:pt idx="3">
-                  <c:v>11.655</c:v>
+                  <c:v>2</c:v>
                 </c:pt>
                 <c:pt idx="4">
-                  <c:v>14.193</c:v>
+                  <c:v>2</c:v>
                 </c:pt>
-              </c:numCache>
-            </c:numRef>
-          </c:val>
-        </c:ser>
-        <c:ser>
-          <c:idx val="2"/>
-          <c:order val="2"/>
-          <c:tx>
-            <c:v>Full resident + decode</c:v>
-          </c:tx>
-          <c:spPr>
-            <a:solidFill xmlns:a="http://schemas.openxmlformats.org/drawingml/2006/main">
-              <a:srgbClr val="536675"/>
-            </a:solidFill>
-          </c:spPr>
-          <c:invertIfNegative val="0"/>
-          <c:cat>
-            <c:strRef>
-              <c:f>'Chart Data'!$E$2:$E$6</c:f>
-              <c:strCache>
-                <c:ptCount val="5"/>
-                <c:pt idx="0">
-                  <c:v>0.7%</c:v>
-                </c:pt>
-                <c:pt idx="1">
-                  <c:v>2.8%</c:v>
-                </c:pt>
-                <c:pt idx="2">
-                  <c:v>11.1%</c:v>
-                </c:pt>
-                <c:pt idx="3">
-                  <c:v>25.0%</c:v>
-                </c:pt>
-                <c:pt idx="4">
-                  <c:v>44.4%</c:v>
-                </c:pt>
-              </c:strCache>
-            </c:strRef>
-          </c:cat>
-          <c:val>
-            <c:numRef>
-              <c:f>'Chart Data'!$F$2:$F$6</c:f>
-              <c:numCache>
-                <c:formatCode>General</c:formatCode>
-                <c:ptCount val="5"/>
-                <c:pt idx="0">
-                  <c:v>13.187</c:v>
-                </c:pt>
-                <c:pt idx="1">
-                  <c:v>13.022</c:v>
-                </c:pt>
-                <c:pt idx="2">
-                  <c:v>13.144</c:v>
-                </c:pt>
-                <c:pt idx="3">
-                  <c:v>13.042</c:v>
-                </c:pt>
-                <c:pt idx="4">
-                  <c:v>13.087</c:v>
+                <c:pt idx="5">
+                  <c:v>2</c:v>
                 </c:pt>
               </c:numCache>
             </c:numRef>
@@ -4197,7 +4078,7 @@
           <c:showLeaderLines val="0"/>
         </c:dLbls>
         <c:gapWidth val="75"/>
-        <c:overlap val="0"/>
+        <c:overlap val="100"/>
         <c:axId val="48650112"/>
         <c:axId val="48672768"/>
       </c:barChart>
@@ -4241,7 +4122,7 @@
         <c:axId val="48672768"/>
         <c:scaling>
           <c:orientation val="minMax"/>
-          <c:max val="16"/>
+          <c:max val="12"/>
           <c:min val="0"/>
         </c:scaling>
         <c:delete val="0"/>
@@ -4267,7 +4148,7 @@
                     <a:ea typeface="Arial"/>
                     <a:cs typeface="Arial"/>
                   </a:rPr>
-                  <a:t>Decode + recon mean (ms)</a:t>
+                  <a:t>Decode + GPU reconstruction (ms)</a:t>
                 </a:r>
               </a:p>
             </c:rich>
@@ -4332,7 +4213,7 @@
         <a:lstStyle xmlns:a="http://schemas.openxmlformats.org/drawingml/2006/main"/>
         <a:p xmlns:a="http://schemas.openxmlformats.org/drawingml/2006/main">
           <a:pPr>
-            <a:defRPr sz="1350">
+            <a:defRPr sz="1500">
               <a:latin typeface="Arial"/>
               <a:ea typeface="Arial"/>
               <a:cs typeface="Arial"/>
@@ -4378,7 +4259,7 @@
           <p:cNvPr id="5" name="">
             <a:extLst xmlns:a="http://schemas.openxmlformats.org/drawingml/2006/main">
               <a:ext uri="{FF2B5EF4-FFF2-40B4-BE49-F238E27FC236}">
-                <a16:creationId xmlns:a16="http://schemas.microsoft.com/office/drawing/2014/main" id="{18A92686-69A8-404D-BF9C-906CB70FF613}"/>
+                <a16:creationId xmlns:a16="http://schemas.microsoft.com/office/drawing/2014/main" id="{D3AC35FD-4B7A-4808-9C27-08FD8D2BA0C4}"/>
               </a:ext>
             </a:extLst>
           </p:cNvPr>
@@ -4436,7 +4317,7 @@
           <p:cNvPr id="2" name="">
             <a:extLst xmlns:a="http://schemas.openxmlformats.org/drawingml/2006/main">
               <a:ext uri="{FF2B5EF4-FFF2-40B4-BE49-F238E27FC236}">
-                <a16:creationId xmlns:a16="http://schemas.microsoft.com/office/drawing/2014/main" id="{EDF7C31D-EE95-4DF4-9708-AA0E667A0BDF}"/>
+                <a16:creationId xmlns:a16="http://schemas.microsoft.com/office/drawing/2014/main" id="{21B3FB4B-F0FF-42E5-B558-758DC6360645}"/>
               </a:ext>
             </a:extLst>
           </p:cNvPr>
@@ -4481,7 +4362,7 @@
           <p:cNvPr id="3" name="">
             <a:extLst xmlns:a="http://schemas.openxmlformats.org/drawingml/2006/main">
               <a:ext uri="{FF2B5EF4-FFF2-40B4-BE49-F238E27FC236}">
-                <a16:creationId xmlns:a16="http://schemas.microsoft.com/office/drawing/2014/main" id="{DEFC9F8B-EC62-464A-B627-673AD38115F3}"/>
+                <a16:creationId xmlns:a16="http://schemas.microsoft.com/office/drawing/2014/main" id="{BA478614-551E-40A4-9C4C-83C8A749492A}"/>
               </a:ext>
             </a:extLst>
           </p:cNvPr>
@@ -4526,7 +4407,7 @@
           <p:cNvPr id="4" name="">
             <a:extLst xmlns:a="http://schemas.openxmlformats.org/drawingml/2006/main">
               <a:ext uri="{FF2B5EF4-FFF2-40B4-BE49-F238E27FC236}">
-                <a16:creationId xmlns:a16="http://schemas.microsoft.com/office/drawing/2014/main" id="{6D2C45ED-149A-4E57-A1F9-C5AD2D9A2456}"/>
+                <a16:creationId xmlns:a16="http://schemas.microsoft.com/office/drawing/2014/main" id="{7EC87427-EAF5-4E74-B91C-311D31F039B8}"/>
               </a:ext>
             </a:extLst>
           </p:cNvPr>
@@ -4569,7 +4450,7 @@
     </p:spTree>
     <p:extLst>
       <p:ext uri="{BB962C8B-B14F-4D97-AF65-F5344CB8AC3E}">
-        <p14:creationId xmlns:p14="http://schemas.microsoft.com/office/powerpoint/2010/main" val="1115952735"/>
+        <p14:creationId xmlns:p14="http://schemas.microsoft.com/office/powerpoint/2010/main" val="293171933"/>
       </p:ext>
     </p:extLst>
   </p:cSld>
@@ -4600,7 +4481,7 @@
           <p:cNvPr id="29" name="">
             <a:extLst xmlns:a="http://schemas.openxmlformats.org/drawingml/2006/main">
               <a:ext uri="{FF2B5EF4-FFF2-40B4-BE49-F238E27FC236}">
-                <a16:creationId xmlns:a16="http://schemas.microsoft.com/office/drawing/2014/main" id="{CFACBA5B-61E3-47F2-B03F-9BCA5C521B64}"/>
+                <a16:creationId xmlns:a16="http://schemas.microsoft.com/office/drawing/2014/main" id="{AD8FA9BA-C557-485C-863F-9E4BD7C6FE90}"/>
               </a:ext>
             </a:extLst>
           </p:cNvPr>
@@ -4645,7 +4526,7 @@
           <p:cNvPr id="2" name="">
             <a:extLst xmlns:a="http://schemas.openxmlformats.org/drawingml/2006/main">
               <a:ext uri="{FF2B5EF4-FFF2-40B4-BE49-F238E27FC236}">
-                <a16:creationId xmlns:a16="http://schemas.microsoft.com/office/drawing/2014/main" id="{1D927697-DC3B-4E3B-B8D4-98A7D8C8C334}"/>
+                <a16:creationId xmlns:a16="http://schemas.microsoft.com/office/drawing/2014/main" id="{C4AE0170-D966-4095-B886-0226A2355A64}"/>
               </a:ext>
             </a:extLst>
           </p:cNvPr>
@@ -4675,7 +4556,7 @@
           <p:cNvPr id="3" name="">
             <a:extLst xmlns:a="http://schemas.openxmlformats.org/drawingml/2006/main">
               <a:ext uri="{FF2B5EF4-FFF2-40B4-BE49-F238E27FC236}">
-                <a16:creationId xmlns:a16="http://schemas.microsoft.com/office/drawing/2014/main" id="{9AE51353-61A1-4D91-9F51-0DE8D3514082}"/>
+                <a16:creationId xmlns:a16="http://schemas.microsoft.com/office/drawing/2014/main" id="{56596B46-E5E5-4196-B3DF-D5421114F456}"/>
               </a:ext>
             </a:extLst>
           </p:cNvPr>
@@ -4720,7 +4601,7 @@
           <p:cNvPr id="4" name="">
             <a:extLst xmlns:a="http://schemas.openxmlformats.org/drawingml/2006/main">
               <a:ext uri="{FF2B5EF4-FFF2-40B4-BE49-F238E27FC236}">
-                <a16:creationId xmlns:a16="http://schemas.microsoft.com/office/drawing/2014/main" id="{717DEF9D-440C-4ED1-B077-9B2F49B5D2A2}"/>
+                <a16:creationId xmlns:a16="http://schemas.microsoft.com/office/drawing/2014/main" id="{B7540364-42D7-406D-8E0E-6990929CEFC2}"/>
               </a:ext>
             </a:extLst>
           </p:cNvPr>
@@ -4765,7 +4646,7 @@
           <p:cNvPr id="5" name="">
             <a:extLst xmlns:a="http://schemas.openxmlformats.org/drawingml/2006/main">
               <a:ext uri="{FF2B5EF4-FFF2-40B4-BE49-F238E27FC236}">
-                <a16:creationId xmlns:a16="http://schemas.microsoft.com/office/drawing/2014/main" id="{48DFAA68-2115-4444-96DC-62CE0473F8D5}"/>
+                <a16:creationId xmlns:a16="http://schemas.microsoft.com/office/drawing/2014/main" id="{D93EADF1-E3D4-418C-BA16-0342278335C5}"/>
               </a:ext>
             </a:extLst>
           </p:cNvPr>
@@ -4810,7 +4691,7 @@
           <p:cNvPr id="6" name="">
             <a:extLst xmlns:a="http://schemas.openxmlformats.org/drawingml/2006/main">
               <a:ext uri="{FF2B5EF4-FFF2-40B4-BE49-F238E27FC236}">
-                <a16:creationId xmlns:a16="http://schemas.microsoft.com/office/drawing/2014/main" id="{4956E592-2F82-44C5-9469-995AE73843C2}"/>
+                <a16:creationId xmlns:a16="http://schemas.microsoft.com/office/drawing/2014/main" id="{B541D8E6-3EBF-4A77-AA35-638F27D55611}"/>
               </a:ext>
             </a:extLst>
           </p:cNvPr>
@@ -4842,7 +4723,7 @@
           <p:cNvPr id="7" name="">
             <a:extLst xmlns:a="http://schemas.openxmlformats.org/drawingml/2006/main">
               <a:ext uri="{FF2B5EF4-FFF2-40B4-BE49-F238E27FC236}">
-                <a16:creationId xmlns:a16="http://schemas.microsoft.com/office/drawing/2014/main" id="{7675879B-9EE6-4BB0-8A64-41A02C8D7FB1}"/>
+                <a16:creationId xmlns:a16="http://schemas.microsoft.com/office/drawing/2014/main" id="{A24B6D2B-3FA7-4708-B8B7-7FC2A10204DA}"/>
               </a:ext>
             </a:extLst>
           </p:cNvPr>
@@ -4874,7 +4755,7 @@
           <p:cNvPr id="8" name="">
             <a:extLst xmlns:a="http://schemas.openxmlformats.org/drawingml/2006/main">
               <a:ext uri="{FF2B5EF4-FFF2-40B4-BE49-F238E27FC236}">
-                <a16:creationId xmlns:a16="http://schemas.microsoft.com/office/drawing/2014/main" id="{23D579B2-D07D-4DB3-A782-E5C591B4FE97}"/>
+                <a16:creationId xmlns:a16="http://schemas.microsoft.com/office/drawing/2014/main" id="{75A00B2D-FC9F-4EED-821F-18DC9D38372D}"/>
               </a:ext>
             </a:extLst>
           </p:cNvPr>
@@ -4906,7 +4787,7 @@
           <p:cNvPr id="9" name="">
             <a:extLst xmlns:a="http://schemas.openxmlformats.org/drawingml/2006/main">
               <a:ext uri="{FF2B5EF4-FFF2-40B4-BE49-F238E27FC236}">
-                <a16:creationId xmlns:a16="http://schemas.microsoft.com/office/drawing/2014/main" id="{2D39941B-E404-40D0-8F56-CE9C8D36764A}"/>
+                <a16:creationId xmlns:a16="http://schemas.microsoft.com/office/drawing/2014/main" id="{EB0D189D-4CA2-45CA-B3BC-110853409893}"/>
               </a:ext>
             </a:extLst>
           </p:cNvPr>
@@ -4951,7 +4832,7 @@
           <p:cNvPr id="10" name="">
             <a:extLst xmlns:a="http://schemas.openxmlformats.org/drawingml/2006/main">
               <a:ext uri="{FF2B5EF4-FFF2-40B4-BE49-F238E27FC236}">
-                <a16:creationId xmlns:a16="http://schemas.microsoft.com/office/drawing/2014/main" id="{E9C0D35C-CAA1-4A01-A44E-8F6E279ABF78}"/>
+                <a16:creationId xmlns:a16="http://schemas.microsoft.com/office/drawing/2014/main" id="{D6FAFB12-9041-40CE-8FE2-1F1A96B967A6}"/>
               </a:ext>
             </a:extLst>
           </p:cNvPr>
@@ -4981,7 +4862,7 @@
           <p:cNvPr id="11" name="">
             <a:extLst xmlns:a="http://schemas.openxmlformats.org/drawingml/2006/main">
               <a:ext uri="{FF2B5EF4-FFF2-40B4-BE49-F238E27FC236}">
-                <a16:creationId xmlns:a16="http://schemas.microsoft.com/office/drawing/2014/main" id="{D4BBE91A-B035-4303-B58B-D935DDAC270A}"/>
+                <a16:creationId xmlns:a16="http://schemas.microsoft.com/office/drawing/2014/main" id="{F35D49DE-3FC1-4963-BD13-79383AFBC6EA}"/>
               </a:ext>
             </a:extLst>
           </p:cNvPr>
@@ -5026,7 +4907,7 @@
           <p:cNvPr id="12" name="">
             <a:extLst xmlns:a="http://schemas.openxmlformats.org/drawingml/2006/main">
               <a:ext uri="{FF2B5EF4-FFF2-40B4-BE49-F238E27FC236}">
-                <a16:creationId xmlns:a16="http://schemas.microsoft.com/office/drawing/2014/main" id="{D73934C4-E1F2-48C0-9BC6-8239FCE3D153}"/>
+                <a16:creationId xmlns:a16="http://schemas.microsoft.com/office/drawing/2014/main" id="{31F43E90-0D70-42ED-B4D3-6D269D9D26E3}"/>
               </a:ext>
             </a:extLst>
           </p:cNvPr>
@@ -5058,7 +4939,7 @@
           <p:cNvPr id="13" name="">
             <a:extLst xmlns:a="http://schemas.openxmlformats.org/drawingml/2006/main">
               <a:ext uri="{FF2B5EF4-FFF2-40B4-BE49-F238E27FC236}">
-                <a16:creationId xmlns:a16="http://schemas.microsoft.com/office/drawing/2014/main" id="{329CE209-3F3F-4EA7-BEE0-C33B656BDE2D}"/>
+                <a16:creationId xmlns:a16="http://schemas.microsoft.com/office/drawing/2014/main" id="{D66E8372-9D83-410B-BD78-E3590AF68F5D}"/>
               </a:ext>
             </a:extLst>
           </p:cNvPr>
@@ -5090,7 +4971,7 @@
           <p:cNvPr id="14" name="">
             <a:extLst xmlns:a="http://schemas.openxmlformats.org/drawingml/2006/main">
               <a:ext uri="{FF2B5EF4-FFF2-40B4-BE49-F238E27FC236}">
-                <a16:creationId xmlns:a16="http://schemas.microsoft.com/office/drawing/2014/main" id="{E49D505D-1576-4936-B9BE-22345E10BBC7}"/>
+                <a16:creationId xmlns:a16="http://schemas.microsoft.com/office/drawing/2014/main" id="{329C7A1A-15E0-423D-9372-92B7F73C852B}"/>
               </a:ext>
             </a:extLst>
           </p:cNvPr>
@@ -5122,7 +5003,7 @@
           <p:cNvPr id="15" name="">
             <a:extLst xmlns:a="http://schemas.openxmlformats.org/drawingml/2006/main">
               <a:ext uri="{FF2B5EF4-FFF2-40B4-BE49-F238E27FC236}">
-                <a16:creationId xmlns:a16="http://schemas.microsoft.com/office/drawing/2014/main" id="{A5AA3B68-26C2-44A4-941C-92E5B4F81156}"/>
+                <a16:creationId xmlns:a16="http://schemas.microsoft.com/office/drawing/2014/main" id="{CACCA813-F062-44AA-B921-6CDB667F05E5}"/>
               </a:ext>
             </a:extLst>
           </p:cNvPr>
@@ -5167,7 +5048,7 @@
           <p:cNvPr id="16" name="">
             <a:extLst xmlns:a="http://schemas.openxmlformats.org/drawingml/2006/main">
               <a:ext uri="{FF2B5EF4-FFF2-40B4-BE49-F238E27FC236}">
-                <a16:creationId xmlns:a16="http://schemas.microsoft.com/office/drawing/2014/main" id="{94CD312C-F2C4-4FE4-A897-31C4A1587F37}"/>
+                <a16:creationId xmlns:a16="http://schemas.microsoft.com/office/drawing/2014/main" id="{4F6FB8BE-1FAF-4CA7-8E53-3C71FE676EB1}"/>
               </a:ext>
             </a:extLst>
           </p:cNvPr>
@@ -5197,7 +5078,7 @@
           <p:cNvPr id="17" name="">
             <a:extLst xmlns:a="http://schemas.openxmlformats.org/drawingml/2006/main">
               <a:ext uri="{FF2B5EF4-FFF2-40B4-BE49-F238E27FC236}">
-                <a16:creationId xmlns:a16="http://schemas.microsoft.com/office/drawing/2014/main" id="{D8166C1B-F7E0-40A8-AFAF-3F7052F3478E}"/>
+                <a16:creationId xmlns:a16="http://schemas.microsoft.com/office/drawing/2014/main" id="{79B8B42B-D9CD-401D-8820-B7C9D6D15021}"/>
               </a:ext>
             </a:extLst>
           </p:cNvPr>
@@ -5242,7 +5123,7 @@
           <p:cNvPr id="18" name="">
             <a:extLst xmlns:a="http://schemas.openxmlformats.org/drawingml/2006/main">
               <a:ext uri="{FF2B5EF4-FFF2-40B4-BE49-F238E27FC236}">
-                <a16:creationId xmlns:a16="http://schemas.microsoft.com/office/drawing/2014/main" id="{EE17512B-AB56-40E4-9032-A24F7AFC336E}"/>
+                <a16:creationId xmlns:a16="http://schemas.microsoft.com/office/drawing/2014/main" id="{592C2AF6-43F4-4F05-8CB5-C372720D787A}"/>
               </a:ext>
             </a:extLst>
           </p:cNvPr>
@@ -5274,7 +5155,7 @@
           <p:cNvPr id="19" name="">
             <a:extLst xmlns:a="http://schemas.openxmlformats.org/drawingml/2006/main">
               <a:ext uri="{FF2B5EF4-FFF2-40B4-BE49-F238E27FC236}">
-                <a16:creationId xmlns:a16="http://schemas.microsoft.com/office/drawing/2014/main" id="{C71BB703-B3F8-42D3-9070-6D6CCD5D3E83}"/>
+                <a16:creationId xmlns:a16="http://schemas.microsoft.com/office/drawing/2014/main" id="{FE806FD0-9AE0-42B5-AB9B-BA3CA9867CCE}"/>
               </a:ext>
             </a:extLst>
           </p:cNvPr>
@@ -5306,7 +5187,7 @@
           <p:cNvPr id="20" name="">
             <a:extLst xmlns:a="http://schemas.openxmlformats.org/drawingml/2006/main">
               <a:ext uri="{FF2B5EF4-FFF2-40B4-BE49-F238E27FC236}">
-                <a16:creationId xmlns:a16="http://schemas.microsoft.com/office/drawing/2014/main" id="{22D73F84-4B01-4BE5-8854-F9621405F3D2}"/>
+                <a16:creationId xmlns:a16="http://schemas.microsoft.com/office/drawing/2014/main" id="{E4568A97-AD65-459C-88E8-9736E3451974}"/>
               </a:ext>
             </a:extLst>
           </p:cNvPr>
@@ -5338,7 +5219,7 @@
           <p:cNvPr id="21" name="">
             <a:extLst xmlns:a="http://schemas.openxmlformats.org/drawingml/2006/main">
               <a:ext uri="{FF2B5EF4-FFF2-40B4-BE49-F238E27FC236}">
-                <a16:creationId xmlns:a16="http://schemas.microsoft.com/office/drawing/2014/main" id="{FE8BDCF4-1BDC-4FB5-9D2B-1FC26B0E90E6}"/>
+                <a16:creationId xmlns:a16="http://schemas.microsoft.com/office/drawing/2014/main" id="{234A82CF-F4EF-4814-8645-BA109DE93118}"/>
               </a:ext>
             </a:extLst>
           </p:cNvPr>
@@ -5383,7 +5264,7 @@
           <p:cNvPr id="22" name="">
             <a:extLst xmlns:a="http://schemas.openxmlformats.org/drawingml/2006/main">
               <a:ext uri="{FF2B5EF4-FFF2-40B4-BE49-F238E27FC236}">
-                <a16:creationId xmlns:a16="http://schemas.microsoft.com/office/drawing/2014/main" id="{B919BD31-FCED-4FC8-85CA-9CD710E4E1B9}"/>
+                <a16:creationId xmlns:a16="http://schemas.microsoft.com/office/drawing/2014/main" id="{A6DA4740-6DD5-438A-BA78-080B7B2871BF}"/>
               </a:ext>
             </a:extLst>
           </p:cNvPr>
@@ -5413,7 +5294,7 @@
           <p:cNvPr id="23" name="">
             <a:extLst xmlns:a="http://schemas.openxmlformats.org/drawingml/2006/main">
               <a:ext uri="{FF2B5EF4-FFF2-40B4-BE49-F238E27FC236}">
-                <a16:creationId xmlns:a16="http://schemas.microsoft.com/office/drawing/2014/main" id="{0EA1022C-05F1-41DC-9737-CB8FFCBFD135}"/>
+                <a16:creationId xmlns:a16="http://schemas.microsoft.com/office/drawing/2014/main" id="{3CDAE90E-9F00-4CA8-B816-9137592620C1}"/>
               </a:ext>
             </a:extLst>
           </p:cNvPr>
@@ -5443,7 +5324,7 @@
           <p:cNvPr id="24" name="">
             <a:extLst xmlns:a="http://schemas.openxmlformats.org/drawingml/2006/main">
               <a:ext uri="{FF2B5EF4-FFF2-40B4-BE49-F238E27FC236}">
-                <a16:creationId xmlns:a16="http://schemas.microsoft.com/office/drawing/2014/main" id="{6CE8ED73-E5FD-47F8-BBB3-FF8128194A21}"/>
+                <a16:creationId xmlns:a16="http://schemas.microsoft.com/office/drawing/2014/main" id="{73F6C8AD-4EEE-4173-A633-5C709E7504AF}"/>
               </a:ext>
             </a:extLst>
           </p:cNvPr>
@@ -5488,7 +5369,7 @@
           <p:cNvPr id="25" name="">
             <a:extLst xmlns:a="http://schemas.openxmlformats.org/drawingml/2006/main">
               <a:ext uri="{FF2B5EF4-FFF2-40B4-BE49-F238E27FC236}">
-                <a16:creationId xmlns:a16="http://schemas.microsoft.com/office/drawing/2014/main" id="{432615EE-953F-4D41-98FF-81B2F3B59F80}"/>
+                <a16:creationId xmlns:a16="http://schemas.microsoft.com/office/drawing/2014/main" id="{6293FBF7-3991-4348-B208-61597910F068}"/>
               </a:ext>
             </a:extLst>
           </p:cNvPr>
@@ -5533,7 +5414,7 @@
           <p:cNvPr id="26" name="">
             <a:extLst xmlns:a="http://schemas.openxmlformats.org/drawingml/2006/main">
               <a:ext uri="{FF2B5EF4-FFF2-40B4-BE49-F238E27FC236}">
-                <a16:creationId xmlns:a16="http://schemas.microsoft.com/office/drawing/2014/main" id="{E7090F4F-6A13-401E-88AA-5D2D26BDE2C6}"/>
+                <a16:creationId xmlns:a16="http://schemas.microsoft.com/office/drawing/2014/main" id="{008CD56A-B1CA-4448-A649-5CAF8ECD9CF5}"/>
               </a:ext>
             </a:extLst>
           </p:cNvPr>
@@ -5578,7 +5459,7 @@
           <p:cNvPr id="27" name="">
             <a:extLst xmlns:a="http://schemas.openxmlformats.org/drawingml/2006/main">
               <a:ext uri="{FF2B5EF4-FFF2-40B4-BE49-F238E27FC236}">
-                <a16:creationId xmlns:a16="http://schemas.microsoft.com/office/drawing/2014/main" id="{DC95FF47-4A38-452E-949E-41BCD2D49EC3}"/>
+                <a16:creationId xmlns:a16="http://schemas.microsoft.com/office/drawing/2014/main" id="{A15931AA-CA09-4172-9590-BC2732046666}"/>
               </a:ext>
             </a:extLst>
           </p:cNvPr>
@@ -5623,7 +5504,7 @@
           <p:cNvPr id="28" name="">
             <a:extLst xmlns:a="http://schemas.openxmlformats.org/drawingml/2006/main">
               <a:ext uri="{FF2B5EF4-FFF2-40B4-BE49-F238E27FC236}">
-                <a16:creationId xmlns:a16="http://schemas.microsoft.com/office/drawing/2014/main" id="{E1E987A0-055A-4AF1-B6FC-89F53AF18379}"/>
+                <a16:creationId xmlns:a16="http://schemas.microsoft.com/office/drawing/2014/main" id="{BBC1D921-351D-4333-823D-70CF2BB502CA}"/>
               </a:ext>
             </a:extLst>
           </p:cNvPr>
@@ -5666,7 +5547,7 @@
     </p:spTree>
     <p:extLst>
       <p:ext uri="{BB962C8B-B14F-4D97-AF65-F5344CB8AC3E}">
-        <p14:creationId xmlns:p14="http://schemas.microsoft.com/office/powerpoint/2010/main" val="1772143501"/>
+        <p14:creationId xmlns:p14="http://schemas.microsoft.com/office/powerpoint/2010/main" val="1281607458"/>
       </p:ext>
     </p:extLst>
   </p:cSld>
@@ -5697,7 +5578,7 @@
           <p:cNvPr id="15" name="">
             <a:extLst xmlns:a="http://schemas.openxmlformats.org/drawingml/2006/main">
               <a:ext uri="{FF2B5EF4-FFF2-40B4-BE49-F238E27FC236}">
-                <a16:creationId xmlns:a16="http://schemas.microsoft.com/office/drawing/2014/main" id="{48314488-95F5-4A89-8254-28504070AEC4}"/>
+                <a16:creationId xmlns:a16="http://schemas.microsoft.com/office/drawing/2014/main" id="{A4C5F1E0-D8E0-437D-A671-9EE943966AED}"/>
               </a:ext>
             </a:extLst>
           </p:cNvPr>
@@ -5742,7 +5623,7 @@
           <p:cNvPr id="2" name="">
             <a:extLst xmlns:a="http://schemas.openxmlformats.org/drawingml/2006/main">
               <a:ext uri="{FF2B5EF4-FFF2-40B4-BE49-F238E27FC236}">
-                <a16:creationId xmlns:a16="http://schemas.microsoft.com/office/drawing/2014/main" id="{E37F8AF4-6809-4482-ABDE-A956CF01A1F2}"/>
+                <a16:creationId xmlns:a16="http://schemas.microsoft.com/office/drawing/2014/main" id="{0F639B5C-66C3-44DD-B4A8-88CF55414449}"/>
               </a:ext>
             </a:extLst>
           </p:cNvPr>
@@ -5772,7 +5653,7 @@
           <p:cNvPr id="3" name="">
             <a:extLst xmlns:a="http://schemas.openxmlformats.org/drawingml/2006/main">
               <a:ext uri="{FF2B5EF4-FFF2-40B4-BE49-F238E27FC236}">
-                <a16:creationId xmlns:a16="http://schemas.microsoft.com/office/drawing/2014/main" id="{949D0F0D-9A1F-4622-843D-15752C163B25}"/>
+                <a16:creationId xmlns:a16="http://schemas.microsoft.com/office/drawing/2014/main" id="{1FE47D76-4B61-4E68-82AC-A0DB1580B2CF}"/>
               </a:ext>
             </a:extLst>
           </p:cNvPr>
@@ -5817,7 +5698,7 @@
           <p:cNvPr id="4" name="">
             <a:extLst xmlns:a="http://schemas.openxmlformats.org/drawingml/2006/main">
               <a:ext uri="{FF2B5EF4-FFF2-40B4-BE49-F238E27FC236}">
-                <a16:creationId xmlns:a16="http://schemas.microsoft.com/office/drawing/2014/main" id="{54F45F1E-AF93-434A-A128-03E7F0FE12AA}"/>
+                <a16:creationId xmlns:a16="http://schemas.microsoft.com/office/drawing/2014/main" id="{E49CCAB6-E288-47B9-AA09-6CCB2ACCE90A}"/>
               </a:ext>
             </a:extLst>
           </p:cNvPr>
@@ -5862,7 +5743,7 @@
           <p:cNvPr id="5" name="">
             <a:extLst xmlns:a="http://schemas.openxmlformats.org/drawingml/2006/main">
               <a:ext uri="{FF2B5EF4-FFF2-40B4-BE49-F238E27FC236}">
-                <a16:creationId xmlns:a16="http://schemas.microsoft.com/office/drawing/2014/main" id="{67369606-E028-46D9-8868-903DFD15430F}"/>
+                <a16:creationId xmlns:a16="http://schemas.microsoft.com/office/drawing/2014/main" id="{EB94666F-9FA1-437D-9032-63AE83984039}"/>
               </a:ext>
             </a:extLst>
           </p:cNvPr>
@@ -5894,7 +5775,7 @@
           <p:cNvPr id="6" name="">
             <a:extLst xmlns:a="http://schemas.openxmlformats.org/drawingml/2006/main">
               <a:ext uri="{FF2B5EF4-FFF2-40B4-BE49-F238E27FC236}">
-                <a16:creationId xmlns:a16="http://schemas.microsoft.com/office/drawing/2014/main" id="{945721C7-F459-4F06-AEF1-4DB2416DB582}"/>
+                <a16:creationId xmlns:a16="http://schemas.microsoft.com/office/drawing/2014/main" id="{698DF346-5E83-4826-8FE4-B2CB7A52EAF1}"/>
               </a:ext>
             </a:extLst>
           </p:cNvPr>
@@ -5926,7 +5807,7 @@
           <p:cNvPr id="7" name="">
             <a:extLst xmlns:a="http://schemas.openxmlformats.org/drawingml/2006/main">
               <a:ext uri="{FF2B5EF4-FFF2-40B4-BE49-F238E27FC236}">
-                <a16:creationId xmlns:a16="http://schemas.microsoft.com/office/drawing/2014/main" id="{1BCF0B65-24E1-40D5-8BE1-26397FC0DD3C}"/>
+                <a16:creationId xmlns:a16="http://schemas.microsoft.com/office/drawing/2014/main" id="{EBF3D435-193A-46AF-A6DF-EF36D7DA6D22}"/>
               </a:ext>
             </a:extLst>
           </p:cNvPr>
@@ -5958,7 +5839,7 @@
           <p:cNvPr id="8" name="">
             <a:extLst xmlns:a="http://schemas.openxmlformats.org/drawingml/2006/main">
               <a:ext uri="{FF2B5EF4-FFF2-40B4-BE49-F238E27FC236}">
-                <a16:creationId xmlns:a16="http://schemas.microsoft.com/office/drawing/2014/main" id="{DF164F27-6195-4D55-925C-B8C3774314BD}"/>
+                <a16:creationId xmlns:a16="http://schemas.microsoft.com/office/drawing/2014/main" id="{DA81EFA4-E2F4-4914-AA4F-ACAC0D4CAB8F}"/>
               </a:ext>
             </a:extLst>
           </p:cNvPr>
@@ -6003,7 +5884,7 @@
           <p:cNvPr id="9" name="">
             <a:extLst xmlns:a="http://schemas.openxmlformats.org/drawingml/2006/main">
               <a:ext uri="{FF2B5EF4-FFF2-40B4-BE49-F238E27FC236}">
-                <a16:creationId xmlns:a16="http://schemas.microsoft.com/office/drawing/2014/main" id="{5904871F-AFF8-4475-8D9D-73415AD2C852}"/>
+                <a16:creationId xmlns:a16="http://schemas.microsoft.com/office/drawing/2014/main" id="{E65B4E72-6CC4-4DFE-9C63-D6B76395A12F}"/>
               </a:ext>
             </a:extLst>
           </p:cNvPr>
@@ -6048,7 +5929,7 @@
           <p:cNvPr id="10" name="">
             <a:extLst xmlns:a="http://schemas.openxmlformats.org/drawingml/2006/main">
               <a:ext uri="{FF2B5EF4-FFF2-40B4-BE49-F238E27FC236}">
-                <a16:creationId xmlns:a16="http://schemas.microsoft.com/office/drawing/2014/main" id="{9E9FF4C9-3B3D-4243-AE2B-A77DE38A4ADB}"/>
+                <a16:creationId xmlns:a16="http://schemas.microsoft.com/office/drawing/2014/main" id="{406E9A6E-5726-474A-BC0D-28CDD7529F28}"/>
               </a:ext>
             </a:extLst>
           </p:cNvPr>
@@ -6080,7 +5961,7 @@
           <p:cNvPr id="11" name="">
             <a:extLst xmlns:a="http://schemas.openxmlformats.org/drawingml/2006/main">
               <a:ext uri="{FF2B5EF4-FFF2-40B4-BE49-F238E27FC236}">
-                <a16:creationId xmlns:a16="http://schemas.microsoft.com/office/drawing/2014/main" id="{CE88174E-7E5A-4433-AAB6-44E2B2869984}"/>
+                <a16:creationId xmlns:a16="http://schemas.microsoft.com/office/drawing/2014/main" id="{DDD9CF34-D6DD-46F4-A8ED-54FB513A4AAE}"/>
               </a:ext>
             </a:extLst>
           </p:cNvPr>
@@ -6112,7 +5993,7 @@
           <p:cNvPr id="12" name="">
             <a:extLst xmlns:a="http://schemas.openxmlformats.org/drawingml/2006/main">
               <a:ext uri="{FF2B5EF4-FFF2-40B4-BE49-F238E27FC236}">
-                <a16:creationId xmlns:a16="http://schemas.microsoft.com/office/drawing/2014/main" id="{1217363F-B071-4FF4-8C04-72A3F84CAFFB}"/>
+                <a16:creationId xmlns:a16="http://schemas.microsoft.com/office/drawing/2014/main" id="{33DD13F8-305F-415D-B184-2CC909298569}"/>
               </a:ext>
             </a:extLst>
           </p:cNvPr>
@@ -6144,7 +6025,7 @@
           <p:cNvPr id="13" name="">
             <a:extLst xmlns:a="http://schemas.openxmlformats.org/drawingml/2006/main">
               <a:ext uri="{FF2B5EF4-FFF2-40B4-BE49-F238E27FC236}">
-                <a16:creationId xmlns:a16="http://schemas.microsoft.com/office/drawing/2014/main" id="{FE88A4C2-F210-4103-84F5-FA660E99F2B8}"/>
+                <a16:creationId xmlns:a16="http://schemas.microsoft.com/office/drawing/2014/main" id="{BC87A948-516E-42C7-9A96-9F98249AC24D}"/>
               </a:ext>
             </a:extLst>
           </p:cNvPr>
@@ -6189,7 +6070,7 @@
           <p:cNvPr id="14" name="">
             <a:extLst xmlns:a="http://schemas.openxmlformats.org/drawingml/2006/main">
               <a:ext uri="{FF2B5EF4-FFF2-40B4-BE49-F238E27FC236}">
-                <a16:creationId xmlns:a16="http://schemas.microsoft.com/office/drawing/2014/main" id="{3ADAFE3C-26D3-4C3D-A814-C8120791612E}"/>
+                <a16:creationId xmlns:a16="http://schemas.microsoft.com/office/drawing/2014/main" id="{F5334C83-4985-40E6-80BA-DF9E109029FF}"/>
               </a:ext>
             </a:extLst>
           </p:cNvPr>
@@ -6232,7 +6113,7 @@
     </p:spTree>
     <p:extLst>
       <p:ext uri="{BB962C8B-B14F-4D97-AF65-F5344CB8AC3E}">
-        <p14:creationId xmlns:p14="http://schemas.microsoft.com/office/powerpoint/2010/main" val="88162140"/>
+        <p14:creationId xmlns:p14="http://schemas.microsoft.com/office/powerpoint/2010/main" val="1958041682"/>
       </p:ext>
     </p:extLst>
   </p:cSld>
@@ -6263,7 +6144,7 @@
           <p:cNvPr id="20" name="">
             <a:extLst xmlns:a="http://schemas.openxmlformats.org/drawingml/2006/main">
               <a:ext uri="{FF2B5EF4-FFF2-40B4-BE49-F238E27FC236}">
-                <a16:creationId xmlns:a16="http://schemas.microsoft.com/office/drawing/2014/main" id="{577A2CD6-9CCA-4F70-8E75-A69F20B3ADE0}"/>
+                <a16:creationId xmlns:a16="http://schemas.microsoft.com/office/drawing/2014/main" id="{CA3FB4C3-94F3-4805-9FD3-8A379BE1057C}"/>
               </a:ext>
             </a:extLst>
           </p:cNvPr>
@@ -6308,7 +6189,7 @@
           <p:cNvPr id="2" name="">
             <a:extLst xmlns:a="http://schemas.openxmlformats.org/drawingml/2006/main">
               <a:ext uri="{FF2B5EF4-FFF2-40B4-BE49-F238E27FC236}">
-                <a16:creationId xmlns:a16="http://schemas.microsoft.com/office/drawing/2014/main" id="{DCF012B0-4761-40C7-9003-6393ECED7B99}"/>
+                <a16:creationId xmlns:a16="http://schemas.microsoft.com/office/drawing/2014/main" id="{0C537509-915D-4A62-9543-8C955297DAF0}"/>
               </a:ext>
             </a:extLst>
           </p:cNvPr>
@@ -6338,7 +6219,7 @@
           <p:cNvPr id="3" name="">
             <a:extLst xmlns:a="http://schemas.openxmlformats.org/drawingml/2006/main">
               <a:ext uri="{FF2B5EF4-FFF2-40B4-BE49-F238E27FC236}">
-                <a16:creationId xmlns:a16="http://schemas.microsoft.com/office/drawing/2014/main" id="{A7A9EA71-E746-477E-B3CA-BBB6CB62D408}"/>
+                <a16:creationId xmlns:a16="http://schemas.microsoft.com/office/drawing/2014/main" id="{DC0E841B-DE4E-481C-9207-9E3FB2CD60BE}"/>
               </a:ext>
             </a:extLst>
           </p:cNvPr>
@@ -6383,7 +6264,7 @@
           <p:cNvPr id="4" name="">
             <a:extLst xmlns:a="http://schemas.openxmlformats.org/drawingml/2006/main">
               <a:ext uri="{FF2B5EF4-FFF2-40B4-BE49-F238E27FC236}">
-                <a16:creationId xmlns:a16="http://schemas.microsoft.com/office/drawing/2014/main" id="{7FAE07CA-C534-4BF5-BAC7-AF0C4C69778B}"/>
+                <a16:creationId xmlns:a16="http://schemas.microsoft.com/office/drawing/2014/main" id="{35439057-5086-417F-BCE9-D9AEC3EFC52F}"/>
               </a:ext>
             </a:extLst>
           </p:cNvPr>
@@ -6428,7 +6309,7 @@
           <p:cNvPr id="5" name="">
             <a:extLst xmlns:a="http://schemas.openxmlformats.org/drawingml/2006/main">
               <a:ext uri="{FF2B5EF4-FFF2-40B4-BE49-F238E27FC236}">
-                <a16:creationId xmlns:a16="http://schemas.microsoft.com/office/drawing/2014/main" id="{A810392A-9967-4924-9C27-39603114A1A5}"/>
+                <a16:creationId xmlns:a16="http://schemas.microsoft.com/office/drawing/2014/main" id="{D47A1FDA-05A8-49F9-B9ED-815D7BBB2A81}"/>
               </a:ext>
             </a:extLst>
           </p:cNvPr>
@@ -6460,7 +6341,7 @@
           <p:cNvPr id="6" name="">
             <a:extLst xmlns:a="http://schemas.openxmlformats.org/drawingml/2006/main">
               <a:ext uri="{FF2B5EF4-FFF2-40B4-BE49-F238E27FC236}">
-                <a16:creationId xmlns:a16="http://schemas.microsoft.com/office/drawing/2014/main" id="{505D8F2E-01E1-4DF6-871A-1378E7BF0A1B}"/>
+                <a16:creationId xmlns:a16="http://schemas.microsoft.com/office/drawing/2014/main" id="{5B4534B5-8557-48B8-B988-8A037B55A08A}"/>
               </a:ext>
             </a:extLst>
           </p:cNvPr>
@@ -6531,7 +6412,7 @@
           <p:cNvPr id="7" name="">
             <a:extLst xmlns:a="http://schemas.openxmlformats.org/drawingml/2006/main">
               <a:ext uri="{FF2B5EF4-FFF2-40B4-BE49-F238E27FC236}">
-                <a16:creationId xmlns:a16="http://schemas.microsoft.com/office/drawing/2014/main" id="{B2291553-3643-4492-9D76-6F42600A5AA8}"/>
+                <a16:creationId xmlns:a16="http://schemas.microsoft.com/office/drawing/2014/main" id="{9D141711-495B-48F2-A819-311F44AAF653}"/>
               </a:ext>
             </a:extLst>
           </p:cNvPr>
@@ -6576,7 +6457,7 @@
           <p:cNvPr id="8" name="">
             <a:extLst xmlns:a="http://schemas.openxmlformats.org/drawingml/2006/main">
               <a:ext uri="{FF2B5EF4-FFF2-40B4-BE49-F238E27FC236}">
-                <a16:creationId xmlns:a16="http://schemas.microsoft.com/office/drawing/2014/main" id="{6538C425-72B7-4683-A882-7EB441F302E7}"/>
+                <a16:creationId xmlns:a16="http://schemas.microsoft.com/office/drawing/2014/main" id="{77A7B5D5-95BB-42A3-BCF4-99AFCCCDEBE4}"/>
               </a:ext>
             </a:extLst>
           </p:cNvPr>
@@ -6608,7 +6489,7 @@
           <p:cNvPr id="9" name="">
             <a:extLst xmlns:a="http://schemas.openxmlformats.org/drawingml/2006/main">
               <a:ext uri="{FF2B5EF4-FFF2-40B4-BE49-F238E27FC236}">
-                <a16:creationId xmlns:a16="http://schemas.microsoft.com/office/drawing/2014/main" id="{21158988-E577-41D8-88E1-6CE53B01029A}"/>
+                <a16:creationId xmlns:a16="http://schemas.microsoft.com/office/drawing/2014/main" id="{CDD86271-CDCF-45B0-9550-9C19D6868678}"/>
               </a:ext>
             </a:extLst>
           </p:cNvPr>
@@ -6640,7 +6521,7 @@
           <p:cNvPr id="10" name="">
             <a:extLst xmlns:a="http://schemas.openxmlformats.org/drawingml/2006/main">
               <a:ext uri="{FF2B5EF4-FFF2-40B4-BE49-F238E27FC236}">
-                <a16:creationId xmlns:a16="http://schemas.microsoft.com/office/drawing/2014/main" id="{E539C618-3801-411B-A00B-36C5D4D02533}"/>
+                <a16:creationId xmlns:a16="http://schemas.microsoft.com/office/drawing/2014/main" id="{E89C1785-4BF8-4FF2-AF40-F0A53DD42F70}"/>
               </a:ext>
             </a:extLst>
           </p:cNvPr>
@@ -6685,7 +6566,7 @@
           <p:cNvPr id="11" name="">
             <a:extLst xmlns:a="http://schemas.openxmlformats.org/drawingml/2006/main">
               <a:ext uri="{FF2B5EF4-FFF2-40B4-BE49-F238E27FC236}">
-                <a16:creationId xmlns:a16="http://schemas.microsoft.com/office/drawing/2014/main" id="{A1C9F0C8-A8F1-4A01-B9D9-61A316C825AA}"/>
+                <a16:creationId xmlns:a16="http://schemas.microsoft.com/office/drawing/2014/main" id="{F632E18F-8B3D-4D4C-B2BD-8D9672EA8530}"/>
               </a:ext>
             </a:extLst>
           </p:cNvPr>
@@ -6730,7 +6611,7 @@
           <p:cNvPr id="12" name="">
             <a:extLst xmlns:a="http://schemas.openxmlformats.org/drawingml/2006/main">
               <a:ext uri="{FF2B5EF4-FFF2-40B4-BE49-F238E27FC236}">
-                <a16:creationId xmlns:a16="http://schemas.microsoft.com/office/drawing/2014/main" id="{729384C7-536F-4347-BB1E-B3FFBBE295DE}"/>
+                <a16:creationId xmlns:a16="http://schemas.microsoft.com/office/drawing/2014/main" id="{A4CE812E-93DE-4038-93EF-1F5210FCE669}"/>
               </a:ext>
             </a:extLst>
           </p:cNvPr>
@@ -6775,7 +6656,7 @@
           <p:cNvPr id="13" name="">
             <a:extLst xmlns:a="http://schemas.openxmlformats.org/drawingml/2006/main">
               <a:ext uri="{FF2B5EF4-FFF2-40B4-BE49-F238E27FC236}">
-                <a16:creationId xmlns:a16="http://schemas.microsoft.com/office/drawing/2014/main" id="{41C87B5D-40AB-4CAB-9EDA-14C71ADE667C}"/>
+                <a16:creationId xmlns:a16="http://schemas.microsoft.com/office/drawing/2014/main" id="{F527E3FF-01E8-4A74-A1CD-41E283936DA6}"/>
               </a:ext>
             </a:extLst>
           </p:cNvPr>
@@ -6807,7 +6688,7 @@
           <p:cNvPr id="14" name="">
             <a:extLst xmlns:a="http://schemas.openxmlformats.org/drawingml/2006/main">
               <a:ext uri="{FF2B5EF4-FFF2-40B4-BE49-F238E27FC236}">
-                <a16:creationId xmlns:a16="http://schemas.microsoft.com/office/drawing/2014/main" id="{45AEE0A7-30F0-4D6A-86AB-81EE30300A3C}"/>
+                <a16:creationId xmlns:a16="http://schemas.microsoft.com/office/drawing/2014/main" id="{DBAC5BC3-ACF1-4E76-9C2F-456C06238439}"/>
               </a:ext>
             </a:extLst>
           </p:cNvPr>
@@ -6839,7 +6720,7 @@
           <p:cNvPr id="15" name="">
             <a:extLst xmlns:a="http://schemas.openxmlformats.org/drawingml/2006/main">
               <a:ext uri="{FF2B5EF4-FFF2-40B4-BE49-F238E27FC236}">
-                <a16:creationId xmlns:a16="http://schemas.microsoft.com/office/drawing/2014/main" id="{5CBD4861-3C39-4768-A4ED-2C311C9A41B0}"/>
+                <a16:creationId xmlns:a16="http://schemas.microsoft.com/office/drawing/2014/main" id="{F2F44C92-9528-403B-ACBE-FE929C791E1C}"/>
               </a:ext>
             </a:extLst>
           </p:cNvPr>
@@ -6871,7 +6752,7 @@
           <p:cNvPr id="16" name="">
             <a:extLst xmlns:a="http://schemas.openxmlformats.org/drawingml/2006/main">
               <a:ext uri="{FF2B5EF4-FFF2-40B4-BE49-F238E27FC236}">
-                <a16:creationId xmlns:a16="http://schemas.microsoft.com/office/drawing/2014/main" id="{F65ED315-533A-4FA1-9300-498275C3D24F}"/>
+                <a16:creationId xmlns:a16="http://schemas.microsoft.com/office/drawing/2014/main" id="{3E746905-0823-4CE1-B66D-BC1DDEE055AA}"/>
               </a:ext>
             </a:extLst>
           </p:cNvPr>
@@ -6916,7 +6797,7 @@
           <p:cNvPr id="17" name="">
             <a:extLst xmlns:a="http://schemas.openxmlformats.org/drawingml/2006/main">
               <a:ext uri="{FF2B5EF4-FFF2-40B4-BE49-F238E27FC236}">
-                <a16:creationId xmlns:a16="http://schemas.microsoft.com/office/drawing/2014/main" id="{F5722ABB-22DB-475C-9A0E-D7D974BF44B3}"/>
+                <a16:creationId xmlns:a16="http://schemas.microsoft.com/office/drawing/2014/main" id="{AA2EF3BB-3495-4307-9132-388F4EE42549}"/>
               </a:ext>
             </a:extLst>
           </p:cNvPr>
@@ -6961,7 +6842,7 @@
           <p:cNvPr id="18" name="">
             <a:extLst xmlns:a="http://schemas.openxmlformats.org/drawingml/2006/main">
               <a:ext uri="{FF2B5EF4-FFF2-40B4-BE49-F238E27FC236}">
-                <a16:creationId xmlns:a16="http://schemas.microsoft.com/office/drawing/2014/main" id="{8FB91103-69AB-4F45-9E54-4A217FECF29C}"/>
+                <a16:creationId xmlns:a16="http://schemas.microsoft.com/office/drawing/2014/main" id="{682673DE-9A5E-45CD-8656-A967C9E14CE2}"/>
               </a:ext>
             </a:extLst>
           </p:cNvPr>
@@ -7006,7 +6887,7 @@
           <p:cNvPr id="19" name="">
             <a:extLst xmlns:a="http://schemas.openxmlformats.org/drawingml/2006/main">
               <a:ext uri="{FF2B5EF4-FFF2-40B4-BE49-F238E27FC236}">
-                <a16:creationId xmlns:a16="http://schemas.microsoft.com/office/drawing/2014/main" id="{C4D6A980-3477-40B1-AB54-4CDC71A5B911}"/>
+                <a16:creationId xmlns:a16="http://schemas.microsoft.com/office/drawing/2014/main" id="{46671EF0-8B2F-48D9-81DE-34308E15C558}"/>
               </a:ext>
             </a:extLst>
           </p:cNvPr>
@@ -7049,7 +6930,7 @@
     </p:spTree>
     <p:extLst>
       <p:ext uri="{BB962C8B-B14F-4D97-AF65-F5344CB8AC3E}">
-        <p14:creationId xmlns:p14="http://schemas.microsoft.com/office/powerpoint/2010/main" val="979343789"/>
+        <p14:creationId xmlns:p14="http://schemas.microsoft.com/office/powerpoint/2010/main" val="6378097"/>
       </p:ext>
     </p:extLst>
   </p:cSld>
@@ -7077,10 +6958,10 @@
       </p:grpSpPr>
       <p:sp>
         <p:nvSpPr>
-          <p:cNvPr id="9" name="">
-            <a:extLst xmlns:a="http://schemas.openxmlformats.org/drawingml/2006/main">
-              <a:ext uri="{FF2B5EF4-FFF2-40B4-BE49-F238E27FC236}">
-                <a16:creationId xmlns:a16="http://schemas.microsoft.com/office/drawing/2014/main" id="{B713F3BE-EB0F-46A2-A664-7ED9CE922A51}"/>
+          <p:cNvPr id="8" name="">
+            <a:extLst xmlns:a="http://schemas.openxmlformats.org/drawingml/2006/main">
+              <a:ext uri="{FF2B5EF4-FFF2-40B4-BE49-F238E27FC236}">
+                <a16:creationId xmlns:a16="http://schemas.microsoft.com/office/drawing/2014/main" id="{E1FB3CA8-73DD-4B0E-B51A-CFC573B4CEDE}"/>
               </a:ext>
             </a:extLst>
           </p:cNvPr>
@@ -7115,7 +6996,7 @@
                 <a:ea typeface="Arial"/>
                 <a:cs typeface="Arial"/>
               </a:rPr>
-              <a:t>Coverage and measurement scope</a:t>
+              <a:t>Timing and quality use separate measurement sets</a:t>
             </a:r>
           </a:p>
         </p:txBody>
@@ -7125,7 +7006,7 @@
           <p:cNvPr id="2" name="">
             <a:extLst xmlns:a="http://schemas.openxmlformats.org/drawingml/2006/main">
               <a:ext uri="{FF2B5EF4-FFF2-40B4-BE49-F238E27FC236}">
-                <a16:creationId xmlns:a16="http://schemas.microsoft.com/office/drawing/2014/main" id="{82BC5469-4B7F-49F3-ACF0-F830AF617BD2}"/>
+                <a16:creationId xmlns:a16="http://schemas.microsoft.com/office/drawing/2014/main" id="{5FF17C6B-992B-4B4C-92CA-5469B604381C}"/>
               </a:ext>
             </a:extLst>
           </p:cNvPr>
@@ -7155,7 +7036,7 @@
           <p:cNvPr id="3" name="">
             <a:extLst xmlns:a="http://schemas.openxmlformats.org/drawingml/2006/main">
               <a:ext uri="{FF2B5EF4-FFF2-40B4-BE49-F238E27FC236}">
-                <a16:creationId xmlns:a16="http://schemas.microsoft.com/office/drawing/2014/main" id="{DE552A5F-1849-4ED4-85F8-479C43DBFA0D}"/>
+                <a16:creationId xmlns:a16="http://schemas.microsoft.com/office/drawing/2014/main" id="{87967DD5-575A-4DB3-B40F-7AA7A2BB1FD7}"/>
               </a:ext>
             </a:extLst>
           </p:cNvPr>
@@ -7200,7 +7081,7 @@
           <p:cNvPr id="4" name="">
             <a:extLst xmlns:a="http://schemas.openxmlformats.org/drawingml/2006/main">
               <a:ext uri="{FF2B5EF4-FFF2-40B4-BE49-F238E27FC236}">
-                <a16:creationId xmlns:a16="http://schemas.microsoft.com/office/drawing/2014/main" id="{FEE9F5E2-F819-4E51-9CC7-AD56E59F1B06}"/>
+                <a16:creationId xmlns:a16="http://schemas.microsoft.com/office/drawing/2014/main" id="{A19D57B2-B38A-4AA0-83FA-A4BB8BD828B9}"/>
               </a:ext>
             </a:extLst>
           </p:cNvPr>
@@ -7208,26 +7089,26 @@
           <p:nvPr/>
         </p:nvGraphicFramePr>
         <p:xfrm>
-          <a:off xmlns:a="http://schemas.openxmlformats.org/drawingml/2006/main" x="609600" y="1590675"/>
-          <a:ext xmlns:a="http://schemas.openxmlformats.org/drawingml/2006/main" cx="6286500" cy="3143250"/>
+          <a:off xmlns:a="http://schemas.openxmlformats.org/drawingml/2006/main" x="609600" y="1638300"/>
+          <a:ext xmlns:a="http://schemas.openxmlformats.org/drawingml/2006/main" cx="10972800" cy="3314700"/>
         </p:xfrm>
         <a:graphic xmlns:a="http://schemas.openxmlformats.org/drawingml/2006/main">
           <a:graphicData uri="http://schemas.openxmlformats.org/drawingml/2006/table">
             <a:tbl>
               <a:tblPr/>
               <a:tblGrid>
-                <a:gridCol w="2286000"/>
-                <a:gridCol w="1333500"/>
-                <a:gridCol w="2667000"/>
+                <a:gridCol w="2476500"/>
+                <a:gridCol w="4248150"/>
+                <a:gridCol w="4248150"/>
               </a:tblGrid>
-              <a:tr h="628650">
+              <a:tr h="552450">
                 <a:tc>
                   <a:txBody>
                     <a:bodyPr/>
                     <a:lstStyle/>
                     <a:p>
                       <a:r>
-                        <a:rPr sz="1800" b="1">
+                        <a:rPr sz="1875" b="1">
                           <a:solidFill>
                             <a:srgbClr val="FFFFFF"/>
                           </a:solidFill>
@@ -7235,7 +7116,7 @@
                           <a:ea typeface="Arial"/>
                           <a:cs typeface="Arial"/>
                         </a:rPr>
-                        <a:t>Forward sequence</a:t>
+                        <a:t/>
                       </a:r>
                     </a:p>
                   </a:txBody>
@@ -7275,7 +7156,7 @@
                     <a:lstStyle/>
                     <a:p>
                       <a:r>
-                        <a:rPr sz="1800" b="1">
+                        <a:rPr sz="1875" b="1">
                           <a:solidFill>
                             <a:srgbClr val="FFFFFF"/>
                           </a:solidFill>
@@ -7283,7 +7164,7 @@
                           <a:ea typeface="Arial"/>
                           <a:cs typeface="Arial"/>
                         </a:rPr>
-                        <a:t>Frames</a:t>
+                        <a:t>Latest timing</a:t>
                       </a:r>
                     </a:p>
                   </a:txBody>
@@ -7317,7 +7198,7 @@
                     <a:lstStyle/>
                     <a:p>
                       <a:r>
-                        <a:rPr sz="1800" b="1">
+                        <a:rPr sz="1875" b="1">
                           <a:solidFill>
                             <a:srgbClr val="FFFFFF"/>
                           </a:solidFill>
@@ -7325,7 +7206,7 @@
                           <a:ea typeface="Arial"/>
                           <a:cs typeface="Arial"/>
                         </a:rPr>
-                        <a:t>Right-eye frame IDs</a:t>
+                        <a:t>Existing quality</a:t>
                       </a:r>
                     </a:p>
                   </a:txBody>
@@ -7354,14 +7235,14 @@
                   </a:tcPr>
                 </a:tc>
               </a:tr>
-              <a:tr h="628650">
+              <a:tr h="552450">
                 <a:tc>
                   <a:txBody>
                     <a:bodyPr/>
                     <a:lstStyle/>
                     <a:p>
                       <a:r>
-                        <a:rPr sz="1800" b="0">
+                        <a:rPr sz="1875" b="0">
                           <a:solidFill>
                             <a:srgbClr val="152D43"/>
                           </a:solidFill>
@@ -7369,7 +7250,7 @@
                           <a:ea typeface="Arial"/>
                           <a:cs typeface="Arial"/>
                         </a:rPr>
-                        <a:t>15 mm / 300</a:t>
+                        <a:t>Implementation</a:t>
                       </a:r>
                     </a:p>
                   </a:txBody>
@@ -7403,7 +7284,7 @@
                     <a:lstStyle/>
                     <a:p>
                       <a:r>
-                        <a:rPr sz="1800" b="0">
+                        <a:rPr sz="1875" b="0">
                           <a:solidFill>
                             <a:srgbClr val="152D43"/>
                           </a:solidFill>
@@ -7411,7 +7292,7 @@
                           <a:ea typeface="Arial"/>
                           <a:cs typeface="Arial"/>
                         </a:rPr>
-                        <a:t>147</a:t>
+                        <a:t>CUDA C++</a:t>
                       </a:r>
                     </a:p>
                   </a:txBody>
@@ -7439,7 +7320,7 @@
                     <a:lstStyle/>
                     <a:p>
                       <a:r>
-                        <a:rPr sz="1800" b="0">
+                        <a:rPr sz="1875" b="0">
                           <a:solidFill>
                             <a:srgbClr val="152D43"/>
                           </a:solidFill>
@@ -7447,7 +7328,7 @@
                           <a:ea typeface="Arial"/>
                           <a:cs typeface="Arial"/>
                         </a:rPr>
-                        <a:t>Odd frames 7–299</a:t>
+                        <a:t>CUDA C++</a:t>
                       </a:r>
                     </a:p>
                   </a:txBody>
@@ -7470,14 +7351,14 @@
                   </a:tcPr>
                 </a:tc>
               </a:tr>
-              <a:tr h="628650">
+              <a:tr h="552450">
                 <a:tc>
                   <a:txBody>
                     <a:bodyPr/>
                     <a:lstStyle/>
                     <a:p>
                       <a:r>
-                        <a:rPr sz="1800" b="0">
+                        <a:rPr sz="1875" b="0">
                           <a:solidFill>
                             <a:srgbClr val="152D43"/>
                           </a:solidFill>
@@ -7485,7 +7366,7 @@
                           <a:ea typeface="Arial"/>
                           <a:cs typeface="Arial"/>
                         </a:rPr>
-                        <a:t>15 mm / 800</a:t>
+                        <a:t>Xavier power mode</a:t>
                       </a:r>
                     </a:p>
                   </a:txBody>
@@ -7519,7 +7400,7 @@
                     <a:lstStyle/>
                     <a:p>
                       <a:r>
-                        <a:rPr sz="1800" b="0">
+                        <a:rPr sz="1875" b="0">
                           <a:solidFill>
                             <a:srgbClr val="152D43"/>
                           </a:solidFill>
@@ -7527,7 +7408,7 @@
                           <a:ea typeface="Arial"/>
                           <a:cs typeface="Arial"/>
                         </a:rPr>
-                        <a:t>387</a:t>
+                        <a:t>30W 4CORE, unlocked</a:t>
                       </a:r>
                     </a:p>
                   </a:txBody>
@@ -7555,7 +7436,7 @@
                     <a:lstStyle/>
                     <a:p>
                       <a:r>
-                        <a:rPr sz="1800" b="0">
+                        <a:rPr sz="1875" b="0">
                           <a:solidFill>
                             <a:srgbClr val="152D43"/>
                           </a:solidFill>
@@ -7563,7 +7444,7 @@
                           <a:ea typeface="Arial"/>
                           <a:cs typeface="Arial"/>
                         </a:rPr>
-                        <a:t>Odd frames 7–779</a:t>
+                        <a:t>15W Desktop, unlocked</a:t>
                       </a:r>
                     </a:p>
                   </a:txBody>
@@ -7586,14 +7467,14 @@
                   </a:tcPr>
                 </a:tc>
               </a:tr>
-              <a:tr h="628650">
+              <a:tr h="552450">
                 <a:tc>
                   <a:txBody>
                     <a:bodyPr/>
                     <a:lstStyle/>
                     <a:p>
                       <a:r>
-                        <a:rPr sz="1800" b="0">
+                        <a:rPr sz="1875" b="0">
                           <a:solidFill>
                             <a:srgbClr val="152D43"/>
                           </a:solidFill>
@@ -7601,7 +7482,7 @@
                           <a:ea typeface="Arial"/>
                           <a:cs typeface="Arial"/>
                         </a:rPr>
-                        <a:t>35 mm / 300</a:t>
+                        <a:t>Coverage</a:t>
                       </a:r>
                     </a:p>
                   </a:txBody>
@@ -7635,7 +7516,7 @@
                     <a:lstStyle/>
                     <a:p>
                       <a:r>
-                        <a:rPr sz="1800" b="0">
+                        <a:rPr sz="1875" b="0">
                           <a:solidFill>
                             <a:srgbClr val="152D43"/>
                           </a:solidFill>
@@ -7643,7 +7524,7 @@
                           <a:ea typeface="Arial"/>
                           <a:cs typeface="Arial"/>
                         </a:rPr>
-                        <a:t>147</a:t>
+                        <a:t>4 workloads × frame 39</a:t>
                       </a:r>
                     </a:p>
                   </a:txBody>
@@ -7671,7 +7552,7 @@
                     <a:lstStyle/>
                     <a:p>
                       <a:r>
-                        <a:rPr sz="1800" b="0">
+                        <a:rPr sz="1875" b="0">
                           <a:solidFill>
                             <a:srgbClr val="152D43"/>
                           </a:solidFill>
@@ -7679,7 +7560,7 @@
                           <a:ea typeface="Arial"/>
                           <a:cs typeface="Arial"/>
                         </a:rPr>
-                        <a:t>Odd frames 7–299</a:t>
+                        <a:t>1068 forward odd frames</a:t>
                       </a:r>
                     </a:p>
                   </a:txBody>
@@ -7702,14 +7583,14 @@
                   </a:tcPr>
                 </a:tc>
               </a:tr>
-              <a:tr h="628650">
+              <a:tr h="552450">
                 <a:tc>
                   <a:txBody>
                     <a:bodyPr/>
                     <a:lstStyle/>
                     <a:p>
                       <a:r>
-                        <a:rPr sz="1800" b="0">
+                        <a:rPr sz="1875" b="0">
                           <a:solidFill>
                             <a:srgbClr val="152D43"/>
                           </a:solidFill>
@@ -7717,7 +7598,7 @@
                           <a:ea typeface="Arial"/>
                           <a:cs typeface="Arial"/>
                         </a:rPr>
-                        <a:t>35 mm / 800</a:t>
+                        <a:t>Sampling</a:t>
                       </a:r>
                     </a:p>
                   </a:txBody>
@@ -7751,7 +7632,7 @@
                     <a:lstStyle/>
                     <a:p>
                       <a:r>
-                        <a:rPr sz="1800" b="0">
+                        <a:rPr sz="1875" b="0">
                           <a:solidFill>
                             <a:srgbClr val="152D43"/>
                           </a:solidFill>
@@ -7759,7 +7640,7 @@
                           <a:ea typeface="Arial"/>
                           <a:cs typeface="Arial"/>
                         </a:rPr>
-                        <a:t>387</a:t>
+                        <a:t>10 warmups + 100 runs/path</a:t>
                       </a:r>
                     </a:p>
                   </a:txBody>
@@ -7787,7 +7668,7 @@
                     <a:lstStyle/>
                     <a:p>
                       <a:r>
-                        <a:rPr sz="1800" b="0">
+                        <a:rPr sz="1875" b="0">
                           <a:solidFill>
                             <a:srgbClr val="152D43"/>
                           </a:solidFill>
@@ -7795,7 +7676,7 @@
                           <a:ea typeface="Arial"/>
                           <a:cs typeface="Arial"/>
                         </a:rPr>
-                        <a:t>Odd frames 7–779</a:t>
+                        <a:t>1 output/config/frame</a:t>
                       </a:r>
                     </a:p>
                   </a:txBody>
@@ -7818,6 +7699,122 @@
                   </a:tcPr>
                 </a:tc>
               </a:tr>
+              <a:tr h="552450">
+                <a:tc>
+                  <a:txBody>
+                    <a:bodyPr/>
+                    <a:lstStyle/>
+                    <a:p>
+                      <a:r>
+                        <a:rPr sz="1875" b="0">
+                          <a:solidFill>
+                            <a:srgbClr val="152D43"/>
+                          </a:solidFill>
+                          <a:latin typeface="Arial"/>
+                          <a:ea typeface="Arial"/>
+                          <a:cs typeface="Arial"/>
+                        </a:rPr>
+                        <a:t>Reported quantity</a:t>
+                      </a:r>
+                    </a:p>
+                  </a:txBody>
+                  <a:tcPr marL="91440" marR="91440" marT="45720" marB="45720">
+                    <a:lnL w="9525">
+                      <a:solidFill>
+                        <a:srgbClr val="D7DFE5"/>
+                      </a:solidFill>
+                      <a:prstDash val="solid"/>
+                    </a:lnL>
+                    <a:lnR w="9525">
+                      <a:solidFill>
+                        <a:srgbClr val="D7DFE5"/>
+                      </a:solidFill>
+                      <a:prstDash val="solid"/>
+                    </a:lnR>
+                    <a:lnB w="9525">
+                      <a:solidFill>
+                        <a:srgbClr val="D7DFE5"/>
+                      </a:solidFill>
+                      <a:prstDash val="solid"/>
+                    </a:lnB>
+                    <a:solidFill>
+                      <a:srgbClr val="FFFFFF"/>
+                    </a:solidFill>
+                  </a:tcPr>
+                </a:tc>
+                <a:tc>
+                  <a:txBody>
+                    <a:bodyPr/>
+                    <a:lstStyle/>
+                    <a:p>
+                      <a:r>
+                        <a:rPr sz="1875" b="0">
+                          <a:solidFill>
+                            <a:srgbClr val="152D43"/>
+                          </a:solidFill>
+                          <a:latin typeface="Arial"/>
+                          <a:ea typeface="Arial"/>
+                          <a:cs typeface="Arial"/>
+                        </a:rPr>
+                        <a:t>Staged GPU timeline mean</a:t>
+                      </a:r>
+                    </a:p>
+                  </a:txBody>
+                  <a:tcPr marL="91440" marR="91440" marT="45720" marB="45720">
+                    <a:lnR w="9525">
+                      <a:solidFill>
+                        <a:srgbClr val="D7DFE5"/>
+                      </a:solidFill>
+                      <a:prstDash val="solid"/>
+                    </a:lnR>
+                    <a:lnB w="9525">
+                      <a:solidFill>
+                        <a:srgbClr val="D7DFE5"/>
+                      </a:solidFill>
+                      <a:prstDash val="solid"/>
+                    </a:lnB>
+                    <a:solidFill>
+                      <a:srgbClr val="FFFFFF"/>
+                    </a:solidFill>
+                  </a:tcPr>
+                </a:tc>
+                <a:tc>
+                  <a:txBody>
+                    <a:bodyPr/>
+                    <a:lstStyle/>
+                    <a:p>
+                      <a:r>
+                        <a:rPr sz="1875" b="0">
+                          <a:solidFill>
+                            <a:srgbClr val="152D43"/>
+                          </a:solidFill>
+                          <a:latin typeface="Arial"/>
+                          <a:ea typeface="Arial"/>
+                          <a:cs typeface="Arial"/>
+                        </a:rPr>
+                        <a:t>Original overflow PSNR</a:t>
+                      </a:r>
+                    </a:p>
+                  </a:txBody>
+                  <a:tcPr marL="91440" marR="91440" marT="45720" marB="45720">
+                    <a:lnR w="9525">
+                      <a:solidFill>
+                        <a:srgbClr val="D7DFE5"/>
+                      </a:solidFill>
+                      <a:prstDash val="solid"/>
+                    </a:lnR>
+                    <a:lnB w="9525">
+                      <a:solidFill>
+                        <a:srgbClr val="D7DFE5"/>
+                      </a:solidFill>
+                      <a:prstDash val="solid"/>
+                    </a:lnB>
+                    <a:solidFill>
+                      <a:srgbClr val="FFFFFF"/>
+                    </a:solidFill>
+                  </a:tcPr>
+                </a:tc>
+              </a:tr>
             </a:tbl>
           </a:graphicData>
         </a:graphic>
@@ -7827,7 +7824,7 @@
           <p:cNvPr id="5" name="">
             <a:extLst xmlns:a="http://schemas.openxmlformats.org/drawingml/2006/main">
               <a:ext uri="{FF2B5EF4-FFF2-40B4-BE49-F238E27FC236}">
-                <a16:creationId xmlns:a16="http://schemas.microsoft.com/office/drawing/2014/main" id="{2A81CA77-6C27-4F2C-AC60-DF328124A0F9}"/>
+                <a16:creationId xmlns:a16="http://schemas.microsoft.com/office/drawing/2014/main" id="{8894DAC9-BB36-46E3-9A7A-1D6F66D65C05}"/>
               </a:ext>
             </a:extLst>
           </p:cNvPr>
@@ -7838,8 +7835,8 @@
         </p:nvSpPr>
         <p:spPr>
           <a:xfrm xmlns:a="http://schemas.openxmlformats.org/drawingml/2006/main">
-            <a:off x="7581900" y="1638300"/>
-            <a:ext cx="3429000" cy="666750"/>
+            <a:off x="609600" y="5191125"/>
+            <a:ext cx="10953750" cy="361950"/>
           </a:xfrm>
           <a:prstGeom xmlns:a="http://schemas.openxmlformats.org/drawingml/2006/main" prst="rect">
             <a:avLst/>
@@ -7854,15 +7851,15 @@
           <a:lstStyle xmlns:a="http://schemas.openxmlformats.org/drawingml/2006/main"/>
           <a:p xmlns:a="http://schemas.openxmlformats.org/drawingml/2006/main">
             <a:r>
-              <a:rPr sz="3600" b="1">
-                <a:solidFill>
-                  <a:srgbClr val="086B93"/>
+              <a:rPr sz="1875" b="0">
+                <a:solidFill>
+                  <a:srgbClr val="152D43"/>
                 </a:solidFill>
                 <a:latin typeface="Arial"/>
                 <a:ea typeface="Arial"/>
                 <a:cs typeface="Arial"/>
               </a:rPr>
-              <a:t>1068 frames</a:t>
+              <a:t>Timing excludes input/output copies, allocation, disk I/O, network, decoding, and display.</a:t>
             </a:r>
           </a:p>
         </p:txBody>
@@ -7872,7 +7869,7 @@
           <p:cNvPr id="6" name="">
             <a:extLst xmlns:a="http://schemas.openxmlformats.org/drawingml/2006/main">
               <a:ext uri="{FF2B5EF4-FFF2-40B4-BE49-F238E27FC236}">
-                <a16:creationId xmlns:a16="http://schemas.microsoft.com/office/drawing/2014/main" id="{F03D4A5E-10FC-400D-974D-6CECACCB772A}"/>
+                <a16:creationId xmlns:a16="http://schemas.microsoft.com/office/drawing/2014/main" id="{32090890-00C3-4E17-AC68-4B226388B7EA}"/>
               </a:ext>
             </a:extLst>
           </p:cNvPr>
@@ -7883,8 +7880,8 @@
         </p:nvSpPr>
         <p:spPr>
           <a:xfrm xmlns:a="http://schemas.openxmlformats.org/drawingml/2006/main">
-            <a:off x="7581900" y="2552700"/>
-            <a:ext cx="3810000" cy="1828800"/>
+            <a:off x="609600" y="5600700"/>
+            <a:ext cx="10953750" cy="361950"/>
           </a:xfrm>
           <a:prstGeom xmlns:a="http://schemas.openxmlformats.org/drawingml/2006/main" prst="rect">
             <a:avLst/>
@@ -7899,54 +7896,15 @@
           <a:lstStyle xmlns:a="http://schemas.openxmlformats.org/drawingml/2006/main"/>
           <a:p xmlns:a="http://schemas.openxmlformats.org/drawingml/2006/main">
             <a:r>
-              <a:rPr sz="1950" b="0">
-                <a:solidFill>
-                  <a:srgbClr val="152D43"/>
+              <a:rPr sz="1875" b="1">
+                <a:solidFill>
+                  <a:srgbClr val="086B93"/>
                 </a:solidFill>
                 <a:latin typeface="Arial"/>
                 <a:ea typeface="Arial"/>
                 <a:cs typeface="Arial"/>
               </a:rPr>
-              <a:t>Xavier 15W Desktop</a:t>
-            </a:r>
-          </a:p>
-          <a:p xmlns:a="http://schemas.openxmlformats.org/drawingml/2006/main">
-            <a:r>
-              <a:rPr sz="1950" b="0">
-                <a:solidFill>
-                  <a:srgbClr val="152D43"/>
-                </a:solidFill>
-                <a:latin typeface="Arial"/>
-                <a:ea typeface="Arial"/>
-                <a:cs typeface="Arial"/>
-              </a:rPr>
-              <a:t>CUDA 11.4, unlocked clocks</a:t>
-            </a:r>
-          </a:p>
-          <a:p xmlns:a="http://schemas.openxmlformats.org/drawingml/2006/main">
-            <a:r>
-              <a:rPr sz="1950" b="0">
-                <a:solidFill>
-                  <a:srgbClr val="152D43"/>
-                </a:solidFill>
-                <a:latin typeface="Arial"/>
-                <a:ea typeface="Arial"/>
-                <a:cs typeface="Arial"/>
-              </a:rPr>
-              <a:t>3 warmups + 5 timed runs/frame</a:t>
-            </a:r>
-          </a:p>
-          <a:p xmlns:a="http://schemas.openxmlformats.org/drawingml/2006/main">
-            <a:r>
-              <a:rPr sz="1950" b="0">
-                <a:solidFill>
-                  <a:srgbClr val="152D43"/>
-                </a:solidFill>
-                <a:latin typeface="Arial"/>
-                <a:ea typeface="Arial"/>
-                <a:cs typeface="Arial"/>
-              </a:rPr>
-              <a:t>One quality output/config/frame</a:t>
+              <a:t>Slides 6–7 add one fixed 2 ms/frame decode budget; this is not measured end-to-end.</a:t>
             </a:r>
           </a:p>
         </p:txBody>
@@ -7956,78 +7914,7 @@
           <p:cNvPr id="7" name="">
             <a:extLst xmlns:a="http://schemas.openxmlformats.org/drawingml/2006/main">
               <a:ext uri="{FF2B5EF4-FFF2-40B4-BE49-F238E27FC236}">
-                <a16:creationId xmlns:a16="http://schemas.microsoft.com/office/drawing/2014/main" id="{DBEC9474-8C8B-4729-8063-1AC73BC5EBC8}"/>
-              </a:ext>
-            </a:extLst>
-          </p:cNvPr>
-          <p:cNvSpPr>
-            <a:spLocks xmlns:a="http://schemas.openxmlformats.org/drawingml/2006/main" noGrp="1"/>
-          </p:cNvSpPr>
-          <p:nvPr/>
-        </p:nvSpPr>
-        <p:spPr>
-          <a:xfrm xmlns:a="http://schemas.openxmlformats.org/drawingml/2006/main">
-            <a:off x="609600" y="4905375"/>
-            <a:ext cx="10810875" cy="942975"/>
-          </a:xfrm>
-          <a:prstGeom xmlns:a="http://schemas.openxmlformats.org/drawingml/2006/main" prst="rect">
-            <a:avLst/>
-          </a:prstGeom>
-          <a:noFill xmlns:a="http://schemas.openxmlformats.org/drawingml/2006/main"/>
-          <a:ln xmlns:a="http://schemas.openxmlformats.org/drawingml/2006/main" w="0">
-            <a:noFill/>
-          </a:ln>
-        </p:spPr>
-        <p:txBody>
-          <a:bodyPr xmlns:a="http://schemas.openxmlformats.org/drawingml/2006/main" lIns="0" tIns="0" rIns="0" bIns="0"/>
-          <a:lstStyle xmlns:a="http://schemas.openxmlformats.org/drawingml/2006/main"/>
-          <a:p xmlns:a="http://schemas.openxmlformats.org/drawingml/2006/main">
-            <a:r>
-              <a:rPr sz="1800" b="0">
-                <a:solidFill>
-                  <a:srgbClr val="152D43"/>
-                </a:solidFill>
-                <a:latin typeface="Arial"/>
-                <a:ea typeface="Arial"/>
-                <a:cs typeface="Arial"/>
-              </a:rPr>
-              <a:t>Resident: GPU-resident inputs, reconstruction, upsampling, and blending</a:t>
-            </a:r>
-          </a:p>
-          <a:p xmlns:a="http://schemas.openxmlformats.org/drawingml/2006/main">
-            <a:r>
-              <a:rPr sz="1800" b="0">
-                <a:solidFill>
-                  <a:srgbClr val="152D43"/>
-                </a:solidFill>
-                <a:latin typeface="Arial"/>
-                <a:ea typeface="Arial"/>
-                <a:cs typeface="Arial"/>
-              </a:rPr>
-              <a:t>Stream: also includes input upload and output download</a:t>
-            </a:r>
-          </a:p>
-          <a:p xmlns:a="http://schemas.openxmlformats.org/drawingml/2006/main">
-            <a:r>
-              <a:rPr sz="1800" b="0">
-                <a:solidFill>
-                  <a:srgbClr val="152D43"/>
-                </a:solidFill>
-                <a:latin typeface="Arial"/>
-                <a:ea typeface="Arial"/>
-                <a:cs typeface="Arial"/>
-              </a:rPr>
-              <a:t>Slides 6–7 add a fixed 2 ms/frame decode budget; not measured end-to-end.</a:t>
-            </a:r>
-          </a:p>
-        </p:txBody>
-      </p:sp>
-      <p:sp>
-        <p:nvSpPr>
-          <p:cNvPr id="8" name="">
-            <a:extLst xmlns:a="http://schemas.openxmlformats.org/drawingml/2006/main">
-              <a:ext uri="{FF2B5EF4-FFF2-40B4-BE49-F238E27FC236}">
-                <a16:creationId xmlns:a16="http://schemas.microsoft.com/office/drawing/2014/main" id="{97E31DD2-707D-424E-B054-983B1743D06A}"/>
+                <a16:creationId xmlns:a16="http://schemas.microsoft.com/office/drawing/2014/main" id="{A276807B-F1E4-43B9-9A84-8836807C2ED8}"/>
               </a:ext>
             </a:extLst>
           </p:cNvPr>
@@ -8062,7 +7949,7 @@
                 <a:ea typeface="Arial"/>
                 <a:cs typeface="Arial"/>
               </a:rPr>
-              <a:t>Excludes backward scenes, even frames, and unsupported tail frames. Timing excludes I/O, allocation, network, decoding, and display.</a:t>
+              <a:t>Timing and quality are from separate experiments. No new quality equivalence or jointly measured trade-off is claimed.</a:t>
             </a:r>
           </a:p>
         </p:txBody>
@@ -8070,7 +7957,7 @@
     </p:spTree>
     <p:extLst>
       <p:ext uri="{BB962C8B-B14F-4D97-AF65-F5344CB8AC3E}">
-        <p14:creationId xmlns:p14="http://schemas.microsoft.com/office/powerpoint/2010/main" val="135584366"/>
+        <p14:creationId xmlns:p14="http://schemas.microsoft.com/office/powerpoint/2010/main" val="1407810125"/>
       </p:ext>
     </p:extLst>
   </p:cSld>
@@ -8101,7 +7988,7 @@
           <p:cNvPr id="12" name="">
             <a:extLst xmlns:a="http://schemas.openxmlformats.org/drawingml/2006/main">
               <a:ext uri="{FF2B5EF4-FFF2-40B4-BE49-F238E27FC236}">
-                <a16:creationId xmlns:a16="http://schemas.microsoft.com/office/drawing/2014/main" id="{0C18236E-9365-4ECB-B77D-FF26FF34AEFA}"/>
+                <a16:creationId xmlns:a16="http://schemas.microsoft.com/office/drawing/2014/main" id="{574119EA-2228-4ED6-8283-648A928414D9}"/>
               </a:ext>
             </a:extLst>
           </p:cNvPr>
@@ -8136,7 +8023,7 @@
                 <a:ea typeface="Arial"/>
                 <a:cs typeface="Arial"/>
               </a:rPr>
-              <a:t>Decode budget + reconstruction across FOV levels</a:t>
+              <a:t>30W CUDA C++: decode budget + reconstruction</a:t>
             </a:r>
           </a:p>
         </p:txBody>
@@ -8146,7 +8033,7 @@
           <p:cNvPr id="2" name="">
             <a:extLst xmlns:a="http://schemas.openxmlformats.org/drawingml/2006/main">
               <a:ext uri="{FF2B5EF4-FFF2-40B4-BE49-F238E27FC236}">
-                <a16:creationId xmlns:a16="http://schemas.microsoft.com/office/drawing/2014/main" id="{002E7BB7-F8D1-41CF-BCAE-E9C278B5A9C3}"/>
+                <a16:creationId xmlns:a16="http://schemas.microsoft.com/office/drawing/2014/main" id="{19A0A1B8-59B0-4AA8-9822-2011A185E765}"/>
               </a:ext>
             </a:extLst>
           </p:cNvPr>
@@ -8176,7 +8063,7 @@
           <p:cNvPr id="3" name="">
             <a:extLst xmlns:a="http://schemas.openxmlformats.org/drawingml/2006/main">
               <a:ext uri="{FF2B5EF4-FFF2-40B4-BE49-F238E27FC236}">
-                <a16:creationId xmlns:a16="http://schemas.microsoft.com/office/drawing/2014/main" id="{0C71149C-B1C7-43C9-A920-4E95536D9A63}"/>
+                <a16:creationId xmlns:a16="http://schemas.microsoft.com/office/drawing/2014/main" id="{2865A3A5-0A9D-4FF9-9788-719D611F0E18}"/>
               </a:ext>
             </a:extLst>
           </p:cNvPr>
@@ -8221,7 +8108,7 @@
           <p:cNvPr id="4" name="Chart">
             <a:extLst xmlns:a="http://schemas.openxmlformats.org/drawingml/2006/main">
               <a:ext uri="{FF2B5EF4-FFF2-40B4-BE49-F238E27FC236}">
-                <a16:creationId xmlns:a16="http://schemas.microsoft.com/office/drawing/2014/main" id="{1DC04A79-CA80-4A38-A015-59BF3E53FB09}"/>
+                <a16:creationId xmlns:a16="http://schemas.microsoft.com/office/drawing/2014/main" id="{E621F1A7-35AB-4CE2-B7EE-9A2C1624DF71}"/>
               </a:ext>
             </a:extLst>
           </p:cNvPr>
@@ -8229,12 +8116,12 @@
           <p:nvPr/>
         </p:nvGraphicFramePr>
         <p:xfrm>
-          <a:off xmlns:a="http://schemas.openxmlformats.org/drawingml/2006/main" x="609600" y="1676400"/>
-          <a:ext xmlns:a="http://schemas.openxmlformats.org/drawingml/2006/main" cx="7715250" cy="3905250"/>
+          <a:off xmlns:a="http://schemas.openxmlformats.org/drawingml/2006/main" x="609600" y="1828800"/>
+          <a:ext xmlns:a="http://schemas.openxmlformats.org/drawingml/2006/main" cx="7715250" cy="3752850"/>
         </p:xfrm>
         <a:graphic xmlns:a="http://schemas.openxmlformats.org/drawingml/2006/main">
           <a:graphicData uri="http://schemas.openxmlformats.org/drawingml/2006/chart">
-            <c:chart xmlns:r="http://schemas.openxmlformats.org/officeDocument/2006/relationships" xmlns:c="http://schemas.openxmlformats.org/drawingml/2006/chart" r:id="R249ff02d47294aaa"/>
+            <c:chart xmlns:r="http://schemas.openxmlformats.org/officeDocument/2006/relationships" xmlns:c="http://schemas.openxmlformats.org/drawingml/2006/chart" r:id="R50ab8559b0a64bd2"/>
           </a:graphicData>
         </a:graphic>
       </p:graphicFrame>
@@ -8243,7 +8130,7 @@
           <p:cNvPr id="5" name="">
             <a:extLst xmlns:a="http://schemas.openxmlformats.org/drawingml/2006/main">
               <a:ext uri="{FF2B5EF4-FFF2-40B4-BE49-F238E27FC236}">
-                <a16:creationId xmlns:a16="http://schemas.microsoft.com/office/drawing/2014/main" id="{6D51D4F5-FF15-4D7F-AA90-F015DBBC8816}"/>
+                <a16:creationId xmlns:a16="http://schemas.microsoft.com/office/drawing/2014/main" id="{2DDA2F4B-09E7-4C10-9C42-E91AE1E4632F}"/>
               </a:ext>
             </a:extLst>
           </p:cNvPr>
@@ -8254,7 +8141,52 @@
         </p:nvSpPr>
         <p:spPr>
           <a:xfrm xmlns:a="http://schemas.openxmlformats.org/drawingml/2006/main">
-            <a:off x="8858250" y="1924050"/>
+            <a:off x="609600" y="1381125"/>
+            <a:ext cx="10906125" cy="333375"/>
+          </a:xfrm>
+          <a:prstGeom xmlns:a="http://schemas.openxmlformats.org/drawingml/2006/main" prst="rect">
+            <a:avLst/>
+          </a:prstGeom>
+          <a:noFill xmlns:a="http://schemas.openxmlformats.org/drawingml/2006/main"/>
+          <a:ln xmlns:a="http://schemas.openxmlformats.org/drawingml/2006/main" w="0">
+            <a:noFill/>
+          </a:ln>
+        </p:spPr>
+        <p:txBody>
+          <a:bodyPr xmlns:a="http://schemas.openxmlformats.org/drawingml/2006/main" lIns="0" tIns="0" rIns="0" bIns="0"/>
+          <a:lstStyle xmlns:a="http://schemas.openxmlformats.org/drawingml/2006/main"/>
+          <a:p xmlns:a="http://schemas.openxmlformats.org/drawingml/2006/main">
+            <a:r>
+              <a:rPr sz="1875" b="1">
+                <a:solidFill>
+                  <a:srgbClr val="086B93"/>
+                </a:solidFill>
+                <a:latin typeface="Arial"/>
+                <a:ea typeface="Arial"/>
+                <a:cs typeface="Arial"/>
+              </a:rPr>
+              <a:t>4 workloads × frame 39; 100 repetitions/path. GPU timeline, not wall time.</a:t>
+            </a:r>
+          </a:p>
+        </p:txBody>
+      </p:sp>
+      <p:sp>
+        <p:nvSpPr>
+          <p:cNvPr id="6" name="">
+            <a:extLst xmlns:a="http://schemas.openxmlformats.org/drawingml/2006/main">
+              <a:ext uri="{FF2B5EF4-FFF2-40B4-BE49-F238E27FC236}">
+                <a16:creationId xmlns:a16="http://schemas.microsoft.com/office/drawing/2014/main" id="{C0C809F9-13D3-411E-89D3-64A96C88D600}"/>
+              </a:ext>
+            </a:extLst>
+          </p:cNvPr>
+          <p:cNvSpPr>
+            <a:spLocks xmlns:a="http://schemas.openxmlformats.org/drawingml/2006/main" noGrp="1"/>
+          </p:cNvSpPr>
+          <p:nvPr/>
+        </p:nvSpPr>
+        <p:spPr>
+          <a:xfrm xmlns:a="http://schemas.openxmlformats.org/drawingml/2006/main">
+            <a:off x="8858250" y="2028825"/>
             <a:ext cx="2667000" cy="476250"/>
           </a:xfrm>
           <a:prstGeom xmlns:a="http://schemas.openxmlformats.org/drawingml/2006/main" prst="rect">
@@ -8285,10 +8217,10 @@
       </p:sp>
       <p:sp>
         <p:nvSpPr>
-          <p:cNvPr id="6" name="">
-            <a:extLst xmlns:a="http://schemas.openxmlformats.org/drawingml/2006/main">
-              <a:ext uri="{FF2B5EF4-FFF2-40B4-BE49-F238E27FC236}">
-                <a16:creationId xmlns:a16="http://schemas.microsoft.com/office/drawing/2014/main" id="{45826A59-AC24-426D-898F-306B3D538DEB}"/>
+          <p:cNvPr id="7" name="">
+            <a:extLst xmlns:a="http://schemas.openxmlformats.org/drawingml/2006/main">
+              <a:ext uri="{FF2B5EF4-FFF2-40B4-BE49-F238E27FC236}">
+                <a16:creationId xmlns:a16="http://schemas.microsoft.com/office/drawing/2014/main" id="{D00AA083-073B-4DE1-B673-55873BF297C0}"/>
               </a:ext>
             </a:extLst>
           </p:cNvPr>
@@ -8299,7 +8231,7 @@
         </p:nvSpPr>
         <p:spPr>
           <a:xfrm xmlns:a="http://schemas.openxmlformats.org/drawingml/2006/main">
-            <a:off x="8858250" y="2619375"/>
+            <a:off x="8858250" y="2695575"/>
             <a:ext cx="2857500" cy="619125"/>
           </a:xfrm>
           <a:prstGeom xmlns:a="http://schemas.openxmlformats.org/drawingml/2006/main" prst="rect">
@@ -8323,17 +8255,17 @@
                 <a:ea typeface="Arial"/>
                 <a:cs typeface="Arial"/>
               </a:rPr>
-              <a:t>6.770 ms</a:t>
+              <a:t>5.462 ms</a:t>
             </a:r>
           </a:p>
         </p:txBody>
       </p:sp>
       <p:sp>
         <p:nvSpPr>
-          <p:cNvPr id="7" name="">
-            <a:extLst xmlns:a="http://schemas.openxmlformats.org/drawingml/2006/main">
-              <a:ext uri="{FF2B5EF4-FFF2-40B4-BE49-F238E27FC236}">
-                <a16:creationId xmlns:a16="http://schemas.microsoft.com/office/drawing/2014/main" id="{0343FACC-B7B1-4BD0-8894-69A4B9600937}"/>
+          <p:cNvPr id="8" name="">
+            <a:extLst xmlns:a="http://schemas.openxmlformats.org/drawingml/2006/main">
+              <a:ext uri="{FF2B5EF4-FFF2-40B4-BE49-F238E27FC236}">
+                <a16:creationId xmlns:a16="http://schemas.microsoft.com/office/drawing/2014/main" id="{C5C18691-F595-4DC0-B750-4289900CCC51}"/>
               </a:ext>
             </a:extLst>
           </p:cNvPr>
@@ -8344,7 +8276,97 @@
         </p:nvSpPr>
         <p:spPr>
           <a:xfrm xmlns:a="http://schemas.openxmlformats.org/drawingml/2006/main">
-            <a:off x="8858250" y="3305175"/>
+            <a:off x="8620125" y="3352800"/>
+            <a:ext cx="2952750" cy="381000"/>
+          </a:xfrm>
+          <a:prstGeom xmlns:a="http://schemas.openxmlformats.org/drawingml/2006/main" prst="rect">
+            <a:avLst/>
+          </a:prstGeom>
+          <a:noFill xmlns:a="http://schemas.openxmlformats.org/drawingml/2006/main"/>
+          <a:ln xmlns:a="http://schemas.openxmlformats.org/drawingml/2006/main" w="0">
+            <a:noFill/>
+          </a:ln>
+        </p:spPr>
+        <p:txBody>
+          <a:bodyPr xmlns:a="http://schemas.openxmlformats.org/drawingml/2006/main" lIns="0" tIns="0" rIns="0" bIns="0"/>
+          <a:lstStyle xmlns:a="http://schemas.openxmlformats.org/drawingml/2006/main"/>
+          <a:p xmlns:a="http://schemas.openxmlformats.org/drawingml/2006/main">
+            <a:r>
+              <a:rPr sz="1725" b="0">
+                <a:solidFill>
+                  <a:srgbClr val="536675"/>
+                </a:solidFill>
+                <a:latin typeface="Arial"/>
+                <a:ea typeface="Arial"/>
+                <a:cs typeface="Arial"/>
+              </a:rPr>
+              <a:t>decode + reconstruction</a:t>
+            </a:r>
+          </a:p>
+        </p:txBody>
+      </p:sp>
+      <p:sp>
+        <p:nvSpPr>
+          <p:cNvPr id="9" name="">
+            <a:extLst xmlns:a="http://schemas.openxmlformats.org/drawingml/2006/main">
+              <a:ext uri="{FF2B5EF4-FFF2-40B4-BE49-F238E27FC236}">
+                <a16:creationId xmlns:a16="http://schemas.microsoft.com/office/drawing/2014/main" id="{B8D40134-A836-4C82-A068-06D41A87C6C9}"/>
+              </a:ext>
+            </a:extLst>
+          </p:cNvPr>
+          <p:cNvSpPr>
+            <a:spLocks xmlns:a="http://schemas.openxmlformats.org/drawingml/2006/main" noGrp="1"/>
+          </p:cNvSpPr>
+          <p:nvPr/>
+        </p:nvSpPr>
+        <p:spPr>
+          <a:xfrm xmlns:a="http://schemas.openxmlformats.org/drawingml/2006/main">
+            <a:off x="8858250" y="4019550"/>
+            <a:ext cx="2667000" cy="590550"/>
+          </a:xfrm>
+          <a:prstGeom xmlns:a="http://schemas.openxmlformats.org/drawingml/2006/main" prst="rect">
+            <a:avLst/>
+          </a:prstGeom>
+          <a:noFill xmlns:a="http://schemas.openxmlformats.org/drawingml/2006/main"/>
+          <a:ln xmlns:a="http://schemas.openxmlformats.org/drawingml/2006/main" w="0">
+            <a:noFill/>
+          </a:ln>
+        </p:spPr>
+        <p:txBody>
+          <a:bodyPr xmlns:a="http://schemas.openxmlformats.org/drawingml/2006/main" lIns="0" tIns="0" rIns="0" bIns="0"/>
+          <a:lstStyle xmlns:a="http://schemas.openxmlformats.org/drawingml/2006/main"/>
+          <a:p xmlns:a="http://schemas.openxmlformats.org/drawingml/2006/main">
+            <a:r>
+              <a:rPr sz="3450" b="1">
+                <a:solidFill>
+                  <a:srgbClr val="148B83"/>
+                </a:solidFill>
+                <a:latin typeface="Arial"/>
+                <a:ea typeface="Arial"/>
+                <a:cs typeface="Arial"/>
+              </a:rPr>
+              <a:t>1.83×</a:t>
+            </a:r>
+          </a:p>
+        </p:txBody>
+      </p:sp>
+      <p:sp>
+        <p:nvSpPr>
+          <p:cNvPr id="10" name="">
+            <a:extLst xmlns:a="http://schemas.openxmlformats.org/drawingml/2006/main">
+              <a:ext uri="{FF2B5EF4-FFF2-40B4-BE49-F238E27FC236}">
+                <a16:creationId xmlns:a16="http://schemas.microsoft.com/office/drawing/2014/main" id="{27525BB6-B97D-47EE-88BC-B323EA269B18}"/>
+              </a:ext>
+            </a:extLst>
+          </p:cNvPr>
+          <p:cNvSpPr>
+            <a:spLocks xmlns:a="http://schemas.openxmlformats.org/drawingml/2006/main" noGrp="1"/>
+          </p:cNvSpPr>
+          <p:nvPr/>
+        </p:nvSpPr>
+        <p:spPr>
+          <a:xfrm xmlns:a="http://schemas.openxmlformats.org/drawingml/2006/main">
+            <a:off x="8858250" y="4667250"/>
             <a:ext cx="2667000" cy="381000"/>
           </a:xfrm>
           <a:prstGeom xmlns:a="http://schemas.openxmlformats.org/drawingml/2006/main" prst="rect">
@@ -8368,152 +8390,17 @@
                 <a:ea typeface="Arial"/>
                 <a:cs typeface="Arial"/>
               </a:rPr>
-              <a:t>decode + resident</a:t>
+              <a:t>versus Full + decode</a:t>
             </a:r>
           </a:p>
         </p:txBody>
       </p:sp>
       <p:sp>
         <p:nvSpPr>
-          <p:cNvPr id="8" name="">
-            <a:extLst xmlns:a="http://schemas.openxmlformats.org/drawingml/2006/main">
-              <a:ext uri="{FF2B5EF4-FFF2-40B4-BE49-F238E27FC236}">
-                <a16:creationId xmlns:a16="http://schemas.microsoft.com/office/drawing/2014/main" id="{A925B8A5-655E-46E4-9ECE-27E6008D55F7}"/>
-              </a:ext>
-            </a:extLst>
-          </p:cNvPr>
-          <p:cNvSpPr>
-            <a:spLocks xmlns:a="http://schemas.openxmlformats.org/drawingml/2006/main" noGrp="1"/>
-          </p:cNvSpPr>
-          <p:nvPr/>
-        </p:nvSpPr>
-        <p:spPr>
-          <a:xfrm xmlns:a="http://schemas.openxmlformats.org/drawingml/2006/main">
-            <a:off x="8858250" y="3971925"/>
-            <a:ext cx="2667000" cy="590550"/>
-          </a:xfrm>
-          <a:prstGeom xmlns:a="http://schemas.openxmlformats.org/drawingml/2006/main" prst="rect">
-            <a:avLst/>
-          </a:prstGeom>
-          <a:noFill xmlns:a="http://schemas.openxmlformats.org/drawingml/2006/main"/>
-          <a:ln xmlns:a="http://schemas.openxmlformats.org/drawingml/2006/main" w="0">
-            <a:noFill/>
-          </a:ln>
-        </p:spPr>
-        <p:txBody>
-          <a:bodyPr xmlns:a="http://schemas.openxmlformats.org/drawingml/2006/main" lIns="0" tIns="0" rIns="0" bIns="0"/>
-          <a:lstStyle xmlns:a="http://schemas.openxmlformats.org/drawingml/2006/main"/>
-          <a:p xmlns:a="http://schemas.openxmlformats.org/drawingml/2006/main">
-            <a:r>
-              <a:rPr sz="3450" b="1">
-                <a:solidFill>
-                  <a:srgbClr val="148B83"/>
-                </a:solidFill>
-                <a:latin typeface="Arial"/>
-                <a:ea typeface="Arial"/>
-                <a:cs typeface="Arial"/>
-              </a:rPr>
-              <a:t>1.92×</a:t>
-            </a:r>
-          </a:p>
-        </p:txBody>
-      </p:sp>
-      <p:sp>
-        <p:nvSpPr>
-          <p:cNvPr id="9" name="">
-            <a:extLst xmlns:a="http://schemas.openxmlformats.org/drawingml/2006/main">
-              <a:ext uri="{FF2B5EF4-FFF2-40B4-BE49-F238E27FC236}">
-                <a16:creationId xmlns:a16="http://schemas.microsoft.com/office/drawing/2014/main" id="{513A9FBF-C677-4F9D-AA41-C0FF619E2AD3}"/>
-              </a:ext>
-            </a:extLst>
-          </p:cNvPr>
-          <p:cNvSpPr>
-            <a:spLocks xmlns:a="http://schemas.openxmlformats.org/drawingml/2006/main" noGrp="1"/>
-          </p:cNvSpPr>
-          <p:nvPr/>
-        </p:nvSpPr>
-        <p:spPr>
-          <a:xfrm xmlns:a="http://schemas.openxmlformats.org/drawingml/2006/main">
-            <a:off x="8858250" y="4619625"/>
-            <a:ext cx="2667000" cy="381000"/>
-          </a:xfrm>
-          <a:prstGeom xmlns:a="http://schemas.openxmlformats.org/drawingml/2006/main" prst="rect">
-            <a:avLst/>
-          </a:prstGeom>
-          <a:noFill xmlns:a="http://schemas.openxmlformats.org/drawingml/2006/main"/>
-          <a:ln xmlns:a="http://schemas.openxmlformats.org/drawingml/2006/main" w="0">
-            <a:noFill/>
-          </a:ln>
-        </p:spPr>
-        <p:txBody>
-          <a:bodyPr xmlns:a="http://schemas.openxmlformats.org/drawingml/2006/main" lIns="0" tIns="0" rIns="0" bIns="0"/>
-          <a:lstStyle xmlns:a="http://schemas.openxmlformats.org/drawingml/2006/main"/>
-          <a:p xmlns:a="http://schemas.openxmlformats.org/drawingml/2006/main">
-            <a:r>
-              <a:rPr sz="1875" b="0">
-                <a:solidFill>
-                  <a:srgbClr val="536675"/>
-                </a:solidFill>
-                <a:latin typeface="Arial"/>
-                <a:ea typeface="Arial"/>
-                <a:cs typeface="Arial"/>
-              </a:rPr>
-              <a:t>versus full + decode</a:t>
-            </a:r>
-          </a:p>
-        </p:txBody>
-      </p:sp>
-      <p:sp>
-        <p:nvSpPr>
-          <p:cNvPr id="10" name="">
-            <a:extLst xmlns:a="http://schemas.openxmlformats.org/drawingml/2006/main">
-              <a:ext uri="{FF2B5EF4-FFF2-40B4-BE49-F238E27FC236}">
-                <a16:creationId xmlns:a16="http://schemas.microsoft.com/office/drawing/2014/main" id="{FF106BD9-5C08-4560-9F54-8C1C4937BE48}"/>
-              </a:ext>
-            </a:extLst>
-          </p:cNvPr>
-          <p:cNvSpPr>
-            <a:spLocks xmlns:a="http://schemas.openxmlformats.org/drawingml/2006/main" noGrp="1"/>
-          </p:cNvSpPr>
-          <p:nvPr/>
-        </p:nvSpPr>
-        <p:spPr>
-          <a:xfrm xmlns:a="http://schemas.openxmlformats.org/drawingml/2006/main">
-            <a:off x="609600" y="1381125"/>
-            <a:ext cx="10906125" cy="295275"/>
-          </a:xfrm>
-          <a:prstGeom xmlns:a="http://schemas.openxmlformats.org/drawingml/2006/main" prst="rect">
-            <a:avLst/>
-          </a:prstGeom>
-          <a:noFill xmlns:a="http://schemas.openxmlformats.org/drawingml/2006/main"/>
-          <a:ln xmlns:a="http://schemas.openxmlformats.org/drawingml/2006/main" w="0">
-            <a:noFill/>
-          </a:ln>
-        </p:spPr>
-        <p:txBody>
-          <a:bodyPr xmlns:a="http://schemas.openxmlformats.org/drawingml/2006/main" lIns="0" tIns="0" rIns="0" bIns="0"/>
-          <a:lstStyle xmlns:a="http://schemas.openxmlformats.org/drawingml/2006/main"/>
-          <a:p xmlns:a="http://schemas.openxmlformats.org/drawingml/2006/main">
-            <a:r>
-              <a:rPr sz="1725" b="1">
-                <a:solidFill>
-                  <a:srgbClr val="086B93"/>
-                </a:solidFill>
-                <a:latin typeface="Arial"/>
-                <a:ea typeface="Arial"/>
-                <a:cs typeface="Arial"/>
-              </a:rPr>
-              <a:t>Fixed decode budget: 2 ms/frame + measured reconstruction; stream also includes copies.</a:t>
-            </a:r>
-          </a:p>
-        </p:txBody>
-      </p:sp>
-      <p:sp>
-        <p:nvSpPr>
           <p:cNvPr id="11" name="">
             <a:extLst xmlns:a="http://schemas.openxmlformats.org/drawingml/2006/main">
               <a:ext uri="{FF2B5EF4-FFF2-40B4-BE49-F238E27FC236}">
-                <a16:creationId xmlns:a16="http://schemas.microsoft.com/office/drawing/2014/main" id="{D6091BB4-A2B5-46C6-B0DC-E9CAC62CA47E}"/>
+                <a16:creationId xmlns:a16="http://schemas.microsoft.com/office/drawing/2014/main" id="{F4B321A8-C7D4-43A3-86BE-868ECA677C0B}"/>
               </a:ext>
             </a:extLst>
           </p:cNvPr>
@@ -8548,7 +8435,7 @@
                 <a:ea typeface="Arial"/>
                 <a:cs typeface="Arial"/>
               </a:rPr>
-              <a:t>Derived budget, not measured end-to-end. Fast resampling enabled; gains also include upsampling changes. No optimal-baseline claim.</a:t>
+              <a:t>Derived budget, not measured end-to-end. Copies excluded. Savings include reduced clearing work; no optimal-Full claim.</a:t>
             </a:r>
           </a:p>
         </p:txBody>
@@ -8556,7 +8443,7 @@
     </p:spTree>
     <p:extLst>
       <p:ext uri="{BB962C8B-B14F-4D97-AF65-F5344CB8AC3E}">
-        <p14:creationId xmlns:p14="http://schemas.microsoft.com/office/powerpoint/2010/main" val="1995950216"/>
+        <p14:creationId xmlns:p14="http://schemas.microsoft.com/office/powerpoint/2010/main" val="1158442540"/>
       </p:ext>
     </p:extLst>
   </p:cSld>
@@ -8587,7 +8474,7 @@
           <p:cNvPr id="8" name="">
             <a:extLst xmlns:a="http://schemas.openxmlformats.org/drawingml/2006/main">
               <a:ext uri="{FF2B5EF4-FFF2-40B4-BE49-F238E27FC236}">
-                <a16:creationId xmlns:a16="http://schemas.microsoft.com/office/drawing/2014/main" id="{4E36535A-3D76-44ED-BEC0-AC83455960C2}"/>
+                <a16:creationId xmlns:a16="http://schemas.microsoft.com/office/drawing/2014/main" id="{D0C93BB5-639A-4E9F-9EF7-5155D388F81D}"/>
               </a:ext>
             </a:extLst>
           </p:cNvPr>
@@ -8622,7 +8509,7 @@
                 <a:ea typeface="Arial"/>
                 <a:cs typeface="Arial"/>
               </a:rPr>
-              <a:t>Quality–latency trade-off</a:t>
+              <a:t>Quality and timing across region sizes</a:t>
             </a:r>
           </a:p>
         </p:txBody>
@@ -8632,7 +8519,7 @@
           <p:cNvPr id="2" name="">
             <a:extLst xmlns:a="http://schemas.openxmlformats.org/drawingml/2006/main">
               <a:ext uri="{FF2B5EF4-FFF2-40B4-BE49-F238E27FC236}">
-                <a16:creationId xmlns:a16="http://schemas.microsoft.com/office/drawing/2014/main" id="{7EE8DD29-BFFD-43DF-8F3F-6719BC4AB9E5}"/>
+                <a16:creationId xmlns:a16="http://schemas.microsoft.com/office/drawing/2014/main" id="{B42CA62D-FF0C-4A0D-981C-818DC1703605}"/>
               </a:ext>
             </a:extLst>
           </p:cNvPr>
@@ -8662,7 +8549,7 @@
           <p:cNvPr id="3" name="">
             <a:extLst xmlns:a="http://schemas.openxmlformats.org/drawingml/2006/main">
               <a:ext uri="{FF2B5EF4-FFF2-40B4-BE49-F238E27FC236}">
-                <a16:creationId xmlns:a16="http://schemas.microsoft.com/office/drawing/2014/main" id="{F78D41F6-AA25-42AD-9C2A-CAEC0375D007}"/>
+                <a16:creationId xmlns:a16="http://schemas.microsoft.com/office/drawing/2014/main" id="{993AE4C4-831A-4477-84B4-884783FBB323}"/>
               </a:ext>
             </a:extLst>
           </p:cNvPr>
@@ -8707,7 +8594,7 @@
           <p:cNvPr id="4" name="">
             <a:extLst xmlns:a="http://schemas.openxmlformats.org/drawingml/2006/main">
               <a:ext uri="{FF2B5EF4-FFF2-40B4-BE49-F238E27FC236}">
-                <a16:creationId xmlns:a16="http://schemas.microsoft.com/office/drawing/2014/main" id="{B75FF649-0591-4B21-82A1-8E2FDB533548}"/>
+                <a16:creationId xmlns:a16="http://schemas.microsoft.com/office/drawing/2014/main" id="{37330260-036B-41E2-870C-ACCC5477FBCA}"/>
               </a:ext>
             </a:extLst>
           </p:cNvPr>
@@ -8961,7 +8848,7 @@
                           <a:ea typeface="Arial"/>
                           <a:cs typeface="Arial"/>
                         </a:rPr>
-                        <a:t>6.562 ms</a:t>
+                        <a:t>5.248 ms</a:t>
                       </a:r>
                     </a:p>
                   </a:txBody>
@@ -9113,7 +9000,7 @@
                           <a:ea typeface="Arial"/>
                           <a:cs typeface="Arial"/>
                         </a:rPr>
-                        <a:t>6.770 ms</a:t>
+                        <a:t>5.462 ms</a:t>
                       </a:r>
                     </a:p>
                   </a:txBody>
@@ -9265,7 +9152,7 @@
                           <a:ea typeface="Arial"/>
                           <a:cs typeface="Arial"/>
                         </a:rPr>
-                        <a:t>7.998 ms</a:t>
+                        <a:t>6.318 ms</a:t>
                       </a:r>
                     </a:p>
                   </a:txBody>
@@ -9417,7 +9304,7 @@
                           <a:ea typeface="Arial"/>
                           <a:cs typeface="Arial"/>
                         </a:rPr>
-                        <a:t>9.772 ms</a:t>
+                        <a:t>7.637 ms</a:t>
                       </a:r>
                     </a:p>
                   </a:txBody>
@@ -9569,7 +9456,7 @@
                           <a:ea typeface="Arial"/>
                           <a:cs typeface="Arial"/>
                         </a:rPr>
-                        <a:t>12.425 ms</a:t>
+                        <a:t>9.543 ms</a:t>
                       </a:r>
                     </a:p>
                   </a:txBody>
@@ -9673,7 +9560,7 @@
           <p:cNvPr id="5" name="">
             <a:extLst xmlns:a="http://schemas.openxmlformats.org/drawingml/2006/main">
               <a:ext uri="{FF2B5EF4-FFF2-40B4-BE49-F238E27FC236}">
-                <a16:creationId xmlns:a16="http://schemas.microsoft.com/office/drawing/2014/main" id="{4914DFD3-DFC4-4708-A964-7A92AEFEEE1E}"/>
+                <a16:creationId xmlns:a16="http://schemas.microsoft.com/office/drawing/2014/main" id="{8AC007F9-DD58-463F-8146-32AD9C82D365}"/>
               </a:ext>
             </a:extLst>
           </p:cNvPr>
@@ -9718,7 +9605,7 @@
           <p:cNvPr id="6" name="">
             <a:extLst xmlns:a="http://schemas.openxmlformats.org/drawingml/2006/main">
               <a:ext uri="{FF2B5EF4-FFF2-40B4-BE49-F238E27FC236}">
-                <a16:creationId xmlns:a16="http://schemas.microsoft.com/office/drawing/2014/main" id="{82977264-1EAE-4303-8E85-688E562E2C16}"/>
+                <a16:creationId xmlns:a16="http://schemas.microsoft.com/office/drawing/2014/main" id="{21008C5F-EDAD-4258-9678-28345C9F9F20}"/>
               </a:ext>
             </a:extLst>
           </p:cNvPr>
@@ -9763,7 +9650,7 @@
           <p:cNvPr id="7" name="">
             <a:extLst xmlns:a="http://schemas.openxmlformats.org/drawingml/2006/main">
               <a:ext uri="{FF2B5EF4-FFF2-40B4-BE49-F238E27FC236}">
-                <a16:creationId xmlns:a16="http://schemas.microsoft.com/office/drawing/2014/main" id="{91AC4755-FD96-4E1C-853B-93C0830B7EA9}"/>
+                <a16:creationId xmlns:a16="http://schemas.microsoft.com/office/drawing/2014/main" id="{8998305E-FED8-4D73-9EB1-22F36CA9C037}"/>
               </a:ext>
             </a:extLst>
           </p:cNvPr>
@@ -9798,7 +9685,7 @@
                 <a:ea typeface="Arial"/>
                 <a:cs typeface="Arial"/>
               </a:rPr>
-              <a:t>Fixed 2 ms decode budget + resident reconstruction. Stereo values derived; non-atomic writes remain. No SSIM/LPIPS.</a:t>
+              <a:t>Timing: 30W, 4 frames + fixed 2 ms decode. Quality: 15W, 1068 frames. Separate experiments, not jointly measured.</a:t>
             </a:r>
           </a:p>
         </p:txBody>
@@ -9806,7 +9693,7 @@
     </p:spTree>
     <p:extLst>
       <p:ext uri="{BB962C8B-B14F-4D97-AF65-F5344CB8AC3E}">
-        <p14:creationId xmlns:p14="http://schemas.microsoft.com/office/powerpoint/2010/main" val="1659209527"/>
+        <p14:creationId xmlns:p14="http://schemas.microsoft.com/office/powerpoint/2010/main" val="31864622"/>
       </p:ext>
     </p:extLst>
   </p:cSld>
@@ -9834,10 +9721,10 @@
       </p:grpSpPr>
       <p:sp>
         <p:nvSpPr>
-          <p:cNvPr id="8" name="">
-            <a:extLst xmlns:a="http://schemas.openxmlformats.org/drawingml/2006/main">
-              <a:ext uri="{FF2B5EF4-FFF2-40B4-BE49-F238E27FC236}">
-                <a16:creationId xmlns:a16="http://schemas.microsoft.com/office/drawing/2014/main" id="{8F621FE3-20C2-401B-A41C-25EC71F084D5}"/>
+          <p:cNvPr id="14" name="">
+            <a:extLst xmlns:a="http://schemas.openxmlformats.org/drawingml/2006/main">
+              <a:ext uri="{FF2B5EF4-FFF2-40B4-BE49-F238E27FC236}">
+                <a16:creationId xmlns:a16="http://schemas.microsoft.com/office/drawing/2014/main" id="{BF763828-6F42-4069-879B-9DE328BB3A47}"/>
               </a:ext>
             </a:extLst>
           </p:cNvPr>
@@ -9872,7 +9759,7 @@
                 <a:ea typeface="Arial"/>
                 <a:cs typeface="Arial"/>
               </a:rPr>
-              <a:t>Numba latency at 15W and 30W</a:t>
+              <a:t>Next: measure deadline behavior under jitter</a:t>
             </a:r>
           </a:p>
         </p:txBody>
@@ -9882,7 +9769,7 @@
           <p:cNvPr id="2" name="">
             <a:extLst xmlns:a="http://schemas.openxmlformats.org/drawingml/2006/main">
               <a:ext uri="{FF2B5EF4-FFF2-40B4-BE49-F238E27FC236}">
-                <a16:creationId xmlns:a16="http://schemas.microsoft.com/office/drawing/2014/main" id="{0F308A0D-3F13-43E0-A2A9-770DEEB953F6}"/>
+                <a16:creationId xmlns:a16="http://schemas.microsoft.com/office/drawing/2014/main" id="{52813728-1379-4089-8896-570BFF358632}"/>
               </a:ext>
             </a:extLst>
           </p:cNvPr>
@@ -9912,7 +9799,7 @@
           <p:cNvPr id="3" name="">
             <a:extLst xmlns:a="http://schemas.openxmlformats.org/drawingml/2006/main">
               <a:ext uri="{FF2B5EF4-FFF2-40B4-BE49-F238E27FC236}">
-                <a16:creationId xmlns:a16="http://schemas.microsoft.com/office/drawing/2014/main" id="{6D155053-AEB3-4185-939B-3B9088D18B22}"/>
+                <a16:creationId xmlns:a16="http://schemas.microsoft.com/office/drawing/2014/main" id="{658D3C62-0DE4-4F5A-9936-D41BC514882D}"/>
               </a:ext>
             </a:extLst>
           </p:cNvPr>
@@ -9952,1310 +9839,12 @@
           </a:p>
         </p:txBody>
       </p:sp>
-      <p:graphicFrame>
-        <p:nvGraphicFramePr>
+      <p:sp>
+        <p:nvSpPr>
           <p:cNvPr id="4" name="">
             <a:extLst xmlns:a="http://schemas.openxmlformats.org/drawingml/2006/main">
               <a:ext uri="{FF2B5EF4-FFF2-40B4-BE49-F238E27FC236}">
-                <a16:creationId xmlns:a16="http://schemas.microsoft.com/office/drawing/2014/main" id="{F8496523-C573-4179-8249-43DF223E69DE}"/>
-              </a:ext>
-            </a:extLst>
-          </p:cNvPr>
-          <p:cNvGraphicFramePr/>
-          <p:nvPr/>
-        </p:nvGraphicFramePr>
-        <p:xfrm>
-          <a:off xmlns:a="http://schemas.openxmlformats.org/drawingml/2006/main" x="609600" y="1714500"/>
-          <a:ext xmlns:a="http://schemas.openxmlformats.org/drawingml/2006/main" cx="10972800" cy="2714625"/>
-        </p:xfrm>
-        <a:graphic xmlns:a="http://schemas.openxmlformats.org/drawingml/2006/main">
-          <a:graphicData uri="http://schemas.openxmlformats.org/drawingml/2006/table">
-            <a:tbl>
-              <a:tblPr/>
-              <a:tblGrid>
-                <a:gridCol w="2209800"/>
-                <a:gridCol w="2190750"/>
-                <a:gridCol w="2190750"/>
-                <a:gridCol w="2190750"/>
-                <a:gridCol w="2190750"/>
-              </a:tblGrid>
-              <a:tr h="542925">
-                <a:tc>
-                  <a:txBody>
-                    <a:bodyPr/>
-                    <a:lstStyle/>
-                    <a:p>
-                      <a:r>
-                        <a:rPr sz="1950" b="1">
-                          <a:solidFill>
-                            <a:srgbClr val="FFFFFF"/>
-                          </a:solidFill>
-                          <a:latin typeface="Arial"/>
-                          <a:ea typeface="Arial"/>
-                          <a:cs typeface="Arial"/>
-                        </a:rPr>
-                        <a:t>Sequence</a:t>
-                      </a:r>
-                    </a:p>
-                  </a:txBody>
-                  <a:tcPr marL="91440" marR="91440" marT="45720" marB="45720">
-                    <a:lnL w="9525">
-                      <a:solidFill>
-                        <a:srgbClr val="D7DFE5"/>
-                      </a:solidFill>
-                      <a:prstDash val="solid"/>
-                    </a:lnL>
-                    <a:lnR w="9525">
-                      <a:solidFill>
-                        <a:srgbClr val="D7DFE5"/>
-                      </a:solidFill>
-                      <a:prstDash val="solid"/>
-                    </a:lnR>
-                    <a:lnT w="9525">
-                      <a:solidFill>
-                        <a:srgbClr val="D7DFE5"/>
-                      </a:solidFill>
-                      <a:prstDash val="solid"/>
-                    </a:lnT>
-                    <a:lnB w="9525">
-                      <a:solidFill>
-                        <a:srgbClr val="D7DFE5"/>
-                      </a:solidFill>
-                      <a:prstDash val="solid"/>
-                    </a:lnB>
-                    <a:solidFill>
-                      <a:srgbClr val="152D43"/>
-                    </a:solidFill>
-                  </a:tcPr>
-                </a:tc>
-                <a:tc>
-                  <a:txBody>
-                    <a:bodyPr/>
-                    <a:lstStyle/>
-                    <a:p>
-                      <a:r>
-                        <a:rPr sz="1950" b="1">
-                          <a:solidFill>
-                            <a:srgbClr val="FFFFFF"/>
-                          </a:solidFill>
-                          <a:latin typeface="Arial"/>
-                          <a:ea typeface="Arial"/>
-                          <a:cs typeface="Arial"/>
-                        </a:rPr>
-                        <a:t>Full 15W</a:t>
-                      </a:r>
-                    </a:p>
-                  </a:txBody>
-                  <a:tcPr marL="91440" marR="91440" marT="45720" marB="45720">
-                    <a:lnR w="9525">
-                      <a:solidFill>
-                        <a:srgbClr val="D7DFE5"/>
-                      </a:solidFill>
-                      <a:prstDash val="solid"/>
-                    </a:lnR>
-                    <a:lnT w="9525">
-                      <a:solidFill>
-                        <a:srgbClr val="D7DFE5"/>
-                      </a:solidFill>
-                      <a:prstDash val="solid"/>
-                    </a:lnT>
-                    <a:lnB w="9525">
-                      <a:solidFill>
-                        <a:srgbClr val="D7DFE5"/>
-                      </a:solidFill>
-                      <a:prstDash val="solid"/>
-                    </a:lnB>
-                    <a:solidFill>
-                      <a:srgbClr val="152D43"/>
-                    </a:solidFill>
-                  </a:tcPr>
-                </a:tc>
-                <a:tc>
-                  <a:txBody>
-                    <a:bodyPr/>
-                    <a:lstStyle/>
-                    <a:p>
-                      <a:r>
-                        <a:rPr sz="1950" b="1">
-                          <a:solidFill>
-                            <a:srgbClr val="FFFFFF"/>
-                          </a:solidFill>
-                          <a:latin typeface="Arial"/>
-                          <a:ea typeface="Arial"/>
-                          <a:cs typeface="Arial"/>
-                        </a:rPr>
-                        <a:t>Full 30W</a:t>
-                      </a:r>
-                    </a:p>
-                  </a:txBody>
-                  <a:tcPr marL="91440" marR="91440" marT="45720" marB="45720">
-                    <a:lnR w="9525">
-                      <a:solidFill>
-                        <a:srgbClr val="D7DFE5"/>
-                      </a:solidFill>
-                      <a:prstDash val="solid"/>
-                    </a:lnR>
-                    <a:lnT w="9525">
-                      <a:solidFill>
-                        <a:srgbClr val="D7DFE5"/>
-                      </a:solidFill>
-                      <a:prstDash val="solid"/>
-                    </a:lnT>
-                    <a:lnB w="9525">
-                      <a:solidFill>
-                        <a:srgbClr val="D7DFE5"/>
-                      </a:solidFill>
-                      <a:prstDash val="solid"/>
-                    </a:lnB>
-                    <a:solidFill>
-                      <a:srgbClr val="152D43"/>
-                    </a:solidFill>
-                  </a:tcPr>
-                </a:tc>
-                <a:tc>
-                  <a:txBody>
-                    <a:bodyPr/>
-                    <a:lstStyle/>
-                    <a:p>
-                      <a:r>
-                        <a:rPr sz="1950" b="1">
-                          <a:solidFill>
-                            <a:srgbClr val="FFFFFF"/>
-                          </a:solidFill>
-                          <a:latin typeface="Arial"/>
-                          <a:ea typeface="Arial"/>
-                          <a:cs typeface="Arial"/>
-                        </a:rPr>
-                        <a:t>ROI 15W</a:t>
-                      </a:r>
-                    </a:p>
-                  </a:txBody>
-                  <a:tcPr marL="91440" marR="91440" marT="45720" marB="45720">
-                    <a:lnR w="9525">
-                      <a:solidFill>
-                        <a:srgbClr val="D7DFE5"/>
-                      </a:solidFill>
-                      <a:prstDash val="solid"/>
-                    </a:lnR>
-                    <a:lnT w="9525">
-                      <a:solidFill>
-                        <a:srgbClr val="D7DFE5"/>
-                      </a:solidFill>
-                      <a:prstDash val="solid"/>
-                    </a:lnT>
-                    <a:lnB w="9525">
-                      <a:solidFill>
-                        <a:srgbClr val="D7DFE5"/>
-                      </a:solidFill>
-                      <a:prstDash val="solid"/>
-                    </a:lnB>
-                    <a:solidFill>
-                      <a:srgbClr val="152D43"/>
-                    </a:solidFill>
-                  </a:tcPr>
-                </a:tc>
-                <a:tc>
-                  <a:txBody>
-                    <a:bodyPr/>
-                    <a:lstStyle/>
-                    <a:p>
-                      <a:r>
-                        <a:rPr sz="1950" b="1">
-                          <a:solidFill>
-                            <a:srgbClr val="FFFFFF"/>
-                          </a:solidFill>
-                          <a:latin typeface="Arial"/>
-                          <a:ea typeface="Arial"/>
-                          <a:cs typeface="Arial"/>
-                        </a:rPr>
-                        <a:t>ROI 30W</a:t>
-                      </a:r>
-                    </a:p>
-                  </a:txBody>
-                  <a:tcPr marL="91440" marR="91440" marT="45720" marB="45720">
-                    <a:lnR w="9525">
-                      <a:solidFill>
-                        <a:srgbClr val="D7DFE5"/>
-                      </a:solidFill>
-                      <a:prstDash val="solid"/>
-                    </a:lnR>
-                    <a:lnT w="9525">
-                      <a:solidFill>
-                        <a:srgbClr val="D7DFE5"/>
-                      </a:solidFill>
-                      <a:prstDash val="solid"/>
-                    </a:lnT>
-                    <a:lnB w="9525">
-                      <a:solidFill>
-                        <a:srgbClr val="D7DFE5"/>
-                      </a:solidFill>
-                      <a:prstDash val="solid"/>
-                    </a:lnB>
-                    <a:solidFill>
-                      <a:srgbClr val="152D43"/>
-                    </a:solidFill>
-                  </a:tcPr>
-                </a:tc>
-              </a:tr>
-              <a:tr h="542925">
-                <a:tc>
-                  <a:txBody>
-                    <a:bodyPr/>
-                    <a:lstStyle/>
-                    <a:p>
-                      <a:r>
-                        <a:rPr sz="1950" b="0">
-                          <a:solidFill>
-                            <a:srgbClr val="152D43"/>
-                          </a:solidFill>
-                          <a:latin typeface="Arial"/>
-                          <a:ea typeface="Arial"/>
-                          <a:cs typeface="Arial"/>
-                        </a:rPr>
-                        <a:t>15_300</a:t>
-                      </a:r>
-                    </a:p>
-                  </a:txBody>
-                  <a:tcPr marL="91440" marR="91440" marT="45720" marB="45720">
-                    <a:lnL w="9525">
-                      <a:solidFill>
-                        <a:srgbClr val="D7DFE5"/>
-                      </a:solidFill>
-                      <a:prstDash val="solid"/>
-                    </a:lnL>
-                    <a:lnR w="9525">
-                      <a:solidFill>
-                        <a:srgbClr val="D7DFE5"/>
-                      </a:solidFill>
-                      <a:prstDash val="solid"/>
-                    </a:lnR>
-                    <a:lnB w="9525">
-                      <a:solidFill>
-                        <a:srgbClr val="D7DFE5"/>
-                      </a:solidFill>
-                      <a:prstDash val="solid"/>
-                    </a:lnB>
-                    <a:solidFill>
-                      <a:srgbClr val="FFFFFF"/>
-                    </a:solidFill>
-                  </a:tcPr>
-                </a:tc>
-                <a:tc>
-                  <a:txBody>
-                    <a:bodyPr/>
-                    <a:lstStyle/>
-                    <a:p>
-                      <a:r>
-                        <a:rPr sz="1950" b="0">
-                          <a:solidFill>
-                            <a:srgbClr val="152D43"/>
-                          </a:solidFill>
-                          <a:latin typeface="Arial"/>
-                          <a:ea typeface="Arial"/>
-                          <a:cs typeface="Arial"/>
-                        </a:rPr>
-                        <a:t>14.661</a:t>
-                      </a:r>
-                    </a:p>
-                  </a:txBody>
-                  <a:tcPr marL="91440" marR="91440" marT="45720" marB="45720">
-                    <a:lnR w="9525">
-                      <a:solidFill>
-                        <a:srgbClr val="D7DFE5"/>
-                      </a:solidFill>
-                      <a:prstDash val="solid"/>
-                    </a:lnR>
-                    <a:lnB w="9525">
-                      <a:solidFill>
-                        <a:srgbClr val="D7DFE5"/>
-                      </a:solidFill>
-                      <a:prstDash val="solid"/>
-                    </a:lnB>
-                    <a:solidFill>
-                      <a:srgbClr val="FFFFFF"/>
-                    </a:solidFill>
-                  </a:tcPr>
-                </a:tc>
-                <a:tc>
-                  <a:txBody>
-                    <a:bodyPr/>
-                    <a:lstStyle/>
-                    <a:p>
-                      <a:r>
-                        <a:rPr sz="1950" b="0">
-                          <a:solidFill>
-                            <a:srgbClr val="152D43"/>
-                          </a:solidFill>
-                          <a:latin typeface="Arial"/>
-                          <a:ea typeface="Arial"/>
-                          <a:cs typeface="Arial"/>
-                        </a:rPr>
-                        <a:t>11.039</a:t>
-                      </a:r>
-                    </a:p>
-                  </a:txBody>
-                  <a:tcPr marL="91440" marR="91440" marT="45720" marB="45720">
-                    <a:lnR w="9525">
-                      <a:solidFill>
-                        <a:srgbClr val="D7DFE5"/>
-                      </a:solidFill>
-                      <a:prstDash val="solid"/>
-                    </a:lnR>
-                    <a:lnB w="9525">
-                      <a:solidFill>
-                        <a:srgbClr val="D7DFE5"/>
-                      </a:solidFill>
-                      <a:prstDash val="solid"/>
-                    </a:lnB>
-                    <a:solidFill>
-                      <a:srgbClr val="FFFFFF"/>
-                    </a:solidFill>
-                  </a:tcPr>
-                </a:tc>
-                <a:tc>
-                  <a:txBody>
-                    <a:bodyPr/>
-                    <a:lstStyle/>
-                    <a:p>
-                      <a:r>
-                        <a:rPr sz="1950" b="0">
-                          <a:solidFill>
-                            <a:srgbClr val="152D43"/>
-                          </a:solidFill>
-                          <a:latin typeface="Arial"/>
-                          <a:ea typeface="Arial"/>
-                          <a:cs typeface="Arial"/>
-                        </a:rPr>
-                        <a:t>8.924</a:t>
-                      </a:r>
-                    </a:p>
-                  </a:txBody>
-                  <a:tcPr marL="91440" marR="91440" marT="45720" marB="45720">
-                    <a:lnR w="9525">
-                      <a:solidFill>
-                        <a:srgbClr val="D7DFE5"/>
-                      </a:solidFill>
-                      <a:prstDash val="solid"/>
-                    </a:lnR>
-                    <a:lnB w="9525">
-                      <a:solidFill>
-                        <a:srgbClr val="D7DFE5"/>
-                      </a:solidFill>
-                      <a:prstDash val="solid"/>
-                    </a:lnB>
-                    <a:solidFill>
-                      <a:srgbClr val="FFFFFF"/>
-                    </a:solidFill>
-                  </a:tcPr>
-                </a:tc>
-                <a:tc>
-                  <a:txBody>
-                    <a:bodyPr/>
-                    <a:lstStyle/>
-                    <a:p>
-                      <a:r>
-                        <a:rPr sz="1950" b="0">
-                          <a:solidFill>
-                            <a:srgbClr val="152D43"/>
-                          </a:solidFill>
-                          <a:latin typeface="Arial"/>
-                          <a:ea typeface="Arial"/>
-                          <a:cs typeface="Arial"/>
-                        </a:rPr>
-                        <a:t>6.803</a:t>
-                      </a:r>
-                    </a:p>
-                  </a:txBody>
-                  <a:tcPr marL="91440" marR="91440" marT="45720" marB="45720">
-                    <a:lnR w="9525">
-                      <a:solidFill>
-                        <a:srgbClr val="D7DFE5"/>
-                      </a:solidFill>
-                      <a:prstDash val="solid"/>
-                    </a:lnR>
-                    <a:lnB w="9525">
-                      <a:solidFill>
-                        <a:srgbClr val="D7DFE5"/>
-                      </a:solidFill>
-                      <a:prstDash val="solid"/>
-                    </a:lnB>
-                    <a:solidFill>
-                      <a:srgbClr val="FFFFFF"/>
-                    </a:solidFill>
-                  </a:tcPr>
-                </a:tc>
-              </a:tr>
-              <a:tr h="542925">
-                <a:tc>
-                  <a:txBody>
-                    <a:bodyPr/>
-                    <a:lstStyle/>
-                    <a:p>
-                      <a:r>
-                        <a:rPr sz="1950" b="0">
-                          <a:solidFill>
-                            <a:srgbClr val="152D43"/>
-                          </a:solidFill>
-                          <a:latin typeface="Arial"/>
-                          <a:ea typeface="Arial"/>
-                          <a:cs typeface="Arial"/>
-                        </a:rPr>
-                        <a:t>15_800</a:t>
-                      </a:r>
-                    </a:p>
-                  </a:txBody>
-                  <a:tcPr marL="91440" marR="91440" marT="45720" marB="45720">
-                    <a:lnL w="9525">
-                      <a:solidFill>
-                        <a:srgbClr val="D7DFE5"/>
-                      </a:solidFill>
-                      <a:prstDash val="solid"/>
-                    </a:lnL>
-                    <a:lnR w="9525">
-                      <a:solidFill>
-                        <a:srgbClr val="D7DFE5"/>
-                      </a:solidFill>
-                      <a:prstDash val="solid"/>
-                    </a:lnR>
-                    <a:lnB w="9525">
-                      <a:solidFill>
-                        <a:srgbClr val="D7DFE5"/>
-                      </a:solidFill>
-                      <a:prstDash val="solid"/>
-                    </a:lnB>
-                    <a:solidFill>
-                      <a:srgbClr val="EAF3F6"/>
-                    </a:solidFill>
-                  </a:tcPr>
-                </a:tc>
-                <a:tc>
-                  <a:txBody>
-                    <a:bodyPr/>
-                    <a:lstStyle/>
-                    <a:p>
-                      <a:r>
-                        <a:rPr sz="1950" b="0">
-                          <a:solidFill>
-                            <a:srgbClr val="152D43"/>
-                          </a:solidFill>
-                          <a:latin typeface="Arial"/>
-                          <a:ea typeface="Arial"/>
-                          <a:cs typeface="Arial"/>
-                        </a:rPr>
-                        <a:t>14.433</a:t>
-                      </a:r>
-                    </a:p>
-                  </a:txBody>
-                  <a:tcPr marL="91440" marR="91440" marT="45720" marB="45720">
-                    <a:lnR w="9525">
-                      <a:solidFill>
-                        <a:srgbClr val="D7DFE5"/>
-                      </a:solidFill>
-                      <a:prstDash val="solid"/>
-                    </a:lnR>
-                    <a:lnB w="9525">
-                      <a:solidFill>
-                        <a:srgbClr val="D7DFE5"/>
-                      </a:solidFill>
-                      <a:prstDash val="solid"/>
-                    </a:lnB>
-                    <a:solidFill>
-                      <a:srgbClr val="EAF3F6"/>
-                    </a:solidFill>
-                  </a:tcPr>
-                </a:tc>
-                <a:tc>
-                  <a:txBody>
-                    <a:bodyPr/>
-                    <a:lstStyle/>
-                    <a:p>
-                      <a:r>
-                        <a:rPr sz="1950" b="0">
-                          <a:solidFill>
-                            <a:srgbClr val="152D43"/>
-                          </a:solidFill>
-                          <a:latin typeface="Arial"/>
-                          <a:ea typeface="Arial"/>
-                          <a:cs typeface="Arial"/>
-                        </a:rPr>
-                        <a:t>10.870</a:t>
-                      </a:r>
-                    </a:p>
-                  </a:txBody>
-                  <a:tcPr marL="91440" marR="91440" marT="45720" marB="45720">
-                    <a:lnR w="9525">
-                      <a:solidFill>
-                        <a:srgbClr val="D7DFE5"/>
-                      </a:solidFill>
-                      <a:prstDash val="solid"/>
-                    </a:lnR>
-                    <a:lnB w="9525">
-                      <a:solidFill>
-                        <a:srgbClr val="D7DFE5"/>
-                      </a:solidFill>
-                      <a:prstDash val="solid"/>
-                    </a:lnB>
-                    <a:solidFill>
-                      <a:srgbClr val="EAF3F6"/>
-                    </a:solidFill>
-                  </a:tcPr>
-                </a:tc>
-                <a:tc>
-                  <a:txBody>
-                    <a:bodyPr/>
-                    <a:lstStyle/>
-                    <a:p>
-                      <a:r>
-                        <a:rPr sz="1950" b="0">
-                          <a:solidFill>
-                            <a:srgbClr val="152D43"/>
-                          </a:solidFill>
-                          <a:latin typeface="Arial"/>
-                          <a:ea typeface="Arial"/>
-                          <a:cs typeface="Arial"/>
-                        </a:rPr>
-                        <a:t>8.910</a:t>
-                      </a:r>
-                    </a:p>
-                  </a:txBody>
-                  <a:tcPr marL="91440" marR="91440" marT="45720" marB="45720">
-                    <a:lnR w="9525">
-                      <a:solidFill>
-                        <a:srgbClr val="D7DFE5"/>
-                      </a:solidFill>
-                      <a:prstDash val="solid"/>
-                    </a:lnR>
-                    <a:lnB w="9525">
-                      <a:solidFill>
-                        <a:srgbClr val="D7DFE5"/>
-                      </a:solidFill>
-                      <a:prstDash val="solid"/>
-                    </a:lnB>
-                    <a:solidFill>
-                      <a:srgbClr val="EAF3F6"/>
-                    </a:solidFill>
-                  </a:tcPr>
-                </a:tc>
-                <a:tc>
-                  <a:txBody>
-                    <a:bodyPr/>
-                    <a:lstStyle/>
-                    <a:p>
-                      <a:r>
-                        <a:rPr sz="1950" b="0">
-                          <a:solidFill>
-                            <a:srgbClr val="152D43"/>
-                          </a:solidFill>
-                          <a:latin typeface="Arial"/>
-                          <a:ea typeface="Arial"/>
-                          <a:cs typeface="Arial"/>
-                        </a:rPr>
-                        <a:t>6.784</a:t>
-                      </a:r>
-                    </a:p>
-                  </a:txBody>
-                  <a:tcPr marL="91440" marR="91440" marT="45720" marB="45720">
-                    <a:lnR w="9525">
-                      <a:solidFill>
-                        <a:srgbClr val="D7DFE5"/>
-                      </a:solidFill>
-                      <a:prstDash val="solid"/>
-                    </a:lnR>
-                    <a:lnB w="9525">
-                      <a:solidFill>
-                        <a:srgbClr val="D7DFE5"/>
-                      </a:solidFill>
-                      <a:prstDash val="solid"/>
-                    </a:lnB>
-                    <a:solidFill>
-                      <a:srgbClr val="EAF3F6"/>
-                    </a:solidFill>
-                  </a:tcPr>
-                </a:tc>
-              </a:tr>
-              <a:tr h="542925">
-                <a:tc>
-                  <a:txBody>
-                    <a:bodyPr/>
-                    <a:lstStyle/>
-                    <a:p>
-                      <a:r>
-                        <a:rPr sz="1950" b="0">
-                          <a:solidFill>
-                            <a:srgbClr val="152D43"/>
-                          </a:solidFill>
-                          <a:latin typeface="Arial"/>
-                          <a:ea typeface="Arial"/>
-                          <a:cs typeface="Arial"/>
-                        </a:rPr>
-                        <a:t>35_300</a:t>
-                      </a:r>
-                    </a:p>
-                  </a:txBody>
-                  <a:tcPr marL="91440" marR="91440" marT="45720" marB="45720">
-                    <a:lnL w="9525">
-                      <a:solidFill>
-                        <a:srgbClr val="D7DFE5"/>
-                      </a:solidFill>
-                      <a:prstDash val="solid"/>
-                    </a:lnL>
-                    <a:lnR w="9525">
-                      <a:solidFill>
-                        <a:srgbClr val="D7DFE5"/>
-                      </a:solidFill>
-                      <a:prstDash val="solid"/>
-                    </a:lnR>
-                    <a:lnB w="9525">
-                      <a:solidFill>
-                        <a:srgbClr val="D7DFE5"/>
-                      </a:solidFill>
-                      <a:prstDash val="solid"/>
-                    </a:lnB>
-                    <a:solidFill>
-                      <a:srgbClr val="FFFFFF"/>
-                    </a:solidFill>
-                  </a:tcPr>
-                </a:tc>
-                <a:tc>
-                  <a:txBody>
-                    <a:bodyPr/>
-                    <a:lstStyle/>
-                    <a:p>
-                      <a:r>
-                        <a:rPr sz="1950" b="0">
-                          <a:solidFill>
-                            <a:srgbClr val="152D43"/>
-                          </a:solidFill>
-                          <a:latin typeface="Arial"/>
-                          <a:ea typeface="Arial"/>
-                          <a:cs typeface="Arial"/>
-                        </a:rPr>
-                        <a:t>14.537</a:t>
-                      </a:r>
-                    </a:p>
-                  </a:txBody>
-                  <a:tcPr marL="91440" marR="91440" marT="45720" marB="45720">
-                    <a:lnR w="9525">
-                      <a:solidFill>
-                        <a:srgbClr val="D7DFE5"/>
-                      </a:solidFill>
-                      <a:prstDash val="solid"/>
-                    </a:lnR>
-                    <a:lnB w="9525">
-                      <a:solidFill>
-                        <a:srgbClr val="D7DFE5"/>
-                      </a:solidFill>
-                      <a:prstDash val="solid"/>
-                    </a:lnB>
-                    <a:solidFill>
-                      <a:srgbClr val="FFFFFF"/>
-                    </a:solidFill>
-                  </a:tcPr>
-                </a:tc>
-                <a:tc>
-                  <a:txBody>
-                    <a:bodyPr/>
-                    <a:lstStyle/>
-                    <a:p>
-                      <a:r>
-                        <a:rPr sz="1950" b="0">
-                          <a:solidFill>
-                            <a:srgbClr val="152D43"/>
-                          </a:solidFill>
-                          <a:latin typeface="Arial"/>
-                          <a:ea typeface="Arial"/>
-                          <a:cs typeface="Arial"/>
-                        </a:rPr>
-                        <a:t>10.914</a:t>
-                      </a:r>
-                    </a:p>
-                  </a:txBody>
-                  <a:tcPr marL="91440" marR="91440" marT="45720" marB="45720">
-                    <a:lnR w="9525">
-                      <a:solidFill>
-                        <a:srgbClr val="D7DFE5"/>
-                      </a:solidFill>
-                      <a:prstDash val="solid"/>
-                    </a:lnR>
-                    <a:lnB w="9525">
-                      <a:solidFill>
-                        <a:srgbClr val="D7DFE5"/>
-                      </a:solidFill>
-                      <a:prstDash val="solid"/>
-                    </a:lnB>
-                    <a:solidFill>
-                      <a:srgbClr val="FFFFFF"/>
-                    </a:solidFill>
-                  </a:tcPr>
-                </a:tc>
-                <a:tc>
-                  <a:txBody>
-                    <a:bodyPr/>
-                    <a:lstStyle/>
-                    <a:p>
-                      <a:r>
-                        <a:rPr sz="1950" b="0">
-                          <a:solidFill>
-                            <a:srgbClr val="152D43"/>
-                          </a:solidFill>
-                          <a:latin typeface="Arial"/>
-                          <a:ea typeface="Arial"/>
-                          <a:cs typeface="Arial"/>
-                        </a:rPr>
-                        <a:t>8.911</a:t>
-                      </a:r>
-                    </a:p>
-                  </a:txBody>
-                  <a:tcPr marL="91440" marR="91440" marT="45720" marB="45720">
-                    <a:lnR w="9525">
-                      <a:solidFill>
-                        <a:srgbClr val="D7DFE5"/>
-                      </a:solidFill>
-                      <a:prstDash val="solid"/>
-                    </a:lnR>
-                    <a:lnB w="9525">
-                      <a:solidFill>
-                        <a:srgbClr val="D7DFE5"/>
-                      </a:solidFill>
-                      <a:prstDash val="solid"/>
-                    </a:lnB>
-                    <a:solidFill>
-                      <a:srgbClr val="FFFFFF"/>
-                    </a:solidFill>
-                  </a:tcPr>
-                </a:tc>
-                <a:tc>
-                  <a:txBody>
-                    <a:bodyPr/>
-                    <a:lstStyle/>
-                    <a:p>
-                      <a:r>
-                        <a:rPr sz="1950" b="0">
-                          <a:solidFill>
-                            <a:srgbClr val="152D43"/>
-                          </a:solidFill>
-                          <a:latin typeface="Arial"/>
-                          <a:ea typeface="Arial"/>
-                          <a:cs typeface="Arial"/>
-                        </a:rPr>
-                        <a:t>6.793</a:t>
-                      </a:r>
-                    </a:p>
-                  </a:txBody>
-                  <a:tcPr marL="91440" marR="91440" marT="45720" marB="45720">
-                    <a:lnR w="9525">
-                      <a:solidFill>
-                        <a:srgbClr val="D7DFE5"/>
-                      </a:solidFill>
-                      <a:prstDash val="solid"/>
-                    </a:lnR>
-                    <a:lnB w="9525">
-                      <a:solidFill>
-                        <a:srgbClr val="D7DFE5"/>
-                      </a:solidFill>
-                      <a:prstDash val="solid"/>
-                    </a:lnB>
-                    <a:solidFill>
-                      <a:srgbClr val="FFFFFF"/>
-                    </a:solidFill>
-                  </a:tcPr>
-                </a:tc>
-              </a:tr>
-              <a:tr h="542925">
-                <a:tc>
-                  <a:txBody>
-                    <a:bodyPr/>
-                    <a:lstStyle/>
-                    <a:p>
-                      <a:r>
-                        <a:rPr sz="1950" b="0">
-                          <a:solidFill>
-                            <a:srgbClr val="152D43"/>
-                          </a:solidFill>
-                          <a:latin typeface="Arial"/>
-                          <a:ea typeface="Arial"/>
-                          <a:cs typeface="Arial"/>
-                        </a:rPr>
-                        <a:t>35_800</a:t>
-                      </a:r>
-                    </a:p>
-                  </a:txBody>
-                  <a:tcPr marL="91440" marR="91440" marT="45720" marB="45720">
-                    <a:lnL w="9525">
-                      <a:solidFill>
-                        <a:srgbClr val="D7DFE5"/>
-                      </a:solidFill>
-                      <a:prstDash val="solid"/>
-                    </a:lnL>
-                    <a:lnR w="9525">
-                      <a:solidFill>
-                        <a:srgbClr val="D7DFE5"/>
-                      </a:solidFill>
-                      <a:prstDash val="solid"/>
-                    </a:lnR>
-                    <a:lnB w="9525">
-                      <a:solidFill>
-                        <a:srgbClr val="D7DFE5"/>
-                      </a:solidFill>
-                      <a:prstDash val="solid"/>
-                    </a:lnB>
-                    <a:solidFill>
-                      <a:srgbClr val="EAF3F6"/>
-                    </a:solidFill>
-                  </a:tcPr>
-                </a:tc>
-                <a:tc>
-                  <a:txBody>
-                    <a:bodyPr/>
-                    <a:lstStyle/>
-                    <a:p>
-                      <a:r>
-                        <a:rPr sz="1950" b="0">
-                          <a:solidFill>
-                            <a:srgbClr val="152D43"/>
-                          </a:solidFill>
-                          <a:latin typeface="Arial"/>
-                          <a:ea typeface="Arial"/>
-                          <a:cs typeface="Arial"/>
-                        </a:rPr>
-                        <a:t>14.567</a:t>
-                      </a:r>
-                    </a:p>
-                  </a:txBody>
-                  <a:tcPr marL="91440" marR="91440" marT="45720" marB="45720">
-                    <a:lnR w="9525">
-                      <a:solidFill>
-                        <a:srgbClr val="D7DFE5"/>
-                      </a:solidFill>
-                      <a:prstDash val="solid"/>
-                    </a:lnR>
-                    <a:lnB w="9525">
-                      <a:solidFill>
-                        <a:srgbClr val="D7DFE5"/>
-                      </a:solidFill>
-                      <a:prstDash val="solid"/>
-                    </a:lnB>
-                    <a:solidFill>
-                      <a:srgbClr val="EAF3F6"/>
-                    </a:solidFill>
-                  </a:tcPr>
-                </a:tc>
-                <a:tc>
-                  <a:txBody>
-                    <a:bodyPr/>
-                    <a:lstStyle/>
-                    <a:p>
-                      <a:r>
-                        <a:rPr sz="1950" b="0">
-                          <a:solidFill>
-                            <a:srgbClr val="152D43"/>
-                          </a:solidFill>
-                          <a:latin typeface="Arial"/>
-                          <a:ea typeface="Arial"/>
-                          <a:cs typeface="Arial"/>
-                        </a:rPr>
-                        <a:t>11.045</a:t>
-                      </a:r>
-                    </a:p>
-                  </a:txBody>
-                  <a:tcPr marL="91440" marR="91440" marT="45720" marB="45720">
-                    <a:lnR w="9525">
-                      <a:solidFill>
-                        <a:srgbClr val="D7DFE5"/>
-                      </a:solidFill>
-                      <a:prstDash val="solid"/>
-                    </a:lnR>
-                    <a:lnB w="9525">
-                      <a:solidFill>
-                        <a:srgbClr val="D7DFE5"/>
-                      </a:solidFill>
-                      <a:prstDash val="solid"/>
-                    </a:lnB>
-                    <a:solidFill>
-                      <a:srgbClr val="EAF3F6"/>
-                    </a:solidFill>
-                  </a:tcPr>
-                </a:tc>
-                <a:tc>
-                  <a:txBody>
-                    <a:bodyPr/>
-                    <a:lstStyle/>
-                    <a:p>
-                      <a:r>
-                        <a:rPr sz="1950" b="0">
-                          <a:solidFill>
-                            <a:srgbClr val="152D43"/>
-                          </a:solidFill>
-                          <a:latin typeface="Arial"/>
-                          <a:ea typeface="Arial"/>
-                          <a:cs typeface="Arial"/>
-                        </a:rPr>
-                        <a:t>8.959</a:t>
-                      </a:r>
-                    </a:p>
-                  </a:txBody>
-                  <a:tcPr marL="91440" marR="91440" marT="45720" marB="45720">
-                    <a:lnR w="9525">
-                      <a:solidFill>
-                        <a:srgbClr val="D7DFE5"/>
-                      </a:solidFill>
-                      <a:prstDash val="solid"/>
-                    </a:lnR>
-                    <a:lnB w="9525">
-                      <a:solidFill>
-                        <a:srgbClr val="D7DFE5"/>
-                      </a:solidFill>
-                      <a:prstDash val="solid"/>
-                    </a:lnB>
-                    <a:solidFill>
-                      <a:srgbClr val="EAF3F6"/>
-                    </a:solidFill>
-                  </a:tcPr>
-                </a:tc>
-                <a:tc>
-                  <a:txBody>
-                    <a:bodyPr/>
-                    <a:lstStyle/>
-                    <a:p>
-                      <a:r>
-                        <a:rPr sz="1950" b="0">
-                          <a:solidFill>
-                            <a:srgbClr val="152D43"/>
-                          </a:solidFill>
-                          <a:latin typeface="Arial"/>
-                          <a:ea typeface="Arial"/>
-                          <a:cs typeface="Arial"/>
-                        </a:rPr>
-                        <a:t>6.841</a:t>
-                      </a:r>
-                    </a:p>
-                  </a:txBody>
-                  <a:tcPr marL="91440" marR="91440" marT="45720" marB="45720">
-                    <a:lnR w="9525">
-                      <a:solidFill>
-                        <a:srgbClr val="D7DFE5"/>
-                      </a:solidFill>
-                      <a:prstDash val="solid"/>
-                    </a:lnR>
-                    <a:lnB w="9525">
-                      <a:solidFill>
-                        <a:srgbClr val="D7DFE5"/>
-                      </a:solidFill>
-                      <a:prstDash val="solid"/>
-                    </a:lnB>
-                    <a:solidFill>
-                      <a:srgbClr val="EAF3F6"/>
-                    </a:solidFill>
-                  </a:tcPr>
-                </a:tc>
-              </a:tr>
-            </a:tbl>
-          </a:graphicData>
-        </a:graphic>
-      </p:graphicFrame>
-      <p:sp>
-        <p:nvSpPr>
-          <p:cNvPr id="5" name="">
-            <a:extLst xmlns:a="http://schemas.openxmlformats.org/drawingml/2006/main">
-              <a:ext uri="{FF2B5EF4-FFF2-40B4-BE49-F238E27FC236}">
-                <a16:creationId xmlns:a16="http://schemas.microsoft.com/office/drawing/2014/main" id="{48786C31-37F4-480F-9C34-F3EAAA7EFCBF}"/>
-              </a:ext>
-            </a:extLst>
-          </p:cNvPr>
-          <p:cNvSpPr>
-            <a:spLocks xmlns:a="http://schemas.openxmlformats.org/drawingml/2006/main" noGrp="1"/>
-          </p:cNvSpPr>
-          <p:nvPr/>
-        </p:nvSpPr>
-        <p:spPr>
-          <a:xfrm xmlns:a="http://schemas.openxmlformats.org/drawingml/2006/main">
-            <a:off x="609600" y="4714875"/>
-            <a:ext cx="10972800" cy="381000"/>
-          </a:xfrm>
-          <a:prstGeom xmlns:a="http://schemas.openxmlformats.org/drawingml/2006/main" prst="rect">
-            <a:avLst/>
-          </a:prstGeom>
-          <a:noFill xmlns:a="http://schemas.openxmlformats.org/drawingml/2006/main"/>
-          <a:ln xmlns:a="http://schemas.openxmlformats.org/drawingml/2006/main" w="0">
-            <a:noFill/>
-          </a:ln>
-        </p:spPr>
-        <p:txBody>
-          <a:bodyPr xmlns:a="http://schemas.openxmlformats.org/drawingml/2006/main" lIns="0" tIns="0" rIns="0" bIns="0"/>
-          <a:lstStyle xmlns:a="http://schemas.openxmlformats.org/drawingml/2006/main"/>
-          <a:p xmlns:a="http://schemas.openxmlformats.org/drawingml/2006/main">
-            <a:r>
-              <a:rPr sz="1950" b="1">
-                <a:solidFill>
-                  <a:srgbClr val="086B93"/>
-                </a:solidFill>
-                <a:latin typeface="Arial"/>
-                <a:ea typeface="Arial"/>
-                <a:cs typeface="Arial"/>
-              </a:rPr>
-              <a:t>Frame 39 per sequence, 100 repeats. Reconstruction means (ms); no decode. Region = 2.8%.</a:t>
-            </a:r>
-          </a:p>
-        </p:txBody>
-      </p:sp>
-      <p:sp>
-        <p:nvSpPr>
-          <p:cNvPr id="6" name="">
-            <a:extLst xmlns:a="http://schemas.openxmlformats.org/drawingml/2006/main">
-              <a:ext uri="{FF2B5EF4-FFF2-40B4-BE49-F238E27FC236}">
-                <a16:creationId xmlns:a16="http://schemas.microsoft.com/office/drawing/2014/main" id="{FE2651F4-E1A4-4591-94B4-57DFD0BD8457}"/>
-              </a:ext>
-            </a:extLst>
-          </p:cNvPr>
-          <p:cNvSpPr>
-            <a:spLocks xmlns:a="http://schemas.openxmlformats.org/drawingml/2006/main" noGrp="1"/>
-          </p:cNvSpPr>
-          <p:nvPr/>
-        </p:nvSpPr>
-        <p:spPr>
-          <a:xfrm xmlns:a="http://schemas.openxmlformats.org/drawingml/2006/main">
-            <a:off x="609600" y="5238750"/>
-            <a:ext cx="10972800" cy="685800"/>
-          </a:xfrm>
-          <a:prstGeom xmlns:a="http://schemas.openxmlformats.org/drawingml/2006/main" prst="rect">
-            <a:avLst/>
-          </a:prstGeom>
-          <a:noFill xmlns:a="http://schemas.openxmlformats.org/drawingml/2006/main"/>
-          <a:ln xmlns:a="http://schemas.openxmlformats.org/drawingml/2006/main" w="0">
-            <a:noFill/>
-          </a:ln>
-        </p:spPr>
-        <p:txBody>
-          <a:bodyPr xmlns:a="http://schemas.openxmlformats.org/drawingml/2006/main" lIns="0" tIns="0" rIns="0" bIns="0"/>
-          <a:lstStyle xmlns:a="http://schemas.openxmlformats.org/drawingml/2006/main"/>
-          <a:p xmlns:a="http://schemas.openxmlformats.org/drawingml/2006/main">
-            <a:r>
-              <a:rPr sz="1875" b="0">
-                <a:solidFill>
-                  <a:srgbClr val="152D43"/>
-                </a:solidFill>
-                <a:latin typeface="Arial"/>
-                <a:ea typeface="Arial"/>
-                <a:cs typeface="Arial"/>
-              </a:rPr>
-              <a:t>30W 4-core mode raises the GPU cap but lowers the CPU cap versus 15W Desktop.</a:t>
-            </a:r>
-          </a:p>
-          <a:p xmlns:a="http://schemas.openxmlformats.org/drawingml/2006/main">
-            <a:r>
-              <a:rPr sz="1875" b="0">
-                <a:solidFill>
-                  <a:srgbClr val="152D43"/>
-                </a:solidFill>
-                <a:latin typeface="Arial"/>
-                <a:ea typeface="Arial"/>
-                <a:cs typeface="Arial"/>
-              </a:rPr>
-              <a:t>Dynamic clocks. Numba and optimized C++ use different upsampling implementations.</a:t>
-            </a:r>
-          </a:p>
-        </p:txBody>
-      </p:sp>
-      <p:sp>
-        <p:nvSpPr>
-          <p:cNvPr id="7" name="">
-            <a:extLst xmlns:a="http://schemas.openxmlformats.org/drawingml/2006/main">
-              <a:ext uri="{FF2B5EF4-FFF2-40B4-BE49-F238E27FC236}">
-                <a16:creationId xmlns:a16="http://schemas.microsoft.com/office/drawing/2014/main" id="{39919E23-0D6B-4BC6-8924-43CB6446DCA7}"/>
-              </a:ext>
-            </a:extLst>
-          </p:cNvPr>
-          <p:cNvSpPr>
-            <a:spLocks xmlns:a="http://schemas.openxmlformats.org/drawingml/2006/main" noGrp="1"/>
-          </p:cNvSpPr>
-          <p:nvPr/>
-        </p:nvSpPr>
-        <p:spPr>
-          <a:xfrm xmlns:a="http://schemas.openxmlformats.org/drawingml/2006/main">
-            <a:off x="609600" y="5924550"/>
-            <a:ext cx="10715625" cy="457200"/>
-          </a:xfrm>
-          <a:prstGeom xmlns:a="http://schemas.openxmlformats.org/drawingml/2006/main" prst="rect">
-            <a:avLst/>
-          </a:prstGeom>
-          <a:noFill xmlns:a="http://schemas.openxmlformats.org/drawingml/2006/main"/>
-          <a:ln xmlns:a="http://schemas.openxmlformats.org/drawingml/2006/main" w="0">
-            <a:noFill/>
-          </a:ln>
-        </p:spPr>
-        <p:txBody>
-          <a:bodyPr xmlns:a="http://schemas.openxmlformats.org/drawingml/2006/main" lIns="0" tIns="0" rIns="0" bIns="0"/>
-          <a:lstStyle xmlns:a="http://schemas.openxmlformats.org/drawingml/2006/main"/>
-          <a:p xmlns:a="http://schemas.openxmlformats.org/drawingml/2006/main">
-            <a:r>
-              <a:rPr sz="1500" b="0">
-                <a:solidFill>
-                  <a:srgbClr val="536675"/>
-                </a:solidFill>
-                <a:latin typeface="Arial"/>
-                <a:ea typeface="Arial"/>
-                <a:cs typeface="Arial"/>
-              </a:rPr>
-              <a:t>Small-sample power-mode comparison, not a complete-dataset study or a language-only comparison.</a:t>
-            </a:r>
-          </a:p>
-        </p:txBody>
-      </p:sp>
-    </p:spTree>
-    <p:extLst>
-      <p:ext uri="{BB962C8B-B14F-4D97-AF65-F5344CB8AC3E}">
-        <p14:creationId xmlns:p14="http://schemas.microsoft.com/office/powerpoint/2010/main" val="1164191138"/>
-      </p:ext>
-    </p:extLst>
-  </p:cSld>
-</p:sld>
-</file>
-
-<file path=ppt/slides/slide9.xml><?xml version="1.0" encoding="utf-8"?>
-<p:sld xmlns:p="http://schemas.openxmlformats.org/presentationml/2006/main">
-  <p:cSld>
-    <p:bg>
-      <p:bgPr>
-        <a:solidFill xmlns:a="http://schemas.openxmlformats.org/drawingml/2006/main">
-          <a:srgbClr val="FFFFFF"/>
-        </a:solidFill>
-      </p:bgPr>
-    </p:bg>
-    <p:spTree>
-      <p:nvGrpSpPr>
-        <p:cNvPr id="1" name=""/>
-        <p:cNvGrpSpPr/>
-        <p:nvPr/>
-      </p:nvGrpSpPr>
-      <p:grpSpPr>
-        <a:xfrm xmlns:a="http://schemas.openxmlformats.org/drawingml/2006/main"/>
-      </p:grpSpPr>
-      <p:sp>
-        <p:nvSpPr>
-          <p:cNvPr id="14" name="">
-            <a:extLst xmlns:a="http://schemas.openxmlformats.org/drawingml/2006/main">
-              <a:ext uri="{FF2B5EF4-FFF2-40B4-BE49-F238E27FC236}">
-                <a16:creationId xmlns:a16="http://schemas.microsoft.com/office/drawing/2014/main" id="{9C2FE9EB-1B78-4E3F-8F19-3869B02541E8}"/>
-              </a:ext>
-            </a:extLst>
-          </p:cNvPr>
-          <p:cNvSpPr>
-            <a:spLocks xmlns:a="http://schemas.openxmlformats.org/drawingml/2006/main" noGrp="1"/>
-          </p:cNvSpPr>
-          <p:nvPr/>
-        </p:nvSpPr>
-        <p:spPr>
-          <a:xfrm xmlns:a="http://schemas.openxmlformats.org/drawingml/2006/main">
-            <a:off x="609600" y="381000"/>
-            <a:ext cx="10906125" cy="628650"/>
-          </a:xfrm>
-          <a:prstGeom xmlns:a="http://schemas.openxmlformats.org/drawingml/2006/main" prst="rect">
-            <a:avLst/>
-          </a:prstGeom>
-          <a:noFill xmlns:a="http://schemas.openxmlformats.org/drawingml/2006/main"/>
-          <a:ln xmlns:a="http://schemas.openxmlformats.org/drawingml/2006/main" w="0">
-            <a:noFill/>
-          </a:ln>
-        </p:spPr>
-        <p:txBody>
-          <a:bodyPr xmlns:a="http://schemas.openxmlformats.org/drawingml/2006/main" lIns="0" tIns="0" rIns="0" bIns="0"/>
-          <a:lstStyle xmlns:a="http://schemas.openxmlformats.org/drawingml/2006/main"/>
-          <a:p xmlns:a="http://schemas.openxmlformats.org/drawingml/2006/main">
-            <a:r>
-              <a:rPr sz="3150" b="1">
-                <a:solidFill>
-                  <a:srgbClr val="152D43"/>
-                </a:solidFill>
-                <a:latin typeface="Arial"/>
-                <a:ea typeface="Arial"/>
-                <a:cs typeface="Arial"/>
-              </a:rPr>
-              <a:t>Next: measure deadline behavior under jitter</a:t>
-            </a:r>
-          </a:p>
-        </p:txBody>
-      </p:sp>
-      <p:sp>
-        <p:nvSpPr>
-          <p:cNvPr id="2" name="">
-            <a:extLst xmlns:a="http://schemas.openxmlformats.org/drawingml/2006/main">
-              <a:ext uri="{FF2B5EF4-FFF2-40B4-BE49-F238E27FC236}">
-                <a16:creationId xmlns:a16="http://schemas.microsoft.com/office/drawing/2014/main" id="{7672AA85-BA9E-4405-96C5-5E002AFCDEF8}"/>
-              </a:ext>
-            </a:extLst>
-          </p:cNvPr>
-          <p:cNvSpPr>
-            <a:spLocks xmlns:a="http://schemas.openxmlformats.org/drawingml/2006/main" noGrp="1"/>
-          </p:cNvSpPr>
-          <p:nvPr/>
-        </p:nvSpPr>
-        <p:spPr>
-          <a:xfrm xmlns:a="http://schemas.openxmlformats.org/drawingml/2006/main">
-            <a:off x="609600" y="1162050"/>
-            <a:ext cx="10972800" cy="0"/>
-          </a:xfrm>
-          <a:prstGeom xmlns:a="http://schemas.openxmlformats.org/drawingml/2006/main" prst="line">
-            <a:avLst/>
-          </a:prstGeom>
-          <a:noFill xmlns:a="http://schemas.openxmlformats.org/drawingml/2006/main"/>
-          <a:ln xmlns:a="http://schemas.openxmlformats.org/drawingml/2006/main" w="9525">
-            <a:solidFill>
-              <a:srgbClr val="D7DFE5"/>
-            </a:solidFill>
-          </a:ln>
-        </p:spPr>
-      </p:sp>
-      <p:sp>
-        <p:nvSpPr>
-          <p:cNvPr id="3" name="">
-            <a:extLst xmlns:a="http://schemas.openxmlformats.org/drawingml/2006/main">
-              <a:ext uri="{FF2B5EF4-FFF2-40B4-BE49-F238E27FC236}">
-                <a16:creationId xmlns:a16="http://schemas.microsoft.com/office/drawing/2014/main" id="{DD409307-5C55-46DB-B7DD-5B787E395489}"/>
-              </a:ext>
-            </a:extLst>
-          </p:cNvPr>
-          <p:cNvSpPr>
-            <a:spLocks xmlns:a="http://schemas.openxmlformats.org/drawingml/2006/main" noGrp="1"/>
-          </p:cNvSpPr>
-          <p:nvPr/>
-        </p:nvSpPr>
-        <p:spPr>
-          <a:xfrm xmlns:a="http://schemas.openxmlformats.org/drawingml/2006/main">
-            <a:off x="11353800" y="6429375"/>
-            <a:ext cx="285750" cy="228600"/>
-          </a:xfrm>
-          <a:prstGeom xmlns:a="http://schemas.openxmlformats.org/drawingml/2006/main" prst="rect">
-            <a:avLst/>
-          </a:prstGeom>
-          <a:noFill xmlns:a="http://schemas.openxmlformats.org/drawingml/2006/main"/>
-          <a:ln xmlns:a="http://schemas.openxmlformats.org/drawingml/2006/main" w="0">
-            <a:noFill/>
-          </a:ln>
-        </p:spPr>
-        <p:txBody>
-          <a:bodyPr xmlns:a="http://schemas.openxmlformats.org/drawingml/2006/main" lIns="0" tIns="0" rIns="0" bIns="0"/>
-          <a:lstStyle xmlns:a="http://schemas.openxmlformats.org/drawingml/2006/main"/>
-          <a:p xmlns:a="http://schemas.openxmlformats.org/drawingml/2006/main">
-            <a:r>
-              <a:rPr sz="1275" b="0">
-                <a:solidFill>
-                  <a:srgbClr val="536675"/>
-                </a:solidFill>
-                <a:latin typeface="Arial"/>
-                <a:ea typeface="Arial"/>
-                <a:cs typeface="Arial"/>
-              </a:rPr>
-              <a:t>9</a:t>
-            </a:r>
-          </a:p>
-        </p:txBody>
-      </p:sp>
-      <p:sp>
-        <p:nvSpPr>
-          <p:cNvPr id="4" name="">
-            <a:extLst xmlns:a="http://schemas.openxmlformats.org/drawingml/2006/main">
-              <a:ext uri="{FF2B5EF4-FFF2-40B4-BE49-F238E27FC236}">
-                <a16:creationId xmlns:a16="http://schemas.microsoft.com/office/drawing/2014/main" id="{96E05C6B-EDD7-4C8A-A0BD-EDF5359F0685}"/>
+                <a16:creationId xmlns:a16="http://schemas.microsoft.com/office/drawing/2014/main" id="{839ED752-2FAE-4885-A5ED-BA7537F36560}"/>
               </a:ext>
             </a:extLst>
           </p:cNvPr>
@@ -11300,7 +9889,7 @@
           <p:cNvPr id="5" name="">
             <a:extLst xmlns:a="http://schemas.openxmlformats.org/drawingml/2006/main">
               <a:ext uri="{FF2B5EF4-FFF2-40B4-BE49-F238E27FC236}">
-                <a16:creationId xmlns:a16="http://schemas.microsoft.com/office/drawing/2014/main" id="{01F14804-78B2-494E-BC92-16E3A164BFF9}"/>
+                <a16:creationId xmlns:a16="http://schemas.microsoft.com/office/drawing/2014/main" id="{8FB8FD4C-1F0A-4F61-A3A4-AC47E705C42B}"/>
               </a:ext>
             </a:extLst>
           </p:cNvPr>
@@ -11345,7 +9934,7 @@
           <p:cNvPr id="6" name="">
             <a:extLst xmlns:a="http://schemas.openxmlformats.org/drawingml/2006/main">
               <a:ext uri="{FF2B5EF4-FFF2-40B4-BE49-F238E27FC236}">
-                <a16:creationId xmlns:a16="http://schemas.microsoft.com/office/drawing/2014/main" id="{26332308-6FF3-4049-BA00-66041711FDB3}"/>
+                <a16:creationId xmlns:a16="http://schemas.microsoft.com/office/drawing/2014/main" id="{BDEC2475-FD2A-4A2A-880A-2DC3F36F0720}"/>
               </a:ext>
             </a:extLst>
           </p:cNvPr>
@@ -11390,7 +9979,7 @@
           <p:cNvPr id="7" name="">
             <a:extLst xmlns:a="http://schemas.openxmlformats.org/drawingml/2006/main">
               <a:ext uri="{FF2B5EF4-FFF2-40B4-BE49-F238E27FC236}">
-                <a16:creationId xmlns:a16="http://schemas.microsoft.com/office/drawing/2014/main" id="{4E2D6B02-A981-4473-88DA-D712017B07FC}"/>
+                <a16:creationId xmlns:a16="http://schemas.microsoft.com/office/drawing/2014/main" id="{EB4507FE-7981-4F57-A6A0-08DA5FEC520E}"/>
               </a:ext>
             </a:extLst>
           </p:cNvPr>
@@ -11435,7 +10024,7 @@
           <p:cNvPr id="8" name="">
             <a:extLst xmlns:a="http://schemas.openxmlformats.org/drawingml/2006/main">
               <a:ext uri="{FF2B5EF4-FFF2-40B4-BE49-F238E27FC236}">
-                <a16:creationId xmlns:a16="http://schemas.microsoft.com/office/drawing/2014/main" id="{FDF60FD4-F107-4299-8040-179FEC0A0182}"/>
+                <a16:creationId xmlns:a16="http://schemas.microsoft.com/office/drawing/2014/main" id="{3030DE88-AA80-44AA-ABC0-A6C7E5B96EE8}"/>
               </a:ext>
             </a:extLst>
           </p:cNvPr>
@@ -11480,7 +10069,7 @@
           <p:cNvPr id="9" name="">
             <a:extLst xmlns:a="http://schemas.openxmlformats.org/drawingml/2006/main">
               <a:ext uri="{FF2B5EF4-FFF2-40B4-BE49-F238E27FC236}">
-                <a16:creationId xmlns:a16="http://schemas.microsoft.com/office/drawing/2014/main" id="{6F29AAA9-1CA3-4346-BEBA-A1AADF94360F}"/>
+                <a16:creationId xmlns:a16="http://schemas.microsoft.com/office/drawing/2014/main" id="{AC771EC7-3B38-43BA-8BBB-EAD1C0DB1877}"/>
               </a:ext>
             </a:extLst>
           </p:cNvPr>
@@ -11525,7 +10114,7 @@
           <p:cNvPr id="10" name="">
             <a:extLst xmlns:a="http://schemas.openxmlformats.org/drawingml/2006/main">
               <a:ext uri="{FF2B5EF4-FFF2-40B4-BE49-F238E27FC236}">
-                <a16:creationId xmlns:a16="http://schemas.microsoft.com/office/drawing/2014/main" id="{F14697C4-3C2E-4DC0-8DEE-0EFE18D2B9D8}"/>
+                <a16:creationId xmlns:a16="http://schemas.microsoft.com/office/drawing/2014/main" id="{2870A9DD-E898-4B76-A813-98BB0C554932}"/>
               </a:ext>
             </a:extLst>
           </p:cNvPr>
@@ -11570,7 +10159,7 @@
           <p:cNvPr id="11" name="">
             <a:extLst xmlns:a="http://schemas.openxmlformats.org/drawingml/2006/main">
               <a:ext uri="{FF2B5EF4-FFF2-40B4-BE49-F238E27FC236}">
-                <a16:creationId xmlns:a16="http://schemas.microsoft.com/office/drawing/2014/main" id="{C48ECCB3-9045-499D-9A24-9D752C1CA228}"/>
+                <a16:creationId xmlns:a16="http://schemas.microsoft.com/office/drawing/2014/main" id="{7F2E25F4-C0D7-4EAA-B73F-0CA3FFFE0C52}"/>
               </a:ext>
             </a:extLst>
           </p:cNvPr>
@@ -11615,7 +10204,7 @@
           <p:cNvPr id="12" name="">
             <a:extLst xmlns:a="http://schemas.openxmlformats.org/drawingml/2006/main">
               <a:ext uri="{FF2B5EF4-FFF2-40B4-BE49-F238E27FC236}">
-                <a16:creationId xmlns:a16="http://schemas.microsoft.com/office/drawing/2014/main" id="{0F517856-ED5F-4933-B1D5-4973CA97E1A6}"/>
+                <a16:creationId xmlns:a16="http://schemas.microsoft.com/office/drawing/2014/main" id="{414F6A07-370B-4EB0-938B-38372927B35D}"/>
               </a:ext>
             </a:extLst>
           </p:cNvPr>
@@ -11660,7 +10249,7 @@
           <p:cNvPr id="13" name="">
             <a:extLst xmlns:a="http://schemas.openxmlformats.org/drawingml/2006/main">
               <a:ext uri="{FF2B5EF4-FFF2-40B4-BE49-F238E27FC236}">
-                <a16:creationId xmlns:a16="http://schemas.microsoft.com/office/drawing/2014/main" id="{AD1D3B16-4456-46F4-8761-28DCD18AF82C}"/>
+                <a16:creationId xmlns:a16="http://schemas.microsoft.com/office/drawing/2014/main" id="{1BB1564C-B0BD-44F9-BEAA-30E6DF719FA0}"/>
               </a:ext>
             </a:extLst>
           </p:cNvPr>
@@ -11703,7 +10292,7 @@
     </p:spTree>
     <p:extLst>
       <p:ext uri="{BB962C8B-B14F-4D97-AF65-F5344CB8AC3E}">
-        <p14:creationId xmlns:p14="http://schemas.microsoft.com/office/powerpoint/2010/main" val="1824263573"/>
+        <p14:creationId xmlns:p14="http://schemas.microsoft.com/office/powerpoint/2010/main" val="844597229"/>
       </p:ext>
     </p:extLst>
   </p:cSld>

</xml_diff>

<commit_message>
Balance reconstruction diagrams and remove measurement scope slide
</commit_message>
<xml_diff>
--- a/presentations/weekly_20261029/weekly_20261029_english_30w.pptx
+++ b/presentations/weekly_20261029/weekly_20261029_english_30w.pptx
@@ -2,20 +2,19 @@
 <file path=ppt/presentation.xml><?xml version="1.0" encoding="utf-8"?>
 <p:presentation xmlns:p="http://schemas.openxmlformats.org/presentationml/2006/main">
   <p:sldMasterIdLst>
-    <p:sldMasterId xmlns:r="http://schemas.openxmlformats.org/officeDocument/2006/relationships" id="2147483648" r:id="R7ca1053cbf0c485f"/>
+    <p:sldMasterId xmlns:r="http://schemas.openxmlformats.org/officeDocument/2006/relationships" id="2147483648" r:id="R179de33e494740a5"/>
   </p:sldMasterIdLst>
   <p:notesMasterIdLst>
-    <p:notesMasterId xmlns:r="http://schemas.openxmlformats.org/officeDocument/2006/relationships" r:id="Rde2cca9fd979416c"/>
+    <p:notesMasterId xmlns:r="http://schemas.openxmlformats.org/officeDocument/2006/relationships" r:id="R0de4b637a0494807"/>
   </p:notesMasterIdLst>
   <p:sldIdLst>
-    <p:sldId xmlns:r="http://schemas.openxmlformats.org/officeDocument/2006/relationships" id="256" r:id="Rc44a82475b684fc6"/>
-    <p:sldId xmlns:r="http://schemas.openxmlformats.org/officeDocument/2006/relationships" id="257" r:id="Re391d4f25ddb4bba"/>
-    <p:sldId xmlns:r="http://schemas.openxmlformats.org/officeDocument/2006/relationships" id="258" r:id="Recac69d6359c4db1"/>
-    <p:sldId xmlns:r="http://schemas.openxmlformats.org/officeDocument/2006/relationships" id="259" r:id="R5b46e918a1164032"/>
-    <p:sldId xmlns:r="http://schemas.openxmlformats.org/officeDocument/2006/relationships" id="260" r:id="R158a05bf337b4ffd"/>
-    <p:sldId xmlns:r="http://schemas.openxmlformats.org/officeDocument/2006/relationships" id="261" r:id="Rda2e366a379d4fe3"/>
-    <p:sldId xmlns:r="http://schemas.openxmlformats.org/officeDocument/2006/relationships" id="262" r:id="R095801c8aa8e474b"/>
-    <p:sldId xmlns:r="http://schemas.openxmlformats.org/officeDocument/2006/relationships" id="263" r:id="R3b354d18e76c4f09"/>
+    <p:sldId xmlns:r="http://schemas.openxmlformats.org/officeDocument/2006/relationships" id="256" r:id="Rdca792a4d3d74194"/>
+    <p:sldId xmlns:r="http://schemas.openxmlformats.org/officeDocument/2006/relationships" id="257" r:id="R6c7ae1ac5d6445e7"/>
+    <p:sldId xmlns:r="http://schemas.openxmlformats.org/officeDocument/2006/relationships" id="258" r:id="R94c45fc12e234211"/>
+    <p:sldId xmlns:r="http://schemas.openxmlformats.org/officeDocument/2006/relationships" id="259" r:id="Re64d9e9c336b470c"/>
+    <p:sldId xmlns:r="http://schemas.openxmlformats.org/officeDocument/2006/relationships" id="260" r:id="R6921852ecdc54e61"/>
+    <p:sldId xmlns:r="http://schemas.openxmlformats.org/officeDocument/2006/relationships" id="261" r:id="Rb1bd142a39464acd"/>
+    <p:sldId xmlns:r="http://schemas.openxmlformats.org/officeDocument/2006/relationships" id="262" r:id="Rb2d53381a81a4f98"/>
   </p:sldIdLst>
   <p:sldSz cx="12192000" cy="6858000"/>
   <p:notesSz cx="6858000" cy="9144000"/>
@@ -729,7 +728,7 @@
           <a:lstStyle xmlns:a="http://schemas.openxmlformats.org/drawingml/2006/main"/>
           <a:p xmlns:a="http://schemas.openxmlformats.org/drawingml/2006/main">
             <a:r>
-              <a:t>Source: results/fov_levels_xavier_full_20261027/README.md; overview.csv; summary.csv. Commit 0f1506c. Date 2026-10-27. Raw evidence: evidence.tar.gz. Timing source: results/cu_breakdown_xavier_20261029/README.md and results/fov_decode_budget_2ms_20261029/summary.csv. Timing: 30W 4CORE mode5, unlocked clocks, four driving workloads each frame39, 10 warmups and 100 timed repetitions per path. Staged CUDA-event GPU timeline, not wall time; events can include launch gaps. Quality: previous 15W evaluation, 1068 valid forward odd frames, one quality output per configuration and frame. These are separate experiments, not jointly measured quality-latency pairs.</a:t>
+              <a:t>Sources: results/cu_breakdown_xavier_20261029/README.md; results/fov_decode_budget_2ms_20261029/summary.csv. Four workloads, each frame39; 10 warmups and 100 timed runs per path. Arithmetic means of staged resident GPU timelines, not wall time. Full uses the paired baseline from the 2.8% configuration. Fixed decode budget is 2 ms once per frame, not measured joint RGB/depth/flow decoding or measured end-to-end timing. No input/output copies, network or display. Fast resampling enabled. Clearing dominates Full and accounts for about 58% of the Full-to-2.8% reconstruction saving, so the gain cannot be attributed entirely to reduced reprojection computation. No claim of an optimal Full baseline.</a:t>
             </a:r>
           </a:p>
         </p:txBody>
@@ -799,7 +798,7 @@
           <a:lstStyle xmlns:a="http://schemas.openxmlformats.org/drawingml/2006/main"/>
           <a:p xmlns:a="http://schemas.openxmlformats.org/drawingml/2006/main">
             <a:r>
-              <a:t>Sources: results/cu_breakdown_xavier_20261029/README.md; results/fov_decode_budget_2ms_20261029/summary.csv. Four workloads, each frame39; 10 warmups and 100 timed runs per path. Arithmetic means of staged resident GPU timelines, not wall time. Full uses the paired baseline from the 2.8% configuration. Fixed decode budget is 2 ms once per frame, not measured joint RGB/depth/flow decoding or measured end-to-end timing. No input/output copies, network or display. Fast resampling enabled. Clearing dominates Full and accounts for about 58% of the Full-to-2.8% reconstruction saving, so the gain cannot be attributed entirely to reduced reprojection computation. No claim of an optimal Full baseline.</a:t>
+              <a:t>Source: results/fov_levels_xavier_full_20261027/README.md; overview.csv; summary.csv. Commit 0f1506c. Date 2026-10-27. Raw evidence: evidence.tar.gz. Original uint8-overflow PSNR preserved. Stereo delta is derived only if left eye remains unchanged and per-eye PSNR dB is averaged. Quality: 15W, 1068 frames. Timing: separate 30W four-frame CUDA staged GPU experiment; not joint measurements and no new quality equivalence verified. Timing is never divided by two. Latency adds a fixed 2 ms per-frame decode budget once, not measured decoding or end-to-end latency. Source: results/fov_decode_budget_2ms_20261029/summary.csv.</a:t>
             </a:r>
           </a:p>
         </p:txBody>
@@ -869,77 +868,7 @@
           <a:lstStyle xmlns:a="http://schemas.openxmlformats.org/drawingml/2006/main"/>
           <a:p xmlns:a="http://schemas.openxmlformats.org/drawingml/2006/main">
             <a:r>
-              <a:t>Source: results/fov_levels_xavier_full_20261027/README.md; overview.csv; summary.csv. Commit 0f1506c. Date 2026-10-27. Raw evidence: evidence.tar.gz. Original uint8-overflow PSNR preserved. Stereo delta is derived only if left eye remains unchanged and per-eye PSNR dB is averaged. Quality: 15W, 1068 frames. Timing: separate 30W four-frame CUDA staged GPU experiment; not joint measurements and no new quality equivalence verified. Timing is never divided by two. Latency adds a fixed 2 ms per-frame decode budget once, not measured decoding or end-to-end latency. Source: results/fov_decode_budget_2ms_20261029/summary.csv.</a:t>
-            </a:r>
-          </a:p>
-        </p:txBody>
-      </p:sp>
-      <p:sp>
-        <p:nvSpPr>
-          <p:cNvPr id="4" name="Slide Number Placeholder 3"/>
-          <p:cNvSpPr>
-            <a:spLocks xmlns:a="http://schemas.openxmlformats.org/drawingml/2006/main" noGrp="1"/>
-          </p:cNvSpPr>
-          <p:nvPr>
-            <p:ph type="sldNum" idx="5"/>
-          </p:nvPr>
-        </p:nvSpPr>
-        <p:spPr/>
-        <p:txBody>
-          <a:bodyPr xmlns:a="http://schemas.openxmlformats.org/drawingml/2006/main"/>
-          <a:lstStyle xmlns:a="http://schemas.openxmlformats.org/drawingml/2006/main"/>
-          <a:p xmlns:a="http://schemas.openxmlformats.org/drawingml/2006/main"/>
-        </p:txBody>
-      </p:sp>
-    </p:spTree>
-  </p:cSld>
-  <p:clrMapOvr>
-    <a:masterClrMapping xmlns:a="http://schemas.openxmlformats.org/drawingml/2006/main"/>
-  </p:clrMapOvr>
-</p:notes>
-</file>
-
-<file path=ppt/notesSlides/notesSlide8.xml><?xml version="1.0" encoding="utf-8"?>
-<p:notes xmlns:p="http://schemas.openxmlformats.org/presentationml/2006/main">
-  <p:cSld>
-    <p:spTree>
-      <p:nvGrpSpPr>
-        <p:cNvPr id="1" name=""/>
-        <p:cNvGrpSpPr/>
-        <p:nvPr/>
-      </p:nvGrpSpPr>
-      <p:grpSpPr>
-        <a:xfrm xmlns:a="http://schemas.openxmlformats.org/drawingml/2006/main"/>
-      </p:grpSpPr>
-      <p:sp>
-        <p:nvSpPr>
-          <p:cNvPr id="2" name="Slide Image Placeholder 1"/>
-          <p:cNvSpPr>
-            <a:spLocks xmlns:a="http://schemas.openxmlformats.org/drawingml/2006/main" noGrp="1"/>
-          </p:cNvSpPr>
-          <p:nvPr>
-            <p:ph type="sldImg" idx="0"/>
-          </p:nvPr>
-        </p:nvSpPr>
-        <p:spPr/>
-      </p:sp>
-      <p:sp>
-        <p:nvSpPr>
-          <p:cNvPr id="3" name="Notes Placeholder 2"/>
-          <p:cNvSpPr>
-            <a:spLocks xmlns:a="http://schemas.openxmlformats.org/drawingml/2006/main" noGrp="1"/>
-          </p:cNvSpPr>
-          <p:nvPr>
-            <p:ph type="body" idx="1"/>
-          </p:nvPr>
-        </p:nvSpPr>
-        <p:spPr/>
-        <p:txBody>
-          <a:bodyPr xmlns:a="http://schemas.openxmlformats.org/drawingml/2006/main"/>
-          <a:lstStyle xmlns:a="http://schemas.openxmlformats.org/drawingml/2006/main"/>
-          <a:p xmlns:a="http://schemas.openxmlformats.org/drawingml/2006/main">
-            <a:r>
-              <a:t>Proposed future work; no measured jitter trace or deadline-miss reduction exists in the current experiment. Slides 6–7 add a fixed 2 ms decode budget to local reconstruction means. Other timing values are local reconstruction measurements. None are measured end-to-end VR results.</a:t>
+              <a:t>Proposed future work; no measured jitter trace or deadline-miss reduction exists in the current experiment. Slides 5–6 add a fixed 2 ms decode budget to local reconstruction means. Other timing values are local reconstruction measurements. None are measured end-to-end VR results.</a:t>
             </a:r>
           </a:p>
         </p:txBody>
@@ -986,7 +915,7 @@
           <p:cNvPr id="3" name="Title">
             <a:extLst xmlns:a="http://schemas.openxmlformats.org/drawingml/2006/main">
               <a:ext uri="{FF2B5EF4-FFF2-40B4-BE49-F238E27FC236}">
-                <a16:creationId xmlns:a16="http://schemas.microsoft.com/office/drawing/2014/main" id="{9FEE180B-B391-4566-B228-D1E047002823}"/>
+                <a16:creationId xmlns:a16="http://schemas.microsoft.com/office/drawing/2014/main" id="{2B873602-1825-4C9F-89B4-348F67A143DD}"/>
               </a:ext>
             </a:extLst>
           </p:cNvPr>
@@ -1215,7 +1144,7 @@
           <p:cNvPr id="2" name="Subtitle">
             <a:extLst xmlns:a="http://schemas.openxmlformats.org/drawingml/2006/main">
               <a:ext uri="{FF2B5EF4-FFF2-40B4-BE49-F238E27FC236}">
-                <a16:creationId xmlns:a16="http://schemas.microsoft.com/office/drawing/2014/main" id="{951D5504-1335-4E57-B3C8-C1B0E480ACF5}"/>
+                <a16:creationId xmlns:a16="http://schemas.microsoft.com/office/drawing/2014/main" id="{FDB43B04-B2BF-4150-86BA-AD2F926508E1}"/>
               </a:ext>
             </a:extLst>
           </p:cNvPr>
@@ -1461,7 +1390,7 @@
           <p:cNvPr id="2" name="Section title">
             <a:extLst xmlns:a="http://schemas.openxmlformats.org/drawingml/2006/main">
               <a:ext uri="{FF2B5EF4-FFF2-40B4-BE49-F238E27FC236}">
-                <a16:creationId xmlns:a16="http://schemas.microsoft.com/office/drawing/2014/main" id="{6DB74584-9611-4101-98B6-85A7848539A9}"/>
+                <a16:creationId xmlns:a16="http://schemas.microsoft.com/office/drawing/2014/main" id="{07304056-3C4A-42F0-9154-D26D831FA37F}"/>
               </a:ext>
             </a:extLst>
           </p:cNvPr>
@@ -1707,7 +1636,7 @@
           <p:cNvPr id="3" name="Title">
             <a:extLst xmlns:a="http://schemas.openxmlformats.org/drawingml/2006/main">
               <a:ext uri="{FF2B5EF4-FFF2-40B4-BE49-F238E27FC236}">
-                <a16:creationId xmlns:a16="http://schemas.microsoft.com/office/drawing/2014/main" id="{664199E0-B7F2-4DB6-AFC4-ECA2793DE071}"/>
+                <a16:creationId xmlns:a16="http://schemas.microsoft.com/office/drawing/2014/main" id="{746F2F85-032D-418F-8FF6-CB247A4A3586}"/>
               </a:ext>
             </a:extLst>
           </p:cNvPr>
@@ -1936,7 +1865,7 @@
           <p:cNvPr id="2" name="Body">
             <a:extLst xmlns:a="http://schemas.openxmlformats.org/drawingml/2006/main">
               <a:ext uri="{FF2B5EF4-FFF2-40B4-BE49-F238E27FC236}">
-                <a16:creationId xmlns:a16="http://schemas.microsoft.com/office/drawing/2014/main" id="{55D6F6FE-A9BA-4DAC-8EAD-90FA03099A33}"/>
+                <a16:creationId xmlns:a16="http://schemas.microsoft.com/office/drawing/2014/main" id="{575C660E-DC4A-4D2D-9454-10B999B867D4}"/>
               </a:ext>
             </a:extLst>
           </p:cNvPr>
@@ -2182,7 +2111,7 @@
           <p:cNvPr id="4" name="Title">
             <a:extLst xmlns:a="http://schemas.openxmlformats.org/drawingml/2006/main">
               <a:ext uri="{FF2B5EF4-FFF2-40B4-BE49-F238E27FC236}">
-                <a16:creationId xmlns:a16="http://schemas.microsoft.com/office/drawing/2014/main" id="{3484D47D-1E5D-4F41-9C39-4DEAB53DC7B9}"/>
+                <a16:creationId xmlns:a16="http://schemas.microsoft.com/office/drawing/2014/main" id="{4CDC0EFB-33C8-4675-824E-5713C8E462E5}"/>
               </a:ext>
             </a:extLst>
           </p:cNvPr>
@@ -2411,7 +2340,7 @@
           <p:cNvPr id="2" name="Left column">
             <a:extLst xmlns:a="http://schemas.openxmlformats.org/drawingml/2006/main">
               <a:ext uri="{FF2B5EF4-FFF2-40B4-BE49-F238E27FC236}">
-                <a16:creationId xmlns:a16="http://schemas.microsoft.com/office/drawing/2014/main" id="{C707FB4C-70BE-4CB6-96D0-9FE41028427E}"/>
+                <a16:creationId xmlns:a16="http://schemas.microsoft.com/office/drawing/2014/main" id="{ABDEF5BD-D96D-4E3C-9041-36AC92BAB0C4}"/>
               </a:ext>
             </a:extLst>
           </p:cNvPr>
@@ -2640,7 +2569,7 @@
           <p:cNvPr id="3" name="Right column">
             <a:extLst xmlns:a="http://schemas.openxmlformats.org/drawingml/2006/main">
               <a:ext uri="{FF2B5EF4-FFF2-40B4-BE49-F238E27FC236}">
-                <a16:creationId xmlns:a16="http://schemas.microsoft.com/office/drawing/2014/main" id="{BF24391E-9A9A-4004-AECC-7A5BAEB90E50}"/>
+                <a16:creationId xmlns:a16="http://schemas.microsoft.com/office/drawing/2014/main" id="{42695DE9-0F6C-42AB-B76C-CA2651021B19}"/>
               </a:ext>
             </a:extLst>
           </p:cNvPr>
@@ -2886,7 +2815,7 @@
           <p:cNvPr id="3" name="Title">
             <a:extLst xmlns:a="http://schemas.openxmlformats.org/drawingml/2006/main">
               <a:ext uri="{FF2B5EF4-FFF2-40B4-BE49-F238E27FC236}">
-                <a16:creationId xmlns:a16="http://schemas.microsoft.com/office/drawing/2014/main" id="{68E062D7-29BF-4D64-899A-3E9C73ABE2B5}"/>
+                <a16:creationId xmlns:a16="http://schemas.microsoft.com/office/drawing/2014/main" id="{A0EB5180-5B59-4F37-BE8F-B87E585B6CC4}"/>
               </a:ext>
             </a:extLst>
           </p:cNvPr>
@@ -3115,7 +3044,7 @@
           <p:cNvPr id="2" name="Left column">
             <a:extLst xmlns:a="http://schemas.openxmlformats.org/drawingml/2006/main">
               <a:ext uri="{FF2B5EF4-FFF2-40B4-BE49-F238E27FC236}">
-                <a16:creationId xmlns:a16="http://schemas.microsoft.com/office/drawing/2014/main" id="{2B3C3C8F-20C3-4776-8576-5E1973D9C271}"/>
+                <a16:creationId xmlns:a16="http://schemas.microsoft.com/office/drawing/2014/main" id="{FD8E5EC7-2F77-4ED2-BDFE-FDBDF54FADA9}"/>
               </a:ext>
             </a:extLst>
           </p:cNvPr>
@@ -3382,12 +3311,12 @@
   </p:cSld>
   <p:clrMap bg1="lt1" tx1="dk1" bg2="lt2" tx2="dk2" accent1="accent1" accent2="accent2" accent3="accent3" accent4="accent4" accent5="accent5" accent6="accent6" hlink="hlink" folHlink="folHlink"/>
   <p:sldLayoutIdLst>
-    <p:sldLayoutId xmlns:r="http://schemas.openxmlformats.org/officeDocument/2006/relationships" id="2147483649" r:id="Rf13116748e6548c0"/>
-    <p:sldLayoutId xmlns:r="http://schemas.openxmlformats.org/officeDocument/2006/relationships" id="2147483650" r:id="Rad1425ba87424009"/>
-    <p:sldLayoutId xmlns:r="http://schemas.openxmlformats.org/officeDocument/2006/relationships" id="2147483651" r:id="R3fb2548c22854566"/>
-    <p:sldLayoutId xmlns:r="http://schemas.openxmlformats.org/officeDocument/2006/relationships" id="2147483652" r:id="Ra6657312b3214369"/>
-    <p:sldLayoutId xmlns:r="http://schemas.openxmlformats.org/officeDocument/2006/relationships" id="2147483653" r:id="R4dcaf2e14cb44152"/>
-    <p:sldLayoutId xmlns:r="http://schemas.openxmlformats.org/officeDocument/2006/relationships" id="2147483654" r:id="Re59bd741f9e343e0"/>
+    <p:sldLayoutId xmlns:r="http://schemas.openxmlformats.org/officeDocument/2006/relationships" id="2147483649" r:id="R72a625dab0af494a"/>
+    <p:sldLayoutId xmlns:r="http://schemas.openxmlformats.org/officeDocument/2006/relationships" id="2147483650" r:id="Rd82813bafa7d4ac4"/>
+    <p:sldLayoutId xmlns:r="http://schemas.openxmlformats.org/officeDocument/2006/relationships" id="2147483651" r:id="R3ce94574400545e7"/>
+    <p:sldLayoutId xmlns:r="http://schemas.openxmlformats.org/officeDocument/2006/relationships" id="2147483652" r:id="Rebca27cfd7ae4322"/>
+    <p:sldLayoutId xmlns:r="http://schemas.openxmlformats.org/officeDocument/2006/relationships" id="2147483653" r:id="R61bdae2f7e984c52"/>
+    <p:sldLayoutId xmlns:r="http://schemas.openxmlformats.org/officeDocument/2006/relationships" id="2147483654" r:id="R95aab2068dac4af1"/>
   </p:sldLayoutIdLst>
   <p:txStyles>
     <p:titleStyle>
@@ -4259,7 +4188,7 @@
           <p:cNvPr id="5" name="">
             <a:extLst xmlns:a="http://schemas.openxmlformats.org/drawingml/2006/main">
               <a:ext uri="{FF2B5EF4-FFF2-40B4-BE49-F238E27FC236}">
-                <a16:creationId xmlns:a16="http://schemas.microsoft.com/office/drawing/2014/main" id="{D3AC35FD-4B7A-4808-9C27-08FD8D2BA0C4}"/>
+                <a16:creationId xmlns:a16="http://schemas.microsoft.com/office/drawing/2014/main" id="{7B329841-71F3-45D8-A5A2-5BFED7BE92E1}"/>
               </a:ext>
             </a:extLst>
           </p:cNvPr>
@@ -4317,7 +4246,7 @@
           <p:cNvPr id="2" name="">
             <a:extLst xmlns:a="http://schemas.openxmlformats.org/drawingml/2006/main">
               <a:ext uri="{FF2B5EF4-FFF2-40B4-BE49-F238E27FC236}">
-                <a16:creationId xmlns:a16="http://schemas.microsoft.com/office/drawing/2014/main" id="{21B3FB4B-F0FF-42E5-B558-758DC6360645}"/>
+                <a16:creationId xmlns:a16="http://schemas.microsoft.com/office/drawing/2014/main" id="{6EF72B89-AD12-43CF-A3D2-857E6E49EB85}"/>
               </a:ext>
             </a:extLst>
           </p:cNvPr>
@@ -4362,7 +4291,7 @@
           <p:cNvPr id="3" name="">
             <a:extLst xmlns:a="http://schemas.openxmlformats.org/drawingml/2006/main">
               <a:ext uri="{FF2B5EF4-FFF2-40B4-BE49-F238E27FC236}">
-                <a16:creationId xmlns:a16="http://schemas.microsoft.com/office/drawing/2014/main" id="{BA478614-551E-40A4-9C4C-83C8A749492A}"/>
+                <a16:creationId xmlns:a16="http://schemas.microsoft.com/office/drawing/2014/main" id="{BF2443F8-A1D6-4F14-B9ED-291E65E4D580}"/>
               </a:ext>
             </a:extLst>
           </p:cNvPr>
@@ -4407,7 +4336,7 @@
           <p:cNvPr id="4" name="">
             <a:extLst xmlns:a="http://schemas.openxmlformats.org/drawingml/2006/main">
               <a:ext uri="{FF2B5EF4-FFF2-40B4-BE49-F238E27FC236}">
-                <a16:creationId xmlns:a16="http://schemas.microsoft.com/office/drawing/2014/main" id="{7EC87427-EAF5-4E74-B91C-311D31F039B8}"/>
+                <a16:creationId xmlns:a16="http://schemas.microsoft.com/office/drawing/2014/main" id="{3144CD67-3E22-4238-BC7D-D7E1D8EFD421}"/>
               </a:ext>
             </a:extLst>
           </p:cNvPr>
@@ -4450,7 +4379,7 @@
     </p:spTree>
     <p:extLst>
       <p:ext uri="{BB962C8B-B14F-4D97-AF65-F5344CB8AC3E}">
-        <p14:creationId xmlns:p14="http://schemas.microsoft.com/office/powerpoint/2010/main" val="293171933"/>
+        <p14:creationId xmlns:p14="http://schemas.microsoft.com/office/powerpoint/2010/main" val="498036716"/>
       </p:ext>
     </p:extLst>
   </p:cSld>
@@ -4481,7 +4410,7 @@
           <p:cNvPr id="29" name="">
             <a:extLst xmlns:a="http://schemas.openxmlformats.org/drawingml/2006/main">
               <a:ext uri="{FF2B5EF4-FFF2-40B4-BE49-F238E27FC236}">
-                <a16:creationId xmlns:a16="http://schemas.microsoft.com/office/drawing/2014/main" id="{AD8FA9BA-C557-485C-863F-9E4BD7C6FE90}"/>
+                <a16:creationId xmlns:a16="http://schemas.microsoft.com/office/drawing/2014/main" id="{A3374315-5E62-4846-91D2-373249F6BD27}"/>
               </a:ext>
             </a:extLst>
           </p:cNvPr>
@@ -4526,7 +4455,7 @@
           <p:cNvPr id="2" name="">
             <a:extLst xmlns:a="http://schemas.openxmlformats.org/drawingml/2006/main">
               <a:ext uri="{FF2B5EF4-FFF2-40B4-BE49-F238E27FC236}">
-                <a16:creationId xmlns:a16="http://schemas.microsoft.com/office/drawing/2014/main" id="{C4AE0170-D966-4095-B886-0226A2355A64}"/>
+                <a16:creationId xmlns:a16="http://schemas.microsoft.com/office/drawing/2014/main" id="{335B14F7-50B1-4C94-9233-B0626B51A5B7}"/>
               </a:ext>
             </a:extLst>
           </p:cNvPr>
@@ -4556,7 +4485,7 @@
           <p:cNvPr id="3" name="">
             <a:extLst xmlns:a="http://schemas.openxmlformats.org/drawingml/2006/main">
               <a:ext uri="{FF2B5EF4-FFF2-40B4-BE49-F238E27FC236}">
-                <a16:creationId xmlns:a16="http://schemas.microsoft.com/office/drawing/2014/main" id="{56596B46-E5E5-4196-B3DF-D5421114F456}"/>
+                <a16:creationId xmlns:a16="http://schemas.microsoft.com/office/drawing/2014/main" id="{B197A882-C7C7-4194-8B62-BC075CC1E85D}"/>
               </a:ext>
             </a:extLst>
           </p:cNvPr>
@@ -4601,7 +4530,7 @@
           <p:cNvPr id="4" name="">
             <a:extLst xmlns:a="http://schemas.openxmlformats.org/drawingml/2006/main">
               <a:ext uri="{FF2B5EF4-FFF2-40B4-BE49-F238E27FC236}">
-                <a16:creationId xmlns:a16="http://schemas.microsoft.com/office/drawing/2014/main" id="{B7540364-42D7-406D-8E0E-6990929CEFC2}"/>
+                <a16:creationId xmlns:a16="http://schemas.microsoft.com/office/drawing/2014/main" id="{11A207DC-3B7D-48E8-89B6-C83C24F34AA0}"/>
               </a:ext>
             </a:extLst>
           </p:cNvPr>
@@ -4646,7 +4575,7 @@
           <p:cNvPr id="5" name="">
             <a:extLst xmlns:a="http://schemas.openxmlformats.org/drawingml/2006/main">
               <a:ext uri="{FF2B5EF4-FFF2-40B4-BE49-F238E27FC236}">
-                <a16:creationId xmlns:a16="http://schemas.microsoft.com/office/drawing/2014/main" id="{D93EADF1-E3D4-418C-BA16-0342278335C5}"/>
+                <a16:creationId xmlns:a16="http://schemas.microsoft.com/office/drawing/2014/main" id="{A2C23E07-BB3D-4466-9E98-446A3BB83CFF}"/>
               </a:ext>
             </a:extLst>
           </p:cNvPr>
@@ -4691,7 +4620,7 @@
           <p:cNvPr id="6" name="">
             <a:extLst xmlns:a="http://schemas.openxmlformats.org/drawingml/2006/main">
               <a:ext uri="{FF2B5EF4-FFF2-40B4-BE49-F238E27FC236}">
-                <a16:creationId xmlns:a16="http://schemas.microsoft.com/office/drawing/2014/main" id="{B541D8E6-3EBF-4A77-AA35-638F27D55611}"/>
+                <a16:creationId xmlns:a16="http://schemas.microsoft.com/office/drawing/2014/main" id="{28E01DD5-19A3-4F94-9DF1-5A66BC8D1A8E}"/>
               </a:ext>
             </a:extLst>
           </p:cNvPr>
@@ -4723,7 +4652,7 @@
           <p:cNvPr id="7" name="">
             <a:extLst xmlns:a="http://schemas.openxmlformats.org/drawingml/2006/main">
               <a:ext uri="{FF2B5EF4-FFF2-40B4-BE49-F238E27FC236}">
-                <a16:creationId xmlns:a16="http://schemas.microsoft.com/office/drawing/2014/main" id="{A24B6D2B-3FA7-4708-B8B7-7FC2A10204DA}"/>
+                <a16:creationId xmlns:a16="http://schemas.microsoft.com/office/drawing/2014/main" id="{8FCCEB64-880B-4EAC-B06B-82E405170BF4}"/>
               </a:ext>
             </a:extLst>
           </p:cNvPr>
@@ -4755,7 +4684,7 @@
           <p:cNvPr id="8" name="">
             <a:extLst xmlns:a="http://schemas.openxmlformats.org/drawingml/2006/main">
               <a:ext uri="{FF2B5EF4-FFF2-40B4-BE49-F238E27FC236}">
-                <a16:creationId xmlns:a16="http://schemas.microsoft.com/office/drawing/2014/main" id="{75A00B2D-FC9F-4EED-821F-18DC9D38372D}"/>
+                <a16:creationId xmlns:a16="http://schemas.microsoft.com/office/drawing/2014/main" id="{8785A3DB-6F13-458E-B129-B864948F3EA4}"/>
               </a:ext>
             </a:extLst>
           </p:cNvPr>
@@ -4787,7 +4716,7 @@
           <p:cNvPr id="9" name="">
             <a:extLst xmlns:a="http://schemas.openxmlformats.org/drawingml/2006/main">
               <a:ext uri="{FF2B5EF4-FFF2-40B4-BE49-F238E27FC236}">
-                <a16:creationId xmlns:a16="http://schemas.microsoft.com/office/drawing/2014/main" id="{EB0D189D-4CA2-45CA-B3BC-110853409893}"/>
+                <a16:creationId xmlns:a16="http://schemas.microsoft.com/office/drawing/2014/main" id="{EA1AAAAE-B75D-44EB-B6A5-353C240C3ED9}"/>
               </a:ext>
             </a:extLst>
           </p:cNvPr>
@@ -4832,7 +4761,7 @@
           <p:cNvPr id="10" name="">
             <a:extLst xmlns:a="http://schemas.openxmlformats.org/drawingml/2006/main">
               <a:ext uri="{FF2B5EF4-FFF2-40B4-BE49-F238E27FC236}">
-                <a16:creationId xmlns:a16="http://schemas.microsoft.com/office/drawing/2014/main" id="{D6FAFB12-9041-40CE-8FE2-1F1A96B967A6}"/>
+                <a16:creationId xmlns:a16="http://schemas.microsoft.com/office/drawing/2014/main" id="{B88A9E18-6631-4B7C-B186-47EC6A6D5C2F}"/>
               </a:ext>
             </a:extLst>
           </p:cNvPr>
@@ -4862,7 +4791,7 @@
           <p:cNvPr id="11" name="">
             <a:extLst xmlns:a="http://schemas.openxmlformats.org/drawingml/2006/main">
               <a:ext uri="{FF2B5EF4-FFF2-40B4-BE49-F238E27FC236}">
-                <a16:creationId xmlns:a16="http://schemas.microsoft.com/office/drawing/2014/main" id="{F35D49DE-3FC1-4963-BD13-79383AFBC6EA}"/>
+                <a16:creationId xmlns:a16="http://schemas.microsoft.com/office/drawing/2014/main" id="{C3281893-1F6F-491C-B0E1-910C5EF5686D}"/>
               </a:ext>
             </a:extLst>
           </p:cNvPr>
@@ -4907,7 +4836,7 @@
           <p:cNvPr id="12" name="">
             <a:extLst xmlns:a="http://schemas.openxmlformats.org/drawingml/2006/main">
               <a:ext uri="{FF2B5EF4-FFF2-40B4-BE49-F238E27FC236}">
-                <a16:creationId xmlns:a16="http://schemas.microsoft.com/office/drawing/2014/main" id="{31F43E90-0D70-42ED-B4D3-6D269D9D26E3}"/>
+                <a16:creationId xmlns:a16="http://schemas.microsoft.com/office/drawing/2014/main" id="{112DE810-0C11-4813-A48F-AFA37215893B}"/>
               </a:ext>
             </a:extLst>
           </p:cNvPr>
@@ -4939,7 +4868,7 @@
           <p:cNvPr id="13" name="">
             <a:extLst xmlns:a="http://schemas.openxmlformats.org/drawingml/2006/main">
               <a:ext uri="{FF2B5EF4-FFF2-40B4-BE49-F238E27FC236}">
-                <a16:creationId xmlns:a16="http://schemas.microsoft.com/office/drawing/2014/main" id="{D66E8372-9D83-410B-BD78-E3590AF68F5D}"/>
+                <a16:creationId xmlns:a16="http://schemas.microsoft.com/office/drawing/2014/main" id="{337180D7-7780-4E81-84DB-375B3A3065A3}"/>
               </a:ext>
             </a:extLst>
           </p:cNvPr>
@@ -4971,7 +4900,7 @@
           <p:cNvPr id="14" name="">
             <a:extLst xmlns:a="http://schemas.openxmlformats.org/drawingml/2006/main">
               <a:ext uri="{FF2B5EF4-FFF2-40B4-BE49-F238E27FC236}">
-                <a16:creationId xmlns:a16="http://schemas.microsoft.com/office/drawing/2014/main" id="{329C7A1A-15E0-423D-9372-92B7F73C852B}"/>
+                <a16:creationId xmlns:a16="http://schemas.microsoft.com/office/drawing/2014/main" id="{89EBDC18-0475-4C64-A4D1-F3A8F9994A94}"/>
               </a:ext>
             </a:extLst>
           </p:cNvPr>
@@ -5003,7 +4932,7 @@
           <p:cNvPr id="15" name="">
             <a:extLst xmlns:a="http://schemas.openxmlformats.org/drawingml/2006/main">
               <a:ext uri="{FF2B5EF4-FFF2-40B4-BE49-F238E27FC236}">
-                <a16:creationId xmlns:a16="http://schemas.microsoft.com/office/drawing/2014/main" id="{CACCA813-F062-44AA-B921-6CDB667F05E5}"/>
+                <a16:creationId xmlns:a16="http://schemas.microsoft.com/office/drawing/2014/main" id="{874A7636-527B-4300-B2F4-0BC2FD27A381}"/>
               </a:ext>
             </a:extLst>
           </p:cNvPr>
@@ -5048,7 +4977,7 @@
           <p:cNvPr id="16" name="">
             <a:extLst xmlns:a="http://schemas.openxmlformats.org/drawingml/2006/main">
               <a:ext uri="{FF2B5EF4-FFF2-40B4-BE49-F238E27FC236}">
-                <a16:creationId xmlns:a16="http://schemas.microsoft.com/office/drawing/2014/main" id="{4F6FB8BE-1FAF-4CA7-8E53-3C71FE676EB1}"/>
+                <a16:creationId xmlns:a16="http://schemas.microsoft.com/office/drawing/2014/main" id="{2D3F4508-6E20-404D-8B4E-DCD0A5840A14}"/>
               </a:ext>
             </a:extLst>
           </p:cNvPr>
@@ -5078,7 +5007,7 @@
           <p:cNvPr id="17" name="">
             <a:extLst xmlns:a="http://schemas.openxmlformats.org/drawingml/2006/main">
               <a:ext uri="{FF2B5EF4-FFF2-40B4-BE49-F238E27FC236}">
-                <a16:creationId xmlns:a16="http://schemas.microsoft.com/office/drawing/2014/main" id="{79B8B42B-D9CD-401D-8820-B7C9D6D15021}"/>
+                <a16:creationId xmlns:a16="http://schemas.microsoft.com/office/drawing/2014/main" id="{51C216B4-5F4B-4ECE-9B98-BE8B4814E2EE}"/>
               </a:ext>
             </a:extLst>
           </p:cNvPr>
@@ -5123,7 +5052,7 @@
           <p:cNvPr id="18" name="">
             <a:extLst xmlns:a="http://schemas.openxmlformats.org/drawingml/2006/main">
               <a:ext uri="{FF2B5EF4-FFF2-40B4-BE49-F238E27FC236}">
-                <a16:creationId xmlns:a16="http://schemas.microsoft.com/office/drawing/2014/main" id="{592C2AF6-43F4-4F05-8CB5-C372720D787A}"/>
+                <a16:creationId xmlns:a16="http://schemas.microsoft.com/office/drawing/2014/main" id="{F617FD9F-8FD9-4F94-9FB0-96DC55904C8C}"/>
               </a:ext>
             </a:extLst>
           </p:cNvPr>
@@ -5155,7 +5084,7 @@
           <p:cNvPr id="19" name="">
             <a:extLst xmlns:a="http://schemas.openxmlformats.org/drawingml/2006/main">
               <a:ext uri="{FF2B5EF4-FFF2-40B4-BE49-F238E27FC236}">
-                <a16:creationId xmlns:a16="http://schemas.microsoft.com/office/drawing/2014/main" id="{FE806FD0-9AE0-42B5-AB9B-BA3CA9867CCE}"/>
+                <a16:creationId xmlns:a16="http://schemas.microsoft.com/office/drawing/2014/main" id="{A64B526B-600B-401F-A256-9118E187A69D}"/>
               </a:ext>
             </a:extLst>
           </p:cNvPr>
@@ -5187,7 +5116,7 @@
           <p:cNvPr id="20" name="">
             <a:extLst xmlns:a="http://schemas.openxmlformats.org/drawingml/2006/main">
               <a:ext uri="{FF2B5EF4-FFF2-40B4-BE49-F238E27FC236}">
-                <a16:creationId xmlns:a16="http://schemas.microsoft.com/office/drawing/2014/main" id="{E4568A97-AD65-459C-88E8-9736E3451974}"/>
+                <a16:creationId xmlns:a16="http://schemas.microsoft.com/office/drawing/2014/main" id="{DD9E5178-FAA3-4886-9570-989CD76FB969}"/>
               </a:ext>
             </a:extLst>
           </p:cNvPr>
@@ -5219,7 +5148,7 @@
           <p:cNvPr id="21" name="">
             <a:extLst xmlns:a="http://schemas.openxmlformats.org/drawingml/2006/main">
               <a:ext uri="{FF2B5EF4-FFF2-40B4-BE49-F238E27FC236}">
-                <a16:creationId xmlns:a16="http://schemas.microsoft.com/office/drawing/2014/main" id="{234A82CF-F4EF-4814-8645-BA109DE93118}"/>
+                <a16:creationId xmlns:a16="http://schemas.microsoft.com/office/drawing/2014/main" id="{6B6006C2-B8F4-411C-8564-6FAD320329FA}"/>
               </a:ext>
             </a:extLst>
           </p:cNvPr>
@@ -5264,7 +5193,7 @@
           <p:cNvPr id="22" name="">
             <a:extLst xmlns:a="http://schemas.openxmlformats.org/drawingml/2006/main">
               <a:ext uri="{FF2B5EF4-FFF2-40B4-BE49-F238E27FC236}">
-                <a16:creationId xmlns:a16="http://schemas.microsoft.com/office/drawing/2014/main" id="{A6DA4740-6DD5-438A-BA78-080B7B2871BF}"/>
+                <a16:creationId xmlns:a16="http://schemas.microsoft.com/office/drawing/2014/main" id="{1876054E-77DF-4268-AC39-A83F0EAA506A}"/>
               </a:ext>
             </a:extLst>
           </p:cNvPr>
@@ -5294,7 +5223,7 @@
           <p:cNvPr id="23" name="">
             <a:extLst xmlns:a="http://schemas.openxmlformats.org/drawingml/2006/main">
               <a:ext uri="{FF2B5EF4-FFF2-40B4-BE49-F238E27FC236}">
-                <a16:creationId xmlns:a16="http://schemas.microsoft.com/office/drawing/2014/main" id="{3CDAE90E-9F00-4CA8-B816-9137592620C1}"/>
+                <a16:creationId xmlns:a16="http://schemas.microsoft.com/office/drawing/2014/main" id="{B6DC4478-DF8D-494F-A7EF-C248D10401CE}"/>
               </a:ext>
             </a:extLst>
           </p:cNvPr>
@@ -5324,7 +5253,7 @@
           <p:cNvPr id="24" name="">
             <a:extLst xmlns:a="http://schemas.openxmlformats.org/drawingml/2006/main">
               <a:ext uri="{FF2B5EF4-FFF2-40B4-BE49-F238E27FC236}">
-                <a16:creationId xmlns:a16="http://schemas.microsoft.com/office/drawing/2014/main" id="{73F6C8AD-4EEE-4173-A633-5C709E7504AF}"/>
+                <a16:creationId xmlns:a16="http://schemas.microsoft.com/office/drawing/2014/main" id="{335CBA70-DD47-4D17-B41B-7BC78208F659}"/>
               </a:ext>
             </a:extLst>
           </p:cNvPr>
@@ -5369,7 +5298,7 @@
           <p:cNvPr id="25" name="">
             <a:extLst xmlns:a="http://schemas.openxmlformats.org/drawingml/2006/main">
               <a:ext uri="{FF2B5EF4-FFF2-40B4-BE49-F238E27FC236}">
-                <a16:creationId xmlns:a16="http://schemas.microsoft.com/office/drawing/2014/main" id="{6293FBF7-3991-4348-B208-61597910F068}"/>
+                <a16:creationId xmlns:a16="http://schemas.microsoft.com/office/drawing/2014/main" id="{A3291467-25B4-4F59-99D4-DE69D47ABA0C}"/>
               </a:ext>
             </a:extLst>
           </p:cNvPr>
@@ -5414,7 +5343,7 @@
           <p:cNvPr id="26" name="">
             <a:extLst xmlns:a="http://schemas.openxmlformats.org/drawingml/2006/main">
               <a:ext uri="{FF2B5EF4-FFF2-40B4-BE49-F238E27FC236}">
-                <a16:creationId xmlns:a16="http://schemas.microsoft.com/office/drawing/2014/main" id="{008CD56A-B1CA-4448-A649-5CAF8ECD9CF5}"/>
+                <a16:creationId xmlns:a16="http://schemas.microsoft.com/office/drawing/2014/main" id="{5E374B4D-4E1E-4370-A018-4675F5C906F2}"/>
               </a:ext>
             </a:extLst>
           </p:cNvPr>
@@ -5459,7 +5388,7 @@
           <p:cNvPr id="27" name="">
             <a:extLst xmlns:a="http://schemas.openxmlformats.org/drawingml/2006/main">
               <a:ext uri="{FF2B5EF4-FFF2-40B4-BE49-F238E27FC236}">
-                <a16:creationId xmlns:a16="http://schemas.microsoft.com/office/drawing/2014/main" id="{A15931AA-CA09-4172-9590-BC2732046666}"/>
+                <a16:creationId xmlns:a16="http://schemas.microsoft.com/office/drawing/2014/main" id="{F5245022-2F24-4EA5-A4EF-60B65847FF00}"/>
               </a:ext>
             </a:extLst>
           </p:cNvPr>
@@ -5504,7 +5433,7 @@
           <p:cNvPr id="28" name="">
             <a:extLst xmlns:a="http://schemas.openxmlformats.org/drawingml/2006/main">
               <a:ext uri="{FF2B5EF4-FFF2-40B4-BE49-F238E27FC236}">
-                <a16:creationId xmlns:a16="http://schemas.microsoft.com/office/drawing/2014/main" id="{BBC1D921-351D-4333-823D-70CF2BB502CA}"/>
+                <a16:creationId xmlns:a16="http://schemas.microsoft.com/office/drawing/2014/main" id="{74D56FB4-12B3-4DA5-AB16-18FEFDDF4A6B}"/>
               </a:ext>
             </a:extLst>
           </p:cNvPr>
@@ -5547,7 +5476,7 @@
     </p:spTree>
     <p:extLst>
       <p:ext uri="{BB962C8B-B14F-4D97-AF65-F5344CB8AC3E}">
-        <p14:creationId xmlns:p14="http://schemas.microsoft.com/office/powerpoint/2010/main" val="1281607458"/>
+        <p14:creationId xmlns:p14="http://schemas.microsoft.com/office/powerpoint/2010/main" val="1832760697"/>
       </p:ext>
     </p:extLst>
   </p:cSld>
@@ -5578,7 +5507,7 @@
           <p:cNvPr id="15" name="">
             <a:extLst xmlns:a="http://schemas.openxmlformats.org/drawingml/2006/main">
               <a:ext uri="{FF2B5EF4-FFF2-40B4-BE49-F238E27FC236}">
-                <a16:creationId xmlns:a16="http://schemas.microsoft.com/office/drawing/2014/main" id="{A4C5F1E0-D8E0-437D-A671-9EE943966AED}"/>
+                <a16:creationId xmlns:a16="http://schemas.microsoft.com/office/drawing/2014/main" id="{2209CFF3-E307-4319-9953-EC9EFA8A0F89}"/>
               </a:ext>
             </a:extLst>
           </p:cNvPr>
@@ -5623,7 +5552,7 @@
           <p:cNvPr id="2" name="">
             <a:extLst xmlns:a="http://schemas.openxmlformats.org/drawingml/2006/main">
               <a:ext uri="{FF2B5EF4-FFF2-40B4-BE49-F238E27FC236}">
-                <a16:creationId xmlns:a16="http://schemas.microsoft.com/office/drawing/2014/main" id="{0F639B5C-66C3-44DD-B4A8-88CF55414449}"/>
+                <a16:creationId xmlns:a16="http://schemas.microsoft.com/office/drawing/2014/main" id="{1DCAA4AB-E29F-45C1-8EB3-A662D4F049F5}"/>
               </a:ext>
             </a:extLst>
           </p:cNvPr>
@@ -5653,7 +5582,7 @@
           <p:cNvPr id="3" name="">
             <a:extLst xmlns:a="http://schemas.openxmlformats.org/drawingml/2006/main">
               <a:ext uri="{FF2B5EF4-FFF2-40B4-BE49-F238E27FC236}">
-                <a16:creationId xmlns:a16="http://schemas.microsoft.com/office/drawing/2014/main" id="{1FE47D76-4B61-4E68-82AC-A0DB1580B2CF}"/>
+                <a16:creationId xmlns:a16="http://schemas.microsoft.com/office/drawing/2014/main" id="{031CD144-DDD5-4FC3-8821-1A0B304DCDA2}"/>
               </a:ext>
             </a:extLst>
           </p:cNvPr>
@@ -5698,19 +5627,19 @@
           <p:cNvPr id="4" name="">
             <a:extLst xmlns:a="http://schemas.openxmlformats.org/drawingml/2006/main">
               <a:ext uri="{FF2B5EF4-FFF2-40B4-BE49-F238E27FC236}">
-                <a16:creationId xmlns:a16="http://schemas.microsoft.com/office/drawing/2014/main" id="{E49CCAB6-E288-47B9-AA09-6CCB2ACCE90A}"/>
-              </a:ext>
-            </a:extLst>
-          </p:cNvPr>
-          <p:cNvSpPr>
-            <a:spLocks xmlns:a="http://schemas.openxmlformats.org/drawingml/2006/main" noGrp="1"/>
-          </p:cNvSpPr>
-          <p:nvPr/>
-        </p:nvSpPr>
-        <p:spPr>
-          <a:xfrm xmlns:a="http://schemas.openxmlformats.org/drawingml/2006/main">
-            <a:off x="609600" y="2219325"/>
-            <a:ext cx="3333750" cy="552450"/>
+                <a16:creationId xmlns:a16="http://schemas.microsoft.com/office/drawing/2014/main" id="{3E4B0435-2181-48B3-AB00-DF0482E7DA70}"/>
+              </a:ext>
+            </a:extLst>
+          </p:cNvPr>
+          <p:cNvSpPr>
+            <a:spLocks xmlns:a="http://schemas.openxmlformats.org/drawingml/2006/main" noGrp="1"/>
+          </p:cNvSpPr>
+          <p:nvPr/>
+        </p:nvSpPr>
+        <p:spPr>
+          <a:xfrm xmlns:a="http://schemas.openxmlformats.org/drawingml/2006/main">
+            <a:off x="762000" y="2333625"/>
+            <a:ext cx="2857500" cy="552450"/>
           </a:xfrm>
           <a:prstGeom xmlns:a="http://schemas.openxmlformats.org/drawingml/2006/main" prst="rect">
             <a:avLst/>
@@ -5743,19 +5672,19 @@
           <p:cNvPr id="5" name="">
             <a:extLst xmlns:a="http://schemas.openxmlformats.org/drawingml/2006/main">
               <a:ext uri="{FF2B5EF4-FFF2-40B4-BE49-F238E27FC236}">
-                <a16:creationId xmlns:a16="http://schemas.microsoft.com/office/drawing/2014/main" id="{EB94666F-9FA1-437D-9032-63AE83984039}"/>
-              </a:ext>
-            </a:extLst>
-          </p:cNvPr>
-          <p:cNvSpPr>
-            <a:spLocks xmlns:a="http://schemas.openxmlformats.org/drawingml/2006/main" noGrp="1"/>
-          </p:cNvSpPr>
-          <p:nvPr/>
-        </p:nvSpPr>
-        <p:spPr>
-          <a:xfrm xmlns:a="http://schemas.openxmlformats.org/drawingml/2006/main">
-            <a:off x="3238500" y="2362200"/>
-            <a:ext cx="1333500" cy="238125"/>
+                <a16:creationId xmlns:a16="http://schemas.microsoft.com/office/drawing/2014/main" id="{3FF9513A-B0B8-4C7C-8AB9-A3E5ABA616CD}"/>
+              </a:ext>
+            </a:extLst>
+          </p:cNvPr>
+          <p:cNvSpPr>
+            <a:spLocks xmlns:a="http://schemas.openxmlformats.org/drawingml/2006/main" noGrp="1"/>
+          </p:cNvSpPr>
+          <p:nvPr/>
+        </p:nvSpPr>
+        <p:spPr>
+          <a:xfrm xmlns:a="http://schemas.openxmlformats.org/drawingml/2006/main">
+            <a:off x="3524250" y="2505075"/>
+            <a:ext cx="1381125" cy="238125"/>
           </a:xfrm>
           <a:prstGeom xmlns:a="http://schemas.openxmlformats.org/drawingml/2006/main" prst="rightArrow">
             <a:avLst/>
@@ -5775,19 +5704,19 @@
           <p:cNvPr id="6" name="">
             <a:extLst xmlns:a="http://schemas.openxmlformats.org/drawingml/2006/main">
               <a:ext uri="{FF2B5EF4-FFF2-40B4-BE49-F238E27FC236}">
-                <a16:creationId xmlns:a16="http://schemas.microsoft.com/office/drawing/2014/main" id="{698DF346-5E83-4826-8FE4-B2CB7A52EAF1}"/>
-              </a:ext>
-            </a:extLst>
-          </p:cNvPr>
-          <p:cNvSpPr>
-            <a:spLocks xmlns:a="http://schemas.openxmlformats.org/drawingml/2006/main" noGrp="1"/>
-          </p:cNvSpPr>
-          <p:nvPr/>
-        </p:nvSpPr>
-        <p:spPr>
-          <a:xfrm xmlns:a="http://schemas.openxmlformats.org/drawingml/2006/main">
-            <a:off x="5095875" y="1714500"/>
-            <a:ext cx="6191250" cy="1476375"/>
+                <a16:creationId xmlns:a16="http://schemas.microsoft.com/office/drawing/2014/main" id="{4D1F1170-648D-4E00-9F09-D4C944A31B1B}"/>
+              </a:ext>
+            </a:extLst>
+          </p:cNvPr>
+          <p:cNvSpPr>
+            <a:spLocks xmlns:a="http://schemas.openxmlformats.org/drawingml/2006/main" noGrp="1"/>
+          </p:cNvSpPr>
+          <p:nvPr/>
+        </p:nvSpPr>
+        <p:spPr>
+          <a:xfrm xmlns:a="http://schemas.openxmlformats.org/drawingml/2006/main">
+            <a:off x="6667500" y="1514475"/>
+            <a:ext cx="3429000" cy="1928813"/>
           </a:xfrm>
           <a:prstGeom xmlns:a="http://schemas.openxmlformats.org/drawingml/2006/main" prst="rect">
             <a:avLst/>
@@ -5807,19 +5736,19 @@
           <p:cNvPr id="7" name="">
             <a:extLst xmlns:a="http://schemas.openxmlformats.org/drawingml/2006/main">
               <a:ext uri="{FF2B5EF4-FFF2-40B4-BE49-F238E27FC236}">
-                <a16:creationId xmlns:a16="http://schemas.microsoft.com/office/drawing/2014/main" id="{EBF3D435-193A-46AF-A6DF-EF36D7DA6D22}"/>
-              </a:ext>
-            </a:extLst>
-          </p:cNvPr>
-          <p:cNvSpPr>
-            <a:spLocks xmlns:a="http://schemas.openxmlformats.org/drawingml/2006/main" noGrp="1"/>
-          </p:cNvSpPr>
-          <p:nvPr/>
-        </p:nvSpPr>
-        <p:spPr>
-          <a:xfrm xmlns:a="http://schemas.openxmlformats.org/drawingml/2006/main">
-            <a:off x="6381750" y="1905000"/>
-            <a:ext cx="3619500" cy="1095375"/>
+                <a16:creationId xmlns:a16="http://schemas.microsoft.com/office/drawing/2014/main" id="{CA05F302-861F-4ABE-8E6F-CA051C37B17E}"/>
+              </a:ext>
+            </a:extLst>
+          </p:cNvPr>
+          <p:cNvSpPr>
+            <a:spLocks xmlns:a="http://schemas.openxmlformats.org/drawingml/2006/main" noGrp="1"/>
+          </p:cNvSpPr>
+          <p:nvPr/>
+        </p:nvSpPr>
+        <p:spPr>
+          <a:xfrm xmlns:a="http://schemas.openxmlformats.org/drawingml/2006/main">
+            <a:off x="7181850" y="1803797"/>
+            <a:ext cx="2400300" cy="1350169"/>
           </a:xfrm>
           <a:prstGeom xmlns:a="http://schemas.openxmlformats.org/drawingml/2006/main" prst="rect">
             <a:avLst/>
@@ -5839,19 +5768,19 @@
           <p:cNvPr id="8" name="">
             <a:extLst xmlns:a="http://schemas.openxmlformats.org/drawingml/2006/main">
               <a:ext uri="{FF2B5EF4-FFF2-40B4-BE49-F238E27FC236}">
-                <a16:creationId xmlns:a16="http://schemas.microsoft.com/office/drawing/2014/main" id="{DA81EFA4-E2F4-4914-AA4F-ACAC0D4CAB8F}"/>
-              </a:ext>
-            </a:extLst>
-          </p:cNvPr>
-          <p:cNvSpPr>
-            <a:spLocks xmlns:a="http://schemas.openxmlformats.org/drawingml/2006/main" noGrp="1"/>
-          </p:cNvSpPr>
-          <p:nvPr/>
-        </p:nvSpPr>
-        <p:spPr>
-          <a:xfrm xmlns:a="http://schemas.openxmlformats.org/drawingml/2006/main">
-            <a:off x="6153150" y="3333750"/>
-            <a:ext cx="5286375" cy="428625"/>
+                <a16:creationId xmlns:a16="http://schemas.microsoft.com/office/drawing/2014/main" id="{50F8B852-4217-4A38-917A-3867D45D4AEB}"/>
+              </a:ext>
+            </a:extLst>
+          </p:cNvPr>
+          <p:cNvSpPr>
+            <a:spLocks xmlns:a="http://schemas.openxmlformats.org/drawingml/2006/main" noGrp="1"/>
+          </p:cNvSpPr>
+          <p:nvPr/>
+        </p:nvSpPr>
+        <p:spPr>
+          <a:xfrm xmlns:a="http://schemas.openxmlformats.org/drawingml/2006/main">
+            <a:off x="857250" y="3076575"/>
+            <a:ext cx="5048250" cy="381000"/>
           </a:xfrm>
           <a:prstGeom xmlns:a="http://schemas.openxmlformats.org/drawingml/2006/main" prst="rect">
             <a:avLst/>
@@ -5866,7 +5795,7 @@
           <a:lstStyle xmlns:a="http://schemas.openxmlformats.org/drawingml/2006/main"/>
           <a:p xmlns:a="http://schemas.openxmlformats.org/drawingml/2006/main">
             <a:r>
-              <a:rPr sz="2175" b="1">
+              <a:rPr sz="2100" b="1">
                 <a:solidFill>
                   <a:srgbClr val="086B93"/>
                 </a:solidFill>
@@ -5884,19 +5813,19 @@
           <p:cNvPr id="9" name="">
             <a:extLst xmlns:a="http://schemas.openxmlformats.org/drawingml/2006/main">
               <a:ext uri="{FF2B5EF4-FFF2-40B4-BE49-F238E27FC236}">
-                <a16:creationId xmlns:a16="http://schemas.microsoft.com/office/drawing/2014/main" id="{E65B4E72-6CC4-4DFE-9C63-D6B76395A12F}"/>
-              </a:ext>
-            </a:extLst>
-          </p:cNvPr>
-          <p:cNvSpPr>
-            <a:spLocks xmlns:a="http://schemas.openxmlformats.org/drawingml/2006/main" noGrp="1"/>
-          </p:cNvSpPr>
-          <p:nvPr/>
-        </p:nvSpPr>
-        <p:spPr>
-          <a:xfrm xmlns:a="http://schemas.openxmlformats.org/drawingml/2006/main">
-            <a:off x="609600" y="4248150"/>
-            <a:ext cx="3333750" cy="552450"/>
+                <a16:creationId xmlns:a16="http://schemas.microsoft.com/office/drawing/2014/main" id="{180BB3A1-656D-47A2-83DC-F578B649150E}"/>
+              </a:ext>
+            </a:extLst>
+          </p:cNvPr>
+          <p:cNvSpPr>
+            <a:spLocks xmlns:a="http://schemas.openxmlformats.org/drawingml/2006/main" noGrp="1"/>
+          </p:cNvSpPr>
+          <p:nvPr/>
+        </p:nvSpPr>
+        <p:spPr>
+          <a:xfrm xmlns:a="http://schemas.openxmlformats.org/drawingml/2006/main">
+            <a:off x="762000" y="4505325"/>
+            <a:ext cx="2857500" cy="552450"/>
           </a:xfrm>
           <a:prstGeom xmlns:a="http://schemas.openxmlformats.org/drawingml/2006/main" prst="rect">
             <a:avLst/>
@@ -5929,19 +5858,19 @@
           <p:cNvPr id="10" name="">
             <a:extLst xmlns:a="http://schemas.openxmlformats.org/drawingml/2006/main">
               <a:ext uri="{FF2B5EF4-FFF2-40B4-BE49-F238E27FC236}">
-                <a16:creationId xmlns:a16="http://schemas.microsoft.com/office/drawing/2014/main" id="{406E9A6E-5726-474A-BC0D-28CDD7529F28}"/>
-              </a:ext>
-            </a:extLst>
-          </p:cNvPr>
-          <p:cNvSpPr>
-            <a:spLocks xmlns:a="http://schemas.openxmlformats.org/drawingml/2006/main" noGrp="1"/>
-          </p:cNvSpPr>
-          <p:nvPr/>
-        </p:nvSpPr>
-        <p:spPr>
-          <a:xfrm xmlns:a="http://schemas.openxmlformats.org/drawingml/2006/main">
-            <a:off x="3238500" y="4391025"/>
-            <a:ext cx="1333500" cy="238125"/>
+                <a16:creationId xmlns:a16="http://schemas.microsoft.com/office/drawing/2014/main" id="{5E1A5D89-E3CD-48D3-93C8-2CEC8764D4CC}"/>
+              </a:ext>
+            </a:extLst>
+          </p:cNvPr>
+          <p:cNvSpPr>
+            <a:spLocks xmlns:a="http://schemas.openxmlformats.org/drawingml/2006/main" noGrp="1"/>
+          </p:cNvSpPr>
+          <p:nvPr/>
+        </p:nvSpPr>
+        <p:spPr>
+          <a:xfrm xmlns:a="http://schemas.openxmlformats.org/drawingml/2006/main">
+            <a:off x="3524250" y="4676775"/>
+            <a:ext cx="1381125" cy="238125"/>
           </a:xfrm>
           <a:prstGeom xmlns:a="http://schemas.openxmlformats.org/drawingml/2006/main" prst="rightArrow">
             <a:avLst/>
@@ -5961,19 +5890,19 @@
           <p:cNvPr id="11" name="">
             <a:extLst xmlns:a="http://schemas.openxmlformats.org/drawingml/2006/main">
               <a:ext uri="{FF2B5EF4-FFF2-40B4-BE49-F238E27FC236}">
-                <a16:creationId xmlns:a16="http://schemas.microsoft.com/office/drawing/2014/main" id="{DDD9CF34-D6DD-46F4-A8ED-54FB513A4AAE}"/>
-              </a:ext>
-            </a:extLst>
-          </p:cNvPr>
-          <p:cNvSpPr>
-            <a:spLocks xmlns:a="http://schemas.openxmlformats.org/drawingml/2006/main" noGrp="1"/>
-          </p:cNvSpPr>
-          <p:nvPr/>
-        </p:nvSpPr>
-        <p:spPr>
-          <a:xfrm xmlns:a="http://schemas.openxmlformats.org/drawingml/2006/main">
-            <a:off x="5095875" y="3857625"/>
-            <a:ext cx="6191250" cy="1476375"/>
+                <a16:creationId xmlns:a16="http://schemas.microsoft.com/office/drawing/2014/main" id="{EE2B8706-E23C-4C1B-809B-F8EDCE283898}"/>
+              </a:ext>
+            </a:extLst>
+          </p:cNvPr>
+          <p:cNvSpPr>
+            <a:spLocks xmlns:a="http://schemas.openxmlformats.org/drawingml/2006/main" noGrp="1"/>
+          </p:cNvSpPr>
+          <p:nvPr/>
+        </p:nvSpPr>
+        <p:spPr>
+          <a:xfrm xmlns:a="http://schemas.openxmlformats.org/drawingml/2006/main">
+            <a:off x="6667500" y="3857625"/>
+            <a:ext cx="3429000" cy="1928813"/>
           </a:xfrm>
           <a:prstGeom xmlns:a="http://schemas.openxmlformats.org/drawingml/2006/main" prst="rect">
             <a:avLst/>
@@ -5993,19 +5922,19 @@
           <p:cNvPr id="12" name="">
             <a:extLst xmlns:a="http://schemas.openxmlformats.org/drawingml/2006/main">
               <a:ext uri="{FF2B5EF4-FFF2-40B4-BE49-F238E27FC236}">
-                <a16:creationId xmlns:a16="http://schemas.microsoft.com/office/drawing/2014/main" id="{33DD13F8-305F-415D-B184-2CC909298569}"/>
-              </a:ext>
-            </a:extLst>
-          </p:cNvPr>
-          <p:cNvSpPr>
-            <a:spLocks xmlns:a="http://schemas.openxmlformats.org/drawingml/2006/main" noGrp="1"/>
-          </p:cNvSpPr>
-          <p:nvPr/>
-        </p:nvSpPr>
-        <p:spPr>
-          <a:xfrm xmlns:a="http://schemas.openxmlformats.org/drawingml/2006/main">
-            <a:off x="7667625" y="4305300"/>
-            <a:ext cx="1047750" cy="590550"/>
+                <a16:creationId xmlns:a16="http://schemas.microsoft.com/office/drawing/2014/main" id="{25C1904A-A86C-4ED6-8A71-82271909787A}"/>
+              </a:ext>
+            </a:extLst>
+          </p:cNvPr>
+          <p:cNvSpPr>
+            <a:spLocks xmlns:a="http://schemas.openxmlformats.org/drawingml/2006/main" noGrp="1"/>
+          </p:cNvSpPr>
+          <p:nvPr/>
+        </p:nvSpPr>
+        <p:spPr>
+          <a:xfrm xmlns:a="http://schemas.openxmlformats.org/drawingml/2006/main">
+            <a:off x="7867650" y="4532709"/>
+            <a:ext cx="1028700" cy="578644"/>
           </a:xfrm>
           <a:prstGeom xmlns:a="http://schemas.openxmlformats.org/drawingml/2006/main" prst="rect">
             <a:avLst/>
@@ -6025,19 +5954,19 @@
           <p:cNvPr id="13" name="">
             <a:extLst xmlns:a="http://schemas.openxmlformats.org/drawingml/2006/main">
               <a:ext uri="{FF2B5EF4-FFF2-40B4-BE49-F238E27FC236}">
-                <a16:creationId xmlns:a16="http://schemas.microsoft.com/office/drawing/2014/main" id="{BC87A948-516E-42C7-9A96-9F98249AC24D}"/>
-              </a:ext>
-            </a:extLst>
-          </p:cNvPr>
-          <p:cNvSpPr>
-            <a:spLocks xmlns:a="http://schemas.openxmlformats.org/drawingml/2006/main" noGrp="1"/>
-          </p:cNvSpPr>
-          <p:nvPr/>
-        </p:nvSpPr>
-        <p:spPr>
-          <a:xfrm xmlns:a="http://schemas.openxmlformats.org/drawingml/2006/main">
-            <a:off x="5953125" y="5476875"/>
-            <a:ext cx="5524500" cy="381000"/>
+                <a16:creationId xmlns:a16="http://schemas.microsoft.com/office/drawing/2014/main" id="{FEBB12A1-6FC0-4760-BDA3-D748443FD5D6}"/>
+              </a:ext>
+            </a:extLst>
+          </p:cNvPr>
+          <p:cNvSpPr>
+            <a:spLocks xmlns:a="http://schemas.openxmlformats.org/drawingml/2006/main" noGrp="1"/>
+          </p:cNvSpPr>
+          <p:nvPr/>
+        </p:nvSpPr>
+        <p:spPr>
+          <a:xfrm xmlns:a="http://schemas.openxmlformats.org/drawingml/2006/main">
+            <a:off x="857250" y="5248275"/>
+            <a:ext cx="5048250" cy="381000"/>
           </a:xfrm>
           <a:prstGeom xmlns:a="http://schemas.openxmlformats.org/drawingml/2006/main" prst="rect">
             <a:avLst/>
@@ -6052,7 +5981,7 @@
           <a:lstStyle xmlns:a="http://schemas.openxmlformats.org/drawingml/2006/main"/>
           <a:p xmlns:a="http://schemas.openxmlformats.org/drawingml/2006/main">
             <a:r>
-              <a:rPr sz="2175" b="1">
+              <a:rPr sz="2100" b="1">
                 <a:solidFill>
                   <a:srgbClr val="148B83"/>
                 </a:solidFill>
@@ -6070,7 +5999,7 @@
           <p:cNvPr id="14" name="">
             <a:extLst xmlns:a="http://schemas.openxmlformats.org/drawingml/2006/main">
               <a:ext uri="{FF2B5EF4-FFF2-40B4-BE49-F238E27FC236}">
-                <a16:creationId xmlns:a16="http://schemas.microsoft.com/office/drawing/2014/main" id="{F5334C83-4985-40E6-80BA-DF9E109029FF}"/>
+                <a16:creationId xmlns:a16="http://schemas.microsoft.com/office/drawing/2014/main" id="{FED5BA41-A66F-46A4-AFC0-376DFB8D4183}"/>
               </a:ext>
             </a:extLst>
           </p:cNvPr>
@@ -6113,7 +6042,7 @@
     </p:spTree>
     <p:extLst>
       <p:ext uri="{BB962C8B-B14F-4D97-AF65-F5344CB8AC3E}">
-        <p14:creationId xmlns:p14="http://schemas.microsoft.com/office/powerpoint/2010/main" val="1958041682"/>
+        <p14:creationId xmlns:p14="http://schemas.microsoft.com/office/powerpoint/2010/main" val="1731396142"/>
       </p:ext>
     </p:extLst>
   </p:cSld>
@@ -6144,7 +6073,7 @@
           <p:cNvPr id="20" name="">
             <a:extLst xmlns:a="http://schemas.openxmlformats.org/drawingml/2006/main">
               <a:ext uri="{FF2B5EF4-FFF2-40B4-BE49-F238E27FC236}">
-                <a16:creationId xmlns:a16="http://schemas.microsoft.com/office/drawing/2014/main" id="{CA3FB4C3-94F3-4805-9FD3-8A379BE1057C}"/>
+                <a16:creationId xmlns:a16="http://schemas.microsoft.com/office/drawing/2014/main" id="{ABBF723A-A912-4A29-B2CB-A9C658D36BC4}"/>
               </a:ext>
             </a:extLst>
           </p:cNvPr>
@@ -6189,7 +6118,7 @@
           <p:cNvPr id="2" name="">
             <a:extLst xmlns:a="http://schemas.openxmlformats.org/drawingml/2006/main">
               <a:ext uri="{FF2B5EF4-FFF2-40B4-BE49-F238E27FC236}">
-                <a16:creationId xmlns:a16="http://schemas.microsoft.com/office/drawing/2014/main" id="{0C537509-915D-4A62-9543-8C955297DAF0}"/>
+                <a16:creationId xmlns:a16="http://schemas.microsoft.com/office/drawing/2014/main" id="{78F62F35-8203-44A6-B6A1-383CDB806B7B}"/>
               </a:ext>
             </a:extLst>
           </p:cNvPr>
@@ -6219,7 +6148,7 @@
           <p:cNvPr id="3" name="">
             <a:extLst xmlns:a="http://schemas.openxmlformats.org/drawingml/2006/main">
               <a:ext uri="{FF2B5EF4-FFF2-40B4-BE49-F238E27FC236}">
-                <a16:creationId xmlns:a16="http://schemas.microsoft.com/office/drawing/2014/main" id="{DC0E841B-DE4E-481C-9207-9E3FB2CD60BE}"/>
+                <a16:creationId xmlns:a16="http://schemas.microsoft.com/office/drawing/2014/main" id="{C136AC8E-5AE9-453D-8ADE-D3A1E234C3C7}"/>
               </a:ext>
             </a:extLst>
           </p:cNvPr>
@@ -6264,7 +6193,7 @@
           <p:cNvPr id="4" name="">
             <a:extLst xmlns:a="http://schemas.openxmlformats.org/drawingml/2006/main">
               <a:ext uri="{FF2B5EF4-FFF2-40B4-BE49-F238E27FC236}">
-                <a16:creationId xmlns:a16="http://schemas.microsoft.com/office/drawing/2014/main" id="{35439057-5086-417F-BCE9-D9AEC3EFC52F}"/>
+                <a16:creationId xmlns:a16="http://schemas.microsoft.com/office/drawing/2014/main" id="{E92BA7DB-6FD4-4AD7-A279-ADE527DBCE98}"/>
               </a:ext>
             </a:extLst>
           </p:cNvPr>
@@ -6309,7 +6238,7 @@
           <p:cNvPr id="5" name="">
             <a:extLst xmlns:a="http://schemas.openxmlformats.org/drawingml/2006/main">
               <a:ext uri="{FF2B5EF4-FFF2-40B4-BE49-F238E27FC236}">
-                <a16:creationId xmlns:a16="http://schemas.microsoft.com/office/drawing/2014/main" id="{D47A1FDA-05A8-49F9-B9ED-815D7BBB2A81}"/>
+                <a16:creationId xmlns:a16="http://schemas.microsoft.com/office/drawing/2014/main" id="{958393B4-F07F-4DB4-98D9-F74BF54A6376}"/>
               </a:ext>
             </a:extLst>
           </p:cNvPr>
@@ -6341,7 +6270,7 @@
           <p:cNvPr id="6" name="">
             <a:extLst xmlns:a="http://schemas.openxmlformats.org/drawingml/2006/main">
               <a:ext uri="{FF2B5EF4-FFF2-40B4-BE49-F238E27FC236}">
-                <a16:creationId xmlns:a16="http://schemas.microsoft.com/office/drawing/2014/main" id="{5B4534B5-8557-48B8-B988-8A037B55A08A}"/>
+                <a16:creationId xmlns:a16="http://schemas.microsoft.com/office/drawing/2014/main" id="{2942032C-1402-46F0-8641-D6CE8E48433C}"/>
               </a:ext>
             </a:extLst>
           </p:cNvPr>
@@ -6412,7 +6341,7 @@
           <p:cNvPr id="7" name="">
             <a:extLst xmlns:a="http://schemas.openxmlformats.org/drawingml/2006/main">
               <a:ext uri="{FF2B5EF4-FFF2-40B4-BE49-F238E27FC236}">
-                <a16:creationId xmlns:a16="http://schemas.microsoft.com/office/drawing/2014/main" id="{9D141711-495B-48F2-A819-311F44AAF653}"/>
+                <a16:creationId xmlns:a16="http://schemas.microsoft.com/office/drawing/2014/main" id="{B9695508-4155-43DC-927E-D9F4BF032A1C}"/>
               </a:ext>
             </a:extLst>
           </p:cNvPr>
@@ -6457,7 +6386,7 @@
           <p:cNvPr id="8" name="">
             <a:extLst xmlns:a="http://schemas.openxmlformats.org/drawingml/2006/main">
               <a:ext uri="{FF2B5EF4-FFF2-40B4-BE49-F238E27FC236}">
-                <a16:creationId xmlns:a16="http://schemas.microsoft.com/office/drawing/2014/main" id="{77A7B5D5-95BB-42A3-BCF4-99AFCCCDEBE4}"/>
+                <a16:creationId xmlns:a16="http://schemas.microsoft.com/office/drawing/2014/main" id="{D67F8474-E533-4C96-AB54-30AF87821599}"/>
               </a:ext>
             </a:extLst>
           </p:cNvPr>
@@ -6489,7 +6418,7 @@
           <p:cNvPr id="9" name="">
             <a:extLst xmlns:a="http://schemas.openxmlformats.org/drawingml/2006/main">
               <a:ext uri="{FF2B5EF4-FFF2-40B4-BE49-F238E27FC236}">
-                <a16:creationId xmlns:a16="http://schemas.microsoft.com/office/drawing/2014/main" id="{CDD86271-CDCF-45B0-9550-9C19D6868678}"/>
+                <a16:creationId xmlns:a16="http://schemas.microsoft.com/office/drawing/2014/main" id="{2E19CF6C-B043-4EF1-B9F9-B1E7F3DBCD02}"/>
               </a:ext>
             </a:extLst>
           </p:cNvPr>
@@ -6521,7 +6450,7 @@
           <p:cNvPr id="10" name="">
             <a:extLst xmlns:a="http://schemas.openxmlformats.org/drawingml/2006/main">
               <a:ext uri="{FF2B5EF4-FFF2-40B4-BE49-F238E27FC236}">
-                <a16:creationId xmlns:a16="http://schemas.microsoft.com/office/drawing/2014/main" id="{E89C1785-4BF8-4FF2-AF40-F0A53DD42F70}"/>
+                <a16:creationId xmlns:a16="http://schemas.microsoft.com/office/drawing/2014/main" id="{89AFB8B6-8473-4EA0-AB59-66848D08CA4D}"/>
               </a:ext>
             </a:extLst>
           </p:cNvPr>
@@ -6566,7 +6495,7 @@
           <p:cNvPr id="11" name="">
             <a:extLst xmlns:a="http://schemas.openxmlformats.org/drawingml/2006/main">
               <a:ext uri="{FF2B5EF4-FFF2-40B4-BE49-F238E27FC236}">
-                <a16:creationId xmlns:a16="http://schemas.microsoft.com/office/drawing/2014/main" id="{F632E18F-8B3D-4D4C-B2BD-8D9672EA8530}"/>
+                <a16:creationId xmlns:a16="http://schemas.microsoft.com/office/drawing/2014/main" id="{983E6B9A-4F84-4E0A-8821-92DA8AC8B566}"/>
               </a:ext>
             </a:extLst>
           </p:cNvPr>
@@ -6611,7 +6540,7 @@
           <p:cNvPr id="12" name="">
             <a:extLst xmlns:a="http://schemas.openxmlformats.org/drawingml/2006/main">
               <a:ext uri="{FF2B5EF4-FFF2-40B4-BE49-F238E27FC236}">
-                <a16:creationId xmlns:a16="http://schemas.microsoft.com/office/drawing/2014/main" id="{A4CE812E-93DE-4038-93EF-1F5210FCE669}"/>
+                <a16:creationId xmlns:a16="http://schemas.microsoft.com/office/drawing/2014/main" id="{94AD05D2-712F-4B7A-87C5-BA1CB15F96A7}"/>
               </a:ext>
             </a:extLst>
           </p:cNvPr>
@@ -6656,7 +6585,7 @@
           <p:cNvPr id="13" name="">
             <a:extLst xmlns:a="http://schemas.openxmlformats.org/drawingml/2006/main">
               <a:ext uri="{FF2B5EF4-FFF2-40B4-BE49-F238E27FC236}">
-                <a16:creationId xmlns:a16="http://schemas.microsoft.com/office/drawing/2014/main" id="{F527E3FF-01E8-4A74-A1CD-41E283936DA6}"/>
+                <a16:creationId xmlns:a16="http://schemas.microsoft.com/office/drawing/2014/main" id="{8AAFF49D-F64E-467B-AE0A-2AD43EF3F957}"/>
               </a:ext>
             </a:extLst>
           </p:cNvPr>
@@ -6688,7 +6617,7 @@
           <p:cNvPr id="14" name="">
             <a:extLst xmlns:a="http://schemas.openxmlformats.org/drawingml/2006/main">
               <a:ext uri="{FF2B5EF4-FFF2-40B4-BE49-F238E27FC236}">
-                <a16:creationId xmlns:a16="http://schemas.microsoft.com/office/drawing/2014/main" id="{DBAC5BC3-ACF1-4E76-9C2F-456C06238439}"/>
+                <a16:creationId xmlns:a16="http://schemas.microsoft.com/office/drawing/2014/main" id="{614E9256-1B6A-4A49-99CA-A3ECEE86FCFD}"/>
               </a:ext>
             </a:extLst>
           </p:cNvPr>
@@ -6720,7 +6649,7 @@
           <p:cNvPr id="15" name="">
             <a:extLst xmlns:a="http://schemas.openxmlformats.org/drawingml/2006/main">
               <a:ext uri="{FF2B5EF4-FFF2-40B4-BE49-F238E27FC236}">
-                <a16:creationId xmlns:a16="http://schemas.microsoft.com/office/drawing/2014/main" id="{F2F44C92-9528-403B-ACBE-FE929C791E1C}"/>
+                <a16:creationId xmlns:a16="http://schemas.microsoft.com/office/drawing/2014/main" id="{A002B53F-7975-48FC-BE17-82EC128DF4D6}"/>
               </a:ext>
             </a:extLst>
           </p:cNvPr>
@@ -6752,7 +6681,7 @@
           <p:cNvPr id="16" name="">
             <a:extLst xmlns:a="http://schemas.openxmlformats.org/drawingml/2006/main">
               <a:ext uri="{FF2B5EF4-FFF2-40B4-BE49-F238E27FC236}">
-                <a16:creationId xmlns:a16="http://schemas.microsoft.com/office/drawing/2014/main" id="{3E746905-0823-4CE1-B66D-BC1DDEE055AA}"/>
+                <a16:creationId xmlns:a16="http://schemas.microsoft.com/office/drawing/2014/main" id="{4C12CED7-8EF1-443E-BEB6-21F70C3263AC}"/>
               </a:ext>
             </a:extLst>
           </p:cNvPr>
@@ -6797,7 +6726,7 @@
           <p:cNvPr id="17" name="">
             <a:extLst xmlns:a="http://schemas.openxmlformats.org/drawingml/2006/main">
               <a:ext uri="{FF2B5EF4-FFF2-40B4-BE49-F238E27FC236}">
-                <a16:creationId xmlns:a16="http://schemas.microsoft.com/office/drawing/2014/main" id="{AA2EF3BB-3495-4307-9132-388F4EE42549}"/>
+                <a16:creationId xmlns:a16="http://schemas.microsoft.com/office/drawing/2014/main" id="{23EAB435-6491-41FF-AF55-DB7C02BF96B9}"/>
               </a:ext>
             </a:extLst>
           </p:cNvPr>
@@ -6842,7 +6771,7 @@
           <p:cNvPr id="18" name="">
             <a:extLst xmlns:a="http://schemas.openxmlformats.org/drawingml/2006/main">
               <a:ext uri="{FF2B5EF4-FFF2-40B4-BE49-F238E27FC236}">
-                <a16:creationId xmlns:a16="http://schemas.microsoft.com/office/drawing/2014/main" id="{682673DE-9A5E-45CD-8656-A967C9E14CE2}"/>
+                <a16:creationId xmlns:a16="http://schemas.microsoft.com/office/drawing/2014/main" id="{F746B42D-189B-4D7E-B05A-1AB7E058D48B}"/>
               </a:ext>
             </a:extLst>
           </p:cNvPr>
@@ -6887,7 +6816,7 @@
           <p:cNvPr id="19" name="">
             <a:extLst xmlns:a="http://schemas.openxmlformats.org/drawingml/2006/main">
               <a:ext uri="{FF2B5EF4-FFF2-40B4-BE49-F238E27FC236}">
-                <a16:creationId xmlns:a16="http://schemas.microsoft.com/office/drawing/2014/main" id="{46671EF0-8B2F-48D9-81DE-34308E15C558}"/>
+                <a16:creationId xmlns:a16="http://schemas.microsoft.com/office/drawing/2014/main" id="{1D8E51DD-0FE4-435C-AD7B-B514D1D3D42B}"/>
               </a:ext>
             </a:extLst>
           </p:cNvPr>
@@ -6930,7 +6859,7 @@
     </p:spTree>
     <p:extLst>
       <p:ext uri="{BB962C8B-B14F-4D97-AF65-F5344CB8AC3E}">
-        <p14:creationId xmlns:p14="http://schemas.microsoft.com/office/powerpoint/2010/main" val="6378097"/>
+        <p14:creationId xmlns:p14="http://schemas.microsoft.com/office/powerpoint/2010/main" val="590900306"/>
       </p:ext>
     </p:extLst>
   </p:cSld>
@@ -6958,10 +6887,10 @@
       </p:grpSpPr>
       <p:sp>
         <p:nvSpPr>
-          <p:cNvPr id="8" name="">
-            <a:extLst xmlns:a="http://schemas.openxmlformats.org/drawingml/2006/main">
-              <a:ext uri="{FF2B5EF4-FFF2-40B4-BE49-F238E27FC236}">
-                <a16:creationId xmlns:a16="http://schemas.microsoft.com/office/drawing/2014/main" id="{E1FB3CA8-73DD-4B0E-B51A-CFC573B4CEDE}"/>
+          <p:cNvPr id="12" name="">
+            <a:extLst xmlns:a="http://schemas.openxmlformats.org/drawingml/2006/main">
+              <a:ext uri="{FF2B5EF4-FFF2-40B4-BE49-F238E27FC236}">
+                <a16:creationId xmlns:a16="http://schemas.microsoft.com/office/drawing/2014/main" id="{58E7B120-2336-4508-AEDD-3A80E7F5DF37}"/>
               </a:ext>
             </a:extLst>
           </p:cNvPr>
@@ -6996,7 +6925,7 @@
                 <a:ea typeface="Arial"/>
                 <a:cs typeface="Arial"/>
               </a:rPr>
-              <a:t>Timing and quality use separate measurement sets</a:t>
+              <a:t>30W CUDA C++: decode budget + reconstruction</a:t>
             </a:r>
           </a:p>
         </p:txBody>
@@ -7006,7 +6935,7 @@
           <p:cNvPr id="2" name="">
             <a:extLst xmlns:a="http://schemas.openxmlformats.org/drawingml/2006/main">
               <a:ext uri="{FF2B5EF4-FFF2-40B4-BE49-F238E27FC236}">
-                <a16:creationId xmlns:a16="http://schemas.microsoft.com/office/drawing/2014/main" id="{5FF17C6B-992B-4B4C-92CA-5469B604381C}"/>
+                <a16:creationId xmlns:a16="http://schemas.microsoft.com/office/drawing/2014/main" id="{8EF7E9B1-56BC-4BB5-A378-6BD835267AA4}"/>
               </a:ext>
             </a:extLst>
           </p:cNvPr>
@@ -7036,7 +6965,7 @@
           <p:cNvPr id="3" name="">
             <a:extLst xmlns:a="http://schemas.openxmlformats.org/drawingml/2006/main">
               <a:ext uri="{FF2B5EF4-FFF2-40B4-BE49-F238E27FC236}">
-                <a16:creationId xmlns:a16="http://schemas.microsoft.com/office/drawing/2014/main" id="{87967DD5-575A-4DB3-B40F-7AA7A2BB1FD7}"/>
+                <a16:creationId xmlns:a16="http://schemas.microsoft.com/office/drawing/2014/main" id="{81366B18-9EAE-4369-B199-9FB6BAD3BC8C}"/>
               </a:ext>
             </a:extLst>
           </p:cNvPr>
@@ -7078,10 +7007,10 @@
       </p:sp>
       <p:graphicFrame>
         <p:nvGraphicFramePr>
-          <p:cNvPr id="4" name="">
-            <a:extLst xmlns:a="http://schemas.openxmlformats.org/drawingml/2006/main">
-              <a:ext uri="{FF2B5EF4-FFF2-40B4-BE49-F238E27FC236}">
-                <a16:creationId xmlns:a16="http://schemas.microsoft.com/office/drawing/2014/main" id="{A19D57B2-B38A-4AA0-83FA-A4BB8BD828B9}"/>
+          <p:cNvPr id="4" name="Chart">
+            <a:extLst xmlns:a="http://schemas.openxmlformats.org/drawingml/2006/main">
+              <a:ext uri="{FF2B5EF4-FFF2-40B4-BE49-F238E27FC236}">
+                <a16:creationId xmlns:a16="http://schemas.microsoft.com/office/drawing/2014/main" id="{E657DE70-47A4-4A50-A164-2D6474B474BF}"/>
               </a:ext>
             </a:extLst>
           </p:cNvPr>
@@ -7089,733 +7018,12 @@
           <p:nvPr/>
         </p:nvGraphicFramePr>
         <p:xfrm>
-          <a:off xmlns:a="http://schemas.openxmlformats.org/drawingml/2006/main" x="609600" y="1638300"/>
-          <a:ext xmlns:a="http://schemas.openxmlformats.org/drawingml/2006/main" cx="10972800" cy="3314700"/>
+          <a:off xmlns:a="http://schemas.openxmlformats.org/drawingml/2006/main" x="609600" y="1828800"/>
+          <a:ext xmlns:a="http://schemas.openxmlformats.org/drawingml/2006/main" cx="7715250" cy="3752850"/>
         </p:xfrm>
         <a:graphic xmlns:a="http://schemas.openxmlformats.org/drawingml/2006/main">
-          <a:graphicData uri="http://schemas.openxmlformats.org/drawingml/2006/table">
-            <a:tbl>
-              <a:tblPr/>
-              <a:tblGrid>
-                <a:gridCol w="2476500"/>
-                <a:gridCol w="4248150"/>
-                <a:gridCol w="4248150"/>
-              </a:tblGrid>
-              <a:tr h="552450">
-                <a:tc>
-                  <a:txBody>
-                    <a:bodyPr/>
-                    <a:lstStyle/>
-                    <a:p>
-                      <a:r>
-                        <a:rPr sz="1875" b="1">
-                          <a:solidFill>
-                            <a:srgbClr val="FFFFFF"/>
-                          </a:solidFill>
-                          <a:latin typeface="Arial"/>
-                          <a:ea typeface="Arial"/>
-                          <a:cs typeface="Arial"/>
-                        </a:rPr>
-                        <a:t/>
-                      </a:r>
-                    </a:p>
-                  </a:txBody>
-                  <a:tcPr marL="91440" marR="91440" marT="45720" marB="45720">
-                    <a:lnL w="9525">
-                      <a:solidFill>
-                        <a:srgbClr val="D7DFE5"/>
-                      </a:solidFill>
-                      <a:prstDash val="solid"/>
-                    </a:lnL>
-                    <a:lnR w="9525">
-                      <a:solidFill>
-                        <a:srgbClr val="D7DFE5"/>
-                      </a:solidFill>
-                      <a:prstDash val="solid"/>
-                    </a:lnR>
-                    <a:lnT w="9525">
-                      <a:solidFill>
-                        <a:srgbClr val="D7DFE5"/>
-                      </a:solidFill>
-                      <a:prstDash val="solid"/>
-                    </a:lnT>
-                    <a:lnB w="9525">
-                      <a:solidFill>
-                        <a:srgbClr val="D7DFE5"/>
-                      </a:solidFill>
-                      <a:prstDash val="solid"/>
-                    </a:lnB>
-                    <a:solidFill>
-                      <a:srgbClr val="152D43"/>
-                    </a:solidFill>
-                  </a:tcPr>
-                </a:tc>
-                <a:tc>
-                  <a:txBody>
-                    <a:bodyPr/>
-                    <a:lstStyle/>
-                    <a:p>
-                      <a:r>
-                        <a:rPr sz="1875" b="1">
-                          <a:solidFill>
-                            <a:srgbClr val="FFFFFF"/>
-                          </a:solidFill>
-                          <a:latin typeface="Arial"/>
-                          <a:ea typeface="Arial"/>
-                          <a:cs typeface="Arial"/>
-                        </a:rPr>
-                        <a:t>Latest timing</a:t>
-                      </a:r>
-                    </a:p>
-                  </a:txBody>
-                  <a:tcPr marL="91440" marR="91440" marT="45720" marB="45720">
-                    <a:lnR w="9525">
-                      <a:solidFill>
-                        <a:srgbClr val="D7DFE5"/>
-                      </a:solidFill>
-                      <a:prstDash val="solid"/>
-                    </a:lnR>
-                    <a:lnT w="9525">
-                      <a:solidFill>
-                        <a:srgbClr val="D7DFE5"/>
-                      </a:solidFill>
-                      <a:prstDash val="solid"/>
-                    </a:lnT>
-                    <a:lnB w="9525">
-                      <a:solidFill>
-                        <a:srgbClr val="D7DFE5"/>
-                      </a:solidFill>
-                      <a:prstDash val="solid"/>
-                    </a:lnB>
-                    <a:solidFill>
-                      <a:srgbClr val="152D43"/>
-                    </a:solidFill>
-                  </a:tcPr>
-                </a:tc>
-                <a:tc>
-                  <a:txBody>
-                    <a:bodyPr/>
-                    <a:lstStyle/>
-                    <a:p>
-                      <a:r>
-                        <a:rPr sz="1875" b="1">
-                          <a:solidFill>
-                            <a:srgbClr val="FFFFFF"/>
-                          </a:solidFill>
-                          <a:latin typeface="Arial"/>
-                          <a:ea typeface="Arial"/>
-                          <a:cs typeface="Arial"/>
-                        </a:rPr>
-                        <a:t>Existing quality</a:t>
-                      </a:r>
-                    </a:p>
-                  </a:txBody>
-                  <a:tcPr marL="91440" marR="91440" marT="45720" marB="45720">
-                    <a:lnR w="9525">
-                      <a:solidFill>
-                        <a:srgbClr val="D7DFE5"/>
-                      </a:solidFill>
-                      <a:prstDash val="solid"/>
-                    </a:lnR>
-                    <a:lnT w="9525">
-                      <a:solidFill>
-                        <a:srgbClr val="D7DFE5"/>
-                      </a:solidFill>
-                      <a:prstDash val="solid"/>
-                    </a:lnT>
-                    <a:lnB w="9525">
-                      <a:solidFill>
-                        <a:srgbClr val="D7DFE5"/>
-                      </a:solidFill>
-                      <a:prstDash val="solid"/>
-                    </a:lnB>
-                    <a:solidFill>
-                      <a:srgbClr val="152D43"/>
-                    </a:solidFill>
-                  </a:tcPr>
-                </a:tc>
-              </a:tr>
-              <a:tr h="552450">
-                <a:tc>
-                  <a:txBody>
-                    <a:bodyPr/>
-                    <a:lstStyle/>
-                    <a:p>
-                      <a:r>
-                        <a:rPr sz="1875" b="0">
-                          <a:solidFill>
-                            <a:srgbClr val="152D43"/>
-                          </a:solidFill>
-                          <a:latin typeface="Arial"/>
-                          <a:ea typeface="Arial"/>
-                          <a:cs typeface="Arial"/>
-                        </a:rPr>
-                        <a:t>Implementation</a:t>
-                      </a:r>
-                    </a:p>
-                  </a:txBody>
-                  <a:tcPr marL="91440" marR="91440" marT="45720" marB="45720">
-                    <a:lnL w="9525">
-                      <a:solidFill>
-                        <a:srgbClr val="D7DFE5"/>
-                      </a:solidFill>
-                      <a:prstDash val="solid"/>
-                    </a:lnL>
-                    <a:lnR w="9525">
-                      <a:solidFill>
-                        <a:srgbClr val="D7DFE5"/>
-                      </a:solidFill>
-                      <a:prstDash val="solid"/>
-                    </a:lnR>
-                    <a:lnB w="9525">
-                      <a:solidFill>
-                        <a:srgbClr val="D7DFE5"/>
-                      </a:solidFill>
-                      <a:prstDash val="solid"/>
-                    </a:lnB>
-                    <a:solidFill>
-                      <a:srgbClr val="FFFFFF"/>
-                    </a:solidFill>
-                  </a:tcPr>
-                </a:tc>
-                <a:tc>
-                  <a:txBody>
-                    <a:bodyPr/>
-                    <a:lstStyle/>
-                    <a:p>
-                      <a:r>
-                        <a:rPr sz="1875" b="0">
-                          <a:solidFill>
-                            <a:srgbClr val="152D43"/>
-                          </a:solidFill>
-                          <a:latin typeface="Arial"/>
-                          <a:ea typeface="Arial"/>
-                          <a:cs typeface="Arial"/>
-                        </a:rPr>
-                        <a:t>CUDA C++</a:t>
-                      </a:r>
-                    </a:p>
-                  </a:txBody>
-                  <a:tcPr marL="91440" marR="91440" marT="45720" marB="45720">
-                    <a:lnR w="9525">
-                      <a:solidFill>
-                        <a:srgbClr val="D7DFE5"/>
-                      </a:solidFill>
-                      <a:prstDash val="solid"/>
-                    </a:lnR>
-                    <a:lnB w="9525">
-                      <a:solidFill>
-                        <a:srgbClr val="D7DFE5"/>
-                      </a:solidFill>
-                      <a:prstDash val="solid"/>
-                    </a:lnB>
-                    <a:solidFill>
-                      <a:srgbClr val="FFFFFF"/>
-                    </a:solidFill>
-                  </a:tcPr>
-                </a:tc>
-                <a:tc>
-                  <a:txBody>
-                    <a:bodyPr/>
-                    <a:lstStyle/>
-                    <a:p>
-                      <a:r>
-                        <a:rPr sz="1875" b="0">
-                          <a:solidFill>
-                            <a:srgbClr val="152D43"/>
-                          </a:solidFill>
-                          <a:latin typeface="Arial"/>
-                          <a:ea typeface="Arial"/>
-                          <a:cs typeface="Arial"/>
-                        </a:rPr>
-                        <a:t>CUDA C++</a:t>
-                      </a:r>
-                    </a:p>
-                  </a:txBody>
-                  <a:tcPr marL="91440" marR="91440" marT="45720" marB="45720">
-                    <a:lnR w="9525">
-                      <a:solidFill>
-                        <a:srgbClr val="D7DFE5"/>
-                      </a:solidFill>
-                      <a:prstDash val="solid"/>
-                    </a:lnR>
-                    <a:lnB w="9525">
-                      <a:solidFill>
-                        <a:srgbClr val="D7DFE5"/>
-                      </a:solidFill>
-                      <a:prstDash val="solid"/>
-                    </a:lnB>
-                    <a:solidFill>
-                      <a:srgbClr val="FFFFFF"/>
-                    </a:solidFill>
-                  </a:tcPr>
-                </a:tc>
-              </a:tr>
-              <a:tr h="552450">
-                <a:tc>
-                  <a:txBody>
-                    <a:bodyPr/>
-                    <a:lstStyle/>
-                    <a:p>
-                      <a:r>
-                        <a:rPr sz="1875" b="0">
-                          <a:solidFill>
-                            <a:srgbClr val="152D43"/>
-                          </a:solidFill>
-                          <a:latin typeface="Arial"/>
-                          <a:ea typeface="Arial"/>
-                          <a:cs typeface="Arial"/>
-                        </a:rPr>
-                        <a:t>Xavier power mode</a:t>
-                      </a:r>
-                    </a:p>
-                  </a:txBody>
-                  <a:tcPr marL="91440" marR="91440" marT="45720" marB="45720">
-                    <a:lnL w="9525">
-                      <a:solidFill>
-                        <a:srgbClr val="D7DFE5"/>
-                      </a:solidFill>
-                      <a:prstDash val="solid"/>
-                    </a:lnL>
-                    <a:lnR w="9525">
-                      <a:solidFill>
-                        <a:srgbClr val="D7DFE5"/>
-                      </a:solidFill>
-                      <a:prstDash val="solid"/>
-                    </a:lnR>
-                    <a:lnB w="9525">
-                      <a:solidFill>
-                        <a:srgbClr val="D7DFE5"/>
-                      </a:solidFill>
-                      <a:prstDash val="solid"/>
-                    </a:lnB>
-                    <a:solidFill>
-                      <a:srgbClr val="EAF3F6"/>
-                    </a:solidFill>
-                  </a:tcPr>
-                </a:tc>
-                <a:tc>
-                  <a:txBody>
-                    <a:bodyPr/>
-                    <a:lstStyle/>
-                    <a:p>
-                      <a:r>
-                        <a:rPr sz="1875" b="0">
-                          <a:solidFill>
-                            <a:srgbClr val="152D43"/>
-                          </a:solidFill>
-                          <a:latin typeface="Arial"/>
-                          <a:ea typeface="Arial"/>
-                          <a:cs typeface="Arial"/>
-                        </a:rPr>
-                        <a:t>30W 4CORE, unlocked</a:t>
-                      </a:r>
-                    </a:p>
-                  </a:txBody>
-                  <a:tcPr marL="91440" marR="91440" marT="45720" marB="45720">
-                    <a:lnR w="9525">
-                      <a:solidFill>
-                        <a:srgbClr val="D7DFE5"/>
-                      </a:solidFill>
-                      <a:prstDash val="solid"/>
-                    </a:lnR>
-                    <a:lnB w="9525">
-                      <a:solidFill>
-                        <a:srgbClr val="D7DFE5"/>
-                      </a:solidFill>
-                      <a:prstDash val="solid"/>
-                    </a:lnB>
-                    <a:solidFill>
-                      <a:srgbClr val="EAF3F6"/>
-                    </a:solidFill>
-                  </a:tcPr>
-                </a:tc>
-                <a:tc>
-                  <a:txBody>
-                    <a:bodyPr/>
-                    <a:lstStyle/>
-                    <a:p>
-                      <a:r>
-                        <a:rPr sz="1875" b="0">
-                          <a:solidFill>
-                            <a:srgbClr val="152D43"/>
-                          </a:solidFill>
-                          <a:latin typeface="Arial"/>
-                          <a:ea typeface="Arial"/>
-                          <a:cs typeface="Arial"/>
-                        </a:rPr>
-                        <a:t>15W Desktop, unlocked</a:t>
-                      </a:r>
-                    </a:p>
-                  </a:txBody>
-                  <a:tcPr marL="91440" marR="91440" marT="45720" marB="45720">
-                    <a:lnR w="9525">
-                      <a:solidFill>
-                        <a:srgbClr val="D7DFE5"/>
-                      </a:solidFill>
-                      <a:prstDash val="solid"/>
-                    </a:lnR>
-                    <a:lnB w="9525">
-                      <a:solidFill>
-                        <a:srgbClr val="D7DFE5"/>
-                      </a:solidFill>
-                      <a:prstDash val="solid"/>
-                    </a:lnB>
-                    <a:solidFill>
-                      <a:srgbClr val="EAF3F6"/>
-                    </a:solidFill>
-                  </a:tcPr>
-                </a:tc>
-              </a:tr>
-              <a:tr h="552450">
-                <a:tc>
-                  <a:txBody>
-                    <a:bodyPr/>
-                    <a:lstStyle/>
-                    <a:p>
-                      <a:r>
-                        <a:rPr sz="1875" b="0">
-                          <a:solidFill>
-                            <a:srgbClr val="152D43"/>
-                          </a:solidFill>
-                          <a:latin typeface="Arial"/>
-                          <a:ea typeface="Arial"/>
-                          <a:cs typeface="Arial"/>
-                        </a:rPr>
-                        <a:t>Coverage</a:t>
-                      </a:r>
-                    </a:p>
-                  </a:txBody>
-                  <a:tcPr marL="91440" marR="91440" marT="45720" marB="45720">
-                    <a:lnL w="9525">
-                      <a:solidFill>
-                        <a:srgbClr val="D7DFE5"/>
-                      </a:solidFill>
-                      <a:prstDash val="solid"/>
-                    </a:lnL>
-                    <a:lnR w="9525">
-                      <a:solidFill>
-                        <a:srgbClr val="D7DFE5"/>
-                      </a:solidFill>
-                      <a:prstDash val="solid"/>
-                    </a:lnR>
-                    <a:lnB w="9525">
-                      <a:solidFill>
-                        <a:srgbClr val="D7DFE5"/>
-                      </a:solidFill>
-                      <a:prstDash val="solid"/>
-                    </a:lnB>
-                    <a:solidFill>
-                      <a:srgbClr val="FFFFFF"/>
-                    </a:solidFill>
-                  </a:tcPr>
-                </a:tc>
-                <a:tc>
-                  <a:txBody>
-                    <a:bodyPr/>
-                    <a:lstStyle/>
-                    <a:p>
-                      <a:r>
-                        <a:rPr sz="1875" b="0">
-                          <a:solidFill>
-                            <a:srgbClr val="152D43"/>
-                          </a:solidFill>
-                          <a:latin typeface="Arial"/>
-                          <a:ea typeface="Arial"/>
-                          <a:cs typeface="Arial"/>
-                        </a:rPr>
-                        <a:t>4 workloads × frame 39</a:t>
-                      </a:r>
-                    </a:p>
-                  </a:txBody>
-                  <a:tcPr marL="91440" marR="91440" marT="45720" marB="45720">
-                    <a:lnR w="9525">
-                      <a:solidFill>
-                        <a:srgbClr val="D7DFE5"/>
-                      </a:solidFill>
-                      <a:prstDash val="solid"/>
-                    </a:lnR>
-                    <a:lnB w="9525">
-                      <a:solidFill>
-                        <a:srgbClr val="D7DFE5"/>
-                      </a:solidFill>
-                      <a:prstDash val="solid"/>
-                    </a:lnB>
-                    <a:solidFill>
-                      <a:srgbClr val="FFFFFF"/>
-                    </a:solidFill>
-                  </a:tcPr>
-                </a:tc>
-                <a:tc>
-                  <a:txBody>
-                    <a:bodyPr/>
-                    <a:lstStyle/>
-                    <a:p>
-                      <a:r>
-                        <a:rPr sz="1875" b="0">
-                          <a:solidFill>
-                            <a:srgbClr val="152D43"/>
-                          </a:solidFill>
-                          <a:latin typeface="Arial"/>
-                          <a:ea typeface="Arial"/>
-                          <a:cs typeface="Arial"/>
-                        </a:rPr>
-                        <a:t>1068 forward odd frames</a:t>
-                      </a:r>
-                    </a:p>
-                  </a:txBody>
-                  <a:tcPr marL="91440" marR="91440" marT="45720" marB="45720">
-                    <a:lnR w="9525">
-                      <a:solidFill>
-                        <a:srgbClr val="D7DFE5"/>
-                      </a:solidFill>
-                      <a:prstDash val="solid"/>
-                    </a:lnR>
-                    <a:lnB w="9525">
-                      <a:solidFill>
-                        <a:srgbClr val="D7DFE5"/>
-                      </a:solidFill>
-                      <a:prstDash val="solid"/>
-                    </a:lnB>
-                    <a:solidFill>
-                      <a:srgbClr val="FFFFFF"/>
-                    </a:solidFill>
-                  </a:tcPr>
-                </a:tc>
-              </a:tr>
-              <a:tr h="552450">
-                <a:tc>
-                  <a:txBody>
-                    <a:bodyPr/>
-                    <a:lstStyle/>
-                    <a:p>
-                      <a:r>
-                        <a:rPr sz="1875" b="0">
-                          <a:solidFill>
-                            <a:srgbClr val="152D43"/>
-                          </a:solidFill>
-                          <a:latin typeface="Arial"/>
-                          <a:ea typeface="Arial"/>
-                          <a:cs typeface="Arial"/>
-                        </a:rPr>
-                        <a:t>Sampling</a:t>
-                      </a:r>
-                    </a:p>
-                  </a:txBody>
-                  <a:tcPr marL="91440" marR="91440" marT="45720" marB="45720">
-                    <a:lnL w="9525">
-                      <a:solidFill>
-                        <a:srgbClr val="D7DFE5"/>
-                      </a:solidFill>
-                      <a:prstDash val="solid"/>
-                    </a:lnL>
-                    <a:lnR w="9525">
-                      <a:solidFill>
-                        <a:srgbClr val="D7DFE5"/>
-                      </a:solidFill>
-                      <a:prstDash val="solid"/>
-                    </a:lnR>
-                    <a:lnB w="9525">
-                      <a:solidFill>
-                        <a:srgbClr val="D7DFE5"/>
-                      </a:solidFill>
-                      <a:prstDash val="solid"/>
-                    </a:lnB>
-                    <a:solidFill>
-                      <a:srgbClr val="EAF3F6"/>
-                    </a:solidFill>
-                  </a:tcPr>
-                </a:tc>
-                <a:tc>
-                  <a:txBody>
-                    <a:bodyPr/>
-                    <a:lstStyle/>
-                    <a:p>
-                      <a:r>
-                        <a:rPr sz="1875" b="0">
-                          <a:solidFill>
-                            <a:srgbClr val="152D43"/>
-                          </a:solidFill>
-                          <a:latin typeface="Arial"/>
-                          <a:ea typeface="Arial"/>
-                          <a:cs typeface="Arial"/>
-                        </a:rPr>
-                        <a:t>10 warmups + 100 runs/path</a:t>
-                      </a:r>
-                    </a:p>
-                  </a:txBody>
-                  <a:tcPr marL="91440" marR="91440" marT="45720" marB="45720">
-                    <a:lnR w="9525">
-                      <a:solidFill>
-                        <a:srgbClr val="D7DFE5"/>
-                      </a:solidFill>
-                      <a:prstDash val="solid"/>
-                    </a:lnR>
-                    <a:lnB w="9525">
-                      <a:solidFill>
-                        <a:srgbClr val="D7DFE5"/>
-                      </a:solidFill>
-                      <a:prstDash val="solid"/>
-                    </a:lnB>
-                    <a:solidFill>
-                      <a:srgbClr val="EAF3F6"/>
-                    </a:solidFill>
-                  </a:tcPr>
-                </a:tc>
-                <a:tc>
-                  <a:txBody>
-                    <a:bodyPr/>
-                    <a:lstStyle/>
-                    <a:p>
-                      <a:r>
-                        <a:rPr sz="1875" b="0">
-                          <a:solidFill>
-                            <a:srgbClr val="152D43"/>
-                          </a:solidFill>
-                          <a:latin typeface="Arial"/>
-                          <a:ea typeface="Arial"/>
-                          <a:cs typeface="Arial"/>
-                        </a:rPr>
-                        <a:t>1 output/config/frame</a:t>
-                      </a:r>
-                    </a:p>
-                  </a:txBody>
-                  <a:tcPr marL="91440" marR="91440" marT="45720" marB="45720">
-                    <a:lnR w="9525">
-                      <a:solidFill>
-                        <a:srgbClr val="D7DFE5"/>
-                      </a:solidFill>
-                      <a:prstDash val="solid"/>
-                    </a:lnR>
-                    <a:lnB w="9525">
-                      <a:solidFill>
-                        <a:srgbClr val="D7DFE5"/>
-                      </a:solidFill>
-                      <a:prstDash val="solid"/>
-                    </a:lnB>
-                    <a:solidFill>
-                      <a:srgbClr val="EAF3F6"/>
-                    </a:solidFill>
-                  </a:tcPr>
-                </a:tc>
-              </a:tr>
-              <a:tr h="552450">
-                <a:tc>
-                  <a:txBody>
-                    <a:bodyPr/>
-                    <a:lstStyle/>
-                    <a:p>
-                      <a:r>
-                        <a:rPr sz="1875" b="0">
-                          <a:solidFill>
-                            <a:srgbClr val="152D43"/>
-                          </a:solidFill>
-                          <a:latin typeface="Arial"/>
-                          <a:ea typeface="Arial"/>
-                          <a:cs typeface="Arial"/>
-                        </a:rPr>
-                        <a:t>Reported quantity</a:t>
-                      </a:r>
-                    </a:p>
-                  </a:txBody>
-                  <a:tcPr marL="91440" marR="91440" marT="45720" marB="45720">
-                    <a:lnL w="9525">
-                      <a:solidFill>
-                        <a:srgbClr val="D7DFE5"/>
-                      </a:solidFill>
-                      <a:prstDash val="solid"/>
-                    </a:lnL>
-                    <a:lnR w="9525">
-                      <a:solidFill>
-                        <a:srgbClr val="D7DFE5"/>
-                      </a:solidFill>
-                      <a:prstDash val="solid"/>
-                    </a:lnR>
-                    <a:lnB w="9525">
-                      <a:solidFill>
-                        <a:srgbClr val="D7DFE5"/>
-                      </a:solidFill>
-                      <a:prstDash val="solid"/>
-                    </a:lnB>
-                    <a:solidFill>
-                      <a:srgbClr val="FFFFFF"/>
-                    </a:solidFill>
-                  </a:tcPr>
-                </a:tc>
-                <a:tc>
-                  <a:txBody>
-                    <a:bodyPr/>
-                    <a:lstStyle/>
-                    <a:p>
-                      <a:r>
-                        <a:rPr sz="1875" b="0">
-                          <a:solidFill>
-                            <a:srgbClr val="152D43"/>
-                          </a:solidFill>
-                          <a:latin typeface="Arial"/>
-                          <a:ea typeface="Arial"/>
-                          <a:cs typeface="Arial"/>
-                        </a:rPr>
-                        <a:t>Staged GPU timeline mean</a:t>
-                      </a:r>
-                    </a:p>
-                  </a:txBody>
-                  <a:tcPr marL="91440" marR="91440" marT="45720" marB="45720">
-                    <a:lnR w="9525">
-                      <a:solidFill>
-                        <a:srgbClr val="D7DFE5"/>
-                      </a:solidFill>
-                      <a:prstDash val="solid"/>
-                    </a:lnR>
-                    <a:lnB w="9525">
-                      <a:solidFill>
-                        <a:srgbClr val="D7DFE5"/>
-                      </a:solidFill>
-                      <a:prstDash val="solid"/>
-                    </a:lnB>
-                    <a:solidFill>
-                      <a:srgbClr val="FFFFFF"/>
-                    </a:solidFill>
-                  </a:tcPr>
-                </a:tc>
-                <a:tc>
-                  <a:txBody>
-                    <a:bodyPr/>
-                    <a:lstStyle/>
-                    <a:p>
-                      <a:r>
-                        <a:rPr sz="1875" b="0">
-                          <a:solidFill>
-                            <a:srgbClr val="152D43"/>
-                          </a:solidFill>
-                          <a:latin typeface="Arial"/>
-                          <a:ea typeface="Arial"/>
-                          <a:cs typeface="Arial"/>
-                        </a:rPr>
-                        <a:t>Original overflow PSNR</a:t>
-                      </a:r>
-                    </a:p>
-                  </a:txBody>
-                  <a:tcPr marL="91440" marR="91440" marT="45720" marB="45720">
-                    <a:lnR w="9525">
-                      <a:solidFill>
-                        <a:srgbClr val="D7DFE5"/>
-                      </a:solidFill>
-                      <a:prstDash val="solid"/>
-                    </a:lnR>
-                    <a:lnB w="9525">
-                      <a:solidFill>
-                        <a:srgbClr val="D7DFE5"/>
-                      </a:solidFill>
-                      <a:prstDash val="solid"/>
-                    </a:lnB>
-                    <a:solidFill>
-                      <a:srgbClr val="FFFFFF"/>
-                    </a:solidFill>
-                  </a:tcPr>
-                </a:tc>
-              </a:tr>
-            </a:tbl>
+          <a:graphicData uri="http://schemas.openxmlformats.org/drawingml/2006/chart">
+            <c:chart xmlns:r="http://schemas.openxmlformats.org/officeDocument/2006/relationships" xmlns:c="http://schemas.openxmlformats.org/drawingml/2006/chart" r:id="R0f94985e972f4ef5"/>
           </a:graphicData>
         </a:graphic>
       </p:graphicFrame>
@@ -7824,19 +7032,244 @@
           <p:cNvPr id="5" name="">
             <a:extLst xmlns:a="http://schemas.openxmlformats.org/drawingml/2006/main">
               <a:ext uri="{FF2B5EF4-FFF2-40B4-BE49-F238E27FC236}">
-                <a16:creationId xmlns:a16="http://schemas.microsoft.com/office/drawing/2014/main" id="{8894DAC9-BB36-46E3-9A7A-1D6F66D65C05}"/>
-              </a:ext>
-            </a:extLst>
-          </p:cNvPr>
-          <p:cNvSpPr>
-            <a:spLocks xmlns:a="http://schemas.openxmlformats.org/drawingml/2006/main" noGrp="1"/>
-          </p:cNvSpPr>
-          <p:nvPr/>
-        </p:nvSpPr>
-        <p:spPr>
-          <a:xfrm xmlns:a="http://schemas.openxmlformats.org/drawingml/2006/main">
-            <a:off x="609600" y="5191125"/>
-            <a:ext cx="10953750" cy="361950"/>
+                <a16:creationId xmlns:a16="http://schemas.microsoft.com/office/drawing/2014/main" id="{FC8587D0-E7AA-4B18-8103-CB9E233E9980}"/>
+              </a:ext>
+            </a:extLst>
+          </p:cNvPr>
+          <p:cNvSpPr>
+            <a:spLocks xmlns:a="http://schemas.openxmlformats.org/drawingml/2006/main" noGrp="1"/>
+          </p:cNvSpPr>
+          <p:nvPr/>
+        </p:nvSpPr>
+        <p:spPr>
+          <a:xfrm xmlns:a="http://schemas.openxmlformats.org/drawingml/2006/main">
+            <a:off x="609600" y="1381125"/>
+            <a:ext cx="10906125" cy="333375"/>
+          </a:xfrm>
+          <a:prstGeom xmlns:a="http://schemas.openxmlformats.org/drawingml/2006/main" prst="rect">
+            <a:avLst/>
+          </a:prstGeom>
+          <a:noFill xmlns:a="http://schemas.openxmlformats.org/drawingml/2006/main"/>
+          <a:ln xmlns:a="http://schemas.openxmlformats.org/drawingml/2006/main" w="0">
+            <a:noFill/>
+          </a:ln>
+        </p:spPr>
+        <p:txBody>
+          <a:bodyPr xmlns:a="http://schemas.openxmlformats.org/drawingml/2006/main" lIns="0" tIns="0" rIns="0" bIns="0"/>
+          <a:lstStyle xmlns:a="http://schemas.openxmlformats.org/drawingml/2006/main"/>
+          <a:p xmlns:a="http://schemas.openxmlformats.org/drawingml/2006/main">
+            <a:r>
+              <a:rPr sz="1875" b="1">
+                <a:solidFill>
+                  <a:srgbClr val="086B93"/>
+                </a:solidFill>
+                <a:latin typeface="Arial"/>
+                <a:ea typeface="Arial"/>
+                <a:cs typeface="Arial"/>
+              </a:rPr>
+              <a:t>4 workloads × frame 39; 100 repetitions/path. GPU timeline, not wall time.</a:t>
+            </a:r>
+          </a:p>
+        </p:txBody>
+      </p:sp>
+      <p:sp>
+        <p:nvSpPr>
+          <p:cNvPr id="6" name="">
+            <a:extLst xmlns:a="http://schemas.openxmlformats.org/drawingml/2006/main">
+              <a:ext uri="{FF2B5EF4-FFF2-40B4-BE49-F238E27FC236}">
+                <a16:creationId xmlns:a16="http://schemas.microsoft.com/office/drawing/2014/main" id="{5B1C1FE3-DC60-44C2-8E0A-0AA8C4B070F1}"/>
+              </a:ext>
+            </a:extLst>
+          </p:cNvPr>
+          <p:cNvSpPr>
+            <a:spLocks xmlns:a="http://schemas.openxmlformats.org/drawingml/2006/main" noGrp="1"/>
+          </p:cNvSpPr>
+          <p:nvPr/>
+        </p:nvSpPr>
+        <p:spPr>
+          <a:xfrm xmlns:a="http://schemas.openxmlformats.org/drawingml/2006/main">
+            <a:off x="8858250" y="2028825"/>
+            <a:ext cx="2667000" cy="476250"/>
+          </a:xfrm>
+          <a:prstGeom xmlns:a="http://schemas.openxmlformats.org/drawingml/2006/main" prst="rect">
+            <a:avLst/>
+          </a:prstGeom>
+          <a:noFill xmlns:a="http://schemas.openxmlformats.org/drawingml/2006/main"/>
+          <a:ln xmlns:a="http://schemas.openxmlformats.org/drawingml/2006/main" w="0">
+            <a:noFill/>
+          </a:ln>
+        </p:spPr>
+        <p:txBody>
+          <a:bodyPr xmlns:a="http://schemas.openxmlformats.org/drawingml/2006/main" lIns="0" tIns="0" rIns="0" bIns="0"/>
+          <a:lstStyle xmlns:a="http://schemas.openxmlformats.org/drawingml/2006/main"/>
+          <a:p xmlns:a="http://schemas.openxmlformats.org/drawingml/2006/main">
+            <a:r>
+              <a:rPr sz="2625" b="1">
+                <a:solidFill>
+                  <a:srgbClr val="086B93"/>
+                </a:solidFill>
+                <a:latin typeface="Arial"/>
+                <a:ea typeface="Arial"/>
+                <a:cs typeface="Arial"/>
+              </a:rPr>
+              <a:t>2.8% region</a:t>
+            </a:r>
+          </a:p>
+        </p:txBody>
+      </p:sp>
+      <p:sp>
+        <p:nvSpPr>
+          <p:cNvPr id="7" name="">
+            <a:extLst xmlns:a="http://schemas.openxmlformats.org/drawingml/2006/main">
+              <a:ext uri="{FF2B5EF4-FFF2-40B4-BE49-F238E27FC236}">
+                <a16:creationId xmlns:a16="http://schemas.microsoft.com/office/drawing/2014/main" id="{399E4EE5-A198-4B0B-B86E-B0A3A6031AC7}"/>
+              </a:ext>
+            </a:extLst>
+          </p:cNvPr>
+          <p:cNvSpPr>
+            <a:spLocks xmlns:a="http://schemas.openxmlformats.org/drawingml/2006/main" noGrp="1"/>
+          </p:cNvSpPr>
+          <p:nvPr/>
+        </p:nvSpPr>
+        <p:spPr>
+          <a:xfrm xmlns:a="http://schemas.openxmlformats.org/drawingml/2006/main">
+            <a:off x="8858250" y="2695575"/>
+            <a:ext cx="2857500" cy="619125"/>
+          </a:xfrm>
+          <a:prstGeom xmlns:a="http://schemas.openxmlformats.org/drawingml/2006/main" prst="rect">
+            <a:avLst/>
+          </a:prstGeom>
+          <a:noFill xmlns:a="http://schemas.openxmlformats.org/drawingml/2006/main"/>
+          <a:ln xmlns:a="http://schemas.openxmlformats.org/drawingml/2006/main" w="0">
+            <a:noFill/>
+          </a:ln>
+        </p:spPr>
+        <p:txBody>
+          <a:bodyPr xmlns:a="http://schemas.openxmlformats.org/drawingml/2006/main" lIns="0" tIns="0" rIns="0" bIns="0"/>
+          <a:lstStyle xmlns:a="http://schemas.openxmlformats.org/drawingml/2006/main"/>
+          <a:p xmlns:a="http://schemas.openxmlformats.org/drawingml/2006/main">
+            <a:r>
+              <a:rPr sz="3375" b="1">
+                <a:solidFill>
+                  <a:srgbClr val="152D43"/>
+                </a:solidFill>
+                <a:latin typeface="Arial"/>
+                <a:ea typeface="Arial"/>
+                <a:cs typeface="Arial"/>
+              </a:rPr>
+              <a:t>5.462 ms</a:t>
+            </a:r>
+          </a:p>
+        </p:txBody>
+      </p:sp>
+      <p:sp>
+        <p:nvSpPr>
+          <p:cNvPr id="8" name="">
+            <a:extLst xmlns:a="http://schemas.openxmlformats.org/drawingml/2006/main">
+              <a:ext uri="{FF2B5EF4-FFF2-40B4-BE49-F238E27FC236}">
+                <a16:creationId xmlns:a16="http://schemas.microsoft.com/office/drawing/2014/main" id="{4891ECD1-451A-4461-A687-264117661EBE}"/>
+              </a:ext>
+            </a:extLst>
+          </p:cNvPr>
+          <p:cNvSpPr>
+            <a:spLocks xmlns:a="http://schemas.openxmlformats.org/drawingml/2006/main" noGrp="1"/>
+          </p:cNvSpPr>
+          <p:nvPr/>
+        </p:nvSpPr>
+        <p:spPr>
+          <a:xfrm xmlns:a="http://schemas.openxmlformats.org/drawingml/2006/main">
+            <a:off x="8620125" y="3352800"/>
+            <a:ext cx="2952750" cy="381000"/>
+          </a:xfrm>
+          <a:prstGeom xmlns:a="http://schemas.openxmlformats.org/drawingml/2006/main" prst="rect">
+            <a:avLst/>
+          </a:prstGeom>
+          <a:noFill xmlns:a="http://schemas.openxmlformats.org/drawingml/2006/main"/>
+          <a:ln xmlns:a="http://schemas.openxmlformats.org/drawingml/2006/main" w="0">
+            <a:noFill/>
+          </a:ln>
+        </p:spPr>
+        <p:txBody>
+          <a:bodyPr xmlns:a="http://schemas.openxmlformats.org/drawingml/2006/main" lIns="0" tIns="0" rIns="0" bIns="0"/>
+          <a:lstStyle xmlns:a="http://schemas.openxmlformats.org/drawingml/2006/main"/>
+          <a:p xmlns:a="http://schemas.openxmlformats.org/drawingml/2006/main">
+            <a:r>
+              <a:rPr sz="1725" b="0">
+                <a:solidFill>
+                  <a:srgbClr val="536675"/>
+                </a:solidFill>
+                <a:latin typeface="Arial"/>
+                <a:ea typeface="Arial"/>
+                <a:cs typeface="Arial"/>
+              </a:rPr>
+              <a:t>decode + reconstruction</a:t>
+            </a:r>
+          </a:p>
+        </p:txBody>
+      </p:sp>
+      <p:sp>
+        <p:nvSpPr>
+          <p:cNvPr id="9" name="">
+            <a:extLst xmlns:a="http://schemas.openxmlformats.org/drawingml/2006/main">
+              <a:ext uri="{FF2B5EF4-FFF2-40B4-BE49-F238E27FC236}">
+                <a16:creationId xmlns:a16="http://schemas.microsoft.com/office/drawing/2014/main" id="{052CEAE3-571A-4803-8325-765F7E19F323}"/>
+              </a:ext>
+            </a:extLst>
+          </p:cNvPr>
+          <p:cNvSpPr>
+            <a:spLocks xmlns:a="http://schemas.openxmlformats.org/drawingml/2006/main" noGrp="1"/>
+          </p:cNvSpPr>
+          <p:nvPr/>
+        </p:nvSpPr>
+        <p:spPr>
+          <a:xfrm xmlns:a="http://schemas.openxmlformats.org/drawingml/2006/main">
+            <a:off x="8858250" y="4019550"/>
+            <a:ext cx="2667000" cy="590550"/>
+          </a:xfrm>
+          <a:prstGeom xmlns:a="http://schemas.openxmlformats.org/drawingml/2006/main" prst="rect">
+            <a:avLst/>
+          </a:prstGeom>
+          <a:noFill xmlns:a="http://schemas.openxmlformats.org/drawingml/2006/main"/>
+          <a:ln xmlns:a="http://schemas.openxmlformats.org/drawingml/2006/main" w="0">
+            <a:noFill/>
+          </a:ln>
+        </p:spPr>
+        <p:txBody>
+          <a:bodyPr xmlns:a="http://schemas.openxmlformats.org/drawingml/2006/main" lIns="0" tIns="0" rIns="0" bIns="0"/>
+          <a:lstStyle xmlns:a="http://schemas.openxmlformats.org/drawingml/2006/main"/>
+          <a:p xmlns:a="http://schemas.openxmlformats.org/drawingml/2006/main">
+            <a:r>
+              <a:rPr sz="3450" b="1">
+                <a:solidFill>
+                  <a:srgbClr val="148B83"/>
+                </a:solidFill>
+                <a:latin typeface="Arial"/>
+                <a:ea typeface="Arial"/>
+                <a:cs typeface="Arial"/>
+              </a:rPr>
+              <a:t>1.83×</a:t>
+            </a:r>
+          </a:p>
+        </p:txBody>
+      </p:sp>
+      <p:sp>
+        <p:nvSpPr>
+          <p:cNvPr id="10" name="">
+            <a:extLst xmlns:a="http://schemas.openxmlformats.org/drawingml/2006/main">
+              <a:ext uri="{FF2B5EF4-FFF2-40B4-BE49-F238E27FC236}">
+                <a16:creationId xmlns:a16="http://schemas.microsoft.com/office/drawing/2014/main" id="{CA760181-77EA-41D6-A00C-EAA672DAD0CC}"/>
+              </a:ext>
+            </a:extLst>
+          </p:cNvPr>
+          <p:cNvSpPr>
+            <a:spLocks xmlns:a="http://schemas.openxmlformats.org/drawingml/2006/main" noGrp="1"/>
+          </p:cNvSpPr>
+          <p:nvPr/>
+        </p:nvSpPr>
+        <p:spPr>
+          <a:xfrm xmlns:a="http://schemas.openxmlformats.org/drawingml/2006/main">
+            <a:off x="8858250" y="4667250"/>
+            <a:ext cx="2667000" cy="381000"/>
           </a:xfrm>
           <a:prstGeom xmlns:a="http://schemas.openxmlformats.org/drawingml/2006/main" prst="rect">
             <a:avLst/>
@@ -7853,68 +7286,23 @@
             <a:r>
               <a:rPr sz="1875" b="0">
                 <a:solidFill>
-                  <a:srgbClr val="152D43"/>
+                  <a:srgbClr val="536675"/>
                 </a:solidFill>
                 <a:latin typeface="Arial"/>
                 <a:ea typeface="Arial"/>
                 <a:cs typeface="Arial"/>
               </a:rPr>
-              <a:t>Timing excludes input/output copies, allocation, disk I/O, network, decoding, and display.</a:t>
+              <a:t>versus Full + decode</a:t>
             </a:r>
           </a:p>
         </p:txBody>
       </p:sp>
       <p:sp>
         <p:nvSpPr>
-          <p:cNvPr id="6" name="">
-            <a:extLst xmlns:a="http://schemas.openxmlformats.org/drawingml/2006/main">
-              <a:ext uri="{FF2B5EF4-FFF2-40B4-BE49-F238E27FC236}">
-                <a16:creationId xmlns:a16="http://schemas.microsoft.com/office/drawing/2014/main" id="{32090890-00C3-4E17-AC68-4B226388B7EA}"/>
-              </a:ext>
-            </a:extLst>
-          </p:cNvPr>
-          <p:cNvSpPr>
-            <a:spLocks xmlns:a="http://schemas.openxmlformats.org/drawingml/2006/main" noGrp="1"/>
-          </p:cNvSpPr>
-          <p:nvPr/>
-        </p:nvSpPr>
-        <p:spPr>
-          <a:xfrm xmlns:a="http://schemas.openxmlformats.org/drawingml/2006/main">
-            <a:off x="609600" y="5600700"/>
-            <a:ext cx="10953750" cy="361950"/>
-          </a:xfrm>
-          <a:prstGeom xmlns:a="http://schemas.openxmlformats.org/drawingml/2006/main" prst="rect">
-            <a:avLst/>
-          </a:prstGeom>
-          <a:noFill xmlns:a="http://schemas.openxmlformats.org/drawingml/2006/main"/>
-          <a:ln xmlns:a="http://schemas.openxmlformats.org/drawingml/2006/main" w="0">
-            <a:noFill/>
-          </a:ln>
-        </p:spPr>
-        <p:txBody>
-          <a:bodyPr xmlns:a="http://schemas.openxmlformats.org/drawingml/2006/main" lIns="0" tIns="0" rIns="0" bIns="0"/>
-          <a:lstStyle xmlns:a="http://schemas.openxmlformats.org/drawingml/2006/main"/>
-          <a:p xmlns:a="http://schemas.openxmlformats.org/drawingml/2006/main">
-            <a:r>
-              <a:rPr sz="1875" b="1">
-                <a:solidFill>
-                  <a:srgbClr val="086B93"/>
-                </a:solidFill>
-                <a:latin typeface="Arial"/>
-                <a:ea typeface="Arial"/>
-                <a:cs typeface="Arial"/>
-              </a:rPr>
-              <a:t>Slides 6–7 add one fixed 2 ms/frame decode budget; this is not measured end-to-end.</a:t>
-            </a:r>
-          </a:p>
-        </p:txBody>
-      </p:sp>
-      <p:sp>
-        <p:nvSpPr>
-          <p:cNvPr id="7" name="">
-            <a:extLst xmlns:a="http://schemas.openxmlformats.org/drawingml/2006/main">
-              <a:ext uri="{FF2B5EF4-FFF2-40B4-BE49-F238E27FC236}">
-                <a16:creationId xmlns:a16="http://schemas.microsoft.com/office/drawing/2014/main" id="{A276807B-F1E4-43B9-9A84-8836807C2ED8}"/>
+          <p:cNvPr id="11" name="">
+            <a:extLst xmlns:a="http://schemas.openxmlformats.org/drawingml/2006/main">
+              <a:ext uri="{FF2B5EF4-FFF2-40B4-BE49-F238E27FC236}">
+                <a16:creationId xmlns:a16="http://schemas.microsoft.com/office/drawing/2014/main" id="{5AAB3EC2-6239-40D6-BC60-602C8853129C}"/>
               </a:ext>
             </a:extLst>
           </p:cNvPr>
@@ -7949,7 +7337,7 @@
                 <a:ea typeface="Arial"/>
                 <a:cs typeface="Arial"/>
               </a:rPr>
-              <a:t>Timing and quality are from separate experiments. No new quality equivalence or jointly measured trade-off is claimed.</a:t>
+              <a:t>Derived budget, not measured end-to-end. Copies excluded. Savings include reduced clearing work; no optimal-Full claim.</a:t>
             </a:r>
           </a:p>
         </p:txBody>
@@ -7957,7 +7345,7 @@
     </p:spTree>
     <p:extLst>
       <p:ext uri="{BB962C8B-B14F-4D97-AF65-F5344CB8AC3E}">
-        <p14:creationId xmlns:p14="http://schemas.microsoft.com/office/powerpoint/2010/main" val="1407810125"/>
+        <p14:creationId xmlns:p14="http://schemas.microsoft.com/office/powerpoint/2010/main" val="1223246617"/>
       </p:ext>
     </p:extLst>
   </p:cSld>
@@ -7985,10 +7373,10 @@
       </p:grpSpPr>
       <p:sp>
         <p:nvSpPr>
-          <p:cNvPr id="12" name="">
-            <a:extLst xmlns:a="http://schemas.openxmlformats.org/drawingml/2006/main">
-              <a:ext uri="{FF2B5EF4-FFF2-40B4-BE49-F238E27FC236}">
-                <a16:creationId xmlns:a16="http://schemas.microsoft.com/office/drawing/2014/main" id="{574119EA-2228-4ED6-8283-648A928414D9}"/>
+          <p:cNvPr id="8" name="">
+            <a:extLst xmlns:a="http://schemas.openxmlformats.org/drawingml/2006/main">
+              <a:ext uri="{FF2B5EF4-FFF2-40B4-BE49-F238E27FC236}">
+                <a16:creationId xmlns:a16="http://schemas.microsoft.com/office/drawing/2014/main" id="{25297BD3-542B-42B4-A0BE-9AC4C6BAB68E}"/>
               </a:ext>
             </a:extLst>
           </p:cNvPr>
@@ -8023,7 +7411,7 @@
                 <a:ea typeface="Arial"/>
                 <a:cs typeface="Arial"/>
               </a:rPr>
-              <a:t>30W CUDA C++: decode budget + reconstruction</a:t>
+              <a:t>Quality and timing across region sizes</a:t>
             </a:r>
           </a:p>
         </p:txBody>
@@ -8033,7 +7421,7 @@
           <p:cNvPr id="2" name="">
             <a:extLst xmlns:a="http://schemas.openxmlformats.org/drawingml/2006/main">
               <a:ext uri="{FF2B5EF4-FFF2-40B4-BE49-F238E27FC236}">
-                <a16:creationId xmlns:a16="http://schemas.microsoft.com/office/drawing/2014/main" id="{19A0A1B8-59B0-4AA8-9822-2011A185E765}"/>
+                <a16:creationId xmlns:a16="http://schemas.microsoft.com/office/drawing/2014/main" id="{7A42AC4E-0C09-4651-80AE-F2A753F72686}"/>
               </a:ext>
             </a:extLst>
           </p:cNvPr>
@@ -8063,7 +7451,7 @@
           <p:cNvPr id="3" name="">
             <a:extLst xmlns:a="http://schemas.openxmlformats.org/drawingml/2006/main">
               <a:ext uri="{FF2B5EF4-FFF2-40B4-BE49-F238E27FC236}">
-                <a16:creationId xmlns:a16="http://schemas.microsoft.com/office/drawing/2014/main" id="{2865A3A5-0A9D-4FF9-9788-719D611F0E18}"/>
+                <a16:creationId xmlns:a16="http://schemas.microsoft.com/office/drawing/2014/main" id="{AB764DB4-DBBE-485A-A0BD-3495CBDA0574}"/>
               </a:ext>
             </a:extLst>
           </p:cNvPr>
@@ -8105,496 +7493,10 @@
       </p:sp>
       <p:graphicFrame>
         <p:nvGraphicFramePr>
-          <p:cNvPr id="4" name="Chart">
-            <a:extLst xmlns:a="http://schemas.openxmlformats.org/drawingml/2006/main">
-              <a:ext uri="{FF2B5EF4-FFF2-40B4-BE49-F238E27FC236}">
-                <a16:creationId xmlns:a16="http://schemas.microsoft.com/office/drawing/2014/main" id="{E621F1A7-35AB-4CE2-B7EE-9A2C1624DF71}"/>
-              </a:ext>
-            </a:extLst>
-          </p:cNvPr>
-          <p:cNvGraphicFramePr/>
-          <p:nvPr/>
-        </p:nvGraphicFramePr>
-        <p:xfrm>
-          <a:off xmlns:a="http://schemas.openxmlformats.org/drawingml/2006/main" x="609600" y="1828800"/>
-          <a:ext xmlns:a="http://schemas.openxmlformats.org/drawingml/2006/main" cx="7715250" cy="3752850"/>
-        </p:xfrm>
-        <a:graphic xmlns:a="http://schemas.openxmlformats.org/drawingml/2006/main">
-          <a:graphicData uri="http://schemas.openxmlformats.org/drawingml/2006/chart">
-            <c:chart xmlns:r="http://schemas.openxmlformats.org/officeDocument/2006/relationships" xmlns:c="http://schemas.openxmlformats.org/drawingml/2006/chart" r:id="R50ab8559b0a64bd2"/>
-          </a:graphicData>
-        </a:graphic>
-      </p:graphicFrame>
-      <p:sp>
-        <p:nvSpPr>
-          <p:cNvPr id="5" name="">
-            <a:extLst xmlns:a="http://schemas.openxmlformats.org/drawingml/2006/main">
-              <a:ext uri="{FF2B5EF4-FFF2-40B4-BE49-F238E27FC236}">
-                <a16:creationId xmlns:a16="http://schemas.microsoft.com/office/drawing/2014/main" id="{2DDA2F4B-09E7-4C10-9C42-E91AE1E4632F}"/>
-              </a:ext>
-            </a:extLst>
-          </p:cNvPr>
-          <p:cNvSpPr>
-            <a:spLocks xmlns:a="http://schemas.openxmlformats.org/drawingml/2006/main" noGrp="1"/>
-          </p:cNvSpPr>
-          <p:nvPr/>
-        </p:nvSpPr>
-        <p:spPr>
-          <a:xfrm xmlns:a="http://schemas.openxmlformats.org/drawingml/2006/main">
-            <a:off x="609600" y="1381125"/>
-            <a:ext cx="10906125" cy="333375"/>
-          </a:xfrm>
-          <a:prstGeom xmlns:a="http://schemas.openxmlformats.org/drawingml/2006/main" prst="rect">
-            <a:avLst/>
-          </a:prstGeom>
-          <a:noFill xmlns:a="http://schemas.openxmlformats.org/drawingml/2006/main"/>
-          <a:ln xmlns:a="http://schemas.openxmlformats.org/drawingml/2006/main" w="0">
-            <a:noFill/>
-          </a:ln>
-        </p:spPr>
-        <p:txBody>
-          <a:bodyPr xmlns:a="http://schemas.openxmlformats.org/drawingml/2006/main" lIns="0" tIns="0" rIns="0" bIns="0"/>
-          <a:lstStyle xmlns:a="http://schemas.openxmlformats.org/drawingml/2006/main"/>
-          <a:p xmlns:a="http://schemas.openxmlformats.org/drawingml/2006/main">
-            <a:r>
-              <a:rPr sz="1875" b="1">
-                <a:solidFill>
-                  <a:srgbClr val="086B93"/>
-                </a:solidFill>
-                <a:latin typeface="Arial"/>
-                <a:ea typeface="Arial"/>
-                <a:cs typeface="Arial"/>
-              </a:rPr>
-              <a:t>4 workloads × frame 39; 100 repetitions/path. GPU timeline, not wall time.</a:t>
-            </a:r>
-          </a:p>
-        </p:txBody>
-      </p:sp>
-      <p:sp>
-        <p:nvSpPr>
-          <p:cNvPr id="6" name="">
-            <a:extLst xmlns:a="http://schemas.openxmlformats.org/drawingml/2006/main">
-              <a:ext uri="{FF2B5EF4-FFF2-40B4-BE49-F238E27FC236}">
-                <a16:creationId xmlns:a16="http://schemas.microsoft.com/office/drawing/2014/main" id="{C0C809F9-13D3-411E-89D3-64A96C88D600}"/>
-              </a:ext>
-            </a:extLst>
-          </p:cNvPr>
-          <p:cNvSpPr>
-            <a:spLocks xmlns:a="http://schemas.openxmlformats.org/drawingml/2006/main" noGrp="1"/>
-          </p:cNvSpPr>
-          <p:nvPr/>
-        </p:nvSpPr>
-        <p:spPr>
-          <a:xfrm xmlns:a="http://schemas.openxmlformats.org/drawingml/2006/main">
-            <a:off x="8858250" y="2028825"/>
-            <a:ext cx="2667000" cy="476250"/>
-          </a:xfrm>
-          <a:prstGeom xmlns:a="http://schemas.openxmlformats.org/drawingml/2006/main" prst="rect">
-            <a:avLst/>
-          </a:prstGeom>
-          <a:noFill xmlns:a="http://schemas.openxmlformats.org/drawingml/2006/main"/>
-          <a:ln xmlns:a="http://schemas.openxmlformats.org/drawingml/2006/main" w="0">
-            <a:noFill/>
-          </a:ln>
-        </p:spPr>
-        <p:txBody>
-          <a:bodyPr xmlns:a="http://schemas.openxmlformats.org/drawingml/2006/main" lIns="0" tIns="0" rIns="0" bIns="0"/>
-          <a:lstStyle xmlns:a="http://schemas.openxmlformats.org/drawingml/2006/main"/>
-          <a:p xmlns:a="http://schemas.openxmlformats.org/drawingml/2006/main">
-            <a:r>
-              <a:rPr sz="2625" b="1">
-                <a:solidFill>
-                  <a:srgbClr val="086B93"/>
-                </a:solidFill>
-                <a:latin typeface="Arial"/>
-                <a:ea typeface="Arial"/>
-                <a:cs typeface="Arial"/>
-              </a:rPr>
-              <a:t>2.8% region</a:t>
-            </a:r>
-          </a:p>
-        </p:txBody>
-      </p:sp>
-      <p:sp>
-        <p:nvSpPr>
-          <p:cNvPr id="7" name="">
-            <a:extLst xmlns:a="http://schemas.openxmlformats.org/drawingml/2006/main">
-              <a:ext uri="{FF2B5EF4-FFF2-40B4-BE49-F238E27FC236}">
-                <a16:creationId xmlns:a16="http://schemas.microsoft.com/office/drawing/2014/main" id="{D00AA083-073B-4DE1-B673-55873BF297C0}"/>
-              </a:ext>
-            </a:extLst>
-          </p:cNvPr>
-          <p:cNvSpPr>
-            <a:spLocks xmlns:a="http://schemas.openxmlformats.org/drawingml/2006/main" noGrp="1"/>
-          </p:cNvSpPr>
-          <p:nvPr/>
-        </p:nvSpPr>
-        <p:spPr>
-          <a:xfrm xmlns:a="http://schemas.openxmlformats.org/drawingml/2006/main">
-            <a:off x="8858250" y="2695575"/>
-            <a:ext cx="2857500" cy="619125"/>
-          </a:xfrm>
-          <a:prstGeom xmlns:a="http://schemas.openxmlformats.org/drawingml/2006/main" prst="rect">
-            <a:avLst/>
-          </a:prstGeom>
-          <a:noFill xmlns:a="http://schemas.openxmlformats.org/drawingml/2006/main"/>
-          <a:ln xmlns:a="http://schemas.openxmlformats.org/drawingml/2006/main" w="0">
-            <a:noFill/>
-          </a:ln>
-        </p:spPr>
-        <p:txBody>
-          <a:bodyPr xmlns:a="http://schemas.openxmlformats.org/drawingml/2006/main" lIns="0" tIns="0" rIns="0" bIns="0"/>
-          <a:lstStyle xmlns:a="http://schemas.openxmlformats.org/drawingml/2006/main"/>
-          <a:p xmlns:a="http://schemas.openxmlformats.org/drawingml/2006/main">
-            <a:r>
-              <a:rPr sz="3375" b="1">
-                <a:solidFill>
-                  <a:srgbClr val="152D43"/>
-                </a:solidFill>
-                <a:latin typeface="Arial"/>
-                <a:ea typeface="Arial"/>
-                <a:cs typeface="Arial"/>
-              </a:rPr>
-              <a:t>5.462 ms</a:t>
-            </a:r>
-          </a:p>
-        </p:txBody>
-      </p:sp>
-      <p:sp>
-        <p:nvSpPr>
-          <p:cNvPr id="8" name="">
-            <a:extLst xmlns:a="http://schemas.openxmlformats.org/drawingml/2006/main">
-              <a:ext uri="{FF2B5EF4-FFF2-40B4-BE49-F238E27FC236}">
-                <a16:creationId xmlns:a16="http://schemas.microsoft.com/office/drawing/2014/main" id="{C5C18691-F595-4DC0-B750-4289900CCC51}"/>
-              </a:ext>
-            </a:extLst>
-          </p:cNvPr>
-          <p:cNvSpPr>
-            <a:spLocks xmlns:a="http://schemas.openxmlformats.org/drawingml/2006/main" noGrp="1"/>
-          </p:cNvSpPr>
-          <p:nvPr/>
-        </p:nvSpPr>
-        <p:spPr>
-          <a:xfrm xmlns:a="http://schemas.openxmlformats.org/drawingml/2006/main">
-            <a:off x="8620125" y="3352800"/>
-            <a:ext cx="2952750" cy="381000"/>
-          </a:xfrm>
-          <a:prstGeom xmlns:a="http://schemas.openxmlformats.org/drawingml/2006/main" prst="rect">
-            <a:avLst/>
-          </a:prstGeom>
-          <a:noFill xmlns:a="http://schemas.openxmlformats.org/drawingml/2006/main"/>
-          <a:ln xmlns:a="http://schemas.openxmlformats.org/drawingml/2006/main" w="0">
-            <a:noFill/>
-          </a:ln>
-        </p:spPr>
-        <p:txBody>
-          <a:bodyPr xmlns:a="http://schemas.openxmlformats.org/drawingml/2006/main" lIns="0" tIns="0" rIns="0" bIns="0"/>
-          <a:lstStyle xmlns:a="http://schemas.openxmlformats.org/drawingml/2006/main"/>
-          <a:p xmlns:a="http://schemas.openxmlformats.org/drawingml/2006/main">
-            <a:r>
-              <a:rPr sz="1725" b="0">
-                <a:solidFill>
-                  <a:srgbClr val="536675"/>
-                </a:solidFill>
-                <a:latin typeface="Arial"/>
-                <a:ea typeface="Arial"/>
-                <a:cs typeface="Arial"/>
-              </a:rPr>
-              <a:t>decode + reconstruction</a:t>
-            </a:r>
-          </a:p>
-        </p:txBody>
-      </p:sp>
-      <p:sp>
-        <p:nvSpPr>
-          <p:cNvPr id="9" name="">
-            <a:extLst xmlns:a="http://schemas.openxmlformats.org/drawingml/2006/main">
-              <a:ext uri="{FF2B5EF4-FFF2-40B4-BE49-F238E27FC236}">
-                <a16:creationId xmlns:a16="http://schemas.microsoft.com/office/drawing/2014/main" id="{B8D40134-A836-4C82-A068-06D41A87C6C9}"/>
-              </a:ext>
-            </a:extLst>
-          </p:cNvPr>
-          <p:cNvSpPr>
-            <a:spLocks xmlns:a="http://schemas.openxmlformats.org/drawingml/2006/main" noGrp="1"/>
-          </p:cNvSpPr>
-          <p:nvPr/>
-        </p:nvSpPr>
-        <p:spPr>
-          <a:xfrm xmlns:a="http://schemas.openxmlformats.org/drawingml/2006/main">
-            <a:off x="8858250" y="4019550"/>
-            <a:ext cx="2667000" cy="590550"/>
-          </a:xfrm>
-          <a:prstGeom xmlns:a="http://schemas.openxmlformats.org/drawingml/2006/main" prst="rect">
-            <a:avLst/>
-          </a:prstGeom>
-          <a:noFill xmlns:a="http://schemas.openxmlformats.org/drawingml/2006/main"/>
-          <a:ln xmlns:a="http://schemas.openxmlformats.org/drawingml/2006/main" w="0">
-            <a:noFill/>
-          </a:ln>
-        </p:spPr>
-        <p:txBody>
-          <a:bodyPr xmlns:a="http://schemas.openxmlformats.org/drawingml/2006/main" lIns="0" tIns="0" rIns="0" bIns="0"/>
-          <a:lstStyle xmlns:a="http://schemas.openxmlformats.org/drawingml/2006/main"/>
-          <a:p xmlns:a="http://schemas.openxmlformats.org/drawingml/2006/main">
-            <a:r>
-              <a:rPr sz="3450" b="1">
-                <a:solidFill>
-                  <a:srgbClr val="148B83"/>
-                </a:solidFill>
-                <a:latin typeface="Arial"/>
-                <a:ea typeface="Arial"/>
-                <a:cs typeface="Arial"/>
-              </a:rPr>
-              <a:t>1.83×</a:t>
-            </a:r>
-          </a:p>
-        </p:txBody>
-      </p:sp>
-      <p:sp>
-        <p:nvSpPr>
-          <p:cNvPr id="10" name="">
-            <a:extLst xmlns:a="http://schemas.openxmlformats.org/drawingml/2006/main">
-              <a:ext uri="{FF2B5EF4-FFF2-40B4-BE49-F238E27FC236}">
-                <a16:creationId xmlns:a16="http://schemas.microsoft.com/office/drawing/2014/main" id="{27525BB6-B97D-47EE-88BC-B323EA269B18}"/>
-              </a:ext>
-            </a:extLst>
-          </p:cNvPr>
-          <p:cNvSpPr>
-            <a:spLocks xmlns:a="http://schemas.openxmlformats.org/drawingml/2006/main" noGrp="1"/>
-          </p:cNvSpPr>
-          <p:nvPr/>
-        </p:nvSpPr>
-        <p:spPr>
-          <a:xfrm xmlns:a="http://schemas.openxmlformats.org/drawingml/2006/main">
-            <a:off x="8858250" y="4667250"/>
-            <a:ext cx="2667000" cy="381000"/>
-          </a:xfrm>
-          <a:prstGeom xmlns:a="http://schemas.openxmlformats.org/drawingml/2006/main" prst="rect">
-            <a:avLst/>
-          </a:prstGeom>
-          <a:noFill xmlns:a="http://schemas.openxmlformats.org/drawingml/2006/main"/>
-          <a:ln xmlns:a="http://schemas.openxmlformats.org/drawingml/2006/main" w="0">
-            <a:noFill/>
-          </a:ln>
-        </p:spPr>
-        <p:txBody>
-          <a:bodyPr xmlns:a="http://schemas.openxmlformats.org/drawingml/2006/main" lIns="0" tIns="0" rIns="0" bIns="0"/>
-          <a:lstStyle xmlns:a="http://schemas.openxmlformats.org/drawingml/2006/main"/>
-          <a:p xmlns:a="http://schemas.openxmlformats.org/drawingml/2006/main">
-            <a:r>
-              <a:rPr sz="1875" b="0">
-                <a:solidFill>
-                  <a:srgbClr val="536675"/>
-                </a:solidFill>
-                <a:latin typeface="Arial"/>
-                <a:ea typeface="Arial"/>
-                <a:cs typeface="Arial"/>
-              </a:rPr>
-              <a:t>versus Full + decode</a:t>
-            </a:r>
-          </a:p>
-        </p:txBody>
-      </p:sp>
-      <p:sp>
-        <p:nvSpPr>
-          <p:cNvPr id="11" name="">
-            <a:extLst xmlns:a="http://schemas.openxmlformats.org/drawingml/2006/main">
-              <a:ext uri="{FF2B5EF4-FFF2-40B4-BE49-F238E27FC236}">
-                <a16:creationId xmlns:a16="http://schemas.microsoft.com/office/drawing/2014/main" id="{F4B321A8-C7D4-43A3-86BE-868ECA677C0B}"/>
-              </a:ext>
-            </a:extLst>
-          </p:cNvPr>
-          <p:cNvSpPr>
-            <a:spLocks xmlns:a="http://schemas.openxmlformats.org/drawingml/2006/main" noGrp="1"/>
-          </p:cNvSpPr>
-          <p:nvPr/>
-        </p:nvSpPr>
-        <p:spPr>
-          <a:xfrm xmlns:a="http://schemas.openxmlformats.org/drawingml/2006/main">
-            <a:off x="609600" y="5924550"/>
-            <a:ext cx="10715625" cy="457200"/>
-          </a:xfrm>
-          <a:prstGeom xmlns:a="http://schemas.openxmlformats.org/drawingml/2006/main" prst="rect">
-            <a:avLst/>
-          </a:prstGeom>
-          <a:noFill xmlns:a="http://schemas.openxmlformats.org/drawingml/2006/main"/>
-          <a:ln xmlns:a="http://schemas.openxmlformats.org/drawingml/2006/main" w="0">
-            <a:noFill/>
-          </a:ln>
-        </p:spPr>
-        <p:txBody>
-          <a:bodyPr xmlns:a="http://schemas.openxmlformats.org/drawingml/2006/main" lIns="0" tIns="0" rIns="0" bIns="0"/>
-          <a:lstStyle xmlns:a="http://schemas.openxmlformats.org/drawingml/2006/main"/>
-          <a:p xmlns:a="http://schemas.openxmlformats.org/drawingml/2006/main">
-            <a:r>
-              <a:rPr sz="1500" b="0">
-                <a:solidFill>
-                  <a:srgbClr val="536675"/>
-                </a:solidFill>
-                <a:latin typeface="Arial"/>
-                <a:ea typeface="Arial"/>
-                <a:cs typeface="Arial"/>
-              </a:rPr>
-              <a:t>Derived budget, not measured end-to-end. Copies excluded. Savings include reduced clearing work; no optimal-Full claim.</a:t>
-            </a:r>
-          </a:p>
-        </p:txBody>
-      </p:sp>
-    </p:spTree>
-    <p:extLst>
-      <p:ext uri="{BB962C8B-B14F-4D97-AF65-F5344CB8AC3E}">
-        <p14:creationId xmlns:p14="http://schemas.microsoft.com/office/powerpoint/2010/main" val="1158442540"/>
-      </p:ext>
-    </p:extLst>
-  </p:cSld>
-</p:sld>
-</file>
-
-<file path=ppt/slides/slide7.xml><?xml version="1.0" encoding="utf-8"?>
-<p:sld xmlns:p="http://schemas.openxmlformats.org/presentationml/2006/main">
-  <p:cSld>
-    <p:bg>
-      <p:bgPr>
-        <a:solidFill xmlns:a="http://schemas.openxmlformats.org/drawingml/2006/main">
-          <a:srgbClr val="FFFFFF"/>
-        </a:solidFill>
-      </p:bgPr>
-    </p:bg>
-    <p:spTree>
-      <p:nvGrpSpPr>
-        <p:cNvPr id="1" name=""/>
-        <p:cNvGrpSpPr/>
-        <p:nvPr/>
-      </p:nvGrpSpPr>
-      <p:grpSpPr>
-        <a:xfrm xmlns:a="http://schemas.openxmlformats.org/drawingml/2006/main"/>
-      </p:grpSpPr>
-      <p:sp>
-        <p:nvSpPr>
-          <p:cNvPr id="8" name="">
-            <a:extLst xmlns:a="http://schemas.openxmlformats.org/drawingml/2006/main">
-              <a:ext uri="{FF2B5EF4-FFF2-40B4-BE49-F238E27FC236}">
-                <a16:creationId xmlns:a16="http://schemas.microsoft.com/office/drawing/2014/main" id="{D0C93BB5-639A-4E9F-9EF7-5155D388F81D}"/>
-              </a:ext>
-            </a:extLst>
-          </p:cNvPr>
-          <p:cNvSpPr>
-            <a:spLocks xmlns:a="http://schemas.openxmlformats.org/drawingml/2006/main" noGrp="1"/>
-          </p:cNvSpPr>
-          <p:nvPr/>
-        </p:nvSpPr>
-        <p:spPr>
-          <a:xfrm xmlns:a="http://schemas.openxmlformats.org/drawingml/2006/main">
-            <a:off x="609600" y="381000"/>
-            <a:ext cx="10906125" cy="628650"/>
-          </a:xfrm>
-          <a:prstGeom xmlns:a="http://schemas.openxmlformats.org/drawingml/2006/main" prst="rect">
-            <a:avLst/>
-          </a:prstGeom>
-          <a:noFill xmlns:a="http://schemas.openxmlformats.org/drawingml/2006/main"/>
-          <a:ln xmlns:a="http://schemas.openxmlformats.org/drawingml/2006/main" w="0">
-            <a:noFill/>
-          </a:ln>
-        </p:spPr>
-        <p:txBody>
-          <a:bodyPr xmlns:a="http://schemas.openxmlformats.org/drawingml/2006/main" lIns="0" tIns="0" rIns="0" bIns="0"/>
-          <a:lstStyle xmlns:a="http://schemas.openxmlformats.org/drawingml/2006/main"/>
-          <a:p xmlns:a="http://schemas.openxmlformats.org/drawingml/2006/main">
-            <a:r>
-              <a:rPr sz="3150" b="1">
-                <a:solidFill>
-                  <a:srgbClr val="152D43"/>
-                </a:solidFill>
-                <a:latin typeface="Arial"/>
-                <a:ea typeface="Arial"/>
-                <a:cs typeface="Arial"/>
-              </a:rPr>
-              <a:t>Quality and timing across region sizes</a:t>
-            </a:r>
-          </a:p>
-        </p:txBody>
-      </p:sp>
-      <p:sp>
-        <p:nvSpPr>
-          <p:cNvPr id="2" name="">
-            <a:extLst xmlns:a="http://schemas.openxmlformats.org/drawingml/2006/main">
-              <a:ext uri="{FF2B5EF4-FFF2-40B4-BE49-F238E27FC236}">
-                <a16:creationId xmlns:a16="http://schemas.microsoft.com/office/drawing/2014/main" id="{B42CA62D-FF0C-4A0D-981C-818DC1703605}"/>
-              </a:ext>
-            </a:extLst>
-          </p:cNvPr>
-          <p:cNvSpPr>
-            <a:spLocks xmlns:a="http://schemas.openxmlformats.org/drawingml/2006/main" noGrp="1"/>
-          </p:cNvSpPr>
-          <p:nvPr/>
-        </p:nvSpPr>
-        <p:spPr>
-          <a:xfrm xmlns:a="http://schemas.openxmlformats.org/drawingml/2006/main">
-            <a:off x="609600" y="1162050"/>
-            <a:ext cx="10972800" cy="0"/>
-          </a:xfrm>
-          <a:prstGeom xmlns:a="http://schemas.openxmlformats.org/drawingml/2006/main" prst="line">
-            <a:avLst/>
-          </a:prstGeom>
-          <a:noFill xmlns:a="http://schemas.openxmlformats.org/drawingml/2006/main"/>
-          <a:ln xmlns:a="http://schemas.openxmlformats.org/drawingml/2006/main" w="9525">
-            <a:solidFill>
-              <a:srgbClr val="D7DFE5"/>
-            </a:solidFill>
-          </a:ln>
-        </p:spPr>
-      </p:sp>
-      <p:sp>
-        <p:nvSpPr>
-          <p:cNvPr id="3" name="">
-            <a:extLst xmlns:a="http://schemas.openxmlformats.org/drawingml/2006/main">
-              <a:ext uri="{FF2B5EF4-FFF2-40B4-BE49-F238E27FC236}">
-                <a16:creationId xmlns:a16="http://schemas.microsoft.com/office/drawing/2014/main" id="{993AE4C4-831A-4477-84B4-884783FBB323}"/>
-              </a:ext>
-            </a:extLst>
-          </p:cNvPr>
-          <p:cNvSpPr>
-            <a:spLocks xmlns:a="http://schemas.openxmlformats.org/drawingml/2006/main" noGrp="1"/>
-          </p:cNvSpPr>
-          <p:nvPr/>
-        </p:nvSpPr>
-        <p:spPr>
-          <a:xfrm xmlns:a="http://schemas.openxmlformats.org/drawingml/2006/main">
-            <a:off x="11353800" y="6429375"/>
-            <a:ext cx="285750" cy="228600"/>
-          </a:xfrm>
-          <a:prstGeom xmlns:a="http://schemas.openxmlformats.org/drawingml/2006/main" prst="rect">
-            <a:avLst/>
-          </a:prstGeom>
-          <a:noFill xmlns:a="http://schemas.openxmlformats.org/drawingml/2006/main"/>
-          <a:ln xmlns:a="http://schemas.openxmlformats.org/drawingml/2006/main" w="0">
-            <a:noFill/>
-          </a:ln>
-        </p:spPr>
-        <p:txBody>
-          <a:bodyPr xmlns:a="http://schemas.openxmlformats.org/drawingml/2006/main" lIns="0" tIns="0" rIns="0" bIns="0"/>
-          <a:lstStyle xmlns:a="http://schemas.openxmlformats.org/drawingml/2006/main"/>
-          <a:p xmlns:a="http://schemas.openxmlformats.org/drawingml/2006/main">
-            <a:r>
-              <a:rPr sz="1275" b="0">
-                <a:solidFill>
-                  <a:srgbClr val="536675"/>
-                </a:solidFill>
-                <a:latin typeface="Arial"/>
-                <a:ea typeface="Arial"/>
-                <a:cs typeface="Arial"/>
-              </a:rPr>
-              <a:t>7</a:t>
-            </a:r>
-          </a:p>
-        </p:txBody>
-      </p:sp>
-      <p:graphicFrame>
-        <p:nvGraphicFramePr>
           <p:cNvPr id="4" name="">
             <a:extLst xmlns:a="http://schemas.openxmlformats.org/drawingml/2006/main">
               <a:ext uri="{FF2B5EF4-FFF2-40B4-BE49-F238E27FC236}">
-                <a16:creationId xmlns:a16="http://schemas.microsoft.com/office/drawing/2014/main" id="{37330260-036B-41E2-870C-ACCC5477FBCA}"/>
+                <a16:creationId xmlns:a16="http://schemas.microsoft.com/office/drawing/2014/main" id="{5DEF8852-C2C1-4ADB-859B-F517255A89B0}"/>
               </a:ext>
             </a:extLst>
           </p:cNvPr>
@@ -9560,7 +8462,7 @@
           <p:cNvPr id="5" name="">
             <a:extLst xmlns:a="http://schemas.openxmlformats.org/drawingml/2006/main">
               <a:ext uri="{FF2B5EF4-FFF2-40B4-BE49-F238E27FC236}">
-                <a16:creationId xmlns:a16="http://schemas.microsoft.com/office/drawing/2014/main" id="{8AC007F9-DD58-463F-8146-32AD9C82D365}"/>
+                <a16:creationId xmlns:a16="http://schemas.microsoft.com/office/drawing/2014/main" id="{46DB63B0-91DC-489B-ADA1-9398EE9360A9}"/>
               </a:ext>
             </a:extLst>
           </p:cNvPr>
@@ -9605,7 +8507,7 @@
           <p:cNvPr id="6" name="">
             <a:extLst xmlns:a="http://schemas.openxmlformats.org/drawingml/2006/main">
               <a:ext uri="{FF2B5EF4-FFF2-40B4-BE49-F238E27FC236}">
-                <a16:creationId xmlns:a16="http://schemas.microsoft.com/office/drawing/2014/main" id="{21008C5F-EDAD-4258-9678-28345C9F9F20}"/>
+                <a16:creationId xmlns:a16="http://schemas.microsoft.com/office/drawing/2014/main" id="{5FBE0DC4-FC57-4BD1-A116-68C3A2C953A4}"/>
               </a:ext>
             </a:extLst>
           </p:cNvPr>
@@ -9650,7 +8552,7 @@
           <p:cNvPr id="7" name="">
             <a:extLst xmlns:a="http://schemas.openxmlformats.org/drawingml/2006/main">
               <a:ext uri="{FF2B5EF4-FFF2-40B4-BE49-F238E27FC236}">
-                <a16:creationId xmlns:a16="http://schemas.microsoft.com/office/drawing/2014/main" id="{8998305E-FED8-4D73-9EB1-22F36CA9C037}"/>
+                <a16:creationId xmlns:a16="http://schemas.microsoft.com/office/drawing/2014/main" id="{1107472D-2F8D-4D76-9B9E-82B27A7CEAEC}"/>
               </a:ext>
             </a:extLst>
           </p:cNvPr>
@@ -9693,14 +8595,14 @@
     </p:spTree>
     <p:extLst>
       <p:ext uri="{BB962C8B-B14F-4D97-AF65-F5344CB8AC3E}">
-        <p14:creationId xmlns:p14="http://schemas.microsoft.com/office/powerpoint/2010/main" val="31864622"/>
+        <p14:creationId xmlns:p14="http://schemas.microsoft.com/office/powerpoint/2010/main" val="419475429"/>
       </p:ext>
     </p:extLst>
   </p:cSld>
 </p:sld>
 </file>
 
-<file path=ppt/slides/slide8.xml><?xml version="1.0" encoding="utf-8"?>
+<file path=ppt/slides/slide7.xml><?xml version="1.0" encoding="utf-8"?>
 <p:sld xmlns:p="http://schemas.openxmlformats.org/presentationml/2006/main">
   <p:cSld>
     <p:bg>
@@ -9724,7 +8626,7 @@
           <p:cNvPr id="14" name="">
             <a:extLst xmlns:a="http://schemas.openxmlformats.org/drawingml/2006/main">
               <a:ext uri="{FF2B5EF4-FFF2-40B4-BE49-F238E27FC236}">
-                <a16:creationId xmlns:a16="http://schemas.microsoft.com/office/drawing/2014/main" id="{BF763828-6F42-4069-879B-9DE328BB3A47}"/>
+                <a16:creationId xmlns:a16="http://schemas.microsoft.com/office/drawing/2014/main" id="{A75F8F7F-DA8E-46EA-BA12-F2623080626D}"/>
               </a:ext>
             </a:extLst>
           </p:cNvPr>
@@ -9769,7 +8671,7 @@
           <p:cNvPr id="2" name="">
             <a:extLst xmlns:a="http://schemas.openxmlformats.org/drawingml/2006/main">
               <a:ext uri="{FF2B5EF4-FFF2-40B4-BE49-F238E27FC236}">
-                <a16:creationId xmlns:a16="http://schemas.microsoft.com/office/drawing/2014/main" id="{52813728-1379-4089-8896-570BFF358632}"/>
+                <a16:creationId xmlns:a16="http://schemas.microsoft.com/office/drawing/2014/main" id="{27BFB765-84FA-4F13-A723-7C915DC7BF82}"/>
               </a:ext>
             </a:extLst>
           </p:cNvPr>
@@ -9799,7 +8701,7 @@
           <p:cNvPr id="3" name="">
             <a:extLst xmlns:a="http://schemas.openxmlformats.org/drawingml/2006/main">
               <a:ext uri="{FF2B5EF4-FFF2-40B4-BE49-F238E27FC236}">
-                <a16:creationId xmlns:a16="http://schemas.microsoft.com/office/drawing/2014/main" id="{658D3C62-0DE4-4F5A-9936-D41BC514882D}"/>
+                <a16:creationId xmlns:a16="http://schemas.microsoft.com/office/drawing/2014/main" id="{762F258C-CD4F-44D3-85E2-87334FFFD6B8}"/>
               </a:ext>
             </a:extLst>
           </p:cNvPr>
@@ -9834,7 +8736,7 @@
                 <a:ea typeface="Arial"/>
                 <a:cs typeface="Arial"/>
               </a:rPr>
-              <a:t>8</a:t>
+              <a:t>7</a:t>
             </a:r>
           </a:p>
         </p:txBody>
@@ -9844,7 +8746,7 @@
           <p:cNvPr id="4" name="">
             <a:extLst xmlns:a="http://schemas.openxmlformats.org/drawingml/2006/main">
               <a:ext uri="{FF2B5EF4-FFF2-40B4-BE49-F238E27FC236}">
-                <a16:creationId xmlns:a16="http://schemas.microsoft.com/office/drawing/2014/main" id="{839ED752-2FAE-4885-A5ED-BA7537F36560}"/>
+                <a16:creationId xmlns:a16="http://schemas.microsoft.com/office/drawing/2014/main" id="{D275C36C-BE03-4069-BA14-873A54FC347C}"/>
               </a:ext>
             </a:extLst>
           </p:cNvPr>
@@ -9889,7 +8791,7 @@
           <p:cNvPr id="5" name="">
             <a:extLst xmlns:a="http://schemas.openxmlformats.org/drawingml/2006/main">
               <a:ext uri="{FF2B5EF4-FFF2-40B4-BE49-F238E27FC236}">
-                <a16:creationId xmlns:a16="http://schemas.microsoft.com/office/drawing/2014/main" id="{8FB8FD4C-1F0A-4F61-A3A4-AC47E705C42B}"/>
+                <a16:creationId xmlns:a16="http://schemas.microsoft.com/office/drawing/2014/main" id="{3DFC9158-FDF4-400B-B3DC-0A57964A60A1}"/>
               </a:ext>
             </a:extLst>
           </p:cNvPr>
@@ -9934,7 +8836,7 @@
           <p:cNvPr id="6" name="">
             <a:extLst xmlns:a="http://schemas.openxmlformats.org/drawingml/2006/main">
               <a:ext uri="{FF2B5EF4-FFF2-40B4-BE49-F238E27FC236}">
-                <a16:creationId xmlns:a16="http://schemas.microsoft.com/office/drawing/2014/main" id="{BDEC2475-FD2A-4A2A-880A-2DC3F36F0720}"/>
+                <a16:creationId xmlns:a16="http://schemas.microsoft.com/office/drawing/2014/main" id="{59F6AEF3-0CFC-4618-9644-830E1267C7FA}"/>
               </a:ext>
             </a:extLst>
           </p:cNvPr>
@@ -9979,7 +8881,7 @@
           <p:cNvPr id="7" name="">
             <a:extLst xmlns:a="http://schemas.openxmlformats.org/drawingml/2006/main">
               <a:ext uri="{FF2B5EF4-FFF2-40B4-BE49-F238E27FC236}">
-                <a16:creationId xmlns:a16="http://schemas.microsoft.com/office/drawing/2014/main" id="{EB4507FE-7981-4F57-A6A0-08DA5FEC520E}"/>
+                <a16:creationId xmlns:a16="http://schemas.microsoft.com/office/drawing/2014/main" id="{52CDF492-2069-4A3A-825E-13C1BF3FEEFC}"/>
               </a:ext>
             </a:extLst>
           </p:cNvPr>
@@ -10024,7 +8926,7 @@
           <p:cNvPr id="8" name="">
             <a:extLst xmlns:a="http://schemas.openxmlformats.org/drawingml/2006/main">
               <a:ext uri="{FF2B5EF4-FFF2-40B4-BE49-F238E27FC236}">
-                <a16:creationId xmlns:a16="http://schemas.microsoft.com/office/drawing/2014/main" id="{3030DE88-AA80-44AA-ABC0-A6C7E5B96EE8}"/>
+                <a16:creationId xmlns:a16="http://schemas.microsoft.com/office/drawing/2014/main" id="{4DE6C9AC-9B16-40DF-B1F0-646E85554935}"/>
               </a:ext>
             </a:extLst>
           </p:cNvPr>
@@ -10069,7 +8971,7 @@
           <p:cNvPr id="9" name="">
             <a:extLst xmlns:a="http://schemas.openxmlformats.org/drawingml/2006/main">
               <a:ext uri="{FF2B5EF4-FFF2-40B4-BE49-F238E27FC236}">
-                <a16:creationId xmlns:a16="http://schemas.microsoft.com/office/drawing/2014/main" id="{AC771EC7-3B38-43BA-8BBB-EAD1C0DB1877}"/>
+                <a16:creationId xmlns:a16="http://schemas.microsoft.com/office/drawing/2014/main" id="{C80D1267-E581-47CF-B687-A0CAFA5CC4C9}"/>
               </a:ext>
             </a:extLst>
           </p:cNvPr>
@@ -10114,7 +9016,7 @@
           <p:cNvPr id="10" name="">
             <a:extLst xmlns:a="http://schemas.openxmlformats.org/drawingml/2006/main">
               <a:ext uri="{FF2B5EF4-FFF2-40B4-BE49-F238E27FC236}">
-                <a16:creationId xmlns:a16="http://schemas.microsoft.com/office/drawing/2014/main" id="{2870A9DD-E898-4B76-A813-98BB0C554932}"/>
+                <a16:creationId xmlns:a16="http://schemas.microsoft.com/office/drawing/2014/main" id="{CC0E7798-7DB6-4851-8166-3B519818628E}"/>
               </a:ext>
             </a:extLst>
           </p:cNvPr>
@@ -10159,7 +9061,7 @@
           <p:cNvPr id="11" name="">
             <a:extLst xmlns:a="http://schemas.openxmlformats.org/drawingml/2006/main">
               <a:ext uri="{FF2B5EF4-FFF2-40B4-BE49-F238E27FC236}">
-                <a16:creationId xmlns:a16="http://schemas.microsoft.com/office/drawing/2014/main" id="{7F2E25F4-C0D7-4EAA-B73F-0CA3FFFE0C52}"/>
+                <a16:creationId xmlns:a16="http://schemas.microsoft.com/office/drawing/2014/main" id="{FBE63E59-E48B-4956-ABA1-6EB52E07A454}"/>
               </a:ext>
             </a:extLst>
           </p:cNvPr>
@@ -10204,7 +9106,7 @@
           <p:cNvPr id="12" name="">
             <a:extLst xmlns:a="http://schemas.openxmlformats.org/drawingml/2006/main">
               <a:ext uri="{FF2B5EF4-FFF2-40B4-BE49-F238E27FC236}">
-                <a16:creationId xmlns:a16="http://schemas.microsoft.com/office/drawing/2014/main" id="{414F6A07-370B-4EB0-938B-38372927B35D}"/>
+                <a16:creationId xmlns:a16="http://schemas.microsoft.com/office/drawing/2014/main" id="{69048389-D926-49A7-94BD-A69FEDFC5712}"/>
               </a:ext>
             </a:extLst>
           </p:cNvPr>
@@ -10249,7 +9151,7 @@
           <p:cNvPr id="13" name="">
             <a:extLst xmlns:a="http://schemas.openxmlformats.org/drawingml/2006/main">
               <a:ext uri="{FF2B5EF4-FFF2-40B4-BE49-F238E27FC236}">
-                <a16:creationId xmlns:a16="http://schemas.microsoft.com/office/drawing/2014/main" id="{1BB1564C-B0BD-44F9-BEAA-30E6DF719FA0}"/>
+                <a16:creationId xmlns:a16="http://schemas.microsoft.com/office/drawing/2014/main" id="{D866EAEF-0C2A-40EC-BE87-7977C55B1FE0}"/>
               </a:ext>
             </a:extLst>
           </p:cNvPr>
@@ -10292,7 +9194,7 @@
     </p:spTree>
     <p:extLst>
       <p:ext uri="{BB962C8B-B14F-4D97-AF65-F5344CB8AC3E}">
-        <p14:creationId xmlns:p14="http://schemas.microsoft.com/office/powerpoint/2010/main" val="844597229"/>
+        <p14:creationId xmlns:p14="http://schemas.microsoft.com/office/powerpoint/2010/main" val="1860536445"/>
       </p:ext>
     </p:extLst>
   </p:cSld>

</xml_diff>

<commit_message>
Show linear region scales on reconstruction mechanism slide
</commit_message>
<xml_diff>
--- a/presentations/weekly_20261029/weekly_20261029_english_30w.pptx
+++ b/presentations/weekly_20261029/weekly_20261029_english_30w.pptx
@@ -2,19 +2,19 @@
 <file path=ppt/presentation.xml><?xml version="1.0" encoding="utf-8"?>
 <p:presentation xmlns:p="http://schemas.openxmlformats.org/presentationml/2006/main">
   <p:sldMasterIdLst>
-    <p:sldMasterId xmlns:r="http://schemas.openxmlformats.org/officeDocument/2006/relationships" id="2147483648" r:id="R179de33e494740a5"/>
+    <p:sldMasterId xmlns:r="http://schemas.openxmlformats.org/officeDocument/2006/relationships" id="2147483648" r:id="Rdfa590dddc3543e5"/>
   </p:sldMasterIdLst>
   <p:notesMasterIdLst>
-    <p:notesMasterId xmlns:r="http://schemas.openxmlformats.org/officeDocument/2006/relationships" r:id="R0de4b637a0494807"/>
+    <p:notesMasterId xmlns:r="http://schemas.openxmlformats.org/officeDocument/2006/relationships" r:id="Rb143149f0eee46ec"/>
   </p:notesMasterIdLst>
   <p:sldIdLst>
-    <p:sldId xmlns:r="http://schemas.openxmlformats.org/officeDocument/2006/relationships" id="256" r:id="Rdca792a4d3d74194"/>
-    <p:sldId xmlns:r="http://schemas.openxmlformats.org/officeDocument/2006/relationships" id="257" r:id="R6c7ae1ac5d6445e7"/>
-    <p:sldId xmlns:r="http://schemas.openxmlformats.org/officeDocument/2006/relationships" id="258" r:id="R94c45fc12e234211"/>
-    <p:sldId xmlns:r="http://schemas.openxmlformats.org/officeDocument/2006/relationships" id="259" r:id="Re64d9e9c336b470c"/>
-    <p:sldId xmlns:r="http://schemas.openxmlformats.org/officeDocument/2006/relationships" id="260" r:id="R6921852ecdc54e61"/>
-    <p:sldId xmlns:r="http://schemas.openxmlformats.org/officeDocument/2006/relationships" id="261" r:id="Rb1bd142a39464acd"/>
-    <p:sldId xmlns:r="http://schemas.openxmlformats.org/officeDocument/2006/relationships" id="262" r:id="Rb2d53381a81a4f98"/>
+    <p:sldId xmlns:r="http://schemas.openxmlformats.org/officeDocument/2006/relationships" id="256" r:id="Reddbe7665d5843a2"/>
+    <p:sldId xmlns:r="http://schemas.openxmlformats.org/officeDocument/2006/relationships" id="257" r:id="Rcd35bc86e509448d"/>
+    <p:sldId xmlns:r="http://schemas.openxmlformats.org/officeDocument/2006/relationships" id="258" r:id="Rb06a29f4d6704829"/>
+    <p:sldId xmlns:r="http://schemas.openxmlformats.org/officeDocument/2006/relationships" id="259" r:id="R8a4e8d52555d4578"/>
+    <p:sldId xmlns:r="http://schemas.openxmlformats.org/officeDocument/2006/relationships" id="260" r:id="R252f7c1b18b24f23"/>
+    <p:sldId xmlns:r="http://schemas.openxmlformats.org/officeDocument/2006/relationships" id="261" r:id="R2cf0c1cf2cd74d70"/>
+    <p:sldId xmlns:r="http://schemas.openxmlformats.org/officeDocument/2006/relationships" id="262" r:id="Rcf73cdef08b142a3"/>
   </p:sldIdLst>
   <p:sldSz cx="12192000" cy="6858000"/>
   <p:notesSz cx="6858000" cy="9144000"/>
@@ -658,7 +658,7 @@
           <a:lstStyle xmlns:a="http://schemas.openxmlformats.org/drawingml/2006/main"/>
           <a:p xmlns:a="http://schemas.openxmlformats.org/drawingml/2006/main">
             <a:r>
-              <a:t>Source: results/fov_levels_xavier_full_20261027/README.md; overview.csv; summary.csv. Commit 0f1506c. Date 2026-10-27. Raw evidence: evidence.tar.gz. Mechanism: half-resolution base + padded full-resolution ROI + feather overlay. Region percentages are spatial coverage of a 960x540 image: 80x46=0.7098765%, 160x90=2.7777778%, 320x180=11.1111111%, 480x270=25%, 640x360=44.4444444%. The base samples at 50% width and 50% height, giving 25% as many pixels (480x270), while covering the entire image. Region coverage and sampling resolution are different quantities.</a:t>
+              <a:t>Source: results/fov_levels_xavier_full_20261027/README.md; overview.csv; summary.csv. Commit 0f1506c. Date 2026-10-27. Raw evidence: evidence.tar.gz. Mechanism: half-resolution base + padded full-resolution ROI + feather overlay. The full output is 960x540 (1.0x). Region scale is ROI width divided by full-image width: 80x46 =&gt; 0.083333x, 160x90 =&gt; 0.166667x, 320x180 =&gt; 0.333333x, 480x270 =&gt; 0.5x, 640x360 =&gt; 0.666667x. Height approximately follows the same scale; the smallest ROI uses height46 for even alignment, instead of45. ROI extent scale is not sampling resolution: pixels within the ROI remain full-resolution. The base samples at 0.5x width and 0.5x height (480x270) while covering the entire image.</a:t>
             </a:r>
           </a:p>
         </p:txBody>
@@ -915,7 +915,7 @@
           <p:cNvPr id="3" name="Title">
             <a:extLst xmlns:a="http://schemas.openxmlformats.org/drawingml/2006/main">
               <a:ext uri="{FF2B5EF4-FFF2-40B4-BE49-F238E27FC236}">
-                <a16:creationId xmlns:a16="http://schemas.microsoft.com/office/drawing/2014/main" id="{2B873602-1825-4C9F-89B4-348F67A143DD}"/>
+                <a16:creationId xmlns:a16="http://schemas.microsoft.com/office/drawing/2014/main" id="{DF09009B-1A47-4272-A1AF-D68F93D8D408}"/>
               </a:ext>
             </a:extLst>
           </p:cNvPr>
@@ -1144,7 +1144,7 @@
           <p:cNvPr id="2" name="Subtitle">
             <a:extLst xmlns:a="http://schemas.openxmlformats.org/drawingml/2006/main">
               <a:ext uri="{FF2B5EF4-FFF2-40B4-BE49-F238E27FC236}">
-                <a16:creationId xmlns:a16="http://schemas.microsoft.com/office/drawing/2014/main" id="{FDB43B04-B2BF-4150-86BA-AD2F926508E1}"/>
+                <a16:creationId xmlns:a16="http://schemas.microsoft.com/office/drawing/2014/main" id="{7651BADE-C19C-4607-825A-F3D5CEF0D18A}"/>
               </a:ext>
             </a:extLst>
           </p:cNvPr>
@@ -1390,7 +1390,7 @@
           <p:cNvPr id="2" name="Section title">
             <a:extLst xmlns:a="http://schemas.openxmlformats.org/drawingml/2006/main">
               <a:ext uri="{FF2B5EF4-FFF2-40B4-BE49-F238E27FC236}">
-                <a16:creationId xmlns:a16="http://schemas.microsoft.com/office/drawing/2014/main" id="{07304056-3C4A-42F0-9154-D26D831FA37F}"/>
+                <a16:creationId xmlns:a16="http://schemas.microsoft.com/office/drawing/2014/main" id="{74BD0149-78AC-4464-AF1D-C8930323768C}"/>
               </a:ext>
             </a:extLst>
           </p:cNvPr>
@@ -1636,7 +1636,7 @@
           <p:cNvPr id="3" name="Title">
             <a:extLst xmlns:a="http://schemas.openxmlformats.org/drawingml/2006/main">
               <a:ext uri="{FF2B5EF4-FFF2-40B4-BE49-F238E27FC236}">
-                <a16:creationId xmlns:a16="http://schemas.microsoft.com/office/drawing/2014/main" id="{746F2F85-032D-418F-8FF6-CB247A4A3586}"/>
+                <a16:creationId xmlns:a16="http://schemas.microsoft.com/office/drawing/2014/main" id="{F92AA6D3-9972-4C18-AF53-12E189C62EFD}"/>
               </a:ext>
             </a:extLst>
           </p:cNvPr>
@@ -1865,7 +1865,7 @@
           <p:cNvPr id="2" name="Body">
             <a:extLst xmlns:a="http://schemas.openxmlformats.org/drawingml/2006/main">
               <a:ext uri="{FF2B5EF4-FFF2-40B4-BE49-F238E27FC236}">
-                <a16:creationId xmlns:a16="http://schemas.microsoft.com/office/drawing/2014/main" id="{575C660E-DC4A-4D2D-9454-10B999B867D4}"/>
+                <a16:creationId xmlns:a16="http://schemas.microsoft.com/office/drawing/2014/main" id="{DAA1C96D-AD45-466C-8D64-86FA687108C9}"/>
               </a:ext>
             </a:extLst>
           </p:cNvPr>
@@ -2111,7 +2111,7 @@
           <p:cNvPr id="4" name="Title">
             <a:extLst xmlns:a="http://schemas.openxmlformats.org/drawingml/2006/main">
               <a:ext uri="{FF2B5EF4-FFF2-40B4-BE49-F238E27FC236}">
-                <a16:creationId xmlns:a16="http://schemas.microsoft.com/office/drawing/2014/main" id="{4CDC0EFB-33C8-4675-824E-5713C8E462E5}"/>
+                <a16:creationId xmlns:a16="http://schemas.microsoft.com/office/drawing/2014/main" id="{66EA457B-E80C-4F55-B0A0-EE9E4DBB12CE}"/>
               </a:ext>
             </a:extLst>
           </p:cNvPr>
@@ -2340,7 +2340,7 @@
           <p:cNvPr id="2" name="Left column">
             <a:extLst xmlns:a="http://schemas.openxmlformats.org/drawingml/2006/main">
               <a:ext uri="{FF2B5EF4-FFF2-40B4-BE49-F238E27FC236}">
-                <a16:creationId xmlns:a16="http://schemas.microsoft.com/office/drawing/2014/main" id="{ABDEF5BD-D96D-4E3C-9041-36AC92BAB0C4}"/>
+                <a16:creationId xmlns:a16="http://schemas.microsoft.com/office/drawing/2014/main" id="{BAD570F6-20C3-4265-9E50-E123F543FEE7}"/>
               </a:ext>
             </a:extLst>
           </p:cNvPr>
@@ -2569,7 +2569,7 @@
           <p:cNvPr id="3" name="Right column">
             <a:extLst xmlns:a="http://schemas.openxmlformats.org/drawingml/2006/main">
               <a:ext uri="{FF2B5EF4-FFF2-40B4-BE49-F238E27FC236}">
-                <a16:creationId xmlns:a16="http://schemas.microsoft.com/office/drawing/2014/main" id="{42695DE9-0F6C-42AB-B76C-CA2651021B19}"/>
+                <a16:creationId xmlns:a16="http://schemas.microsoft.com/office/drawing/2014/main" id="{B33ADD3E-A083-4557-B64C-334442F7BEF8}"/>
               </a:ext>
             </a:extLst>
           </p:cNvPr>
@@ -2815,7 +2815,7 @@
           <p:cNvPr id="3" name="Title">
             <a:extLst xmlns:a="http://schemas.openxmlformats.org/drawingml/2006/main">
               <a:ext uri="{FF2B5EF4-FFF2-40B4-BE49-F238E27FC236}">
-                <a16:creationId xmlns:a16="http://schemas.microsoft.com/office/drawing/2014/main" id="{A0EB5180-5B59-4F37-BE8F-B87E585B6CC4}"/>
+                <a16:creationId xmlns:a16="http://schemas.microsoft.com/office/drawing/2014/main" id="{FCF3CE29-133F-465D-835B-AD89879F852D}"/>
               </a:ext>
             </a:extLst>
           </p:cNvPr>
@@ -3044,7 +3044,7 @@
           <p:cNvPr id="2" name="Left column">
             <a:extLst xmlns:a="http://schemas.openxmlformats.org/drawingml/2006/main">
               <a:ext uri="{FF2B5EF4-FFF2-40B4-BE49-F238E27FC236}">
-                <a16:creationId xmlns:a16="http://schemas.microsoft.com/office/drawing/2014/main" id="{FD8E5EC7-2F77-4ED2-BDFE-FDBDF54FADA9}"/>
+                <a16:creationId xmlns:a16="http://schemas.microsoft.com/office/drawing/2014/main" id="{427D6870-A1F9-4897-81D5-344E699834EB}"/>
               </a:ext>
             </a:extLst>
           </p:cNvPr>
@@ -3311,12 +3311,12 @@
   </p:cSld>
   <p:clrMap bg1="lt1" tx1="dk1" bg2="lt2" tx2="dk2" accent1="accent1" accent2="accent2" accent3="accent3" accent4="accent4" accent5="accent5" accent6="accent6" hlink="hlink" folHlink="folHlink"/>
   <p:sldLayoutIdLst>
-    <p:sldLayoutId xmlns:r="http://schemas.openxmlformats.org/officeDocument/2006/relationships" id="2147483649" r:id="R72a625dab0af494a"/>
-    <p:sldLayoutId xmlns:r="http://schemas.openxmlformats.org/officeDocument/2006/relationships" id="2147483650" r:id="Rd82813bafa7d4ac4"/>
-    <p:sldLayoutId xmlns:r="http://schemas.openxmlformats.org/officeDocument/2006/relationships" id="2147483651" r:id="R3ce94574400545e7"/>
-    <p:sldLayoutId xmlns:r="http://schemas.openxmlformats.org/officeDocument/2006/relationships" id="2147483652" r:id="Rebca27cfd7ae4322"/>
-    <p:sldLayoutId xmlns:r="http://schemas.openxmlformats.org/officeDocument/2006/relationships" id="2147483653" r:id="R61bdae2f7e984c52"/>
-    <p:sldLayoutId xmlns:r="http://schemas.openxmlformats.org/officeDocument/2006/relationships" id="2147483654" r:id="R95aab2068dac4af1"/>
+    <p:sldLayoutId xmlns:r="http://schemas.openxmlformats.org/officeDocument/2006/relationships" id="2147483649" r:id="R56a1220e3f764421"/>
+    <p:sldLayoutId xmlns:r="http://schemas.openxmlformats.org/officeDocument/2006/relationships" id="2147483650" r:id="Rdb37c5a3c1f14175"/>
+    <p:sldLayoutId xmlns:r="http://schemas.openxmlformats.org/officeDocument/2006/relationships" id="2147483651" r:id="R0d71e67c7e2a4467"/>
+    <p:sldLayoutId xmlns:r="http://schemas.openxmlformats.org/officeDocument/2006/relationships" id="2147483652" r:id="Recb73b78be3d49e5"/>
+    <p:sldLayoutId xmlns:r="http://schemas.openxmlformats.org/officeDocument/2006/relationships" id="2147483653" r:id="Rdfa5bbec01004df8"/>
+    <p:sldLayoutId xmlns:r="http://schemas.openxmlformats.org/officeDocument/2006/relationships" id="2147483654" r:id="Rcd4490f23ec3440f"/>
   </p:sldLayoutIdLst>
   <p:txStyles>
     <p:titleStyle>
@@ -4188,7 +4188,7 @@
           <p:cNvPr id="5" name="">
             <a:extLst xmlns:a="http://schemas.openxmlformats.org/drawingml/2006/main">
               <a:ext uri="{FF2B5EF4-FFF2-40B4-BE49-F238E27FC236}">
-                <a16:creationId xmlns:a16="http://schemas.microsoft.com/office/drawing/2014/main" id="{7B329841-71F3-45D8-A5A2-5BFED7BE92E1}"/>
+                <a16:creationId xmlns:a16="http://schemas.microsoft.com/office/drawing/2014/main" id="{8839185C-01FE-48E9-8E68-11D433472E8F}"/>
               </a:ext>
             </a:extLst>
           </p:cNvPr>
@@ -4246,7 +4246,7 @@
           <p:cNvPr id="2" name="">
             <a:extLst xmlns:a="http://schemas.openxmlformats.org/drawingml/2006/main">
               <a:ext uri="{FF2B5EF4-FFF2-40B4-BE49-F238E27FC236}">
-                <a16:creationId xmlns:a16="http://schemas.microsoft.com/office/drawing/2014/main" id="{6EF72B89-AD12-43CF-A3D2-857E6E49EB85}"/>
+                <a16:creationId xmlns:a16="http://schemas.microsoft.com/office/drawing/2014/main" id="{BBCC9B25-B5F1-49D7-A870-7DE736A735F6}"/>
               </a:ext>
             </a:extLst>
           </p:cNvPr>
@@ -4291,7 +4291,7 @@
           <p:cNvPr id="3" name="">
             <a:extLst xmlns:a="http://schemas.openxmlformats.org/drawingml/2006/main">
               <a:ext uri="{FF2B5EF4-FFF2-40B4-BE49-F238E27FC236}">
-                <a16:creationId xmlns:a16="http://schemas.microsoft.com/office/drawing/2014/main" id="{BF2443F8-A1D6-4F14-B9ED-291E65E4D580}"/>
+                <a16:creationId xmlns:a16="http://schemas.microsoft.com/office/drawing/2014/main" id="{DD3926AD-B103-49A7-84B2-3971E0728361}"/>
               </a:ext>
             </a:extLst>
           </p:cNvPr>
@@ -4336,7 +4336,7 @@
           <p:cNvPr id="4" name="">
             <a:extLst xmlns:a="http://schemas.openxmlformats.org/drawingml/2006/main">
               <a:ext uri="{FF2B5EF4-FFF2-40B4-BE49-F238E27FC236}">
-                <a16:creationId xmlns:a16="http://schemas.microsoft.com/office/drawing/2014/main" id="{3144CD67-3E22-4238-BC7D-D7E1D8EFD421}"/>
+                <a16:creationId xmlns:a16="http://schemas.microsoft.com/office/drawing/2014/main" id="{4BB6D7B6-E683-4CB7-8FF8-40832E568E3D}"/>
               </a:ext>
             </a:extLst>
           </p:cNvPr>
@@ -4379,7 +4379,7 @@
     </p:spTree>
     <p:extLst>
       <p:ext uri="{BB962C8B-B14F-4D97-AF65-F5344CB8AC3E}">
-        <p14:creationId xmlns:p14="http://schemas.microsoft.com/office/powerpoint/2010/main" val="498036716"/>
+        <p14:creationId xmlns:p14="http://schemas.microsoft.com/office/powerpoint/2010/main" val="1845059078"/>
       </p:ext>
     </p:extLst>
   </p:cSld>
@@ -4410,7 +4410,7 @@
           <p:cNvPr id="29" name="">
             <a:extLst xmlns:a="http://schemas.openxmlformats.org/drawingml/2006/main">
               <a:ext uri="{FF2B5EF4-FFF2-40B4-BE49-F238E27FC236}">
-                <a16:creationId xmlns:a16="http://schemas.microsoft.com/office/drawing/2014/main" id="{A3374315-5E62-4846-91D2-373249F6BD27}"/>
+                <a16:creationId xmlns:a16="http://schemas.microsoft.com/office/drawing/2014/main" id="{40889156-0D14-4233-A9F7-DD2D38BC91D0}"/>
               </a:ext>
             </a:extLst>
           </p:cNvPr>
@@ -4455,7 +4455,7 @@
           <p:cNvPr id="2" name="">
             <a:extLst xmlns:a="http://schemas.openxmlformats.org/drawingml/2006/main">
               <a:ext uri="{FF2B5EF4-FFF2-40B4-BE49-F238E27FC236}">
-                <a16:creationId xmlns:a16="http://schemas.microsoft.com/office/drawing/2014/main" id="{335B14F7-50B1-4C94-9233-B0626B51A5B7}"/>
+                <a16:creationId xmlns:a16="http://schemas.microsoft.com/office/drawing/2014/main" id="{7AFBA3E8-37EC-40F9-96B5-41503E79D16C}"/>
               </a:ext>
             </a:extLst>
           </p:cNvPr>
@@ -4485,7 +4485,7 @@
           <p:cNvPr id="3" name="">
             <a:extLst xmlns:a="http://schemas.openxmlformats.org/drawingml/2006/main">
               <a:ext uri="{FF2B5EF4-FFF2-40B4-BE49-F238E27FC236}">
-                <a16:creationId xmlns:a16="http://schemas.microsoft.com/office/drawing/2014/main" id="{B197A882-C7C7-4194-8B62-BC075CC1E85D}"/>
+                <a16:creationId xmlns:a16="http://schemas.microsoft.com/office/drawing/2014/main" id="{0D9D112C-CD28-4A5E-A1D4-485B66C00625}"/>
               </a:ext>
             </a:extLst>
           </p:cNvPr>
@@ -4530,7 +4530,7 @@
           <p:cNvPr id="4" name="">
             <a:extLst xmlns:a="http://schemas.openxmlformats.org/drawingml/2006/main">
               <a:ext uri="{FF2B5EF4-FFF2-40B4-BE49-F238E27FC236}">
-                <a16:creationId xmlns:a16="http://schemas.microsoft.com/office/drawing/2014/main" id="{11A207DC-3B7D-48E8-89B6-C83C24F34AA0}"/>
+                <a16:creationId xmlns:a16="http://schemas.microsoft.com/office/drawing/2014/main" id="{C4C3B468-A151-46B7-999B-708ED9381852}"/>
               </a:ext>
             </a:extLst>
           </p:cNvPr>
@@ -4575,7 +4575,7 @@
           <p:cNvPr id="5" name="">
             <a:extLst xmlns:a="http://schemas.openxmlformats.org/drawingml/2006/main">
               <a:ext uri="{FF2B5EF4-FFF2-40B4-BE49-F238E27FC236}">
-                <a16:creationId xmlns:a16="http://schemas.microsoft.com/office/drawing/2014/main" id="{A2C23E07-BB3D-4466-9E98-446A3BB83CFF}"/>
+                <a16:creationId xmlns:a16="http://schemas.microsoft.com/office/drawing/2014/main" id="{D2E6AB31-0113-418D-A4C0-0200BD8A2383}"/>
               </a:ext>
             </a:extLst>
           </p:cNvPr>
@@ -4620,7 +4620,7 @@
           <p:cNvPr id="6" name="">
             <a:extLst xmlns:a="http://schemas.openxmlformats.org/drawingml/2006/main">
               <a:ext uri="{FF2B5EF4-FFF2-40B4-BE49-F238E27FC236}">
-                <a16:creationId xmlns:a16="http://schemas.microsoft.com/office/drawing/2014/main" id="{28E01DD5-19A3-4F94-9DF1-5A66BC8D1A8E}"/>
+                <a16:creationId xmlns:a16="http://schemas.microsoft.com/office/drawing/2014/main" id="{063279DA-3A5F-44C0-9820-B1F3CA01C409}"/>
               </a:ext>
             </a:extLst>
           </p:cNvPr>
@@ -4652,7 +4652,7 @@
           <p:cNvPr id="7" name="">
             <a:extLst xmlns:a="http://schemas.openxmlformats.org/drawingml/2006/main">
               <a:ext uri="{FF2B5EF4-FFF2-40B4-BE49-F238E27FC236}">
-                <a16:creationId xmlns:a16="http://schemas.microsoft.com/office/drawing/2014/main" id="{8FCCEB64-880B-4EAC-B06B-82E405170BF4}"/>
+                <a16:creationId xmlns:a16="http://schemas.microsoft.com/office/drawing/2014/main" id="{342DD79D-C86F-4565-B208-60DB8B234A22}"/>
               </a:ext>
             </a:extLst>
           </p:cNvPr>
@@ -4684,7 +4684,7 @@
           <p:cNvPr id="8" name="">
             <a:extLst xmlns:a="http://schemas.openxmlformats.org/drawingml/2006/main">
               <a:ext uri="{FF2B5EF4-FFF2-40B4-BE49-F238E27FC236}">
-                <a16:creationId xmlns:a16="http://schemas.microsoft.com/office/drawing/2014/main" id="{8785A3DB-6F13-458E-B129-B864948F3EA4}"/>
+                <a16:creationId xmlns:a16="http://schemas.microsoft.com/office/drawing/2014/main" id="{85F02417-D056-4586-BE2B-59F2B6817E75}"/>
               </a:ext>
             </a:extLst>
           </p:cNvPr>
@@ -4716,7 +4716,7 @@
           <p:cNvPr id="9" name="">
             <a:extLst xmlns:a="http://schemas.openxmlformats.org/drawingml/2006/main">
               <a:ext uri="{FF2B5EF4-FFF2-40B4-BE49-F238E27FC236}">
-                <a16:creationId xmlns:a16="http://schemas.microsoft.com/office/drawing/2014/main" id="{EA1AAAAE-B75D-44EB-B6A5-353C240C3ED9}"/>
+                <a16:creationId xmlns:a16="http://schemas.microsoft.com/office/drawing/2014/main" id="{D3CF5134-F031-496E-B91C-2CCB310E687F}"/>
               </a:ext>
             </a:extLst>
           </p:cNvPr>
@@ -4761,7 +4761,7 @@
           <p:cNvPr id="10" name="">
             <a:extLst xmlns:a="http://schemas.openxmlformats.org/drawingml/2006/main">
               <a:ext uri="{FF2B5EF4-FFF2-40B4-BE49-F238E27FC236}">
-                <a16:creationId xmlns:a16="http://schemas.microsoft.com/office/drawing/2014/main" id="{B88A9E18-6631-4B7C-B186-47EC6A6D5C2F}"/>
+                <a16:creationId xmlns:a16="http://schemas.microsoft.com/office/drawing/2014/main" id="{E144674D-F33D-4B17-9C2D-D1DC5A794903}"/>
               </a:ext>
             </a:extLst>
           </p:cNvPr>
@@ -4791,7 +4791,7 @@
           <p:cNvPr id="11" name="">
             <a:extLst xmlns:a="http://schemas.openxmlformats.org/drawingml/2006/main">
               <a:ext uri="{FF2B5EF4-FFF2-40B4-BE49-F238E27FC236}">
-                <a16:creationId xmlns:a16="http://schemas.microsoft.com/office/drawing/2014/main" id="{C3281893-1F6F-491C-B0E1-910C5EF5686D}"/>
+                <a16:creationId xmlns:a16="http://schemas.microsoft.com/office/drawing/2014/main" id="{5B1812AF-268D-4C19-A6C9-A77F1B1F669E}"/>
               </a:ext>
             </a:extLst>
           </p:cNvPr>
@@ -4836,7 +4836,7 @@
           <p:cNvPr id="12" name="">
             <a:extLst xmlns:a="http://schemas.openxmlformats.org/drawingml/2006/main">
               <a:ext uri="{FF2B5EF4-FFF2-40B4-BE49-F238E27FC236}">
-                <a16:creationId xmlns:a16="http://schemas.microsoft.com/office/drawing/2014/main" id="{112DE810-0C11-4813-A48F-AFA37215893B}"/>
+                <a16:creationId xmlns:a16="http://schemas.microsoft.com/office/drawing/2014/main" id="{5150D6F9-C8EB-44A6-A6DD-51EA68FBE4CB}"/>
               </a:ext>
             </a:extLst>
           </p:cNvPr>
@@ -4868,7 +4868,7 @@
           <p:cNvPr id="13" name="">
             <a:extLst xmlns:a="http://schemas.openxmlformats.org/drawingml/2006/main">
               <a:ext uri="{FF2B5EF4-FFF2-40B4-BE49-F238E27FC236}">
-                <a16:creationId xmlns:a16="http://schemas.microsoft.com/office/drawing/2014/main" id="{337180D7-7780-4E81-84DB-375B3A3065A3}"/>
+                <a16:creationId xmlns:a16="http://schemas.microsoft.com/office/drawing/2014/main" id="{30449A39-7FDB-4443-A6E0-59FD68A8DA1F}"/>
               </a:ext>
             </a:extLst>
           </p:cNvPr>
@@ -4900,7 +4900,7 @@
           <p:cNvPr id="14" name="">
             <a:extLst xmlns:a="http://schemas.openxmlformats.org/drawingml/2006/main">
               <a:ext uri="{FF2B5EF4-FFF2-40B4-BE49-F238E27FC236}">
-                <a16:creationId xmlns:a16="http://schemas.microsoft.com/office/drawing/2014/main" id="{89EBDC18-0475-4C64-A4D1-F3A8F9994A94}"/>
+                <a16:creationId xmlns:a16="http://schemas.microsoft.com/office/drawing/2014/main" id="{44478E5B-4CF3-4388-B4C3-8467765F43AF}"/>
               </a:ext>
             </a:extLst>
           </p:cNvPr>
@@ -4932,7 +4932,7 @@
           <p:cNvPr id="15" name="">
             <a:extLst xmlns:a="http://schemas.openxmlformats.org/drawingml/2006/main">
               <a:ext uri="{FF2B5EF4-FFF2-40B4-BE49-F238E27FC236}">
-                <a16:creationId xmlns:a16="http://schemas.microsoft.com/office/drawing/2014/main" id="{874A7636-527B-4300-B2F4-0BC2FD27A381}"/>
+                <a16:creationId xmlns:a16="http://schemas.microsoft.com/office/drawing/2014/main" id="{E759F7FA-B562-4D0C-9458-7912B2CB4A11}"/>
               </a:ext>
             </a:extLst>
           </p:cNvPr>
@@ -4977,7 +4977,7 @@
           <p:cNvPr id="16" name="">
             <a:extLst xmlns:a="http://schemas.openxmlformats.org/drawingml/2006/main">
               <a:ext uri="{FF2B5EF4-FFF2-40B4-BE49-F238E27FC236}">
-                <a16:creationId xmlns:a16="http://schemas.microsoft.com/office/drawing/2014/main" id="{2D3F4508-6E20-404D-8B4E-DCD0A5840A14}"/>
+                <a16:creationId xmlns:a16="http://schemas.microsoft.com/office/drawing/2014/main" id="{7BBFB918-8402-4C93-B258-E3158B51EC69}"/>
               </a:ext>
             </a:extLst>
           </p:cNvPr>
@@ -5007,7 +5007,7 @@
           <p:cNvPr id="17" name="">
             <a:extLst xmlns:a="http://schemas.openxmlformats.org/drawingml/2006/main">
               <a:ext uri="{FF2B5EF4-FFF2-40B4-BE49-F238E27FC236}">
-                <a16:creationId xmlns:a16="http://schemas.microsoft.com/office/drawing/2014/main" id="{51C216B4-5F4B-4ECE-9B98-BE8B4814E2EE}"/>
+                <a16:creationId xmlns:a16="http://schemas.microsoft.com/office/drawing/2014/main" id="{D71FD7E6-A4D8-4AEB-88B6-AE1F3F6F82DA}"/>
               </a:ext>
             </a:extLst>
           </p:cNvPr>
@@ -5052,7 +5052,7 @@
           <p:cNvPr id="18" name="">
             <a:extLst xmlns:a="http://schemas.openxmlformats.org/drawingml/2006/main">
               <a:ext uri="{FF2B5EF4-FFF2-40B4-BE49-F238E27FC236}">
-                <a16:creationId xmlns:a16="http://schemas.microsoft.com/office/drawing/2014/main" id="{F617FD9F-8FD9-4F94-9FB0-96DC55904C8C}"/>
+                <a16:creationId xmlns:a16="http://schemas.microsoft.com/office/drawing/2014/main" id="{67790418-9369-4D10-8321-415940EB71A0}"/>
               </a:ext>
             </a:extLst>
           </p:cNvPr>
@@ -5084,7 +5084,7 @@
           <p:cNvPr id="19" name="">
             <a:extLst xmlns:a="http://schemas.openxmlformats.org/drawingml/2006/main">
               <a:ext uri="{FF2B5EF4-FFF2-40B4-BE49-F238E27FC236}">
-                <a16:creationId xmlns:a16="http://schemas.microsoft.com/office/drawing/2014/main" id="{A64B526B-600B-401F-A256-9118E187A69D}"/>
+                <a16:creationId xmlns:a16="http://schemas.microsoft.com/office/drawing/2014/main" id="{B5B3ACBC-3BC9-450F-8B81-52DD49042863}"/>
               </a:ext>
             </a:extLst>
           </p:cNvPr>
@@ -5116,7 +5116,7 @@
           <p:cNvPr id="20" name="">
             <a:extLst xmlns:a="http://schemas.openxmlformats.org/drawingml/2006/main">
               <a:ext uri="{FF2B5EF4-FFF2-40B4-BE49-F238E27FC236}">
-                <a16:creationId xmlns:a16="http://schemas.microsoft.com/office/drawing/2014/main" id="{DD9E5178-FAA3-4886-9570-989CD76FB969}"/>
+                <a16:creationId xmlns:a16="http://schemas.microsoft.com/office/drawing/2014/main" id="{9973351F-262A-4398-8909-31892CCA2E85}"/>
               </a:ext>
             </a:extLst>
           </p:cNvPr>
@@ -5148,7 +5148,7 @@
           <p:cNvPr id="21" name="">
             <a:extLst xmlns:a="http://schemas.openxmlformats.org/drawingml/2006/main">
               <a:ext uri="{FF2B5EF4-FFF2-40B4-BE49-F238E27FC236}">
-                <a16:creationId xmlns:a16="http://schemas.microsoft.com/office/drawing/2014/main" id="{6B6006C2-B8F4-411C-8564-6FAD320329FA}"/>
+                <a16:creationId xmlns:a16="http://schemas.microsoft.com/office/drawing/2014/main" id="{2266F7D3-B078-444D-BA1C-0C9B19A04BAD}"/>
               </a:ext>
             </a:extLst>
           </p:cNvPr>
@@ -5193,7 +5193,7 @@
           <p:cNvPr id="22" name="">
             <a:extLst xmlns:a="http://schemas.openxmlformats.org/drawingml/2006/main">
               <a:ext uri="{FF2B5EF4-FFF2-40B4-BE49-F238E27FC236}">
-                <a16:creationId xmlns:a16="http://schemas.microsoft.com/office/drawing/2014/main" id="{1876054E-77DF-4268-AC39-A83F0EAA506A}"/>
+                <a16:creationId xmlns:a16="http://schemas.microsoft.com/office/drawing/2014/main" id="{D05B0D14-396F-4EA8-AEF2-F6E3986C7836}"/>
               </a:ext>
             </a:extLst>
           </p:cNvPr>
@@ -5223,7 +5223,7 @@
           <p:cNvPr id="23" name="">
             <a:extLst xmlns:a="http://schemas.openxmlformats.org/drawingml/2006/main">
               <a:ext uri="{FF2B5EF4-FFF2-40B4-BE49-F238E27FC236}">
-                <a16:creationId xmlns:a16="http://schemas.microsoft.com/office/drawing/2014/main" id="{B6DC4478-DF8D-494F-A7EF-C248D10401CE}"/>
+                <a16:creationId xmlns:a16="http://schemas.microsoft.com/office/drawing/2014/main" id="{4D389395-F859-43DE-9FA6-1C5AA1B008A3}"/>
               </a:ext>
             </a:extLst>
           </p:cNvPr>
@@ -5253,7 +5253,7 @@
           <p:cNvPr id="24" name="">
             <a:extLst xmlns:a="http://schemas.openxmlformats.org/drawingml/2006/main">
               <a:ext uri="{FF2B5EF4-FFF2-40B4-BE49-F238E27FC236}">
-                <a16:creationId xmlns:a16="http://schemas.microsoft.com/office/drawing/2014/main" id="{335CBA70-DD47-4D17-B41B-7BC78208F659}"/>
+                <a16:creationId xmlns:a16="http://schemas.microsoft.com/office/drawing/2014/main" id="{EA5CD671-9298-47D5-AB30-EA232745E808}"/>
               </a:ext>
             </a:extLst>
           </p:cNvPr>
@@ -5298,7 +5298,7 @@
           <p:cNvPr id="25" name="">
             <a:extLst xmlns:a="http://schemas.openxmlformats.org/drawingml/2006/main">
               <a:ext uri="{FF2B5EF4-FFF2-40B4-BE49-F238E27FC236}">
-                <a16:creationId xmlns:a16="http://schemas.microsoft.com/office/drawing/2014/main" id="{A3291467-25B4-4F59-99D4-DE69D47ABA0C}"/>
+                <a16:creationId xmlns:a16="http://schemas.microsoft.com/office/drawing/2014/main" id="{46C4900D-D60D-4953-9336-51E315F3F84B}"/>
               </a:ext>
             </a:extLst>
           </p:cNvPr>
@@ -5343,7 +5343,7 @@
           <p:cNvPr id="26" name="">
             <a:extLst xmlns:a="http://schemas.openxmlformats.org/drawingml/2006/main">
               <a:ext uri="{FF2B5EF4-FFF2-40B4-BE49-F238E27FC236}">
-                <a16:creationId xmlns:a16="http://schemas.microsoft.com/office/drawing/2014/main" id="{5E374B4D-4E1E-4370-A018-4675F5C906F2}"/>
+                <a16:creationId xmlns:a16="http://schemas.microsoft.com/office/drawing/2014/main" id="{6356077A-D621-4F95-9B34-56913F862669}"/>
               </a:ext>
             </a:extLst>
           </p:cNvPr>
@@ -5388,7 +5388,7 @@
           <p:cNvPr id="27" name="">
             <a:extLst xmlns:a="http://schemas.openxmlformats.org/drawingml/2006/main">
               <a:ext uri="{FF2B5EF4-FFF2-40B4-BE49-F238E27FC236}">
-                <a16:creationId xmlns:a16="http://schemas.microsoft.com/office/drawing/2014/main" id="{F5245022-2F24-4EA5-A4EF-60B65847FF00}"/>
+                <a16:creationId xmlns:a16="http://schemas.microsoft.com/office/drawing/2014/main" id="{2D68AF76-8A31-4F7C-ACC4-82D4B8D31A4A}"/>
               </a:ext>
             </a:extLst>
           </p:cNvPr>
@@ -5433,7 +5433,7 @@
           <p:cNvPr id="28" name="">
             <a:extLst xmlns:a="http://schemas.openxmlformats.org/drawingml/2006/main">
               <a:ext uri="{FF2B5EF4-FFF2-40B4-BE49-F238E27FC236}">
-                <a16:creationId xmlns:a16="http://schemas.microsoft.com/office/drawing/2014/main" id="{74D56FB4-12B3-4DA5-AB16-18FEFDDF4A6B}"/>
+                <a16:creationId xmlns:a16="http://schemas.microsoft.com/office/drawing/2014/main" id="{60C9C0CE-3DFA-46E8-B4EF-F2636F72A8F4}"/>
               </a:ext>
             </a:extLst>
           </p:cNvPr>
@@ -5476,7 +5476,7 @@
     </p:spTree>
     <p:extLst>
       <p:ext uri="{BB962C8B-B14F-4D97-AF65-F5344CB8AC3E}">
-        <p14:creationId xmlns:p14="http://schemas.microsoft.com/office/powerpoint/2010/main" val="1832760697"/>
+        <p14:creationId xmlns:p14="http://schemas.microsoft.com/office/powerpoint/2010/main" val="1409362772"/>
       </p:ext>
     </p:extLst>
   </p:cSld>
@@ -5507,7 +5507,7 @@
           <p:cNvPr id="15" name="">
             <a:extLst xmlns:a="http://schemas.openxmlformats.org/drawingml/2006/main">
               <a:ext uri="{FF2B5EF4-FFF2-40B4-BE49-F238E27FC236}">
-                <a16:creationId xmlns:a16="http://schemas.microsoft.com/office/drawing/2014/main" id="{2209CFF3-E307-4319-9953-EC9EFA8A0F89}"/>
+                <a16:creationId xmlns:a16="http://schemas.microsoft.com/office/drawing/2014/main" id="{6CA318F4-ADA3-4F82-A7E5-1F9C5BF427A3}"/>
               </a:ext>
             </a:extLst>
           </p:cNvPr>
@@ -5552,7 +5552,7 @@
           <p:cNvPr id="2" name="">
             <a:extLst xmlns:a="http://schemas.openxmlformats.org/drawingml/2006/main">
               <a:ext uri="{FF2B5EF4-FFF2-40B4-BE49-F238E27FC236}">
-                <a16:creationId xmlns:a16="http://schemas.microsoft.com/office/drawing/2014/main" id="{1DCAA4AB-E29F-45C1-8EB3-A662D4F049F5}"/>
+                <a16:creationId xmlns:a16="http://schemas.microsoft.com/office/drawing/2014/main" id="{1551F25F-479F-4A1A-9DDD-8CE04CE68DBE}"/>
               </a:ext>
             </a:extLst>
           </p:cNvPr>
@@ -5582,7 +5582,7 @@
           <p:cNvPr id="3" name="">
             <a:extLst xmlns:a="http://schemas.openxmlformats.org/drawingml/2006/main">
               <a:ext uri="{FF2B5EF4-FFF2-40B4-BE49-F238E27FC236}">
-                <a16:creationId xmlns:a16="http://schemas.microsoft.com/office/drawing/2014/main" id="{031CD144-DDD5-4FC3-8821-1A0B304DCDA2}"/>
+                <a16:creationId xmlns:a16="http://schemas.microsoft.com/office/drawing/2014/main" id="{9A8182CE-5FA7-4CF6-B813-3AD3EAFBFAFF}"/>
               </a:ext>
             </a:extLst>
           </p:cNvPr>
@@ -5627,7 +5627,7 @@
           <p:cNvPr id="4" name="">
             <a:extLst xmlns:a="http://schemas.openxmlformats.org/drawingml/2006/main">
               <a:ext uri="{FF2B5EF4-FFF2-40B4-BE49-F238E27FC236}">
-                <a16:creationId xmlns:a16="http://schemas.microsoft.com/office/drawing/2014/main" id="{3E4B0435-2181-48B3-AB00-DF0482E7DA70}"/>
+                <a16:creationId xmlns:a16="http://schemas.microsoft.com/office/drawing/2014/main" id="{06158392-017D-4F5B-95C7-4C215A1149AF}"/>
               </a:ext>
             </a:extLst>
           </p:cNvPr>
@@ -5672,7 +5672,7 @@
           <p:cNvPr id="5" name="">
             <a:extLst xmlns:a="http://schemas.openxmlformats.org/drawingml/2006/main">
               <a:ext uri="{FF2B5EF4-FFF2-40B4-BE49-F238E27FC236}">
-                <a16:creationId xmlns:a16="http://schemas.microsoft.com/office/drawing/2014/main" id="{3FF9513A-B0B8-4C7C-8AB9-A3E5ABA616CD}"/>
+                <a16:creationId xmlns:a16="http://schemas.microsoft.com/office/drawing/2014/main" id="{C50EC432-D71D-464D-B3C0-7AF4DEF4EB04}"/>
               </a:ext>
             </a:extLst>
           </p:cNvPr>
@@ -5704,7 +5704,7 @@
           <p:cNvPr id="6" name="">
             <a:extLst xmlns:a="http://schemas.openxmlformats.org/drawingml/2006/main">
               <a:ext uri="{FF2B5EF4-FFF2-40B4-BE49-F238E27FC236}">
-                <a16:creationId xmlns:a16="http://schemas.microsoft.com/office/drawing/2014/main" id="{4D1F1170-648D-4E00-9F09-D4C944A31B1B}"/>
+                <a16:creationId xmlns:a16="http://schemas.microsoft.com/office/drawing/2014/main" id="{CC2CD2D0-A0FC-4CE1-8556-FBC272F32C57}"/>
               </a:ext>
             </a:extLst>
           </p:cNvPr>
@@ -5736,7 +5736,7 @@
           <p:cNvPr id="7" name="">
             <a:extLst xmlns:a="http://schemas.openxmlformats.org/drawingml/2006/main">
               <a:ext uri="{FF2B5EF4-FFF2-40B4-BE49-F238E27FC236}">
-                <a16:creationId xmlns:a16="http://schemas.microsoft.com/office/drawing/2014/main" id="{CA05F302-861F-4ABE-8E6F-CA051C37B17E}"/>
+                <a16:creationId xmlns:a16="http://schemas.microsoft.com/office/drawing/2014/main" id="{0923FC36-C0DF-47EB-BBBF-6C2F22B53F79}"/>
               </a:ext>
             </a:extLst>
           </p:cNvPr>
@@ -5768,7 +5768,7 @@
           <p:cNvPr id="8" name="">
             <a:extLst xmlns:a="http://schemas.openxmlformats.org/drawingml/2006/main">
               <a:ext uri="{FF2B5EF4-FFF2-40B4-BE49-F238E27FC236}">
-                <a16:creationId xmlns:a16="http://schemas.microsoft.com/office/drawing/2014/main" id="{50F8B852-4217-4A38-917A-3867D45D4AEB}"/>
+                <a16:creationId xmlns:a16="http://schemas.microsoft.com/office/drawing/2014/main" id="{E9406F8D-7381-4317-9570-3F24E8595381}"/>
               </a:ext>
             </a:extLst>
           </p:cNvPr>
@@ -5813,7 +5813,7 @@
           <p:cNvPr id="9" name="">
             <a:extLst xmlns:a="http://schemas.openxmlformats.org/drawingml/2006/main">
               <a:ext uri="{FF2B5EF4-FFF2-40B4-BE49-F238E27FC236}">
-                <a16:creationId xmlns:a16="http://schemas.microsoft.com/office/drawing/2014/main" id="{180BB3A1-656D-47A2-83DC-F578B649150E}"/>
+                <a16:creationId xmlns:a16="http://schemas.microsoft.com/office/drawing/2014/main" id="{F324F411-56E3-49DE-8ACF-5848DCBCB53E}"/>
               </a:ext>
             </a:extLst>
           </p:cNvPr>
@@ -5858,7 +5858,7 @@
           <p:cNvPr id="10" name="">
             <a:extLst xmlns:a="http://schemas.openxmlformats.org/drawingml/2006/main">
               <a:ext uri="{FF2B5EF4-FFF2-40B4-BE49-F238E27FC236}">
-                <a16:creationId xmlns:a16="http://schemas.microsoft.com/office/drawing/2014/main" id="{5E1A5D89-E3CD-48D3-93C8-2CEC8764D4CC}"/>
+                <a16:creationId xmlns:a16="http://schemas.microsoft.com/office/drawing/2014/main" id="{14959647-6806-4C2B-BEDD-9528253068B8}"/>
               </a:ext>
             </a:extLst>
           </p:cNvPr>
@@ -5890,7 +5890,7 @@
           <p:cNvPr id="11" name="">
             <a:extLst xmlns:a="http://schemas.openxmlformats.org/drawingml/2006/main">
               <a:ext uri="{FF2B5EF4-FFF2-40B4-BE49-F238E27FC236}">
-                <a16:creationId xmlns:a16="http://schemas.microsoft.com/office/drawing/2014/main" id="{EE2B8706-E23C-4C1B-809B-F8EDCE283898}"/>
+                <a16:creationId xmlns:a16="http://schemas.microsoft.com/office/drawing/2014/main" id="{671CCFD7-C78B-44DB-8759-DDB7CFEB13B7}"/>
               </a:ext>
             </a:extLst>
           </p:cNvPr>
@@ -5922,7 +5922,7 @@
           <p:cNvPr id="12" name="">
             <a:extLst xmlns:a="http://schemas.openxmlformats.org/drawingml/2006/main">
               <a:ext uri="{FF2B5EF4-FFF2-40B4-BE49-F238E27FC236}">
-                <a16:creationId xmlns:a16="http://schemas.microsoft.com/office/drawing/2014/main" id="{25C1904A-A86C-4ED6-8A71-82271909787A}"/>
+                <a16:creationId xmlns:a16="http://schemas.microsoft.com/office/drawing/2014/main" id="{EC192CC3-3BA5-4E45-AA27-9176397A5252}"/>
               </a:ext>
             </a:extLst>
           </p:cNvPr>
@@ -5954,7 +5954,7 @@
           <p:cNvPr id="13" name="">
             <a:extLst xmlns:a="http://schemas.openxmlformats.org/drawingml/2006/main">
               <a:ext uri="{FF2B5EF4-FFF2-40B4-BE49-F238E27FC236}">
-                <a16:creationId xmlns:a16="http://schemas.microsoft.com/office/drawing/2014/main" id="{FEBB12A1-6FC0-4760-BDA3-D748443FD5D6}"/>
+                <a16:creationId xmlns:a16="http://schemas.microsoft.com/office/drawing/2014/main" id="{45399602-0D6B-4F66-B196-C16617BBD894}"/>
               </a:ext>
             </a:extLst>
           </p:cNvPr>
@@ -5999,7 +5999,7 @@
           <p:cNvPr id="14" name="">
             <a:extLst xmlns:a="http://schemas.openxmlformats.org/drawingml/2006/main">
               <a:ext uri="{FF2B5EF4-FFF2-40B4-BE49-F238E27FC236}">
-                <a16:creationId xmlns:a16="http://schemas.microsoft.com/office/drawing/2014/main" id="{FED5BA41-A66F-46A4-AFC0-376DFB8D4183}"/>
+                <a16:creationId xmlns:a16="http://schemas.microsoft.com/office/drawing/2014/main" id="{FAF618C8-29F6-4152-A5FB-4237E39A7076}"/>
               </a:ext>
             </a:extLst>
           </p:cNvPr>
@@ -6042,7 +6042,7 @@
     </p:spTree>
     <p:extLst>
       <p:ext uri="{BB962C8B-B14F-4D97-AF65-F5344CB8AC3E}">
-        <p14:creationId xmlns:p14="http://schemas.microsoft.com/office/powerpoint/2010/main" val="1731396142"/>
+        <p14:creationId xmlns:p14="http://schemas.microsoft.com/office/powerpoint/2010/main" val="520135501"/>
       </p:ext>
     </p:extLst>
   </p:cSld>
@@ -6073,7 +6073,7 @@
           <p:cNvPr id="20" name="">
             <a:extLst xmlns:a="http://schemas.openxmlformats.org/drawingml/2006/main">
               <a:ext uri="{FF2B5EF4-FFF2-40B4-BE49-F238E27FC236}">
-                <a16:creationId xmlns:a16="http://schemas.microsoft.com/office/drawing/2014/main" id="{ABBF723A-A912-4A29-B2CB-A9C658D36BC4}"/>
+                <a16:creationId xmlns:a16="http://schemas.microsoft.com/office/drawing/2014/main" id="{B590E7BC-F5E2-414A-AC52-863D442E1D29}"/>
               </a:ext>
             </a:extLst>
           </p:cNvPr>
@@ -6118,7 +6118,7 @@
           <p:cNvPr id="2" name="">
             <a:extLst xmlns:a="http://schemas.openxmlformats.org/drawingml/2006/main">
               <a:ext uri="{FF2B5EF4-FFF2-40B4-BE49-F238E27FC236}">
-                <a16:creationId xmlns:a16="http://schemas.microsoft.com/office/drawing/2014/main" id="{78F62F35-8203-44A6-B6A1-383CDB806B7B}"/>
+                <a16:creationId xmlns:a16="http://schemas.microsoft.com/office/drawing/2014/main" id="{09311848-0E3F-4D59-8A38-88896869BAFF}"/>
               </a:ext>
             </a:extLst>
           </p:cNvPr>
@@ -6148,7 +6148,7 @@
           <p:cNvPr id="3" name="">
             <a:extLst xmlns:a="http://schemas.openxmlformats.org/drawingml/2006/main">
               <a:ext uri="{FF2B5EF4-FFF2-40B4-BE49-F238E27FC236}">
-                <a16:creationId xmlns:a16="http://schemas.microsoft.com/office/drawing/2014/main" id="{C136AC8E-5AE9-453D-8ADE-D3A1E234C3C7}"/>
+                <a16:creationId xmlns:a16="http://schemas.microsoft.com/office/drawing/2014/main" id="{DB7B14C4-A3A3-437F-829F-C3366F696123}"/>
               </a:ext>
             </a:extLst>
           </p:cNvPr>
@@ -6193,7 +6193,7 @@
           <p:cNvPr id="4" name="">
             <a:extLst xmlns:a="http://schemas.openxmlformats.org/drawingml/2006/main">
               <a:ext uri="{FF2B5EF4-FFF2-40B4-BE49-F238E27FC236}">
-                <a16:creationId xmlns:a16="http://schemas.microsoft.com/office/drawing/2014/main" id="{E92BA7DB-6FD4-4AD7-A279-ADE527DBCE98}"/>
+                <a16:creationId xmlns:a16="http://schemas.microsoft.com/office/drawing/2014/main" id="{32CA59B4-FA89-44A1-99D7-724FB0F08AB5}"/>
               </a:ext>
             </a:extLst>
           </p:cNvPr>
@@ -6238,7 +6238,7 @@
           <p:cNvPr id="5" name="">
             <a:extLst xmlns:a="http://schemas.openxmlformats.org/drawingml/2006/main">
               <a:ext uri="{FF2B5EF4-FFF2-40B4-BE49-F238E27FC236}">
-                <a16:creationId xmlns:a16="http://schemas.microsoft.com/office/drawing/2014/main" id="{958393B4-F07F-4DB4-98D9-F74BF54A6376}"/>
+                <a16:creationId xmlns:a16="http://schemas.microsoft.com/office/drawing/2014/main" id="{D4B6C474-24DB-45FD-B544-7E797567C1CD}"/>
               </a:ext>
             </a:extLst>
           </p:cNvPr>
@@ -6270,7 +6270,7 @@
           <p:cNvPr id="6" name="">
             <a:extLst xmlns:a="http://schemas.openxmlformats.org/drawingml/2006/main">
               <a:ext uri="{FF2B5EF4-FFF2-40B4-BE49-F238E27FC236}">
-                <a16:creationId xmlns:a16="http://schemas.microsoft.com/office/drawing/2014/main" id="{2942032C-1402-46F0-8641-D6CE8E48433C}"/>
+                <a16:creationId xmlns:a16="http://schemas.microsoft.com/office/drawing/2014/main" id="{70E5C0ED-197E-49DC-9B2E-82474062517B}"/>
               </a:ext>
             </a:extLst>
           </p:cNvPr>
@@ -6318,7 +6318,7 @@
                 <a:ea typeface="Arial"/>
                 <a:cs typeface="Arial"/>
               </a:rPr>
-              <a:t>50% W × 50% H</a:t>
+              <a:t>0.5× width</a:t>
             </a:r>
           </a:p>
           <a:p xmlns:a="http://schemas.openxmlformats.org/drawingml/2006/main">
@@ -6331,7 +6331,7 @@
                 <a:ea typeface="Arial"/>
                 <a:cs typeface="Arial"/>
               </a:rPr>
-              <a:t>(25% of pixels)</a:t>
+              <a:t>0.5× height</a:t>
             </a:r>
           </a:p>
         </p:txBody>
@@ -6341,7 +6341,7 @@
           <p:cNvPr id="7" name="">
             <a:extLst xmlns:a="http://schemas.openxmlformats.org/drawingml/2006/main">
               <a:ext uri="{FF2B5EF4-FFF2-40B4-BE49-F238E27FC236}">
-                <a16:creationId xmlns:a16="http://schemas.microsoft.com/office/drawing/2014/main" id="{B9695508-4155-43DC-927E-D9F4BF032A1C}"/>
+                <a16:creationId xmlns:a16="http://schemas.microsoft.com/office/drawing/2014/main" id="{8558AE41-8932-445C-90D5-E48CECC27755}"/>
               </a:ext>
             </a:extLst>
           </p:cNvPr>
@@ -6386,7 +6386,7 @@
           <p:cNvPr id="8" name="">
             <a:extLst xmlns:a="http://schemas.openxmlformats.org/drawingml/2006/main">
               <a:ext uri="{FF2B5EF4-FFF2-40B4-BE49-F238E27FC236}">
-                <a16:creationId xmlns:a16="http://schemas.microsoft.com/office/drawing/2014/main" id="{D67F8474-E533-4C96-AB54-30AF87821599}"/>
+                <a16:creationId xmlns:a16="http://schemas.microsoft.com/office/drawing/2014/main" id="{03650FF8-98B7-4E6E-9DE9-A9F2A655B22B}"/>
               </a:ext>
             </a:extLst>
           </p:cNvPr>
@@ -6418,7 +6418,7 @@
           <p:cNvPr id="9" name="">
             <a:extLst xmlns:a="http://schemas.openxmlformats.org/drawingml/2006/main">
               <a:ext uri="{FF2B5EF4-FFF2-40B4-BE49-F238E27FC236}">
-                <a16:creationId xmlns:a16="http://schemas.microsoft.com/office/drawing/2014/main" id="{2E19CF6C-B043-4EF1-B9F9-B1E7F3DBCD02}"/>
+                <a16:creationId xmlns:a16="http://schemas.microsoft.com/office/drawing/2014/main" id="{338A9744-7733-4338-B2EA-754BBD0111EC}"/>
               </a:ext>
             </a:extLst>
           </p:cNvPr>
@@ -6450,7 +6450,7 @@
           <p:cNvPr id="10" name="">
             <a:extLst xmlns:a="http://schemas.openxmlformats.org/drawingml/2006/main">
               <a:ext uri="{FF2B5EF4-FFF2-40B4-BE49-F238E27FC236}">
-                <a16:creationId xmlns:a16="http://schemas.microsoft.com/office/drawing/2014/main" id="{89AFB8B6-8473-4EA0-AB59-66848D08CA4D}"/>
+                <a16:creationId xmlns:a16="http://schemas.microsoft.com/office/drawing/2014/main" id="{64E1D8D4-54D2-4F20-B837-C90A7FD111D7}"/>
               </a:ext>
             </a:extLst>
           </p:cNvPr>
@@ -6495,7 +6495,7 @@
           <p:cNvPr id="11" name="">
             <a:extLst xmlns:a="http://schemas.openxmlformats.org/drawingml/2006/main">
               <a:ext uri="{FF2B5EF4-FFF2-40B4-BE49-F238E27FC236}">
-                <a16:creationId xmlns:a16="http://schemas.microsoft.com/office/drawing/2014/main" id="{983E6B9A-4F84-4E0A-8821-92DA8AC8B566}"/>
+                <a16:creationId xmlns:a16="http://schemas.microsoft.com/office/drawing/2014/main" id="{6E0CA3C0-C7FE-4D04-A534-0407DD321B55}"/>
               </a:ext>
             </a:extLst>
           </p:cNvPr>
@@ -6540,7 +6540,7 @@
           <p:cNvPr id="12" name="">
             <a:extLst xmlns:a="http://schemas.openxmlformats.org/drawingml/2006/main">
               <a:ext uri="{FF2B5EF4-FFF2-40B4-BE49-F238E27FC236}">
-                <a16:creationId xmlns:a16="http://schemas.microsoft.com/office/drawing/2014/main" id="{94AD05D2-712F-4B7A-87C5-BA1CB15F96A7}"/>
+                <a16:creationId xmlns:a16="http://schemas.microsoft.com/office/drawing/2014/main" id="{ADAE545E-C88B-45D1-BE3D-904282A5F47D}"/>
               </a:ext>
             </a:extLst>
           </p:cNvPr>
@@ -6585,7 +6585,7 @@
           <p:cNvPr id="13" name="">
             <a:extLst xmlns:a="http://schemas.openxmlformats.org/drawingml/2006/main">
               <a:ext uri="{FF2B5EF4-FFF2-40B4-BE49-F238E27FC236}">
-                <a16:creationId xmlns:a16="http://schemas.microsoft.com/office/drawing/2014/main" id="{8AAFF49D-F64E-467B-AE0A-2AD43EF3F957}"/>
+                <a16:creationId xmlns:a16="http://schemas.microsoft.com/office/drawing/2014/main" id="{340BC6D5-EF0D-49EC-8B90-982C96F689DB}"/>
               </a:ext>
             </a:extLst>
           </p:cNvPr>
@@ -6617,7 +6617,7 @@
           <p:cNvPr id="14" name="">
             <a:extLst xmlns:a="http://schemas.openxmlformats.org/drawingml/2006/main">
               <a:ext uri="{FF2B5EF4-FFF2-40B4-BE49-F238E27FC236}">
-                <a16:creationId xmlns:a16="http://schemas.microsoft.com/office/drawing/2014/main" id="{614E9256-1B6A-4A49-99CA-A3ECEE86FCFD}"/>
+                <a16:creationId xmlns:a16="http://schemas.microsoft.com/office/drawing/2014/main" id="{C27E8751-4EDD-4021-9553-55DC26EB54B3}"/>
               </a:ext>
             </a:extLst>
           </p:cNvPr>
@@ -6649,7 +6649,7 @@
           <p:cNvPr id="15" name="">
             <a:extLst xmlns:a="http://schemas.openxmlformats.org/drawingml/2006/main">
               <a:ext uri="{FF2B5EF4-FFF2-40B4-BE49-F238E27FC236}">
-                <a16:creationId xmlns:a16="http://schemas.microsoft.com/office/drawing/2014/main" id="{A002B53F-7975-48FC-BE17-82EC128DF4D6}"/>
+                <a16:creationId xmlns:a16="http://schemas.microsoft.com/office/drawing/2014/main" id="{D9E2F185-C79A-4AE2-9115-82DDDB9F2002}"/>
               </a:ext>
             </a:extLst>
           </p:cNvPr>
@@ -6681,7 +6681,7 @@
           <p:cNvPr id="16" name="">
             <a:extLst xmlns:a="http://schemas.openxmlformats.org/drawingml/2006/main">
               <a:ext uri="{FF2B5EF4-FFF2-40B4-BE49-F238E27FC236}">
-                <a16:creationId xmlns:a16="http://schemas.microsoft.com/office/drawing/2014/main" id="{4C12CED7-8EF1-443E-BEB6-21F70C3263AC}"/>
+                <a16:creationId xmlns:a16="http://schemas.microsoft.com/office/drawing/2014/main" id="{AA0E4506-D1E4-4CAE-B56E-2526D1A7DC15}"/>
               </a:ext>
             </a:extLst>
           </p:cNvPr>
@@ -6726,7 +6726,7 @@
           <p:cNvPr id="17" name="">
             <a:extLst xmlns:a="http://schemas.openxmlformats.org/drawingml/2006/main">
               <a:ext uri="{FF2B5EF4-FFF2-40B4-BE49-F238E27FC236}">
-                <a16:creationId xmlns:a16="http://schemas.microsoft.com/office/drawing/2014/main" id="{23EAB435-6491-41FF-AF55-DB7C02BF96B9}"/>
+                <a16:creationId xmlns:a16="http://schemas.microsoft.com/office/drawing/2014/main" id="{934B62B1-220F-4C6D-8CAB-24CD4B07F020}"/>
               </a:ext>
             </a:extLst>
           </p:cNvPr>
@@ -6761,7 +6761,7 @@
                 <a:ea typeface="Arial"/>
                 <a:cs typeface="Arial"/>
               </a:rPr>
-              <a:t>960 × 540 output</a:t>
+              <a:t>1.0× output</a:t>
             </a:r>
           </a:p>
         </p:txBody>
@@ -6771,7 +6771,7 @@
           <p:cNvPr id="18" name="">
             <a:extLst xmlns:a="http://schemas.openxmlformats.org/drawingml/2006/main">
               <a:ext uri="{FF2B5EF4-FFF2-40B4-BE49-F238E27FC236}">
-                <a16:creationId xmlns:a16="http://schemas.microsoft.com/office/drawing/2014/main" id="{F746B42D-189B-4D7E-B05A-1AB7E058D48B}"/>
+                <a16:creationId xmlns:a16="http://schemas.microsoft.com/office/drawing/2014/main" id="{D8A7DF32-B0A9-4602-B8A4-002DCC5A153C}"/>
               </a:ext>
             </a:extLst>
           </p:cNvPr>
@@ -6806,7 +6806,7 @@
                 <a:ea typeface="Arial"/>
                 <a:cs typeface="Arial"/>
               </a:rPr>
-              <a:t>Full-resolution region: 0.7%, 2.8%, 11.1%, 25.0%, 44.4% of image</a:t>
+              <a:t>Full-resolution region width: 0.08×, 0.17×, 0.33×, 0.50×, 0.67×</a:t>
             </a:r>
           </a:p>
         </p:txBody>
@@ -6816,7 +6816,7 @@
           <p:cNvPr id="19" name="">
             <a:extLst xmlns:a="http://schemas.openxmlformats.org/drawingml/2006/main">
               <a:ext uri="{FF2B5EF4-FFF2-40B4-BE49-F238E27FC236}">
-                <a16:creationId xmlns:a16="http://schemas.microsoft.com/office/drawing/2014/main" id="{1D8E51DD-0FE4-435C-AD7B-B514D1D3D42B}"/>
+                <a16:creationId xmlns:a16="http://schemas.microsoft.com/office/drawing/2014/main" id="{EE9D7666-F742-47FC-9761-89CBA26D813F}"/>
               </a:ext>
             </a:extLst>
           </p:cNvPr>
@@ -6851,7 +6851,7 @@
                 <a:ea typeface="Arial"/>
                 <a:cs typeface="Arial"/>
               </a:rPr>
-              <a:t>Region % means image-area coverage; base sampling is separate. Fixed center, 3 px halo; no eye tracking.</a:t>
+              <a:t>Region scale = region width / image width. Sampling inside the region stays at full resolution.</a:t>
             </a:r>
           </a:p>
         </p:txBody>
@@ -6859,7 +6859,7 @@
     </p:spTree>
     <p:extLst>
       <p:ext uri="{BB962C8B-B14F-4D97-AF65-F5344CB8AC3E}">
-        <p14:creationId xmlns:p14="http://schemas.microsoft.com/office/powerpoint/2010/main" val="590900306"/>
+        <p14:creationId xmlns:p14="http://schemas.microsoft.com/office/powerpoint/2010/main" val="606043869"/>
       </p:ext>
     </p:extLst>
   </p:cSld>
@@ -6890,7 +6890,7 @@
           <p:cNvPr id="12" name="">
             <a:extLst xmlns:a="http://schemas.openxmlformats.org/drawingml/2006/main">
               <a:ext uri="{FF2B5EF4-FFF2-40B4-BE49-F238E27FC236}">
-                <a16:creationId xmlns:a16="http://schemas.microsoft.com/office/drawing/2014/main" id="{58E7B120-2336-4508-AEDD-3A80E7F5DF37}"/>
+                <a16:creationId xmlns:a16="http://schemas.microsoft.com/office/drawing/2014/main" id="{C2A0E4F3-1574-411F-878A-BD7553CEB9CA}"/>
               </a:ext>
             </a:extLst>
           </p:cNvPr>
@@ -6935,7 +6935,7 @@
           <p:cNvPr id="2" name="">
             <a:extLst xmlns:a="http://schemas.openxmlformats.org/drawingml/2006/main">
               <a:ext uri="{FF2B5EF4-FFF2-40B4-BE49-F238E27FC236}">
-                <a16:creationId xmlns:a16="http://schemas.microsoft.com/office/drawing/2014/main" id="{8EF7E9B1-56BC-4BB5-A378-6BD835267AA4}"/>
+                <a16:creationId xmlns:a16="http://schemas.microsoft.com/office/drawing/2014/main" id="{B2A2A012-794B-45CC-A04B-FDDCC9FFDF20}"/>
               </a:ext>
             </a:extLst>
           </p:cNvPr>
@@ -6965,7 +6965,7 @@
           <p:cNvPr id="3" name="">
             <a:extLst xmlns:a="http://schemas.openxmlformats.org/drawingml/2006/main">
               <a:ext uri="{FF2B5EF4-FFF2-40B4-BE49-F238E27FC236}">
-                <a16:creationId xmlns:a16="http://schemas.microsoft.com/office/drawing/2014/main" id="{81366B18-9EAE-4369-B199-9FB6BAD3BC8C}"/>
+                <a16:creationId xmlns:a16="http://schemas.microsoft.com/office/drawing/2014/main" id="{F7E29E61-CB9C-44DB-8A4A-59D3EE23E28E}"/>
               </a:ext>
             </a:extLst>
           </p:cNvPr>
@@ -7010,7 +7010,7 @@
           <p:cNvPr id="4" name="Chart">
             <a:extLst xmlns:a="http://schemas.openxmlformats.org/drawingml/2006/main">
               <a:ext uri="{FF2B5EF4-FFF2-40B4-BE49-F238E27FC236}">
-                <a16:creationId xmlns:a16="http://schemas.microsoft.com/office/drawing/2014/main" id="{E657DE70-47A4-4A50-A164-2D6474B474BF}"/>
+                <a16:creationId xmlns:a16="http://schemas.microsoft.com/office/drawing/2014/main" id="{59844BE6-ECD9-439B-AC1C-7836C10B5F24}"/>
               </a:ext>
             </a:extLst>
           </p:cNvPr>
@@ -7023,7 +7023,7 @@
         </p:xfrm>
         <a:graphic xmlns:a="http://schemas.openxmlformats.org/drawingml/2006/main">
           <a:graphicData uri="http://schemas.openxmlformats.org/drawingml/2006/chart">
-            <c:chart xmlns:r="http://schemas.openxmlformats.org/officeDocument/2006/relationships" xmlns:c="http://schemas.openxmlformats.org/drawingml/2006/chart" r:id="R0f94985e972f4ef5"/>
+            <c:chart xmlns:r="http://schemas.openxmlformats.org/officeDocument/2006/relationships" xmlns:c="http://schemas.openxmlformats.org/drawingml/2006/chart" r:id="Ra00bb7ec55c04ba2"/>
           </a:graphicData>
         </a:graphic>
       </p:graphicFrame>
@@ -7032,7 +7032,7 @@
           <p:cNvPr id="5" name="">
             <a:extLst xmlns:a="http://schemas.openxmlformats.org/drawingml/2006/main">
               <a:ext uri="{FF2B5EF4-FFF2-40B4-BE49-F238E27FC236}">
-                <a16:creationId xmlns:a16="http://schemas.microsoft.com/office/drawing/2014/main" id="{FC8587D0-E7AA-4B18-8103-CB9E233E9980}"/>
+                <a16:creationId xmlns:a16="http://schemas.microsoft.com/office/drawing/2014/main" id="{62565BA1-E81E-4E51-8B2C-2505B4052BF3}"/>
               </a:ext>
             </a:extLst>
           </p:cNvPr>
@@ -7077,7 +7077,7 @@
           <p:cNvPr id="6" name="">
             <a:extLst xmlns:a="http://schemas.openxmlformats.org/drawingml/2006/main">
               <a:ext uri="{FF2B5EF4-FFF2-40B4-BE49-F238E27FC236}">
-                <a16:creationId xmlns:a16="http://schemas.microsoft.com/office/drawing/2014/main" id="{5B1C1FE3-DC60-44C2-8E0A-0AA8C4B070F1}"/>
+                <a16:creationId xmlns:a16="http://schemas.microsoft.com/office/drawing/2014/main" id="{81D8E702-AF40-4E3C-9C30-6C3DB5B75771}"/>
               </a:ext>
             </a:extLst>
           </p:cNvPr>
@@ -7122,7 +7122,7 @@
           <p:cNvPr id="7" name="">
             <a:extLst xmlns:a="http://schemas.openxmlformats.org/drawingml/2006/main">
               <a:ext uri="{FF2B5EF4-FFF2-40B4-BE49-F238E27FC236}">
-                <a16:creationId xmlns:a16="http://schemas.microsoft.com/office/drawing/2014/main" id="{399E4EE5-A198-4B0B-B86E-B0A3A6031AC7}"/>
+                <a16:creationId xmlns:a16="http://schemas.microsoft.com/office/drawing/2014/main" id="{9FD1AA88-549B-4459-937A-49F95284C1BE}"/>
               </a:ext>
             </a:extLst>
           </p:cNvPr>
@@ -7167,7 +7167,7 @@
           <p:cNvPr id="8" name="">
             <a:extLst xmlns:a="http://schemas.openxmlformats.org/drawingml/2006/main">
               <a:ext uri="{FF2B5EF4-FFF2-40B4-BE49-F238E27FC236}">
-                <a16:creationId xmlns:a16="http://schemas.microsoft.com/office/drawing/2014/main" id="{4891ECD1-451A-4461-A687-264117661EBE}"/>
+                <a16:creationId xmlns:a16="http://schemas.microsoft.com/office/drawing/2014/main" id="{DF1E08D9-DE6D-463C-81B3-16C85A2A3EF7}"/>
               </a:ext>
             </a:extLst>
           </p:cNvPr>
@@ -7212,7 +7212,7 @@
           <p:cNvPr id="9" name="">
             <a:extLst xmlns:a="http://schemas.openxmlformats.org/drawingml/2006/main">
               <a:ext uri="{FF2B5EF4-FFF2-40B4-BE49-F238E27FC236}">
-                <a16:creationId xmlns:a16="http://schemas.microsoft.com/office/drawing/2014/main" id="{052CEAE3-571A-4803-8325-765F7E19F323}"/>
+                <a16:creationId xmlns:a16="http://schemas.microsoft.com/office/drawing/2014/main" id="{255AA6EB-02FB-42A5-94DD-924562B9C9BC}"/>
               </a:ext>
             </a:extLst>
           </p:cNvPr>
@@ -7257,7 +7257,7 @@
           <p:cNvPr id="10" name="">
             <a:extLst xmlns:a="http://schemas.openxmlformats.org/drawingml/2006/main">
               <a:ext uri="{FF2B5EF4-FFF2-40B4-BE49-F238E27FC236}">
-                <a16:creationId xmlns:a16="http://schemas.microsoft.com/office/drawing/2014/main" id="{CA760181-77EA-41D6-A00C-EAA672DAD0CC}"/>
+                <a16:creationId xmlns:a16="http://schemas.microsoft.com/office/drawing/2014/main" id="{F136F32D-FC77-4962-BD3A-22FF1BAB31B2}"/>
               </a:ext>
             </a:extLst>
           </p:cNvPr>
@@ -7302,7 +7302,7 @@
           <p:cNvPr id="11" name="">
             <a:extLst xmlns:a="http://schemas.openxmlformats.org/drawingml/2006/main">
               <a:ext uri="{FF2B5EF4-FFF2-40B4-BE49-F238E27FC236}">
-                <a16:creationId xmlns:a16="http://schemas.microsoft.com/office/drawing/2014/main" id="{5AAB3EC2-6239-40D6-BC60-602C8853129C}"/>
+                <a16:creationId xmlns:a16="http://schemas.microsoft.com/office/drawing/2014/main" id="{59332637-B9D4-4203-822C-4D17BE9FCD7C}"/>
               </a:ext>
             </a:extLst>
           </p:cNvPr>
@@ -7345,7 +7345,7 @@
     </p:spTree>
     <p:extLst>
       <p:ext uri="{BB962C8B-B14F-4D97-AF65-F5344CB8AC3E}">
-        <p14:creationId xmlns:p14="http://schemas.microsoft.com/office/powerpoint/2010/main" val="1223246617"/>
+        <p14:creationId xmlns:p14="http://schemas.microsoft.com/office/powerpoint/2010/main" val="584151859"/>
       </p:ext>
     </p:extLst>
   </p:cSld>
@@ -7376,7 +7376,7 @@
           <p:cNvPr id="8" name="">
             <a:extLst xmlns:a="http://schemas.openxmlformats.org/drawingml/2006/main">
               <a:ext uri="{FF2B5EF4-FFF2-40B4-BE49-F238E27FC236}">
-                <a16:creationId xmlns:a16="http://schemas.microsoft.com/office/drawing/2014/main" id="{25297BD3-542B-42B4-A0BE-9AC4C6BAB68E}"/>
+                <a16:creationId xmlns:a16="http://schemas.microsoft.com/office/drawing/2014/main" id="{7E4CE1E8-BF96-4F64-B6E3-D44062434E1A}"/>
               </a:ext>
             </a:extLst>
           </p:cNvPr>
@@ -7421,7 +7421,7 @@
           <p:cNvPr id="2" name="">
             <a:extLst xmlns:a="http://schemas.openxmlformats.org/drawingml/2006/main">
               <a:ext uri="{FF2B5EF4-FFF2-40B4-BE49-F238E27FC236}">
-                <a16:creationId xmlns:a16="http://schemas.microsoft.com/office/drawing/2014/main" id="{7A42AC4E-0C09-4651-80AE-F2A753F72686}"/>
+                <a16:creationId xmlns:a16="http://schemas.microsoft.com/office/drawing/2014/main" id="{02F3FBD6-E63F-40FA-97D3-82A6A5963E3F}"/>
               </a:ext>
             </a:extLst>
           </p:cNvPr>
@@ -7451,7 +7451,7 @@
           <p:cNvPr id="3" name="">
             <a:extLst xmlns:a="http://schemas.openxmlformats.org/drawingml/2006/main">
               <a:ext uri="{FF2B5EF4-FFF2-40B4-BE49-F238E27FC236}">
-                <a16:creationId xmlns:a16="http://schemas.microsoft.com/office/drawing/2014/main" id="{AB764DB4-DBBE-485A-A0BD-3495CBDA0574}"/>
+                <a16:creationId xmlns:a16="http://schemas.microsoft.com/office/drawing/2014/main" id="{4C75864A-465E-4583-9191-F1556CA59891}"/>
               </a:ext>
             </a:extLst>
           </p:cNvPr>
@@ -7496,7 +7496,7 @@
           <p:cNvPr id="4" name="">
             <a:extLst xmlns:a="http://schemas.openxmlformats.org/drawingml/2006/main">
               <a:ext uri="{FF2B5EF4-FFF2-40B4-BE49-F238E27FC236}">
-                <a16:creationId xmlns:a16="http://schemas.microsoft.com/office/drawing/2014/main" id="{5DEF8852-C2C1-4ADB-859B-F517255A89B0}"/>
+                <a16:creationId xmlns:a16="http://schemas.microsoft.com/office/drawing/2014/main" id="{806A95FC-757C-4E87-A70C-188BC0811CD4}"/>
               </a:ext>
             </a:extLst>
           </p:cNvPr>
@@ -8462,7 +8462,7 @@
           <p:cNvPr id="5" name="">
             <a:extLst xmlns:a="http://schemas.openxmlformats.org/drawingml/2006/main">
               <a:ext uri="{FF2B5EF4-FFF2-40B4-BE49-F238E27FC236}">
-                <a16:creationId xmlns:a16="http://schemas.microsoft.com/office/drawing/2014/main" id="{46DB63B0-91DC-489B-ADA1-9398EE9360A9}"/>
+                <a16:creationId xmlns:a16="http://schemas.microsoft.com/office/drawing/2014/main" id="{A311A780-70FE-47B1-91FD-A2859593565F}"/>
               </a:ext>
             </a:extLst>
           </p:cNvPr>
@@ -8507,7 +8507,7 @@
           <p:cNvPr id="6" name="">
             <a:extLst xmlns:a="http://schemas.openxmlformats.org/drawingml/2006/main">
               <a:ext uri="{FF2B5EF4-FFF2-40B4-BE49-F238E27FC236}">
-                <a16:creationId xmlns:a16="http://schemas.microsoft.com/office/drawing/2014/main" id="{5FBE0DC4-FC57-4BD1-A116-68C3A2C953A4}"/>
+                <a16:creationId xmlns:a16="http://schemas.microsoft.com/office/drawing/2014/main" id="{578622C3-34F2-42B1-9079-660A3A787005}"/>
               </a:ext>
             </a:extLst>
           </p:cNvPr>
@@ -8552,7 +8552,7 @@
           <p:cNvPr id="7" name="">
             <a:extLst xmlns:a="http://schemas.openxmlformats.org/drawingml/2006/main">
               <a:ext uri="{FF2B5EF4-FFF2-40B4-BE49-F238E27FC236}">
-                <a16:creationId xmlns:a16="http://schemas.microsoft.com/office/drawing/2014/main" id="{1107472D-2F8D-4D76-9B9E-82B27A7CEAEC}"/>
+                <a16:creationId xmlns:a16="http://schemas.microsoft.com/office/drawing/2014/main" id="{C11FCAC2-791E-4524-A062-83BE093C56AB}"/>
               </a:ext>
             </a:extLst>
           </p:cNvPr>
@@ -8595,7 +8595,7 @@
     </p:spTree>
     <p:extLst>
       <p:ext uri="{BB962C8B-B14F-4D97-AF65-F5344CB8AC3E}">
-        <p14:creationId xmlns:p14="http://schemas.microsoft.com/office/powerpoint/2010/main" val="419475429"/>
+        <p14:creationId xmlns:p14="http://schemas.microsoft.com/office/powerpoint/2010/main" val="97320965"/>
       </p:ext>
     </p:extLst>
   </p:cSld>
@@ -8626,7 +8626,7 @@
           <p:cNvPr id="14" name="">
             <a:extLst xmlns:a="http://schemas.openxmlformats.org/drawingml/2006/main">
               <a:ext uri="{FF2B5EF4-FFF2-40B4-BE49-F238E27FC236}">
-                <a16:creationId xmlns:a16="http://schemas.microsoft.com/office/drawing/2014/main" id="{A75F8F7F-DA8E-46EA-BA12-F2623080626D}"/>
+                <a16:creationId xmlns:a16="http://schemas.microsoft.com/office/drawing/2014/main" id="{84061BC2-1C04-4E6D-88A4-723A6807EB9F}"/>
               </a:ext>
             </a:extLst>
           </p:cNvPr>
@@ -8671,7 +8671,7 @@
           <p:cNvPr id="2" name="">
             <a:extLst xmlns:a="http://schemas.openxmlformats.org/drawingml/2006/main">
               <a:ext uri="{FF2B5EF4-FFF2-40B4-BE49-F238E27FC236}">
-                <a16:creationId xmlns:a16="http://schemas.microsoft.com/office/drawing/2014/main" id="{27BFB765-84FA-4F13-A723-7C915DC7BF82}"/>
+                <a16:creationId xmlns:a16="http://schemas.microsoft.com/office/drawing/2014/main" id="{A961DC4C-62F7-429A-AAA8-F8055C952384}"/>
               </a:ext>
             </a:extLst>
           </p:cNvPr>
@@ -8701,7 +8701,7 @@
           <p:cNvPr id="3" name="">
             <a:extLst xmlns:a="http://schemas.openxmlformats.org/drawingml/2006/main">
               <a:ext uri="{FF2B5EF4-FFF2-40B4-BE49-F238E27FC236}">
-                <a16:creationId xmlns:a16="http://schemas.microsoft.com/office/drawing/2014/main" id="{762F258C-CD4F-44D3-85E2-87334FFFD6B8}"/>
+                <a16:creationId xmlns:a16="http://schemas.microsoft.com/office/drawing/2014/main" id="{A13B84C5-357B-4A37-A60E-1478AA8444C1}"/>
               </a:ext>
             </a:extLst>
           </p:cNvPr>
@@ -8746,7 +8746,7 @@
           <p:cNvPr id="4" name="">
             <a:extLst xmlns:a="http://schemas.openxmlformats.org/drawingml/2006/main">
               <a:ext uri="{FF2B5EF4-FFF2-40B4-BE49-F238E27FC236}">
-                <a16:creationId xmlns:a16="http://schemas.microsoft.com/office/drawing/2014/main" id="{D275C36C-BE03-4069-BA14-873A54FC347C}"/>
+                <a16:creationId xmlns:a16="http://schemas.microsoft.com/office/drawing/2014/main" id="{BF394C24-AB06-4D11-9010-997A298A3726}"/>
               </a:ext>
             </a:extLst>
           </p:cNvPr>
@@ -8791,7 +8791,7 @@
           <p:cNvPr id="5" name="">
             <a:extLst xmlns:a="http://schemas.openxmlformats.org/drawingml/2006/main">
               <a:ext uri="{FF2B5EF4-FFF2-40B4-BE49-F238E27FC236}">
-                <a16:creationId xmlns:a16="http://schemas.microsoft.com/office/drawing/2014/main" id="{3DFC9158-FDF4-400B-B3DC-0A57964A60A1}"/>
+                <a16:creationId xmlns:a16="http://schemas.microsoft.com/office/drawing/2014/main" id="{3DCA773A-821F-4D39-B1B2-1E8D9CED399B}"/>
               </a:ext>
             </a:extLst>
           </p:cNvPr>
@@ -8836,7 +8836,7 @@
           <p:cNvPr id="6" name="">
             <a:extLst xmlns:a="http://schemas.openxmlformats.org/drawingml/2006/main">
               <a:ext uri="{FF2B5EF4-FFF2-40B4-BE49-F238E27FC236}">
-                <a16:creationId xmlns:a16="http://schemas.microsoft.com/office/drawing/2014/main" id="{59F6AEF3-0CFC-4618-9644-830E1267C7FA}"/>
+                <a16:creationId xmlns:a16="http://schemas.microsoft.com/office/drawing/2014/main" id="{6B8B170B-B280-487B-83A8-F96A8E4DA29A}"/>
               </a:ext>
             </a:extLst>
           </p:cNvPr>
@@ -8881,7 +8881,7 @@
           <p:cNvPr id="7" name="">
             <a:extLst xmlns:a="http://schemas.openxmlformats.org/drawingml/2006/main">
               <a:ext uri="{FF2B5EF4-FFF2-40B4-BE49-F238E27FC236}">
-                <a16:creationId xmlns:a16="http://schemas.microsoft.com/office/drawing/2014/main" id="{52CDF492-2069-4A3A-825E-13C1BF3FEEFC}"/>
+                <a16:creationId xmlns:a16="http://schemas.microsoft.com/office/drawing/2014/main" id="{6267466E-2A78-44A0-8807-651FEE27E726}"/>
               </a:ext>
             </a:extLst>
           </p:cNvPr>
@@ -8926,7 +8926,7 @@
           <p:cNvPr id="8" name="">
             <a:extLst xmlns:a="http://schemas.openxmlformats.org/drawingml/2006/main">
               <a:ext uri="{FF2B5EF4-FFF2-40B4-BE49-F238E27FC236}">
-                <a16:creationId xmlns:a16="http://schemas.microsoft.com/office/drawing/2014/main" id="{4DE6C9AC-9B16-40DF-B1F0-646E85554935}"/>
+                <a16:creationId xmlns:a16="http://schemas.microsoft.com/office/drawing/2014/main" id="{48D26CF3-E8ED-4B4A-BF09-D9105063FCDA}"/>
               </a:ext>
             </a:extLst>
           </p:cNvPr>
@@ -8971,7 +8971,7 @@
           <p:cNvPr id="9" name="">
             <a:extLst xmlns:a="http://schemas.openxmlformats.org/drawingml/2006/main">
               <a:ext uri="{FF2B5EF4-FFF2-40B4-BE49-F238E27FC236}">
-                <a16:creationId xmlns:a16="http://schemas.microsoft.com/office/drawing/2014/main" id="{C80D1267-E581-47CF-B687-A0CAFA5CC4C9}"/>
+                <a16:creationId xmlns:a16="http://schemas.microsoft.com/office/drawing/2014/main" id="{8904E76B-2401-4993-AC76-6830022A959A}"/>
               </a:ext>
             </a:extLst>
           </p:cNvPr>
@@ -9016,7 +9016,7 @@
           <p:cNvPr id="10" name="">
             <a:extLst xmlns:a="http://schemas.openxmlformats.org/drawingml/2006/main">
               <a:ext uri="{FF2B5EF4-FFF2-40B4-BE49-F238E27FC236}">
-                <a16:creationId xmlns:a16="http://schemas.microsoft.com/office/drawing/2014/main" id="{CC0E7798-7DB6-4851-8166-3B519818628E}"/>
+                <a16:creationId xmlns:a16="http://schemas.microsoft.com/office/drawing/2014/main" id="{580E08B7-8360-42A4-9E2E-425511FD99AF}"/>
               </a:ext>
             </a:extLst>
           </p:cNvPr>
@@ -9061,7 +9061,7 @@
           <p:cNvPr id="11" name="">
             <a:extLst xmlns:a="http://schemas.openxmlformats.org/drawingml/2006/main">
               <a:ext uri="{FF2B5EF4-FFF2-40B4-BE49-F238E27FC236}">
-                <a16:creationId xmlns:a16="http://schemas.microsoft.com/office/drawing/2014/main" id="{FBE63E59-E48B-4956-ABA1-6EB52E07A454}"/>
+                <a16:creationId xmlns:a16="http://schemas.microsoft.com/office/drawing/2014/main" id="{FF2DCCC0-0A43-4FE8-9C63-1C6971E50A4E}"/>
               </a:ext>
             </a:extLst>
           </p:cNvPr>
@@ -9106,7 +9106,7 @@
           <p:cNvPr id="12" name="">
             <a:extLst xmlns:a="http://schemas.openxmlformats.org/drawingml/2006/main">
               <a:ext uri="{FF2B5EF4-FFF2-40B4-BE49-F238E27FC236}">
-                <a16:creationId xmlns:a16="http://schemas.microsoft.com/office/drawing/2014/main" id="{69048389-D926-49A7-94BD-A69FEDFC5712}"/>
+                <a16:creationId xmlns:a16="http://schemas.microsoft.com/office/drawing/2014/main" id="{B501E293-2794-4830-B726-E157A1D6A1DF}"/>
               </a:ext>
             </a:extLst>
           </p:cNvPr>
@@ -9151,7 +9151,7 @@
           <p:cNvPr id="13" name="">
             <a:extLst xmlns:a="http://schemas.openxmlformats.org/drawingml/2006/main">
               <a:ext uri="{FF2B5EF4-FFF2-40B4-BE49-F238E27FC236}">
-                <a16:creationId xmlns:a16="http://schemas.microsoft.com/office/drawing/2014/main" id="{D866EAEF-0C2A-40EC-BE87-7977C55B1FE0}"/>
+                <a16:creationId xmlns:a16="http://schemas.microsoft.com/office/drawing/2014/main" id="{7ADC0EEC-5BEE-45E7-B4AD-66BF4878C4C9}"/>
               </a:ext>
             </a:extLst>
           </p:cNvPr>
@@ -9194,7 +9194,7 @@
     </p:spTree>
     <p:extLst>
       <p:ext uri="{BB962C8B-B14F-4D97-AF65-F5344CB8AC3E}">
-        <p14:creationId xmlns:p14="http://schemas.microsoft.com/office/powerpoint/2010/main" val="1860536445"/>
+        <p14:creationId xmlns:p14="http://schemas.microsoft.com/office/powerpoint/2010/main" val="1884115885"/>
       </p:ext>
     </p:extLst>
   </p:cSld>

</xml_diff>

<commit_message>
Measure four new FOV scales on all Driving frames and update slides
</commit_message>
<xml_diff>
--- a/presentations/weekly_20261029/weekly_20261029_english_30w.pptx
+++ b/presentations/weekly_20261029/weekly_20261029_english_30w.pptx
@@ -2,19 +2,19 @@
 <file path=ppt/presentation.xml><?xml version="1.0" encoding="utf-8"?>
 <p:presentation xmlns:p="http://schemas.openxmlformats.org/presentationml/2006/main">
   <p:sldMasterIdLst>
-    <p:sldMasterId xmlns:r="http://schemas.openxmlformats.org/officeDocument/2006/relationships" id="2147483648" r:id="Rdfa590dddc3543e5"/>
+    <p:sldMasterId xmlns:r="http://schemas.openxmlformats.org/officeDocument/2006/relationships" id="2147483648" r:id="Rf308f94b18b34d62"/>
   </p:sldMasterIdLst>
   <p:notesMasterIdLst>
-    <p:notesMasterId xmlns:r="http://schemas.openxmlformats.org/officeDocument/2006/relationships" r:id="Rb143149f0eee46ec"/>
+    <p:notesMasterId xmlns:r="http://schemas.openxmlformats.org/officeDocument/2006/relationships" r:id="Rd2e34191d92b40dd"/>
   </p:notesMasterIdLst>
   <p:sldIdLst>
-    <p:sldId xmlns:r="http://schemas.openxmlformats.org/officeDocument/2006/relationships" id="256" r:id="Reddbe7665d5843a2"/>
-    <p:sldId xmlns:r="http://schemas.openxmlformats.org/officeDocument/2006/relationships" id="257" r:id="Rcd35bc86e509448d"/>
-    <p:sldId xmlns:r="http://schemas.openxmlformats.org/officeDocument/2006/relationships" id="258" r:id="Rb06a29f4d6704829"/>
-    <p:sldId xmlns:r="http://schemas.openxmlformats.org/officeDocument/2006/relationships" id="259" r:id="R8a4e8d52555d4578"/>
-    <p:sldId xmlns:r="http://schemas.openxmlformats.org/officeDocument/2006/relationships" id="260" r:id="R252f7c1b18b24f23"/>
-    <p:sldId xmlns:r="http://schemas.openxmlformats.org/officeDocument/2006/relationships" id="261" r:id="R2cf0c1cf2cd74d70"/>
-    <p:sldId xmlns:r="http://schemas.openxmlformats.org/officeDocument/2006/relationships" id="262" r:id="Rcf73cdef08b142a3"/>
+    <p:sldId xmlns:r="http://schemas.openxmlformats.org/officeDocument/2006/relationships" id="256" r:id="Rb539c0c24beb475e"/>
+    <p:sldId xmlns:r="http://schemas.openxmlformats.org/officeDocument/2006/relationships" id="257" r:id="R1a2cb4e75b2646eb"/>
+    <p:sldId xmlns:r="http://schemas.openxmlformats.org/officeDocument/2006/relationships" id="258" r:id="Re2ec917e25a44556"/>
+    <p:sldId xmlns:r="http://schemas.openxmlformats.org/officeDocument/2006/relationships" id="259" r:id="R615b38e118dc4a08"/>
+    <p:sldId xmlns:r="http://schemas.openxmlformats.org/officeDocument/2006/relationships" id="260" r:id="R51e1c74341c047bc"/>
+    <p:sldId xmlns:r="http://schemas.openxmlformats.org/officeDocument/2006/relationships" id="261" r:id="Ra90747cd58984512"/>
+    <p:sldId xmlns:r="http://schemas.openxmlformats.org/officeDocument/2006/relationships" id="262" r:id="Rf0bc18ac014d4af4"/>
   </p:sldIdLst>
   <p:sldSz cx="12192000" cy="6858000"/>
   <p:notesSz cx="6858000" cy="9144000"/>
@@ -658,7 +658,7 @@
           <a:lstStyle xmlns:a="http://schemas.openxmlformats.org/drawingml/2006/main"/>
           <a:p xmlns:a="http://schemas.openxmlformats.org/drawingml/2006/main">
             <a:r>
-              <a:t>Source: results/fov_levels_xavier_full_20261027/README.md; overview.csv; summary.csv. Commit 0f1506c. Date 2026-10-27. Raw evidence: evidence.tar.gz. Mechanism: half-resolution base + padded full-resolution ROI + feather overlay. The full output is 960x540 (1.0x). Region scale is ROI width divided by full-image width: 80x46 =&gt; 0.083333x, 160x90 =&gt; 0.166667x, 320x180 =&gt; 0.333333x, 480x270 =&gt; 0.5x, 640x360 =&gt; 0.666667x. Height approximately follows the same scale; the smallest ROI uses height46 for even alignment, instead of45. ROI extent scale is not sampling resolution: pixels within the ROI remain full-resolution. The base samples at 0.5x width and 0.5x height (480x270) while covering the entire image.</a:t>
+              <a:t>Source: results/fov_scales_full_20261029/scale_results.json and README.md. Same 30W CUDA C++ run: 1068 valid forward odd frames, 3 warmups, 5 timed repetitions per frame, one quality output per configuration/frame. Resident whole-pipeline GPU event timing without internal stage markers, fast resampling, dynamic clocks. This differs from the previous small-sample staged experiment. Mechanism: half-resolution base + padded full-resolution ROI + feather overlay. The full output is 960x540 (1.0x). Region scale is ROI width divided by full-image width: 96x54 =&gt; 0.1x, 240x135 =&gt; 0.25x, 480x270 =&gt; 0.5x, 720x405 =&gt; 0.75x. Width and height both follow these scales. ROI extent scale is not sampling resolution: pixels within the ROI remain full-resolution. The base samples at 0.5x width and 0.5x height (480x270) while covering the entire image.</a:t>
             </a:r>
           </a:p>
         </p:txBody>
@@ -728,7 +728,7 @@
           <a:lstStyle xmlns:a="http://schemas.openxmlformats.org/drawingml/2006/main"/>
           <a:p xmlns:a="http://schemas.openxmlformats.org/drawingml/2006/main">
             <a:r>
-              <a:t>Sources: results/cu_breakdown_xavier_20261029/README.md; results/fov_decode_budget_2ms_20261029/summary.csv. Four workloads, each frame39; 10 warmups and 100 timed runs per path. Arithmetic means of staged resident GPU timelines, not wall time. Full uses the paired baseline from the 2.8% configuration. Fixed decode budget is 2 ms once per frame, not measured joint RGB/depth/flow decoding or measured end-to-end timing. No input/output copies, network or display. Fast resampling enabled. Clearing dominates Full and accounts for about 58% of the Full-to-2.8% reconstruction saving, so the gain cannot be attributed entirely to reduced reprojection computation. No claim of an optimal Full baseline.</a:t>
+              <a:t>Source: results/fov_scales_full_20261029/scale_results.json and README.md. Same 30W CUDA C++ run: 1068 valid forward odd frames, 3 warmups, 5 timed repetitions per frame, one quality output per configuration/frame. Resident whole-pipeline GPU event timing without internal stage markers, fast resampling, dynamic clocks. This differs from the previous small-sample staged experiment. Arithmetic means of all 5340 recorded resident whole-pipeline GPU timings per configuration, not wall time. No internal stage markers. Full uses the paired baseline from the 0.25x configuration. Fixed decode budget is 2 ms once per frame, not measured joint RGB/depth/flow decoding or measured end-to-end timing. No input/output copies, network or display. Savings may include reduced clearing and resampling work; no optimal Full baseline claim.</a:t>
             </a:r>
           </a:p>
         </p:txBody>
@@ -798,7 +798,7 @@
           <a:lstStyle xmlns:a="http://schemas.openxmlformats.org/drawingml/2006/main"/>
           <a:p xmlns:a="http://schemas.openxmlformats.org/drawingml/2006/main">
             <a:r>
-              <a:t>Source: results/fov_levels_xavier_full_20261027/README.md; overview.csv; summary.csv. Commit 0f1506c. Date 2026-10-27. Raw evidence: evidence.tar.gz. Original uint8-overflow PSNR preserved. Stereo delta is derived only if left eye remains unchanged and per-eye PSNR dB is averaged. Quality: 15W, 1068 frames. Timing: separate 30W four-frame CUDA staged GPU experiment; not joint measurements and no new quality equivalence verified. Timing is never divided by two. Latency adds a fixed 2 ms per-frame decode budget once, not measured decoding or end-to-end latency. Source: results/fov_decode_budget_2ms_20261029/summary.csv.</a:t>
+              <a:t>Source: results/fov_scales_full_20261029/scale_results.json and README.md. Same 30W CUDA C++ run: 1068 valid forward odd frames, 3 warmups, 5 timed repetitions per frame, one quality output per configuration/frame. Resident whole-pipeline GPU event timing without internal stage markers, fast resampling, dynamic clocks. This differs from the previous small-sample staged experiment. Original uint8-overflow PSNR preserved. Stereo delta is derived only if left eye remains unchanged and per-eye PSNR dB is averaged. Quality and timing use the same 30W 1068-frame experiment: 3 warmups and 5 timing samples per frame, one quality output per configuration/frame. Timing is never divided by two. Latency adds a fixed 2 ms per-frame decode budget once, not measured decoding or end-to-end latency. Source: results/fov_scales_full_20261029/scale_results.json.</a:t>
             </a:r>
           </a:p>
         </p:txBody>
@@ -915,7 +915,7 @@
           <p:cNvPr id="3" name="Title">
             <a:extLst xmlns:a="http://schemas.openxmlformats.org/drawingml/2006/main">
               <a:ext uri="{FF2B5EF4-FFF2-40B4-BE49-F238E27FC236}">
-                <a16:creationId xmlns:a16="http://schemas.microsoft.com/office/drawing/2014/main" id="{DF09009B-1A47-4272-A1AF-D68F93D8D408}"/>
+                <a16:creationId xmlns:a16="http://schemas.microsoft.com/office/drawing/2014/main" id="{4656B61E-6F12-41FF-82B5-C7DB83FF10A5}"/>
               </a:ext>
             </a:extLst>
           </p:cNvPr>
@@ -1144,7 +1144,7 @@
           <p:cNvPr id="2" name="Subtitle">
             <a:extLst xmlns:a="http://schemas.openxmlformats.org/drawingml/2006/main">
               <a:ext uri="{FF2B5EF4-FFF2-40B4-BE49-F238E27FC236}">
-                <a16:creationId xmlns:a16="http://schemas.microsoft.com/office/drawing/2014/main" id="{7651BADE-C19C-4607-825A-F3D5CEF0D18A}"/>
+                <a16:creationId xmlns:a16="http://schemas.microsoft.com/office/drawing/2014/main" id="{13E56DEB-E7B5-4B7D-9E1D-D9FC17A58799}"/>
               </a:ext>
             </a:extLst>
           </p:cNvPr>
@@ -1390,7 +1390,7 @@
           <p:cNvPr id="2" name="Section title">
             <a:extLst xmlns:a="http://schemas.openxmlformats.org/drawingml/2006/main">
               <a:ext uri="{FF2B5EF4-FFF2-40B4-BE49-F238E27FC236}">
-                <a16:creationId xmlns:a16="http://schemas.microsoft.com/office/drawing/2014/main" id="{74BD0149-78AC-4464-AF1D-C8930323768C}"/>
+                <a16:creationId xmlns:a16="http://schemas.microsoft.com/office/drawing/2014/main" id="{F4C64E40-54CD-4D7E-8241-8C74044B2782}"/>
               </a:ext>
             </a:extLst>
           </p:cNvPr>
@@ -1636,7 +1636,7 @@
           <p:cNvPr id="3" name="Title">
             <a:extLst xmlns:a="http://schemas.openxmlformats.org/drawingml/2006/main">
               <a:ext uri="{FF2B5EF4-FFF2-40B4-BE49-F238E27FC236}">
-                <a16:creationId xmlns:a16="http://schemas.microsoft.com/office/drawing/2014/main" id="{F92AA6D3-9972-4C18-AF53-12E189C62EFD}"/>
+                <a16:creationId xmlns:a16="http://schemas.microsoft.com/office/drawing/2014/main" id="{034EB934-449C-4E12-83DC-0592C95AAE32}"/>
               </a:ext>
             </a:extLst>
           </p:cNvPr>
@@ -1865,7 +1865,7 @@
           <p:cNvPr id="2" name="Body">
             <a:extLst xmlns:a="http://schemas.openxmlformats.org/drawingml/2006/main">
               <a:ext uri="{FF2B5EF4-FFF2-40B4-BE49-F238E27FC236}">
-                <a16:creationId xmlns:a16="http://schemas.microsoft.com/office/drawing/2014/main" id="{DAA1C96D-AD45-466C-8D64-86FA687108C9}"/>
+                <a16:creationId xmlns:a16="http://schemas.microsoft.com/office/drawing/2014/main" id="{F20A3173-92E1-4118-A89A-2ADC1C45EA02}"/>
               </a:ext>
             </a:extLst>
           </p:cNvPr>
@@ -2111,7 +2111,7 @@
           <p:cNvPr id="4" name="Title">
             <a:extLst xmlns:a="http://schemas.openxmlformats.org/drawingml/2006/main">
               <a:ext uri="{FF2B5EF4-FFF2-40B4-BE49-F238E27FC236}">
-                <a16:creationId xmlns:a16="http://schemas.microsoft.com/office/drawing/2014/main" id="{66EA457B-E80C-4F55-B0A0-EE9E4DBB12CE}"/>
+                <a16:creationId xmlns:a16="http://schemas.microsoft.com/office/drawing/2014/main" id="{899173B2-457A-4516-8CCA-782998DAD26B}"/>
               </a:ext>
             </a:extLst>
           </p:cNvPr>
@@ -2340,7 +2340,7 @@
           <p:cNvPr id="2" name="Left column">
             <a:extLst xmlns:a="http://schemas.openxmlformats.org/drawingml/2006/main">
               <a:ext uri="{FF2B5EF4-FFF2-40B4-BE49-F238E27FC236}">
-                <a16:creationId xmlns:a16="http://schemas.microsoft.com/office/drawing/2014/main" id="{BAD570F6-20C3-4265-9E50-E123F543FEE7}"/>
+                <a16:creationId xmlns:a16="http://schemas.microsoft.com/office/drawing/2014/main" id="{47041428-08D6-42BE-8E2C-A1D2C73A9632}"/>
               </a:ext>
             </a:extLst>
           </p:cNvPr>
@@ -2569,7 +2569,7 @@
           <p:cNvPr id="3" name="Right column">
             <a:extLst xmlns:a="http://schemas.openxmlformats.org/drawingml/2006/main">
               <a:ext uri="{FF2B5EF4-FFF2-40B4-BE49-F238E27FC236}">
-                <a16:creationId xmlns:a16="http://schemas.microsoft.com/office/drawing/2014/main" id="{B33ADD3E-A083-4557-B64C-334442F7BEF8}"/>
+                <a16:creationId xmlns:a16="http://schemas.microsoft.com/office/drawing/2014/main" id="{A361810E-580C-4F59-B861-A54ABA3F728B}"/>
               </a:ext>
             </a:extLst>
           </p:cNvPr>
@@ -2815,7 +2815,7 @@
           <p:cNvPr id="3" name="Title">
             <a:extLst xmlns:a="http://schemas.openxmlformats.org/drawingml/2006/main">
               <a:ext uri="{FF2B5EF4-FFF2-40B4-BE49-F238E27FC236}">
-                <a16:creationId xmlns:a16="http://schemas.microsoft.com/office/drawing/2014/main" id="{FCF3CE29-133F-465D-835B-AD89879F852D}"/>
+                <a16:creationId xmlns:a16="http://schemas.microsoft.com/office/drawing/2014/main" id="{C9EDE04E-21E5-4A13-A4F6-CE3C05FCA13E}"/>
               </a:ext>
             </a:extLst>
           </p:cNvPr>
@@ -3044,7 +3044,7 @@
           <p:cNvPr id="2" name="Left column">
             <a:extLst xmlns:a="http://schemas.openxmlformats.org/drawingml/2006/main">
               <a:ext uri="{FF2B5EF4-FFF2-40B4-BE49-F238E27FC236}">
-                <a16:creationId xmlns:a16="http://schemas.microsoft.com/office/drawing/2014/main" id="{427D6870-A1F9-4897-81D5-344E699834EB}"/>
+                <a16:creationId xmlns:a16="http://schemas.microsoft.com/office/drawing/2014/main" id="{CC7E3F32-BC89-457D-B886-659244175253}"/>
               </a:ext>
             </a:extLst>
           </p:cNvPr>
@@ -3311,12 +3311,12 @@
   </p:cSld>
   <p:clrMap bg1="lt1" tx1="dk1" bg2="lt2" tx2="dk2" accent1="accent1" accent2="accent2" accent3="accent3" accent4="accent4" accent5="accent5" accent6="accent6" hlink="hlink" folHlink="folHlink"/>
   <p:sldLayoutIdLst>
-    <p:sldLayoutId xmlns:r="http://schemas.openxmlformats.org/officeDocument/2006/relationships" id="2147483649" r:id="R56a1220e3f764421"/>
-    <p:sldLayoutId xmlns:r="http://schemas.openxmlformats.org/officeDocument/2006/relationships" id="2147483650" r:id="Rdb37c5a3c1f14175"/>
-    <p:sldLayoutId xmlns:r="http://schemas.openxmlformats.org/officeDocument/2006/relationships" id="2147483651" r:id="R0d71e67c7e2a4467"/>
-    <p:sldLayoutId xmlns:r="http://schemas.openxmlformats.org/officeDocument/2006/relationships" id="2147483652" r:id="Recb73b78be3d49e5"/>
-    <p:sldLayoutId xmlns:r="http://schemas.openxmlformats.org/officeDocument/2006/relationships" id="2147483653" r:id="Rdfa5bbec01004df8"/>
-    <p:sldLayoutId xmlns:r="http://schemas.openxmlformats.org/officeDocument/2006/relationships" id="2147483654" r:id="Rcd4490f23ec3440f"/>
+    <p:sldLayoutId xmlns:r="http://schemas.openxmlformats.org/officeDocument/2006/relationships" id="2147483649" r:id="R4e61cfc36b694702"/>
+    <p:sldLayoutId xmlns:r="http://schemas.openxmlformats.org/officeDocument/2006/relationships" id="2147483650" r:id="R82e3c27429bd4427"/>
+    <p:sldLayoutId xmlns:r="http://schemas.openxmlformats.org/officeDocument/2006/relationships" id="2147483651" r:id="Rd3884a5e79154551"/>
+    <p:sldLayoutId xmlns:r="http://schemas.openxmlformats.org/officeDocument/2006/relationships" id="2147483652" r:id="R38ccc95140b94a01"/>
+    <p:sldLayoutId xmlns:r="http://schemas.openxmlformats.org/officeDocument/2006/relationships" id="2147483653" r:id="R2a902b4618f94d45"/>
+    <p:sldLayoutId xmlns:r="http://schemas.openxmlformats.org/officeDocument/2006/relationships" id="2147483654" r:id="Re7d2499ac55a4c90"/>
   </p:sldLayoutIdLst>
   <p:txStyles>
     <p:titleStyle>
@@ -3866,53 +3866,47 @@
           <c:invertIfNegative val="0"/>
           <c:cat>
             <c:strRef>
-              <c:f>'Chart Data'!$A$2:$A$7</c:f>
+              <c:f>'Chart Data'!$A$2:$A$6</c:f>
               <c:strCache>
-                <c:ptCount val="6"/>
+                <c:ptCount val="5"/>
                 <c:pt idx="0">
                   <c:v>Full</c:v>
                 </c:pt>
                 <c:pt idx="1">
-                  <c:v>0.7%</c:v>
+                  <c:v>0.1×</c:v>
                 </c:pt>
                 <c:pt idx="2">
-                  <c:v>2.8%</c:v>
+                  <c:v>0.25×</c:v>
                 </c:pt>
                 <c:pt idx="3">
-                  <c:v>11.1%</c:v>
+                  <c:v>0.5×</c:v>
                 </c:pt>
                 <c:pt idx="4">
-                  <c:v>25.0%</c:v>
-                </c:pt>
-                <c:pt idx="5">
-                  <c:v>44.4%</c:v>
+                  <c:v>0.75×</c:v>
                 </c:pt>
               </c:strCache>
             </c:strRef>
           </c:cat>
           <c:val>
             <c:numRef>
-              <c:f>'Chart Data'!$B$2:$B$7</c:f>
+              <c:f>'Chart Data'!$B$2:$B$6</c:f>
               <c:numCache>
                 <c:formatCode>General</c:formatCode>
-                <c:ptCount val="6"/>
+                <c:ptCount val="5"/>
                 <c:pt idx="0">
-                  <c:v>7.996</c:v>
+                  <c:v>8.882</c:v>
                 </c:pt>
                 <c:pt idx="1">
-                  <c:v>3.248</c:v>
+                  <c:v>3.631</c:v>
                 </c:pt>
                 <c:pt idx="2">
-                  <c:v>3.462</c:v>
+                  <c:v>4.257</c:v>
                 </c:pt>
                 <c:pt idx="3">
-                  <c:v>4.318</c:v>
+                  <c:v>6.158</c:v>
                 </c:pt>
                 <c:pt idx="4">
-                  <c:v>5.637</c:v>
-                </c:pt>
-                <c:pt idx="5">
-                  <c:v>7.543</c:v>
+                  <c:v>9.039</c:v>
                 </c:pt>
               </c:numCache>
             </c:numRef>
@@ -3932,36 +3926,33 @@
           <c:invertIfNegative val="0"/>
           <c:cat>
             <c:strRef>
-              <c:f>'Chart Data'!$C$2:$C$7</c:f>
+              <c:f>'Chart Data'!$C$2:$C$6</c:f>
               <c:strCache>
-                <c:ptCount val="6"/>
+                <c:ptCount val="5"/>
                 <c:pt idx="0">
                   <c:v>Full</c:v>
                 </c:pt>
                 <c:pt idx="1">
-                  <c:v>0.7%</c:v>
+                  <c:v>0.1×</c:v>
                 </c:pt>
                 <c:pt idx="2">
-                  <c:v>2.8%</c:v>
+                  <c:v>0.25×</c:v>
                 </c:pt>
                 <c:pt idx="3">
-                  <c:v>11.1%</c:v>
+                  <c:v>0.5×</c:v>
                 </c:pt>
                 <c:pt idx="4">
-                  <c:v>25.0%</c:v>
-                </c:pt>
-                <c:pt idx="5">
-                  <c:v>44.4%</c:v>
+                  <c:v>0.75×</c:v>
                 </c:pt>
               </c:strCache>
             </c:strRef>
           </c:cat>
           <c:val>
             <c:numRef>
-              <c:f>'Chart Data'!$D$2:$D$7</c:f>
+              <c:f>'Chart Data'!$D$2:$D$6</c:f>
               <c:numCache>
                 <c:formatCode>General</c:formatCode>
-                <c:ptCount val="6"/>
+                <c:ptCount val="5"/>
                 <c:pt idx="0">
                   <c:v>2</c:v>
                 </c:pt>
@@ -3975,9 +3966,6 @@
                   <c:v>2</c:v>
                 </c:pt>
                 <c:pt idx="4">
-                  <c:v>2</c:v>
-                </c:pt>
-                <c:pt idx="5">
                   <c:v>2</c:v>
                 </c:pt>
               </c:numCache>
@@ -4188,7 +4176,7 @@
           <p:cNvPr id="5" name="">
             <a:extLst xmlns:a="http://schemas.openxmlformats.org/drawingml/2006/main">
               <a:ext uri="{FF2B5EF4-FFF2-40B4-BE49-F238E27FC236}">
-                <a16:creationId xmlns:a16="http://schemas.microsoft.com/office/drawing/2014/main" id="{8839185C-01FE-48E9-8E68-11D433472E8F}"/>
+                <a16:creationId xmlns:a16="http://schemas.microsoft.com/office/drawing/2014/main" id="{6231B366-2261-4CA3-A4F6-3C93D194AFB1}"/>
               </a:ext>
             </a:extLst>
           </p:cNvPr>
@@ -4246,7 +4234,7 @@
           <p:cNvPr id="2" name="">
             <a:extLst xmlns:a="http://schemas.openxmlformats.org/drawingml/2006/main">
               <a:ext uri="{FF2B5EF4-FFF2-40B4-BE49-F238E27FC236}">
-                <a16:creationId xmlns:a16="http://schemas.microsoft.com/office/drawing/2014/main" id="{BBCC9B25-B5F1-49D7-A870-7DE736A735F6}"/>
+                <a16:creationId xmlns:a16="http://schemas.microsoft.com/office/drawing/2014/main" id="{92B64A86-41B4-4018-A123-111331AE706C}"/>
               </a:ext>
             </a:extLst>
           </p:cNvPr>
@@ -4291,7 +4279,7 @@
           <p:cNvPr id="3" name="">
             <a:extLst xmlns:a="http://schemas.openxmlformats.org/drawingml/2006/main">
               <a:ext uri="{FF2B5EF4-FFF2-40B4-BE49-F238E27FC236}">
-                <a16:creationId xmlns:a16="http://schemas.microsoft.com/office/drawing/2014/main" id="{DD3926AD-B103-49A7-84B2-3971E0728361}"/>
+                <a16:creationId xmlns:a16="http://schemas.microsoft.com/office/drawing/2014/main" id="{16919AF6-57B0-43BB-9D3B-C7484D24BD81}"/>
               </a:ext>
             </a:extLst>
           </p:cNvPr>
@@ -4336,7 +4324,7 @@
           <p:cNvPr id="4" name="">
             <a:extLst xmlns:a="http://schemas.openxmlformats.org/drawingml/2006/main">
               <a:ext uri="{FF2B5EF4-FFF2-40B4-BE49-F238E27FC236}">
-                <a16:creationId xmlns:a16="http://schemas.microsoft.com/office/drawing/2014/main" id="{4BB6D7B6-E683-4CB7-8FF8-40832E568E3D}"/>
+                <a16:creationId xmlns:a16="http://schemas.microsoft.com/office/drawing/2014/main" id="{4CDA085C-C1D9-447B-B492-95E1492984B9}"/>
               </a:ext>
             </a:extLst>
           </p:cNvPr>
@@ -4379,7 +4367,7 @@
     </p:spTree>
     <p:extLst>
       <p:ext uri="{BB962C8B-B14F-4D97-AF65-F5344CB8AC3E}">
-        <p14:creationId xmlns:p14="http://schemas.microsoft.com/office/powerpoint/2010/main" val="1845059078"/>
+        <p14:creationId xmlns:p14="http://schemas.microsoft.com/office/powerpoint/2010/main" val="908829904"/>
       </p:ext>
     </p:extLst>
   </p:cSld>
@@ -4410,7 +4398,7 @@
           <p:cNvPr id="29" name="">
             <a:extLst xmlns:a="http://schemas.openxmlformats.org/drawingml/2006/main">
               <a:ext uri="{FF2B5EF4-FFF2-40B4-BE49-F238E27FC236}">
-                <a16:creationId xmlns:a16="http://schemas.microsoft.com/office/drawing/2014/main" id="{40889156-0D14-4233-A9F7-DD2D38BC91D0}"/>
+                <a16:creationId xmlns:a16="http://schemas.microsoft.com/office/drawing/2014/main" id="{43B02E36-C599-4A4F-816A-27653C3C660E}"/>
               </a:ext>
             </a:extLst>
           </p:cNvPr>
@@ -4455,7 +4443,7 @@
           <p:cNvPr id="2" name="">
             <a:extLst xmlns:a="http://schemas.openxmlformats.org/drawingml/2006/main">
               <a:ext uri="{FF2B5EF4-FFF2-40B4-BE49-F238E27FC236}">
-                <a16:creationId xmlns:a16="http://schemas.microsoft.com/office/drawing/2014/main" id="{7AFBA3E8-37EC-40F9-96B5-41503E79D16C}"/>
+                <a16:creationId xmlns:a16="http://schemas.microsoft.com/office/drawing/2014/main" id="{C2001038-B31A-4B98-ADC5-6C9BC270A238}"/>
               </a:ext>
             </a:extLst>
           </p:cNvPr>
@@ -4485,7 +4473,7 @@
           <p:cNvPr id="3" name="">
             <a:extLst xmlns:a="http://schemas.openxmlformats.org/drawingml/2006/main">
               <a:ext uri="{FF2B5EF4-FFF2-40B4-BE49-F238E27FC236}">
-                <a16:creationId xmlns:a16="http://schemas.microsoft.com/office/drawing/2014/main" id="{0D9D112C-CD28-4A5E-A1D4-485B66C00625}"/>
+                <a16:creationId xmlns:a16="http://schemas.microsoft.com/office/drawing/2014/main" id="{EA46BDE2-E62C-4BF8-A7B1-8FC97AE5C3C4}"/>
               </a:ext>
             </a:extLst>
           </p:cNvPr>
@@ -4530,7 +4518,7 @@
           <p:cNvPr id="4" name="">
             <a:extLst xmlns:a="http://schemas.openxmlformats.org/drawingml/2006/main">
               <a:ext uri="{FF2B5EF4-FFF2-40B4-BE49-F238E27FC236}">
-                <a16:creationId xmlns:a16="http://schemas.microsoft.com/office/drawing/2014/main" id="{C4C3B468-A151-46B7-999B-708ED9381852}"/>
+                <a16:creationId xmlns:a16="http://schemas.microsoft.com/office/drawing/2014/main" id="{B5B693C0-EAA2-4246-9DDB-633745478776}"/>
               </a:ext>
             </a:extLst>
           </p:cNvPr>
@@ -4575,7 +4563,7 @@
           <p:cNvPr id="5" name="">
             <a:extLst xmlns:a="http://schemas.openxmlformats.org/drawingml/2006/main">
               <a:ext uri="{FF2B5EF4-FFF2-40B4-BE49-F238E27FC236}">
-                <a16:creationId xmlns:a16="http://schemas.microsoft.com/office/drawing/2014/main" id="{D2E6AB31-0113-418D-A4C0-0200BD8A2383}"/>
+                <a16:creationId xmlns:a16="http://schemas.microsoft.com/office/drawing/2014/main" id="{1BBA93F7-732F-47CB-A93D-309FF8CBEBD5}"/>
               </a:ext>
             </a:extLst>
           </p:cNvPr>
@@ -4620,7 +4608,7 @@
           <p:cNvPr id="6" name="">
             <a:extLst xmlns:a="http://schemas.openxmlformats.org/drawingml/2006/main">
               <a:ext uri="{FF2B5EF4-FFF2-40B4-BE49-F238E27FC236}">
-                <a16:creationId xmlns:a16="http://schemas.microsoft.com/office/drawing/2014/main" id="{063279DA-3A5F-44C0-9820-B1F3CA01C409}"/>
+                <a16:creationId xmlns:a16="http://schemas.microsoft.com/office/drawing/2014/main" id="{DA5DA816-2638-41A5-8D72-908D6081B5D8}"/>
               </a:ext>
             </a:extLst>
           </p:cNvPr>
@@ -4652,7 +4640,7 @@
           <p:cNvPr id="7" name="">
             <a:extLst xmlns:a="http://schemas.openxmlformats.org/drawingml/2006/main">
               <a:ext uri="{FF2B5EF4-FFF2-40B4-BE49-F238E27FC236}">
-                <a16:creationId xmlns:a16="http://schemas.microsoft.com/office/drawing/2014/main" id="{342DD79D-C86F-4565-B208-60DB8B234A22}"/>
+                <a16:creationId xmlns:a16="http://schemas.microsoft.com/office/drawing/2014/main" id="{1E79AE19-21E0-4A6E-AA54-9E4433BA4605}"/>
               </a:ext>
             </a:extLst>
           </p:cNvPr>
@@ -4684,7 +4672,7 @@
           <p:cNvPr id="8" name="">
             <a:extLst xmlns:a="http://schemas.openxmlformats.org/drawingml/2006/main">
               <a:ext uri="{FF2B5EF4-FFF2-40B4-BE49-F238E27FC236}">
-                <a16:creationId xmlns:a16="http://schemas.microsoft.com/office/drawing/2014/main" id="{85F02417-D056-4586-BE2B-59F2B6817E75}"/>
+                <a16:creationId xmlns:a16="http://schemas.microsoft.com/office/drawing/2014/main" id="{17B9A4CC-7537-4BDF-81D2-CBCB56115368}"/>
               </a:ext>
             </a:extLst>
           </p:cNvPr>
@@ -4716,7 +4704,7 @@
           <p:cNvPr id="9" name="">
             <a:extLst xmlns:a="http://schemas.openxmlformats.org/drawingml/2006/main">
               <a:ext uri="{FF2B5EF4-FFF2-40B4-BE49-F238E27FC236}">
-                <a16:creationId xmlns:a16="http://schemas.microsoft.com/office/drawing/2014/main" id="{D3CF5134-F031-496E-B91C-2CCB310E687F}"/>
+                <a16:creationId xmlns:a16="http://schemas.microsoft.com/office/drawing/2014/main" id="{9E746EE6-9B3A-484A-8FC4-A8DDA27F37F1}"/>
               </a:ext>
             </a:extLst>
           </p:cNvPr>
@@ -4761,7 +4749,7 @@
           <p:cNvPr id="10" name="">
             <a:extLst xmlns:a="http://schemas.openxmlformats.org/drawingml/2006/main">
               <a:ext uri="{FF2B5EF4-FFF2-40B4-BE49-F238E27FC236}">
-                <a16:creationId xmlns:a16="http://schemas.microsoft.com/office/drawing/2014/main" id="{E144674D-F33D-4B17-9C2D-D1DC5A794903}"/>
+                <a16:creationId xmlns:a16="http://schemas.microsoft.com/office/drawing/2014/main" id="{DD55872A-81A7-4779-BF5D-67081D1DDB71}"/>
               </a:ext>
             </a:extLst>
           </p:cNvPr>
@@ -4791,7 +4779,7 @@
           <p:cNvPr id="11" name="">
             <a:extLst xmlns:a="http://schemas.openxmlformats.org/drawingml/2006/main">
               <a:ext uri="{FF2B5EF4-FFF2-40B4-BE49-F238E27FC236}">
-                <a16:creationId xmlns:a16="http://schemas.microsoft.com/office/drawing/2014/main" id="{5B1812AF-268D-4C19-A6C9-A77F1B1F669E}"/>
+                <a16:creationId xmlns:a16="http://schemas.microsoft.com/office/drawing/2014/main" id="{F4B628EA-B1A2-4027-B614-857317F382C4}"/>
               </a:ext>
             </a:extLst>
           </p:cNvPr>
@@ -4836,7 +4824,7 @@
           <p:cNvPr id="12" name="">
             <a:extLst xmlns:a="http://schemas.openxmlformats.org/drawingml/2006/main">
               <a:ext uri="{FF2B5EF4-FFF2-40B4-BE49-F238E27FC236}">
-                <a16:creationId xmlns:a16="http://schemas.microsoft.com/office/drawing/2014/main" id="{5150D6F9-C8EB-44A6-A6DD-51EA68FBE4CB}"/>
+                <a16:creationId xmlns:a16="http://schemas.microsoft.com/office/drawing/2014/main" id="{74EF305D-ADCE-48B5-9E8C-0C274BD437CB}"/>
               </a:ext>
             </a:extLst>
           </p:cNvPr>
@@ -4868,7 +4856,7 @@
           <p:cNvPr id="13" name="">
             <a:extLst xmlns:a="http://schemas.openxmlformats.org/drawingml/2006/main">
               <a:ext uri="{FF2B5EF4-FFF2-40B4-BE49-F238E27FC236}">
-                <a16:creationId xmlns:a16="http://schemas.microsoft.com/office/drawing/2014/main" id="{30449A39-7FDB-4443-A6E0-59FD68A8DA1F}"/>
+                <a16:creationId xmlns:a16="http://schemas.microsoft.com/office/drawing/2014/main" id="{3B04BFB6-0905-4D94-8724-91EDE16AE2F5}"/>
               </a:ext>
             </a:extLst>
           </p:cNvPr>
@@ -4900,7 +4888,7 @@
           <p:cNvPr id="14" name="">
             <a:extLst xmlns:a="http://schemas.openxmlformats.org/drawingml/2006/main">
               <a:ext uri="{FF2B5EF4-FFF2-40B4-BE49-F238E27FC236}">
-                <a16:creationId xmlns:a16="http://schemas.microsoft.com/office/drawing/2014/main" id="{44478E5B-4CF3-4388-B4C3-8467765F43AF}"/>
+                <a16:creationId xmlns:a16="http://schemas.microsoft.com/office/drawing/2014/main" id="{44AE3A98-44CF-4F77-BBEB-CC17A61D2AAA}"/>
               </a:ext>
             </a:extLst>
           </p:cNvPr>
@@ -4932,7 +4920,7 @@
           <p:cNvPr id="15" name="">
             <a:extLst xmlns:a="http://schemas.openxmlformats.org/drawingml/2006/main">
               <a:ext uri="{FF2B5EF4-FFF2-40B4-BE49-F238E27FC236}">
-                <a16:creationId xmlns:a16="http://schemas.microsoft.com/office/drawing/2014/main" id="{E759F7FA-B562-4D0C-9458-7912B2CB4A11}"/>
+                <a16:creationId xmlns:a16="http://schemas.microsoft.com/office/drawing/2014/main" id="{A9FB1F65-409A-44AC-86E1-8FB224D28D88}"/>
               </a:ext>
             </a:extLst>
           </p:cNvPr>
@@ -4977,7 +4965,7 @@
           <p:cNvPr id="16" name="">
             <a:extLst xmlns:a="http://schemas.openxmlformats.org/drawingml/2006/main">
               <a:ext uri="{FF2B5EF4-FFF2-40B4-BE49-F238E27FC236}">
-                <a16:creationId xmlns:a16="http://schemas.microsoft.com/office/drawing/2014/main" id="{7BBFB918-8402-4C93-B258-E3158B51EC69}"/>
+                <a16:creationId xmlns:a16="http://schemas.microsoft.com/office/drawing/2014/main" id="{51C6E4FB-48D6-47E3-9BFF-FB5AC3AA790C}"/>
               </a:ext>
             </a:extLst>
           </p:cNvPr>
@@ -5007,7 +4995,7 @@
           <p:cNvPr id="17" name="">
             <a:extLst xmlns:a="http://schemas.openxmlformats.org/drawingml/2006/main">
               <a:ext uri="{FF2B5EF4-FFF2-40B4-BE49-F238E27FC236}">
-                <a16:creationId xmlns:a16="http://schemas.microsoft.com/office/drawing/2014/main" id="{D71FD7E6-A4D8-4AEB-88B6-AE1F3F6F82DA}"/>
+                <a16:creationId xmlns:a16="http://schemas.microsoft.com/office/drawing/2014/main" id="{41D9E7B1-678B-4C9E-B5FB-E995D3A31D06}"/>
               </a:ext>
             </a:extLst>
           </p:cNvPr>
@@ -5052,7 +5040,7 @@
           <p:cNvPr id="18" name="">
             <a:extLst xmlns:a="http://schemas.openxmlformats.org/drawingml/2006/main">
               <a:ext uri="{FF2B5EF4-FFF2-40B4-BE49-F238E27FC236}">
-                <a16:creationId xmlns:a16="http://schemas.microsoft.com/office/drawing/2014/main" id="{67790418-9369-4D10-8321-415940EB71A0}"/>
+                <a16:creationId xmlns:a16="http://schemas.microsoft.com/office/drawing/2014/main" id="{AC7311ED-961E-4DE7-9D8E-49CCAEE48D10}"/>
               </a:ext>
             </a:extLst>
           </p:cNvPr>
@@ -5084,7 +5072,7 @@
           <p:cNvPr id="19" name="">
             <a:extLst xmlns:a="http://schemas.openxmlformats.org/drawingml/2006/main">
               <a:ext uri="{FF2B5EF4-FFF2-40B4-BE49-F238E27FC236}">
-                <a16:creationId xmlns:a16="http://schemas.microsoft.com/office/drawing/2014/main" id="{B5B3ACBC-3BC9-450F-8B81-52DD49042863}"/>
+                <a16:creationId xmlns:a16="http://schemas.microsoft.com/office/drawing/2014/main" id="{04859C60-0F59-487D-85B1-E3042BA26C64}"/>
               </a:ext>
             </a:extLst>
           </p:cNvPr>
@@ -5116,7 +5104,7 @@
           <p:cNvPr id="20" name="">
             <a:extLst xmlns:a="http://schemas.openxmlformats.org/drawingml/2006/main">
               <a:ext uri="{FF2B5EF4-FFF2-40B4-BE49-F238E27FC236}">
-                <a16:creationId xmlns:a16="http://schemas.microsoft.com/office/drawing/2014/main" id="{9973351F-262A-4398-8909-31892CCA2E85}"/>
+                <a16:creationId xmlns:a16="http://schemas.microsoft.com/office/drawing/2014/main" id="{05CB488B-C44B-49E9-8041-0883188557CE}"/>
               </a:ext>
             </a:extLst>
           </p:cNvPr>
@@ -5148,7 +5136,7 @@
           <p:cNvPr id="21" name="">
             <a:extLst xmlns:a="http://schemas.openxmlformats.org/drawingml/2006/main">
               <a:ext uri="{FF2B5EF4-FFF2-40B4-BE49-F238E27FC236}">
-                <a16:creationId xmlns:a16="http://schemas.microsoft.com/office/drawing/2014/main" id="{2266F7D3-B078-444D-BA1C-0C9B19A04BAD}"/>
+                <a16:creationId xmlns:a16="http://schemas.microsoft.com/office/drawing/2014/main" id="{837D9F8B-4CD0-4CFA-AFB0-23DD83A296EF}"/>
               </a:ext>
             </a:extLst>
           </p:cNvPr>
@@ -5193,7 +5181,7 @@
           <p:cNvPr id="22" name="">
             <a:extLst xmlns:a="http://schemas.openxmlformats.org/drawingml/2006/main">
               <a:ext uri="{FF2B5EF4-FFF2-40B4-BE49-F238E27FC236}">
-                <a16:creationId xmlns:a16="http://schemas.microsoft.com/office/drawing/2014/main" id="{D05B0D14-396F-4EA8-AEF2-F6E3986C7836}"/>
+                <a16:creationId xmlns:a16="http://schemas.microsoft.com/office/drawing/2014/main" id="{996F28F0-E659-4D9A-87F4-60CC48C05C27}"/>
               </a:ext>
             </a:extLst>
           </p:cNvPr>
@@ -5223,7 +5211,7 @@
           <p:cNvPr id="23" name="">
             <a:extLst xmlns:a="http://schemas.openxmlformats.org/drawingml/2006/main">
               <a:ext uri="{FF2B5EF4-FFF2-40B4-BE49-F238E27FC236}">
-                <a16:creationId xmlns:a16="http://schemas.microsoft.com/office/drawing/2014/main" id="{4D389395-F859-43DE-9FA6-1C5AA1B008A3}"/>
+                <a16:creationId xmlns:a16="http://schemas.microsoft.com/office/drawing/2014/main" id="{6B84ED23-FEDC-423A-906C-CFB7A0B54CD8}"/>
               </a:ext>
             </a:extLst>
           </p:cNvPr>
@@ -5253,7 +5241,7 @@
           <p:cNvPr id="24" name="">
             <a:extLst xmlns:a="http://schemas.openxmlformats.org/drawingml/2006/main">
               <a:ext uri="{FF2B5EF4-FFF2-40B4-BE49-F238E27FC236}">
-                <a16:creationId xmlns:a16="http://schemas.microsoft.com/office/drawing/2014/main" id="{EA5CD671-9298-47D5-AB30-EA232745E808}"/>
+                <a16:creationId xmlns:a16="http://schemas.microsoft.com/office/drawing/2014/main" id="{EBF8C550-3C16-4011-94F6-8846C615B67A}"/>
               </a:ext>
             </a:extLst>
           </p:cNvPr>
@@ -5298,7 +5286,7 @@
           <p:cNvPr id="25" name="">
             <a:extLst xmlns:a="http://schemas.openxmlformats.org/drawingml/2006/main">
               <a:ext uri="{FF2B5EF4-FFF2-40B4-BE49-F238E27FC236}">
-                <a16:creationId xmlns:a16="http://schemas.microsoft.com/office/drawing/2014/main" id="{46C4900D-D60D-4953-9336-51E315F3F84B}"/>
+                <a16:creationId xmlns:a16="http://schemas.microsoft.com/office/drawing/2014/main" id="{0A39B664-F2AE-4C2A-A109-CD81D22F9CD7}"/>
               </a:ext>
             </a:extLst>
           </p:cNvPr>
@@ -5343,7 +5331,7 @@
           <p:cNvPr id="26" name="">
             <a:extLst xmlns:a="http://schemas.openxmlformats.org/drawingml/2006/main">
               <a:ext uri="{FF2B5EF4-FFF2-40B4-BE49-F238E27FC236}">
-                <a16:creationId xmlns:a16="http://schemas.microsoft.com/office/drawing/2014/main" id="{6356077A-D621-4F95-9B34-56913F862669}"/>
+                <a16:creationId xmlns:a16="http://schemas.microsoft.com/office/drawing/2014/main" id="{E45C719B-4085-498E-B153-C067208A04F2}"/>
               </a:ext>
             </a:extLst>
           </p:cNvPr>
@@ -5388,7 +5376,7 @@
           <p:cNvPr id="27" name="">
             <a:extLst xmlns:a="http://schemas.openxmlformats.org/drawingml/2006/main">
               <a:ext uri="{FF2B5EF4-FFF2-40B4-BE49-F238E27FC236}">
-                <a16:creationId xmlns:a16="http://schemas.microsoft.com/office/drawing/2014/main" id="{2D68AF76-8A31-4F7C-ACC4-82D4B8D31A4A}"/>
+                <a16:creationId xmlns:a16="http://schemas.microsoft.com/office/drawing/2014/main" id="{972677C9-24FC-4F68-AE9D-E745C0F4CF3D}"/>
               </a:ext>
             </a:extLst>
           </p:cNvPr>
@@ -5433,7 +5421,7 @@
           <p:cNvPr id="28" name="">
             <a:extLst xmlns:a="http://schemas.openxmlformats.org/drawingml/2006/main">
               <a:ext uri="{FF2B5EF4-FFF2-40B4-BE49-F238E27FC236}">
-                <a16:creationId xmlns:a16="http://schemas.microsoft.com/office/drawing/2014/main" id="{60C9C0CE-3DFA-46E8-B4EF-F2636F72A8F4}"/>
+                <a16:creationId xmlns:a16="http://schemas.microsoft.com/office/drawing/2014/main" id="{99010137-F9FF-4BF4-B84F-81B5BF9E7160}"/>
               </a:ext>
             </a:extLst>
           </p:cNvPr>
@@ -5476,7 +5464,7 @@
     </p:spTree>
     <p:extLst>
       <p:ext uri="{BB962C8B-B14F-4D97-AF65-F5344CB8AC3E}">
-        <p14:creationId xmlns:p14="http://schemas.microsoft.com/office/powerpoint/2010/main" val="1409362772"/>
+        <p14:creationId xmlns:p14="http://schemas.microsoft.com/office/powerpoint/2010/main" val="642412264"/>
       </p:ext>
     </p:extLst>
   </p:cSld>
@@ -5507,7 +5495,7 @@
           <p:cNvPr id="15" name="">
             <a:extLst xmlns:a="http://schemas.openxmlformats.org/drawingml/2006/main">
               <a:ext uri="{FF2B5EF4-FFF2-40B4-BE49-F238E27FC236}">
-                <a16:creationId xmlns:a16="http://schemas.microsoft.com/office/drawing/2014/main" id="{6CA318F4-ADA3-4F82-A7E5-1F9C5BF427A3}"/>
+                <a16:creationId xmlns:a16="http://schemas.microsoft.com/office/drawing/2014/main" id="{765A061E-2B64-45FD-A7D0-80D5A98A62C2}"/>
               </a:ext>
             </a:extLst>
           </p:cNvPr>
@@ -5552,7 +5540,7 @@
           <p:cNvPr id="2" name="">
             <a:extLst xmlns:a="http://schemas.openxmlformats.org/drawingml/2006/main">
               <a:ext uri="{FF2B5EF4-FFF2-40B4-BE49-F238E27FC236}">
-                <a16:creationId xmlns:a16="http://schemas.microsoft.com/office/drawing/2014/main" id="{1551F25F-479F-4A1A-9DDD-8CE04CE68DBE}"/>
+                <a16:creationId xmlns:a16="http://schemas.microsoft.com/office/drawing/2014/main" id="{4C224ABD-D0AF-4831-B542-C2A23BDC3593}"/>
               </a:ext>
             </a:extLst>
           </p:cNvPr>
@@ -5582,7 +5570,7 @@
           <p:cNvPr id="3" name="">
             <a:extLst xmlns:a="http://schemas.openxmlformats.org/drawingml/2006/main">
               <a:ext uri="{FF2B5EF4-FFF2-40B4-BE49-F238E27FC236}">
-                <a16:creationId xmlns:a16="http://schemas.microsoft.com/office/drawing/2014/main" id="{9A8182CE-5FA7-4CF6-B813-3AD3EAFBFAFF}"/>
+                <a16:creationId xmlns:a16="http://schemas.microsoft.com/office/drawing/2014/main" id="{47AF6682-BAE4-4394-8690-6E79D912B81B}"/>
               </a:ext>
             </a:extLst>
           </p:cNvPr>
@@ -5627,7 +5615,7 @@
           <p:cNvPr id="4" name="">
             <a:extLst xmlns:a="http://schemas.openxmlformats.org/drawingml/2006/main">
               <a:ext uri="{FF2B5EF4-FFF2-40B4-BE49-F238E27FC236}">
-                <a16:creationId xmlns:a16="http://schemas.microsoft.com/office/drawing/2014/main" id="{06158392-017D-4F5B-95C7-4C215A1149AF}"/>
+                <a16:creationId xmlns:a16="http://schemas.microsoft.com/office/drawing/2014/main" id="{A2F14EDE-D2BC-4D69-986C-302916D13825}"/>
               </a:ext>
             </a:extLst>
           </p:cNvPr>
@@ -5672,7 +5660,7 @@
           <p:cNvPr id="5" name="">
             <a:extLst xmlns:a="http://schemas.openxmlformats.org/drawingml/2006/main">
               <a:ext uri="{FF2B5EF4-FFF2-40B4-BE49-F238E27FC236}">
-                <a16:creationId xmlns:a16="http://schemas.microsoft.com/office/drawing/2014/main" id="{C50EC432-D71D-464D-B3C0-7AF4DEF4EB04}"/>
+                <a16:creationId xmlns:a16="http://schemas.microsoft.com/office/drawing/2014/main" id="{F679DFA3-755C-41E1-AAC9-56B3C0281CD7}"/>
               </a:ext>
             </a:extLst>
           </p:cNvPr>
@@ -5704,7 +5692,7 @@
           <p:cNvPr id="6" name="">
             <a:extLst xmlns:a="http://schemas.openxmlformats.org/drawingml/2006/main">
               <a:ext uri="{FF2B5EF4-FFF2-40B4-BE49-F238E27FC236}">
-                <a16:creationId xmlns:a16="http://schemas.microsoft.com/office/drawing/2014/main" id="{CC2CD2D0-A0FC-4CE1-8556-FBC272F32C57}"/>
+                <a16:creationId xmlns:a16="http://schemas.microsoft.com/office/drawing/2014/main" id="{E06DC108-746A-4105-BCAA-8B013835961A}"/>
               </a:ext>
             </a:extLst>
           </p:cNvPr>
@@ -5736,7 +5724,7 @@
           <p:cNvPr id="7" name="">
             <a:extLst xmlns:a="http://schemas.openxmlformats.org/drawingml/2006/main">
               <a:ext uri="{FF2B5EF4-FFF2-40B4-BE49-F238E27FC236}">
-                <a16:creationId xmlns:a16="http://schemas.microsoft.com/office/drawing/2014/main" id="{0923FC36-C0DF-47EB-BBBF-6C2F22B53F79}"/>
+                <a16:creationId xmlns:a16="http://schemas.microsoft.com/office/drawing/2014/main" id="{B97F84B9-7426-4B5B-A8AE-33281E7BE891}"/>
               </a:ext>
             </a:extLst>
           </p:cNvPr>
@@ -5768,7 +5756,7 @@
           <p:cNvPr id="8" name="">
             <a:extLst xmlns:a="http://schemas.openxmlformats.org/drawingml/2006/main">
               <a:ext uri="{FF2B5EF4-FFF2-40B4-BE49-F238E27FC236}">
-                <a16:creationId xmlns:a16="http://schemas.microsoft.com/office/drawing/2014/main" id="{E9406F8D-7381-4317-9570-3F24E8595381}"/>
+                <a16:creationId xmlns:a16="http://schemas.microsoft.com/office/drawing/2014/main" id="{EE37B65E-7CED-47B6-9D4D-5E25CAA8C0A3}"/>
               </a:ext>
             </a:extLst>
           </p:cNvPr>
@@ -5813,7 +5801,7 @@
           <p:cNvPr id="9" name="">
             <a:extLst xmlns:a="http://schemas.openxmlformats.org/drawingml/2006/main">
               <a:ext uri="{FF2B5EF4-FFF2-40B4-BE49-F238E27FC236}">
-                <a16:creationId xmlns:a16="http://schemas.microsoft.com/office/drawing/2014/main" id="{F324F411-56E3-49DE-8ACF-5848DCBCB53E}"/>
+                <a16:creationId xmlns:a16="http://schemas.microsoft.com/office/drawing/2014/main" id="{6FCC6E87-8B8C-4D15-AEC0-2E55DB751426}"/>
               </a:ext>
             </a:extLst>
           </p:cNvPr>
@@ -5858,7 +5846,7 @@
           <p:cNvPr id="10" name="">
             <a:extLst xmlns:a="http://schemas.openxmlformats.org/drawingml/2006/main">
               <a:ext uri="{FF2B5EF4-FFF2-40B4-BE49-F238E27FC236}">
-                <a16:creationId xmlns:a16="http://schemas.microsoft.com/office/drawing/2014/main" id="{14959647-6806-4C2B-BEDD-9528253068B8}"/>
+                <a16:creationId xmlns:a16="http://schemas.microsoft.com/office/drawing/2014/main" id="{3122CAE1-D0BC-4019-8344-8E8CFC147D33}"/>
               </a:ext>
             </a:extLst>
           </p:cNvPr>
@@ -5890,7 +5878,7 @@
           <p:cNvPr id="11" name="">
             <a:extLst xmlns:a="http://schemas.openxmlformats.org/drawingml/2006/main">
               <a:ext uri="{FF2B5EF4-FFF2-40B4-BE49-F238E27FC236}">
-                <a16:creationId xmlns:a16="http://schemas.microsoft.com/office/drawing/2014/main" id="{671CCFD7-C78B-44DB-8759-DDB7CFEB13B7}"/>
+                <a16:creationId xmlns:a16="http://schemas.microsoft.com/office/drawing/2014/main" id="{90E444CD-C497-4B92-95A6-9F51514CB853}"/>
               </a:ext>
             </a:extLst>
           </p:cNvPr>
@@ -5922,7 +5910,7 @@
           <p:cNvPr id="12" name="">
             <a:extLst xmlns:a="http://schemas.openxmlformats.org/drawingml/2006/main">
               <a:ext uri="{FF2B5EF4-FFF2-40B4-BE49-F238E27FC236}">
-                <a16:creationId xmlns:a16="http://schemas.microsoft.com/office/drawing/2014/main" id="{EC192CC3-3BA5-4E45-AA27-9176397A5252}"/>
+                <a16:creationId xmlns:a16="http://schemas.microsoft.com/office/drawing/2014/main" id="{3F30FBFC-02D3-4EC0-AC28-0F3A650241DF}"/>
               </a:ext>
             </a:extLst>
           </p:cNvPr>
@@ -5954,7 +5942,7 @@
           <p:cNvPr id="13" name="">
             <a:extLst xmlns:a="http://schemas.openxmlformats.org/drawingml/2006/main">
               <a:ext uri="{FF2B5EF4-FFF2-40B4-BE49-F238E27FC236}">
-                <a16:creationId xmlns:a16="http://schemas.microsoft.com/office/drawing/2014/main" id="{45399602-0D6B-4F66-B196-C16617BBD894}"/>
+                <a16:creationId xmlns:a16="http://schemas.microsoft.com/office/drawing/2014/main" id="{96F9E5DA-1B5B-4167-BC57-4D5EF226760A}"/>
               </a:ext>
             </a:extLst>
           </p:cNvPr>
@@ -5999,7 +5987,7 @@
           <p:cNvPr id="14" name="">
             <a:extLst xmlns:a="http://schemas.openxmlformats.org/drawingml/2006/main">
               <a:ext uri="{FF2B5EF4-FFF2-40B4-BE49-F238E27FC236}">
-                <a16:creationId xmlns:a16="http://schemas.microsoft.com/office/drawing/2014/main" id="{FAF618C8-29F6-4152-A5FB-4237E39A7076}"/>
+                <a16:creationId xmlns:a16="http://schemas.microsoft.com/office/drawing/2014/main" id="{C09C3F46-2449-405D-BB5A-6094E3FEBF31}"/>
               </a:ext>
             </a:extLst>
           </p:cNvPr>
@@ -6042,7 +6030,7 @@
     </p:spTree>
     <p:extLst>
       <p:ext uri="{BB962C8B-B14F-4D97-AF65-F5344CB8AC3E}">
-        <p14:creationId xmlns:p14="http://schemas.microsoft.com/office/powerpoint/2010/main" val="520135501"/>
+        <p14:creationId xmlns:p14="http://schemas.microsoft.com/office/powerpoint/2010/main" val="2147422174"/>
       </p:ext>
     </p:extLst>
   </p:cSld>
@@ -6073,7 +6061,7 @@
           <p:cNvPr id="20" name="">
             <a:extLst xmlns:a="http://schemas.openxmlformats.org/drawingml/2006/main">
               <a:ext uri="{FF2B5EF4-FFF2-40B4-BE49-F238E27FC236}">
-                <a16:creationId xmlns:a16="http://schemas.microsoft.com/office/drawing/2014/main" id="{B590E7BC-F5E2-414A-AC52-863D442E1D29}"/>
+                <a16:creationId xmlns:a16="http://schemas.microsoft.com/office/drawing/2014/main" id="{410B444B-C51E-4889-88B1-CE3E85C447D1}"/>
               </a:ext>
             </a:extLst>
           </p:cNvPr>
@@ -6118,7 +6106,7 @@
           <p:cNvPr id="2" name="">
             <a:extLst xmlns:a="http://schemas.openxmlformats.org/drawingml/2006/main">
               <a:ext uri="{FF2B5EF4-FFF2-40B4-BE49-F238E27FC236}">
-                <a16:creationId xmlns:a16="http://schemas.microsoft.com/office/drawing/2014/main" id="{09311848-0E3F-4D59-8A38-88896869BAFF}"/>
+                <a16:creationId xmlns:a16="http://schemas.microsoft.com/office/drawing/2014/main" id="{8BDE328E-5218-49CB-98CC-EE33768887AD}"/>
               </a:ext>
             </a:extLst>
           </p:cNvPr>
@@ -6148,7 +6136,7 @@
           <p:cNvPr id="3" name="">
             <a:extLst xmlns:a="http://schemas.openxmlformats.org/drawingml/2006/main">
               <a:ext uri="{FF2B5EF4-FFF2-40B4-BE49-F238E27FC236}">
-                <a16:creationId xmlns:a16="http://schemas.microsoft.com/office/drawing/2014/main" id="{DB7B14C4-A3A3-437F-829F-C3366F696123}"/>
+                <a16:creationId xmlns:a16="http://schemas.microsoft.com/office/drawing/2014/main" id="{8E2AAEEF-B888-4FE0-B4DE-F3CF99C15DA1}"/>
               </a:ext>
             </a:extLst>
           </p:cNvPr>
@@ -6193,7 +6181,7 @@
           <p:cNvPr id="4" name="">
             <a:extLst xmlns:a="http://schemas.openxmlformats.org/drawingml/2006/main">
               <a:ext uri="{FF2B5EF4-FFF2-40B4-BE49-F238E27FC236}">
-                <a16:creationId xmlns:a16="http://schemas.microsoft.com/office/drawing/2014/main" id="{32CA59B4-FA89-44A1-99D7-724FB0F08AB5}"/>
+                <a16:creationId xmlns:a16="http://schemas.microsoft.com/office/drawing/2014/main" id="{3693E3B2-DF85-4C0E-AA5D-9E0C3D4CCC4D}"/>
               </a:ext>
             </a:extLst>
           </p:cNvPr>
@@ -6238,7 +6226,7 @@
           <p:cNvPr id="5" name="">
             <a:extLst xmlns:a="http://schemas.openxmlformats.org/drawingml/2006/main">
               <a:ext uri="{FF2B5EF4-FFF2-40B4-BE49-F238E27FC236}">
-                <a16:creationId xmlns:a16="http://schemas.microsoft.com/office/drawing/2014/main" id="{D4B6C474-24DB-45FD-B544-7E797567C1CD}"/>
+                <a16:creationId xmlns:a16="http://schemas.microsoft.com/office/drawing/2014/main" id="{17BC88C0-3C43-4EF0-8760-B951C1C232A4}"/>
               </a:ext>
             </a:extLst>
           </p:cNvPr>
@@ -6270,7 +6258,7 @@
           <p:cNvPr id="6" name="">
             <a:extLst xmlns:a="http://schemas.openxmlformats.org/drawingml/2006/main">
               <a:ext uri="{FF2B5EF4-FFF2-40B4-BE49-F238E27FC236}">
-                <a16:creationId xmlns:a16="http://schemas.microsoft.com/office/drawing/2014/main" id="{70E5C0ED-197E-49DC-9B2E-82474062517B}"/>
+                <a16:creationId xmlns:a16="http://schemas.microsoft.com/office/drawing/2014/main" id="{9E320794-C25A-4839-8860-EA2B91A2CDAD}"/>
               </a:ext>
             </a:extLst>
           </p:cNvPr>
@@ -6341,7 +6329,7 @@
           <p:cNvPr id="7" name="">
             <a:extLst xmlns:a="http://schemas.openxmlformats.org/drawingml/2006/main">
               <a:ext uri="{FF2B5EF4-FFF2-40B4-BE49-F238E27FC236}">
-                <a16:creationId xmlns:a16="http://schemas.microsoft.com/office/drawing/2014/main" id="{8558AE41-8932-445C-90D5-E48CECC27755}"/>
+                <a16:creationId xmlns:a16="http://schemas.microsoft.com/office/drawing/2014/main" id="{DCC9342B-A440-49DC-A3B7-9F514187F553}"/>
               </a:ext>
             </a:extLst>
           </p:cNvPr>
@@ -6386,7 +6374,7 @@
           <p:cNvPr id="8" name="">
             <a:extLst xmlns:a="http://schemas.openxmlformats.org/drawingml/2006/main">
               <a:ext uri="{FF2B5EF4-FFF2-40B4-BE49-F238E27FC236}">
-                <a16:creationId xmlns:a16="http://schemas.microsoft.com/office/drawing/2014/main" id="{03650FF8-98B7-4E6E-9DE9-A9F2A655B22B}"/>
+                <a16:creationId xmlns:a16="http://schemas.microsoft.com/office/drawing/2014/main" id="{0A28EABF-FB5A-4E81-9942-5539C8CFD18D}"/>
               </a:ext>
             </a:extLst>
           </p:cNvPr>
@@ -6418,7 +6406,7 @@
           <p:cNvPr id="9" name="">
             <a:extLst xmlns:a="http://schemas.openxmlformats.org/drawingml/2006/main">
               <a:ext uri="{FF2B5EF4-FFF2-40B4-BE49-F238E27FC236}">
-                <a16:creationId xmlns:a16="http://schemas.microsoft.com/office/drawing/2014/main" id="{338A9744-7733-4338-B2EA-754BBD0111EC}"/>
+                <a16:creationId xmlns:a16="http://schemas.microsoft.com/office/drawing/2014/main" id="{632C8C73-9262-4AF5-9396-22D5E0F0C946}"/>
               </a:ext>
             </a:extLst>
           </p:cNvPr>
@@ -6450,7 +6438,7 @@
           <p:cNvPr id="10" name="">
             <a:extLst xmlns:a="http://schemas.openxmlformats.org/drawingml/2006/main">
               <a:ext uri="{FF2B5EF4-FFF2-40B4-BE49-F238E27FC236}">
-                <a16:creationId xmlns:a16="http://schemas.microsoft.com/office/drawing/2014/main" id="{64E1D8D4-54D2-4F20-B837-C90A7FD111D7}"/>
+                <a16:creationId xmlns:a16="http://schemas.microsoft.com/office/drawing/2014/main" id="{9E30B800-F6DC-4818-8318-6382A45402B7}"/>
               </a:ext>
             </a:extLst>
           </p:cNvPr>
@@ -6495,7 +6483,7 @@
           <p:cNvPr id="11" name="">
             <a:extLst xmlns:a="http://schemas.openxmlformats.org/drawingml/2006/main">
               <a:ext uri="{FF2B5EF4-FFF2-40B4-BE49-F238E27FC236}">
-                <a16:creationId xmlns:a16="http://schemas.microsoft.com/office/drawing/2014/main" id="{6E0CA3C0-C7FE-4D04-A534-0407DD321B55}"/>
+                <a16:creationId xmlns:a16="http://schemas.microsoft.com/office/drawing/2014/main" id="{3189AC21-4931-4CED-992A-4605D2AE02FE}"/>
               </a:ext>
             </a:extLst>
           </p:cNvPr>
@@ -6540,7 +6528,7 @@
           <p:cNvPr id="12" name="">
             <a:extLst xmlns:a="http://schemas.openxmlformats.org/drawingml/2006/main">
               <a:ext uri="{FF2B5EF4-FFF2-40B4-BE49-F238E27FC236}">
-                <a16:creationId xmlns:a16="http://schemas.microsoft.com/office/drawing/2014/main" id="{ADAE545E-C88B-45D1-BE3D-904282A5F47D}"/>
+                <a16:creationId xmlns:a16="http://schemas.microsoft.com/office/drawing/2014/main" id="{052E2D93-2AE9-45E0-AECF-896A487E2706}"/>
               </a:ext>
             </a:extLst>
           </p:cNvPr>
@@ -6585,7 +6573,7 @@
           <p:cNvPr id="13" name="">
             <a:extLst xmlns:a="http://schemas.openxmlformats.org/drawingml/2006/main">
               <a:ext uri="{FF2B5EF4-FFF2-40B4-BE49-F238E27FC236}">
-                <a16:creationId xmlns:a16="http://schemas.microsoft.com/office/drawing/2014/main" id="{340BC6D5-EF0D-49EC-8B90-982C96F689DB}"/>
+                <a16:creationId xmlns:a16="http://schemas.microsoft.com/office/drawing/2014/main" id="{5A659BDD-41E6-4FB3-B2EF-B9C07A4A353B}"/>
               </a:ext>
             </a:extLst>
           </p:cNvPr>
@@ -6617,7 +6605,7 @@
           <p:cNvPr id="14" name="">
             <a:extLst xmlns:a="http://schemas.openxmlformats.org/drawingml/2006/main">
               <a:ext uri="{FF2B5EF4-FFF2-40B4-BE49-F238E27FC236}">
-                <a16:creationId xmlns:a16="http://schemas.microsoft.com/office/drawing/2014/main" id="{C27E8751-4EDD-4021-9553-55DC26EB54B3}"/>
+                <a16:creationId xmlns:a16="http://schemas.microsoft.com/office/drawing/2014/main" id="{B566DD6A-AF8E-4F0E-89DB-0C0E92499D98}"/>
               </a:ext>
             </a:extLst>
           </p:cNvPr>
@@ -6649,7 +6637,7 @@
           <p:cNvPr id="15" name="">
             <a:extLst xmlns:a="http://schemas.openxmlformats.org/drawingml/2006/main">
               <a:ext uri="{FF2B5EF4-FFF2-40B4-BE49-F238E27FC236}">
-                <a16:creationId xmlns:a16="http://schemas.microsoft.com/office/drawing/2014/main" id="{D9E2F185-C79A-4AE2-9115-82DDDB9F2002}"/>
+                <a16:creationId xmlns:a16="http://schemas.microsoft.com/office/drawing/2014/main" id="{37A1E445-AC6A-40CA-A356-8A6F1E0C0ABE}"/>
               </a:ext>
             </a:extLst>
           </p:cNvPr>
@@ -6681,7 +6669,7 @@
           <p:cNvPr id="16" name="">
             <a:extLst xmlns:a="http://schemas.openxmlformats.org/drawingml/2006/main">
               <a:ext uri="{FF2B5EF4-FFF2-40B4-BE49-F238E27FC236}">
-                <a16:creationId xmlns:a16="http://schemas.microsoft.com/office/drawing/2014/main" id="{AA0E4506-D1E4-4CAE-B56E-2526D1A7DC15}"/>
+                <a16:creationId xmlns:a16="http://schemas.microsoft.com/office/drawing/2014/main" id="{EF3862AD-C493-46AD-84EA-AA572B2043FB}"/>
               </a:ext>
             </a:extLst>
           </p:cNvPr>
@@ -6726,7 +6714,7 @@
           <p:cNvPr id="17" name="">
             <a:extLst xmlns:a="http://schemas.openxmlformats.org/drawingml/2006/main">
               <a:ext uri="{FF2B5EF4-FFF2-40B4-BE49-F238E27FC236}">
-                <a16:creationId xmlns:a16="http://schemas.microsoft.com/office/drawing/2014/main" id="{934B62B1-220F-4C6D-8CAB-24CD4B07F020}"/>
+                <a16:creationId xmlns:a16="http://schemas.microsoft.com/office/drawing/2014/main" id="{93E1F6B8-FB5D-4836-BF0E-B89741493568}"/>
               </a:ext>
             </a:extLst>
           </p:cNvPr>
@@ -6771,7 +6759,7 @@
           <p:cNvPr id="18" name="">
             <a:extLst xmlns:a="http://schemas.openxmlformats.org/drawingml/2006/main">
               <a:ext uri="{FF2B5EF4-FFF2-40B4-BE49-F238E27FC236}">
-                <a16:creationId xmlns:a16="http://schemas.microsoft.com/office/drawing/2014/main" id="{D8A7DF32-B0A9-4602-B8A4-002DCC5A153C}"/>
+                <a16:creationId xmlns:a16="http://schemas.microsoft.com/office/drawing/2014/main" id="{74FB4767-1894-406A-968F-7E13A952E3E5}"/>
               </a:ext>
             </a:extLst>
           </p:cNvPr>
@@ -6806,7 +6794,7 @@
                 <a:ea typeface="Arial"/>
                 <a:cs typeface="Arial"/>
               </a:rPr>
-              <a:t>Full-resolution region width: 0.08×, 0.17×, 0.33×, 0.50×, 0.67×</a:t>
+              <a:t>Full-resolution region width: 0.1×, 0.25×, 0.5×, 0.75×</a:t>
             </a:r>
           </a:p>
         </p:txBody>
@@ -6816,7 +6804,7 @@
           <p:cNvPr id="19" name="">
             <a:extLst xmlns:a="http://schemas.openxmlformats.org/drawingml/2006/main">
               <a:ext uri="{FF2B5EF4-FFF2-40B4-BE49-F238E27FC236}">
-                <a16:creationId xmlns:a16="http://schemas.microsoft.com/office/drawing/2014/main" id="{EE9D7666-F742-47FC-9761-89CBA26D813F}"/>
+                <a16:creationId xmlns:a16="http://schemas.microsoft.com/office/drawing/2014/main" id="{078715CB-92A6-47B6-AD82-6F29E6E4E0DF}"/>
               </a:ext>
             </a:extLst>
           </p:cNvPr>
@@ -6859,7 +6847,7 @@
     </p:spTree>
     <p:extLst>
       <p:ext uri="{BB962C8B-B14F-4D97-AF65-F5344CB8AC3E}">
-        <p14:creationId xmlns:p14="http://schemas.microsoft.com/office/powerpoint/2010/main" val="606043869"/>
+        <p14:creationId xmlns:p14="http://schemas.microsoft.com/office/powerpoint/2010/main" val="2028844609"/>
       </p:ext>
     </p:extLst>
   </p:cSld>
@@ -6890,7 +6878,7 @@
           <p:cNvPr id="12" name="">
             <a:extLst xmlns:a="http://schemas.openxmlformats.org/drawingml/2006/main">
               <a:ext uri="{FF2B5EF4-FFF2-40B4-BE49-F238E27FC236}">
-                <a16:creationId xmlns:a16="http://schemas.microsoft.com/office/drawing/2014/main" id="{C2A0E4F3-1574-411F-878A-BD7553CEB9CA}"/>
+                <a16:creationId xmlns:a16="http://schemas.microsoft.com/office/drawing/2014/main" id="{6361B034-0E03-4A3A-B60A-725BF61BEAC5}"/>
               </a:ext>
             </a:extLst>
           </p:cNvPr>
@@ -6935,7 +6923,7 @@
           <p:cNvPr id="2" name="">
             <a:extLst xmlns:a="http://schemas.openxmlformats.org/drawingml/2006/main">
               <a:ext uri="{FF2B5EF4-FFF2-40B4-BE49-F238E27FC236}">
-                <a16:creationId xmlns:a16="http://schemas.microsoft.com/office/drawing/2014/main" id="{B2A2A012-794B-45CC-A04B-FDDCC9FFDF20}"/>
+                <a16:creationId xmlns:a16="http://schemas.microsoft.com/office/drawing/2014/main" id="{96ECD673-CD30-486E-8726-2E28CBF9BA04}"/>
               </a:ext>
             </a:extLst>
           </p:cNvPr>
@@ -6965,7 +6953,7 @@
           <p:cNvPr id="3" name="">
             <a:extLst xmlns:a="http://schemas.openxmlformats.org/drawingml/2006/main">
               <a:ext uri="{FF2B5EF4-FFF2-40B4-BE49-F238E27FC236}">
-                <a16:creationId xmlns:a16="http://schemas.microsoft.com/office/drawing/2014/main" id="{F7E29E61-CB9C-44DB-8A4A-59D3EE23E28E}"/>
+                <a16:creationId xmlns:a16="http://schemas.microsoft.com/office/drawing/2014/main" id="{2DDFD84A-E1A8-423E-A924-E5B471BC38ED}"/>
               </a:ext>
             </a:extLst>
           </p:cNvPr>
@@ -7010,7 +6998,7 @@
           <p:cNvPr id="4" name="Chart">
             <a:extLst xmlns:a="http://schemas.openxmlformats.org/drawingml/2006/main">
               <a:ext uri="{FF2B5EF4-FFF2-40B4-BE49-F238E27FC236}">
-                <a16:creationId xmlns:a16="http://schemas.microsoft.com/office/drawing/2014/main" id="{59844BE6-ECD9-439B-AC1C-7836C10B5F24}"/>
+                <a16:creationId xmlns:a16="http://schemas.microsoft.com/office/drawing/2014/main" id="{7FFD565B-E74F-4B7B-8BEF-96B9369D3738}"/>
               </a:ext>
             </a:extLst>
           </p:cNvPr>
@@ -7023,7 +7011,7 @@
         </p:xfrm>
         <a:graphic xmlns:a="http://schemas.openxmlformats.org/drawingml/2006/main">
           <a:graphicData uri="http://schemas.openxmlformats.org/drawingml/2006/chart">
-            <c:chart xmlns:r="http://schemas.openxmlformats.org/officeDocument/2006/relationships" xmlns:c="http://schemas.openxmlformats.org/drawingml/2006/chart" r:id="Ra00bb7ec55c04ba2"/>
+            <c:chart xmlns:r="http://schemas.openxmlformats.org/officeDocument/2006/relationships" xmlns:c="http://schemas.openxmlformats.org/drawingml/2006/chart" r:id="Re03d09c5d506474d"/>
           </a:graphicData>
         </a:graphic>
       </p:graphicFrame>
@@ -7032,7 +7020,7 @@
           <p:cNvPr id="5" name="">
             <a:extLst xmlns:a="http://schemas.openxmlformats.org/drawingml/2006/main">
               <a:ext uri="{FF2B5EF4-FFF2-40B4-BE49-F238E27FC236}">
-                <a16:creationId xmlns:a16="http://schemas.microsoft.com/office/drawing/2014/main" id="{62565BA1-E81E-4E51-8B2C-2505B4052BF3}"/>
+                <a16:creationId xmlns:a16="http://schemas.microsoft.com/office/drawing/2014/main" id="{E3B18D00-8C1B-4B62-A646-86E637B0833F}"/>
               </a:ext>
             </a:extLst>
           </p:cNvPr>
@@ -7067,7 +7055,7 @@
                 <a:ea typeface="Arial"/>
                 <a:cs typeface="Arial"/>
               </a:rPr>
-              <a:t>4 workloads × frame 39; 100 repetitions/path. GPU timeline, not wall time.</a:t>
+              <a:t>1068 frames at 30W; 5 repetitions/frame. GPU timing, not wall time.</a:t>
             </a:r>
           </a:p>
         </p:txBody>
@@ -7077,7 +7065,7 @@
           <p:cNvPr id="6" name="">
             <a:extLst xmlns:a="http://schemas.openxmlformats.org/drawingml/2006/main">
               <a:ext uri="{FF2B5EF4-FFF2-40B4-BE49-F238E27FC236}">
-                <a16:creationId xmlns:a16="http://schemas.microsoft.com/office/drawing/2014/main" id="{81D8E702-AF40-4E3C-9C30-6C3DB5B75771}"/>
+                <a16:creationId xmlns:a16="http://schemas.microsoft.com/office/drawing/2014/main" id="{01A56016-B867-4E67-B90B-80C353DB1DB4}"/>
               </a:ext>
             </a:extLst>
           </p:cNvPr>
@@ -7112,7 +7100,7 @@
                 <a:ea typeface="Arial"/>
                 <a:cs typeface="Arial"/>
               </a:rPr>
-              <a:t>2.8% region</a:t>
+              <a:t>0.25× region</a:t>
             </a:r>
           </a:p>
         </p:txBody>
@@ -7122,7 +7110,7 @@
           <p:cNvPr id="7" name="">
             <a:extLst xmlns:a="http://schemas.openxmlformats.org/drawingml/2006/main">
               <a:ext uri="{FF2B5EF4-FFF2-40B4-BE49-F238E27FC236}">
-                <a16:creationId xmlns:a16="http://schemas.microsoft.com/office/drawing/2014/main" id="{9FD1AA88-549B-4459-937A-49F95284C1BE}"/>
+                <a16:creationId xmlns:a16="http://schemas.microsoft.com/office/drawing/2014/main" id="{18BFCCA9-1ECE-40EC-A3BA-71407D23A775}"/>
               </a:ext>
             </a:extLst>
           </p:cNvPr>
@@ -7157,7 +7145,7 @@
                 <a:ea typeface="Arial"/>
                 <a:cs typeface="Arial"/>
               </a:rPr>
-              <a:t>5.462 ms</a:t>
+              <a:t>6.257 ms</a:t>
             </a:r>
           </a:p>
         </p:txBody>
@@ -7167,7 +7155,7 @@
           <p:cNvPr id="8" name="">
             <a:extLst xmlns:a="http://schemas.openxmlformats.org/drawingml/2006/main">
               <a:ext uri="{FF2B5EF4-FFF2-40B4-BE49-F238E27FC236}">
-                <a16:creationId xmlns:a16="http://schemas.microsoft.com/office/drawing/2014/main" id="{DF1E08D9-DE6D-463C-81B3-16C85A2A3EF7}"/>
+                <a16:creationId xmlns:a16="http://schemas.microsoft.com/office/drawing/2014/main" id="{7B5C357C-DF8B-48C5-B661-AB67BF267C9A}"/>
               </a:ext>
             </a:extLst>
           </p:cNvPr>
@@ -7212,7 +7200,7 @@
           <p:cNvPr id="9" name="">
             <a:extLst xmlns:a="http://schemas.openxmlformats.org/drawingml/2006/main">
               <a:ext uri="{FF2B5EF4-FFF2-40B4-BE49-F238E27FC236}">
-                <a16:creationId xmlns:a16="http://schemas.microsoft.com/office/drawing/2014/main" id="{255AA6EB-02FB-42A5-94DD-924562B9C9BC}"/>
+                <a16:creationId xmlns:a16="http://schemas.microsoft.com/office/drawing/2014/main" id="{CD63A0AB-D86B-411E-8D73-B0948BF7B6AF}"/>
               </a:ext>
             </a:extLst>
           </p:cNvPr>
@@ -7247,7 +7235,7 @@
                 <a:ea typeface="Arial"/>
                 <a:cs typeface="Arial"/>
               </a:rPr>
-              <a:t>1.83×</a:t>
+              <a:t>1.74×</a:t>
             </a:r>
           </a:p>
         </p:txBody>
@@ -7257,7 +7245,7 @@
           <p:cNvPr id="10" name="">
             <a:extLst xmlns:a="http://schemas.openxmlformats.org/drawingml/2006/main">
               <a:ext uri="{FF2B5EF4-FFF2-40B4-BE49-F238E27FC236}">
-                <a16:creationId xmlns:a16="http://schemas.microsoft.com/office/drawing/2014/main" id="{F136F32D-FC77-4962-BD3A-22FF1BAB31B2}"/>
+                <a16:creationId xmlns:a16="http://schemas.microsoft.com/office/drawing/2014/main" id="{3F474BB0-FC29-4A2C-ACBB-239A693A67C8}"/>
               </a:ext>
             </a:extLst>
           </p:cNvPr>
@@ -7302,7 +7290,7 @@
           <p:cNvPr id="11" name="">
             <a:extLst xmlns:a="http://schemas.openxmlformats.org/drawingml/2006/main">
               <a:ext uri="{FF2B5EF4-FFF2-40B4-BE49-F238E27FC236}">
-                <a16:creationId xmlns:a16="http://schemas.microsoft.com/office/drawing/2014/main" id="{59332637-B9D4-4203-822C-4D17BE9FCD7C}"/>
+                <a16:creationId xmlns:a16="http://schemas.microsoft.com/office/drawing/2014/main" id="{9B8B0DAF-1E89-47E3-A431-A363FB2B9371}"/>
               </a:ext>
             </a:extLst>
           </p:cNvPr>
@@ -7337,7 +7325,7 @@
                 <a:ea typeface="Arial"/>
                 <a:cs typeface="Arial"/>
               </a:rPr>
-              <a:t>Derived budget, not measured end-to-end. Copies excluded. Savings include reduced clearing work; no optimal-Full claim.</a:t>
+              <a:t>Derived budget, not measured end-to-end. Copies excluded. Includes clearing and resampling; no optimal-Full claim.</a:t>
             </a:r>
           </a:p>
         </p:txBody>
@@ -7345,7 +7333,7 @@
     </p:spTree>
     <p:extLst>
       <p:ext uri="{BB962C8B-B14F-4D97-AF65-F5344CB8AC3E}">
-        <p14:creationId xmlns:p14="http://schemas.microsoft.com/office/powerpoint/2010/main" val="584151859"/>
+        <p14:creationId xmlns:p14="http://schemas.microsoft.com/office/powerpoint/2010/main" val="214652951"/>
       </p:ext>
     </p:extLst>
   </p:cSld>
@@ -7376,7 +7364,7 @@
           <p:cNvPr id="8" name="">
             <a:extLst xmlns:a="http://schemas.openxmlformats.org/drawingml/2006/main">
               <a:ext uri="{FF2B5EF4-FFF2-40B4-BE49-F238E27FC236}">
-                <a16:creationId xmlns:a16="http://schemas.microsoft.com/office/drawing/2014/main" id="{7E4CE1E8-BF96-4F64-B6E3-D44062434E1A}"/>
+                <a16:creationId xmlns:a16="http://schemas.microsoft.com/office/drawing/2014/main" id="{E7499C8F-677E-452E-8AB0-B3AB35802E48}"/>
               </a:ext>
             </a:extLst>
           </p:cNvPr>
@@ -7421,7 +7409,7 @@
           <p:cNvPr id="2" name="">
             <a:extLst xmlns:a="http://schemas.openxmlformats.org/drawingml/2006/main">
               <a:ext uri="{FF2B5EF4-FFF2-40B4-BE49-F238E27FC236}">
-                <a16:creationId xmlns:a16="http://schemas.microsoft.com/office/drawing/2014/main" id="{02F3FBD6-E63F-40FA-97D3-82A6A5963E3F}"/>
+                <a16:creationId xmlns:a16="http://schemas.microsoft.com/office/drawing/2014/main" id="{D6974AA6-01A6-4885-AB7B-DD352FFC9052}"/>
               </a:ext>
             </a:extLst>
           </p:cNvPr>
@@ -7451,7 +7439,7 @@
           <p:cNvPr id="3" name="">
             <a:extLst xmlns:a="http://schemas.openxmlformats.org/drawingml/2006/main">
               <a:ext uri="{FF2B5EF4-FFF2-40B4-BE49-F238E27FC236}">
-                <a16:creationId xmlns:a16="http://schemas.microsoft.com/office/drawing/2014/main" id="{4C75864A-465E-4583-9191-F1556CA59891}"/>
+                <a16:creationId xmlns:a16="http://schemas.microsoft.com/office/drawing/2014/main" id="{3CB516E5-504C-4F59-AA11-7BC137A20C37}"/>
               </a:ext>
             </a:extLst>
           </p:cNvPr>
@@ -7496,7 +7484,7 @@
           <p:cNvPr id="4" name="">
             <a:extLst xmlns:a="http://schemas.openxmlformats.org/drawingml/2006/main">
               <a:ext uri="{FF2B5EF4-FFF2-40B4-BE49-F238E27FC236}">
-                <a16:creationId xmlns:a16="http://schemas.microsoft.com/office/drawing/2014/main" id="{806A95FC-757C-4E87-A70C-188BC0811CD4}"/>
+                <a16:creationId xmlns:a16="http://schemas.microsoft.com/office/drawing/2014/main" id="{6B1A04D3-D71D-411C-BD6D-6D2A05525EDF}"/>
               </a:ext>
             </a:extLst>
           </p:cNvPr>
@@ -7517,7 +7505,7 @@
                 <a:gridCol w="2724150"/>
                 <a:gridCol w="3105150"/>
               </a:tblGrid>
-              <a:tr h="534988">
+              <a:tr h="641985">
                 <a:tc>
                   <a:txBody>
                     <a:bodyPr/>
@@ -7532,7 +7520,7 @@
                           <a:ea typeface="Arial"/>
                           <a:cs typeface="Arial"/>
                         </a:rPr>
-                        <a:t>Region (% of image)</a:t>
+                        <a:t>Region width scale</a:t>
                       </a:r>
                     </a:p>
                   </a:txBody>
@@ -7693,7 +7681,7 @@
                   </a:tcPr>
                 </a:tc>
               </a:tr>
-              <a:tr h="534988">
+              <a:tr h="641985">
                 <a:tc>
                   <a:txBody>
                     <a:bodyPr/>
@@ -7708,7 +7696,7 @@
                           <a:ea typeface="Arial"/>
                           <a:cs typeface="Arial"/>
                         </a:rPr>
-                        <a:t>0.7%</a:t>
+                        <a:t>0.1×</a:t>
                       </a:r>
                     </a:p>
                   </a:txBody>
@@ -7750,7 +7738,7 @@
                           <a:ea typeface="Arial"/>
                           <a:cs typeface="Arial"/>
                         </a:rPr>
-                        <a:t>5.248 ms</a:t>
+                        <a:t>5.631 ms</a:t>
                       </a:r>
                     </a:p>
                   </a:txBody>
@@ -7786,7 +7774,7 @@
                           <a:ea typeface="Arial"/>
                           <a:cs typeface="Arial"/>
                         </a:rPr>
-                        <a:t>-0.1727 dB</a:t>
+                        <a:t>-0.1718 dB</a:t>
                       </a:r>
                     </a:p>
                   </a:txBody>
@@ -7822,7 +7810,7 @@
                           <a:ea typeface="Arial"/>
                           <a:cs typeface="Arial"/>
                         </a:rPr>
-                        <a:t>-0.0864 dB</a:t>
+                        <a:t>-0.0859 dB</a:t>
                       </a:r>
                     </a:p>
                   </a:txBody>
@@ -7845,7 +7833,7 @@
                   </a:tcPr>
                 </a:tc>
               </a:tr>
-              <a:tr h="534988">
+              <a:tr h="641985">
                 <a:tc>
                   <a:txBody>
                     <a:bodyPr/>
@@ -7860,7 +7848,7 @@
                           <a:ea typeface="Arial"/>
                           <a:cs typeface="Arial"/>
                         </a:rPr>
-                        <a:t>2.8%</a:t>
+                        <a:t>0.25×</a:t>
                       </a:r>
                     </a:p>
                   </a:txBody>
@@ -7902,7 +7890,7 @@
                           <a:ea typeface="Arial"/>
                           <a:cs typeface="Arial"/>
                         </a:rPr>
-                        <a:t>5.462 ms</a:t>
+                        <a:t>6.257 ms</a:t>
                       </a:r>
                     </a:p>
                   </a:txBody>
@@ -7938,7 +7926,7 @@
                           <a:ea typeface="Arial"/>
                           <a:cs typeface="Arial"/>
                         </a:rPr>
-                        <a:t>-0.1668 dB</a:t>
+                        <a:t>-0.1569 dB</a:t>
                       </a:r>
                     </a:p>
                   </a:txBody>
@@ -7974,7 +7962,7 @@
                           <a:ea typeface="Arial"/>
                           <a:cs typeface="Arial"/>
                         </a:rPr>
-                        <a:t>-0.0834 dB</a:t>
+                        <a:t>-0.0785 dB</a:t>
                       </a:r>
                     </a:p>
                   </a:txBody>
@@ -7997,7 +7985,7 @@
                   </a:tcPr>
                 </a:tc>
               </a:tr>
-              <a:tr h="534988">
+              <a:tr h="641985">
                 <a:tc>
                   <a:txBody>
                     <a:bodyPr/>
@@ -8012,7 +8000,7 @@
                           <a:ea typeface="Arial"/>
                           <a:cs typeface="Arial"/>
                         </a:rPr>
-                        <a:t>11.1%</a:t>
+                        <a:t>0.5×</a:t>
                       </a:r>
                     </a:p>
                   </a:txBody>
@@ -8054,7 +8042,7 @@
                           <a:ea typeface="Arial"/>
                           <a:cs typeface="Arial"/>
                         </a:rPr>
-                        <a:t>6.318 ms</a:t>
+                        <a:t>8.158 ms</a:t>
                       </a:r>
                     </a:p>
                   </a:txBody>
@@ -8090,7 +8078,7 @@
                           <a:ea typeface="Arial"/>
                           <a:cs typeface="Arial"/>
                         </a:rPr>
-                        <a:t>-0.1462 dB</a:t>
+                        <a:t>-0.1198 dB</a:t>
                       </a:r>
                     </a:p>
                   </a:txBody>
@@ -8126,7 +8114,7 @@
                           <a:ea typeface="Arial"/>
                           <a:cs typeface="Arial"/>
                         </a:rPr>
-                        <a:t>-0.0731 dB</a:t>
+                        <a:t>-0.0599 dB</a:t>
                       </a:r>
                     </a:p>
                   </a:txBody>
@@ -8149,7 +8137,7 @@
                   </a:tcPr>
                 </a:tc>
               </a:tr>
-              <a:tr h="534988">
+              <a:tr h="641985">
                 <a:tc>
                   <a:txBody>
                     <a:bodyPr/>
@@ -8164,7 +8152,7 @@
                           <a:ea typeface="Arial"/>
                           <a:cs typeface="Arial"/>
                         </a:rPr>
-                        <a:t>25.0%</a:t>
+                        <a:t>0.75×</a:t>
                       </a:r>
                     </a:p>
                   </a:txBody>
@@ -8206,7 +8194,7 @@
                           <a:ea typeface="Arial"/>
                           <a:cs typeface="Arial"/>
                         </a:rPr>
-                        <a:t>7.637 ms</a:t>
+                        <a:t>11.039 ms</a:t>
                       </a:r>
                     </a:p>
                   </a:txBody>
@@ -8242,7 +8230,7 @@
                           <a:ea typeface="Arial"/>
                           <a:cs typeface="Arial"/>
                         </a:rPr>
-                        <a:t>-0.1200 dB</a:t>
+                        <a:t>-0.0669 dB</a:t>
                       </a:r>
                     </a:p>
                   </a:txBody>
@@ -8278,7 +8266,7 @@
                           <a:ea typeface="Arial"/>
                           <a:cs typeface="Arial"/>
                         </a:rPr>
-                        <a:t>-0.0600 dB</a:t>
+                        <a:t>-0.0335 dB</a:t>
                       </a:r>
                     </a:p>
                   </a:txBody>
@@ -8301,158 +8289,6 @@
                   </a:tcPr>
                 </a:tc>
               </a:tr>
-              <a:tr h="534988">
-                <a:tc>
-                  <a:txBody>
-                    <a:bodyPr/>
-                    <a:lstStyle/>
-                    <a:p>
-                      <a:r>
-                        <a:rPr sz="1800" b="0">
-                          <a:solidFill>
-                            <a:srgbClr val="152D43"/>
-                          </a:solidFill>
-                          <a:latin typeface="Arial"/>
-                          <a:ea typeface="Arial"/>
-                          <a:cs typeface="Arial"/>
-                        </a:rPr>
-                        <a:t>44.4%</a:t>
-                      </a:r>
-                    </a:p>
-                  </a:txBody>
-                  <a:tcPr marL="91440" marR="91440" marT="45720" marB="45720">
-                    <a:lnL w="9525">
-                      <a:solidFill>
-                        <a:srgbClr val="D7DFE5"/>
-                      </a:solidFill>
-                      <a:prstDash val="solid"/>
-                    </a:lnL>
-                    <a:lnR w="9525">
-                      <a:solidFill>
-                        <a:srgbClr val="D7DFE5"/>
-                      </a:solidFill>
-                      <a:prstDash val="solid"/>
-                    </a:lnR>
-                    <a:lnB w="9525">
-                      <a:solidFill>
-                        <a:srgbClr val="D7DFE5"/>
-                      </a:solidFill>
-                      <a:prstDash val="solid"/>
-                    </a:lnB>
-                    <a:solidFill>
-                      <a:srgbClr val="FFFFFF"/>
-                    </a:solidFill>
-                  </a:tcPr>
-                </a:tc>
-                <a:tc>
-                  <a:txBody>
-                    <a:bodyPr/>
-                    <a:lstStyle/>
-                    <a:p>
-                      <a:r>
-                        <a:rPr sz="1800" b="0">
-                          <a:solidFill>
-                            <a:srgbClr val="152D43"/>
-                          </a:solidFill>
-                          <a:latin typeface="Arial"/>
-                          <a:ea typeface="Arial"/>
-                          <a:cs typeface="Arial"/>
-                        </a:rPr>
-                        <a:t>9.543 ms</a:t>
-                      </a:r>
-                    </a:p>
-                  </a:txBody>
-                  <a:tcPr marL="91440" marR="91440" marT="45720" marB="45720">
-                    <a:lnR w="9525">
-                      <a:solidFill>
-                        <a:srgbClr val="D7DFE5"/>
-                      </a:solidFill>
-                      <a:prstDash val="solid"/>
-                    </a:lnR>
-                    <a:lnB w="9525">
-                      <a:solidFill>
-                        <a:srgbClr val="D7DFE5"/>
-                      </a:solidFill>
-                      <a:prstDash val="solid"/>
-                    </a:lnB>
-                    <a:solidFill>
-                      <a:srgbClr val="FFFFFF"/>
-                    </a:solidFill>
-                  </a:tcPr>
-                </a:tc>
-                <a:tc>
-                  <a:txBody>
-                    <a:bodyPr/>
-                    <a:lstStyle/>
-                    <a:p>
-                      <a:r>
-                        <a:rPr sz="1800" b="0">
-                          <a:solidFill>
-                            <a:srgbClr val="152D43"/>
-                          </a:solidFill>
-                          <a:latin typeface="Arial"/>
-                          <a:ea typeface="Arial"/>
-                          <a:cs typeface="Arial"/>
-                        </a:rPr>
-                        <a:t>-0.0861 dB</a:t>
-                      </a:r>
-                    </a:p>
-                  </a:txBody>
-                  <a:tcPr marL="91440" marR="91440" marT="45720" marB="45720">
-                    <a:lnR w="9525">
-                      <a:solidFill>
-                        <a:srgbClr val="D7DFE5"/>
-                      </a:solidFill>
-                      <a:prstDash val="solid"/>
-                    </a:lnR>
-                    <a:lnB w="9525">
-                      <a:solidFill>
-                        <a:srgbClr val="D7DFE5"/>
-                      </a:solidFill>
-                      <a:prstDash val="solid"/>
-                    </a:lnB>
-                    <a:solidFill>
-                      <a:srgbClr val="FFFFFF"/>
-                    </a:solidFill>
-                  </a:tcPr>
-                </a:tc>
-                <a:tc>
-                  <a:txBody>
-                    <a:bodyPr/>
-                    <a:lstStyle/>
-                    <a:p>
-                      <a:r>
-                        <a:rPr sz="1800" b="0">
-                          <a:solidFill>
-                            <a:srgbClr val="152D43"/>
-                          </a:solidFill>
-                          <a:latin typeface="Arial"/>
-                          <a:ea typeface="Arial"/>
-                          <a:cs typeface="Arial"/>
-                        </a:rPr>
-                        <a:t>-0.0430 dB</a:t>
-                      </a:r>
-                    </a:p>
-                  </a:txBody>
-                  <a:tcPr marL="91440" marR="91440" marT="45720" marB="45720">
-                    <a:lnR w="9525">
-                      <a:solidFill>
-                        <a:srgbClr val="D7DFE5"/>
-                      </a:solidFill>
-                      <a:prstDash val="solid"/>
-                    </a:lnR>
-                    <a:lnB w="9525">
-                      <a:solidFill>
-                        <a:srgbClr val="D7DFE5"/>
-                      </a:solidFill>
-                      <a:prstDash val="solid"/>
-                    </a:lnB>
-                    <a:solidFill>
-                      <a:srgbClr val="FFFFFF"/>
-                    </a:solidFill>
-                  </a:tcPr>
-                </a:tc>
-              </a:tr>
             </a:tbl>
           </a:graphicData>
         </a:graphic>
@@ -8462,7 +8298,7 @@
           <p:cNvPr id="5" name="">
             <a:extLst xmlns:a="http://schemas.openxmlformats.org/drawingml/2006/main">
               <a:ext uri="{FF2B5EF4-FFF2-40B4-BE49-F238E27FC236}">
-                <a16:creationId xmlns:a16="http://schemas.microsoft.com/office/drawing/2014/main" id="{A311A780-70FE-47B1-91FD-A2859593565F}"/>
+                <a16:creationId xmlns:a16="http://schemas.microsoft.com/office/drawing/2014/main" id="{78845179-391D-423F-9121-20793BFE5480}"/>
               </a:ext>
             </a:extLst>
           </p:cNvPr>
@@ -8507,7 +8343,7 @@
           <p:cNvPr id="6" name="">
             <a:extLst xmlns:a="http://schemas.openxmlformats.org/drawingml/2006/main">
               <a:ext uri="{FF2B5EF4-FFF2-40B4-BE49-F238E27FC236}">
-                <a16:creationId xmlns:a16="http://schemas.microsoft.com/office/drawing/2014/main" id="{578622C3-34F2-42B1-9079-660A3A787005}"/>
+                <a16:creationId xmlns:a16="http://schemas.microsoft.com/office/drawing/2014/main" id="{93348659-FF28-42E5-954B-0BB80CEC89CA}"/>
               </a:ext>
             </a:extLst>
           </p:cNvPr>
@@ -8552,7 +8388,7 @@
           <p:cNvPr id="7" name="">
             <a:extLst xmlns:a="http://schemas.openxmlformats.org/drawingml/2006/main">
               <a:ext uri="{FF2B5EF4-FFF2-40B4-BE49-F238E27FC236}">
-                <a16:creationId xmlns:a16="http://schemas.microsoft.com/office/drawing/2014/main" id="{C11FCAC2-791E-4524-A062-83BE093C56AB}"/>
+                <a16:creationId xmlns:a16="http://schemas.microsoft.com/office/drawing/2014/main" id="{CDBFA6A6-0EAB-4D78-A498-A8CB4D15D861}"/>
               </a:ext>
             </a:extLst>
           </p:cNvPr>
@@ -8587,7 +8423,7 @@
                 <a:ea typeface="Arial"/>
                 <a:cs typeface="Arial"/>
               </a:rPr>
-              <a:t>Timing: 30W, 4 frames + fixed 2 ms decode. Quality: 15W, 1068 frames. Separate experiments, not jointly measured.</a:t>
+              <a:t>Quality and timing: same 30W run, 1068 frames. Timing adds a fixed 2 ms decode budget; not measured end-to-end.</a:t>
             </a:r>
           </a:p>
         </p:txBody>
@@ -8595,7 +8431,7 @@
     </p:spTree>
     <p:extLst>
       <p:ext uri="{BB962C8B-B14F-4D97-AF65-F5344CB8AC3E}">
-        <p14:creationId xmlns:p14="http://schemas.microsoft.com/office/powerpoint/2010/main" val="97320965"/>
+        <p14:creationId xmlns:p14="http://schemas.microsoft.com/office/powerpoint/2010/main" val="720353213"/>
       </p:ext>
     </p:extLst>
   </p:cSld>
@@ -8626,7 +8462,7 @@
           <p:cNvPr id="14" name="">
             <a:extLst xmlns:a="http://schemas.openxmlformats.org/drawingml/2006/main">
               <a:ext uri="{FF2B5EF4-FFF2-40B4-BE49-F238E27FC236}">
-                <a16:creationId xmlns:a16="http://schemas.microsoft.com/office/drawing/2014/main" id="{84061BC2-1C04-4E6D-88A4-723A6807EB9F}"/>
+                <a16:creationId xmlns:a16="http://schemas.microsoft.com/office/drawing/2014/main" id="{26F57AA7-DD06-4260-98A3-B39E42C0493F}"/>
               </a:ext>
             </a:extLst>
           </p:cNvPr>
@@ -8671,7 +8507,7 @@
           <p:cNvPr id="2" name="">
             <a:extLst xmlns:a="http://schemas.openxmlformats.org/drawingml/2006/main">
               <a:ext uri="{FF2B5EF4-FFF2-40B4-BE49-F238E27FC236}">
-                <a16:creationId xmlns:a16="http://schemas.microsoft.com/office/drawing/2014/main" id="{A961DC4C-62F7-429A-AAA8-F8055C952384}"/>
+                <a16:creationId xmlns:a16="http://schemas.microsoft.com/office/drawing/2014/main" id="{4B85743C-7B2F-451E-938A-F9DE3D5B93B3}"/>
               </a:ext>
             </a:extLst>
           </p:cNvPr>
@@ -8701,7 +8537,7 @@
           <p:cNvPr id="3" name="">
             <a:extLst xmlns:a="http://schemas.openxmlformats.org/drawingml/2006/main">
               <a:ext uri="{FF2B5EF4-FFF2-40B4-BE49-F238E27FC236}">
-                <a16:creationId xmlns:a16="http://schemas.microsoft.com/office/drawing/2014/main" id="{A13B84C5-357B-4A37-A60E-1478AA8444C1}"/>
+                <a16:creationId xmlns:a16="http://schemas.microsoft.com/office/drawing/2014/main" id="{84541237-6331-4BA9-BAC6-30F07F872198}"/>
               </a:ext>
             </a:extLst>
           </p:cNvPr>
@@ -8746,7 +8582,7 @@
           <p:cNvPr id="4" name="">
             <a:extLst xmlns:a="http://schemas.openxmlformats.org/drawingml/2006/main">
               <a:ext uri="{FF2B5EF4-FFF2-40B4-BE49-F238E27FC236}">
-                <a16:creationId xmlns:a16="http://schemas.microsoft.com/office/drawing/2014/main" id="{BF394C24-AB06-4D11-9010-997A298A3726}"/>
+                <a16:creationId xmlns:a16="http://schemas.microsoft.com/office/drawing/2014/main" id="{95581A7D-84B2-4F2C-A567-A46A8C83FCFF}"/>
               </a:ext>
             </a:extLst>
           </p:cNvPr>
@@ -8791,7 +8627,7 @@
           <p:cNvPr id="5" name="">
             <a:extLst xmlns:a="http://schemas.openxmlformats.org/drawingml/2006/main">
               <a:ext uri="{FF2B5EF4-FFF2-40B4-BE49-F238E27FC236}">
-                <a16:creationId xmlns:a16="http://schemas.microsoft.com/office/drawing/2014/main" id="{3DCA773A-821F-4D39-B1B2-1E8D9CED399B}"/>
+                <a16:creationId xmlns:a16="http://schemas.microsoft.com/office/drawing/2014/main" id="{360619D1-1293-4968-B7E3-562BCB7858B2}"/>
               </a:ext>
             </a:extLst>
           </p:cNvPr>
@@ -8836,7 +8672,7 @@
           <p:cNvPr id="6" name="">
             <a:extLst xmlns:a="http://schemas.openxmlformats.org/drawingml/2006/main">
               <a:ext uri="{FF2B5EF4-FFF2-40B4-BE49-F238E27FC236}">
-                <a16:creationId xmlns:a16="http://schemas.microsoft.com/office/drawing/2014/main" id="{6B8B170B-B280-487B-83A8-F96A8E4DA29A}"/>
+                <a16:creationId xmlns:a16="http://schemas.microsoft.com/office/drawing/2014/main" id="{F655579D-C90B-4A3E-99DF-A3492D559FD0}"/>
               </a:ext>
             </a:extLst>
           </p:cNvPr>
@@ -8881,7 +8717,7 @@
           <p:cNvPr id="7" name="">
             <a:extLst xmlns:a="http://schemas.openxmlformats.org/drawingml/2006/main">
               <a:ext uri="{FF2B5EF4-FFF2-40B4-BE49-F238E27FC236}">
-                <a16:creationId xmlns:a16="http://schemas.microsoft.com/office/drawing/2014/main" id="{6267466E-2A78-44A0-8807-651FEE27E726}"/>
+                <a16:creationId xmlns:a16="http://schemas.microsoft.com/office/drawing/2014/main" id="{EB046320-0FA2-4221-8D2F-AD1712345789}"/>
               </a:ext>
             </a:extLst>
           </p:cNvPr>
@@ -8926,7 +8762,7 @@
           <p:cNvPr id="8" name="">
             <a:extLst xmlns:a="http://schemas.openxmlformats.org/drawingml/2006/main">
               <a:ext uri="{FF2B5EF4-FFF2-40B4-BE49-F238E27FC236}">
-                <a16:creationId xmlns:a16="http://schemas.microsoft.com/office/drawing/2014/main" id="{48D26CF3-E8ED-4B4A-BF09-D9105063FCDA}"/>
+                <a16:creationId xmlns:a16="http://schemas.microsoft.com/office/drawing/2014/main" id="{5FE29D2A-CD74-45E4-80D7-019F34EAB054}"/>
               </a:ext>
             </a:extLst>
           </p:cNvPr>
@@ -8971,7 +8807,7 @@
           <p:cNvPr id="9" name="">
             <a:extLst xmlns:a="http://schemas.openxmlformats.org/drawingml/2006/main">
               <a:ext uri="{FF2B5EF4-FFF2-40B4-BE49-F238E27FC236}">
-                <a16:creationId xmlns:a16="http://schemas.microsoft.com/office/drawing/2014/main" id="{8904E76B-2401-4993-AC76-6830022A959A}"/>
+                <a16:creationId xmlns:a16="http://schemas.microsoft.com/office/drawing/2014/main" id="{8D25A889-9CB1-4128-9F8B-00535CCEA86F}"/>
               </a:ext>
             </a:extLst>
           </p:cNvPr>
@@ -9016,7 +8852,7 @@
           <p:cNvPr id="10" name="">
             <a:extLst xmlns:a="http://schemas.openxmlformats.org/drawingml/2006/main">
               <a:ext uri="{FF2B5EF4-FFF2-40B4-BE49-F238E27FC236}">
-                <a16:creationId xmlns:a16="http://schemas.microsoft.com/office/drawing/2014/main" id="{580E08B7-8360-42A4-9E2E-425511FD99AF}"/>
+                <a16:creationId xmlns:a16="http://schemas.microsoft.com/office/drawing/2014/main" id="{04B7544D-2930-4FB2-862E-9424ECE1E339}"/>
               </a:ext>
             </a:extLst>
           </p:cNvPr>
@@ -9061,7 +8897,7 @@
           <p:cNvPr id="11" name="">
             <a:extLst xmlns:a="http://schemas.openxmlformats.org/drawingml/2006/main">
               <a:ext uri="{FF2B5EF4-FFF2-40B4-BE49-F238E27FC236}">
-                <a16:creationId xmlns:a16="http://schemas.microsoft.com/office/drawing/2014/main" id="{FF2DCCC0-0A43-4FE8-9C63-1C6971E50A4E}"/>
+                <a16:creationId xmlns:a16="http://schemas.microsoft.com/office/drawing/2014/main" id="{3C50DDC9-205E-48C8-8678-45C61EB72E42}"/>
               </a:ext>
             </a:extLst>
           </p:cNvPr>
@@ -9106,7 +8942,7 @@
           <p:cNvPr id="12" name="">
             <a:extLst xmlns:a="http://schemas.openxmlformats.org/drawingml/2006/main">
               <a:ext uri="{FF2B5EF4-FFF2-40B4-BE49-F238E27FC236}">
-                <a16:creationId xmlns:a16="http://schemas.microsoft.com/office/drawing/2014/main" id="{B501E293-2794-4830-B726-E157A1D6A1DF}"/>
+                <a16:creationId xmlns:a16="http://schemas.microsoft.com/office/drawing/2014/main" id="{351FAC18-7016-445E-A93D-E7FD5774FA74}"/>
               </a:ext>
             </a:extLst>
           </p:cNvPr>
@@ -9151,7 +8987,7 @@
           <p:cNvPr id="13" name="">
             <a:extLst xmlns:a="http://schemas.openxmlformats.org/drawingml/2006/main">
               <a:ext uri="{FF2B5EF4-FFF2-40B4-BE49-F238E27FC236}">
-                <a16:creationId xmlns:a16="http://schemas.microsoft.com/office/drawing/2014/main" id="{7ADC0EEC-5BEE-45E7-B4AD-66BF4878C4C9}"/>
+                <a16:creationId xmlns:a16="http://schemas.microsoft.com/office/drawing/2014/main" id="{239FD8E2-16B4-4A0B-99C4-FF51323F506A}"/>
               </a:ext>
             </a:extLst>
           </p:cNvPr>
@@ -9194,7 +9030,7 @@
     </p:spTree>
     <p:extLst>
       <p:ext uri="{BB962C8B-B14F-4D97-AF65-F5344CB8AC3E}">
-        <p14:creationId xmlns:p14="http://schemas.microsoft.com/office/powerpoint/2010/main" val="1884115885"/>
+        <p14:creationId xmlns:p14="http://schemas.microsoft.com/office/powerpoint/2010/main" val="718374681"/>
       </p:ext>
     </p:extLst>
   </p:cSld>

</xml_diff>

<commit_message>
Present three FOV scales and stereo PSNR loss only
</commit_message>
<xml_diff>
--- a/presentations/weekly_20261029/weekly_20261029_english_30w.pptx
+++ b/presentations/weekly_20261029/weekly_20261029_english_30w.pptx
@@ -2,19 +2,19 @@
 <file path=ppt/presentation.xml><?xml version="1.0" encoding="utf-8"?>
 <p:presentation xmlns:p="http://schemas.openxmlformats.org/presentationml/2006/main">
   <p:sldMasterIdLst>
-    <p:sldMasterId xmlns:r="http://schemas.openxmlformats.org/officeDocument/2006/relationships" id="2147483648" r:id="Rf308f94b18b34d62"/>
+    <p:sldMasterId xmlns:r="http://schemas.openxmlformats.org/officeDocument/2006/relationships" id="2147483648" r:id="Re832cea49ea24aaa"/>
   </p:sldMasterIdLst>
   <p:notesMasterIdLst>
-    <p:notesMasterId xmlns:r="http://schemas.openxmlformats.org/officeDocument/2006/relationships" r:id="Rd2e34191d92b40dd"/>
+    <p:notesMasterId xmlns:r="http://schemas.openxmlformats.org/officeDocument/2006/relationships" r:id="R360564877f574f05"/>
   </p:notesMasterIdLst>
   <p:sldIdLst>
-    <p:sldId xmlns:r="http://schemas.openxmlformats.org/officeDocument/2006/relationships" id="256" r:id="Rb539c0c24beb475e"/>
-    <p:sldId xmlns:r="http://schemas.openxmlformats.org/officeDocument/2006/relationships" id="257" r:id="R1a2cb4e75b2646eb"/>
-    <p:sldId xmlns:r="http://schemas.openxmlformats.org/officeDocument/2006/relationships" id="258" r:id="Re2ec917e25a44556"/>
-    <p:sldId xmlns:r="http://schemas.openxmlformats.org/officeDocument/2006/relationships" id="259" r:id="R615b38e118dc4a08"/>
-    <p:sldId xmlns:r="http://schemas.openxmlformats.org/officeDocument/2006/relationships" id="260" r:id="R51e1c74341c047bc"/>
-    <p:sldId xmlns:r="http://schemas.openxmlformats.org/officeDocument/2006/relationships" id="261" r:id="Ra90747cd58984512"/>
-    <p:sldId xmlns:r="http://schemas.openxmlformats.org/officeDocument/2006/relationships" id="262" r:id="Rf0bc18ac014d4af4"/>
+    <p:sldId xmlns:r="http://schemas.openxmlformats.org/officeDocument/2006/relationships" id="256" r:id="Rcbb8d092bfeb451b"/>
+    <p:sldId xmlns:r="http://schemas.openxmlformats.org/officeDocument/2006/relationships" id="257" r:id="R74638d07bfb9464b"/>
+    <p:sldId xmlns:r="http://schemas.openxmlformats.org/officeDocument/2006/relationships" id="258" r:id="R540129de170f4ce5"/>
+    <p:sldId xmlns:r="http://schemas.openxmlformats.org/officeDocument/2006/relationships" id="259" r:id="Rbc3c4ca43d954c1f"/>
+    <p:sldId xmlns:r="http://schemas.openxmlformats.org/officeDocument/2006/relationships" id="260" r:id="R76b02ab1c2f245a4"/>
+    <p:sldId xmlns:r="http://schemas.openxmlformats.org/officeDocument/2006/relationships" id="261" r:id="R43cbe419d6a040c6"/>
+    <p:sldId xmlns:r="http://schemas.openxmlformats.org/officeDocument/2006/relationships" id="262" r:id="Rb332c0f122804713"/>
   </p:sldIdLst>
   <p:sldSz cx="12192000" cy="6858000"/>
   <p:notesSz cx="6858000" cy="9144000"/>
@@ -658,7 +658,7 @@
           <a:lstStyle xmlns:a="http://schemas.openxmlformats.org/drawingml/2006/main"/>
           <a:p xmlns:a="http://schemas.openxmlformats.org/drawingml/2006/main">
             <a:r>
-              <a:t>Source: results/fov_scales_full_20261029/scale_results.json and README.md. Same 30W CUDA C++ run: 1068 valid forward odd frames, 3 warmups, 5 timed repetitions per frame, one quality output per configuration/frame. Resident whole-pipeline GPU event timing without internal stage markers, fast resampling, dynamic clocks. This differs from the previous small-sample staged experiment. Mechanism: half-resolution base + padded full-resolution ROI + feather overlay. The full output is 960x540 (1.0x). Region scale is ROI width divided by full-image width: 96x54 =&gt; 0.1x, 240x135 =&gt; 0.25x, 480x270 =&gt; 0.5x, 720x405 =&gt; 0.75x. Width and height both follow these scales. ROI extent scale is not sampling resolution: pixels within the ROI remain full-resolution. The base samples at 0.5x width and 0.5x height (480x270) while covering the entire image.</a:t>
+              <a:t>Source: results/fov_scales_full_20261029/scale_results.json and README.md. Same 30W CUDA C++ run: 1068 valid forward odd frames, 3 warmups, 5 timed repetitions per frame, one quality output per configuration/frame. Resident whole-pipeline GPU event timing without internal stage markers, fast resampling, dynamic clocks. This differs from the previous small-sample staged experiment. Mechanism: half-resolution base + padded full-resolution ROI + feather overlay. The full output is 960x540 (1.0x). Region scale is ROI width divided by full-image width: 96x54 =&gt; 0.1x, 240x135 =&gt; 0.25x, 480x270 =&gt; 0.5x. The measured 0.75x level remains in the source dataset but is omitted from this presentation. Width and height both follow these scales. ROI extent scale is not sampling resolution: pixels within the ROI remain full-resolution. The base samples at 0.5x width and 0.5x height (480x270) while covering the entire image.</a:t>
             </a:r>
           </a:p>
         </p:txBody>
@@ -915,7 +915,7 @@
           <p:cNvPr id="3" name="Title">
             <a:extLst xmlns:a="http://schemas.openxmlformats.org/drawingml/2006/main">
               <a:ext uri="{FF2B5EF4-FFF2-40B4-BE49-F238E27FC236}">
-                <a16:creationId xmlns:a16="http://schemas.microsoft.com/office/drawing/2014/main" id="{4656B61E-6F12-41FF-82B5-C7DB83FF10A5}"/>
+                <a16:creationId xmlns:a16="http://schemas.microsoft.com/office/drawing/2014/main" id="{92ABD667-D094-4590-9F25-E3AC22B0E282}"/>
               </a:ext>
             </a:extLst>
           </p:cNvPr>
@@ -1144,7 +1144,7 @@
           <p:cNvPr id="2" name="Subtitle">
             <a:extLst xmlns:a="http://schemas.openxmlformats.org/drawingml/2006/main">
               <a:ext uri="{FF2B5EF4-FFF2-40B4-BE49-F238E27FC236}">
-                <a16:creationId xmlns:a16="http://schemas.microsoft.com/office/drawing/2014/main" id="{13E56DEB-E7B5-4B7D-9E1D-D9FC17A58799}"/>
+                <a16:creationId xmlns:a16="http://schemas.microsoft.com/office/drawing/2014/main" id="{B432252E-E14B-4A61-BB8A-174695D4A91C}"/>
               </a:ext>
             </a:extLst>
           </p:cNvPr>
@@ -1390,7 +1390,7 @@
           <p:cNvPr id="2" name="Section title">
             <a:extLst xmlns:a="http://schemas.openxmlformats.org/drawingml/2006/main">
               <a:ext uri="{FF2B5EF4-FFF2-40B4-BE49-F238E27FC236}">
-                <a16:creationId xmlns:a16="http://schemas.microsoft.com/office/drawing/2014/main" id="{F4C64E40-54CD-4D7E-8241-8C74044B2782}"/>
+                <a16:creationId xmlns:a16="http://schemas.microsoft.com/office/drawing/2014/main" id="{3BD4335D-A81E-40E7-B0F6-BE8652C2EAE0}"/>
               </a:ext>
             </a:extLst>
           </p:cNvPr>
@@ -1636,7 +1636,7 @@
           <p:cNvPr id="3" name="Title">
             <a:extLst xmlns:a="http://schemas.openxmlformats.org/drawingml/2006/main">
               <a:ext uri="{FF2B5EF4-FFF2-40B4-BE49-F238E27FC236}">
-                <a16:creationId xmlns:a16="http://schemas.microsoft.com/office/drawing/2014/main" id="{034EB934-449C-4E12-83DC-0592C95AAE32}"/>
+                <a16:creationId xmlns:a16="http://schemas.microsoft.com/office/drawing/2014/main" id="{1FE97686-6382-4DDD-9000-B3D789E9F989}"/>
               </a:ext>
             </a:extLst>
           </p:cNvPr>
@@ -1865,7 +1865,7 @@
           <p:cNvPr id="2" name="Body">
             <a:extLst xmlns:a="http://schemas.openxmlformats.org/drawingml/2006/main">
               <a:ext uri="{FF2B5EF4-FFF2-40B4-BE49-F238E27FC236}">
-                <a16:creationId xmlns:a16="http://schemas.microsoft.com/office/drawing/2014/main" id="{F20A3173-92E1-4118-A89A-2ADC1C45EA02}"/>
+                <a16:creationId xmlns:a16="http://schemas.microsoft.com/office/drawing/2014/main" id="{57E4A63F-EB2C-4ED8-9E79-F5DA171AC689}"/>
               </a:ext>
             </a:extLst>
           </p:cNvPr>
@@ -2111,7 +2111,7 @@
           <p:cNvPr id="4" name="Title">
             <a:extLst xmlns:a="http://schemas.openxmlformats.org/drawingml/2006/main">
               <a:ext uri="{FF2B5EF4-FFF2-40B4-BE49-F238E27FC236}">
-                <a16:creationId xmlns:a16="http://schemas.microsoft.com/office/drawing/2014/main" id="{899173B2-457A-4516-8CCA-782998DAD26B}"/>
+                <a16:creationId xmlns:a16="http://schemas.microsoft.com/office/drawing/2014/main" id="{238D6A94-C7C2-4B41-AA9B-7B5D4F0DF1AE}"/>
               </a:ext>
             </a:extLst>
           </p:cNvPr>
@@ -2340,7 +2340,7 @@
           <p:cNvPr id="2" name="Left column">
             <a:extLst xmlns:a="http://schemas.openxmlformats.org/drawingml/2006/main">
               <a:ext uri="{FF2B5EF4-FFF2-40B4-BE49-F238E27FC236}">
-                <a16:creationId xmlns:a16="http://schemas.microsoft.com/office/drawing/2014/main" id="{47041428-08D6-42BE-8E2C-A1D2C73A9632}"/>
+                <a16:creationId xmlns:a16="http://schemas.microsoft.com/office/drawing/2014/main" id="{78A41F0E-EADD-4354-B1E0-20EA1EE44636}"/>
               </a:ext>
             </a:extLst>
           </p:cNvPr>
@@ -2569,7 +2569,7 @@
           <p:cNvPr id="3" name="Right column">
             <a:extLst xmlns:a="http://schemas.openxmlformats.org/drawingml/2006/main">
               <a:ext uri="{FF2B5EF4-FFF2-40B4-BE49-F238E27FC236}">
-                <a16:creationId xmlns:a16="http://schemas.microsoft.com/office/drawing/2014/main" id="{A361810E-580C-4F59-B861-A54ABA3F728B}"/>
+                <a16:creationId xmlns:a16="http://schemas.microsoft.com/office/drawing/2014/main" id="{FB60E174-0798-464B-AA68-6665C0803040}"/>
               </a:ext>
             </a:extLst>
           </p:cNvPr>
@@ -2815,7 +2815,7 @@
           <p:cNvPr id="3" name="Title">
             <a:extLst xmlns:a="http://schemas.openxmlformats.org/drawingml/2006/main">
               <a:ext uri="{FF2B5EF4-FFF2-40B4-BE49-F238E27FC236}">
-                <a16:creationId xmlns:a16="http://schemas.microsoft.com/office/drawing/2014/main" id="{C9EDE04E-21E5-4A13-A4F6-CE3C05FCA13E}"/>
+                <a16:creationId xmlns:a16="http://schemas.microsoft.com/office/drawing/2014/main" id="{70598EF3-043C-444A-A5A1-B18969FEB2CC}"/>
               </a:ext>
             </a:extLst>
           </p:cNvPr>
@@ -3044,7 +3044,7 @@
           <p:cNvPr id="2" name="Left column">
             <a:extLst xmlns:a="http://schemas.openxmlformats.org/drawingml/2006/main">
               <a:ext uri="{FF2B5EF4-FFF2-40B4-BE49-F238E27FC236}">
-                <a16:creationId xmlns:a16="http://schemas.microsoft.com/office/drawing/2014/main" id="{CC7E3F32-BC89-457D-B886-659244175253}"/>
+                <a16:creationId xmlns:a16="http://schemas.microsoft.com/office/drawing/2014/main" id="{FE399677-67CB-4289-9849-3CCC9426635C}"/>
               </a:ext>
             </a:extLst>
           </p:cNvPr>
@@ -3311,12 +3311,12 @@
   </p:cSld>
   <p:clrMap bg1="lt1" tx1="dk1" bg2="lt2" tx2="dk2" accent1="accent1" accent2="accent2" accent3="accent3" accent4="accent4" accent5="accent5" accent6="accent6" hlink="hlink" folHlink="folHlink"/>
   <p:sldLayoutIdLst>
-    <p:sldLayoutId xmlns:r="http://schemas.openxmlformats.org/officeDocument/2006/relationships" id="2147483649" r:id="R4e61cfc36b694702"/>
-    <p:sldLayoutId xmlns:r="http://schemas.openxmlformats.org/officeDocument/2006/relationships" id="2147483650" r:id="R82e3c27429bd4427"/>
-    <p:sldLayoutId xmlns:r="http://schemas.openxmlformats.org/officeDocument/2006/relationships" id="2147483651" r:id="Rd3884a5e79154551"/>
-    <p:sldLayoutId xmlns:r="http://schemas.openxmlformats.org/officeDocument/2006/relationships" id="2147483652" r:id="R38ccc95140b94a01"/>
-    <p:sldLayoutId xmlns:r="http://schemas.openxmlformats.org/officeDocument/2006/relationships" id="2147483653" r:id="R2a902b4618f94d45"/>
-    <p:sldLayoutId xmlns:r="http://schemas.openxmlformats.org/officeDocument/2006/relationships" id="2147483654" r:id="Re7d2499ac55a4c90"/>
+    <p:sldLayoutId xmlns:r="http://schemas.openxmlformats.org/officeDocument/2006/relationships" id="2147483649" r:id="Rb813607ffdac450c"/>
+    <p:sldLayoutId xmlns:r="http://schemas.openxmlformats.org/officeDocument/2006/relationships" id="2147483650" r:id="R9e9fc027ed754cc0"/>
+    <p:sldLayoutId xmlns:r="http://schemas.openxmlformats.org/officeDocument/2006/relationships" id="2147483651" r:id="R091a50b85bd3430d"/>
+    <p:sldLayoutId xmlns:r="http://schemas.openxmlformats.org/officeDocument/2006/relationships" id="2147483652" r:id="Re14965a389d04172"/>
+    <p:sldLayoutId xmlns:r="http://schemas.openxmlformats.org/officeDocument/2006/relationships" id="2147483653" r:id="Rc79c43a5a795441b"/>
+    <p:sldLayoutId xmlns:r="http://schemas.openxmlformats.org/officeDocument/2006/relationships" id="2147483654" r:id="Reade1bf42a6740a1"/>
   </p:sldLayoutIdLst>
   <p:txStyles>
     <p:titleStyle>
@@ -3866,9 +3866,9 @@
           <c:invertIfNegative val="0"/>
           <c:cat>
             <c:strRef>
-              <c:f>'Chart Data'!$A$2:$A$6</c:f>
+              <c:f>'Chart Data'!$A$2:$A$5</c:f>
               <c:strCache>
-                <c:ptCount val="5"/>
+                <c:ptCount val="4"/>
                 <c:pt idx="0">
                   <c:v>Full</c:v>
                 </c:pt>
@@ -3881,18 +3881,15 @@
                 <c:pt idx="3">
                   <c:v>0.5×</c:v>
                 </c:pt>
-                <c:pt idx="4">
-                  <c:v>0.75×</c:v>
-                </c:pt>
               </c:strCache>
             </c:strRef>
           </c:cat>
           <c:val>
             <c:numRef>
-              <c:f>'Chart Data'!$B$2:$B$6</c:f>
+              <c:f>'Chart Data'!$B$2:$B$5</c:f>
               <c:numCache>
                 <c:formatCode>General</c:formatCode>
-                <c:ptCount val="5"/>
+                <c:ptCount val="4"/>
                 <c:pt idx="0">
                   <c:v>8.882</c:v>
                 </c:pt>
@@ -3904,9 +3901,6 @@
                 </c:pt>
                 <c:pt idx="3">
                   <c:v>6.158</c:v>
-                </c:pt>
-                <c:pt idx="4">
-                  <c:v>9.039</c:v>
                 </c:pt>
               </c:numCache>
             </c:numRef>
@@ -3926,9 +3920,9 @@
           <c:invertIfNegative val="0"/>
           <c:cat>
             <c:strRef>
-              <c:f>'Chart Data'!$C$2:$C$6</c:f>
+              <c:f>'Chart Data'!$C$2:$C$5</c:f>
               <c:strCache>
-                <c:ptCount val="5"/>
+                <c:ptCount val="4"/>
                 <c:pt idx="0">
                   <c:v>Full</c:v>
                 </c:pt>
@@ -3941,18 +3935,15 @@
                 <c:pt idx="3">
                   <c:v>0.5×</c:v>
                 </c:pt>
-                <c:pt idx="4">
-                  <c:v>0.75×</c:v>
-                </c:pt>
               </c:strCache>
             </c:strRef>
           </c:cat>
           <c:val>
             <c:numRef>
-              <c:f>'Chart Data'!$D$2:$D$6</c:f>
+              <c:f>'Chart Data'!$D$2:$D$5</c:f>
               <c:numCache>
                 <c:formatCode>General</c:formatCode>
-                <c:ptCount val="5"/>
+                <c:ptCount val="4"/>
                 <c:pt idx="0">
                   <c:v>2</c:v>
                 </c:pt>
@@ -3963,9 +3954,6 @@
                   <c:v>2</c:v>
                 </c:pt>
                 <c:pt idx="3">
-                  <c:v>2</c:v>
-                </c:pt>
-                <c:pt idx="4">
                   <c:v>2</c:v>
                 </c:pt>
               </c:numCache>
@@ -4176,7 +4164,7 @@
           <p:cNvPr id="5" name="">
             <a:extLst xmlns:a="http://schemas.openxmlformats.org/drawingml/2006/main">
               <a:ext uri="{FF2B5EF4-FFF2-40B4-BE49-F238E27FC236}">
-                <a16:creationId xmlns:a16="http://schemas.microsoft.com/office/drawing/2014/main" id="{6231B366-2261-4CA3-A4F6-3C93D194AFB1}"/>
+                <a16:creationId xmlns:a16="http://schemas.microsoft.com/office/drawing/2014/main" id="{FB96B3B9-E27D-4F70-9EFF-463781721C60}"/>
               </a:ext>
             </a:extLst>
           </p:cNvPr>
@@ -4234,7 +4222,7 @@
           <p:cNvPr id="2" name="">
             <a:extLst xmlns:a="http://schemas.openxmlformats.org/drawingml/2006/main">
               <a:ext uri="{FF2B5EF4-FFF2-40B4-BE49-F238E27FC236}">
-                <a16:creationId xmlns:a16="http://schemas.microsoft.com/office/drawing/2014/main" id="{92B64A86-41B4-4018-A123-111331AE706C}"/>
+                <a16:creationId xmlns:a16="http://schemas.microsoft.com/office/drawing/2014/main" id="{E92B54C1-30D9-4EA6-9756-7A2C7304EAC2}"/>
               </a:ext>
             </a:extLst>
           </p:cNvPr>
@@ -4279,7 +4267,7 @@
           <p:cNvPr id="3" name="">
             <a:extLst xmlns:a="http://schemas.openxmlformats.org/drawingml/2006/main">
               <a:ext uri="{FF2B5EF4-FFF2-40B4-BE49-F238E27FC236}">
-                <a16:creationId xmlns:a16="http://schemas.microsoft.com/office/drawing/2014/main" id="{16919AF6-57B0-43BB-9D3B-C7484D24BD81}"/>
+                <a16:creationId xmlns:a16="http://schemas.microsoft.com/office/drawing/2014/main" id="{5194251D-410F-4685-A072-2A9E3F2E4CC4}"/>
               </a:ext>
             </a:extLst>
           </p:cNvPr>
@@ -4324,7 +4312,7 @@
           <p:cNvPr id="4" name="">
             <a:extLst xmlns:a="http://schemas.openxmlformats.org/drawingml/2006/main">
               <a:ext uri="{FF2B5EF4-FFF2-40B4-BE49-F238E27FC236}">
-                <a16:creationId xmlns:a16="http://schemas.microsoft.com/office/drawing/2014/main" id="{4CDA085C-C1D9-447B-B492-95E1492984B9}"/>
+                <a16:creationId xmlns:a16="http://schemas.microsoft.com/office/drawing/2014/main" id="{CE18FAA2-D72C-4133-B368-CEE8D039DE9A}"/>
               </a:ext>
             </a:extLst>
           </p:cNvPr>
@@ -4367,7 +4355,7 @@
     </p:spTree>
     <p:extLst>
       <p:ext uri="{BB962C8B-B14F-4D97-AF65-F5344CB8AC3E}">
-        <p14:creationId xmlns:p14="http://schemas.microsoft.com/office/powerpoint/2010/main" val="908829904"/>
+        <p14:creationId xmlns:p14="http://schemas.microsoft.com/office/powerpoint/2010/main" val="939593045"/>
       </p:ext>
     </p:extLst>
   </p:cSld>
@@ -4398,7 +4386,7 @@
           <p:cNvPr id="29" name="">
             <a:extLst xmlns:a="http://schemas.openxmlformats.org/drawingml/2006/main">
               <a:ext uri="{FF2B5EF4-FFF2-40B4-BE49-F238E27FC236}">
-                <a16:creationId xmlns:a16="http://schemas.microsoft.com/office/drawing/2014/main" id="{43B02E36-C599-4A4F-816A-27653C3C660E}"/>
+                <a16:creationId xmlns:a16="http://schemas.microsoft.com/office/drawing/2014/main" id="{E57A48EE-7652-4540-8B5F-E0C4D59DAE4A}"/>
               </a:ext>
             </a:extLst>
           </p:cNvPr>
@@ -4443,7 +4431,7 @@
           <p:cNvPr id="2" name="">
             <a:extLst xmlns:a="http://schemas.openxmlformats.org/drawingml/2006/main">
               <a:ext uri="{FF2B5EF4-FFF2-40B4-BE49-F238E27FC236}">
-                <a16:creationId xmlns:a16="http://schemas.microsoft.com/office/drawing/2014/main" id="{C2001038-B31A-4B98-ADC5-6C9BC270A238}"/>
+                <a16:creationId xmlns:a16="http://schemas.microsoft.com/office/drawing/2014/main" id="{8BE77A37-6968-4F85-ABF0-72C999CE879E}"/>
               </a:ext>
             </a:extLst>
           </p:cNvPr>
@@ -4473,7 +4461,7 @@
           <p:cNvPr id="3" name="">
             <a:extLst xmlns:a="http://schemas.openxmlformats.org/drawingml/2006/main">
               <a:ext uri="{FF2B5EF4-FFF2-40B4-BE49-F238E27FC236}">
-                <a16:creationId xmlns:a16="http://schemas.microsoft.com/office/drawing/2014/main" id="{EA46BDE2-E62C-4BF8-A7B1-8FC97AE5C3C4}"/>
+                <a16:creationId xmlns:a16="http://schemas.microsoft.com/office/drawing/2014/main" id="{EC0B1FD8-0296-48CA-8B80-EB5617263F74}"/>
               </a:ext>
             </a:extLst>
           </p:cNvPr>
@@ -4518,7 +4506,7 @@
           <p:cNvPr id="4" name="">
             <a:extLst xmlns:a="http://schemas.openxmlformats.org/drawingml/2006/main">
               <a:ext uri="{FF2B5EF4-FFF2-40B4-BE49-F238E27FC236}">
-                <a16:creationId xmlns:a16="http://schemas.microsoft.com/office/drawing/2014/main" id="{B5B693C0-EAA2-4246-9DDB-633745478776}"/>
+                <a16:creationId xmlns:a16="http://schemas.microsoft.com/office/drawing/2014/main" id="{F56374B2-1EB6-4D88-9CB7-3BB76243AB85}"/>
               </a:ext>
             </a:extLst>
           </p:cNvPr>
@@ -4563,7 +4551,7 @@
           <p:cNvPr id="5" name="">
             <a:extLst xmlns:a="http://schemas.openxmlformats.org/drawingml/2006/main">
               <a:ext uri="{FF2B5EF4-FFF2-40B4-BE49-F238E27FC236}">
-                <a16:creationId xmlns:a16="http://schemas.microsoft.com/office/drawing/2014/main" id="{1BBA93F7-732F-47CB-A93D-309FF8CBEBD5}"/>
+                <a16:creationId xmlns:a16="http://schemas.microsoft.com/office/drawing/2014/main" id="{29943380-9A93-4737-AD43-C70B74881F6B}"/>
               </a:ext>
             </a:extLst>
           </p:cNvPr>
@@ -4608,7 +4596,7 @@
           <p:cNvPr id="6" name="">
             <a:extLst xmlns:a="http://schemas.openxmlformats.org/drawingml/2006/main">
               <a:ext uri="{FF2B5EF4-FFF2-40B4-BE49-F238E27FC236}">
-                <a16:creationId xmlns:a16="http://schemas.microsoft.com/office/drawing/2014/main" id="{DA5DA816-2638-41A5-8D72-908D6081B5D8}"/>
+                <a16:creationId xmlns:a16="http://schemas.microsoft.com/office/drawing/2014/main" id="{6DDCA64C-BD4C-41A4-BCB7-2383B610148F}"/>
               </a:ext>
             </a:extLst>
           </p:cNvPr>
@@ -4640,7 +4628,7 @@
           <p:cNvPr id="7" name="">
             <a:extLst xmlns:a="http://schemas.openxmlformats.org/drawingml/2006/main">
               <a:ext uri="{FF2B5EF4-FFF2-40B4-BE49-F238E27FC236}">
-                <a16:creationId xmlns:a16="http://schemas.microsoft.com/office/drawing/2014/main" id="{1E79AE19-21E0-4A6E-AA54-9E4433BA4605}"/>
+                <a16:creationId xmlns:a16="http://schemas.microsoft.com/office/drawing/2014/main" id="{37754F06-6443-49BE-B43A-971E81E9EDCC}"/>
               </a:ext>
             </a:extLst>
           </p:cNvPr>
@@ -4672,7 +4660,7 @@
           <p:cNvPr id="8" name="">
             <a:extLst xmlns:a="http://schemas.openxmlformats.org/drawingml/2006/main">
               <a:ext uri="{FF2B5EF4-FFF2-40B4-BE49-F238E27FC236}">
-                <a16:creationId xmlns:a16="http://schemas.microsoft.com/office/drawing/2014/main" id="{17B9A4CC-7537-4BDF-81D2-CBCB56115368}"/>
+                <a16:creationId xmlns:a16="http://schemas.microsoft.com/office/drawing/2014/main" id="{F40C0710-29A0-44EE-AF38-622D341FE803}"/>
               </a:ext>
             </a:extLst>
           </p:cNvPr>
@@ -4704,7 +4692,7 @@
           <p:cNvPr id="9" name="">
             <a:extLst xmlns:a="http://schemas.openxmlformats.org/drawingml/2006/main">
               <a:ext uri="{FF2B5EF4-FFF2-40B4-BE49-F238E27FC236}">
-                <a16:creationId xmlns:a16="http://schemas.microsoft.com/office/drawing/2014/main" id="{9E746EE6-9B3A-484A-8FC4-A8DDA27F37F1}"/>
+                <a16:creationId xmlns:a16="http://schemas.microsoft.com/office/drawing/2014/main" id="{CD40F7E8-03F0-47BA-9733-4F6893799735}"/>
               </a:ext>
             </a:extLst>
           </p:cNvPr>
@@ -4749,7 +4737,7 @@
           <p:cNvPr id="10" name="">
             <a:extLst xmlns:a="http://schemas.openxmlformats.org/drawingml/2006/main">
               <a:ext uri="{FF2B5EF4-FFF2-40B4-BE49-F238E27FC236}">
-                <a16:creationId xmlns:a16="http://schemas.microsoft.com/office/drawing/2014/main" id="{DD55872A-81A7-4779-BF5D-67081D1DDB71}"/>
+                <a16:creationId xmlns:a16="http://schemas.microsoft.com/office/drawing/2014/main" id="{12AC0234-EF08-41C8-9347-BAE36C5151C8}"/>
               </a:ext>
             </a:extLst>
           </p:cNvPr>
@@ -4779,7 +4767,7 @@
           <p:cNvPr id="11" name="">
             <a:extLst xmlns:a="http://schemas.openxmlformats.org/drawingml/2006/main">
               <a:ext uri="{FF2B5EF4-FFF2-40B4-BE49-F238E27FC236}">
-                <a16:creationId xmlns:a16="http://schemas.microsoft.com/office/drawing/2014/main" id="{F4B628EA-B1A2-4027-B614-857317F382C4}"/>
+                <a16:creationId xmlns:a16="http://schemas.microsoft.com/office/drawing/2014/main" id="{E3EBE8BD-CE58-475B-825A-B985CE47C32E}"/>
               </a:ext>
             </a:extLst>
           </p:cNvPr>
@@ -4824,7 +4812,7 @@
           <p:cNvPr id="12" name="">
             <a:extLst xmlns:a="http://schemas.openxmlformats.org/drawingml/2006/main">
               <a:ext uri="{FF2B5EF4-FFF2-40B4-BE49-F238E27FC236}">
-                <a16:creationId xmlns:a16="http://schemas.microsoft.com/office/drawing/2014/main" id="{74EF305D-ADCE-48B5-9E8C-0C274BD437CB}"/>
+                <a16:creationId xmlns:a16="http://schemas.microsoft.com/office/drawing/2014/main" id="{F72851C4-5144-4CB2-827B-1ABEBBDB1110}"/>
               </a:ext>
             </a:extLst>
           </p:cNvPr>
@@ -4856,7 +4844,7 @@
           <p:cNvPr id="13" name="">
             <a:extLst xmlns:a="http://schemas.openxmlformats.org/drawingml/2006/main">
               <a:ext uri="{FF2B5EF4-FFF2-40B4-BE49-F238E27FC236}">
-                <a16:creationId xmlns:a16="http://schemas.microsoft.com/office/drawing/2014/main" id="{3B04BFB6-0905-4D94-8724-91EDE16AE2F5}"/>
+                <a16:creationId xmlns:a16="http://schemas.microsoft.com/office/drawing/2014/main" id="{B1A005E2-7188-4981-8554-F6F4EA29D4E7}"/>
               </a:ext>
             </a:extLst>
           </p:cNvPr>
@@ -4888,7 +4876,7 @@
           <p:cNvPr id="14" name="">
             <a:extLst xmlns:a="http://schemas.openxmlformats.org/drawingml/2006/main">
               <a:ext uri="{FF2B5EF4-FFF2-40B4-BE49-F238E27FC236}">
-                <a16:creationId xmlns:a16="http://schemas.microsoft.com/office/drawing/2014/main" id="{44AE3A98-44CF-4F77-BBEB-CC17A61D2AAA}"/>
+                <a16:creationId xmlns:a16="http://schemas.microsoft.com/office/drawing/2014/main" id="{2FC231E1-07DF-4A0A-A25D-8B51BB465E8B}"/>
               </a:ext>
             </a:extLst>
           </p:cNvPr>
@@ -4920,7 +4908,7 @@
           <p:cNvPr id="15" name="">
             <a:extLst xmlns:a="http://schemas.openxmlformats.org/drawingml/2006/main">
               <a:ext uri="{FF2B5EF4-FFF2-40B4-BE49-F238E27FC236}">
-                <a16:creationId xmlns:a16="http://schemas.microsoft.com/office/drawing/2014/main" id="{A9FB1F65-409A-44AC-86E1-8FB224D28D88}"/>
+                <a16:creationId xmlns:a16="http://schemas.microsoft.com/office/drawing/2014/main" id="{C5AAD455-1100-404A-ACCE-99475A396ED8}"/>
               </a:ext>
             </a:extLst>
           </p:cNvPr>
@@ -4965,7 +4953,7 @@
           <p:cNvPr id="16" name="">
             <a:extLst xmlns:a="http://schemas.openxmlformats.org/drawingml/2006/main">
               <a:ext uri="{FF2B5EF4-FFF2-40B4-BE49-F238E27FC236}">
-                <a16:creationId xmlns:a16="http://schemas.microsoft.com/office/drawing/2014/main" id="{51C6E4FB-48D6-47E3-9BFF-FB5AC3AA790C}"/>
+                <a16:creationId xmlns:a16="http://schemas.microsoft.com/office/drawing/2014/main" id="{B9C94F78-C9D4-471B-ACD2-0D50E4A42B75}"/>
               </a:ext>
             </a:extLst>
           </p:cNvPr>
@@ -4995,7 +4983,7 @@
           <p:cNvPr id="17" name="">
             <a:extLst xmlns:a="http://schemas.openxmlformats.org/drawingml/2006/main">
               <a:ext uri="{FF2B5EF4-FFF2-40B4-BE49-F238E27FC236}">
-                <a16:creationId xmlns:a16="http://schemas.microsoft.com/office/drawing/2014/main" id="{41D9E7B1-678B-4C9E-B5FB-E995D3A31D06}"/>
+                <a16:creationId xmlns:a16="http://schemas.microsoft.com/office/drawing/2014/main" id="{0642146F-8896-4942-9FFD-8ACEA50C2A69}"/>
               </a:ext>
             </a:extLst>
           </p:cNvPr>
@@ -5040,7 +5028,7 @@
           <p:cNvPr id="18" name="">
             <a:extLst xmlns:a="http://schemas.openxmlformats.org/drawingml/2006/main">
               <a:ext uri="{FF2B5EF4-FFF2-40B4-BE49-F238E27FC236}">
-                <a16:creationId xmlns:a16="http://schemas.microsoft.com/office/drawing/2014/main" id="{AC7311ED-961E-4DE7-9D8E-49CCAEE48D10}"/>
+                <a16:creationId xmlns:a16="http://schemas.microsoft.com/office/drawing/2014/main" id="{CFE530E6-FBAE-4963-93E7-886F04B55BCC}"/>
               </a:ext>
             </a:extLst>
           </p:cNvPr>
@@ -5072,7 +5060,7 @@
           <p:cNvPr id="19" name="">
             <a:extLst xmlns:a="http://schemas.openxmlformats.org/drawingml/2006/main">
               <a:ext uri="{FF2B5EF4-FFF2-40B4-BE49-F238E27FC236}">
-                <a16:creationId xmlns:a16="http://schemas.microsoft.com/office/drawing/2014/main" id="{04859C60-0F59-487D-85B1-E3042BA26C64}"/>
+                <a16:creationId xmlns:a16="http://schemas.microsoft.com/office/drawing/2014/main" id="{965CC9C7-3285-46EB-B1C0-251386EBE4B6}"/>
               </a:ext>
             </a:extLst>
           </p:cNvPr>
@@ -5104,7 +5092,7 @@
           <p:cNvPr id="20" name="">
             <a:extLst xmlns:a="http://schemas.openxmlformats.org/drawingml/2006/main">
               <a:ext uri="{FF2B5EF4-FFF2-40B4-BE49-F238E27FC236}">
-                <a16:creationId xmlns:a16="http://schemas.microsoft.com/office/drawing/2014/main" id="{05CB488B-C44B-49E9-8041-0883188557CE}"/>
+                <a16:creationId xmlns:a16="http://schemas.microsoft.com/office/drawing/2014/main" id="{A0804ED7-AEDC-46D8-AF8A-D13F96D8B9F8}"/>
               </a:ext>
             </a:extLst>
           </p:cNvPr>
@@ -5136,7 +5124,7 @@
           <p:cNvPr id="21" name="">
             <a:extLst xmlns:a="http://schemas.openxmlformats.org/drawingml/2006/main">
               <a:ext uri="{FF2B5EF4-FFF2-40B4-BE49-F238E27FC236}">
-                <a16:creationId xmlns:a16="http://schemas.microsoft.com/office/drawing/2014/main" id="{837D9F8B-4CD0-4CFA-AFB0-23DD83A296EF}"/>
+                <a16:creationId xmlns:a16="http://schemas.microsoft.com/office/drawing/2014/main" id="{D1A4F118-66B1-422D-81EE-21DF2232BE46}"/>
               </a:ext>
             </a:extLst>
           </p:cNvPr>
@@ -5181,7 +5169,7 @@
           <p:cNvPr id="22" name="">
             <a:extLst xmlns:a="http://schemas.openxmlformats.org/drawingml/2006/main">
               <a:ext uri="{FF2B5EF4-FFF2-40B4-BE49-F238E27FC236}">
-                <a16:creationId xmlns:a16="http://schemas.microsoft.com/office/drawing/2014/main" id="{996F28F0-E659-4D9A-87F4-60CC48C05C27}"/>
+                <a16:creationId xmlns:a16="http://schemas.microsoft.com/office/drawing/2014/main" id="{7815DBAE-7EA4-4B7E-AB92-95D7C9164606}"/>
               </a:ext>
             </a:extLst>
           </p:cNvPr>
@@ -5211,7 +5199,7 @@
           <p:cNvPr id="23" name="">
             <a:extLst xmlns:a="http://schemas.openxmlformats.org/drawingml/2006/main">
               <a:ext uri="{FF2B5EF4-FFF2-40B4-BE49-F238E27FC236}">
-                <a16:creationId xmlns:a16="http://schemas.microsoft.com/office/drawing/2014/main" id="{6B84ED23-FEDC-423A-906C-CFB7A0B54CD8}"/>
+                <a16:creationId xmlns:a16="http://schemas.microsoft.com/office/drawing/2014/main" id="{C98E40C4-2167-41B0-9D20-653D7A7EA86B}"/>
               </a:ext>
             </a:extLst>
           </p:cNvPr>
@@ -5241,7 +5229,7 @@
           <p:cNvPr id="24" name="">
             <a:extLst xmlns:a="http://schemas.openxmlformats.org/drawingml/2006/main">
               <a:ext uri="{FF2B5EF4-FFF2-40B4-BE49-F238E27FC236}">
-                <a16:creationId xmlns:a16="http://schemas.microsoft.com/office/drawing/2014/main" id="{EBF8C550-3C16-4011-94F6-8846C615B67A}"/>
+                <a16:creationId xmlns:a16="http://schemas.microsoft.com/office/drawing/2014/main" id="{32DBD944-5A50-4AED-852F-85156280549C}"/>
               </a:ext>
             </a:extLst>
           </p:cNvPr>
@@ -5286,7 +5274,7 @@
           <p:cNvPr id="25" name="">
             <a:extLst xmlns:a="http://schemas.openxmlformats.org/drawingml/2006/main">
               <a:ext uri="{FF2B5EF4-FFF2-40B4-BE49-F238E27FC236}">
-                <a16:creationId xmlns:a16="http://schemas.microsoft.com/office/drawing/2014/main" id="{0A39B664-F2AE-4C2A-A109-CD81D22F9CD7}"/>
+                <a16:creationId xmlns:a16="http://schemas.microsoft.com/office/drawing/2014/main" id="{AE260CA8-5F07-463B-A566-E7EAACB1158B}"/>
               </a:ext>
             </a:extLst>
           </p:cNvPr>
@@ -5331,7 +5319,7 @@
           <p:cNvPr id="26" name="">
             <a:extLst xmlns:a="http://schemas.openxmlformats.org/drawingml/2006/main">
               <a:ext uri="{FF2B5EF4-FFF2-40B4-BE49-F238E27FC236}">
-                <a16:creationId xmlns:a16="http://schemas.microsoft.com/office/drawing/2014/main" id="{E45C719B-4085-498E-B153-C067208A04F2}"/>
+                <a16:creationId xmlns:a16="http://schemas.microsoft.com/office/drawing/2014/main" id="{F7429049-F10F-4F18-8820-49687F01B565}"/>
               </a:ext>
             </a:extLst>
           </p:cNvPr>
@@ -5376,7 +5364,7 @@
           <p:cNvPr id="27" name="">
             <a:extLst xmlns:a="http://schemas.openxmlformats.org/drawingml/2006/main">
               <a:ext uri="{FF2B5EF4-FFF2-40B4-BE49-F238E27FC236}">
-                <a16:creationId xmlns:a16="http://schemas.microsoft.com/office/drawing/2014/main" id="{972677C9-24FC-4F68-AE9D-E745C0F4CF3D}"/>
+                <a16:creationId xmlns:a16="http://schemas.microsoft.com/office/drawing/2014/main" id="{CE1C3C00-8D44-4687-98E7-FA939230E3DA}"/>
               </a:ext>
             </a:extLst>
           </p:cNvPr>
@@ -5421,7 +5409,7 @@
           <p:cNvPr id="28" name="">
             <a:extLst xmlns:a="http://schemas.openxmlformats.org/drawingml/2006/main">
               <a:ext uri="{FF2B5EF4-FFF2-40B4-BE49-F238E27FC236}">
-                <a16:creationId xmlns:a16="http://schemas.microsoft.com/office/drawing/2014/main" id="{99010137-F9FF-4BF4-B84F-81B5BF9E7160}"/>
+                <a16:creationId xmlns:a16="http://schemas.microsoft.com/office/drawing/2014/main" id="{7C583CDF-4AB2-40BD-90AE-89BD1F0A5468}"/>
               </a:ext>
             </a:extLst>
           </p:cNvPr>
@@ -5464,7 +5452,7 @@
     </p:spTree>
     <p:extLst>
       <p:ext uri="{BB962C8B-B14F-4D97-AF65-F5344CB8AC3E}">
-        <p14:creationId xmlns:p14="http://schemas.microsoft.com/office/powerpoint/2010/main" val="642412264"/>
+        <p14:creationId xmlns:p14="http://schemas.microsoft.com/office/powerpoint/2010/main" val="298063405"/>
       </p:ext>
     </p:extLst>
   </p:cSld>
@@ -5495,7 +5483,7 @@
           <p:cNvPr id="15" name="">
             <a:extLst xmlns:a="http://schemas.openxmlformats.org/drawingml/2006/main">
               <a:ext uri="{FF2B5EF4-FFF2-40B4-BE49-F238E27FC236}">
-                <a16:creationId xmlns:a16="http://schemas.microsoft.com/office/drawing/2014/main" id="{765A061E-2B64-45FD-A7D0-80D5A98A62C2}"/>
+                <a16:creationId xmlns:a16="http://schemas.microsoft.com/office/drawing/2014/main" id="{235D8A48-309B-450D-9AA0-5DE13F41185F}"/>
               </a:ext>
             </a:extLst>
           </p:cNvPr>
@@ -5540,7 +5528,7 @@
           <p:cNvPr id="2" name="">
             <a:extLst xmlns:a="http://schemas.openxmlformats.org/drawingml/2006/main">
               <a:ext uri="{FF2B5EF4-FFF2-40B4-BE49-F238E27FC236}">
-                <a16:creationId xmlns:a16="http://schemas.microsoft.com/office/drawing/2014/main" id="{4C224ABD-D0AF-4831-B542-C2A23BDC3593}"/>
+                <a16:creationId xmlns:a16="http://schemas.microsoft.com/office/drawing/2014/main" id="{42EBD704-4BDE-4767-8992-AD702634F02C}"/>
               </a:ext>
             </a:extLst>
           </p:cNvPr>
@@ -5570,7 +5558,7 @@
           <p:cNvPr id="3" name="">
             <a:extLst xmlns:a="http://schemas.openxmlformats.org/drawingml/2006/main">
               <a:ext uri="{FF2B5EF4-FFF2-40B4-BE49-F238E27FC236}">
-                <a16:creationId xmlns:a16="http://schemas.microsoft.com/office/drawing/2014/main" id="{47AF6682-BAE4-4394-8690-6E79D912B81B}"/>
+                <a16:creationId xmlns:a16="http://schemas.microsoft.com/office/drawing/2014/main" id="{4F18428C-504E-4505-BC27-96C86784D4EC}"/>
               </a:ext>
             </a:extLst>
           </p:cNvPr>
@@ -5615,7 +5603,7 @@
           <p:cNvPr id="4" name="">
             <a:extLst xmlns:a="http://schemas.openxmlformats.org/drawingml/2006/main">
               <a:ext uri="{FF2B5EF4-FFF2-40B4-BE49-F238E27FC236}">
-                <a16:creationId xmlns:a16="http://schemas.microsoft.com/office/drawing/2014/main" id="{A2F14EDE-D2BC-4D69-986C-302916D13825}"/>
+                <a16:creationId xmlns:a16="http://schemas.microsoft.com/office/drawing/2014/main" id="{5F946B46-4B1B-4ABE-B3CC-0A6C70A438B3}"/>
               </a:ext>
             </a:extLst>
           </p:cNvPr>
@@ -5660,7 +5648,7 @@
           <p:cNvPr id="5" name="">
             <a:extLst xmlns:a="http://schemas.openxmlformats.org/drawingml/2006/main">
               <a:ext uri="{FF2B5EF4-FFF2-40B4-BE49-F238E27FC236}">
-                <a16:creationId xmlns:a16="http://schemas.microsoft.com/office/drawing/2014/main" id="{F679DFA3-755C-41E1-AAC9-56B3C0281CD7}"/>
+                <a16:creationId xmlns:a16="http://schemas.microsoft.com/office/drawing/2014/main" id="{BF27FE57-EBF0-4492-901E-B07A58631FD5}"/>
               </a:ext>
             </a:extLst>
           </p:cNvPr>
@@ -5692,7 +5680,7 @@
           <p:cNvPr id="6" name="">
             <a:extLst xmlns:a="http://schemas.openxmlformats.org/drawingml/2006/main">
               <a:ext uri="{FF2B5EF4-FFF2-40B4-BE49-F238E27FC236}">
-                <a16:creationId xmlns:a16="http://schemas.microsoft.com/office/drawing/2014/main" id="{E06DC108-746A-4105-BCAA-8B013835961A}"/>
+                <a16:creationId xmlns:a16="http://schemas.microsoft.com/office/drawing/2014/main" id="{E5E13740-D0F8-462F-A215-7883059BBA59}"/>
               </a:ext>
             </a:extLst>
           </p:cNvPr>
@@ -5724,7 +5712,7 @@
           <p:cNvPr id="7" name="">
             <a:extLst xmlns:a="http://schemas.openxmlformats.org/drawingml/2006/main">
               <a:ext uri="{FF2B5EF4-FFF2-40B4-BE49-F238E27FC236}">
-                <a16:creationId xmlns:a16="http://schemas.microsoft.com/office/drawing/2014/main" id="{B97F84B9-7426-4B5B-A8AE-33281E7BE891}"/>
+                <a16:creationId xmlns:a16="http://schemas.microsoft.com/office/drawing/2014/main" id="{621D1375-6055-4EFF-9787-6C327FBD857C}"/>
               </a:ext>
             </a:extLst>
           </p:cNvPr>
@@ -5756,7 +5744,7 @@
           <p:cNvPr id="8" name="">
             <a:extLst xmlns:a="http://schemas.openxmlformats.org/drawingml/2006/main">
               <a:ext uri="{FF2B5EF4-FFF2-40B4-BE49-F238E27FC236}">
-                <a16:creationId xmlns:a16="http://schemas.microsoft.com/office/drawing/2014/main" id="{EE37B65E-7CED-47B6-9D4D-5E25CAA8C0A3}"/>
+                <a16:creationId xmlns:a16="http://schemas.microsoft.com/office/drawing/2014/main" id="{1A2BC7C6-0FE2-41E9-895B-F970C1E49186}"/>
               </a:ext>
             </a:extLst>
           </p:cNvPr>
@@ -5801,7 +5789,7 @@
           <p:cNvPr id="9" name="">
             <a:extLst xmlns:a="http://schemas.openxmlformats.org/drawingml/2006/main">
               <a:ext uri="{FF2B5EF4-FFF2-40B4-BE49-F238E27FC236}">
-                <a16:creationId xmlns:a16="http://schemas.microsoft.com/office/drawing/2014/main" id="{6FCC6E87-8B8C-4D15-AEC0-2E55DB751426}"/>
+                <a16:creationId xmlns:a16="http://schemas.microsoft.com/office/drawing/2014/main" id="{121DD18C-3C4F-4815-B7C1-6309D05F5742}"/>
               </a:ext>
             </a:extLst>
           </p:cNvPr>
@@ -5846,7 +5834,7 @@
           <p:cNvPr id="10" name="">
             <a:extLst xmlns:a="http://schemas.openxmlformats.org/drawingml/2006/main">
               <a:ext uri="{FF2B5EF4-FFF2-40B4-BE49-F238E27FC236}">
-                <a16:creationId xmlns:a16="http://schemas.microsoft.com/office/drawing/2014/main" id="{3122CAE1-D0BC-4019-8344-8E8CFC147D33}"/>
+                <a16:creationId xmlns:a16="http://schemas.microsoft.com/office/drawing/2014/main" id="{6BFC541D-FB32-47E4-835C-736D8A660758}"/>
               </a:ext>
             </a:extLst>
           </p:cNvPr>
@@ -5878,7 +5866,7 @@
           <p:cNvPr id="11" name="">
             <a:extLst xmlns:a="http://schemas.openxmlformats.org/drawingml/2006/main">
               <a:ext uri="{FF2B5EF4-FFF2-40B4-BE49-F238E27FC236}">
-                <a16:creationId xmlns:a16="http://schemas.microsoft.com/office/drawing/2014/main" id="{90E444CD-C497-4B92-95A6-9F51514CB853}"/>
+                <a16:creationId xmlns:a16="http://schemas.microsoft.com/office/drawing/2014/main" id="{913FC954-F9A5-497E-97B0-2813D8975F8C}"/>
               </a:ext>
             </a:extLst>
           </p:cNvPr>
@@ -5910,7 +5898,7 @@
           <p:cNvPr id="12" name="">
             <a:extLst xmlns:a="http://schemas.openxmlformats.org/drawingml/2006/main">
               <a:ext uri="{FF2B5EF4-FFF2-40B4-BE49-F238E27FC236}">
-                <a16:creationId xmlns:a16="http://schemas.microsoft.com/office/drawing/2014/main" id="{3F30FBFC-02D3-4EC0-AC28-0F3A650241DF}"/>
+                <a16:creationId xmlns:a16="http://schemas.microsoft.com/office/drawing/2014/main" id="{78134293-C5F0-4D93-8916-70303102579F}"/>
               </a:ext>
             </a:extLst>
           </p:cNvPr>
@@ -5942,7 +5930,7 @@
           <p:cNvPr id="13" name="">
             <a:extLst xmlns:a="http://schemas.openxmlformats.org/drawingml/2006/main">
               <a:ext uri="{FF2B5EF4-FFF2-40B4-BE49-F238E27FC236}">
-                <a16:creationId xmlns:a16="http://schemas.microsoft.com/office/drawing/2014/main" id="{96F9E5DA-1B5B-4167-BC57-4D5EF226760A}"/>
+                <a16:creationId xmlns:a16="http://schemas.microsoft.com/office/drawing/2014/main" id="{DAF33DE7-4FAE-4890-82C3-BAF74D8C79D6}"/>
               </a:ext>
             </a:extLst>
           </p:cNvPr>
@@ -5987,7 +5975,7 @@
           <p:cNvPr id="14" name="">
             <a:extLst xmlns:a="http://schemas.openxmlformats.org/drawingml/2006/main">
               <a:ext uri="{FF2B5EF4-FFF2-40B4-BE49-F238E27FC236}">
-                <a16:creationId xmlns:a16="http://schemas.microsoft.com/office/drawing/2014/main" id="{C09C3F46-2449-405D-BB5A-6094E3FEBF31}"/>
+                <a16:creationId xmlns:a16="http://schemas.microsoft.com/office/drawing/2014/main" id="{5A6A18DA-B5E0-4110-B23C-F35FD33E652C}"/>
               </a:ext>
             </a:extLst>
           </p:cNvPr>
@@ -6030,7 +6018,7 @@
     </p:spTree>
     <p:extLst>
       <p:ext uri="{BB962C8B-B14F-4D97-AF65-F5344CB8AC3E}">
-        <p14:creationId xmlns:p14="http://schemas.microsoft.com/office/powerpoint/2010/main" val="2147422174"/>
+        <p14:creationId xmlns:p14="http://schemas.microsoft.com/office/powerpoint/2010/main" val="1004197667"/>
       </p:ext>
     </p:extLst>
   </p:cSld>
@@ -6061,7 +6049,7 @@
           <p:cNvPr id="20" name="">
             <a:extLst xmlns:a="http://schemas.openxmlformats.org/drawingml/2006/main">
               <a:ext uri="{FF2B5EF4-FFF2-40B4-BE49-F238E27FC236}">
-                <a16:creationId xmlns:a16="http://schemas.microsoft.com/office/drawing/2014/main" id="{410B444B-C51E-4889-88B1-CE3E85C447D1}"/>
+                <a16:creationId xmlns:a16="http://schemas.microsoft.com/office/drawing/2014/main" id="{12160E10-80D1-4873-ACCD-E248EF0E8E2F}"/>
               </a:ext>
             </a:extLst>
           </p:cNvPr>
@@ -6106,7 +6094,7 @@
           <p:cNvPr id="2" name="">
             <a:extLst xmlns:a="http://schemas.openxmlformats.org/drawingml/2006/main">
               <a:ext uri="{FF2B5EF4-FFF2-40B4-BE49-F238E27FC236}">
-                <a16:creationId xmlns:a16="http://schemas.microsoft.com/office/drawing/2014/main" id="{8BDE328E-5218-49CB-98CC-EE33768887AD}"/>
+                <a16:creationId xmlns:a16="http://schemas.microsoft.com/office/drawing/2014/main" id="{B2DEEAF6-69D5-4E07-A4EF-847EBD0E46D9}"/>
               </a:ext>
             </a:extLst>
           </p:cNvPr>
@@ -6136,7 +6124,7 @@
           <p:cNvPr id="3" name="">
             <a:extLst xmlns:a="http://schemas.openxmlformats.org/drawingml/2006/main">
               <a:ext uri="{FF2B5EF4-FFF2-40B4-BE49-F238E27FC236}">
-                <a16:creationId xmlns:a16="http://schemas.microsoft.com/office/drawing/2014/main" id="{8E2AAEEF-B888-4FE0-B4DE-F3CF99C15DA1}"/>
+                <a16:creationId xmlns:a16="http://schemas.microsoft.com/office/drawing/2014/main" id="{C611B946-8CA4-4106-9BB0-4A1BF8767D91}"/>
               </a:ext>
             </a:extLst>
           </p:cNvPr>
@@ -6181,7 +6169,7 @@
           <p:cNvPr id="4" name="">
             <a:extLst xmlns:a="http://schemas.openxmlformats.org/drawingml/2006/main">
               <a:ext uri="{FF2B5EF4-FFF2-40B4-BE49-F238E27FC236}">
-                <a16:creationId xmlns:a16="http://schemas.microsoft.com/office/drawing/2014/main" id="{3693E3B2-DF85-4C0E-AA5D-9E0C3D4CCC4D}"/>
+                <a16:creationId xmlns:a16="http://schemas.microsoft.com/office/drawing/2014/main" id="{4D1ABFA0-BCA8-4977-A2EA-4D0B30B050A2}"/>
               </a:ext>
             </a:extLst>
           </p:cNvPr>
@@ -6226,7 +6214,7 @@
           <p:cNvPr id="5" name="">
             <a:extLst xmlns:a="http://schemas.openxmlformats.org/drawingml/2006/main">
               <a:ext uri="{FF2B5EF4-FFF2-40B4-BE49-F238E27FC236}">
-                <a16:creationId xmlns:a16="http://schemas.microsoft.com/office/drawing/2014/main" id="{17BC88C0-3C43-4EF0-8760-B951C1C232A4}"/>
+                <a16:creationId xmlns:a16="http://schemas.microsoft.com/office/drawing/2014/main" id="{33C86966-D340-4B3F-839D-AB3770337956}"/>
               </a:ext>
             </a:extLst>
           </p:cNvPr>
@@ -6258,7 +6246,7 @@
           <p:cNvPr id="6" name="">
             <a:extLst xmlns:a="http://schemas.openxmlformats.org/drawingml/2006/main">
               <a:ext uri="{FF2B5EF4-FFF2-40B4-BE49-F238E27FC236}">
-                <a16:creationId xmlns:a16="http://schemas.microsoft.com/office/drawing/2014/main" id="{9E320794-C25A-4839-8860-EA2B91A2CDAD}"/>
+                <a16:creationId xmlns:a16="http://schemas.microsoft.com/office/drawing/2014/main" id="{9FEF53F8-D1D0-4909-B1E1-DE3E34CDE1CB}"/>
               </a:ext>
             </a:extLst>
           </p:cNvPr>
@@ -6329,7 +6317,7 @@
           <p:cNvPr id="7" name="">
             <a:extLst xmlns:a="http://schemas.openxmlformats.org/drawingml/2006/main">
               <a:ext uri="{FF2B5EF4-FFF2-40B4-BE49-F238E27FC236}">
-                <a16:creationId xmlns:a16="http://schemas.microsoft.com/office/drawing/2014/main" id="{DCC9342B-A440-49DC-A3B7-9F514187F553}"/>
+                <a16:creationId xmlns:a16="http://schemas.microsoft.com/office/drawing/2014/main" id="{9C9F7E01-5985-4AF8-A196-56FB27E7A4DA}"/>
               </a:ext>
             </a:extLst>
           </p:cNvPr>
@@ -6374,7 +6362,7 @@
           <p:cNvPr id="8" name="">
             <a:extLst xmlns:a="http://schemas.openxmlformats.org/drawingml/2006/main">
               <a:ext uri="{FF2B5EF4-FFF2-40B4-BE49-F238E27FC236}">
-                <a16:creationId xmlns:a16="http://schemas.microsoft.com/office/drawing/2014/main" id="{0A28EABF-FB5A-4E81-9942-5539C8CFD18D}"/>
+                <a16:creationId xmlns:a16="http://schemas.microsoft.com/office/drawing/2014/main" id="{82E0D6C1-8B12-4F0C-9217-17E389D0B30D}"/>
               </a:ext>
             </a:extLst>
           </p:cNvPr>
@@ -6406,7 +6394,7 @@
           <p:cNvPr id="9" name="">
             <a:extLst xmlns:a="http://schemas.openxmlformats.org/drawingml/2006/main">
               <a:ext uri="{FF2B5EF4-FFF2-40B4-BE49-F238E27FC236}">
-                <a16:creationId xmlns:a16="http://schemas.microsoft.com/office/drawing/2014/main" id="{632C8C73-9262-4AF5-9396-22D5E0F0C946}"/>
+                <a16:creationId xmlns:a16="http://schemas.microsoft.com/office/drawing/2014/main" id="{E4925D2C-133B-4AC2-A573-3B607BCA573E}"/>
               </a:ext>
             </a:extLst>
           </p:cNvPr>
@@ -6438,7 +6426,7 @@
           <p:cNvPr id="10" name="">
             <a:extLst xmlns:a="http://schemas.openxmlformats.org/drawingml/2006/main">
               <a:ext uri="{FF2B5EF4-FFF2-40B4-BE49-F238E27FC236}">
-                <a16:creationId xmlns:a16="http://schemas.microsoft.com/office/drawing/2014/main" id="{9E30B800-F6DC-4818-8318-6382A45402B7}"/>
+                <a16:creationId xmlns:a16="http://schemas.microsoft.com/office/drawing/2014/main" id="{EC163119-7449-4DE3-B8D7-1DEF6BA9D529}"/>
               </a:ext>
             </a:extLst>
           </p:cNvPr>
@@ -6483,7 +6471,7 @@
           <p:cNvPr id="11" name="">
             <a:extLst xmlns:a="http://schemas.openxmlformats.org/drawingml/2006/main">
               <a:ext uri="{FF2B5EF4-FFF2-40B4-BE49-F238E27FC236}">
-                <a16:creationId xmlns:a16="http://schemas.microsoft.com/office/drawing/2014/main" id="{3189AC21-4931-4CED-992A-4605D2AE02FE}"/>
+                <a16:creationId xmlns:a16="http://schemas.microsoft.com/office/drawing/2014/main" id="{2A650142-7EBA-4BEF-BC5B-3BF06AE69D37}"/>
               </a:ext>
             </a:extLst>
           </p:cNvPr>
@@ -6528,7 +6516,7 @@
           <p:cNvPr id="12" name="">
             <a:extLst xmlns:a="http://schemas.openxmlformats.org/drawingml/2006/main">
               <a:ext uri="{FF2B5EF4-FFF2-40B4-BE49-F238E27FC236}">
-                <a16:creationId xmlns:a16="http://schemas.microsoft.com/office/drawing/2014/main" id="{052E2D93-2AE9-45E0-AECF-896A487E2706}"/>
+                <a16:creationId xmlns:a16="http://schemas.microsoft.com/office/drawing/2014/main" id="{75C2F24F-DB16-4D3F-8698-9BCC6DABECD8}"/>
               </a:ext>
             </a:extLst>
           </p:cNvPr>
@@ -6573,7 +6561,7 @@
           <p:cNvPr id="13" name="">
             <a:extLst xmlns:a="http://schemas.openxmlformats.org/drawingml/2006/main">
               <a:ext uri="{FF2B5EF4-FFF2-40B4-BE49-F238E27FC236}">
-                <a16:creationId xmlns:a16="http://schemas.microsoft.com/office/drawing/2014/main" id="{5A659BDD-41E6-4FB3-B2EF-B9C07A4A353B}"/>
+                <a16:creationId xmlns:a16="http://schemas.microsoft.com/office/drawing/2014/main" id="{24A327AA-859C-41B1-9BE9-47BC930C1D8F}"/>
               </a:ext>
             </a:extLst>
           </p:cNvPr>
@@ -6605,7 +6593,7 @@
           <p:cNvPr id="14" name="">
             <a:extLst xmlns:a="http://schemas.openxmlformats.org/drawingml/2006/main">
               <a:ext uri="{FF2B5EF4-FFF2-40B4-BE49-F238E27FC236}">
-                <a16:creationId xmlns:a16="http://schemas.microsoft.com/office/drawing/2014/main" id="{B566DD6A-AF8E-4F0E-89DB-0C0E92499D98}"/>
+                <a16:creationId xmlns:a16="http://schemas.microsoft.com/office/drawing/2014/main" id="{90273DEA-CF34-46BE-A4BB-E7A069A32495}"/>
               </a:ext>
             </a:extLst>
           </p:cNvPr>
@@ -6637,7 +6625,7 @@
           <p:cNvPr id="15" name="">
             <a:extLst xmlns:a="http://schemas.openxmlformats.org/drawingml/2006/main">
               <a:ext uri="{FF2B5EF4-FFF2-40B4-BE49-F238E27FC236}">
-                <a16:creationId xmlns:a16="http://schemas.microsoft.com/office/drawing/2014/main" id="{37A1E445-AC6A-40CA-A356-8A6F1E0C0ABE}"/>
+                <a16:creationId xmlns:a16="http://schemas.microsoft.com/office/drawing/2014/main" id="{797A4FF3-C532-4F6C-8BC0-1D6529559F84}"/>
               </a:ext>
             </a:extLst>
           </p:cNvPr>
@@ -6669,7 +6657,7 @@
           <p:cNvPr id="16" name="">
             <a:extLst xmlns:a="http://schemas.openxmlformats.org/drawingml/2006/main">
               <a:ext uri="{FF2B5EF4-FFF2-40B4-BE49-F238E27FC236}">
-                <a16:creationId xmlns:a16="http://schemas.microsoft.com/office/drawing/2014/main" id="{EF3862AD-C493-46AD-84EA-AA572B2043FB}"/>
+                <a16:creationId xmlns:a16="http://schemas.microsoft.com/office/drawing/2014/main" id="{5024BEE1-D249-43BB-A282-2A1010891D0F}"/>
               </a:ext>
             </a:extLst>
           </p:cNvPr>
@@ -6714,7 +6702,7 @@
           <p:cNvPr id="17" name="">
             <a:extLst xmlns:a="http://schemas.openxmlformats.org/drawingml/2006/main">
               <a:ext uri="{FF2B5EF4-FFF2-40B4-BE49-F238E27FC236}">
-                <a16:creationId xmlns:a16="http://schemas.microsoft.com/office/drawing/2014/main" id="{93E1F6B8-FB5D-4836-BF0E-B89741493568}"/>
+                <a16:creationId xmlns:a16="http://schemas.microsoft.com/office/drawing/2014/main" id="{8EF6E008-FB53-4E6E-A9EB-DE8B22A7BAA7}"/>
               </a:ext>
             </a:extLst>
           </p:cNvPr>
@@ -6759,7 +6747,7 @@
           <p:cNvPr id="18" name="">
             <a:extLst xmlns:a="http://schemas.openxmlformats.org/drawingml/2006/main">
               <a:ext uri="{FF2B5EF4-FFF2-40B4-BE49-F238E27FC236}">
-                <a16:creationId xmlns:a16="http://schemas.microsoft.com/office/drawing/2014/main" id="{74FB4767-1894-406A-968F-7E13A952E3E5}"/>
+                <a16:creationId xmlns:a16="http://schemas.microsoft.com/office/drawing/2014/main" id="{90B1A712-2F5D-4989-AAA2-CDDCEA3258C6}"/>
               </a:ext>
             </a:extLst>
           </p:cNvPr>
@@ -6794,7 +6782,7 @@
                 <a:ea typeface="Arial"/>
                 <a:cs typeface="Arial"/>
               </a:rPr>
-              <a:t>Full-resolution region width: 0.1×, 0.25×, 0.5×, 0.75×</a:t>
+              <a:t>Full-resolution region width: 0.1×, 0.25×, 0.5×</a:t>
             </a:r>
           </a:p>
         </p:txBody>
@@ -6804,7 +6792,7 @@
           <p:cNvPr id="19" name="">
             <a:extLst xmlns:a="http://schemas.openxmlformats.org/drawingml/2006/main">
               <a:ext uri="{FF2B5EF4-FFF2-40B4-BE49-F238E27FC236}">
-                <a16:creationId xmlns:a16="http://schemas.microsoft.com/office/drawing/2014/main" id="{078715CB-92A6-47B6-AD82-6F29E6E4E0DF}"/>
+                <a16:creationId xmlns:a16="http://schemas.microsoft.com/office/drawing/2014/main" id="{F8F14F78-1956-4EF4-9486-57568E8895DD}"/>
               </a:ext>
             </a:extLst>
           </p:cNvPr>
@@ -6847,7 +6835,7 @@
     </p:spTree>
     <p:extLst>
       <p:ext uri="{BB962C8B-B14F-4D97-AF65-F5344CB8AC3E}">
-        <p14:creationId xmlns:p14="http://schemas.microsoft.com/office/powerpoint/2010/main" val="2028844609"/>
+        <p14:creationId xmlns:p14="http://schemas.microsoft.com/office/powerpoint/2010/main" val="1968107453"/>
       </p:ext>
     </p:extLst>
   </p:cSld>
@@ -6878,7 +6866,7 @@
           <p:cNvPr id="12" name="">
             <a:extLst xmlns:a="http://schemas.openxmlformats.org/drawingml/2006/main">
               <a:ext uri="{FF2B5EF4-FFF2-40B4-BE49-F238E27FC236}">
-                <a16:creationId xmlns:a16="http://schemas.microsoft.com/office/drawing/2014/main" id="{6361B034-0E03-4A3A-B60A-725BF61BEAC5}"/>
+                <a16:creationId xmlns:a16="http://schemas.microsoft.com/office/drawing/2014/main" id="{787E003F-CA2B-4A50-B33A-D8C95C688FBC}"/>
               </a:ext>
             </a:extLst>
           </p:cNvPr>
@@ -6923,7 +6911,7 @@
           <p:cNvPr id="2" name="">
             <a:extLst xmlns:a="http://schemas.openxmlformats.org/drawingml/2006/main">
               <a:ext uri="{FF2B5EF4-FFF2-40B4-BE49-F238E27FC236}">
-                <a16:creationId xmlns:a16="http://schemas.microsoft.com/office/drawing/2014/main" id="{96ECD673-CD30-486E-8726-2E28CBF9BA04}"/>
+                <a16:creationId xmlns:a16="http://schemas.microsoft.com/office/drawing/2014/main" id="{93CF75C9-6297-40F4-BBA6-9492432EE5C3}"/>
               </a:ext>
             </a:extLst>
           </p:cNvPr>
@@ -6953,7 +6941,7 @@
           <p:cNvPr id="3" name="">
             <a:extLst xmlns:a="http://schemas.openxmlformats.org/drawingml/2006/main">
               <a:ext uri="{FF2B5EF4-FFF2-40B4-BE49-F238E27FC236}">
-                <a16:creationId xmlns:a16="http://schemas.microsoft.com/office/drawing/2014/main" id="{2DDFD84A-E1A8-423E-A924-E5B471BC38ED}"/>
+                <a16:creationId xmlns:a16="http://schemas.microsoft.com/office/drawing/2014/main" id="{0634ADD6-BEFB-4184-B614-FEBA084354A1}"/>
               </a:ext>
             </a:extLst>
           </p:cNvPr>
@@ -6998,7 +6986,7 @@
           <p:cNvPr id="4" name="Chart">
             <a:extLst xmlns:a="http://schemas.openxmlformats.org/drawingml/2006/main">
               <a:ext uri="{FF2B5EF4-FFF2-40B4-BE49-F238E27FC236}">
-                <a16:creationId xmlns:a16="http://schemas.microsoft.com/office/drawing/2014/main" id="{7FFD565B-E74F-4B7B-8BEF-96B9369D3738}"/>
+                <a16:creationId xmlns:a16="http://schemas.microsoft.com/office/drawing/2014/main" id="{B886552D-D426-4B67-9A22-F4C1B9418EA2}"/>
               </a:ext>
             </a:extLst>
           </p:cNvPr>
@@ -7011,7 +6999,7 @@
         </p:xfrm>
         <a:graphic xmlns:a="http://schemas.openxmlformats.org/drawingml/2006/main">
           <a:graphicData uri="http://schemas.openxmlformats.org/drawingml/2006/chart">
-            <c:chart xmlns:r="http://schemas.openxmlformats.org/officeDocument/2006/relationships" xmlns:c="http://schemas.openxmlformats.org/drawingml/2006/chart" r:id="Re03d09c5d506474d"/>
+            <c:chart xmlns:r="http://schemas.openxmlformats.org/officeDocument/2006/relationships" xmlns:c="http://schemas.openxmlformats.org/drawingml/2006/chart" r:id="Rcace51438dbf4d65"/>
           </a:graphicData>
         </a:graphic>
       </p:graphicFrame>
@@ -7020,7 +7008,7 @@
           <p:cNvPr id="5" name="">
             <a:extLst xmlns:a="http://schemas.openxmlformats.org/drawingml/2006/main">
               <a:ext uri="{FF2B5EF4-FFF2-40B4-BE49-F238E27FC236}">
-                <a16:creationId xmlns:a16="http://schemas.microsoft.com/office/drawing/2014/main" id="{E3B18D00-8C1B-4B62-A646-86E637B0833F}"/>
+                <a16:creationId xmlns:a16="http://schemas.microsoft.com/office/drawing/2014/main" id="{FCB420D4-4060-4203-9D09-136A09C22697}"/>
               </a:ext>
             </a:extLst>
           </p:cNvPr>
@@ -7065,7 +7053,7 @@
           <p:cNvPr id="6" name="">
             <a:extLst xmlns:a="http://schemas.openxmlformats.org/drawingml/2006/main">
               <a:ext uri="{FF2B5EF4-FFF2-40B4-BE49-F238E27FC236}">
-                <a16:creationId xmlns:a16="http://schemas.microsoft.com/office/drawing/2014/main" id="{01A56016-B867-4E67-B90B-80C353DB1DB4}"/>
+                <a16:creationId xmlns:a16="http://schemas.microsoft.com/office/drawing/2014/main" id="{A1A92C47-6C49-48BD-A3BA-D12957501D3B}"/>
               </a:ext>
             </a:extLst>
           </p:cNvPr>
@@ -7110,7 +7098,7 @@
           <p:cNvPr id="7" name="">
             <a:extLst xmlns:a="http://schemas.openxmlformats.org/drawingml/2006/main">
               <a:ext uri="{FF2B5EF4-FFF2-40B4-BE49-F238E27FC236}">
-                <a16:creationId xmlns:a16="http://schemas.microsoft.com/office/drawing/2014/main" id="{18BFCCA9-1ECE-40EC-A3BA-71407D23A775}"/>
+                <a16:creationId xmlns:a16="http://schemas.microsoft.com/office/drawing/2014/main" id="{DC57521F-AB3E-41DD-96AF-D8CEE093EDD2}"/>
               </a:ext>
             </a:extLst>
           </p:cNvPr>
@@ -7155,7 +7143,7 @@
           <p:cNvPr id="8" name="">
             <a:extLst xmlns:a="http://schemas.openxmlformats.org/drawingml/2006/main">
               <a:ext uri="{FF2B5EF4-FFF2-40B4-BE49-F238E27FC236}">
-                <a16:creationId xmlns:a16="http://schemas.microsoft.com/office/drawing/2014/main" id="{7B5C357C-DF8B-48C5-B661-AB67BF267C9A}"/>
+                <a16:creationId xmlns:a16="http://schemas.microsoft.com/office/drawing/2014/main" id="{476675CE-E416-4ABF-9A14-554DD593E8EA}"/>
               </a:ext>
             </a:extLst>
           </p:cNvPr>
@@ -7200,7 +7188,7 @@
           <p:cNvPr id="9" name="">
             <a:extLst xmlns:a="http://schemas.openxmlformats.org/drawingml/2006/main">
               <a:ext uri="{FF2B5EF4-FFF2-40B4-BE49-F238E27FC236}">
-                <a16:creationId xmlns:a16="http://schemas.microsoft.com/office/drawing/2014/main" id="{CD63A0AB-D86B-411E-8D73-B0948BF7B6AF}"/>
+                <a16:creationId xmlns:a16="http://schemas.microsoft.com/office/drawing/2014/main" id="{C0C2F7C3-8CC3-4F30-B3BA-E1BE23C65FED}"/>
               </a:ext>
             </a:extLst>
           </p:cNvPr>
@@ -7245,7 +7233,7 @@
           <p:cNvPr id="10" name="">
             <a:extLst xmlns:a="http://schemas.openxmlformats.org/drawingml/2006/main">
               <a:ext uri="{FF2B5EF4-FFF2-40B4-BE49-F238E27FC236}">
-                <a16:creationId xmlns:a16="http://schemas.microsoft.com/office/drawing/2014/main" id="{3F474BB0-FC29-4A2C-ACBB-239A693A67C8}"/>
+                <a16:creationId xmlns:a16="http://schemas.microsoft.com/office/drawing/2014/main" id="{1C0D56BB-C3F9-4301-955C-A076030CBBA6}"/>
               </a:ext>
             </a:extLst>
           </p:cNvPr>
@@ -7290,7 +7278,7 @@
           <p:cNvPr id="11" name="">
             <a:extLst xmlns:a="http://schemas.openxmlformats.org/drawingml/2006/main">
               <a:ext uri="{FF2B5EF4-FFF2-40B4-BE49-F238E27FC236}">
-                <a16:creationId xmlns:a16="http://schemas.microsoft.com/office/drawing/2014/main" id="{9B8B0DAF-1E89-47E3-A431-A363FB2B9371}"/>
+                <a16:creationId xmlns:a16="http://schemas.microsoft.com/office/drawing/2014/main" id="{083FDFF0-1BAB-4DD4-89C1-D61FB699B399}"/>
               </a:ext>
             </a:extLst>
           </p:cNvPr>
@@ -7333,7 +7321,7 @@
     </p:spTree>
     <p:extLst>
       <p:ext uri="{BB962C8B-B14F-4D97-AF65-F5344CB8AC3E}">
-        <p14:creationId xmlns:p14="http://schemas.microsoft.com/office/powerpoint/2010/main" val="214652951"/>
+        <p14:creationId xmlns:p14="http://schemas.microsoft.com/office/powerpoint/2010/main" val="1841926725"/>
       </p:ext>
     </p:extLst>
   </p:cSld>
@@ -7364,7 +7352,7 @@
           <p:cNvPr id="8" name="">
             <a:extLst xmlns:a="http://schemas.openxmlformats.org/drawingml/2006/main">
               <a:ext uri="{FF2B5EF4-FFF2-40B4-BE49-F238E27FC236}">
-                <a16:creationId xmlns:a16="http://schemas.microsoft.com/office/drawing/2014/main" id="{E7499C8F-677E-452E-8AB0-B3AB35802E48}"/>
+                <a16:creationId xmlns:a16="http://schemas.microsoft.com/office/drawing/2014/main" id="{2D27BD5C-1D53-4591-B927-ADEFEF998F8F}"/>
               </a:ext>
             </a:extLst>
           </p:cNvPr>
@@ -7409,7 +7397,7 @@
           <p:cNvPr id="2" name="">
             <a:extLst xmlns:a="http://schemas.openxmlformats.org/drawingml/2006/main">
               <a:ext uri="{FF2B5EF4-FFF2-40B4-BE49-F238E27FC236}">
-                <a16:creationId xmlns:a16="http://schemas.microsoft.com/office/drawing/2014/main" id="{D6974AA6-01A6-4885-AB7B-DD352FFC9052}"/>
+                <a16:creationId xmlns:a16="http://schemas.microsoft.com/office/drawing/2014/main" id="{6238650C-9037-4AB2-95F7-F6BBF6253FF6}"/>
               </a:ext>
             </a:extLst>
           </p:cNvPr>
@@ -7439,7 +7427,7 @@
           <p:cNvPr id="3" name="">
             <a:extLst xmlns:a="http://schemas.openxmlformats.org/drawingml/2006/main">
               <a:ext uri="{FF2B5EF4-FFF2-40B4-BE49-F238E27FC236}">
-                <a16:creationId xmlns:a16="http://schemas.microsoft.com/office/drawing/2014/main" id="{3CB516E5-504C-4F59-AA11-7BC137A20C37}"/>
+                <a16:creationId xmlns:a16="http://schemas.microsoft.com/office/drawing/2014/main" id="{E0063598-DD78-42F3-9F07-68FFA4250A95}"/>
               </a:ext>
             </a:extLst>
           </p:cNvPr>
@@ -7484,7 +7472,7 @@
           <p:cNvPr id="4" name="">
             <a:extLst xmlns:a="http://schemas.openxmlformats.org/drawingml/2006/main">
               <a:ext uri="{FF2B5EF4-FFF2-40B4-BE49-F238E27FC236}">
-                <a16:creationId xmlns:a16="http://schemas.microsoft.com/office/drawing/2014/main" id="{6B1A04D3-D71D-411C-BD6D-6D2A05525EDF}"/>
+                <a16:creationId xmlns:a16="http://schemas.microsoft.com/office/drawing/2014/main" id="{49E244F8-0B9B-4822-8D52-6F832A090294}"/>
               </a:ext>
             </a:extLst>
           </p:cNvPr>
@@ -7500,19 +7488,18 @@
             <a:tbl>
               <a:tblPr/>
               <a:tblGrid>
-                <a:gridCol w="2524125"/>
-                <a:gridCol w="2619375"/>
-                <a:gridCol w="2724150"/>
-                <a:gridCol w="3105150"/>
+                <a:gridCol w="3238500"/>
+                <a:gridCol w="3714750"/>
+                <a:gridCol w="4019550"/>
               </a:tblGrid>
-              <a:tr h="641985">
+              <a:tr h="802481">
                 <a:tc>
                   <a:txBody>
                     <a:bodyPr/>
                     <a:lstStyle/>
                     <a:p>
                       <a:r>
-                        <a:rPr sz="1800" b="1">
+                        <a:rPr sz="2025" b="1">
                           <a:solidFill>
                             <a:srgbClr val="FFFFFF"/>
                           </a:solidFill>
@@ -7560,7 +7547,7 @@
                     <a:lstStyle/>
                     <a:p>
                       <a:r>
-                        <a:rPr sz="1800" b="1">
+                        <a:rPr sz="2025" b="1">
                           <a:solidFill>
                             <a:srgbClr val="FFFFFF"/>
                           </a:solidFill>
@@ -7602,7 +7589,7 @@
                     <a:lstStyle/>
                     <a:p>
                       <a:r>
-                        <a:rPr sz="1800" b="1">
+                        <a:rPr sz="2025" b="1">
                           <a:solidFill>
                             <a:srgbClr val="FFFFFF"/>
                           </a:solidFill>
@@ -7610,49 +7597,7 @@
                           <a:ea typeface="Arial"/>
                           <a:cs typeface="Arial"/>
                         </a:rPr>
-                        <a:t>Right-eye ΔPSNR</a:t>
-                      </a:r>
-                    </a:p>
-                  </a:txBody>
-                  <a:tcPr marL="91440" marR="91440" marT="45720" marB="45720">
-                    <a:lnR w="9525">
-                      <a:solidFill>
-                        <a:srgbClr val="D7DFE5"/>
-                      </a:solidFill>
-                      <a:prstDash val="solid"/>
-                    </a:lnR>
-                    <a:lnT w="9525">
-                      <a:solidFill>
-                        <a:srgbClr val="D7DFE5"/>
-                      </a:solidFill>
-                      <a:prstDash val="solid"/>
-                    </a:lnT>
-                    <a:lnB w="9525">
-                      <a:solidFill>
-                        <a:srgbClr val="D7DFE5"/>
-                      </a:solidFill>
-                      <a:prstDash val="solid"/>
-                    </a:lnB>
-                    <a:solidFill>
-                      <a:srgbClr val="152D43"/>
-                    </a:solidFill>
-                  </a:tcPr>
-                </a:tc>
-                <a:tc>
-                  <a:txBody>
-                    <a:bodyPr/>
-                    <a:lstStyle/>
-                    <a:p>
-                      <a:r>
-                        <a:rPr sz="1800" b="1">
-                          <a:solidFill>
-                            <a:srgbClr val="FFFFFF"/>
-                          </a:solidFill>
-                          <a:latin typeface="Arial"/>
-                          <a:ea typeface="Arial"/>
-                          <a:cs typeface="Arial"/>
-                        </a:rPr>
-                        <a:t>Stereo mean ΔPSNR*</a:t>
+                        <a:t>Stereo PSNR loss (dB)</a:t>
                       </a:r>
                     </a:p>
                   </a:txBody>
@@ -7681,14 +7626,14 @@
                   </a:tcPr>
                 </a:tc>
               </a:tr>
-              <a:tr h="641985">
+              <a:tr h="802481">
                 <a:tc>
                   <a:txBody>
                     <a:bodyPr/>
                     <a:lstStyle/>
                     <a:p>
                       <a:r>
-                        <a:rPr sz="1800" b="0">
+                        <a:rPr sz="2025" b="0">
                           <a:solidFill>
                             <a:srgbClr val="152D43"/>
                           </a:solidFill>
@@ -7730,7 +7675,7 @@
                     <a:lstStyle/>
                     <a:p>
                       <a:r>
-                        <a:rPr sz="1800" b="0">
+                        <a:rPr sz="2025" b="0">
                           <a:solidFill>
                             <a:srgbClr val="152D43"/>
                           </a:solidFill>
@@ -7766,7 +7711,7 @@
                     <a:lstStyle/>
                     <a:p>
                       <a:r>
-                        <a:rPr sz="1800" b="0">
+                        <a:rPr sz="2025" b="0">
                           <a:solidFill>
                             <a:srgbClr val="152D43"/>
                           </a:solidFill>
@@ -7774,43 +7719,7 @@
                           <a:ea typeface="Arial"/>
                           <a:cs typeface="Arial"/>
                         </a:rPr>
-                        <a:t>-0.1718 dB</a:t>
-                      </a:r>
-                    </a:p>
-                  </a:txBody>
-                  <a:tcPr marL="91440" marR="91440" marT="45720" marB="45720">
-                    <a:lnR w="9525">
-                      <a:solidFill>
-                        <a:srgbClr val="D7DFE5"/>
-                      </a:solidFill>
-                      <a:prstDash val="solid"/>
-                    </a:lnR>
-                    <a:lnB w="9525">
-                      <a:solidFill>
-                        <a:srgbClr val="D7DFE5"/>
-                      </a:solidFill>
-                      <a:prstDash val="solid"/>
-                    </a:lnB>
-                    <a:solidFill>
-                      <a:srgbClr val="FFFFFF"/>
-                    </a:solidFill>
-                  </a:tcPr>
-                </a:tc>
-                <a:tc>
-                  <a:txBody>
-                    <a:bodyPr/>
-                    <a:lstStyle/>
-                    <a:p>
-                      <a:r>
-                        <a:rPr sz="1800" b="0">
-                          <a:solidFill>
-                            <a:srgbClr val="152D43"/>
-                          </a:solidFill>
-                          <a:latin typeface="Arial"/>
-                          <a:ea typeface="Arial"/>
-                          <a:cs typeface="Arial"/>
-                        </a:rPr>
-                        <a:t>-0.0859 dB</a:t>
+                        <a:t>0.0859</a:t>
                       </a:r>
                     </a:p>
                   </a:txBody>
@@ -7833,14 +7742,14 @@
                   </a:tcPr>
                 </a:tc>
               </a:tr>
-              <a:tr h="641985">
+              <a:tr h="802481">
                 <a:tc>
                   <a:txBody>
                     <a:bodyPr/>
                     <a:lstStyle/>
                     <a:p>
                       <a:r>
-                        <a:rPr sz="1800" b="0">
+                        <a:rPr sz="2025" b="0">
                           <a:solidFill>
                             <a:srgbClr val="152D43"/>
                           </a:solidFill>
@@ -7882,7 +7791,7 @@
                     <a:lstStyle/>
                     <a:p>
                       <a:r>
-                        <a:rPr sz="1800" b="0">
+                        <a:rPr sz="2025" b="0">
                           <a:solidFill>
                             <a:srgbClr val="152D43"/>
                           </a:solidFill>
@@ -7918,7 +7827,7 @@
                     <a:lstStyle/>
                     <a:p>
                       <a:r>
-                        <a:rPr sz="1800" b="0">
+                        <a:rPr sz="2025" b="0">
                           <a:solidFill>
                             <a:srgbClr val="152D43"/>
                           </a:solidFill>
@@ -7926,43 +7835,7 @@
                           <a:ea typeface="Arial"/>
                           <a:cs typeface="Arial"/>
                         </a:rPr>
-                        <a:t>-0.1569 dB</a:t>
-                      </a:r>
-                    </a:p>
-                  </a:txBody>
-                  <a:tcPr marL="91440" marR="91440" marT="45720" marB="45720">
-                    <a:lnR w="9525">
-                      <a:solidFill>
-                        <a:srgbClr val="D7DFE5"/>
-                      </a:solidFill>
-                      <a:prstDash val="solid"/>
-                    </a:lnR>
-                    <a:lnB w="9525">
-                      <a:solidFill>
-                        <a:srgbClr val="D7DFE5"/>
-                      </a:solidFill>
-                      <a:prstDash val="solid"/>
-                    </a:lnB>
-                    <a:solidFill>
-                      <a:srgbClr val="EAF3F6"/>
-                    </a:solidFill>
-                  </a:tcPr>
-                </a:tc>
-                <a:tc>
-                  <a:txBody>
-                    <a:bodyPr/>
-                    <a:lstStyle/>
-                    <a:p>
-                      <a:r>
-                        <a:rPr sz="1800" b="0">
-                          <a:solidFill>
-                            <a:srgbClr val="152D43"/>
-                          </a:solidFill>
-                          <a:latin typeface="Arial"/>
-                          <a:ea typeface="Arial"/>
-                          <a:cs typeface="Arial"/>
-                        </a:rPr>
-                        <a:t>-0.0785 dB</a:t>
+                        <a:t>0.0785</a:t>
                       </a:r>
                     </a:p>
                   </a:txBody>
@@ -7985,14 +7858,14 @@
                   </a:tcPr>
                 </a:tc>
               </a:tr>
-              <a:tr h="641985">
+              <a:tr h="802481">
                 <a:tc>
                   <a:txBody>
                     <a:bodyPr/>
                     <a:lstStyle/>
                     <a:p>
                       <a:r>
-                        <a:rPr sz="1800" b="0">
+                        <a:rPr sz="2025" b="0">
                           <a:solidFill>
                             <a:srgbClr val="152D43"/>
                           </a:solidFill>
@@ -8034,7 +7907,7 @@
                     <a:lstStyle/>
                     <a:p>
                       <a:r>
-                        <a:rPr sz="1800" b="0">
+                        <a:rPr sz="2025" b="0">
                           <a:solidFill>
                             <a:srgbClr val="152D43"/>
                           </a:solidFill>
@@ -8070,7 +7943,7 @@
                     <a:lstStyle/>
                     <a:p>
                       <a:r>
-                        <a:rPr sz="1800" b="0">
+                        <a:rPr sz="2025" b="0">
                           <a:solidFill>
                             <a:srgbClr val="152D43"/>
                           </a:solidFill>
@@ -8078,43 +7951,7 @@
                           <a:ea typeface="Arial"/>
                           <a:cs typeface="Arial"/>
                         </a:rPr>
-                        <a:t>-0.1198 dB</a:t>
-                      </a:r>
-                    </a:p>
-                  </a:txBody>
-                  <a:tcPr marL="91440" marR="91440" marT="45720" marB="45720">
-                    <a:lnR w="9525">
-                      <a:solidFill>
-                        <a:srgbClr val="D7DFE5"/>
-                      </a:solidFill>
-                      <a:prstDash val="solid"/>
-                    </a:lnR>
-                    <a:lnB w="9525">
-                      <a:solidFill>
-                        <a:srgbClr val="D7DFE5"/>
-                      </a:solidFill>
-                      <a:prstDash val="solid"/>
-                    </a:lnB>
-                    <a:solidFill>
-                      <a:srgbClr val="FFFFFF"/>
-                    </a:solidFill>
-                  </a:tcPr>
-                </a:tc>
-                <a:tc>
-                  <a:txBody>
-                    <a:bodyPr/>
-                    <a:lstStyle/>
-                    <a:p>
-                      <a:r>
-                        <a:rPr sz="1800" b="0">
-                          <a:solidFill>
-                            <a:srgbClr val="152D43"/>
-                          </a:solidFill>
-                          <a:latin typeface="Arial"/>
-                          <a:ea typeface="Arial"/>
-                          <a:cs typeface="Arial"/>
-                        </a:rPr>
-                        <a:t>-0.0599 dB</a:t>
+                        <a:t>0.0599</a:t>
                       </a:r>
                     </a:p>
                   </a:txBody>
@@ -8137,158 +7974,6 @@
                   </a:tcPr>
                 </a:tc>
               </a:tr>
-              <a:tr h="641985">
-                <a:tc>
-                  <a:txBody>
-                    <a:bodyPr/>
-                    <a:lstStyle/>
-                    <a:p>
-                      <a:r>
-                        <a:rPr sz="1800" b="0">
-                          <a:solidFill>
-                            <a:srgbClr val="152D43"/>
-                          </a:solidFill>
-                          <a:latin typeface="Arial"/>
-                          <a:ea typeface="Arial"/>
-                          <a:cs typeface="Arial"/>
-                        </a:rPr>
-                        <a:t>0.75×</a:t>
-                      </a:r>
-                    </a:p>
-                  </a:txBody>
-                  <a:tcPr marL="91440" marR="91440" marT="45720" marB="45720">
-                    <a:lnL w="9525">
-                      <a:solidFill>
-                        <a:srgbClr val="D7DFE5"/>
-                      </a:solidFill>
-                      <a:prstDash val="solid"/>
-                    </a:lnL>
-                    <a:lnR w="9525">
-                      <a:solidFill>
-                        <a:srgbClr val="D7DFE5"/>
-                      </a:solidFill>
-                      <a:prstDash val="solid"/>
-                    </a:lnR>
-                    <a:lnB w="9525">
-                      <a:solidFill>
-                        <a:srgbClr val="D7DFE5"/>
-                      </a:solidFill>
-                      <a:prstDash val="solid"/>
-                    </a:lnB>
-                    <a:solidFill>
-                      <a:srgbClr val="EAF3F6"/>
-                    </a:solidFill>
-                  </a:tcPr>
-                </a:tc>
-                <a:tc>
-                  <a:txBody>
-                    <a:bodyPr/>
-                    <a:lstStyle/>
-                    <a:p>
-                      <a:r>
-                        <a:rPr sz="1800" b="0">
-                          <a:solidFill>
-                            <a:srgbClr val="152D43"/>
-                          </a:solidFill>
-                          <a:latin typeface="Arial"/>
-                          <a:ea typeface="Arial"/>
-                          <a:cs typeface="Arial"/>
-                        </a:rPr>
-                        <a:t>11.039 ms</a:t>
-                      </a:r>
-                    </a:p>
-                  </a:txBody>
-                  <a:tcPr marL="91440" marR="91440" marT="45720" marB="45720">
-                    <a:lnR w="9525">
-                      <a:solidFill>
-                        <a:srgbClr val="D7DFE5"/>
-                      </a:solidFill>
-                      <a:prstDash val="solid"/>
-                    </a:lnR>
-                    <a:lnB w="9525">
-                      <a:solidFill>
-                        <a:srgbClr val="D7DFE5"/>
-                      </a:solidFill>
-                      <a:prstDash val="solid"/>
-                    </a:lnB>
-                    <a:solidFill>
-                      <a:srgbClr val="EAF3F6"/>
-                    </a:solidFill>
-                  </a:tcPr>
-                </a:tc>
-                <a:tc>
-                  <a:txBody>
-                    <a:bodyPr/>
-                    <a:lstStyle/>
-                    <a:p>
-                      <a:r>
-                        <a:rPr sz="1800" b="0">
-                          <a:solidFill>
-                            <a:srgbClr val="152D43"/>
-                          </a:solidFill>
-                          <a:latin typeface="Arial"/>
-                          <a:ea typeface="Arial"/>
-                          <a:cs typeface="Arial"/>
-                        </a:rPr>
-                        <a:t>-0.0669 dB</a:t>
-                      </a:r>
-                    </a:p>
-                  </a:txBody>
-                  <a:tcPr marL="91440" marR="91440" marT="45720" marB="45720">
-                    <a:lnR w="9525">
-                      <a:solidFill>
-                        <a:srgbClr val="D7DFE5"/>
-                      </a:solidFill>
-                      <a:prstDash val="solid"/>
-                    </a:lnR>
-                    <a:lnB w="9525">
-                      <a:solidFill>
-                        <a:srgbClr val="D7DFE5"/>
-                      </a:solidFill>
-                      <a:prstDash val="solid"/>
-                    </a:lnB>
-                    <a:solidFill>
-                      <a:srgbClr val="EAF3F6"/>
-                    </a:solidFill>
-                  </a:tcPr>
-                </a:tc>
-                <a:tc>
-                  <a:txBody>
-                    <a:bodyPr/>
-                    <a:lstStyle/>
-                    <a:p>
-                      <a:r>
-                        <a:rPr sz="1800" b="0">
-                          <a:solidFill>
-                            <a:srgbClr val="152D43"/>
-                          </a:solidFill>
-                          <a:latin typeface="Arial"/>
-                          <a:ea typeface="Arial"/>
-                          <a:cs typeface="Arial"/>
-                        </a:rPr>
-                        <a:t>-0.0335 dB</a:t>
-                      </a:r>
-                    </a:p>
-                  </a:txBody>
-                  <a:tcPr marL="91440" marR="91440" marT="45720" marB="45720">
-                    <a:lnR w="9525">
-                      <a:solidFill>
-                        <a:srgbClr val="D7DFE5"/>
-                      </a:solidFill>
-                      <a:prstDash val="solid"/>
-                    </a:lnR>
-                    <a:lnB w="9525">
-                      <a:solidFill>
-                        <a:srgbClr val="D7DFE5"/>
-                      </a:solidFill>
-                      <a:prstDash val="solid"/>
-                    </a:lnB>
-                    <a:solidFill>
-                      <a:srgbClr val="EAF3F6"/>
-                    </a:solidFill>
-                  </a:tcPr>
-                </a:tc>
-              </a:tr>
             </a:tbl>
           </a:graphicData>
         </a:graphic>
@@ -8298,7 +7983,7 @@
           <p:cNvPr id="5" name="">
             <a:extLst xmlns:a="http://schemas.openxmlformats.org/drawingml/2006/main">
               <a:ext uri="{FF2B5EF4-FFF2-40B4-BE49-F238E27FC236}">
-                <a16:creationId xmlns:a16="http://schemas.microsoft.com/office/drawing/2014/main" id="{78845179-391D-423F-9121-20793BFE5480}"/>
+                <a16:creationId xmlns:a16="http://schemas.microsoft.com/office/drawing/2014/main" id="{E6260E00-BE88-4BF3-AA36-0F3953153A39}"/>
               </a:ext>
             </a:extLst>
           </p:cNvPr>
@@ -8333,7 +8018,7 @@
                 <a:ea typeface="Arial"/>
                 <a:cs typeface="Arial"/>
               </a:rPr>
-              <a:t>* Unchanged left eye, mean per-eye PSNR in dB: stereo difference = right-eye difference / 2</a:t>
+              <a:t>Loss versus Full. Derived assuming unchanged left eye and mean per-eye PSNR in dB.</a:t>
             </a:r>
           </a:p>
         </p:txBody>
@@ -8343,7 +8028,7 @@
           <p:cNvPr id="6" name="">
             <a:extLst xmlns:a="http://schemas.openxmlformats.org/drawingml/2006/main">
               <a:ext uri="{FF2B5EF4-FFF2-40B4-BE49-F238E27FC236}">
-                <a16:creationId xmlns:a16="http://schemas.microsoft.com/office/drawing/2014/main" id="{93348659-FF28-42E5-954B-0BB80CEC89CA}"/>
+                <a16:creationId xmlns:a16="http://schemas.microsoft.com/office/drawing/2014/main" id="{1C62D957-4003-4D07-A01D-1B17E75C366E}"/>
               </a:ext>
             </a:extLst>
           </p:cNvPr>
@@ -8378,7 +8063,7 @@
                 <a:ea typeface="Arial"/>
                 <a:cs typeface="Arial"/>
               </a:rPr>
-              <a:t>ΔPSNR = FOV − full, using original overflow PSNR. Standard PSNR can show a different trend.</a:t>
+              <a:t>Original overflow PSNR preserved. Quality and timing: same 30W run, 1068 frames.</a:t>
             </a:r>
           </a:p>
         </p:txBody>
@@ -8388,7 +8073,7 @@
           <p:cNvPr id="7" name="">
             <a:extLst xmlns:a="http://schemas.openxmlformats.org/drawingml/2006/main">
               <a:ext uri="{FF2B5EF4-FFF2-40B4-BE49-F238E27FC236}">
-                <a16:creationId xmlns:a16="http://schemas.microsoft.com/office/drawing/2014/main" id="{CDBFA6A6-0EAB-4D78-A498-A8CB4D15D861}"/>
+                <a16:creationId xmlns:a16="http://schemas.microsoft.com/office/drawing/2014/main" id="{841887F4-034A-451D-833C-12B83E11F75F}"/>
               </a:ext>
             </a:extLst>
           </p:cNvPr>
@@ -8423,7 +8108,7 @@
                 <a:ea typeface="Arial"/>
                 <a:cs typeface="Arial"/>
               </a:rPr>
-              <a:t>Quality and timing: same 30W run, 1068 frames. Timing adds a fixed 2 ms decode budget; not measured end-to-end.</a:t>
+              <a:t>Timing adds a fixed 2 ms decode budget; not measured end-to-end.</a:t>
             </a:r>
           </a:p>
         </p:txBody>
@@ -8431,7 +8116,7 @@
     </p:spTree>
     <p:extLst>
       <p:ext uri="{BB962C8B-B14F-4D97-AF65-F5344CB8AC3E}">
-        <p14:creationId xmlns:p14="http://schemas.microsoft.com/office/powerpoint/2010/main" val="720353213"/>
+        <p14:creationId xmlns:p14="http://schemas.microsoft.com/office/powerpoint/2010/main" val="1749368288"/>
       </p:ext>
     </p:extLst>
   </p:cSld>
@@ -8462,7 +8147,7 @@
           <p:cNvPr id="14" name="">
             <a:extLst xmlns:a="http://schemas.openxmlformats.org/drawingml/2006/main">
               <a:ext uri="{FF2B5EF4-FFF2-40B4-BE49-F238E27FC236}">
-                <a16:creationId xmlns:a16="http://schemas.microsoft.com/office/drawing/2014/main" id="{26F57AA7-DD06-4260-98A3-B39E42C0493F}"/>
+                <a16:creationId xmlns:a16="http://schemas.microsoft.com/office/drawing/2014/main" id="{7340E5E0-BA90-45BF-BEC9-211C0F9CDD3A}"/>
               </a:ext>
             </a:extLst>
           </p:cNvPr>
@@ -8507,7 +8192,7 @@
           <p:cNvPr id="2" name="">
             <a:extLst xmlns:a="http://schemas.openxmlformats.org/drawingml/2006/main">
               <a:ext uri="{FF2B5EF4-FFF2-40B4-BE49-F238E27FC236}">
-                <a16:creationId xmlns:a16="http://schemas.microsoft.com/office/drawing/2014/main" id="{4B85743C-7B2F-451E-938A-F9DE3D5B93B3}"/>
+                <a16:creationId xmlns:a16="http://schemas.microsoft.com/office/drawing/2014/main" id="{27240A45-73A3-419D-B6A6-4FAB5FAF3A59}"/>
               </a:ext>
             </a:extLst>
           </p:cNvPr>
@@ -8537,7 +8222,7 @@
           <p:cNvPr id="3" name="">
             <a:extLst xmlns:a="http://schemas.openxmlformats.org/drawingml/2006/main">
               <a:ext uri="{FF2B5EF4-FFF2-40B4-BE49-F238E27FC236}">
-                <a16:creationId xmlns:a16="http://schemas.microsoft.com/office/drawing/2014/main" id="{84541237-6331-4BA9-BAC6-30F07F872198}"/>
+                <a16:creationId xmlns:a16="http://schemas.microsoft.com/office/drawing/2014/main" id="{AE28BB7F-5AF8-4460-B091-180B35AAECBD}"/>
               </a:ext>
             </a:extLst>
           </p:cNvPr>
@@ -8582,7 +8267,7 @@
           <p:cNvPr id="4" name="">
             <a:extLst xmlns:a="http://schemas.openxmlformats.org/drawingml/2006/main">
               <a:ext uri="{FF2B5EF4-FFF2-40B4-BE49-F238E27FC236}">
-                <a16:creationId xmlns:a16="http://schemas.microsoft.com/office/drawing/2014/main" id="{95581A7D-84B2-4F2C-A567-A46A8C83FCFF}"/>
+                <a16:creationId xmlns:a16="http://schemas.microsoft.com/office/drawing/2014/main" id="{A84A3BCE-9310-4826-B745-8064F6E74545}"/>
               </a:ext>
             </a:extLst>
           </p:cNvPr>
@@ -8627,7 +8312,7 @@
           <p:cNvPr id="5" name="">
             <a:extLst xmlns:a="http://schemas.openxmlformats.org/drawingml/2006/main">
               <a:ext uri="{FF2B5EF4-FFF2-40B4-BE49-F238E27FC236}">
-                <a16:creationId xmlns:a16="http://schemas.microsoft.com/office/drawing/2014/main" id="{360619D1-1293-4968-B7E3-562BCB7858B2}"/>
+                <a16:creationId xmlns:a16="http://schemas.microsoft.com/office/drawing/2014/main" id="{E6B05D98-95B4-4453-B73F-A64166B8FBB7}"/>
               </a:ext>
             </a:extLst>
           </p:cNvPr>
@@ -8672,7 +8357,7 @@
           <p:cNvPr id="6" name="">
             <a:extLst xmlns:a="http://schemas.openxmlformats.org/drawingml/2006/main">
               <a:ext uri="{FF2B5EF4-FFF2-40B4-BE49-F238E27FC236}">
-                <a16:creationId xmlns:a16="http://schemas.microsoft.com/office/drawing/2014/main" id="{F655579D-C90B-4A3E-99DF-A3492D559FD0}"/>
+                <a16:creationId xmlns:a16="http://schemas.microsoft.com/office/drawing/2014/main" id="{A7315D8C-959B-475F-8AF8-3CF724DA0896}"/>
               </a:ext>
             </a:extLst>
           </p:cNvPr>
@@ -8717,7 +8402,7 @@
           <p:cNvPr id="7" name="">
             <a:extLst xmlns:a="http://schemas.openxmlformats.org/drawingml/2006/main">
               <a:ext uri="{FF2B5EF4-FFF2-40B4-BE49-F238E27FC236}">
-                <a16:creationId xmlns:a16="http://schemas.microsoft.com/office/drawing/2014/main" id="{EB046320-0FA2-4221-8D2F-AD1712345789}"/>
+                <a16:creationId xmlns:a16="http://schemas.microsoft.com/office/drawing/2014/main" id="{3B910781-E82E-43D5-A987-32BDC7EA1FAA}"/>
               </a:ext>
             </a:extLst>
           </p:cNvPr>
@@ -8762,7 +8447,7 @@
           <p:cNvPr id="8" name="">
             <a:extLst xmlns:a="http://schemas.openxmlformats.org/drawingml/2006/main">
               <a:ext uri="{FF2B5EF4-FFF2-40B4-BE49-F238E27FC236}">
-                <a16:creationId xmlns:a16="http://schemas.microsoft.com/office/drawing/2014/main" id="{5FE29D2A-CD74-45E4-80D7-019F34EAB054}"/>
+                <a16:creationId xmlns:a16="http://schemas.microsoft.com/office/drawing/2014/main" id="{072D710E-13CE-4C17-91CB-FD1C27079BAE}"/>
               </a:ext>
             </a:extLst>
           </p:cNvPr>
@@ -8807,7 +8492,7 @@
           <p:cNvPr id="9" name="">
             <a:extLst xmlns:a="http://schemas.openxmlformats.org/drawingml/2006/main">
               <a:ext uri="{FF2B5EF4-FFF2-40B4-BE49-F238E27FC236}">
-                <a16:creationId xmlns:a16="http://schemas.microsoft.com/office/drawing/2014/main" id="{8D25A889-9CB1-4128-9F8B-00535CCEA86F}"/>
+                <a16:creationId xmlns:a16="http://schemas.microsoft.com/office/drawing/2014/main" id="{8C6B8D78-F0AF-4F2C-9DD5-8800E0CE1124}"/>
               </a:ext>
             </a:extLst>
           </p:cNvPr>
@@ -8852,7 +8537,7 @@
           <p:cNvPr id="10" name="">
             <a:extLst xmlns:a="http://schemas.openxmlformats.org/drawingml/2006/main">
               <a:ext uri="{FF2B5EF4-FFF2-40B4-BE49-F238E27FC236}">
-                <a16:creationId xmlns:a16="http://schemas.microsoft.com/office/drawing/2014/main" id="{04B7544D-2930-4FB2-862E-9424ECE1E339}"/>
+                <a16:creationId xmlns:a16="http://schemas.microsoft.com/office/drawing/2014/main" id="{4095094E-494A-4857-9546-697B8729225A}"/>
               </a:ext>
             </a:extLst>
           </p:cNvPr>
@@ -8897,7 +8582,7 @@
           <p:cNvPr id="11" name="">
             <a:extLst xmlns:a="http://schemas.openxmlformats.org/drawingml/2006/main">
               <a:ext uri="{FF2B5EF4-FFF2-40B4-BE49-F238E27FC236}">
-                <a16:creationId xmlns:a16="http://schemas.microsoft.com/office/drawing/2014/main" id="{3C50DDC9-205E-48C8-8678-45C61EB72E42}"/>
+                <a16:creationId xmlns:a16="http://schemas.microsoft.com/office/drawing/2014/main" id="{2D689CAB-75C3-4CBD-BF4F-44DC445B4D3A}"/>
               </a:ext>
             </a:extLst>
           </p:cNvPr>
@@ -8942,7 +8627,7 @@
           <p:cNvPr id="12" name="">
             <a:extLst xmlns:a="http://schemas.openxmlformats.org/drawingml/2006/main">
               <a:ext uri="{FF2B5EF4-FFF2-40B4-BE49-F238E27FC236}">
-                <a16:creationId xmlns:a16="http://schemas.microsoft.com/office/drawing/2014/main" id="{351FAC18-7016-445E-A93D-E7FD5774FA74}"/>
+                <a16:creationId xmlns:a16="http://schemas.microsoft.com/office/drawing/2014/main" id="{7744A144-5FA2-4DAD-8290-579FD24215CA}"/>
               </a:ext>
             </a:extLst>
           </p:cNvPr>
@@ -8987,7 +8672,7 @@
           <p:cNvPr id="13" name="">
             <a:extLst xmlns:a="http://schemas.openxmlformats.org/drawingml/2006/main">
               <a:ext uri="{FF2B5EF4-FFF2-40B4-BE49-F238E27FC236}">
-                <a16:creationId xmlns:a16="http://schemas.microsoft.com/office/drawing/2014/main" id="{239FD8E2-16B4-4A0B-99C4-FF51323F506A}"/>
+                <a16:creationId xmlns:a16="http://schemas.microsoft.com/office/drawing/2014/main" id="{EC50BF56-F2B8-4A3B-9D5A-07178816AC09}"/>
               </a:ext>
             </a:extLst>
           </p:cNvPr>
@@ -9030,7 +8715,7 @@
     </p:spTree>
     <p:extLst>
       <p:ext uri="{BB962C8B-B14F-4D97-AF65-F5344CB8AC3E}">
-        <p14:creationId xmlns:p14="http://schemas.microsoft.com/office/powerpoint/2010/main" val="718374681"/>
+        <p14:creationId xmlns:p14="http://schemas.microsoft.com/office/powerpoint/2010/main" val="1815090642"/>
       </p:ext>
     </p:extLst>
   </p:cSld>

</xml_diff>

<commit_message>
Update slides with saved FOV timing samples and stereo quality losses
</commit_message>
<xml_diff>
--- a/presentations/weekly_20261029/weekly_20261029_english_30w.pptx
+++ b/presentations/weekly_20261029/weekly_20261029_english_30w.pptx
@@ -2,19 +2,19 @@
 <file path=ppt/presentation.xml><?xml version="1.0" encoding="utf-8"?>
 <p:presentation xmlns:p="http://schemas.openxmlformats.org/presentationml/2006/main">
   <p:sldMasterIdLst>
-    <p:sldMasterId xmlns:r="http://schemas.openxmlformats.org/officeDocument/2006/relationships" id="2147483648" r:id="Re832cea49ea24aaa"/>
+    <p:sldMasterId xmlns:r="http://schemas.openxmlformats.org/officeDocument/2006/relationships" id="2147483648" r:id="Rf690a31be8c84dd3"/>
   </p:sldMasterIdLst>
   <p:notesMasterIdLst>
-    <p:notesMasterId xmlns:r="http://schemas.openxmlformats.org/officeDocument/2006/relationships" r:id="R360564877f574f05"/>
+    <p:notesMasterId xmlns:r="http://schemas.openxmlformats.org/officeDocument/2006/relationships" r:id="R0efe101220a64ac0"/>
   </p:notesMasterIdLst>
   <p:sldIdLst>
-    <p:sldId xmlns:r="http://schemas.openxmlformats.org/officeDocument/2006/relationships" id="256" r:id="Rcbb8d092bfeb451b"/>
-    <p:sldId xmlns:r="http://schemas.openxmlformats.org/officeDocument/2006/relationships" id="257" r:id="R74638d07bfb9464b"/>
-    <p:sldId xmlns:r="http://schemas.openxmlformats.org/officeDocument/2006/relationships" id="258" r:id="R540129de170f4ce5"/>
-    <p:sldId xmlns:r="http://schemas.openxmlformats.org/officeDocument/2006/relationships" id="259" r:id="Rbc3c4ca43d954c1f"/>
-    <p:sldId xmlns:r="http://schemas.openxmlformats.org/officeDocument/2006/relationships" id="260" r:id="R76b02ab1c2f245a4"/>
-    <p:sldId xmlns:r="http://schemas.openxmlformats.org/officeDocument/2006/relationships" id="261" r:id="R43cbe419d6a040c6"/>
-    <p:sldId xmlns:r="http://schemas.openxmlformats.org/officeDocument/2006/relationships" id="262" r:id="Rb332c0f122804713"/>
+    <p:sldId xmlns:r="http://schemas.openxmlformats.org/officeDocument/2006/relationships" id="256" r:id="Rb55fbf17bc4b4755"/>
+    <p:sldId xmlns:r="http://schemas.openxmlformats.org/officeDocument/2006/relationships" id="257" r:id="Rdda749aa707d4ae3"/>
+    <p:sldId xmlns:r="http://schemas.openxmlformats.org/officeDocument/2006/relationships" id="258" r:id="R1beee0aa97bf4345"/>
+    <p:sldId xmlns:r="http://schemas.openxmlformats.org/officeDocument/2006/relationships" id="259" r:id="Rc05d8a1316674e31"/>
+    <p:sldId xmlns:r="http://schemas.openxmlformats.org/officeDocument/2006/relationships" id="260" r:id="R432243fde55d4be6"/>
+    <p:sldId xmlns:r="http://schemas.openxmlformats.org/officeDocument/2006/relationships" id="261" r:id="Rae603fbc004e49f0"/>
+    <p:sldId xmlns:r="http://schemas.openxmlformats.org/officeDocument/2006/relationships" id="262" r:id="R4f5df459e4a74de5"/>
   </p:sldIdLst>
   <p:sldSz cx="12192000" cy="6858000"/>
   <p:notesSz cx="6858000" cy="9144000"/>
@@ -658,7 +658,7 @@
           <a:lstStyle xmlns:a="http://schemas.openxmlformats.org/drawingml/2006/main"/>
           <a:p xmlns:a="http://schemas.openxmlformats.org/drawingml/2006/main">
             <a:r>
-              <a:t>Source: results/fov_scales_full_20261029/scale_results.json and README.md. Same 30W CUDA C++ run: 1068 valid forward odd frames, 3 warmups, 5 timed repetitions per frame, one quality output per configuration/frame. Resident whole-pipeline GPU event timing without internal stage markers, fast resampling, dynamic clocks. This differs from the previous small-sample staged experiment. Mechanism: half-resolution base + padded full-resolution ROI + feather overlay. The full output is 960x540 (1.0x). Region scale is ROI width divided by full-image width: 96x54 =&gt; 0.1x, 240x135 =&gt; 0.25x, 480x270 =&gt; 0.5x. The measured 0.75x level remains in the source dataset but is omitted from this presentation. Width and height both follow these scales. ROI extent scale is not sampling resolution: pixels within the ROI remain full-resolution. The base samples at 0.5x width and 0.5x height (480x270) while covering the entire image.</a:t>
+              <a:t>Source: results/fov_only_clear_partial_20261030/presentation_results.json. Partial saved results at Xavier 30W: timing uses 500 common frames with 5 repetitions (2500 samples/level); quality uses 672 common frames. Timing and quality have different coverage. Mechanism: half-resolution base + padded full-resolution ROI + feather overlay. The full output is 960x540 (1.0x). Region scale is ROI width divided by full-image width: 96x54 =&gt; 0.1x, 240x135 =&gt; 0.25x, 480x270 =&gt; 0.5x, 672x378 =&gt; 0.7x. Width and height both follow these scales. ROI extent scale is not sampling resolution: pixels within the ROI remain full-resolution. The base samples at 0.5x width and 0.5x height (480x270) while covering the entire image.</a:t>
             </a:r>
           </a:p>
         </p:txBody>
@@ -728,7 +728,7 @@
           <a:lstStyle xmlns:a="http://schemas.openxmlformats.org/drawingml/2006/main"/>
           <a:p xmlns:a="http://schemas.openxmlformats.org/drawingml/2006/main">
             <a:r>
-              <a:t>Source: results/fov_scales_full_20261029/scale_results.json and README.md. Same 30W CUDA C++ run: 1068 valid forward odd frames, 3 warmups, 5 timed repetitions per frame, one quality output per configuration/frame. Resident whole-pipeline GPU event timing without internal stage markers, fast resampling, dynamic clocks. This differs from the previous small-sample staged experiment. Arithmetic means of all 5340 recorded resident whole-pipeline GPU timings per configuration, not wall time. No internal stage markers. Full uses the paired baseline from the 0.25x configuration. Fixed decode budget is 2 ms once per frame, not measured joint RGB/depth/flow decoding or measured end-to-end timing. No input/output copies, network or display. Savings may include reduced clearing and resampling work; no optimal Full baseline claim.</a:t>
+              <a:t>Source: results/fov_only_clear_partial_20261030/presentation_results.json. Partial saved results at Xavier 30W: timing uses 500 common frames with 5 repetitions (2500 samples/level); quality uses 672 common frames. Timing and quality have different coverage. Arithmetic means of all 2500 recorded resident whole-pipeline GPU timings per configuration, not wall time. Full uses the paired baseline from the 0.25x configuration. Fixed decode budget is 2 ms once per frame, not measured joint RGB/depth/flow decoding or measured end-to-end timing. No input/output copies, network or display. </a:t>
             </a:r>
           </a:p>
         </p:txBody>
@@ -798,7 +798,7 @@
           <a:lstStyle xmlns:a="http://schemas.openxmlformats.org/drawingml/2006/main"/>
           <a:p xmlns:a="http://schemas.openxmlformats.org/drawingml/2006/main">
             <a:r>
-              <a:t>Source: results/fov_scales_full_20261029/scale_results.json and README.md. Same 30W CUDA C++ run: 1068 valid forward odd frames, 3 warmups, 5 timed repetitions per frame, one quality output per configuration/frame. Resident whole-pipeline GPU event timing without internal stage markers, fast resampling, dynamic clocks. This differs from the previous small-sample staged experiment. Original uint8-overflow PSNR preserved. Stereo delta is derived only if left eye remains unchanged and per-eye PSNR dB is averaged. Quality and timing use the same 30W 1068-frame experiment: 3 warmups and 5 timing samples per frame, one quality output per configuration/frame. Timing is never divided by two. Latency adds a fixed 2 ms per-frame decode budget once, not measured decoding or end-to-end latency. Source: results/fov_scales_full_20261029/scale_results.json.</a:t>
+              <a:t>Source: results/fov_only_clear_partial_20261030/presentation_results.json. Partial saved results at Xavier 30W: timing uses 500 common frames with 5 repetitions (2500 samples/level); quality uses 672 common frames. Timing and quality have different coverage. Original uint8-overflow PSNR preserved. Stereo delta is derived only if left eye remains unchanged and per-eye PSNR dB is averaged. Timing uses 500 common frames; quality uses 672 common frames. These are partial saved results, not a complete dataset run. Timing is never divided by two. Latency adds a fixed 2 ms per-frame decode budget once, not measured decoding or end-to-end latency. Source: results/fov_only_clear_partial_20261030/presentation_results.json.</a:t>
             </a:r>
           </a:p>
         </p:txBody>
@@ -915,7 +915,7 @@
           <p:cNvPr id="3" name="Title">
             <a:extLst xmlns:a="http://schemas.openxmlformats.org/drawingml/2006/main">
               <a:ext uri="{FF2B5EF4-FFF2-40B4-BE49-F238E27FC236}">
-                <a16:creationId xmlns:a16="http://schemas.microsoft.com/office/drawing/2014/main" id="{92ABD667-D094-4590-9F25-E3AC22B0E282}"/>
+                <a16:creationId xmlns:a16="http://schemas.microsoft.com/office/drawing/2014/main" id="{6BED6099-54D8-4A41-B6D9-0C0DAB523DD1}"/>
               </a:ext>
             </a:extLst>
           </p:cNvPr>
@@ -1144,7 +1144,7 @@
           <p:cNvPr id="2" name="Subtitle">
             <a:extLst xmlns:a="http://schemas.openxmlformats.org/drawingml/2006/main">
               <a:ext uri="{FF2B5EF4-FFF2-40B4-BE49-F238E27FC236}">
-                <a16:creationId xmlns:a16="http://schemas.microsoft.com/office/drawing/2014/main" id="{B432252E-E14B-4A61-BB8A-174695D4A91C}"/>
+                <a16:creationId xmlns:a16="http://schemas.microsoft.com/office/drawing/2014/main" id="{34D6C2DF-49FA-424B-B556-85EC672EAD11}"/>
               </a:ext>
             </a:extLst>
           </p:cNvPr>
@@ -1390,7 +1390,7 @@
           <p:cNvPr id="2" name="Section title">
             <a:extLst xmlns:a="http://schemas.openxmlformats.org/drawingml/2006/main">
               <a:ext uri="{FF2B5EF4-FFF2-40B4-BE49-F238E27FC236}">
-                <a16:creationId xmlns:a16="http://schemas.microsoft.com/office/drawing/2014/main" id="{3BD4335D-A81E-40E7-B0F6-BE8652C2EAE0}"/>
+                <a16:creationId xmlns:a16="http://schemas.microsoft.com/office/drawing/2014/main" id="{7402D87B-56C8-4565-933B-558ECA55D93B}"/>
               </a:ext>
             </a:extLst>
           </p:cNvPr>
@@ -1636,7 +1636,7 @@
           <p:cNvPr id="3" name="Title">
             <a:extLst xmlns:a="http://schemas.openxmlformats.org/drawingml/2006/main">
               <a:ext uri="{FF2B5EF4-FFF2-40B4-BE49-F238E27FC236}">
-                <a16:creationId xmlns:a16="http://schemas.microsoft.com/office/drawing/2014/main" id="{1FE97686-6382-4DDD-9000-B3D789E9F989}"/>
+                <a16:creationId xmlns:a16="http://schemas.microsoft.com/office/drawing/2014/main" id="{D1BB576B-61FA-4986-ACA1-CB7285BB1D59}"/>
               </a:ext>
             </a:extLst>
           </p:cNvPr>
@@ -1865,7 +1865,7 @@
           <p:cNvPr id="2" name="Body">
             <a:extLst xmlns:a="http://schemas.openxmlformats.org/drawingml/2006/main">
               <a:ext uri="{FF2B5EF4-FFF2-40B4-BE49-F238E27FC236}">
-                <a16:creationId xmlns:a16="http://schemas.microsoft.com/office/drawing/2014/main" id="{57E4A63F-EB2C-4ED8-9E79-F5DA171AC689}"/>
+                <a16:creationId xmlns:a16="http://schemas.microsoft.com/office/drawing/2014/main" id="{942305A6-4251-4CA5-9C32-D82C31F2031F}"/>
               </a:ext>
             </a:extLst>
           </p:cNvPr>
@@ -2111,7 +2111,7 @@
           <p:cNvPr id="4" name="Title">
             <a:extLst xmlns:a="http://schemas.openxmlformats.org/drawingml/2006/main">
               <a:ext uri="{FF2B5EF4-FFF2-40B4-BE49-F238E27FC236}">
-                <a16:creationId xmlns:a16="http://schemas.microsoft.com/office/drawing/2014/main" id="{238D6A94-C7C2-4B41-AA9B-7B5D4F0DF1AE}"/>
+                <a16:creationId xmlns:a16="http://schemas.microsoft.com/office/drawing/2014/main" id="{E5B95822-C253-40C2-BB5C-968A69644AA8}"/>
               </a:ext>
             </a:extLst>
           </p:cNvPr>
@@ -2340,7 +2340,7 @@
           <p:cNvPr id="2" name="Left column">
             <a:extLst xmlns:a="http://schemas.openxmlformats.org/drawingml/2006/main">
               <a:ext uri="{FF2B5EF4-FFF2-40B4-BE49-F238E27FC236}">
-                <a16:creationId xmlns:a16="http://schemas.microsoft.com/office/drawing/2014/main" id="{78A41F0E-EADD-4354-B1E0-20EA1EE44636}"/>
+                <a16:creationId xmlns:a16="http://schemas.microsoft.com/office/drawing/2014/main" id="{AE4E8BDA-09B6-4366-84EC-837692FE27DB}"/>
               </a:ext>
             </a:extLst>
           </p:cNvPr>
@@ -2569,7 +2569,7 @@
           <p:cNvPr id="3" name="Right column">
             <a:extLst xmlns:a="http://schemas.openxmlformats.org/drawingml/2006/main">
               <a:ext uri="{FF2B5EF4-FFF2-40B4-BE49-F238E27FC236}">
-                <a16:creationId xmlns:a16="http://schemas.microsoft.com/office/drawing/2014/main" id="{FB60E174-0798-464B-AA68-6665C0803040}"/>
+                <a16:creationId xmlns:a16="http://schemas.microsoft.com/office/drawing/2014/main" id="{CCB2563A-63E5-4A5A-A2C0-F138C1757534}"/>
               </a:ext>
             </a:extLst>
           </p:cNvPr>
@@ -2815,7 +2815,7 @@
           <p:cNvPr id="3" name="Title">
             <a:extLst xmlns:a="http://schemas.openxmlformats.org/drawingml/2006/main">
               <a:ext uri="{FF2B5EF4-FFF2-40B4-BE49-F238E27FC236}">
-                <a16:creationId xmlns:a16="http://schemas.microsoft.com/office/drawing/2014/main" id="{70598EF3-043C-444A-A5A1-B18969FEB2CC}"/>
+                <a16:creationId xmlns:a16="http://schemas.microsoft.com/office/drawing/2014/main" id="{49646206-AAE7-4D3B-AD6E-B1303BDA7EA8}"/>
               </a:ext>
             </a:extLst>
           </p:cNvPr>
@@ -3044,7 +3044,7 @@
           <p:cNvPr id="2" name="Left column">
             <a:extLst xmlns:a="http://schemas.openxmlformats.org/drawingml/2006/main">
               <a:ext uri="{FF2B5EF4-FFF2-40B4-BE49-F238E27FC236}">
-                <a16:creationId xmlns:a16="http://schemas.microsoft.com/office/drawing/2014/main" id="{FE399677-67CB-4289-9849-3CCC9426635C}"/>
+                <a16:creationId xmlns:a16="http://schemas.microsoft.com/office/drawing/2014/main" id="{9B2EB64C-4E8E-4732-ADDB-B7FCAF3939C3}"/>
               </a:ext>
             </a:extLst>
           </p:cNvPr>
@@ -3311,12 +3311,12 @@
   </p:cSld>
   <p:clrMap bg1="lt1" tx1="dk1" bg2="lt2" tx2="dk2" accent1="accent1" accent2="accent2" accent3="accent3" accent4="accent4" accent5="accent5" accent6="accent6" hlink="hlink" folHlink="folHlink"/>
   <p:sldLayoutIdLst>
-    <p:sldLayoutId xmlns:r="http://schemas.openxmlformats.org/officeDocument/2006/relationships" id="2147483649" r:id="Rb813607ffdac450c"/>
-    <p:sldLayoutId xmlns:r="http://schemas.openxmlformats.org/officeDocument/2006/relationships" id="2147483650" r:id="R9e9fc027ed754cc0"/>
-    <p:sldLayoutId xmlns:r="http://schemas.openxmlformats.org/officeDocument/2006/relationships" id="2147483651" r:id="R091a50b85bd3430d"/>
-    <p:sldLayoutId xmlns:r="http://schemas.openxmlformats.org/officeDocument/2006/relationships" id="2147483652" r:id="Re14965a389d04172"/>
-    <p:sldLayoutId xmlns:r="http://schemas.openxmlformats.org/officeDocument/2006/relationships" id="2147483653" r:id="Rc79c43a5a795441b"/>
-    <p:sldLayoutId xmlns:r="http://schemas.openxmlformats.org/officeDocument/2006/relationships" id="2147483654" r:id="Reade1bf42a6740a1"/>
+    <p:sldLayoutId xmlns:r="http://schemas.openxmlformats.org/officeDocument/2006/relationships" id="2147483649" r:id="Rab63bf626c5f4ea7"/>
+    <p:sldLayoutId xmlns:r="http://schemas.openxmlformats.org/officeDocument/2006/relationships" id="2147483650" r:id="Rd0b2073e0358466b"/>
+    <p:sldLayoutId xmlns:r="http://schemas.openxmlformats.org/officeDocument/2006/relationships" id="2147483651" r:id="R4a79d6a073c24217"/>
+    <p:sldLayoutId xmlns:r="http://schemas.openxmlformats.org/officeDocument/2006/relationships" id="2147483652" r:id="R3307555d1e174865"/>
+    <p:sldLayoutId xmlns:r="http://schemas.openxmlformats.org/officeDocument/2006/relationships" id="2147483653" r:id="R9931caf5b37541fd"/>
+    <p:sldLayoutId xmlns:r="http://schemas.openxmlformats.org/officeDocument/2006/relationships" id="2147483654" r:id="R5918525f58964a95"/>
   </p:sldLayoutIdLst>
   <p:txStyles>
     <p:titleStyle>
@@ -3866,11 +3866,11 @@
           <c:invertIfNegative val="0"/>
           <c:cat>
             <c:strRef>
-              <c:f>'Chart Data'!$A$2:$A$5</c:f>
+              <c:f>'Chart Data'!$A$2:$A$6</c:f>
               <c:strCache>
-                <c:ptCount val="4"/>
+                <c:ptCount val="5"/>
                 <c:pt idx="0">
-                  <c:v>Full</c:v>
+                  <c:v>Full baseline</c:v>
                 </c:pt>
                 <c:pt idx="1">
                   <c:v>0.1×</c:v>
@@ -3881,26 +3881,32 @@
                 <c:pt idx="3">
                   <c:v>0.5×</c:v>
                 </c:pt>
+                <c:pt idx="4">
+                  <c:v>0.7×</c:v>
+                </c:pt>
               </c:strCache>
             </c:strRef>
           </c:cat>
           <c:val>
             <c:numRef>
-              <c:f>'Chart Data'!$B$2:$B$5</c:f>
+              <c:f>'Chart Data'!$B$2:$B$6</c:f>
               <c:numCache>
                 <c:formatCode>General</c:formatCode>
-                <c:ptCount val="4"/>
+                <c:ptCount val="5"/>
                 <c:pt idx="0">
-                  <c:v>8.882</c:v>
+                  <c:v>8.658</c:v>
                 </c:pt>
                 <c:pt idx="1">
-                  <c:v>3.631</c:v>
+                  <c:v>2.46</c:v>
                 </c:pt>
                 <c:pt idx="2">
-                  <c:v>4.257</c:v>
+                  <c:v>2.89</c:v>
                 </c:pt>
                 <c:pt idx="3">
-                  <c:v>6.158</c:v>
+                  <c:v>4.461</c:v>
+                </c:pt>
+                <c:pt idx="4">
+                  <c:v>5.429</c:v>
                 </c:pt>
               </c:numCache>
             </c:numRef>
@@ -3920,11 +3926,11 @@
           <c:invertIfNegative val="0"/>
           <c:cat>
             <c:strRef>
-              <c:f>'Chart Data'!$C$2:$C$5</c:f>
+              <c:f>'Chart Data'!$C$2:$C$6</c:f>
               <c:strCache>
-                <c:ptCount val="4"/>
+                <c:ptCount val="5"/>
                 <c:pt idx="0">
-                  <c:v>Full</c:v>
+                  <c:v>Full baseline</c:v>
                 </c:pt>
                 <c:pt idx="1">
                   <c:v>0.1×</c:v>
@@ -3935,15 +3941,18 @@
                 <c:pt idx="3">
                   <c:v>0.5×</c:v>
                 </c:pt>
+                <c:pt idx="4">
+                  <c:v>0.7×</c:v>
+                </c:pt>
               </c:strCache>
             </c:strRef>
           </c:cat>
           <c:val>
             <c:numRef>
-              <c:f>'Chart Data'!$D$2:$D$5</c:f>
+              <c:f>'Chart Data'!$D$2:$D$6</c:f>
               <c:numCache>
                 <c:formatCode>General</c:formatCode>
-                <c:ptCount val="4"/>
+                <c:ptCount val="5"/>
                 <c:pt idx="0">
                   <c:v>2</c:v>
                 </c:pt>
@@ -3954,6 +3963,9 @@
                   <c:v>2</c:v>
                 </c:pt>
                 <c:pt idx="3">
+                  <c:v>2</c:v>
+                </c:pt>
+                <c:pt idx="4">
                   <c:v>2</c:v>
                 </c:pt>
               </c:numCache>
@@ -4164,7 +4176,7 @@
           <p:cNvPr id="5" name="">
             <a:extLst xmlns:a="http://schemas.openxmlformats.org/drawingml/2006/main">
               <a:ext uri="{FF2B5EF4-FFF2-40B4-BE49-F238E27FC236}">
-                <a16:creationId xmlns:a16="http://schemas.microsoft.com/office/drawing/2014/main" id="{FB96B3B9-E27D-4F70-9EFF-463781721C60}"/>
+                <a16:creationId xmlns:a16="http://schemas.microsoft.com/office/drawing/2014/main" id="{A65C383B-8883-4CC4-9778-52A0356AAEA7}"/>
               </a:ext>
             </a:extLst>
           </p:cNvPr>
@@ -4222,7 +4234,7 @@
           <p:cNvPr id="2" name="">
             <a:extLst xmlns:a="http://schemas.openxmlformats.org/drawingml/2006/main">
               <a:ext uri="{FF2B5EF4-FFF2-40B4-BE49-F238E27FC236}">
-                <a16:creationId xmlns:a16="http://schemas.microsoft.com/office/drawing/2014/main" id="{E92B54C1-30D9-4EA6-9756-7A2C7304EAC2}"/>
+                <a16:creationId xmlns:a16="http://schemas.microsoft.com/office/drawing/2014/main" id="{102D5957-F3BB-467F-80A3-A6C7F909AE5F}"/>
               </a:ext>
             </a:extLst>
           </p:cNvPr>
@@ -4267,7 +4279,7 @@
           <p:cNvPr id="3" name="">
             <a:extLst xmlns:a="http://schemas.openxmlformats.org/drawingml/2006/main">
               <a:ext uri="{FF2B5EF4-FFF2-40B4-BE49-F238E27FC236}">
-                <a16:creationId xmlns:a16="http://schemas.microsoft.com/office/drawing/2014/main" id="{5194251D-410F-4685-A072-2A9E3F2E4CC4}"/>
+                <a16:creationId xmlns:a16="http://schemas.microsoft.com/office/drawing/2014/main" id="{485D118A-D065-4E5F-B3E7-BA1F06C8CC7A}"/>
               </a:ext>
             </a:extLst>
           </p:cNvPr>
@@ -4312,7 +4324,7 @@
           <p:cNvPr id="4" name="">
             <a:extLst xmlns:a="http://schemas.openxmlformats.org/drawingml/2006/main">
               <a:ext uri="{FF2B5EF4-FFF2-40B4-BE49-F238E27FC236}">
-                <a16:creationId xmlns:a16="http://schemas.microsoft.com/office/drawing/2014/main" id="{CE18FAA2-D72C-4133-B368-CEE8D039DE9A}"/>
+                <a16:creationId xmlns:a16="http://schemas.microsoft.com/office/drawing/2014/main" id="{1C29FA77-3595-4954-8CC5-E3D7EC4A8845}"/>
               </a:ext>
             </a:extLst>
           </p:cNvPr>
@@ -4355,7 +4367,7 @@
     </p:spTree>
     <p:extLst>
       <p:ext uri="{BB962C8B-B14F-4D97-AF65-F5344CB8AC3E}">
-        <p14:creationId xmlns:p14="http://schemas.microsoft.com/office/powerpoint/2010/main" val="939593045"/>
+        <p14:creationId xmlns:p14="http://schemas.microsoft.com/office/powerpoint/2010/main" val="1824775973"/>
       </p:ext>
     </p:extLst>
   </p:cSld>
@@ -4386,7 +4398,7 @@
           <p:cNvPr id="29" name="">
             <a:extLst xmlns:a="http://schemas.openxmlformats.org/drawingml/2006/main">
               <a:ext uri="{FF2B5EF4-FFF2-40B4-BE49-F238E27FC236}">
-                <a16:creationId xmlns:a16="http://schemas.microsoft.com/office/drawing/2014/main" id="{E57A48EE-7652-4540-8B5F-E0C4D59DAE4A}"/>
+                <a16:creationId xmlns:a16="http://schemas.microsoft.com/office/drawing/2014/main" id="{7B8C6D03-520B-484D-8291-16F6D49764B2}"/>
               </a:ext>
             </a:extLst>
           </p:cNvPr>
@@ -4431,7 +4443,7 @@
           <p:cNvPr id="2" name="">
             <a:extLst xmlns:a="http://schemas.openxmlformats.org/drawingml/2006/main">
               <a:ext uri="{FF2B5EF4-FFF2-40B4-BE49-F238E27FC236}">
-                <a16:creationId xmlns:a16="http://schemas.microsoft.com/office/drawing/2014/main" id="{8BE77A37-6968-4F85-ABF0-72C999CE879E}"/>
+                <a16:creationId xmlns:a16="http://schemas.microsoft.com/office/drawing/2014/main" id="{B1A09784-615F-43C1-8D8F-D87FDEA8C952}"/>
               </a:ext>
             </a:extLst>
           </p:cNvPr>
@@ -4461,7 +4473,7 @@
           <p:cNvPr id="3" name="">
             <a:extLst xmlns:a="http://schemas.openxmlformats.org/drawingml/2006/main">
               <a:ext uri="{FF2B5EF4-FFF2-40B4-BE49-F238E27FC236}">
-                <a16:creationId xmlns:a16="http://schemas.microsoft.com/office/drawing/2014/main" id="{EC0B1FD8-0296-48CA-8B80-EB5617263F74}"/>
+                <a16:creationId xmlns:a16="http://schemas.microsoft.com/office/drawing/2014/main" id="{1152A649-BEE5-4850-A8E3-55514947A1DF}"/>
               </a:ext>
             </a:extLst>
           </p:cNvPr>
@@ -4506,7 +4518,7 @@
           <p:cNvPr id="4" name="">
             <a:extLst xmlns:a="http://schemas.openxmlformats.org/drawingml/2006/main">
               <a:ext uri="{FF2B5EF4-FFF2-40B4-BE49-F238E27FC236}">
-                <a16:creationId xmlns:a16="http://schemas.microsoft.com/office/drawing/2014/main" id="{F56374B2-1EB6-4D88-9CB7-3BB76243AB85}"/>
+                <a16:creationId xmlns:a16="http://schemas.microsoft.com/office/drawing/2014/main" id="{E6901D4B-8FAB-4E61-852A-354A6767BCF2}"/>
               </a:ext>
             </a:extLst>
           </p:cNvPr>
@@ -4551,7 +4563,7 @@
           <p:cNvPr id="5" name="">
             <a:extLst xmlns:a="http://schemas.openxmlformats.org/drawingml/2006/main">
               <a:ext uri="{FF2B5EF4-FFF2-40B4-BE49-F238E27FC236}">
-                <a16:creationId xmlns:a16="http://schemas.microsoft.com/office/drawing/2014/main" id="{29943380-9A93-4737-AD43-C70B74881F6B}"/>
+                <a16:creationId xmlns:a16="http://schemas.microsoft.com/office/drawing/2014/main" id="{27556DA3-B797-4D0E-96C6-DEB3812F31D2}"/>
               </a:ext>
             </a:extLst>
           </p:cNvPr>
@@ -4596,7 +4608,7 @@
           <p:cNvPr id="6" name="">
             <a:extLst xmlns:a="http://schemas.openxmlformats.org/drawingml/2006/main">
               <a:ext uri="{FF2B5EF4-FFF2-40B4-BE49-F238E27FC236}">
-                <a16:creationId xmlns:a16="http://schemas.microsoft.com/office/drawing/2014/main" id="{6DDCA64C-BD4C-41A4-BCB7-2383B610148F}"/>
+                <a16:creationId xmlns:a16="http://schemas.microsoft.com/office/drawing/2014/main" id="{8B8BB3DB-2BB7-4363-B27B-DE210A6A6AC5}"/>
               </a:ext>
             </a:extLst>
           </p:cNvPr>
@@ -4628,7 +4640,7 @@
           <p:cNvPr id="7" name="">
             <a:extLst xmlns:a="http://schemas.openxmlformats.org/drawingml/2006/main">
               <a:ext uri="{FF2B5EF4-FFF2-40B4-BE49-F238E27FC236}">
-                <a16:creationId xmlns:a16="http://schemas.microsoft.com/office/drawing/2014/main" id="{37754F06-6443-49BE-B43A-971E81E9EDCC}"/>
+                <a16:creationId xmlns:a16="http://schemas.microsoft.com/office/drawing/2014/main" id="{40D22FB7-AEE4-4416-9B82-C0974E949E6B}"/>
               </a:ext>
             </a:extLst>
           </p:cNvPr>
@@ -4660,7 +4672,7 @@
           <p:cNvPr id="8" name="">
             <a:extLst xmlns:a="http://schemas.openxmlformats.org/drawingml/2006/main">
               <a:ext uri="{FF2B5EF4-FFF2-40B4-BE49-F238E27FC236}">
-                <a16:creationId xmlns:a16="http://schemas.microsoft.com/office/drawing/2014/main" id="{F40C0710-29A0-44EE-AF38-622D341FE803}"/>
+                <a16:creationId xmlns:a16="http://schemas.microsoft.com/office/drawing/2014/main" id="{2DCF3332-31FF-4FF2-83F2-7C80C4D34EB2}"/>
               </a:ext>
             </a:extLst>
           </p:cNvPr>
@@ -4692,7 +4704,7 @@
           <p:cNvPr id="9" name="">
             <a:extLst xmlns:a="http://schemas.openxmlformats.org/drawingml/2006/main">
               <a:ext uri="{FF2B5EF4-FFF2-40B4-BE49-F238E27FC236}">
-                <a16:creationId xmlns:a16="http://schemas.microsoft.com/office/drawing/2014/main" id="{CD40F7E8-03F0-47BA-9733-4F6893799735}"/>
+                <a16:creationId xmlns:a16="http://schemas.microsoft.com/office/drawing/2014/main" id="{C8611382-083B-4D6E-ABEA-F93D53AB4D39}"/>
               </a:ext>
             </a:extLst>
           </p:cNvPr>
@@ -4737,7 +4749,7 @@
           <p:cNvPr id="10" name="">
             <a:extLst xmlns:a="http://schemas.openxmlformats.org/drawingml/2006/main">
               <a:ext uri="{FF2B5EF4-FFF2-40B4-BE49-F238E27FC236}">
-                <a16:creationId xmlns:a16="http://schemas.microsoft.com/office/drawing/2014/main" id="{12AC0234-EF08-41C8-9347-BAE36C5151C8}"/>
+                <a16:creationId xmlns:a16="http://schemas.microsoft.com/office/drawing/2014/main" id="{5FF81205-4AAA-4F24-B720-61C2F3EBAD9F}"/>
               </a:ext>
             </a:extLst>
           </p:cNvPr>
@@ -4767,7 +4779,7 @@
           <p:cNvPr id="11" name="">
             <a:extLst xmlns:a="http://schemas.openxmlformats.org/drawingml/2006/main">
               <a:ext uri="{FF2B5EF4-FFF2-40B4-BE49-F238E27FC236}">
-                <a16:creationId xmlns:a16="http://schemas.microsoft.com/office/drawing/2014/main" id="{E3EBE8BD-CE58-475B-825A-B985CE47C32E}"/>
+                <a16:creationId xmlns:a16="http://schemas.microsoft.com/office/drawing/2014/main" id="{064A66A1-A9AE-49E0-B4F5-E5A3EBB6ECD6}"/>
               </a:ext>
             </a:extLst>
           </p:cNvPr>
@@ -4812,7 +4824,7 @@
           <p:cNvPr id="12" name="">
             <a:extLst xmlns:a="http://schemas.openxmlformats.org/drawingml/2006/main">
               <a:ext uri="{FF2B5EF4-FFF2-40B4-BE49-F238E27FC236}">
-                <a16:creationId xmlns:a16="http://schemas.microsoft.com/office/drawing/2014/main" id="{F72851C4-5144-4CB2-827B-1ABEBBDB1110}"/>
+                <a16:creationId xmlns:a16="http://schemas.microsoft.com/office/drawing/2014/main" id="{552AF6CF-46EC-4954-AE67-EE626120E42F}"/>
               </a:ext>
             </a:extLst>
           </p:cNvPr>
@@ -4844,7 +4856,7 @@
           <p:cNvPr id="13" name="">
             <a:extLst xmlns:a="http://schemas.openxmlformats.org/drawingml/2006/main">
               <a:ext uri="{FF2B5EF4-FFF2-40B4-BE49-F238E27FC236}">
-                <a16:creationId xmlns:a16="http://schemas.microsoft.com/office/drawing/2014/main" id="{B1A005E2-7188-4981-8554-F6F4EA29D4E7}"/>
+                <a16:creationId xmlns:a16="http://schemas.microsoft.com/office/drawing/2014/main" id="{C1189D85-ECA7-439A-AF44-E98BE8092328}"/>
               </a:ext>
             </a:extLst>
           </p:cNvPr>
@@ -4876,7 +4888,7 @@
           <p:cNvPr id="14" name="">
             <a:extLst xmlns:a="http://schemas.openxmlformats.org/drawingml/2006/main">
               <a:ext uri="{FF2B5EF4-FFF2-40B4-BE49-F238E27FC236}">
-                <a16:creationId xmlns:a16="http://schemas.microsoft.com/office/drawing/2014/main" id="{2FC231E1-07DF-4A0A-A25D-8B51BB465E8B}"/>
+                <a16:creationId xmlns:a16="http://schemas.microsoft.com/office/drawing/2014/main" id="{2ACECB34-8F52-4DBA-9444-C951AC664EAB}"/>
               </a:ext>
             </a:extLst>
           </p:cNvPr>
@@ -4908,7 +4920,7 @@
           <p:cNvPr id="15" name="">
             <a:extLst xmlns:a="http://schemas.openxmlformats.org/drawingml/2006/main">
               <a:ext uri="{FF2B5EF4-FFF2-40B4-BE49-F238E27FC236}">
-                <a16:creationId xmlns:a16="http://schemas.microsoft.com/office/drawing/2014/main" id="{C5AAD455-1100-404A-ACCE-99475A396ED8}"/>
+                <a16:creationId xmlns:a16="http://schemas.microsoft.com/office/drawing/2014/main" id="{143F6680-4E68-4E25-BBCD-BBF9CDCDB1D5}"/>
               </a:ext>
             </a:extLst>
           </p:cNvPr>
@@ -4953,7 +4965,7 @@
           <p:cNvPr id="16" name="">
             <a:extLst xmlns:a="http://schemas.openxmlformats.org/drawingml/2006/main">
               <a:ext uri="{FF2B5EF4-FFF2-40B4-BE49-F238E27FC236}">
-                <a16:creationId xmlns:a16="http://schemas.microsoft.com/office/drawing/2014/main" id="{B9C94F78-C9D4-471B-ACD2-0D50E4A42B75}"/>
+                <a16:creationId xmlns:a16="http://schemas.microsoft.com/office/drawing/2014/main" id="{FB2BA399-3648-4824-8533-9499EF6D5129}"/>
               </a:ext>
             </a:extLst>
           </p:cNvPr>
@@ -4983,7 +4995,7 @@
           <p:cNvPr id="17" name="">
             <a:extLst xmlns:a="http://schemas.openxmlformats.org/drawingml/2006/main">
               <a:ext uri="{FF2B5EF4-FFF2-40B4-BE49-F238E27FC236}">
-                <a16:creationId xmlns:a16="http://schemas.microsoft.com/office/drawing/2014/main" id="{0642146F-8896-4942-9FFD-8ACEA50C2A69}"/>
+                <a16:creationId xmlns:a16="http://schemas.microsoft.com/office/drawing/2014/main" id="{CF9AA00F-5804-43DF-AE3E-F9B17AE47CA1}"/>
               </a:ext>
             </a:extLst>
           </p:cNvPr>
@@ -5028,7 +5040,7 @@
           <p:cNvPr id="18" name="">
             <a:extLst xmlns:a="http://schemas.openxmlformats.org/drawingml/2006/main">
               <a:ext uri="{FF2B5EF4-FFF2-40B4-BE49-F238E27FC236}">
-                <a16:creationId xmlns:a16="http://schemas.microsoft.com/office/drawing/2014/main" id="{CFE530E6-FBAE-4963-93E7-886F04B55BCC}"/>
+                <a16:creationId xmlns:a16="http://schemas.microsoft.com/office/drawing/2014/main" id="{190FA276-642F-4A6D-B4F0-A214E10411A0}"/>
               </a:ext>
             </a:extLst>
           </p:cNvPr>
@@ -5060,7 +5072,7 @@
           <p:cNvPr id="19" name="">
             <a:extLst xmlns:a="http://schemas.openxmlformats.org/drawingml/2006/main">
               <a:ext uri="{FF2B5EF4-FFF2-40B4-BE49-F238E27FC236}">
-                <a16:creationId xmlns:a16="http://schemas.microsoft.com/office/drawing/2014/main" id="{965CC9C7-3285-46EB-B1C0-251386EBE4B6}"/>
+                <a16:creationId xmlns:a16="http://schemas.microsoft.com/office/drawing/2014/main" id="{BACA7281-D8A2-44AE-BEC3-1944E536ACFA}"/>
               </a:ext>
             </a:extLst>
           </p:cNvPr>
@@ -5092,7 +5104,7 @@
           <p:cNvPr id="20" name="">
             <a:extLst xmlns:a="http://schemas.openxmlformats.org/drawingml/2006/main">
               <a:ext uri="{FF2B5EF4-FFF2-40B4-BE49-F238E27FC236}">
-                <a16:creationId xmlns:a16="http://schemas.microsoft.com/office/drawing/2014/main" id="{A0804ED7-AEDC-46D8-AF8A-D13F96D8B9F8}"/>
+                <a16:creationId xmlns:a16="http://schemas.microsoft.com/office/drawing/2014/main" id="{E9C2A71F-A7FB-4225-B424-C4E82662D8F3}"/>
               </a:ext>
             </a:extLst>
           </p:cNvPr>
@@ -5124,7 +5136,7 @@
           <p:cNvPr id="21" name="">
             <a:extLst xmlns:a="http://schemas.openxmlformats.org/drawingml/2006/main">
               <a:ext uri="{FF2B5EF4-FFF2-40B4-BE49-F238E27FC236}">
-                <a16:creationId xmlns:a16="http://schemas.microsoft.com/office/drawing/2014/main" id="{D1A4F118-66B1-422D-81EE-21DF2232BE46}"/>
+                <a16:creationId xmlns:a16="http://schemas.microsoft.com/office/drawing/2014/main" id="{157E52A8-C4FA-4648-908F-FF1794147F84}"/>
               </a:ext>
             </a:extLst>
           </p:cNvPr>
@@ -5169,7 +5181,7 @@
           <p:cNvPr id="22" name="">
             <a:extLst xmlns:a="http://schemas.openxmlformats.org/drawingml/2006/main">
               <a:ext uri="{FF2B5EF4-FFF2-40B4-BE49-F238E27FC236}">
-                <a16:creationId xmlns:a16="http://schemas.microsoft.com/office/drawing/2014/main" id="{7815DBAE-7EA4-4B7E-AB92-95D7C9164606}"/>
+                <a16:creationId xmlns:a16="http://schemas.microsoft.com/office/drawing/2014/main" id="{E017ED18-7786-4BE1-9173-2C880DD43AA0}"/>
               </a:ext>
             </a:extLst>
           </p:cNvPr>
@@ -5199,7 +5211,7 @@
           <p:cNvPr id="23" name="">
             <a:extLst xmlns:a="http://schemas.openxmlformats.org/drawingml/2006/main">
               <a:ext uri="{FF2B5EF4-FFF2-40B4-BE49-F238E27FC236}">
-                <a16:creationId xmlns:a16="http://schemas.microsoft.com/office/drawing/2014/main" id="{C98E40C4-2167-41B0-9D20-653D7A7EA86B}"/>
+                <a16:creationId xmlns:a16="http://schemas.microsoft.com/office/drawing/2014/main" id="{B1F405B7-11CB-4F27-AA79-2A55E529BDAA}"/>
               </a:ext>
             </a:extLst>
           </p:cNvPr>
@@ -5229,7 +5241,7 @@
           <p:cNvPr id="24" name="">
             <a:extLst xmlns:a="http://schemas.openxmlformats.org/drawingml/2006/main">
               <a:ext uri="{FF2B5EF4-FFF2-40B4-BE49-F238E27FC236}">
-                <a16:creationId xmlns:a16="http://schemas.microsoft.com/office/drawing/2014/main" id="{32DBD944-5A50-4AED-852F-85156280549C}"/>
+                <a16:creationId xmlns:a16="http://schemas.microsoft.com/office/drawing/2014/main" id="{E4737E20-C832-489E-87F2-07282CA77747}"/>
               </a:ext>
             </a:extLst>
           </p:cNvPr>
@@ -5274,7 +5286,7 @@
           <p:cNvPr id="25" name="">
             <a:extLst xmlns:a="http://schemas.openxmlformats.org/drawingml/2006/main">
               <a:ext uri="{FF2B5EF4-FFF2-40B4-BE49-F238E27FC236}">
-                <a16:creationId xmlns:a16="http://schemas.microsoft.com/office/drawing/2014/main" id="{AE260CA8-5F07-463B-A566-E7EAACB1158B}"/>
+                <a16:creationId xmlns:a16="http://schemas.microsoft.com/office/drawing/2014/main" id="{3A313B33-1F2E-4173-958D-7728904443D2}"/>
               </a:ext>
             </a:extLst>
           </p:cNvPr>
@@ -5319,7 +5331,7 @@
           <p:cNvPr id="26" name="">
             <a:extLst xmlns:a="http://schemas.openxmlformats.org/drawingml/2006/main">
               <a:ext uri="{FF2B5EF4-FFF2-40B4-BE49-F238E27FC236}">
-                <a16:creationId xmlns:a16="http://schemas.microsoft.com/office/drawing/2014/main" id="{F7429049-F10F-4F18-8820-49687F01B565}"/>
+                <a16:creationId xmlns:a16="http://schemas.microsoft.com/office/drawing/2014/main" id="{DA91E890-C5A4-4070-B33C-50BBE9B9F4E4}"/>
               </a:ext>
             </a:extLst>
           </p:cNvPr>
@@ -5364,7 +5376,7 @@
           <p:cNvPr id="27" name="">
             <a:extLst xmlns:a="http://schemas.openxmlformats.org/drawingml/2006/main">
               <a:ext uri="{FF2B5EF4-FFF2-40B4-BE49-F238E27FC236}">
-                <a16:creationId xmlns:a16="http://schemas.microsoft.com/office/drawing/2014/main" id="{CE1C3C00-8D44-4687-98E7-FA939230E3DA}"/>
+                <a16:creationId xmlns:a16="http://schemas.microsoft.com/office/drawing/2014/main" id="{4A6D31EE-4A03-46DF-BCB8-267B97D677E9}"/>
               </a:ext>
             </a:extLst>
           </p:cNvPr>
@@ -5409,7 +5421,7 @@
           <p:cNvPr id="28" name="">
             <a:extLst xmlns:a="http://schemas.openxmlformats.org/drawingml/2006/main">
               <a:ext uri="{FF2B5EF4-FFF2-40B4-BE49-F238E27FC236}">
-                <a16:creationId xmlns:a16="http://schemas.microsoft.com/office/drawing/2014/main" id="{7C583CDF-4AB2-40BD-90AE-89BD1F0A5468}"/>
+                <a16:creationId xmlns:a16="http://schemas.microsoft.com/office/drawing/2014/main" id="{7CC81B7B-0BCF-491E-BA6D-39B87B25CBDD}"/>
               </a:ext>
             </a:extLst>
           </p:cNvPr>
@@ -5452,7 +5464,7 @@
     </p:spTree>
     <p:extLst>
       <p:ext uri="{BB962C8B-B14F-4D97-AF65-F5344CB8AC3E}">
-        <p14:creationId xmlns:p14="http://schemas.microsoft.com/office/powerpoint/2010/main" val="298063405"/>
+        <p14:creationId xmlns:p14="http://schemas.microsoft.com/office/powerpoint/2010/main" val="911371109"/>
       </p:ext>
     </p:extLst>
   </p:cSld>
@@ -5483,7 +5495,7 @@
           <p:cNvPr id="15" name="">
             <a:extLst xmlns:a="http://schemas.openxmlformats.org/drawingml/2006/main">
               <a:ext uri="{FF2B5EF4-FFF2-40B4-BE49-F238E27FC236}">
-                <a16:creationId xmlns:a16="http://schemas.microsoft.com/office/drawing/2014/main" id="{235D8A48-309B-450D-9AA0-5DE13F41185F}"/>
+                <a16:creationId xmlns:a16="http://schemas.microsoft.com/office/drawing/2014/main" id="{03442926-FEEE-4CD9-A10E-2E8230054175}"/>
               </a:ext>
             </a:extLst>
           </p:cNvPr>
@@ -5528,7 +5540,7 @@
           <p:cNvPr id="2" name="">
             <a:extLst xmlns:a="http://schemas.openxmlformats.org/drawingml/2006/main">
               <a:ext uri="{FF2B5EF4-FFF2-40B4-BE49-F238E27FC236}">
-                <a16:creationId xmlns:a16="http://schemas.microsoft.com/office/drawing/2014/main" id="{42EBD704-4BDE-4767-8992-AD702634F02C}"/>
+                <a16:creationId xmlns:a16="http://schemas.microsoft.com/office/drawing/2014/main" id="{7DC080DF-8082-4DF3-8FF6-F4A0498DEBCB}"/>
               </a:ext>
             </a:extLst>
           </p:cNvPr>
@@ -5558,7 +5570,7 @@
           <p:cNvPr id="3" name="">
             <a:extLst xmlns:a="http://schemas.openxmlformats.org/drawingml/2006/main">
               <a:ext uri="{FF2B5EF4-FFF2-40B4-BE49-F238E27FC236}">
-                <a16:creationId xmlns:a16="http://schemas.microsoft.com/office/drawing/2014/main" id="{4F18428C-504E-4505-BC27-96C86784D4EC}"/>
+                <a16:creationId xmlns:a16="http://schemas.microsoft.com/office/drawing/2014/main" id="{6A64A39F-0D39-41B0-B78C-ED919601FE8B}"/>
               </a:ext>
             </a:extLst>
           </p:cNvPr>
@@ -5603,7 +5615,7 @@
           <p:cNvPr id="4" name="">
             <a:extLst xmlns:a="http://schemas.openxmlformats.org/drawingml/2006/main">
               <a:ext uri="{FF2B5EF4-FFF2-40B4-BE49-F238E27FC236}">
-                <a16:creationId xmlns:a16="http://schemas.microsoft.com/office/drawing/2014/main" id="{5F946B46-4B1B-4ABE-B3CC-0A6C70A438B3}"/>
+                <a16:creationId xmlns:a16="http://schemas.microsoft.com/office/drawing/2014/main" id="{6C95C2B3-6EB7-4AF3-B020-916AC4D0DE89}"/>
               </a:ext>
             </a:extLst>
           </p:cNvPr>
@@ -5648,7 +5660,7 @@
           <p:cNvPr id="5" name="">
             <a:extLst xmlns:a="http://schemas.openxmlformats.org/drawingml/2006/main">
               <a:ext uri="{FF2B5EF4-FFF2-40B4-BE49-F238E27FC236}">
-                <a16:creationId xmlns:a16="http://schemas.microsoft.com/office/drawing/2014/main" id="{BF27FE57-EBF0-4492-901E-B07A58631FD5}"/>
+                <a16:creationId xmlns:a16="http://schemas.microsoft.com/office/drawing/2014/main" id="{BA7766EF-29A6-4C07-AFD8-4AFBA8F2E36E}"/>
               </a:ext>
             </a:extLst>
           </p:cNvPr>
@@ -5680,7 +5692,7 @@
           <p:cNvPr id="6" name="">
             <a:extLst xmlns:a="http://schemas.openxmlformats.org/drawingml/2006/main">
               <a:ext uri="{FF2B5EF4-FFF2-40B4-BE49-F238E27FC236}">
-                <a16:creationId xmlns:a16="http://schemas.microsoft.com/office/drawing/2014/main" id="{E5E13740-D0F8-462F-A215-7883059BBA59}"/>
+                <a16:creationId xmlns:a16="http://schemas.microsoft.com/office/drawing/2014/main" id="{2202A97E-5938-4BF6-B085-415C9F69F1C4}"/>
               </a:ext>
             </a:extLst>
           </p:cNvPr>
@@ -5712,7 +5724,7 @@
           <p:cNvPr id="7" name="">
             <a:extLst xmlns:a="http://schemas.openxmlformats.org/drawingml/2006/main">
               <a:ext uri="{FF2B5EF4-FFF2-40B4-BE49-F238E27FC236}">
-                <a16:creationId xmlns:a16="http://schemas.microsoft.com/office/drawing/2014/main" id="{621D1375-6055-4EFF-9787-6C327FBD857C}"/>
+                <a16:creationId xmlns:a16="http://schemas.microsoft.com/office/drawing/2014/main" id="{401CF9B3-A297-4BE3-84BC-D9264F17AA44}"/>
               </a:ext>
             </a:extLst>
           </p:cNvPr>
@@ -5744,7 +5756,7 @@
           <p:cNvPr id="8" name="">
             <a:extLst xmlns:a="http://schemas.openxmlformats.org/drawingml/2006/main">
               <a:ext uri="{FF2B5EF4-FFF2-40B4-BE49-F238E27FC236}">
-                <a16:creationId xmlns:a16="http://schemas.microsoft.com/office/drawing/2014/main" id="{1A2BC7C6-0FE2-41E9-895B-F970C1E49186}"/>
+                <a16:creationId xmlns:a16="http://schemas.microsoft.com/office/drawing/2014/main" id="{16444D25-8F91-4E82-82F0-141580EC51A8}"/>
               </a:ext>
             </a:extLst>
           </p:cNvPr>
@@ -5789,7 +5801,7 @@
           <p:cNvPr id="9" name="">
             <a:extLst xmlns:a="http://schemas.openxmlformats.org/drawingml/2006/main">
               <a:ext uri="{FF2B5EF4-FFF2-40B4-BE49-F238E27FC236}">
-                <a16:creationId xmlns:a16="http://schemas.microsoft.com/office/drawing/2014/main" id="{121DD18C-3C4F-4815-B7C1-6309D05F5742}"/>
+                <a16:creationId xmlns:a16="http://schemas.microsoft.com/office/drawing/2014/main" id="{C34AB15E-1BB8-49E4-8577-AE85A9B5690B}"/>
               </a:ext>
             </a:extLst>
           </p:cNvPr>
@@ -5834,7 +5846,7 @@
           <p:cNvPr id="10" name="">
             <a:extLst xmlns:a="http://schemas.openxmlformats.org/drawingml/2006/main">
               <a:ext uri="{FF2B5EF4-FFF2-40B4-BE49-F238E27FC236}">
-                <a16:creationId xmlns:a16="http://schemas.microsoft.com/office/drawing/2014/main" id="{6BFC541D-FB32-47E4-835C-736D8A660758}"/>
+                <a16:creationId xmlns:a16="http://schemas.microsoft.com/office/drawing/2014/main" id="{EF83A3A7-BCF7-473F-A924-91C6F9755803}"/>
               </a:ext>
             </a:extLst>
           </p:cNvPr>
@@ -5866,7 +5878,7 @@
           <p:cNvPr id="11" name="">
             <a:extLst xmlns:a="http://schemas.openxmlformats.org/drawingml/2006/main">
               <a:ext uri="{FF2B5EF4-FFF2-40B4-BE49-F238E27FC236}">
-                <a16:creationId xmlns:a16="http://schemas.microsoft.com/office/drawing/2014/main" id="{913FC954-F9A5-497E-97B0-2813D8975F8C}"/>
+                <a16:creationId xmlns:a16="http://schemas.microsoft.com/office/drawing/2014/main" id="{C1CFBBA9-DBFE-42AD-AA0A-6AE3925DD51E}"/>
               </a:ext>
             </a:extLst>
           </p:cNvPr>
@@ -5898,7 +5910,7 @@
           <p:cNvPr id="12" name="">
             <a:extLst xmlns:a="http://schemas.openxmlformats.org/drawingml/2006/main">
               <a:ext uri="{FF2B5EF4-FFF2-40B4-BE49-F238E27FC236}">
-                <a16:creationId xmlns:a16="http://schemas.microsoft.com/office/drawing/2014/main" id="{78134293-C5F0-4D93-8916-70303102579F}"/>
+                <a16:creationId xmlns:a16="http://schemas.microsoft.com/office/drawing/2014/main" id="{55603292-B926-42EB-BE1E-358AD485D97A}"/>
               </a:ext>
             </a:extLst>
           </p:cNvPr>
@@ -5930,7 +5942,7 @@
           <p:cNvPr id="13" name="">
             <a:extLst xmlns:a="http://schemas.openxmlformats.org/drawingml/2006/main">
               <a:ext uri="{FF2B5EF4-FFF2-40B4-BE49-F238E27FC236}">
-                <a16:creationId xmlns:a16="http://schemas.microsoft.com/office/drawing/2014/main" id="{DAF33DE7-4FAE-4890-82C3-BAF74D8C79D6}"/>
+                <a16:creationId xmlns:a16="http://schemas.microsoft.com/office/drawing/2014/main" id="{E1795D38-D46D-488B-B5F7-D857386413DC}"/>
               </a:ext>
             </a:extLst>
           </p:cNvPr>
@@ -5975,7 +5987,7 @@
           <p:cNvPr id="14" name="">
             <a:extLst xmlns:a="http://schemas.openxmlformats.org/drawingml/2006/main">
               <a:ext uri="{FF2B5EF4-FFF2-40B4-BE49-F238E27FC236}">
-                <a16:creationId xmlns:a16="http://schemas.microsoft.com/office/drawing/2014/main" id="{5A6A18DA-B5E0-4110-B23C-F35FD33E652C}"/>
+                <a16:creationId xmlns:a16="http://schemas.microsoft.com/office/drawing/2014/main" id="{EBA0009C-FD2F-45DA-BD36-0B4594D58409}"/>
               </a:ext>
             </a:extLst>
           </p:cNvPr>
@@ -6018,7 +6030,7 @@
     </p:spTree>
     <p:extLst>
       <p:ext uri="{BB962C8B-B14F-4D97-AF65-F5344CB8AC3E}">
-        <p14:creationId xmlns:p14="http://schemas.microsoft.com/office/powerpoint/2010/main" val="1004197667"/>
+        <p14:creationId xmlns:p14="http://schemas.microsoft.com/office/powerpoint/2010/main" val="809550037"/>
       </p:ext>
     </p:extLst>
   </p:cSld>
@@ -6049,7 +6061,7 @@
           <p:cNvPr id="20" name="">
             <a:extLst xmlns:a="http://schemas.openxmlformats.org/drawingml/2006/main">
               <a:ext uri="{FF2B5EF4-FFF2-40B4-BE49-F238E27FC236}">
-                <a16:creationId xmlns:a16="http://schemas.microsoft.com/office/drawing/2014/main" id="{12160E10-80D1-4873-ACCD-E248EF0E8E2F}"/>
+                <a16:creationId xmlns:a16="http://schemas.microsoft.com/office/drawing/2014/main" id="{699A1191-4D3C-434C-8D25-DB73511B211F}"/>
               </a:ext>
             </a:extLst>
           </p:cNvPr>
@@ -6094,7 +6106,7 @@
           <p:cNvPr id="2" name="">
             <a:extLst xmlns:a="http://schemas.openxmlformats.org/drawingml/2006/main">
               <a:ext uri="{FF2B5EF4-FFF2-40B4-BE49-F238E27FC236}">
-                <a16:creationId xmlns:a16="http://schemas.microsoft.com/office/drawing/2014/main" id="{B2DEEAF6-69D5-4E07-A4EF-847EBD0E46D9}"/>
+                <a16:creationId xmlns:a16="http://schemas.microsoft.com/office/drawing/2014/main" id="{E848398F-B907-4BC8-970A-D56390EC23A6}"/>
               </a:ext>
             </a:extLst>
           </p:cNvPr>
@@ -6124,7 +6136,7 @@
           <p:cNvPr id="3" name="">
             <a:extLst xmlns:a="http://schemas.openxmlformats.org/drawingml/2006/main">
               <a:ext uri="{FF2B5EF4-FFF2-40B4-BE49-F238E27FC236}">
-                <a16:creationId xmlns:a16="http://schemas.microsoft.com/office/drawing/2014/main" id="{C611B946-8CA4-4106-9BB0-4A1BF8767D91}"/>
+                <a16:creationId xmlns:a16="http://schemas.microsoft.com/office/drawing/2014/main" id="{BBA469ED-3284-4389-9E9A-E071E488F6AD}"/>
               </a:ext>
             </a:extLst>
           </p:cNvPr>
@@ -6169,7 +6181,7 @@
           <p:cNvPr id="4" name="">
             <a:extLst xmlns:a="http://schemas.openxmlformats.org/drawingml/2006/main">
               <a:ext uri="{FF2B5EF4-FFF2-40B4-BE49-F238E27FC236}">
-                <a16:creationId xmlns:a16="http://schemas.microsoft.com/office/drawing/2014/main" id="{4D1ABFA0-BCA8-4977-A2EA-4D0B30B050A2}"/>
+                <a16:creationId xmlns:a16="http://schemas.microsoft.com/office/drawing/2014/main" id="{1A59B0EC-DEA3-4DF7-A473-972E44AAD1E8}"/>
               </a:ext>
             </a:extLst>
           </p:cNvPr>
@@ -6214,7 +6226,7 @@
           <p:cNvPr id="5" name="">
             <a:extLst xmlns:a="http://schemas.openxmlformats.org/drawingml/2006/main">
               <a:ext uri="{FF2B5EF4-FFF2-40B4-BE49-F238E27FC236}">
-                <a16:creationId xmlns:a16="http://schemas.microsoft.com/office/drawing/2014/main" id="{33C86966-D340-4B3F-839D-AB3770337956}"/>
+                <a16:creationId xmlns:a16="http://schemas.microsoft.com/office/drawing/2014/main" id="{36947818-DAAC-4E10-87B3-A2C1470A6F26}"/>
               </a:ext>
             </a:extLst>
           </p:cNvPr>
@@ -6246,7 +6258,7 @@
           <p:cNvPr id="6" name="">
             <a:extLst xmlns:a="http://schemas.openxmlformats.org/drawingml/2006/main">
               <a:ext uri="{FF2B5EF4-FFF2-40B4-BE49-F238E27FC236}">
-                <a16:creationId xmlns:a16="http://schemas.microsoft.com/office/drawing/2014/main" id="{9FEF53F8-D1D0-4909-B1E1-DE3E34CDE1CB}"/>
+                <a16:creationId xmlns:a16="http://schemas.microsoft.com/office/drawing/2014/main" id="{106BAD6E-BD84-4E6E-A8B6-E1D8839CC51A}"/>
               </a:ext>
             </a:extLst>
           </p:cNvPr>
@@ -6317,7 +6329,7 @@
           <p:cNvPr id="7" name="">
             <a:extLst xmlns:a="http://schemas.openxmlformats.org/drawingml/2006/main">
               <a:ext uri="{FF2B5EF4-FFF2-40B4-BE49-F238E27FC236}">
-                <a16:creationId xmlns:a16="http://schemas.microsoft.com/office/drawing/2014/main" id="{9C9F7E01-5985-4AF8-A196-56FB27E7A4DA}"/>
+                <a16:creationId xmlns:a16="http://schemas.microsoft.com/office/drawing/2014/main" id="{B553C864-2805-450F-8074-F65027EDEE2E}"/>
               </a:ext>
             </a:extLst>
           </p:cNvPr>
@@ -6362,7 +6374,7 @@
           <p:cNvPr id="8" name="">
             <a:extLst xmlns:a="http://schemas.openxmlformats.org/drawingml/2006/main">
               <a:ext uri="{FF2B5EF4-FFF2-40B4-BE49-F238E27FC236}">
-                <a16:creationId xmlns:a16="http://schemas.microsoft.com/office/drawing/2014/main" id="{82E0D6C1-8B12-4F0C-9217-17E389D0B30D}"/>
+                <a16:creationId xmlns:a16="http://schemas.microsoft.com/office/drawing/2014/main" id="{7C89BFB9-0293-4CE6-A55A-B49C9E45079F}"/>
               </a:ext>
             </a:extLst>
           </p:cNvPr>
@@ -6394,7 +6406,7 @@
           <p:cNvPr id="9" name="">
             <a:extLst xmlns:a="http://schemas.openxmlformats.org/drawingml/2006/main">
               <a:ext uri="{FF2B5EF4-FFF2-40B4-BE49-F238E27FC236}">
-                <a16:creationId xmlns:a16="http://schemas.microsoft.com/office/drawing/2014/main" id="{E4925D2C-133B-4AC2-A573-3B607BCA573E}"/>
+                <a16:creationId xmlns:a16="http://schemas.microsoft.com/office/drawing/2014/main" id="{0D6B22B3-6C9F-4243-B3A4-D7D38FF44143}"/>
               </a:ext>
             </a:extLst>
           </p:cNvPr>
@@ -6426,7 +6438,7 @@
           <p:cNvPr id="10" name="">
             <a:extLst xmlns:a="http://schemas.openxmlformats.org/drawingml/2006/main">
               <a:ext uri="{FF2B5EF4-FFF2-40B4-BE49-F238E27FC236}">
-                <a16:creationId xmlns:a16="http://schemas.microsoft.com/office/drawing/2014/main" id="{EC163119-7449-4DE3-B8D7-1DEF6BA9D529}"/>
+                <a16:creationId xmlns:a16="http://schemas.microsoft.com/office/drawing/2014/main" id="{3569F922-4E16-46D1-8BA8-49316709B9B0}"/>
               </a:ext>
             </a:extLst>
           </p:cNvPr>
@@ -6471,7 +6483,7 @@
           <p:cNvPr id="11" name="">
             <a:extLst xmlns:a="http://schemas.openxmlformats.org/drawingml/2006/main">
               <a:ext uri="{FF2B5EF4-FFF2-40B4-BE49-F238E27FC236}">
-                <a16:creationId xmlns:a16="http://schemas.microsoft.com/office/drawing/2014/main" id="{2A650142-7EBA-4BEF-BC5B-3BF06AE69D37}"/>
+                <a16:creationId xmlns:a16="http://schemas.microsoft.com/office/drawing/2014/main" id="{DC36E927-8F24-4B00-9227-29880609D525}"/>
               </a:ext>
             </a:extLst>
           </p:cNvPr>
@@ -6516,7 +6528,7 @@
           <p:cNvPr id="12" name="">
             <a:extLst xmlns:a="http://schemas.openxmlformats.org/drawingml/2006/main">
               <a:ext uri="{FF2B5EF4-FFF2-40B4-BE49-F238E27FC236}">
-                <a16:creationId xmlns:a16="http://schemas.microsoft.com/office/drawing/2014/main" id="{75C2F24F-DB16-4D3F-8698-9BCC6DABECD8}"/>
+                <a16:creationId xmlns:a16="http://schemas.microsoft.com/office/drawing/2014/main" id="{D5CFC489-2058-471A-B4E7-0DA986EB9B0A}"/>
               </a:ext>
             </a:extLst>
           </p:cNvPr>
@@ -6561,7 +6573,7 @@
           <p:cNvPr id="13" name="">
             <a:extLst xmlns:a="http://schemas.openxmlformats.org/drawingml/2006/main">
               <a:ext uri="{FF2B5EF4-FFF2-40B4-BE49-F238E27FC236}">
-                <a16:creationId xmlns:a16="http://schemas.microsoft.com/office/drawing/2014/main" id="{24A327AA-859C-41B1-9BE9-47BC930C1D8F}"/>
+                <a16:creationId xmlns:a16="http://schemas.microsoft.com/office/drawing/2014/main" id="{5281B444-154D-4DBB-BAA6-E0DEB94440C7}"/>
               </a:ext>
             </a:extLst>
           </p:cNvPr>
@@ -6593,7 +6605,7 @@
           <p:cNvPr id="14" name="">
             <a:extLst xmlns:a="http://schemas.openxmlformats.org/drawingml/2006/main">
               <a:ext uri="{FF2B5EF4-FFF2-40B4-BE49-F238E27FC236}">
-                <a16:creationId xmlns:a16="http://schemas.microsoft.com/office/drawing/2014/main" id="{90273DEA-CF34-46BE-A4BB-E7A069A32495}"/>
+                <a16:creationId xmlns:a16="http://schemas.microsoft.com/office/drawing/2014/main" id="{21C3375A-1306-464B-8F5F-25189D593337}"/>
               </a:ext>
             </a:extLst>
           </p:cNvPr>
@@ -6625,7 +6637,7 @@
           <p:cNvPr id="15" name="">
             <a:extLst xmlns:a="http://schemas.openxmlformats.org/drawingml/2006/main">
               <a:ext uri="{FF2B5EF4-FFF2-40B4-BE49-F238E27FC236}">
-                <a16:creationId xmlns:a16="http://schemas.microsoft.com/office/drawing/2014/main" id="{797A4FF3-C532-4F6C-8BC0-1D6529559F84}"/>
+                <a16:creationId xmlns:a16="http://schemas.microsoft.com/office/drawing/2014/main" id="{90E096AD-98E3-4BF7-A0B3-135984D44563}"/>
               </a:ext>
             </a:extLst>
           </p:cNvPr>
@@ -6657,7 +6669,7 @@
           <p:cNvPr id="16" name="">
             <a:extLst xmlns:a="http://schemas.openxmlformats.org/drawingml/2006/main">
               <a:ext uri="{FF2B5EF4-FFF2-40B4-BE49-F238E27FC236}">
-                <a16:creationId xmlns:a16="http://schemas.microsoft.com/office/drawing/2014/main" id="{5024BEE1-D249-43BB-A282-2A1010891D0F}"/>
+                <a16:creationId xmlns:a16="http://schemas.microsoft.com/office/drawing/2014/main" id="{C369E07D-8861-45C4-8477-10CDCADBF97E}"/>
               </a:ext>
             </a:extLst>
           </p:cNvPr>
@@ -6702,7 +6714,7 @@
           <p:cNvPr id="17" name="">
             <a:extLst xmlns:a="http://schemas.openxmlformats.org/drawingml/2006/main">
               <a:ext uri="{FF2B5EF4-FFF2-40B4-BE49-F238E27FC236}">
-                <a16:creationId xmlns:a16="http://schemas.microsoft.com/office/drawing/2014/main" id="{8EF6E008-FB53-4E6E-A9EB-DE8B22A7BAA7}"/>
+                <a16:creationId xmlns:a16="http://schemas.microsoft.com/office/drawing/2014/main" id="{0CEC7D23-E1AD-4C60-BF02-9D09917976D7}"/>
               </a:ext>
             </a:extLst>
           </p:cNvPr>
@@ -6747,7 +6759,7 @@
           <p:cNvPr id="18" name="">
             <a:extLst xmlns:a="http://schemas.openxmlformats.org/drawingml/2006/main">
               <a:ext uri="{FF2B5EF4-FFF2-40B4-BE49-F238E27FC236}">
-                <a16:creationId xmlns:a16="http://schemas.microsoft.com/office/drawing/2014/main" id="{90B1A712-2F5D-4989-AAA2-CDDCEA3258C6}"/>
+                <a16:creationId xmlns:a16="http://schemas.microsoft.com/office/drawing/2014/main" id="{51314204-048F-4E66-B598-A74FAC496733}"/>
               </a:ext>
             </a:extLst>
           </p:cNvPr>
@@ -6782,7 +6794,7 @@
                 <a:ea typeface="Arial"/>
                 <a:cs typeface="Arial"/>
               </a:rPr>
-              <a:t>Full-resolution region width: 0.1×, 0.25×, 0.5×</a:t>
+              <a:t>Full-resolution region width: 0.1×, 0.25×, 0.5×, 0.7×</a:t>
             </a:r>
           </a:p>
         </p:txBody>
@@ -6792,7 +6804,7 @@
           <p:cNvPr id="19" name="">
             <a:extLst xmlns:a="http://schemas.openxmlformats.org/drawingml/2006/main">
               <a:ext uri="{FF2B5EF4-FFF2-40B4-BE49-F238E27FC236}">
-                <a16:creationId xmlns:a16="http://schemas.microsoft.com/office/drawing/2014/main" id="{F8F14F78-1956-4EF4-9486-57568E8895DD}"/>
+                <a16:creationId xmlns:a16="http://schemas.microsoft.com/office/drawing/2014/main" id="{B9C2E3C3-FB5E-4FB1-B306-D9E8517DB507}"/>
               </a:ext>
             </a:extLst>
           </p:cNvPr>
@@ -6835,7 +6847,7 @@
     </p:spTree>
     <p:extLst>
       <p:ext uri="{BB962C8B-B14F-4D97-AF65-F5344CB8AC3E}">
-        <p14:creationId xmlns:p14="http://schemas.microsoft.com/office/powerpoint/2010/main" val="1968107453"/>
+        <p14:creationId xmlns:p14="http://schemas.microsoft.com/office/powerpoint/2010/main" val="1528795321"/>
       </p:ext>
     </p:extLst>
   </p:cSld>
@@ -6866,7 +6878,7 @@
           <p:cNvPr id="12" name="">
             <a:extLst xmlns:a="http://schemas.openxmlformats.org/drawingml/2006/main">
               <a:ext uri="{FF2B5EF4-FFF2-40B4-BE49-F238E27FC236}">
-                <a16:creationId xmlns:a16="http://schemas.microsoft.com/office/drawing/2014/main" id="{787E003F-CA2B-4A50-B33A-D8C95C688FBC}"/>
+                <a16:creationId xmlns:a16="http://schemas.microsoft.com/office/drawing/2014/main" id="{EBA7ABF9-2AD1-47CD-9CAB-C9CE105819F4}"/>
               </a:ext>
             </a:extLst>
           </p:cNvPr>
@@ -6911,7 +6923,7 @@
           <p:cNvPr id="2" name="">
             <a:extLst xmlns:a="http://schemas.openxmlformats.org/drawingml/2006/main">
               <a:ext uri="{FF2B5EF4-FFF2-40B4-BE49-F238E27FC236}">
-                <a16:creationId xmlns:a16="http://schemas.microsoft.com/office/drawing/2014/main" id="{93CF75C9-6297-40F4-BBA6-9492432EE5C3}"/>
+                <a16:creationId xmlns:a16="http://schemas.microsoft.com/office/drawing/2014/main" id="{179ECFBB-92C2-48E8-9B84-ED0D296306B0}"/>
               </a:ext>
             </a:extLst>
           </p:cNvPr>
@@ -6941,7 +6953,7 @@
           <p:cNvPr id="3" name="">
             <a:extLst xmlns:a="http://schemas.openxmlformats.org/drawingml/2006/main">
               <a:ext uri="{FF2B5EF4-FFF2-40B4-BE49-F238E27FC236}">
-                <a16:creationId xmlns:a16="http://schemas.microsoft.com/office/drawing/2014/main" id="{0634ADD6-BEFB-4184-B614-FEBA084354A1}"/>
+                <a16:creationId xmlns:a16="http://schemas.microsoft.com/office/drawing/2014/main" id="{83612117-4188-458D-AB79-7137E10A561C}"/>
               </a:ext>
             </a:extLst>
           </p:cNvPr>
@@ -6986,7 +6998,7 @@
           <p:cNvPr id="4" name="Chart">
             <a:extLst xmlns:a="http://schemas.openxmlformats.org/drawingml/2006/main">
               <a:ext uri="{FF2B5EF4-FFF2-40B4-BE49-F238E27FC236}">
-                <a16:creationId xmlns:a16="http://schemas.microsoft.com/office/drawing/2014/main" id="{B886552D-D426-4B67-9A22-F4C1B9418EA2}"/>
+                <a16:creationId xmlns:a16="http://schemas.microsoft.com/office/drawing/2014/main" id="{AA574F3A-6FF9-4372-A48F-250DA3FEDCDA}"/>
               </a:ext>
             </a:extLst>
           </p:cNvPr>
@@ -6999,7 +7011,7 @@
         </p:xfrm>
         <a:graphic xmlns:a="http://schemas.openxmlformats.org/drawingml/2006/main">
           <a:graphicData uri="http://schemas.openxmlformats.org/drawingml/2006/chart">
-            <c:chart xmlns:r="http://schemas.openxmlformats.org/officeDocument/2006/relationships" xmlns:c="http://schemas.openxmlformats.org/drawingml/2006/chart" r:id="Rcace51438dbf4d65"/>
+            <c:chart xmlns:r="http://schemas.openxmlformats.org/officeDocument/2006/relationships" xmlns:c="http://schemas.openxmlformats.org/drawingml/2006/chart" r:id="Rdb300c96411e4f99"/>
           </a:graphicData>
         </a:graphic>
       </p:graphicFrame>
@@ -7008,7 +7020,7 @@
           <p:cNvPr id="5" name="">
             <a:extLst xmlns:a="http://schemas.openxmlformats.org/drawingml/2006/main">
               <a:ext uri="{FF2B5EF4-FFF2-40B4-BE49-F238E27FC236}">
-                <a16:creationId xmlns:a16="http://schemas.microsoft.com/office/drawing/2014/main" id="{FCB420D4-4060-4203-9D09-136A09C22697}"/>
+                <a16:creationId xmlns:a16="http://schemas.microsoft.com/office/drawing/2014/main" id="{E82AA022-DDDC-411E-ADBB-0EA5AE7F5C90}"/>
               </a:ext>
             </a:extLst>
           </p:cNvPr>
@@ -7043,7 +7055,7 @@
                 <a:ea typeface="Arial"/>
                 <a:cs typeface="Arial"/>
               </a:rPr>
-              <a:t>1068 frames at 30W; 5 repetitions/frame. GPU timing, not wall time.</a:t>
+              <a:t>Sampled timing at 30W; mean</a:t>
             </a:r>
           </a:p>
         </p:txBody>
@@ -7053,7 +7065,7 @@
           <p:cNvPr id="6" name="">
             <a:extLst xmlns:a="http://schemas.openxmlformats.org/drawingml/2006/main">
               <a:ext uri="{FF2B5EF4-FFF2-40B4-BE49-F238E27FC236}">
-                <a16:creationId xmlns:a16="http://schemas.microsoft.com/office/drawing/2014/main" id="{A1A92C47-6C49-48BD-A3BA-D12957501D3B}"/>
+                <a16:creationId xmlns:a16="http://schemas.microsoft.com/office/drawing/2014/main" id="{21B12F02-1E9D-454D-90FC-4122BC982F82}"/>
               </a:ext>
             </a:extLst>
           </p:cNvPr>
@@ -7098,7 +7110,7 @@
           <p:cNvPr id="7" name="">
             <a:extLst xmlns:a="http://schemas.openxmlformats.org/drawingml/2006/main">
               <a:ext uri="{FF2B5EF4-FFF2-40B4-BE49-F238E27FC236}">
-                <a16:creationId xmlns:a16="http://schemas.microsoft.com/office/drawing/2014/main" id="{DC57521F-AB3E-41DD-96AF-D8CEE093EDD2}"/>
+                <a16:creationId xmlns:a16="http://schemas.microsoft.com/office/drawing/2014/main" id="{F9D493FE-5893-4AF8-80B1-EBA8A58DF817}"/>
               </a:ext>
             </a:extLst>
           </p:cNvPr>
@@ -7133,7 +7145,7 @@
                 <a:ea typeface="Arial"/>
                 <a:cs typeface="Arial"/>
               </a:rPr>
-              <a:t>6.257 ms</a:t>
+              <a:t>4.890 ms</a:t>
             </a:r>
           </a:p>
         </p:txBody>
@@ -7143,7 +7155,7 @@
           <p:cNvPr id="8" name="">
             <a:extLst xmlns:a="http://schemas.openxmlformats.org/drawingml/2006/main">
               <a:ext uri="{FF2B5EF4-FFF2-40B4-BE49-F238E27FC236}">
-                <a16:creationId xmlns:a16="http://schemas.microsoft.com/office/drawing/2014/main" id="{476675CE-E416-4ABF-9A14-554DD593E8EA}"/>
+                <a16:creationId xmlns:a16="http://schemas.microsoft.com/office/drawing/2014/main" id="{9660D510-FB88-4302-80FA-F103418C3224}"/>
               </a:ext>
             </a:extLst>
           </p:cNvPr>
@@ -7188,7 +7200,7 @@
           <p:cNvPr id="9" name="">
             <a:extLst xmlns:a="http://schemas.openxmlformats.org/drawingml/2006/main">
               <a:ext uri="{FF2B5EF4-FFF2-40B4-BE49-F238E27FC236}">
-                <a16:creationId xmlns:a16="http://schemas.microsoft.com/office/drawing/2014/main" id="{C0C2F7C3-8CC3-4F30-B3BA-E1BE23C65FED}"/>
+                <a16:creationId xmlns:a16="http://schemas.microsoft.com/office/drawing/2014/main" id="{EB4B689A-EC6C-4462-8B9A-6A93C35BD122}"/>
               </a:ext>
             </a:extLst>
           </p:cNvPr>
@@ -7223,7 +7235,7 @@
                 <a:ea typeface="Arial"/>
                 <a:cs typeface="Arial"/>
               </a:rPr>
-              <a:t>1.74×</a:t>
+              <a:t>2.18×</a:t>
             </a:r>
           </a:p>
         </p:txBody>
@@ -7233,7 +7245,7 @@
           <p:cNvPr id="10" name="">
             <a:extLst xmlns:a="http://schemas.openxmlformats.org/drawingml/2006/main">
               <a:ext uri="{FF2B5EF4-FFF2-40B4-BE49-F238E27FC236}">
-                <a16:creationId xmlns:a16="http://schemas.microsoft.com/office/drawing/2014/main" id="{1C0D56BB-C3F9-4301-955C-A076030CBBA6}"/>
+                <a16:creationId xmlns:a16="http://schemas.microsoft.com/office/drawing/2014/main" id="{19C14D4A-AFE3-42C0-8B14-B7B09830F502}"/>
               </a:ext>
             </a:extLst>
           </p:cNvPr>
@@ -7278,7 +7290,7 @@
           <p:cNvPr id="11" name="">
             <a:extLst xmlns:a="http://schemas.openxmlformats.org/drawingml/2006/main">
               <a:ext uri="{FF2B5EF4-FFF2-40B4-BE49-F238E27FC236}">
-                <a16:creationId xmlns:a16="http://schemas.microsoft.com/office/drawing/2014/main" id="{083FDFF0-1BAB-4DD4-89C1-D61FB699B399}"/>
+                <a16:creationId xmlns:a16="http://schemas.microsoft.com/office/drawing/2014/main" id="{90725BF8-3A7A-4797-B3F0-ECD7D0FAF606}"/>
               </a:ext>
             </a:extLst>
           </p:cNvPr>
@@ -7313,7 +7325,7 @@
                 <a:ea typeface="Arial"/>
                 <a:cs typeface="Arial"/>
               </a:rPr>
-              <a:t>Derived budget, not measured end-to-end. Copies excluded. Includes clearing and resampling; no optimal-Full claim.</a:t>
+              <a:t>Timing: 500 frames. Fixed 2 ms decode budget + measured reconstruction; not measured end-to-end.</a:t>
             </a:r>
           </a:p>
         </p:txBody>
@@ -7321,7 +7333,7 @@
     </p:spTree>
     <p:extLst>
       <p:ext uri="{BB962C8B-B14F-4D97-AF65-F5344CB8AC3E}">
-        <p14:creationId xmlns:p14="http://schemas.microsoft.com/office/powerpoint/2010/main" val="1841926725"/>
+        <p14:creationId xmlns:p14="http://schemas.microsoft.com/office/powerpoint/2010/main" val="1011385261"/>
       </p:ext>
     </p:extLst>
   </p:cSld>
@@ -7352,7 +7364,7 @@
           <p:cNvPr id="8" name="">
             <a:extLst xmlns:a="http://schemas.openxmlformats.org/drawingml/2006/main">
               <a:ext uri="{FF2B5EF4-FFF2-40B4-BE49-F238E27FC236}">
-                <a16:creationId xmlns:a16="http://schemas.microsoft.com/office/drawing/2014/main" id="{2D27BD5C-1D53-4591-B927-ADEFEF998F8F}"/>
+                <a16:creationId xmlns:a16="http://schemas.microsoft.com/office/drawing/2014/main" id="{7BCFC477-6F35-4ED5-A7D6-D01B1B2C7126}"/>
               </a:ext>
             </a:extLst>
           </p:cNvPr>
@@ -7397,7 +7409,7 @@
           <p:cNvPr id="2" name="">
             <a:extLst xmlns:a="http://schemas.openxmlformats.org/drawingml/2006/main">
               <a:ext uri="{FF2B5EF4-FFF2-40B4-BE49-F238E27FC236}">
-                <a16:creationId xmlns:a16="http://schemas.microsoft.com/office/drawing/2014/main" id="{6238650C-9037-4AB2-95F7-F6BBF6253FF6}"/>
+                <a16:creationId xmlns:a16="http://schemas.microsoft.com/office/drawing/2014/main" id="{4D4195D6-956B-4022-B8FF-EFAD6B57982B}"/>
               </a:ext>
             </a:extLst>
           </p:cNvPr>
@@ -7427,7 +7439,7 @@
           <p:cNvPr id="3" name="">
             <a:extLst xmlns:a="http://schemas.openxmlformats.org/drawingml/2006/main">
               <a:ext uri="{FF2B5EF4-FFF2-40B4-BE49-F238E27FC236}">
-                <a16:creationId xmlns:a16="http://schemas.microsoft.com/office/drawing/2014/main" id="{E0063598-DD78-42F3-9F07-68FFA4250A95}"/>
+                <a16:creationId xmlns:a16="http://schemas.microsoft.com/office/drawing/2014/main" id="{5BDC7ADE-99E4-4099-8DB9-F1AC5E697145}"/>
               </a:ext>
             </a:extLst>
           </p:cNvPr>
@@ -7472,7 +7484,7 @@
           <p:cNvPr id="4" name="">
             <a:extLst xmlns:a="http://schemas.openxmlformats.org/drawingml/2006/main">
               <a:ext uri="{FF2B5EF4-FFF2-40B4-BE49-F238E27FC236}">
-                <a16:creationId xmlns:a16="http://schemas.microsoft.com/office/drawing/2014/main" id="{49E244F8-0B9B-4822-8D52-6F832A090294}"/>
+                <a16:creationId xmlns:a16="http://schemas.microsoft.com/office/drawing/2014/main" id="{026F19FD-188F-4757-9FA6-213822D9F1A8}"/>
               </a:ext>
             </a:extLst>
           </p:cNvPr>
@@ -7492,7 +7504,7 @@
                 <a:gridCol w="3714750"/>
                 <a:gridCol w="4019550"/>
               </a:tblGrid>
-              <a:tr h="802481">
+              <a:tr h="641985">
                 <a:tc>
                   <a:txBody>
                     <a:bodyPr/>
@@ -7626,7 +7638,7 @@
                   </a:tcPr>
                 </a:tc>
               </a:tr>
-              <a:tr h="802481">
+              <a:tr h="641985">
                 <a:tc>
                   <a:txBody>
                     <a:bodyPr/>
@@ -7683,7 +7695,7 @@
                           <a:ea typeface="Arial"/>
                           <a:cs typeface="Arial"/>
                         </a:rPr>
-                        <a:t>5.631 ms</a:t>
+                        <a:t>4.460 ms</a:t>
                       </a:r>
                     </a:p>
                   </a:txBody>
@@ -7719,7 +7731,7 @@
                           <a:ea typeface="Arial"/>
                           <a:cs typeface="Arial"/>
                         </a:rPr>
-                        <a:t>0.0859</a:t>
+                        <a:t>0.0979</a:t>
                       </a:r>
                     </a:p>
                   </a:txBody>
@@ -7742,7 +7754,7 @@
                   </a:tcPr>
                 </a:tc>
               </a:tr>
-              <a:tr h="802481">
+              <a:tr h="641985">
                 <a:tc>
                   <a:txBody>
                     <a:bodyPr/>
@@ -7799,7 +7811,7 @@
                           <a:ea typeface="Arial"/>
                           <a:cs typeface="Arial"/>
                         </a:rPr>
-                        <a:t>6.257 ms</a:t>
+                        <a:t>4.890 ms</a:t>
                       </a:r>
                     </a:p>
                   </a:txBody>
@@ -7835,7 +7847,7 @@
                           <a:ea typeface="Arial"/>
                           <a:cs typeface="Arial"/>
                         </a:rPr>
-                        <a:t>0.0785</a:t>
+                        <a:t>0.0904</a:t>
                       </a:r>
                     </a:p>
                   </a:txBody>
@@ -7858,7 +7870,7 @@
                   </a:tcPr>
                 </a:tc>
               </a:tr>
-              <a:tr h="802481">
+              <a:tr h="641985">
                 <a:tc>
                   <a:txBody>
                     <a:bodyPr/>
@@ -7915,7 +7927,7 @@
                           <a:ea typeface="Arial"/>
                           <a:cs typeface="Arial"/>
                         </a:rPr>
-                        <a:t>8.158 ms</a:t>
+                        <a:t>6.461 ms</a:t>
                       </a:r>
                     </a:p>
                   </a:txBody>
@@ -7951,7 +7963,7 @@
                           <a:ea typeface="Arial"/>
                           <a:cs typeface="Arial"/>
                         </a:rPr>
-                        <a:t>0.0599</a:t>
+                        <a:t>0.0712</a:t>
                       </a:r>
                     </a:p>
                   </a:txBody>
@@ -7974,6 +7986,122 @@
                   </a:tcPr>
                 </a:tc>
               </a:tr>
+              <a:tr h="641985">
+                <a:tc>
+                  <a:txBody>
+                    <a:bodyPr/>
+                    <a:lstStyle/>
+                    <a:p>
+                      <a:r>
+                        <a:rPr sz="2025" b="0">
+                          <a:solidFill>
+                            <a:srgbClr val="152D43"/>
+                          </a:solidFill>
+                          <a:latin typeface="Arial"/>
+                          <a:ea typeface="Arial"/>
+                          <a:cs typeface="Arial"/>
+                        </a:rPr>
+                        <a:t>0.7×</a:t>
+                      </a:r>
+                    </a:p>
+                  </a:txBody>
+                  <a:tcPr marL="91440" marR="91440" marT="45720" marB="45720">
+                    <a:lnL w="9525">
+                      <a:solidFill>
+                        <a:srgbClr val="D7DFE5"/>
+                      </a:solidFill>
+                      <a:prstDash val="solid"/>
+                    </a:lnL>
+                    <a:lnR w="9525">
+                      <a:solidFill>
+                        <a:srgbClr val="D7DFE5"/>
+                      </a:solidFill>
+                      <a:prstDash val="solid"/>
+                    </a:lnR>
+                    <a:lnB w="9525">
+                      <a:solidFill>
+                        <a:srgbClr val="D7DFE5"/>
+                      </a:solidFill>
+                      <a:prstDash val="solid"/>
+                    </a:lnB>
+                    <a:solidFill>
+                      <a:srgbClr val="EAF3F6"/>
+                    </a:solidFill>
+                  </a:tcPr>
+                </a:tc>
+                <a:tc>
+                  <a:txBody>
+                    <a:bodyPr/>
+                    <a:lstStyle/>
+                    <a:p>
+                      <a:r>
+                        <a:rPr sz="2025" b="0">
+                          <a:solidFill>
+                            <a:srgbClr val="152D43"/>
+                          </a:solidFill>
+                          <a:latin typeface="Arial"/>
+                          <a:ea typeface="Arial"/>
+                          <a:cs typeface="Arial"/>
+                        </a:rPr>
+                        <a:t>7.429 ms</a:t>
+                      </a:r>
+                    </a:p>
+                  </a:txBody>
+                  <a:tcPr marL="91440" marR="91440" marT="45720" marB="45720">
+                    <a:lnR w="9525">
+                      <a:solidFill>
+                        <a:srgbClr val="D7DFE5"/>
+                      </a:solidFill>
+                      <a:prstDash val="solid"/>
+                    </a:lnR>
+                    <a:lnB w="9525">
+                      <a:solidFill>
+                        <a:srgbClr val="D7DFE5"/>
+                      </a:solidFill>
+                      <a:prstDash val="solid"/>
+                    </a:lnB>
+                    <a:solidFill>
+                      <a:srgbClr val="EAF3F6"/>
+                    </a:solidFill>
+                  </a:tcPr>
+                </a:tc>
+                <a:tc>
+                  <a:txBody>
+                    <a:bodyPr/>
+                    <a:lstStyle/>
+                    <a:p>
+                      <a:r>
+                        <a:rPr sz="2025" b="0">
+                          <a:solidFill>
+                            <a:srgbClr val="152D43"/>
+                          </a:solidFill>
+                          <a:latin typeface="Arial"/>
+                          <a:ea typeface="Arial"/>
+                          <a:cs typeface="Arial"/>
+                        </a:rPr>
+                        <a:t>0.0481</a:t>
+                      </a:r>
+                    </a:p>
+                  </a:txBody>
+                  <a:tcPr marL="91440" marR="91440" marT="45720" marB="45720">
+                    <a:lnR w="9525">
+                      <a:solidFill>
+                        <a:srgbClr val="D7DFE5"/>
+                      </a:solidFill>
+                      <a:prstDash val="solid"/>
+                    </a:lnR>
+                    <a:lnB w="9525">
+                      <a:solidFill>
+                        <a:srgbClr val="D7DFE5"/>
+                      </a:solidFill>
+                      <a:prstDash val="solid"/>
+                    </a:lnB>
+                    <a:solidFill>
+                      <a:srgbClr val="EAF3F6"/>
+                    </a:solidFill>
+                  </a:tcPr>
+                </a:tc>
+              </a:tr>
             </a:tbl>
           </a:graphicData>
         </a:graphic>
@@ -7983,7 +8111,7 @@
           <p:cNvPr id="5" name="">
             <a:extLst xmlns:a="http://schemas.openxmlformats.org/drawingml/2006/main">
               <a:ext uri="{FF2B5EF4-FFF2-40B4-BE49-F238E27FC236}">
-                <a16:creationId xmlns:a16="http://schemas.microsoft.com/office/drawing/2014/main" id="{E6260E00-BE88-4BF3-AA36-0F3953153A39}"/>
+                <a16:creationId xmlns:a16="http://schemas.microsoft.com/office/drawing/2014/main" id="{487942ED-0D28-4DC7-AB72-F95EC1BFCB0D}"/>
               </a:ext>
             </a:extLst>
           </p:cNvPr>
@@ -8028,7 +8156,7 @@
           <p:cNvPr id="6" name="">
             <a:extLst xmlns:a="http://schemas.openxmlformats.org/drawingml/2006/main">
               <a:ext uri="{FF2B5EF4-FFF2-40B4-BE49-F238E27FC236}">
-                <a16:creationId xmlns:a16="http://schemas.microsoft.com/office/drawing/2014/main" id="{1C62D957-4003-4D07-A01D-1B17E75C366E}"/>
+                <a16:creationId xmlns:a16="http://schemas.microsoft.com/office/drawing/2014/main" id="{2E77EBE6-E15A-4EAA-A2BF-9ADF1EE8DC8C}"/>
               </a:ext>
             </a:extLst>
           </p:cNvPr>
@@ -8063,7 +8191,7 @@
                 <a:ea typeface="Arial"/>
                 <a:cs typeface="Arial"/>
               </a:rPr>
-              <a:t>Original overflow PSNR preserved. Quality and timing: same 30W run, 1068 frames.</a:t>
+              <a:t>PSNR uses the original evaluation protocol.</a:t>
             </a:r>
           </a:p>
         </p:txBody>
@@ -8073,7 +8201,7 @@
           <p:cNvPr id="7" name="">
             <a:extLst xmlns:a="http://schemas.openxmlformats.org/drawingml/2006/main">
               <a:ext uri="{FF2B5EF4-FFF2-40B4-BE49-F238E27FC236}">
-                <a16:creationId xmlns:a16="http://schemas.microsoft.com/office/drawing/2014/main" id="{841887F4-034A-451D-833C-12B83E11F75F}"/>
+                <a16:creationId xmlns:a16="http://schemas.microsoft.com/office/drawing/2014/main" id="{1BC46B50-141F-4DB7-9812-526CCA6F1615}"/>
               </a:ext>
             </a:extLst>
           </p:cNvPr>
@@ -8108,7 +8236,7 @@
                 <a:ea typeface="Arial"/>
                 <a:cs typeface="Arial"/>
               </a:rPr>
-              <a:t>Timing adds a fixed 2 ms decode budget; not measured end-to-end.</a:t>
+              <a:t>Timing: 500 frames. Quality: 672 frames. Fixed decode budget: 2 ms.</a:t>
             </a:r>
           </a:p>
         </p:txBody>
@@ -8116,7 +8244,7 @@
     </p:spTree>
     <p:extLst>
       <p:ext uri="{BB962C8B-B14F-4D97-AF65-F5344CB8AC3E}">
-        <p14:creationId xmlns:p14="http://schemas.microsoft.com/office/powerpoint/2010/main" val="1749368288"/>
+        <p14:creationId xmlns:p14="http://schemas.microsoft.com/office/powerpoint/2010/main" val="690856604"/>
       </p:ext>
     </p:extLst>
   </p:cSld>
@@ -8147,7 +8275,7 @@
           <p:cNvPr id="14" name="">
             <a:extLst xmlns:a="http://schemas.openxmlformats.org/drawingml/2006/main">
               <a:ext uri="{FF2B5EF4-FFF2-40B4-BE49-F238E27FC236}">
-                <a16:creationId xmlns:a16="http://schemas.microsoft.com/office/drawing/2014/main" id="{7340E5E0-BA90-45BF-BEC9-211C0F9CDD3A}"/>
+                <a16:creationId xmlns:a16="http://schemas.microsoft.com/office/drawing/2014/main" id="{BCCE9A48-1D6E-4A83-9CA1-8CFE400186B1}"/>
               </a:ext>
             </a:extLst>
           </p:cNvPr>
@@ -8192,7 +8320,7 @@
           <p:cNvPr id="2" name="">
             <a:extLst xmlns:a="http://schemas.openxmlformats.org/drawingml/2006/main">
               <a:ext uri="{FF2B5EF4-FFF2-40B4-BE49-F238E27FC236}">
-                <a16:creationId xmlns:a16="http://schemas.microsoft.com/office/drawing/2014/main" id="{27240A45-73A3-419D-B6A6-4FAB5FAF3A59}"/>
+                <a16:creationId xmlns:a16="http://schemas.microsoft.com/office/drawing/2014/main" id="{E066C3A2-BB63-4190-B0FA-9FA817E0AFA4}"/>
               </a:ext>
             </a:extLst>
           </p:cNvPr>
@@ -8222,7 +8350,7 @@
           <p:cNvPr id="3" name="">
             <a:extLst xmlns:a="http://schemas.openxmlformats.org/drawingml/2006/main">
               <a:ext uri="{FF2B5EF4-FFF2-40B4-BE49-F238E27FC236}">
-                <a16:creationId xmlns:a16="http://schemas.microsoft.com/office/drawing/2014/main" id="{AE28BB7F-5AF8-4460-B091-180B35AAECBD}"/>
+                <a16:creationId xmlns:a16="http://schemas.microsoft.com/office/drawing/2014/main" id="{0B304B32-2D64-4CBA-8EDC-36675DF42308}"/>
               </a:ext>
             </a:extLst>
           </p:cNvPr>
@@ -8267,7 +8395,7 @@
           <p:cNvPr id="4" name="">
             <a:extLst xmlns:a="http://schemas.openxmlformats.org/drawingml/2006/main">
               <a:ext uri="{FF2B5EF4-FFF2-40B4-BE49-F238E27FC236}">
-                <a16:creationId xmlns:a16="http://schemas.microsoft.com/office/drawing/2014/main" id="{A84A3BCE-9310-4826-B745-8064F6E74545}"/>
+                <a16:creationId xmlns:a16="http://schemas.microsoft.com/office/drawing/2014/main" id="{1B4A34E0-79F6-4E96-B5BF-794DB4C20077}"/>
               </a:ext>
             </a:extLst>
           </p:cNvPr>
@@ -8312,7 +8440,7 @@
           <p:cNvPr id="5" name="">
             <a:extLst xmlns:a="http://schemas.openxmlformats.org/drawingml/2006/main">
               <a:ext uri="{FF2B5EF4-FFF2-40B4-BE49-F238E27FC236}">
-                <a16:creationId xmlns:a16="http://schemas.microsoft.com/office/drawing/2014/main" id="{E6B05D98-95B4-4453-B73F-A64166B8FBB7}"/>
+                <a16:creationId xmlns:a16="http://schemas.microsoft.com/office/drawing/2014/main" id="{6435A1F5-991A-4360-89DD-23A7EBDC4942}"/>
               </a:ext>
             </a:extLst>
           </p:cNvPr>
@@ -8357,7 +8485,7 @@
           <p:cNvPr id="6" name="">
             <a:extLst xmlns:a="http://schemas.openxmlformats.org/drawingml/2006/main">
               <a:ext uri="{FF2B5EF4-FFF2-40B4-BE49-F238E27FC236}">
-                <a16:creationId xmlns:a16="http://schemas.microsoft.com/office/drawing/2014/main" id="{A7315D8C-959B-475F-8AF8-3CF724DA0896}"/>
+                <a16:creationId xmlns:a16="http://schemas.microsoft.com/office/drawing/2014/main" id="{DDFEC6B9-CCA3-4EB7-B161-5D6AEEA42041}"/>
               </a:ext>
             </a:extLst>
           </p:cNvPr>
@@ -8402,7 +8530,7 @@
           <p:cNvPr id="7" name="">
             <a:extLst xmlns:a="http://schemas.openxmlformats.org/drawingml/2006/main">
               <a:ext uri="{FF2B5EF4-FFF2-40B4-BE49-F238E27FC236}">
-                <a16:creationId xmlns:a16="http://schemas.microsoft.com/office/drawing/2014/main" id="{3B910781-E82E-43D5-A987-32BDC7EA1FAA}"/>
+                <a16:creationId xmlns:a16="http://schemas.microsoft.com/office/drawing/2014/main" id="{AF24A686-9EEC-4FAC-BB2C-EBD8850C1157}"/>
               </a:ext>
             </a:extLst>
           </p:cNvPr>
@@ -8447,7 +8575,7 @@
           <p:cNvPr id="8" name="">
             <a:extLst xmlns:a="http://schemas.openxmlformats.org/drawingml/2006/main">
               <a:ext uri="{FF2B5EF4-FFF2-40B4-BE49-F238E27FC236}">
-                <a16:creationId xmlns:a16="http://schemas.microsoft.com/office/drawing/2014/main" id="{072D710E-13CE-4C17-91CB-FD1C27079BAE}"/>
+                <a16:creationId xmlns:a16="http://schemas.microsoft.com/office/drawing/2014/main" id="{AAA565A7-980A-48D4-9D35-431B15588789}"/>
               </a:ext>
             </a:extLst>
           </p:cNvPr>
@@ -8492,7 +8620,7 @@
           <p:cNvPr id="9" name="">
             <a:extLst xmlns:a="http://schemas.openxmlformats.org/drawingml/2006/main">
               <a:ext uri="{FF2B5EF4-FFF2-40B4-BE49-F238E27FC236}">
-                <a16:creationId xmlns:a16="http://schemas.microsoft.com/office/drawing/2014/main" id="{8C6B8D78-F0AF-4F2C-9DD5-8800E0CE1124}"/>
+                <a16:creationId xmlns:a16="http://schemas.microsoft.com/office/drawing/2014/main" id="{77268D79-0BF4-489D-B449-E059BC7792FA}"/>
               </a:ext>
             </a:extLst>
           </p:cNvPr>
@@ -8537,7 +8665,7 @@
           <p:cNvPr id="10" name="">
             <a:extLst xmlns:a="http://schemas.openxmlformats.org/drawingml/2006/main">
               <a:ext uri="{FF2B5EF4-FFF2-40B4-BE49-F238E27FC236}">
-                <a16:creationId xmlns:a16="http://schemas.microsoft.com/office/drawing/2014/main" id="{4095094E-494A-4857-9546-697B8729225A}"/>
+                <a16:creationId xmlns:a16="http://schemas.microsoft.com/office/drawing/2014/main" id="{435D6491-AFD1-4196-8FDB-A4F72CE74A6A}"/>
               </a:ext>
             </a:extLst>
           </p:cNvPr>
@@ -8582,7 +8710,7 @@
           <p:cNvPr id="11" name="">
             <a:extLst xmlns:a="http://schemas.openxmlformats.org/drawingml/2006/main">
               <a:ext uri="{FF2B5EF4-FFF2-40B4-BE49-F238E27FC236}">
-                <a16:creationId xmlns:a16="http://schemas.microsoft.com/office/drawing/2014/main" id="{2D689CAB-75C3-4CBD-BF4F-44DC445B4D3A}"/>
+                <a16:creationId xmlns:a16="http://schemas.microsoft.com/office/drawing/2014/main" id="{7752B160-2CA6-4869-A7FF-FB96C326714F}"/>
               </a:ext>
             </a:extLst>
           </p:cNvPr>
@@ -8627,7 +8755,7 @@
           <p:cNvPr id="12" name="">
             <a:extLst xmlns:a="http://schemas.openxmlformats.org/drawingml/2006/main">
               <a:ext uri="{FF2B5EF4-FFF2-40B4-BE49-F238E27FC236}">
-                <a16:creationId xmlns:a16="http://schemas.microsoft.com/office/drawing/2014/main" id="{7744A144-5FA2-4DAD-8290-579FD24215CA}"/>
+                <a16:creationId xmlns:a16="http://schemas.microsoft.com/office/drawing/2014/main" id="{BE51B4C8-AB44-4ECB-BE8A-9A1F98961A92}"/>
               </a:ext>
             </a:extLst>
           </p:cNvPr>
@@ -8672,7 +8800,7 @@
           <p:cNvPr id="13" name="">
             <a:extLst xmlns:a="http://schemas.openxmlformats.org/drawingml/2006/main">
               <a:ext uri="{FF2B5EF4-FFF2-40B4-BE49-F238E27FC236}">
-                <a16:creationId xmlns:a16="http://schemas.microsoft.com/office/drawing/2014/main" id="{EC50BF56-F2B8-4A3B-9D5A-07178816AC09}"/>
+                <a16:creationId xmlns:a16="http://schemas.microsoft.com/office/drawing/2014/main" id="{C104C9E1-CBC9-4C84-881E-2AB654BF59D4}"/>
               </a:ext>
             </a:extLst>
           </p:cNvPr>
@@ -8715,7 +8843,7 @@
     </p:spTree>
     <p:extLst>
       <p:ext uri="{BB962C8B-B14F-4D97-AF65-F5344CB8AC3E}">
-        <p14:creationId xmlns:p14="http://schemas.microsoft.com/office/powerpoint/2010/main" val="1815090642"/>
+        <p14:creationId xmlns:p14="http://schemas.microsoft.com/office/powerpoint/2010/main" val="326408459"/>
       </p:ext>
     </p:extLst>
   </p:cSld>

</xml_diff>

<commit_message>
Add Full reference row and remove next-steps slide
</commit_message>
<xml_diff>
--- a/presentations/weekly_20261029/weekly_20261029_english_30w.pptx
+++ b/presentations/weekly_20261029/weekly_20261029_english_30w.pptx
@@ -2,19 +2,18 @@
 <file path=ppt/presentation.xml><?xml version="1.0" encoding="utf-8"?>
 <p:presentation xmlns:p="http://schemas.openxmlformats.org/presentationml/2006/main">
   <p:sldMasterIdLst>
-    <p:sldMasterId xmlns:r="http://schemas.openxmlformats.org/officeDocument/2006/relationships" id="2147483648" r:id="Rf690a31be8c84dd3"/>
+    <p:sldMasterId xmlns:r="http://schemas.openxmlformats.org/officeDocument/2006/relationships" id="2147483648" r:id="Rb8ee618e2280419d"/>
   </p:sldMasterIdLst>
   <p:notesMasterIdLst>
-    <p:notesMasterId xmlns:r="http://schemas.openxmlformats.org/officeDocument/2006/relationships" r:id="R0efe101220a64ac0"/>
+    <p:notesMasterId xmlns:r="http://schemas.openxmlformats.org/officeDocument/2006/relationships" r:id="Rda22ccb23be94a4d"/>
   </p:notesMasterIdLst>
   <p:sldIdLst>
-    <p:sldId xmlns:r="http://schemas.openxmlformats.org/officeDocument/2006/relationships" id="256" r:id="Rb55fbf17bc4b4755"/>
-    <p:sldId xmlns:r="http://schemas.openxmlformats.org/officeDocument/2006/relationships" id="257" r:id="Rdda749aa707d4ae3"/>
-    <p:sldId xmlns:r="http://schemas.openxmlformats.org/officeDocument/2006/relationships" id="258" r:id="R1beee0aa97bf4345"/>
-    <p:sldId xmlns:r="http://schemas.openxmlformats.org/officeDocument/2006/relationships" id="259" r:id="Rc05d8a1316674e31"/>
-    <p:sldId xmlns:r="http://schemas.openxmlformats.org/officeDocument/2006/relationships" id="260" r:id="R432243fde55d4be6"/>
-    <p:sldId xmlns:r="http://schemas.openxmlformats.org/officeDocument/2006/relationships" id="261" r:id="Rae603fbc004e49f0"/>
-    <p:sldId xmlns:r="http://schemas.openxmlformats.org/officeDocument/2006/relationships" id="262" r:id="R4f5df459e4a74de5"/>
+    <p:sldId xmlns:r="http://schemas.openxmlformats.org/officeDocument/2006/relationships" id="256" r:id="Re9e29533bc574e0d"/>
+    <p:sldId xmlns:r="http://schemas.openxmlformats.org/officeDocument/2006/relationships" id="257" r:id="R3465666631ad44b1"/>
+    <p:sldId xmlns:r="http://schemas.openxmlformats.org/officeDocument/2006/relationships" id="258" r:id="Ra355d07bf40b43e7"/>
+    <p:sldId xmlns:r="http://schemas.openxmlformats.org/officeDocument/2006/relationships" id="259" r:id="R977e2b604f144301"/>
+    <p:sldId xmlns:r="http://schemas.openxmlformats.org/officeDocument/2006/relationships" id="260" r:id="R1ac3b8a4a790423a"/>
+    <p:sldId xmlns:r="http://schemas.openxmlformats.org/officeDocument/2006/relationships" id="261" r:id="R992fdb30862b4d8c"/>
   </p:sldIdLst>
   <p:sldSz cx="12192000" cy="6858000"/>
   <p:notesSz cx="6858000" cy="9144000"/>
@@ -828,76 +827,6 @@
 </p:notes>
 </file>
 
-<file path=ppt/notesSlides/notesSlide7.xml><?xml version="1.0" encoding="utf-8"?>
-<p:notes xmlns:p="http://schemas.openxmlformats.org/presentationml/2006/main">
-  <p:cSld>
-    <p:spTree>
-      <p:nvGrpSpPr>
-        <p:cNvPr id="1" name=""/>
-        <p:cNvGrpSpPr/>
-        <p:nvPr/>
-      </p:nvGrpSpPr>
-      <p:grpSpPr>
-        <a:xfrm xmlns:a="http://schemas.openxmlformats.org/drawingml/2006/main"/>
-      </p:grpSpPr>
-      <p:sp>
-        <p:nvSpPr>
-          <p:cNvPr id="2" name="Slide Image Placeholder 1"/>
-          <p:cNvSpPr>
-            <a:spLocks xmlns:a="http://schemas.openxmlformats.org/drawingml/2006/main" noGrp="1"/>
-          </p:cNvSpPr>
-          <p:nvPr>
-            <p:ph type="sldImg" idx="0"/>
-          </p:nvPr>
-        </p:nvSpPr>
-        <p:spPr/>
-      </p:sp>
-      <p:sp>
-        <p:nvSpPr>
-          <p:cNvPr id="3" name="Notes Placeholder 2"/>
-          <p:cNvSpPr>
-            <a:spLocks xmlns:a="http://schemas.openxmlformats.org/drawingml/2006/main" noGrp="1"/>
-          </p:cNvSpPr>
-          <p:nvPr>
-            <p:ph type="body" idx="1"/>
-          </p:nvPr>
-        </p:nvSpPr>
-        <p:spPr/>
-        <p:txBody>
-          <a:bodyPr xmlns:a="http://schemas.openxmlformats.org/drawingml/2006/main"/>
-          <a:lstStyle xmlns:a="http://schemas.openxmlformats.org/drawingml/2006/main"/>
-          <a:p xmlns:a="http://schemas.openxmlformats.org/drawingml/2006/main">
-            <a:r>
-              <a:t>Proposed future work; no measured jitter trace or deadline-miss reduction exists in the current experiment. Slides 5–6 add a fixed 2 ms decode budget to local reconstruction means. Other timing values are local reconstruction measurements. None are measured end-to-end VR results.</a:t>
-            </a:r>
-          </a:p>
-        </p:txBody>
-      </p:sp>
-      <p:sp>
-        <p:nvSpPr>
-          <p:cNvPr id="4" name="Slide Number Placeholder 3"/>
-          <p:cNvSpPr>
-            <a:spLocks xmlns:a="http://schemas.openxmlformats.org/drawingml/2006/main" noGrp="1"/>
-          </p:cNvSpPr>
-          <p:nvPr>
-            <p:ph type="sldNum" idx="5"/>
-          </p:nvPr>
-        </p:nvSpPr>
-        <p:spPr/>
-        <p:txBody>
-          <a:bodyPr xmlns:a="http://schemas.openxmlformats.org/drawingml/2006/main"/>
-          <a:lstStyle xmlns:a="http://schemas.openxmlformats.org/drawingml/2006/main"/>
-          <a:p xmlns:a="http://schemas.openxmlformats.org/drawingml/2006/main"/>
-        </p:txBody>
-      </p:sp>
-    </p:spTree>
-  </p:cSld>
-  <p:clrMapOvr>
-    <a:masterClrMapping xmlns:a="http://schemas.openxmlformats.org/drawingml/2006/main"/>
-  </p:clrMapOvr>
-</p:notes>
-</file>
-
 <file path=ppt/slideLayouts/slideLayout1.xml><?xml version="1.0" encoding="utf-8"?>
 <p:sldLayout xmlns:p="http://schemas.openxmlformats.org/presentationml/2006/main" type="title">
   <p:cSld name="Title Slide">
@@ -915,7 +844,7 @@
           <p:cNvPr id="3" name="Title">
             <a:extLst xmlns:a="http://schemas.openxmlformats.org/drawingml/2006/main">
               <a:ext uri="{FF2B5EF4-FFF2-40B4-BE49-F238E27FC236}">
-                <a16:creationId xmlns:a16="http://schemas.microsoft.com/office/drawing/2014/main" id="{6BED6099-54D8-4A41-B6D9-0C0DAB523DD1}"/>
+                <a16:creationId xmlns:a16="http://schemas.microsoft.com/office/drawing/2014/main" id="{F3234756-93B2-4767-BD9E-6FE043BAA4AF}"/>
               </a:ext>
             </a:extLst>
           </p:cNvPr>
@@ -1144,7 +1073,7 @@
           <p:cNvPr id="2" name="Subtitle">
             <a:extLst xmlns:a="http://schemas.openxmlformats.org/drawingml/2006/main">
               <a:ext uri="{FF2B5EF4-FFF2-40B4-BE49-F238E27FC236}">
-                <a16:creationId xmlns:a16="http://schemas.microsoft.com/office/drawing/2014/main" id="{34D6C2DF-49FA-424B-B556-85EC672EAD11}"/>
+                <a16:creationId xmlns:a16="http://schemas.microsoft.com/office/drawing/2014/main" id="{2B7C7DB0-7FE5-4C1A-84FA-B310BE0A2D05}"/>
               </a:ext>
             </a:extLst>
           </p:cNvPr>
@@ -1390,7 +1319,7 @@
           <p:cNvPr id="2" name="Section title">
             <a:extLst xmlns:a="http://schemas.openxmlformats.org/drawingml/2006/main">
               <a:ext uri="{FF2B5EF4-FFF2-40B4-BE49-F238E27FC236}">
-                <a16:creationId xmlns:a16="http://schemas.microsoft.com/office/drawing/2014/main" id="{7402D87B-56C8-4565-933B-558ECA55D93B}"/>
+                <a16:creationId xmlns:a16="http://schemas.microsoft.com/office/drawing/2014/main" id="{6BF5B1A7-A1DD-4060-93DB-5462016A0434}"/>
               </a:ext>
             </a:extLst>
           </p:cNvPr>
@@ -1636,7 +1565,7 @@
           <p:cNvPr id="3" name="Title">
             <a:extLst xmlns:a="http://schemas.openxmlformats.org/drawingml/2006/main">
               <a:ext uri="{FF2B5EF4-FFF2-40B4-BE49-F238E27FC236}">
-                <a16:creationId xmlns:a16="http://schemas.microsoft.com/office/drawing/2014/main" id="{D1BB576B-61FA-4986-ACA1-CB7285BB1D59}"/>
+                <a16:creationId xmlns:a16="http://schemas.microsoft.com/office/drawing/2014/main" id="{F8A9D8BD-F94B-4C3F-90E0-DB8F8F880CC7}"/>
               </a:ext>
             </a:extLst>
           </p:cNvPr>
@@ -1865,7 +1794,7 @@
           <p:cNvPr id="2" name="Body">
             <a:extLst xmlns:a="http://schemas.openxmlformats.org/drawingml/2006/main">
               <a:ext uri="{FF2B5EF4-FFF2-40B4-BE49-F238E27FC236}">
-                <a16:creationId xmlns:a16="http://schemas.microsoft.com/office/drawing/2014/main" id="{942305A6-4251-4CA5-9C32-D82C31F2031F}"/>
+                <a16:creationId xmlns:a16="http://schemas.microsoft.com/office/drawing/2014/main" id="{61A3BF5D-794A-4D71-B347-C1EFA211B5B6}"/>
               </a:ext>
             </a:extLst>
           </p:cNvPr>
@@ -2111,7 +2040,7 @@
           <p:cNvPr id="4" name="Title">
             <a:extLst xmlns:a="http://schemas.openxmlformats.org/drawingml/2006/main">
               <a:ext uri="{FF2B5EF4-FFF2-40B4-BE49-F238E27FC236}">
-                <a16:creationId xmlns:a16="http://schemas.microsoft.com/office/drawing/2014/main" id="{E5B95822-C253-40C2-BB5C-968A69644AA8}"/>
+                <a16:creationId xmlns:a16="http://schemas.microsoft.com/office/drawing/2014/main" id="{01295B9E-34E2-42CB-8D70-A937B4621CAF}"/>
               </a:ext>
             </a:extLst>
           </p:cNvPr>
@@ -2340,7 +2269,7 @@
           <p:cNvPr id="2" name="Left column">
             <a:extLst xmlns:a="http://schemas.openxmlformats.org/drawingml/2006/main">
               <a:ext uri="{FF2B5EF4-FFF2-40B4-BE49-F238E27FC236}">
-                <a16:creationId xmlns:a16="http://schemas.microsoft.com/office/drawing/2014/main" id="{AE4E8BDA-09B6-4366-84EC-837692FE27DB}"/>
+                <a16:creationId xmlns:a16="http://schemas.microsoft.com/office/drawing/2014/main" id="{F13F9569-5947-4E96-AB27-00D7764DFD1B}"/>
               </a:ext>
             </a:extLst>
           </p:cNvPr>
@@ -2569,7 +2498,7 @@
           <p:cNvPr id="3" name="Right column">
             <a:extLst xmlns:a="http://schemas.openxmlformats.org/drawingml/2006/main">
               <a:ext uri="{FF2B5EF4-FFF2-40B4-BE49-F238E27FC236}">
-                <a16:creationId xmlns:a16="http://schemas.microsoft.com/office/drawing/2014/main" id="{CCB2563A-63E5-4A5A-A2C0-F138C1757534}"/>
+                <a16:creationId xmlns:a16="http://schemas.microsoft.com/office/drawing/2014/main" id="{F9669E77-B412-4389-8D3C-157FC39229C7}"/>
               </a:ext>
             </a:extLst>
           </p:cNvPr>
@@ -2815,7 +2744,7 @@
           <p:cNvPr id="3" name="Title">
             <a:extLst xmlns:a="http://schemas.openxmlformats.org/drawingml/2006/main">
               <a:ext uri="{FF2B5EF4-FFF2-40B4-BE49-F238E27FC236}">
-                <a16:creationId xmlns:a16="http://schemas.microsoft.com/office/drawing/2014/main" id="{49646206-AAE7-4D3B-AD6E-B1303BDA7EA8}"/>
+                <a16:creationId xmlns:a16="http://schemas.microsoft.com/office/drawing/2014/main" id="{82F4E557-A2F6-43FA-ACCD-193DB3802703}"/>
               </a:ext>
             </a:extLst>
           </p:cNvPr>
@@ -3044,7 +2973,7 @@
           <p:cNvPr id="2" name="Left column">
             <a:extLst xmlns:a="http://schemas.openxmlformats.org/drawingml/2006/main">
               <a:ext uri="{FF2B5EF4-FFF2-40B4-BE49-F238E27FC236}">
-                <a16:creationId xmlns:a16="http://schemas.microsoft.com/office/drawing/2014/main" id="{9B2EB64C-4E8E-4732-ADDB-B7FCAF3939C3}"/>
+                <a16:creationId xmlns:a16="http://schemas.microsoft.com/office/drawing/2014/main" id="{D717FDAF-33B2-4285-8459-817894D5C5AE}"/>
               </a:ext>
             </a:extLst>
           </p:cNvPr>
@@ -3311,12 +3240,12 @@
   </p:cSld>
   <p:clrMap bg1="lt1" tx1="dk1" bg2="lt2" tx2="dk2" accent1="accent1" accent2="accent2" accent3="accent3" accent4="accent4" accent5="accent5" accent6="accent6" hlink="hlink" folHlink="folHlink"/>
   <p:sldLayoutIdLst>
-    <p:sldLayoutId xmlns:r="http://schemas.openxmlformats.org/officeDocument/2006/relationships" id="2147483649" r:id="Rab63bf626c5f4ea7"/>
-    <p:sldLayoutId xmlns:r="http://schemas.openxmlformats.org/officeDocument/2006/relationships" id="2147483650" r:id="Rd0b2073e0358466b"/>
-    <p:sldLayoutId xmlns:r="http://schemas.openxmlformats.org/officeDocument/2006/relationships" id="2147483651" r:id="R4a79d6a073c24217"/>
-    <p:sldLayoutId xmlns:r="http://schemas.openxmlformats.org/officeDocument/2006/relationships" id="2147483652" r:id="R3307555d1e174865"/>
-    <p:sldLayoutId xmlns:r="http://schemas.openxmlformats.org/officeDocument/2006/relationships" id="2147483653" r:id="R9931caf5b37541fd"/>
-    <p:sldLayoutId xmlns:r="http://schemas.openxmlformats.org/officeDocument/2006/relationships" id="2147483654" r:id="R5918525f58964a95"/>
+    <p:sldLayoutId xmlns:r="http://schemas.openxmlformats.org/officeDocument/2006/relationships" id="2147483649" r:id="R16002300ce5b4659"/>
+    <p:sldLayoutId xmlns:r="http://schemas.openxmlformats.org/officeDocument/2006/relationships" id="2147483650" r:id="R0a2842ee06b3486f"/>
+    <p:sldLayoutId xmlns:r="http://schemas.openxmlformats.org/officeDocument/2006/relationships" id="2147483651" r:id="Re8ecabde7c684619"/>
+    <p:sldLayoutId xmlns:r="http://schemas.openxmlformats.org/officeDocument/2006/relationships" id="2147483652" r:id="Rc7df62f4c1a14a01"/>
+    <p:sldLayoutId xmlns:r="http://schemas.openxmlformats.org/officeDocument/2006/relationships" id="2147483653" r:id="R7b9edccbee2a4f4f"/>
+    <p:sldLayoutId xmlns:r="http://schemas.openxmlformats.org/officeDocument/2006/relationships" id="2147483654" r:id="R123bd17866d24ecc"/>
   </p:sldLayoutIdLst>
   <p:txStyles>
     <p:titleStyle>
@@ -4176,7 +4105,7 @@
           <p:cNvPr id="5" name="">
             <a:extLst xmlns:a="http://schemas.openxmlformats.org/drawingml/2006/main">
               <a:ext uri="{FF2B5EF4-FFF2-40B4-BE49-F238E27FC236}">
-                <a16:creationId xmlns:a16="http://schemas.microsoft.com/office/drawing/2014/main" id="{A65C383B-8883-4CC4-9778-52A0356AAEA7}"/>
+                <a16:creationId xmlns:a16="http://schemas.microsoft.com/office/drawing/2014/main" id="{F2C21DE0-C2D5-4E99-A7FC-DD58F72081C5}"/>
               </a:ext>
             </a:extLst>
           </p:cNvPr>
@@ -4234,7 +4163,7 @@
           <p:cNvPr id="2" name="">
             <a:extLst xmlns:a="http://schemas.openxmlformats.org/drawingml/2006/main">
               <a:ext uri="{FF2B5EF4-FFF2-40B4-BE49-F238E27FC236}">
-                <a16:creationId xmlns:a16="http://schemas.microsoft.com/office/drawing/2014/main" id="{102D5957-F3BB-467F-80A3-A6C7F909AE5F}"/>
+                <a16:creationId xmlns:a16="http://schemas.microsoft.com/office/drawing/2014/main" id="{100786EF-8129-42BB-9E54-756B61F9F08A}"/>
               </a:ext>
             </a:extLst>
           </p:cNvPr>
@@ -4279,7 +4208,7 @@
           <p:cNvPr id="3" name="">
             <a:extLst xmlns:a="http://schemas.openxmlformats.org/drawingml/2006/main">
               <a:ext uri="{FF2B5EF4-FFF2-40B4-BE49-F238E27FC236}">
-                <a16:creationId xmlns:a16="http://schemas.microsoft.com/office/drawing/2014/main" id="{485D118A-D065-4E5F-B3E7-BA1F06C8CC7A}"/>
+                <a16:creationId xmlns:a16="http://schemas.microsoft.com/office/drawing/2014/main" id="{32BA005F-9B12-4F39-899A-B3FC9FDB027A}"/>
               </a:ext>
             </a:extLst>
           </p:cNvPr>
@@ -4324,7 +4253,7 @@
           <p:cNvPr id="4" name="">
             <a:extLst xmlns:a="http://schemas.openxmlformats.org/drawingml/2006/main">
               <a:ext uri="{FF2B5EF4-FFF2-40B4-BE49-F238E27FC236}">
-                <a16:creationId xmlns:a16="http://schemas.microsoft.com/office/drawing/2014/main" id="{1C29FA77-3595-4954-8CC5-E3D7EC4A8845}"/>
+                <a16:creationId xmlns:a16="http://schemas.microsoft.com/office/drawing/2014/main" id="{2D7105AF-A883-437F-A1C9-5C0BB395A4F2}"/>
               </a:ext>
             </a:extLst>
           </p:cNvPr>
@@ -4367,7 +4296,7 @@
     </p:spTree>
     <p:extLst>
       <p:ext uri="{BB962C8B-B14F-4D97-AF65-F5344CB8AC3E}">
-        <p14:creationId xmlns:p14="http://schemas.microsoft.com/office/powerpoint/2010/main" val="1824775973"/>
+        <p14:creationId xmlns:p14="http://schemas.microsoft.com/office/powerpoint/2010/main" val="1098538985"/>
       </p:ext>
     </p:extLst>
   </p:cSld>
@@ -4398,7 +4327,7 @@
           <p:cNvPr id="29" name="">
             <a:extLst xmlns:a="http://schemas.openxmlformats.org/drawingml/2006/main">
               <a:ext uri="{FF2B5EF4-FFF2-40B4-BE49-F238E27FC236}">
-                <a16:creationId xmlns:a16="http://schemas.microsoft.com/office/drawing/2014/main" id="{7B8C6D03-520B-484D-8291-16F6D49764B2}"/>
+                <a16:creationId xmlns:a16="http://schemas.microsoft.com/office/drawing/2014/main" id="{6FBB8466-B763-4095-929E-2110711D5BE2}"/>
               </a:ext>
             </a:extLst>
           </p:cNvPr>
@@ -4443,7 +4372,7 @@
           <p:cNvPr id="2" name="">
             <a:extLst xmlns:a="http://schemas.openxmlformats.org/drawingml/2006/main">
               <a:ext uri="{FF2B5EF4-FFF2-40B4-BE49-F238E27FC236}">
-                <a16:creationId xmlns:a16="http://schemas.microsoft.com/office/drawing/2014/main" id="{B1A09784-615F-43C1-8D8F-D87FDEA8C952}"/>
+                <a16:creationId xmlns:a16="http://schemas.microsoft.com/office/drawing/2014/main" id="{9DF0594E-BCEE-45FA-90D0-65DB9922F587}"/>
               </a:ext>
             </a:extLst>
           </p:cNvPr>
@@ -4473,7 +4402,7 @@
           <p:cNvPr id="3" name="">
             <a:extLst xmlns:a="http://schemas.openxmlformats.org/drawingml/2006/main">
               <a:ext uri="{FF2B5EF4-FFF2-40B4-BE49-F238E27FC236}">
-                <a16:creationId xmlns:a16="http://schemas.microsoft.com/office/drawing/2014/main" id="{1152A649-BEE5-4850-A8E3-55514947A1DF}"/>
+                <a16:creationId xmlns:a16="http://schemas.microsoft.com/office/drawing/2014/main" id="{3BD96097-BEED-4AA8-AB97-CCD01B759270}"/>
               </a:ext>
             </a:extLst>
           </p:cNvPr>
@@ -4518,7 +4447,7 @@
           <p:cNvPr id="4" name="">
             <a:extLst xmlns:a="http://schemas.openxmlformats.org/drawingml/2006/main">
               <a:ext uri="{FF2B5EF4-FFF2-40B4-BE49-F238E27FC236}">
-                <a16:creationId xmlns:a16="http://schemas.microsoft.com/office/drawing/2014/main" id="{E6901D4B-8FAB-4E61-852A-354A6767BCF2}"/>
+                <a16:creationId xmlns:a16="http://schemas.microsoft.com/office/drawing/2014/main" id="{58FCC34B-658F-41F2-80BD-693F7B121520}"/>
               </a:ext>
             </a:extLst>
           </p:cNvPr>
@@ -4563,7 +4492,7 @@
           <p:cNvPr id="5" name="">
             <a:extLst xmlns:a="http://schemas.openxmlformats.org/drawingml/2006/main">
               <a:ext uri="{FF2B5EF4-FFF2-40B4-BE49-F238E27FC236}">
-                <a16:creationId xmlns:a16="http://schemas.microsoft.com/office/drawing/2014/main" id="{27556DA3-B797-4D0E-96C6-DEB3812F31D2}"/>
+                <a16:creationId xmlns:a16="http://schemas.microsoft.com/office/drawing/2014/main" id="{E68B8280-C528-4043-9CF4-C42124736809}"/>
               </a:ext>
             </a:extLst>
           </p:cNvPr>
@@ -4608,7 +4537,7 @@
           <p:cNvPr id="6" name="">
             <a:extLst xmlns:a="http://schemas.openxmlformats.org/drawingml/2006/main">
               <a:ext uri="{FF2B5EF4-FFF2-40B4-BE49-F238E27FC236}">
-                <a16:creationId xmlns:a16="http://schemas.microsoft.com/office/drawing/2014/main" id="{8B8BB3DB-2BB7-4363-B27B-DE210A6A6AC5}"/>
+                <a16:creationId xmlns:a16="http://schemas.microsoft.com/office/drawing/2014/main" id="{10B8E362-C37D-489A-B848-8A714A1AB4EE}"/>
               </a:ext>
             </a:extLst>
           </p:cNvPr>
@@ -4640,7 +4569,7 @@
           <p:cNvPr id="7" name="">
             <a:extLst xmlns:a="http://schemas.openxmlformats.org/drawingml/2006/main">
               <a:ext uri="{FF2B5EF4-FFF2-40B4-BE49-F238E27FC236}">
-                <a16:creationId xmlns:a16="http://schemas.microsoft.com/office/drawing/2014/main" id="{40D22FB7-AEE4-4416-9B82-C0974E949E6B}"/>
+                <a16:creationId xmlns:a16="http://schemas.microsoft.com/office/drawing/2014/main" id="{B8376151-6249-4AD0-9D86-8A5B13752F47}"/>
               </a:ext>
             </a:extLst>
           </p:cNvPr>
@@ -4672,7 +4601,7 @@
           <p:cNvPr id="8" name="">
             <a:extLst xmlns:a="http://schemas.openxmlformats.org/drawingml/2006/main">
               <a:ext uri="{FF2B5EF4-FFF2-40B4-BE49-F238E27FC236}">
-                <a16:creationId xmlns:a16="http://schemas.microsoft.com/office/drawing/2014/main" id="{2DCF3332-31FF-4FF2-83F2-7C80C4D34EB2}"/>
+                <a16:creationId xmlns:a16="http://schemas.microsoft.com/office/drawing/2014/main" id="{AC63768D-6689-48BD-976F-6B9614735C13}"/>
               </a:ext>
             </a:extLst>
           </p:cNvPr>
@@ -4704,7 +4633,7 @@
           <p:cNvPr id="9" name="">
             <a:extLst xmlns:a="http://schemas.openxmlformats.org/drawingml/2006/main">
               <a:ext uri="{FF2B5EF4-FFF2-40B4-BE49-F238E27FC236}">
-                <a16:creationId xmlns:a16="http://schemas.microsoft.com/office/drawing/2014/main" id="{C8611382-083B-4D6E-ABEA-F93D53AB4D39}"/>
+                <a16:creationId xmlns:a16="http://schemas.microsoft.com/office/drawing/2014/main" id="{09296E59-35FD-49C3-808B-E449FC571299}"/>
               </a:ext>
             </a:extLst>
           </p:cNvPr>
@@ -4749,7 +4678,7 @@
           <p:cNvPr id="10" name="">
             <a:extLst xmlns:a="http://schemas.openxmlformats.org/drawingml/2006/main">
               <a:ext uri="{FF2B5EF4-FFF2-40B4-BE49-F238E27FC236}">
-                <a16:creationId xmlns:a16="http://schemas.microsoft.com/office/drawing/2014/main" id="{5FF81205-4AAA-4F24-B720-61C2F3EBAD9F}"/>
+                <a16:creationId xmlns:a16="http://schemas.microsoft.com/office/drawing/2014/main" id="{3A70735C-EF3A-4AFB-8A6A-692D34A50948}"/>
               </a:ext>
             </a:extLst>
           </p:cNvPr>
@@ -4779,7 +4708,7 @@
           <p:cNvPr id="11" name="">
             <a:extLst xmlns:a="http://schemas.openxmlformats.org/drawingml/2006/main">
               <a:ext uri="{FF2B5EF4-FFF2-40B4-BE49-F238E27FC236}">
-                <a16:creationId xmlns:a16="http://schemas.microsoft.com/office/drawing/2014/main" id="{064A66A1-A9AE-49E0-B4F5-E5A3EBB6ECD6}"/>
+                <a16:creationId xmlns:a16="http://schemas.microsoft.com/office/drawing/2014/main" id="{4C82C2C5-88E6-4DD8-AE30-22359B426E77}"/>
               </a:ext>
             </a:extLst>
           </p:cNvPr>
@@ -4824,7 +4753,7 @@
           <p:cNvPr id="12" name="">
             <a:extLst xmlns:a="http://schemas.openxmlformats.org/drawingml/2006/main">
               <a:ext uri="{FF2B5EF4-FFF2-40B4-BE49-F238E27FC236}">
-                <a16:creationId xmlns:a16="http://schemas.microsoft.com/office/drawing/2014/main" id="{552AF6CF-46EC-4954-AE67-EE626120E42F}"/>
+                <a16:creationId xmlns:a16="http://schemas.microsoft.com/office/drawing/2014/main" id="{8B62DD2D-F8AA-46B7-8B44-0C0019917271}"/>
               </a:ext>
             </a:extLst>
           </p:cNvPr>
@@ -4856,7 +4785,7 @@
           <p:cNvPr id="13" name="">
             <a:extLst xmlns:a="http://schemas.openxmlformats.org/drawingml/2006/main">
               <a:ext uri="{FF2B5EF4-FFF2-40B4-BE49-F238E27FC236}">
-                <a16:creationId xmlns:a16="http://schemas.microsoft.com/office/drawing/2014/main" id="{C1189D85-ECA7-439A-AF44-E98BE8092328}"/>
+                <a16:creationId xmlns:a16="http://schemas.microsoft.com/office/drawing/2014/main" id="{EA0D1E13-9417-4312-B12E-8F2B3C95F77F}"/>
               </a:ext>
             </a:extLst>
           </p:cNvPr>
@@ -4888,7 +4817,7 @@
           <p:cNvPr id="14" name="">
             <a:extLst xmlns:a="http://schemas.openxmlformats.org/drawingml/2006/main">
               <a:ext uri="{FF2B5EF4-FFF2-40B4-BE49-F238E27FC236}">
-                <a16:creationId xmlns:a16="http://schemas.microsoft.com/office/drawing/2014/main" id="{2ACECB34-8F52-4DBA-9444-C951AC664EAB}"/>
+                <a16:creationId xmlns:a16="http://schemas.microsoft.com/office/drawing/2014/main" id="{7E0D474F-ACC9-43C9-BA2C-19DC0FDC7693}"/>
               </a:ext>
             </a:extLst>
           </p:cNvPr>
@@ -4920,7 +4849,7 @@
           <p:cNvPr id="15" name="">
             <a:extLst xmlns:a="http://schemas.openxmlformats.org/drawingml/2006/main">
               <a:ext uri="{FF2B5EF4-FFF2-40B4-BE49-F238E27FC236}">
-                <a16:creationId xmlns:a16="http://schemas.microsoft.com/office/drawing/2014/main" id="{143F6680-4E68-4E25-BBCD-BBF9CDCDB1D5}"/>
+                <a16:creationId xmlns:a16="http://schemas.microsoft.com/office/drawing/2014/main" id="{5EAA5F99-EF8B-4E9B-9823-22CDDD338AE8}"/>
               </a:ext>
             </a:extLst>
           </p:cNvPr>
@@ -4965,7 +4894,7 @@
           <p:cNvPr id="16" name="">
             <a:extLst xmlns:a="http://schemas.openxmlformats.org/drawingml/2006/main">
               <a:ext uri="{FF2B5EF4-FFF2-40B4-BE49-F238E27FC236}">
-                <a16:creationId xmlns:a16="http://schemas.microsoft.com/office/drawing/2014/main" id="{FB2BA399-3648-4824-8533-9499EF6D5129}"/>
+                <a16:creationId xmlns:a16="http://schemas.microsoft.com/office/drawing/2014/main" id="{7645844A-76C1-4C85-B3D1-170492D5ED87}"/>
               </a:ext>
             </a:extLst>
           </p:cNvPr>
@@ -4995,7 +4924,7 @@
           <p:cNvPr id="17" name="">
             <a:extLst xmlns:a="http://schemas.openxmlformats.org/drawingml/2006/main">
               <a:ext uri="{FF2B5EF4-FFF2-40B4-BE49-F238E27FC236}">
-                <a16:creationId xmlns:a16="http://schemas.microsoft.com/office/drawing/2014/main" id="{CF9AA00F-5804-43DF-AE3E-F9B17AE47CA1}"/>
+                <a16:creationId xmlns:a16="http://schemas.microsoft.com/office/drawing/2014/main" id="{85CFC73F-D638-4BA5-AB65-507ED9F67A57}"/>
               </a:ext>
             </a:extLst>
           </p:cNvPr>
@@ -5040,7 +4969,7 @@
           <p:cNvPr id="18" name="">
             <a:extLst xmlns:a="http://schemas.openxmlformats.org/drawingml/2006/main">
               <a:ext uri="{FF2B5EF4-FFF2-40B4-BE49-F238E27FC236}">
-                <a16:creationId xmlns:a16="http://schemas.microsoft.com/office/drawing/2014/main" id="{190FA276-642F-4A6D-B4F0-A214E10411A0}"/>
+                <a16:creationId xmlns:a16="http://schemas.microsoft.com/office/drawing/2014/main" id="{0000227C-D5A2-42BD-AE89-95DD4274EFC2}"/>
               </a:ext>
             </a:extLst>
           </p:cNvPr>
@@ -5072,7 +5001,7 @@
           <p:cNvPr id="19" name="">
             <a:extLst xmlns:a="http://schemas.openxmlformats.org/drawingml/2006/main">
               <a:ext uri="{FF2B5EF4-FFF2-40B4-BE49-F238E27FC236}">
-                <a16:creationId xmlns:a16="http://schemas.microsoft.com/office/drawing/2014/main" id="{BACA7281-D8A2-44AE-BEC3-1944E536ACFA}"/>
+                <a16:creationId xmlns:a16="http://schemas.microsoft.com/office/drawing/2014/main" id="{B1106D4D-2B33-4F8D-ACF0-049A589C3EC0}"/>
               </a:ext>
             </a:extLst>
           </p:cNvPr>
@@ -5104,7 +5033,7 @@
           <p:cNvPr id="20" name="">
             <a:extLst xmlns:a="http://schemas.openxmlformats.org/drawingml/2006/main">
               <a:ext uri="{FF2B5EF4-FFF2-40B4-BE49-F238E27FC236}">
-                <a16:creationId xmlns:a16="http://schemas.microsoft.com/office/drawing/2014/main" id="{E9C2A71F-A7FB-4225-B424-C4E82662D8F3}"/>
+                <a16:creationId xmlns:a16="http://schemas.microsoft.com/office/drawing/2014/main" id="{B029756C-B5FB-4423-B584-56D4E3C18A75}"/>
               </a:ext>
             </a:extLst>
           </p:cNvPr>
@@ -5136,7 +5065,7 @@
           <p:cNvPr id="21" name="">
             <a:extLst xmlns:a="http://schemas.openxmlformats.org/drawingml/2006/main">
               <a:ext uri="{FF2B5EF4-FFF2-40B4-BE49-F238E27FC236}">
-                <a16:creationId xmlns:a16="http://schemas.microsoft.com/office/drawing/2014/main" id="{157E52A8-C4FA-4648-908F-FF1794147F84}"/>
+                <a16:creationId xmlns:a16="http://schemas.microsoft.com/office/drawing/2014/main" id="{8301AAEC-808B-4C12-BC05-E4DD8DA5A12D}"/>
               </a:ext>
             </a:extLst>
           </p:cNvPr>
@@ -5181,7 +5110,7 @@
           <p:cNvPr id="22" name="">
             <a:extLst xmlns:a="http://schemas.openxmlformats.org/drawingml/2006/main">
               <a:ext uri="{FF2B5EF4-FFF2-40B4-BE49-F238E27FC236}">
-                <a16:creationId xmlns:a16="http://schemas.microsoft.com/office/drawing/2014/main" id="{E017ED18-7786-4BE1-9173-2C880DD43AA0}"/>
+                <a16:creationId xmlns:a16="http://schemas.microsoft.com/office/drawing/2014/main" id="{671C5611-CA0F-4AB9-A613-699BB41D6245}"/>
               </a:ext>
             </a:extLst>
           </p:cNvPr>
@@ -5211,7 +5140,7 @@
           <p:cNvPr id="23" name="">
             <a:extLst xmlns:a="http://schemas.openxmlformats.org/drawingml/2006/main">
               <a:ext uri="{FF2B5EF4-FFF2-40B4-BE49-F238E27FC236}">
-                <a16:creationId xmlns:a16="http://schemas.microsoft.com/office/drawing/2014/main" id="{B1F405B7-11CB-4F27-AA79-2A55E529BDAA}"/>
+                <a16:creationId xmlns:a16="http://schemas.microsoft.com/office/drawing/2014/main" id="{20B2AC55-731A-4EE8-B7F3-1547F23B9F37}"/>
               </a:ext>
             </a:extLst>
           </p:cNvPr>
@@ -5241,7 +5170,7 @@
           <p:cNvPr id="24" name="">
             <a:extLst xmlns:a="http://schemas.openxmlformats.org/drawingml/2006/main">
               <a:ext uri="{FF2B5EF4-FFF2-40B4-BE49-F238E27FC236}">
-                <a16:creationId xmlns:a16="http://schemas.microsoft.com/office/drawing/2014/main" id="{E4737E20-C832-489E-87F2-07282CA77747}"/>
+                <a16:creationId xmlns:a16="http://schemas.microsoft.com/office/drawing/2014/main" id="{78D4E822-649A-4385-8511-24081CA9439C}"/>
               </a:ext>
             </a:extLst>
           </p:cNvPr>
@@ -5286,7 +5215,7 @@
           <p:cNvPr id="25" name="">
             <a:extLst xmlns:a="http://schemas.openxmlformats.org/drawingml/2006/main">
               <a:ext uri="{FF2B5EF4-FFF2-40B4-BE49-F238E27FC236}">
-                <a16:creationId xmlns:a16="http://schemas.microsoft.com/office/drawing/2014/main" id="{3A313B33-1F2E-4173-958D-7728904443D2}"/>
+                <a16:creationId xmlns:a16="http://schemas.microsoft.com/office/drawing/2014/main" id="{C7994790-776E-4FA4-AEC2-05F30E31AE6A}"/>
               </a:ext>
             </a:extLst>
           </p:cNvPr>
@@ -5331,7 +5260,7 @@
           <p:cNvPr id="26" name="">
             <a:extLst xmlns:a="http://schemas.openxmlformats.org/drawingml/2006/main">
               <a:ext uri="{FF2B5EF4-FFF2-40B4-BE49-F238E27FC236}">
-                <a16:creationId xmlns:a16="http://schemas.microsoft.com/office/drawing/2014/main" id="{DA91E890-C5A4-4070-B33C-50BBE9B9F4E4}"/>
+                <a16:creationId xmlns:a16="http://schemas.microsoft.com/office/drawing/2014/main" id="{940E4468-9646-4CB0-9BFF-5D5653A365B7}"/>
               </a:ext>
             </a:extLst>
           </p:cNvPr>
@@ -5376,7 +5305,7 @@
           <p:cNvPr id="27" name="">
             <a:extLst xmlns:a="http://schemas.openxmlformats.org/drawingml/2006/main">
               <a:ext uri="{FF2B5EF4-FFF2-40B4-BE49-F238E27FC236}">
-                <a16:creationId xmlns:a16="http://schemas.microsoft.com/office/drawing/2014/main" id="{4A6D31EE-4A03-46DF-BCB8-267B97D677E9}"/>
+                <a16:creationId xmlns:a16="http://schemas.microsoft.com/office/drawing/2014/main" id="{C63CC81E-8CA4-47FF-B7E6-A02E8DD29E32}"/>
               </a:ext>
             </a:extLst>
           </p:cNvPr>
@@ -5421,7 +5350,7 @@
           <p:cNvPr id="28" name="">
             <a:extLst xmlns:a="http://schemas.openxmlformats.org/drawingml/2006/main">
               <a:ext uri="{FF2B5EF4-FFF2-40B4-BE49-F238E27FC236}">
-                <a16:creationId xmlns:a16="http://schemas.microsoft.com/office/drawing/2014/main" id="{7CC81B7B-0BCF-491E-BA6D-39B87B25CBDD}"/>
+                <a16:creationId xmlns:a16="http://schemas.microsoft.com/office/drawing/2014/main" id="{25239EAB-5A00-4352-A76C-5A265E61BDEA}"/>
               </a:ext>
             </a:extLst>
           </p:cNvPr>
@@ -5464,7 +5393,7 @@
     </p:spTree>
     <p:extLst>
       <p:ext uri="{BB962C8B-B14F-4D97-AF65-F5344CB8AC3E}">
-        <p14:creationId xmlns:p14="http://schemas.microsoft.com/office/powerpoint/2010/main" val="911371109"/>
+        <p14:creationId xmlns:p14="http://schemas.microsoft.com/office/powerpoint/2010/main" val="1155682298"/>
       </p:ext>
     </p:extLst>
   </p:cSld>
@@ -5495,7 +5424,7 @@
           <p:cNvPr id="15" name="">
             <a:extLst xmlns:a="http://schemas.openxmlformats.org/drawingml/2006/main">
               <a:ext uri="{FF2B5EF4-FFF2-40B4-BE49-F238E27FC236}">
-                <a16:creationId xmlns:a16="http://schemas.microsoft.com/office/drawing/2014/main" id="{03442926-FEEE-4CD9-A10E-2E8230054175}"/>
+                <a16:creationId xmlns:a16="http://schemas.microsoft.com/office/drawing/2014/main" id="{C878295E-DB95-4D55-A389-A0F9C00E7164}"/>
               </a:ext>
             </a:extLst>
           </p:cNvPr>
@@ -5540,7 +5469,7 @@
           <p:cNvPr id="2" name="">
             <a:extLst xmlns:a="http://schemas.openxmlformats.org/drawingml/2006/main">
               <a:ext uri="{FF2B5EF4-FFF2-40B4-BE49-F238E27FC236}">
-                <a16:creationId xmlns:a16="http://schemas.microsoft.com/office/drawing/2014/main" id="{7DC080DF-8082-4DF3-8FF6-F4A0498DEBCB}"/>
+                <a16:creationId xmlns:a16="http://schemas.microsoft.com/office/drawing/2014/main" id="{59461C63-FDEE-40F3-8D70-AC4918BD6753}"/>
               </a:ext>
             </a:extLst>
           </p:cNvPr>
@@ -5570,7 +5499,7 @@
           <p:cNvPr id="3" name="">
             <a:extLst xmlns:a="http://schemas.openxmlformats.org/drawingml/2006/main">
               <a:ext uri="{FF2B5EF4-FFF2-40B4-BE49-F238E27FC236}">
-                <a16:creationId xmlns:a16="http://schemas.microsoft.com/office/drawing/2014/main" id="{6A64A39F-0D39-41B0-B78C-ED919601FE8B}"/>
+                <a16:creationId xmlns:a16="http://schemas.microsoft.com/office/drawing/2014/main" id="{09C76645-FDF3-4C9E-9CD3-99E920AAB3DB}"/>
               </a:ext>
             </a:extLst>
           </p:cNvPr>
@@ -5615,7 +5544,7 @@
           <p:cNvPr id="4" name="">
             <a:extLst xmlns:a="http://schemas.openxmlformats.org/drawingml/2006/main">
               <a:ext uri="{FF2B5EF4-FFF2-40B4-BE49-F238E27FC236}">
-                <a16:creationId xmlns:a16="http://schemas.microsoft.com/office/drawing/2014/main" id="{6C95C2B3-6EB7-4AF3-B020-916AC4D0DE89}"/>
+                <a16:creationId xmlns:a16="http://schemas.microsoft.com/office/drawing/2014/main" id="{F31EF084-FD37-4737-BAB2-AED8DD232910}"/>
               </a:ext>
             </a:extLst>
           </p:cNvPr>
@@ -5660,7 +5589,7 @@
           <p:cNvPr id="5" name="">
             <a:extLst xmlns:a="http://schemas.openxmlformats.org/drawingml/2006/main">
               <a:ext uri="{FF2B5EF4-FFF2-40B4-BE49-F238E27FC236}">
-                <a16:creationId xmlns:a16="http://schemas.microsoft.com/office/drawing/2014/main" id="{BA7766EF-29A6-4C07-AFD8-4AFBA8F2E36E}"/>
+                <a16:creationId xmlns:a16="http://schemas.microsoft.com/office/drawing/2014/main" id="{6FBEE27C-1A43-4D47-8A3F-F97E0A3C82F9}"/>
               </a:ext>
             </a:extLst>
           </p:cNvPr>
@@ -5692,7 +5621,7 @@
           <p:cNvPr id="6" name="">
             <a:extLst xmlns:a="http://schemas.openxmlformats.org/drawingml/2006/main">
               <a:ext uri="{FF2B5EF4-FFF2-40B4-BE49-F238E27FC236}">
-                <a16:creationId xmlns:a16="http://schemas.microsoft.com/office/drawing/2014/main" id="{2202A97E-5938-4BF6-B085-415C9F69F1C4}"/>
+                <a16:creationId xmlns:a16="http://schemas.microsoft.com/office/drawing/2014/main" id="{FBF675E3-7B3D-4177-B820-C18435B3B1AF}"/>
               </a:ext>
             </a:extLst>
           </p:cNvPr>
@@ -5724,7 +5653,7 @@
           <p:cNvPr id="7" name="">
             <a:extLst xmlns:a="http://schemas.openxmlformats.org/drawingml/2006/main">
               <a:ext uri="{FF2B5EF4-FFF2-40B4-BE49-F238E27FC236}">
-                <a16:creationId xmlns:a16="http://schemas.microsoft.com/office/drawing/2014/main" id="{401CF9B3-A297-4BE3-84BC-D9264F17AA44}"/>
+                <a16:creationId xmlns:a16="http://schemas.microsoft.com/office/drawing/2014/main" id="{FC9F815D-ABBD-4086-9FA4-E8F70EE43945}"/>
               </a:ext>
             </a:extLst>
           </p:cNvPr>
@@ -5756,7 +5685,7 @@
           <p:cNvPr id="8" name="">
             <a:extLst xmlns:a="http://schemas.openxmlformats.org/drawingml/2006/main">
               <a:ext uri="{FF2B5EF4-FFF2-40B4-BE49-F238E27FC236}">
-                <a16:creationId xmlns:a16="http://schemas.microsoft.com/office/drawing/2014/main" id="{16444D25-8F91-4E82-82F0-141580EC51A8}"/>
+                <a16:creationId xmlns:a16="http://schemas.microsoft.com/office/drawing/2014/main" id="{63530DC6-E99B-4929-B933-30E8B39BD776}"/>
               </a:ext>
             </a:extLst>
           </p:cNvPr>
@@ -5801,7 +5730,7 @@
           <p:cNvPr id="9" name="">
             <a:extLst xmlns:a="http://schemas.openxmlformats.org/drawingml/2006/main">
               <a:ext uri="{FF2B5EF4-FFF2-40B4-BE49-F238E27FC236}">
-                <a16:creationId xmlns:a16="http://schemas.microsoft.com/office/drawing/2014/main" id="{C34AB15E-1BB8-49E4-8577-AE85A9B5690B}"/>
+                <a16:creationId xmlns:a16="http://schemas.microsoft.com/office/drawing/2014/main" id="{1E7CB34B-F045-485A-B32E-C7E610CA0A61}"/>
               </a:ext>
             </a:extLst>
           </p:cNvPr>
@@ -5846,7 +5775,7 @@
           <p:cNvPr id="10" name="">
             <a:extLst xmlns:a="http://schemas.openxmlformats.org/drawingml/2006/main">
               <a:ext uri="{FF2B5EF4-FFF2-40B4-BE49-F238E27FC236}">
-                <a16:creationId xmlns:a16="http://schemas.microsoft.com/office/drawing/2014/main" id="{EF83A3A7-BCF7-473F-A924-91C6F9755803}"/>
+                <a16:creationId xmlns:a16="http://schemas.microsoft.com/office/drawing/2014/main" id="{8B40E75F-A567-47DE-BFA1-74072F5E333B}"/>
               </a:ext>
             </a:extLst>
           </p:cNvPr>
@@ -5878,7 +5807,7 @@
           <p:cNvPr id="11" name="">
             <a:extLst xmlns:a="http://schemas.openxmlformats.org/drawingml/2006/main">
               <a:ext uri="{FF2B5EF4-FFF2-40B4-BE49-F238E27FC236}">
-                <a16:creationId xmlns:a16="http://schemas.microsoft.com/office/drawing/2014/main" id="{C1CFBBA9-DBFE-42AD-AA0A-6AE3925DD51E}"/>
+                <a16:creationId xmlns:a16="http://schemas.microsoft.com/office/drawing/2014/main" id="{A3F252BF-8583-4C19-A594-083E2554A8F7}"/>
               </a:ext>
             </a:extLst>
           </p:cNvPr>
@@ -5910,7 +5839,7 @@
           <p:cNvPr id="12" name="">
             <a:extLst xmlns:a="http://schemas.openxmlformats.org/drawingml/2006/main">
               <a:ext uri="{FF2B5EF4-FFF2-40B4-BE49-F238E27FC236}">
-                <a16:creationId xmlns:a16="http://schemas.microsoft.com/office/drawing/2014/main" id="{55603292-B926-42EB-BE1E-358AD485D97A}"/>
+                <a16:creationId xmlns:a16="http://schemas.microsoft.com/office/drawing/2014/main" id="{81D6B880-C5A3-49C0-B38B-1A5783DFC4DC}"/>
               </a:ext>
             </a:extLst>
           </p:cNvPr>
@@ -5942,7 +5871,7 @@
           <p:cNvPr id="13" name="">
             <a:extLst xmlns:a="http://schemas.openxmlformats.org/drawingml/2006/main">
               <a:ext uri="{FF2B5EF4-FFF2-40B4-BE49-F238E27FC236}">
-                <a16:creationId xmlns:a16="http://schemas.microsoft.com/office/drawing/2014/main" id="{E1795D38-D46D-488B-B5F7-D857386413DC}"/>
+                <a16:creationId xmlns:a16="http://schemas.microsoft.com/office/drawing/2014/main" id="{1B34CC6D-2487-40C7-9DD0-CE75D97CC784}"/>
               </a:ext>
             </a:extLst>
           </p:cNvPr>
@@ -5987,7 +5916,7 @@
           <p:cNvPr id="14" name="">
             <a:extLst xmlns:a="http://schemas.openxmlformats.org/drawingml/2006/main">
               <a:ext uri="{FF2B5EF4-FFF2-40B4-BE49-F238E27FC236}">
-                <a16:creationId xmlns:a16="http://schemas.microsoft.com/office/drawing/2014/main" id="{EBA0009C-FD2F-45DA-BD36-0B4594D58409}"/>
+                <a16:creationId xmlns:a16="http://schemas.microsoft.com/office/drawing/2014/main" id="{A46F8DD6-6881-459F-BE06-E39690137BBC}"/>
               </a:ext>
             </a:extLst>
           </p:cNvPr>
@@ -6030,7 +5959,7 @@
     </p:spTree>
     <p:extLst>
       <p:ext uri="{BB962C8B-B14F-4D97-AF65-F5344CB8AC3E}">
-        <p14:creationId xmlns:p14="http://schemas.microsoft.com/office/powerpoint/2010/main" val="809550037"/>
+        <p14:creationId xmlns:p14="http://schemas.microsoft.com/office/powerpoint/2010/main" val="1964606944"/>
       </p:ext>
     </p:extLst>
   </p:cSld>
@@ -6061,7 +5990,7 @@
           <p:cNvPr id="20" name="">
             <a:extLst xmlns:a="http://schemas.openxmlformats.org/drawingml/2006/main">
               <a:ext uri="{FF2B5EF4-FFF2-40B4-BE49-F238E27FC236}">
-                <a16:creationId xmlns:a16="http://schemas.microsoft.com/office/drawing/2014/main" id="{699A1191-4D3C-434C-8D25-DB73511B211F}"/>
+                <a16:creationId xmlns:a16="http://schemas.microsoft.com/office/drawing/2014/main" id="{618D5017-C450-43C6-998B-36596429DEFB}"/>
               </a:ext>
             </a:extLst>
           </p:cNvPr>
@@ -6106,7 +6035,7 @@
           <p:cNvPr id="2" name="">
             <a:extLst xmlns:a="http://schemas.openxmlformats.org/drawingml/2006/main">
               <a:ext uri="{FF2B5EF4-FFF2-40B4-BE49-F238E27FC236}">
-                <a16:creationId xmlns:a16="http://schemas.microsoft.com/office/drawing/2014/main" id="{E848398F-B907-4BC8-970A-D56390EC23A6}"/>
+                <a16:creationId xmlns:a16="http://schemas.microsoft.com/office/drawing/2014/main" id="{2A65AB68-FC6D-46E4-B5FB-A7D9AC37AFEB}"/>
               </a:ext>
             </a:extLst>
           </p:cNvPr>
@@ -6136,7 +6065,7 @@
           <p:cNvPr id="3" name="">
             <a:extLst xmlns:a="http://schemas.openxmlformats.org/drawingml/2006/main">
               <a:ext uri="{FF2B5EF4-FFF2-40B4-BE49-F238E27FC236}">
-                <a16:creationId xmlns:a16="http://schemas.microsoft.com/office/drawing/2014/main" id="{BBA469ED-3284-4389-9E9A-E071E488F6AD}"/>
+                <a16:creationId xmlns:a16="http://schemas.microsoft.com/office/drawing/2014/main" id="{40EB2D15-8789-4811-8A50-94225A5CB6B4}"/>
               </a:ext>
             </a:extLst>
           </p:cNvPr>
@@ -6181,7 +6110,7 @@
           <p:cNvPr id="4" name="">
             <a:extLst xmlns:a="http://schemas.openxmlformats.org/drawingml/2006/main">
               <a:ext uri="{FF2B5EF4-FFF2-40B4-BE49-F238E27FC236}">
-                <a16:creationId xmlns:a16="http://schemas.microsoft.com/office/drawing/2014/main" id="{1A59B0EC-DEA3-4DF7-A473-972E44AAD1E8}"/>
+                <a16:creationId xmlns:a16="http://schemas.microsoft.com/office/drawing/2014/main" id="{46E15977-1FC9-4936-9E93-A4204536D28C}"/>
               </a:ext>
             </a:extLst>
           </p:cNvPr>
@@ -6226,7 +6155,7 @@
           <p:cNvPr id="5" name="">
             <a:extLst xmlns:a="http://schemas.openxmlformats.org/drawingml/2006/main">
               <a:ext uri="{FF2B5EF4-FFF2-40B4-BE49-F238E27FC236}">
-                <a16:creationId xmlns:a16="http://schemas.microsoft.com/office/drawing/2014/main" id="{36947818-DAAC-4E10-87B3-A2C1470A6F26}"/>
+                <a16:creationId xmlns:a16="http://schemas.microsoft.com/office/drawing/2014/main" id="{A92EF43E-9979-42FD-9D87-04EB57AD7F2E}"/>
               </a:ext>
             </a:extLst>
           </p:cNvPr>
@@ -6258,7 +6187,7 @@
           <p:cNvPr id="6" name="">
             <a:extLst xmlns:a="http://schemas.openxmlformats.org/drawingml/2006/main">
               <a:ext uri="{FF2B5EF4-FFF2-40B4-BE49-F238E27FC236}">
-                <a16:creationId xmlns:a16="http://schemas.microsoft.com/office/drawing/2014/main" id="{106BAD6E-BD84-4E6E-A8B6-E1D8839CC51A}"/>
+                <a16:creationId xmlns:a16="http://schemas.microsoft.com/office/drawing/2014/main" id="{F9EB57AE-752C-4AB6-B790-5A85A421ADD0}"/>
               </a:ext>
             </a:extLst>
           </p:cNvPr>
@@ -6329,7 +6258,7 @@
           <p:cNvPr id="7" name="">
             <a:extLst xmlns:a="http://schemas.openxmlformats.org/drawingml/2006/main">
               <a:ext uri="{FF2B5EF4-FFF2-40B4-BE49-F238E27FC236}">
-                <a16:creationId xmlns:a16="http://schemas.microsoft.com/office/drawing/2014/main" id="{B553C864-2805-450F-8074-F65027EDEE2E}"/>
+                <a16:creationId xmlns:a16="http://schemas.microsoft.com/office/drawing/2014/main" id="{869D9580-EFD3-4179-8D84-BC0EA92FA2A7}"/>
               </a:ext>
             </a:extLst>
           </p:cNvPr>
@@ -6374,7 +6303,7 @@
           <p:cNvPr id="8" name="">
             <a:extLst xmlns:a="http://schemas.openxmlformats.org/drawingml/2006/main">
               <a:ext uri="{FF2B5EF4-FFF2-40B4-BE49-F238E27FC236}">
-                <a16:creationId xmlns:a16="http://schemas.microsoft.com/office/drawing/2014/main" id="{7C89BFB9-0293-4CE6-A55A-B49C9E45079F}"/>
+                <a16:creationId xmlns:a16="http://schemas.microsoft.com/office/drawing/2014/main" id="{C2D48B5A-B2DC-44DE-9916-BA4B01C7D4CC}"/>
               </a:ext>
             </a:extLst>
           </p:cNvPr>
@@ -6406,7 +6335,7 @@
           <p:cNvPr id="9" name="">
             <a:extLst xmlns:a="http://schemas.openxmlformats.org/drawingml/2006/main">
               <a:ext uri="{FF2B5EF4-FFF2-40B4-BE49-F238E27FC236}">
-                <a16:creationId xmlns:a16="http://schemas.microsoft.com/office/drawing/2014/main" id="{0D6B22B3-6C9F-4243-B3A4-D7D38FF44143}"/>
+                <a16:creationId xmlns:a16="http://schemas.microsoft.com/office/drawing/2014/main" id="{655E4FD5-2468-4ACC-A4FB-434287070B44}"/>
               </a:ext>
             </a:extLst>
           </p:cNvPr>
@@ -6438,7 +6367,7 @@
           <p:cNvPr id="10" name="">
             <a:extLst xmlns:a="http://schemas.openxmlformats.org/drawingml/2006/main">
               <a:ext uri="{FF2B5EF4-FFF2-40B4-BE49-F238E27FC236}">
-                <a16:creationId xmlns:a16="http://schemas.microsoft.com/office/drawing/2014/main" id="{3569F922-4E16-46D1-8BA8-49316709B9B0}"/>
+                <a16:creationId xmlns:a16="http://schemas.microsoft.com/office/drawing/2014/main" id="{725A3B03-36E7-4523-83A9-3910A1F48F74}"/>
               </a:ext>
             </a:extLst>
           </p:cNvPr>
@@ -6483,7 +6412,7 @@
           <p:cNvPr id="11" name="">
             <a:extLst xmlns:a="http://schemas.openxmlformats.org/drawingml/2006/main">
               <a:ext uri="{FF2B5EF4-FFF2-40B4-BE49-F238E27FC236}">
-                <a16:creationId xmlns:a16="http://schemas.microsoft.com/office/drawing/2014/main" id="{DC36E927-8F24-4B00-9227-29880609D525}"/>
+                <a16:creationId xmlns:a16="http://schemas.microsoft.com/office/drawing/2014/main" id="{D2C88053-665A-4550-9B0B-725F4FA1892B}"/>
               </a:ext>
             </a:extLst>
           </p:cNvPr>
@@ -6528,7 +6457,7 @@
           <p:cNvPr id="12" name="">
             <a:extLst xmlns:a="http://schemas.openxmlformats.org/drawingml/2006/main">
               <a:ext uri="{FF2B5EF4-FFF2-40B4-BE49-F238E27FC236}">
-                <a16:creationId xmlns:a16="http://schemas.microsoft.com/office/drawing/2014/main" id="{D5CFC489-2058-471A-B4E7-0DA986EB9B0A}"/>
+                <a16:creationId xmlns:a16="http://schemas.microsoft.com/office/drawing/2014/main" id="{F7B0E7EB-1B94-4383-AB51-B04622FF2ADB}"/>
               </a:ext>
             </a:extLst>
           </p:cNvPr>
@@ -6573,7 +6502,7 @@
           <p:cNvPr id="13" name="">
             <a:extLst xmlns:a="http://schemas.openxmlformats.org/drawingml/2006/main">
               <a:ext uri="{FF2B5EF4-FFF2-40B4-BE49-F238E27FC236}">
-                <a16:creationId xmlns:a16="http://schemas.microsoft.com/office/drawing/2014/main" id="{5281B444-154D-4DBB-BAA6-E0DEB94440C7}"/>
+                <a16:creationId xmlns:a16="http://schemas.microsoft.com/office/drawing/2014/main" id="{22E71B4D-5AC2-4BEB-B334-FC94ED0137C2}"/>
               </a:ext>
             </a:extLst>
           </p:cNvPr>
@@ -6605,7 +6534,7 @@
           <p:cNvPr id="14" name="">
             <a:extLst xmlns:a="http://schemas.openxmlformats.org/drawingml/2006/main">
               <a:ext uri="{FF2B5EF4-FFF2-40B4-BE49-F238E27FC236}">
-                <a16:creationId xmlns:a16="http://schemas.microsoft.com/office/drawing/2014/main" id="{21C3375A-1306-464B-8F5F-25189D593337}"/>
+                <a16:creationId xmlns:a16="http://schemas.microsoft.com/office/drawing/2014/main" id="{C71BC81C-E880-4B41-BB15-50AF89B5E81E}"/>
               </a:ext>
             </a:extLst>
           </p:cNvPr>
@@ -6637,7 +6566,7 @@
           <p:cNvPr id="15" name="">
             <a:extLst xmlns:a="http://schemas.openxmlformats.org/drawingml/2006/main">
               <a:ext uri="{FF2B5EF4-FFF2-40B4-BE49-F238E27FC236}">
-                <a16:creationId xmlns:a16="http://schemas.microsoft.com/office/drawing/2014/main" id="{90E096AD-98E3-4BF7-A0B3-135984D44563}"/>
+                <a16:creationId xmlns:a16="http://schemas.microsoft.com/office/drawing/2014/main" id="{6A9AE341-0959-4AE4-BF5A-E25C0C0C6F58}"/>
               </a:ext>
             </a:extLst>
           </p:cNvPr>
@@ -6669,7 +6598,7 @@
           <p:cNvPr id="16" name="">
             <a:extLst xmlns:a="http://schemas.openxmlformats.org/drawingml/2006/main">
               <a:ext uri="{FF2B5EF4-FFF2-40B4-BE49-F238E27FC236}">
-                <a16:creationId xmlns:a16="http://schemas.microsoft.com/office/drawing/2014/main" id="{C369E07D-8861-45C4-8477-10CDCADBF97E}"/>
+                <a16:creationId xmlns:a16="http://schemas.microsoft.com/office/drawing/2014/main" id="{D538E1C6-98B5-4BB3-83F8-226527D23D43}"/>
               </a:ext>
             </a:extLst>
           </p:cNvPr>
@@ -6714,7 +6643,7 @@
           <p:cNvPr id="17" name="">
             <a:extLst xmlns:a="http://schemas.openxmlformats.org/drawingml/2006/main">
               <a:ext uri="{FF2B5EF4-FFF2-40B4-BE49-F238E27FC236}">
-                <a16:creationId xmlns:a16="http://schemas.microsoft.com/office/drawing/2014/main" id="{0CEC7D23-E1AD-4C60-BF02-9D09917976D7}"/>
+                <a16:creationId xmlns:a16="http://schemas.microsoft.com/office/drawing/2014/main" id="{19FA5B29-7CA4-40D0-AB8E-154E7B7BF47E}"/>
               </a:ext>
             </a:extLst>
           </p:cNvPr>
@@ -6759,7 +6688,7 @@
           <p:cNvPr id="18" name="">
             <a:extLst xmlns:a="http://schemas.openxmlformats.org/drawingml/2006/main">
               <a:ext uri="{FF2B5EF4-FFF2-40B4-BE49-F238E27FC236}">
-                <a16:creationId xmlns:a16="http://schemas.microsoft.com/office/drawing/2014/main" id="{51314204-048F-4E66-B598-A74FAC496733}"/>
+                <a16:creationId xmlns:a16="http://schemas.microsoft.com/office/drawing/2014/main" id="{7EEA9DA3-B42A-4F8B-9275-CEDA759A01C8}"/>
               </a:ext>
             </a:extLst>
           </p:cNvPr>
@@ -6804,7 +6733,7 @@
           <p:cNvPr id="19" name="">
             <a:extLst xmlns:a="http://schemas.openxmlformats.org/drawingml/2006/main">
               <a:ext uri="{FF2B5EF4-FFF2-40B4-BE49-F238E27FC236}">
-                <a16:creationId xmlns:a16="http://schemas.microsoft.com/office/drawing/2014/main" id="{B9C2E3C3-FB5E-4FB1-B306-D9E8517DB507}"/>
+                <a16:creationId xmlns:a16="http://schemas.microsoft.com/office/drawing/2014/main" id="{25271499-F614-4B83-B68F-31DACDF7884E}"/>
               </a:ext>
             </a:extLst>
           </p:cNvPr>
@@ -6847,7 +6776,7 @@
     </p:spTree>
     <p:extLst>
       <p:ext uri="{BB962C8B-B14F-4D97-AF65-F5344CB8AC3E}">
-        <p14:creationId xmlns:p14="http://schemas.microsoft.com/office/powerpoint/2010/main" val="1528795321"/>
+        <p14:creationId xmlns:p14="http://schemas.microsoft.com/office/powerpoint/2010/main" val="1607201243"/>
       </p:ext>
     </p:extLst>
   </p:cSld>
@@ -6878,7 +6807,7 @@
           <p:cNvPr id="12" name="">
             <a:extLst xmlns:a="http://schemas.openxmlformats.org/drawingml/2006/main">
               <a:ext uri="{FF2B5EF4-FFF2-40B4-BE49-F238E27FC236}">
-                <a16:creationId xmlns:a16="http://schemas.microsoft.com/office/drawing/2014/main" id="{EBA7ABF9-2AD1-47CD-9CAB-C9CE105819F4}"/>
+                <a16:creationId xmlns:a16="http://schemas.microsoft.com/office/drawing/2014/main" id="{B4FD0BD3-6996-4639-8A1D-EB5A76675B57}"/>
               </a:ext>
             </a:extLst>
           </p:cNvPr>
@@ -6923,7 +6852,7 @@
           <p:cNvPr id="2" name="">
             <a:extLst xmlns:a="http://schemas.openxmlformats.org/drawingml/2006/main">
               <a:ext uri="{FF2B5EF4-FFF2-40B4-BE49-F238E27FC236}">
-                <a16:creationId xmlns:a16="http://schemas.microsoft.com/office/drawing/2014/main" id="{179ECFBB-92C2-48E8-9B84-ED0D296306B0}"/>
+                <a16:creationId xmlns:a16="http://schemas.microsoft.com/office/drawing/2014/main" id="{AA3C9BAE-0470-4426-9EE5-9976A7FD53B2}"/>
               </a:ext>
             </a:extLst>
           </p:cNvPr>
@@ -6953,7 +6882,7 @@
           <p:cNvPr id="3" name="">
             <a:extLst xmlns:a="http://schemas.openxmlformats.org/drawingml/2006/main">
               <a:ext uri="{FF2B5EF4-FFF2-40B4-BE49-F238E27FC236}">
-                <a16:creationId xmlns:a16="http://schemas.microsoft.com/office/drawing/2014/main" id="{83612117-4188-458D-AB79-7137E10A561C}"/>
+                <a16:creationId xmlns:a16="http://schemas.microsoft.com/office/drawing/2014/main" id="{061FEC70-0253-4305-991C-CF81F50818DF}"/>
               </a:ext>
             </a:extLst>
           </p:cNvPr>
@@ -6998,7 +6927,7 @@
           <p:cNvPr id="4" name="Chart">
             <a:extLst xmlns:a="http://schemas.openxmlformats.org/drawingml/2006/main">
               <a:ext uri="{FF2B5EF4-FFF2-40B4-BE49-F238E27FC236}">
-                <a16:creationId xmlns:a16="http://schemas.microsoft.com/office/drawing/2014/main" id="{AA574F3A-6FF9-4372-A48F-250DA3FEDCDA}"/>
+                <a16:creationId xmlns:a16="http://schemas.microsoft.com/office/drawing/2014/main" id="{FC6B9114-AFFD-4524-BD48-23076938FBA8}"/>
               </a:ext>
             </a:extLst>
           </p:cNvPr>
@@ -7011,7 +6940,7 @@
         </p:xfrm>
         <a:graphic xmlns:a="http://schemas.openxmlformats.org/drawingml/2006/main">
           <a:graphicData uri="http://schemas.openxmlformats.org/drawingml/2006/chart">
-            <c:chart xmlns:r="http://schemas.openxmlformats.org/officeDocument/2006/relationships" xmlns:c="http://schemas.openxmlformats.org/drawingml/2006/chart" r:id="Rdb300c96411e4f99"/>
+            <c:chart xmlns:r="http://schemas.openxmlformats.org/officeDocument/2006/relationships" xmlns:c="http://schemas.openxmlformats.org/drawingml/2006/chart" r:id="Rbb89b224dab84d2b"/>
           </a:graphicData>
         </a:graphic>
       </p:graphicFrame>
@@ -7020,7 +6949,7 @@
           <p:cNvPr id="5" name="">
             <a:extLst xmlns:a="http://schemas.openxmlformats.org/drawingml/2006/main">
               <a:ext uri="{FF2B5EF4-FFF2-40B4-BE49-F238E27FC236}">
-                <a16:creationId xmlns:a16="http://schemas.microsoft.com/office/drawing/2014/main" id="{E82AA022-DDDC-411E-ADBB-0EA5AE7F5C90}"/>
+                <a16:creationId xmlns:a16="http://schemas.microsoft.com/office/drawing/2014/main" id="{9C3467F5-23A2-4F84-BDED-2FED58166F5C}"/>
               </a:ext>
             </a:extLst>
           </p:cNvPr>
@@ -7065,7 +6994,7 @@
           <p:cNvPr id="6" name="">
             <a:extLst xmlns:a="http://schemas.openxmlformats.org/drawingml/2006/main">
               <a:ext uri="{FF2B5EF4-FFF2-40B4-BE49-F238E27FC236}">
-                <a16:creationId xmlns:a16="http://schemas.microsoft.com/office/drawing/2014/main" id="{21B12F02-1E9D-454D-90FC-4122BC982F82}"/>
+                <a16:creationId xmlns:a16="http://schemas.microsoft.com/office/drawing/2014/main" id="{1B0F6BAA-DCF8-4B8F-9FB7-D7C240FA1C50}"/>
               </a:ext>
             </a:extLst>
           </p:cNvPr>
@@ -7110,7 +7039,7 @@
           <p:cNvPr id="7" name="">
             <a:extLst xmlns:a="http://schemas.openxmlformats.org/drawingml/2006/main">
               <a:ext uri="{FF2B5EF4-FFF2-40B4-BE49-F238E27FC236}">
-                <a16:creationId xmlns:a16="http://schemas.microsoft.com/office/drawing/2014/main" id="{F9D493FE-5893-4AF8-80B1-EBA8A58DF817}"/>
+                <a16:creationId xmlns:a16="http://schemas.microsoft.com/office/drawing/2014/main" id="{E09DDAA4-71F3-4A95-9FDB-AABCCAEB3758}"/>
               </a:ext>
             </a:extLst>
           </p:cNvPr>
@@ -7155,7 +7084,7 @@
           <p:cNvPr id="8" name="">
             <a:extLst xmlns:a="http://schemas.openxmlformats.org/drawingml/2006/main">
               <a:ext uri="{FF2B5EF4-FFF2-40B4-BE49-F238E27FC236}">
-                <a16:creationId xmlns:a16="http://schemas.microsoft.com/office/drawing/2014/main" id="{9660D510-FB88-4302-80FA-F103418C3224}"/>
+                <a16:creationId xmlns:a16="http://schemas.microsoft.com/office/drawing/2014/main" id="{3C4BB3D4-D7A5-45C8-B9A8-D4ECC61BEA6D}"/>
               </a:ext>
             </a:extLst>
           </p:cNvPr>
@@ -7200,7 +7129,7 @@
           <p:cNvPr id="9" name="">
             <a:extLst xmlns:a="http://schemas.openxmlformats.org/drawingml/2006/main">
               <a:ext uri="{FF2B5EF4-FFF2-40B4-BE49-F238E27FC236}">
-                <a16:creationId xmlns:a16="http://schemas.microsoft.com/office/drawing/2014/main" id="{EB4B689A-EC6C-4462-8B9A-6A93C35BD122}"/>
+                <a16:creationId xmlns:a16="http://schemas.microsoft.com/office/drawing/2014/main" id="{396602B1-4208-4B1D-8FAB-F6B968D70B2E}"/>
               </a:ext>
             </a:extLst>
           </p:cNvPr>
@@ -7245,7 +7174,7 @@
           <p:cNvPr id="10" name="">
             <a:extLst xmlns:a="http://schemas.openxmlformats.org/drawingml/2006/main">
               <a:ext uri="{FF2B5EF4-FFF2-40B4-BE49-F238E27FC236}">
-                <a16:creationId xmlns:a16="http://schemas.microsoft.com/office/drawing/2014/main" id="{19C14D4A-AFE3-42C0-8B14-B7B09830F502}"/>
+                <a16:creationId xmlns:a16="http://schemas.microsoft.com/office/drawing/2014/main" id="{F92915DC-2DD3-4445-BE5D-DBA91A4377DF}"/>
               </a:ext>
             </a:extLst>
           </p:cNvPr>
@@ -7290,7 +7219,7 @@
           <p:cNvPr id="11" name="">
             <a:extLst xmlns:a="http://schemas.openxmlformats.org/drawingml/2006/main">
               <a:ext uri="{FF2B5EF4-FFF2-40B4-BE49-F238E27FC236}">
-                <a16:creationId xmlns:a16="http://schemas.microsoft.com/office/drawing/2014/main" id="{90725BF8-3A7A-4797-B3F0-ECD7D0FAF606}"/>
+                <a16:creationId xmlns:a16="http://schemas.microsoft.com/office/drawing/2014/main" id="{31CBAD2F-220B-4AEC-B4C6-DCB18FB43BAA}"/>
               </a:ext>
             </a:extLst>
           </p:cNvPr>
@@ -7333,7 +7262,7 @@
     </p:spTree>
     <p:extLst>
       <p:ext uri="{BB962C8B-B14F-4D97-AF65-F5344CB8AC3E}">
-        <p14:creationId xmlns:p14="http://schemas.microsoft.com/office/powerpoint/2010/main" val="1011385261"/>
+        <p14:creationId xmlns:p14="http://schemas.microsoft.com/office/powerpoint/2010/main" val="1731156891"/>
       </p:ext>
     </p:extLst>
   </p:cSld>
@@ -7364,7 +7293,7 @@
           <p:cNvPr id="8" name="">
             <a:extLst xmlns:a="http://schemas.openxmlformats.org/drawingml/2006/main">
               <a:ext uri="{FF2B5EF4-FFF2-40B4-BE49-F238E27FC236}">
-                <a16:creationId xmlns:a16="http://schemas.microsoft.com/office/drawing/2014/main" id="{7BCFC477-6F35-4ED5-A7D6-D01B1B2C7126}"/>
+                <a16:creationId xmlns:a16="http://schemas.microsoft.com/office/drawing/2014/main" id="{08BFE412-7F47-4F91-BF73-5100F7A5DB2D}"/>
               </a:ext>
             </a:extLst>
           </p:cNvPr>
@@ -7409,7 +7338,7 @@
           <p:cNvPr id="2" name="">
             <a:extLst xmlns:a="http://schemas.openxmlformats.org/drawingml/2006/main">
               <a:ext uri="{FF2B5EF4-FFF2-40B4-BE49-F238E27FC236}">
-                <a16:creationId xmlns:a16="http://schemas.microsoft.com/office/drawing/2014/main" id="{4D4195D6-956B-4022-B8FF-EFAD6B57982B}"/>
+                <a16:creationId xmlns:a16="http://schemas.microsoft.com/office/drawing/2014/main" id="{E8B9B8F0-1276-4BB2-A12B-0B727B8761B2}"/>
               </a:ext>
             </a:extLst>
           </p:cNvPr>
@@ -7439,7 +7368,7 @@
           <p:cNvPr id="3" name="">
             <a:extLst xmlns:a="http://schemas.openxmlformats.org/drawingml/2006/main">
               <a:ext uri="{FF2B5EF4-FFF2-40B4-BE49-F238E27FC236}">
-                <a16:creationId xmlns:a16="http://schemas.microsoft.com/office/drawing/2014/main" id="{5BDC7ADE-99E4-4099-8DB9-F1AC5E697145}"/>
+                <a16:creationId xmlns:a16="http://schemas.microsoft.com/office/drawing/2014/main" id="{A976E25F-9C52-46F9-91A6-57FE23A2944A}"/>
               </a:ext>
             </a:extLst>
           </p:cNvPr>
@@ -7484,7 +7413,7 @@
           <p:cNvPr id="4" name="">
             <a:extLst xmlns:a="http://schemas.openxmlformats.org/drawingml/2006/main">
               <a:ext uri="{FF2B5EF4-FFF2-40B4-BE49-F238E27FC236}">
-                <a16:creationId xmlns:a16="http://schemas.microsoft.com/office/drawing/2014/main" id="{026F19FD-188F-4757-9FA6-213822D9F1A8}"/>
+                <a16:creationId xmlns:a16="http://schemas.microsoft.com/office/drawing/2014/main" id="{016DEF2C-66CE-4915-8C2B-29379EB1676B}"/>
               </a:ext>
             </a:extLst>
           </p:cNvPr>
@@ -7504,14 +7433,14 @@
                 <a:gridCol w="3714750"/>
                 <a:gridCol w="4019550"/>
               </a:tblGrid>
-              <a:tr h="641985">
+              <a:tr h="534988">
                 <a:tc>
                   <a:txBody>
                     <a:bodyPr/>
                     <a:lstStyle/>
                     <a:p>
                       <a:r>
-                        <a:rPr sz="2025" b="1">
+                        <a:rPr sz="1875" b="1">
                           <a:solidFill>
                             <a:srgbClr val="FFFFFF"/>
                           </a:solidFill>
@@ -7559,7 +7488,7 @@
                     <a:lstStyle/>
                     <a:p>
                       <a:r>
-                        <a:rPr sz="2025" b="1">
+                        <a:rPr sz="1875" b="1">
                           <a:solidFill>
                             <a:srgbClr val="FFFFFF"/>
                           </a:solidFill>
@@ -7601,7 +7530,7 @@
                     <a:lstStyle/>
                     <a:p>
                       <a:r>
-                        <a:rPr sz="2025" b="1">
+                        <a:rPr sz="1875" b="1">
                           <a:solidFill>
                             <a:srgbClr val="FFFFFF"/>
                           </a:solidFill>
@@ -7638,14 +7567,14 @@
                   </a:tcPr>
                 </a:tc>
               </a:tr>
-              <a:tr h="641985">
+              <a:tr h="534988">
                 <a:tc>
                   <a:txBody>
                     <a:bodyPr/>
                     <a:lstStyle/>
                     <a:p>
                       <a:r>
-                        <a:rPr sz="2025" b="0">
+                        <a:rPr sz="1875" b="0">
                           <a:solidFill>
                             <a:srgbClr val="152D43"/>
                           </a:solidFill>
@@ -7687,7 +7616,7 @@
                     <a:lstStyle/>
                     <a:p>
                       <a:r>
-                        <a:rPr sz="2025" b="0">
+                        <a:rPr sz="1875" b="0">
                           <a:solidFill>
                             <a:srgbClr val="152D43"/>
                           </a:solidFill>
@@ -7723,7 +7652,7 @@
                     <a:lstStyle/>
                     <a:p>
                       <a:r>
-                        <a:rPr sz="2025" b="0">
+                        <a:rPr sz="1875" b="0">
                           <a:solidFill>
                             <a:srgbClr val="152D43"/>
                           </a:solidFill>
@@ -7754,14 +7683,14 @@
                   </a:tcPr>
                 </a:tc>
               </a:tr>
-              <a:tr h="641985">
+              <a:tr h="534988">
                 <a:tc>
                   <a:txBody>
                     <a:bodyPr/>
                     <a:lstStyle/>
                     <a:p>
                       <a:r>
-                        <a:rPr sz="2025" b="0">
+                        <a:rPr sz="1875" b="0">
                           <a:solidFill>
                             <a:srgbClr val="152D43"/>
                           </a:solidFill>
@@ -7803,7 +7732,7 @@
                     <a:lstStyle/>
                     <a:p>
                       <a:r>
-                        <a:rPr sz="2025" b="0">
+                        <a:rPr sz="1875" b="0">
                           <a:solidFill>
                             <a:srgbClr val="152D43"/>
                           </a:solidFill>
@@ -7839,7 +7768,7 @@
                     <a:lstStyle/>
                     <a:p>
                       <a:r>
-                        <a:rPr sz="2025" b="0">
+                        <a:rPr sz="1875" b="0">
                           <a:solidFill>
                             <a:srgbClr val="152D43"/>
                           </a:solidFill>
@@ -7870,14 +7799,14 @@
                   </a:tcPr>
                 </a:tc>
               </a:tr>
-              <a:tr h="641985">
+              <a:tr h="534988">
                 <a:tc>
                   <a:txBody>
                     <a:bodyPr/>
                     <a:lstStyle/>
                     <a:p>
                       <a:r>
-                        <a:rPr sz="2025" b="0">
+                        <a:rPr sz="1875" b="0">
                           <a:solidFill>
                             <a:srgbClr val="152D43"/>
                           </a:solidFill>
@@ -7919,7 +7848,7 @@
                     <a:lstStyle/>
                     <a:p>
                       <a:r>
-                        <a:rPr sz="2025" b="0">
+                        <a:rPr sz="1875" b="0">
                           <a:solidFill>
                             <a:srgbClr val="152D43"/>
                           </a:solidFill>
@@ -7955,7 +7884,7 @@
                     <a:lstStyle/>
                     <a:p>
                       <a:r>
-                        <a:rPr sz="2025" b="0">
+                        <a:rPr sz="1875" b="0">
                           <a:solidFill>
                             <a:srgbClr val="152D43"/>
                           </a:solidFill>
@@ -7986,14 +7915,14 @@
                   </a:tcPr>
                 </a:tc>
               </a:tr>
-              <a:tr h="641985">
+              <a:tr h="534988">
                 <a:tc>
                   <a:txBody>
                     <a:bodyPr/>
                     <a:lstStyle/>
                     <a:p>
                       <a:r>
-                        <a:rPr sz="2025" b="0">
+                        <a:rPr sz="1875" b="0">
                           <a:solidFill>
                             <a:srgbClr val="152D43"/>
                           </a:solidFill>
@@ -8035,7 +7964,7 @@
                     <a:lstStyle/>
                     <a:p>
                       <a:r>
-                        <a:rPr sz="2025" b="0">
+                        <a:rPr sz="1875" b="0">
                           <a:solidFill>
                             <a:srgbClr val="152D43"/>
                           </a:solidFill>
@@ -8071,7 +8000,7 @@
                     <a:lstStyle/>
                     <a:p>
                       <a:r>
-                        <a:rPr sz="2025" b="0">
+                        <a:rPr sz="1875" b="0">
                           <a:solidFill>
                             <a:srgbClr val="152D43"/>
                           </a:solidFill>
@@ -8102,6 +8031,122 @@
                   </a:tcPr>
                 </a:tc>
               </a:tr>
+              <a:tr h="534988">
+                <a:tc>
+                  <a:txBody>
+                    <a:bodyPr/>
+                    <a:lstStyle/>
+                    <a:p>
+                      <a:r>
+                        <a:rPr sz="1875" b="0">
+                          <a:solidFill>
+                            <a:srgbClr val="152D43"/>
+                          </a:solidFill>
+                          <a:latin typeface="Arial"/>
+                          <a:ea typeface="Arial"/>
+                          <a:cs typeface="Arial"/>
+                        </a:rPr>
+                        <a:t>Full</a:t>
+                      </a:r>
+                    </a:p>
+                  </a:txBody>
+                  <a:tcPr marL="91440" marR="91440" marT="45720" marB="45720">
+                    <a:lnL w="9525">
+                      <a:solidFill>
+                        <a:srgbClr val="D7DFE5"/>
+                      </a:solidFill>
+                      <a:prstDash val="solid"/>
+                    </a:lnL>
+                    <a:lnR w="9525">
+                      <a:solidFill>
+                        <a:srgbClr val="D7DFE5"/>
+                      </a:solidFill>
+                      <a:prstDash val="solid"/>
+                    </a:lnR>
+                    <a:lnB w="9525">
+                      <a:solidFill>
+                        <a:srgbClr val="D7DFE5"/>
+                      </a:solidFill>
+                      <a:prstDash val="solid"/>
+                    </a:lnB>
+                    <a:solidFill>
+                      <a:srgbClr val="FFFFFF"/>
+                    </a:solidFill>
+                  </a:tcPr>
+                </a:tc>
+                <a:tc>
+                  <a:txBody>
+                    <a:bodyPr/>
+                    <a:lstStyle/>
+                    <a:p>
+                      <a:r>
+                        <a:rPr sz="1875" b="0">
+                          <a:solidFill>
+                            <a:srgbClr val="152D43"/>
+                          </a:solidFill>
+                          <a:latin typeface="Arial"/>
+                          <a:ea typeface="Arial"/>
+                          <a:cs typeface="Arial"/>
+                        </a:rPr>
+                        <a:t>10.658 ms</a:t>
+                      </a:r>
+                    </a:p>
+                  </a:txBody>
+                  <a:tcPr marL="91440" marR="91440" marT="45720" marB="45720">
+                    <a:lnR w="9525">
+                      <a:solidFill>
+                        <a:srgbClr val="D7DFE5"/>
+                      </a:solidFill>
+                      <a:prstDash val="solid"/>
+                    </a:lnR>
+                    <a:lnB w="9525">
+                      <a:solidFill>
+                        <a:srgbClr val="D7DFE5"/>
+                      </a:solidFill>
+                      <a:prstDash val="solid"/>
+                    </a:lnB>
+                    <a:solidFill>
+                      <a:srgbClr val="FFFFFF"/>
+                    </a:solidFill>
+                  </a:tcPr>
+                </a:tc>
+                <a:tc>
+                  <a:txBody>
+                    <a:bodyPr/>
+                    <a:lstStyle/>
+                    <a:p>
+                      <a:r>
+                        <a:rPr sz="1875" b="0">
+                          <a:solidFill>
+                            <a:srgbClr val="152D43"/>
+                          </a:solidFill>
+                          <a:latin typeface="Arial"/>
+                          <a:ea typeface="Arial"/>
+                          <a:cs typeface="Arial"/>
+                        </a:rPr>
+                        <a:t>0.0000</a:t>
+                      </a:r>
+                    </a:p>
+                  </a:txBody>
+                  <a:tcPr marL="91440" marR="91440" marT="45720" marB="45720">
+                    <a:lnR w="9525">
+                      <a:solidFill>
+                        <a:srgbClr val="D7DFE5"/>
+                      </a:solidFill>
+                      <a:prstDash val="solid"/>
+                    </a:lnR>
+                    <a:lnB w="9525">
+                      <a:solidFill>
+                        <a:srgbClr val="D7DFE5"/>
+                      </a:solidFill>
+                      <a:prstDash val="solid"/>
+                    </a:lnB>
+                    <a:solidFill>
+                      <a:srgbClr val="FFFFFF"/>
+                    </a:solidFill>
+                  </a:tcPr>
+                </a:tc>
+              </a:tr>
             </a:tbl>
           </a:graphicData>
         </a:graphic>
@@ -8111,7 +8156,7 @@
           <p:cNvPr id="5" name="">
             <a:extLst xmlns:a="http://schemas.openxmlformats.org/drawingml/2006/main">
               <a:ext uri="{FF2B5EF4-FFF2-40B4-BE49-F238E27FC236}">
-                <a16:creationId xmlns:a16="http://schemas.microsoft.com/office/drawing/2014/main" id="{487942ED-0D28-4DC7-AB72-F95EC1BFCB0D}"/>
+                <a16:creationId xmlns:a16="http://schemas.microsoft.com/office/drawing/2014/main" id="{CC7AB6D2-FE42-4739-B92E-B2086815A08A}"/>
               </a:ext>
             </a:extLst>
           </p:cNvPr>
@@ -8156,7 +8201,7 @@
           <p:cNvPr id="6" name="">
             <a:extLst xmlns:a="http://schemas.openxmlformats.org/drawingml/2006/main">
               <a:ext uri="{FF2B5EF4-FFF2-40B4-BE49-F238E27FC236}">
-                <a16:creationId xmlns:a16="http://schemas.microsoft.com/office/drawing/2014/main" id="{2E77EBE6-E15A-4EAA-A2BF-9ADF1EE8DC8C}"/>
+                <a16:creationId xmlns:a16="http://schemas.microsoft.com/office/drawing/2014/main" id="{10C3B9F4-CDB0-469C-8D12-3869C6A0446B}"/>
               </a:ext>
             </a:extLst>
           </p:cNvPr>
@@ -8201,7 +8246,7 @@
           <p:cNvPr id="7" name="">
             <a:extLst xmlns:a="http://schemas.openxmlformats.org/drawingml/2006/main">
               <a:ext uri="{FF2B5EF4-FFF2-40B4-BE49-F238E27FC236}">
-                <a16:creationId xmlns:a16="http://schemas.microsoft.com/office/drawing/2014/main" id="{1BC46B50-141F-4DB7-9812-526CCA6F1615}"/>
+                <a16:creationId xmlns:a16="http://schemas.microsoft.com/office/drawing/2014/main" id="{A92A9CD6-A9B9-489A-9EFB-6630EEC715D4}"/>
               </a:ext>
             </a:extLst>
           </p:cNvPr>
@@ -8244,606 +8289,7 @@
     </p:spTree>
     <p:extLst>
       <p:ext uri="{BB962C8B-B14F-4D97-AF65-F5344CB8AC3E}">
-        <p14:creationId xmlns:p14="http://schemas.microsoft.com/office/powerpoint/2010/main" val="690856604"/>
-      </p:ext>
-    </p:extLst>
-  </p:cSld>
-</p:sld>
-</file>
-
-<file path=ppt/slides/slide7.xml><?xml version="1.0" encoding="utf-8"?>
-<p:sld xmlns:p="http://schemas.openxmlformats.org/presentationml/2006/main">
-  <p:cSld>
-    <p:bg>
-      <p:bgPr>
-        <a:solidFill xmlns:a="http://schemas.openxmlformats.org/drawingml/2006/main">
-          <a:srgbClr val="FFFFFF"/>
-        </a:solidFill>
-      </p:bgPr>
-    </p:bg>
-    <p:spTree>
-      <p:nvGrpSpPr>
-        <p:cNvPr id="1" name=""/>
-        <p:cNvGrpSpPr/>
-        <p:nvPr/>
-      </p:nvGrpSpPr>
-      <p:grpSpPr>
-        <a:xfrm xmlns:a="http://schemas.openxmlformats.org/drawingml/2006/main"/>
-      </p:grpSpPr>
-      <p:sp>
-        <p:nvSpPr>
-          <p:cNvPr id="14" name="">
-            <a:extLst xmlns:a="http://schemas.openxmlformats.org/drawingml/2006/main">
-              <a:ext uri="{FF2B5EF4-FFF2-40B4-BE49-F238E27FC236}">
-                <a16:creationId xmlns:a16="http://schemas.microsoft.com/office/drawing/2014/main" id="{BCCE9A48-1D6E-4A83-9CA1-8CFE400186B1}"/>
-              </a:ext>
-            </a:extLst>
-          </p:cNvPr>
-          <p:cNvSpPr>
-            <a:spLocks xmlns:a="http://schemas.openxmlformats.org/drawingml/2006/main" noGrp="1"/>
-          </p:cNvSpPr>
-          <p:nvPr/>
-        </p:nvSpPr>
-        <p:spPr>
-          <a:xfrm xmlns:a="http://schemas.openxmlformats.org/drawingml/2006/main">
-            <a:off x="609600" y="381000"/>
-            <a:ext cx="10906125" cy="628650"/>
-          </a:xfrm>
-          <a:prstGeom xmlns:a="http://schemas.openxmlformats.org/drawingml/2006/main" prst="rect">
-            <a:avLst/>
-          </a:prstGeom>
-          <a:noFill xmlns:a="http://schemas.openxmlformats.org/drawingml/2006/main"/>
-          <a:ln xmlns:a="http://schemas.openxmlformats.org/drawingml/2006/main" w="0">
-            <a:noFill/>
-          </a:ln>
-        </p:spPr>
-        <p:txBody>
-          <a:bodyPr xmlns:a="http://schemas.openxmlformats.org/drawingml/2006/main" lIns="0" tIns="0" rIns="0" bIns="0"/>
-          <a:lstStyle xmlns:a="http://schemas.openxmlformats.org/drawingml/2006/main"/>
-          <a:p xmlns:a="http://schemas.openxmlformats.org/drawingml/2006/main">
-            <a:r>
-              <a:rPr sz="3150" b="1">
-                <a:solidFill>
-                  <a:srgbClr val="152D43"/>
-                </a:solidFill>
-                <a:latin typeface="Arial"/>
-                <a:ea typeface="Arial"/>
-                <a:cs typeface="Arial"/>
-              </a:rPr>
-              <a:t>Next: measure deadline behavior under jitter</a:t>
-            </a:r>
-          </a:p>
-        </p:txBody>
-      </p:sp>
-      <p:sp>
-        <p:nvSpPr>
-          <p:cNvPr id="2" name="">
-            <a:extLst xmlns:a="http://schemas.openxmlformats.org/drawingml/2006/main">
-              <a:ext uri="{FF2B5EF4-FFF2-40B4-BE49-F238E27FC236}">
-                <a16:creationId xmlns:a16="http://schemas.microsoft.com/office/drawing/2014/main" id="{E066C3A2-BB63-4190-B0FA-9FA817E0AFA4}"/>
-              </a:ext>
-            </a:extLst>
-          </p:cNvPr>
-          <p:cNvSpPr>
-            <a:spLocks xmlns:a="http://schemas.openxmlformats.org/drawingml/2006/main" noGrp="1"/>
-          </p:cNvSpPr>
-          <p:nvPr/>
-        </p:nvSpPr>
-        <p:spPr>
-          <a:xfrm xmlns:a="http://schemas.openxmlformats.org/drawingml/2006/main">
-            <a:off x="609600" y="1162050"/>
-            <a:ext cx="10972800" cy="0"/>
-          </a:xfrm>
-          <a:prstGeom xmlns:a="http://schemas.openxmlformats.org/drawingml/2006/main" prst="line">
-            <a:avLst/>
-          </a:prstGeom>
-          <a:noFill xmlns:a="http://schemas.openxmlformats.org/drawingml/2006/main"/>
-          <a:ln xmlns:a="http://schemas.openxmlformats.org/drawingml/2006/main" w="9525">
-            <a:solidFill>
-              <a:srgbClr val="D7DFE5"/>
-            </a:solidFill>
-          </a:ln>
-        </p:spPr>
-      </p:sp>
-      <p:sp>
-        <p:nvSpPr>
-          <p:cNvPr id="3" name="">
-            <a:extLst xmlns:a="http://schemas.openxmlformats.org/drawingml/2006/main">
-              <a:ext uri="{FF2B5EF4-FFF2-40B4-BE49-F238E27FC236}">
-                <a16:creationId xmlns:a16="http://schemas.microsoft.com/office/drawing/2014/main" id="{0B304B32-2D64-4CBA-8EDC-36675DF42308}"/>
-              </a:ext>
-            </a:extLst>
-          </p:cNvPr>
-          <p:cNvSpPr>
-            <a:spLocks xmlns:a="http://schemas.openxmlformats.org/drawingml/2006/main" noGrp="1"/>
-          </p:cNvSpPr>
-          <p:nvPr/>
-        </p:nvSpPr>
-        <p:spPr>
-          <a:xfrm xmlns:a="http://schemas.openxmlformats.org/drawingml/2006/main">
-            <a:off x="11353800" y="6429375"/>
-            <a:ext cx="285750" cy="228600"/>
-          </a:xfrm>
-          <a:prstGeom xmlns:a="http://schemas.openxmlformats.org/drawingml/2006/main" prst="rect">
-            <a:avLst/>
-          </a:prstGeom>
-          <a:noFill xmlns:a="http://schemas.openxmlformats.org/drawingml/2006/main"/>
-          <a:ln xmlns:a="http://schemas.openxmlformats.org/drawingml/2006/main" w="0">
-            <a:noFill/>
-          </a:ln>
-        </p:spPr>
-        <p:txBody>
-          <a:bodyPr xmlns:a="http://schemas.openxmlformats.org/drawingml/2006/main" lIns="0" tIns="0" rIns="0" bIns="0"/>
-          <a:lstStyle xmlns:a="http://schemas.openxmlformats.org/drawingml/2006/main"/>
-          <a:p xmlns:a="http://schemas.openxmlformats.org/drawingml/2006/main">
-            <a:r>
-              <a:rPr sz="1275" b="0">
-                <a:solidFill>
-                  <a:srgbClr val="536675"/>
-                </a:solidFill>
-                <a:latin typeface="Arial"/>
-                <a:ea typeface="Arial"/>
-                <a:cs typeface="Arial"/>
-              </a:rPr>
-              <a:t>7</a:t>
-            </a:r>
-          </a:p>
-        </p:txBody>
-      </p:sp>
-      <p:sp>
-        <p:nvSpPr>
-          <p:cNvPr id="4" name="">
-            <a:extLst xmlns:a="http://schemas.openxmlformats.org/drawingml/2006/main">
-              <a:ext uri="{FF2B5EF4-FFF2-40B4-BE49-F238E27FC236}">
-                <a16:creationId xmlns:a16="http://schemas.microsoft.com/office/drawing/2014/main" id="{1B4A34E0-79F6-4E96-B5BF-794DB4C20077}"/>
-              </a:ext>
-            </a:extLst>
-          </p:cNvPr>
-          <p:cNvSpPr>
-            <a:spLocks xmlns:a="http://schemas.openxmlformats.org/drawingml/2006/main" noGrp="1"/>
-          </p:cNvSpPr>
-          <p:nvPr/>
-        </p:nvSpPr>
-        <p:spPr>
-          <a:xfrm xmlns:a="http://schemas.openxmlformats.org/drawingml/2006/main">
-            <a:off x="628650" y="1704975"/>
-            <a:ext cx="571500" cy="571500"/>
-          </a:xfrm>
-          <a:prstGeom xmlns:a="http://schemas.openxmlformats.org/drawingml/2006/main" prst="rect">
-            <a:avLst/>
-          </a:prstGeom>
-          <a:noFill xmlns:a="http://schemas.openxmlformats.org/drawingml/2006/main"/>
-          <a:ln xmlns:a="http://schemas.openxmlformats.org/drawingml/2006/main" w="0">
-            <a:noFill/>
-          </a:ln>
-        </p:spPr>
-        <p:txBody>
-          <a:bodyPr xmlns:a="http://schemas.openxmlformats.org/drawingml/2006/main" lIns="0" tIns="0" rIns="0" bIns="0"/>
-          <a:lstStyle xmlns:a="http://schemas.openxmlformats.org/drawingml/2006/main"/>
-          <a:p xmlns:a="http://schemas.openxmlformats.org/drawingml/2006/main">
-            <a:r>
-              <a:rPr sz="3000" b="1">
-                <a:solidFill>
-                  <a:srgbClr val="086B93"/>
-                </a:solidFill>
-                <a:latin typeface="Arial"/>
-                <a:ea typeface="Arial"/>
-                <a:cs typeface="Arial"/>
-              </a:rPr>
-              <a:t>1</a:t>
-            </a:r>
-          </a:p>
-        </p:txBody>
-      </p:sp>
-      <p:sp>
-        <p:nvSpPr>
-          <p:cNvPr id="5" name="">
-            <a:extLst xmlns:a="http://schemas.openxmlformats.org/drawingml/2006/main">
-              <a:ext uri="{FF2B5EF4-FFF2-40B4-BE49-F238E27FC236}">
-                <a16:creationId xmlns:a16="http://schemas.microsoft.com/office/drawing/2014/main" id="{6435A1F5-991A-4360-89DD-23A7EBDC4942}"/>
-              </a:ext>
-            </a:extLst>
-          </p:cNvPr>
-          <p:cNvSpPr>
-            <a:spLocks xmlns:a="http://schemas.openxmlformats.org/drawingml/2006/main" noGrp="1"/>
-          </p:cNvSpPr>
-          <p:nvPr/>
-        </p:nvSpPr>
-        <p:spPr>
-          <a:xfrm xmlns:a="http://schemas.openxmlformats.org/drawingml/2006/main">
-            <a:off x="1333500" y="1704975"/>
-            <a:ext cx="10001250" cy="457200"/>
-          </a:xfrm>
-          <a:prstGeom xmlns:a="http://schemas.openxmlformats.org/drawingml/2006/main" prst="rect">
-            <a:avLst/>
-          </a:prstGeom>
-          <a:noFill xmlns:a="http://schemas.openxmlformats.org/drawingml/2006/main"/>
-          <a:ln xmlns:a="http://schemas.openxmlformats.org/drawingml/2006/main" w="0">
-            <a:noFill/>
-          </a:ln>
-        </p:spPr>
-        <p:txBody>
-          <a:bodyPr xmlns:a="http://schemas.openxmlformats.org/drawingml/2006/main" lIns="0" tIns="0" rIns="0" bIns="0"/>
-          <a:lstStyle xmlns:a="http://schemas.openxmlformats.org/drawingml/2006/main"/>
-          <a:p xmlns:a="http://schemas.openxmlformats.org/drawingml/2006/main">
-            <a:r>
-              <a:rPr sz="2400" b="1">
-                <a:solidFill>
-                  <a:srgbClr val="152D43"/>
-                </a:solidFill>
-                <a:latin typeface="Arial"/>
-                <a:ea typeface="Arial"/>
-                <a:cs typeface="Arial"/>
-              </a:rPr>
-              <a:t>Record the actual per-frame budget</a:t>
-            </a:r>
-          </a:p>
-        </p:txBody>
-      </p:sp>
-      <p:sp>
-        <p:nvSpPr>
-          <p:cNvPr id="6" name="">
-            <a:extLst xmlns:a="http://schemas.openxmlformats.org/drawingml/2006/main">
-              <a:ext uri="{FF2B5EF4-FFF2-40B4-BE49-F238E27FC236}">
-                <a16:creationId xmlns:a16="http://schemas.microsoft.com/office/drawing/2014/main" id="{DDFEC6B9-CCA3-4EB7-B161-5D6AEEA42041}"/>
-              </a:ext>
-            </a:extLst>
-          </p:cNvPr>
-          <p:cNvSpPr>
-            <a:spLocks xmlns:a="http://schemas.openxmlformats.org/drawingml/2006/main" noGrp="1"/>
-          </p:cNvSpPr>
-          <p:nvPr/>
-        </p:nvSpPr>
-        <p:spPr>
-          <a:xfrm xmlns:a="http://schemas.openxmlformats.org/drawingml/2006/main">
-            <a:off x="1333500" y="2247900"/>
-            <a:ext cx="9953625" cy="457200"/>
-          </a:xfrm>
-          <a:prstGeom xmlns:a="http://schemas.openxmlformats.org/drawingml/2006/main" prst="rect">
-            <a:avLst/>
-          </a:prstGeom>
-          <a:noFill xmlns:a="http://schemas.openxmlformats.org/drawingml/2006/main"/>
-          <a:ln xmlns:a="http://schemas.openxmlformats.org/drawingml/2006/main" w="0">
-            <a:noFill/>
-          </a:ln>
-        </p:spPr>
-        <p:txBody>
-          <a:bodyPr xmlns:a="http://schemas.openxmlformats.org/drawingml/2006/main" lIns="0" tIns="0" rIns="0" bIns="0"/>
-          <a:lstStyle xmlns:a="http://schemas.openxmlformats.org/drawingml/2006/main"/>
-          <a:p xmlns:a="http://schemas.openxmlformats.org/drawingml/2006/main">
-            <a:r>
-              <a:rPr sz="2025" b="0">
-                <a:solidFill>
-                  <a:srgbClr val="536675"/>
-                </a:solidFill>
-                <a:latin typeface="Arial"/>
-                <a:ea typeface="Arial"/>
-                <a:cs typeface="Arial"/>
-              </a:rPr>
-              <a:t>Log arrival, decode completion, and display deadline. Reserve display time and a margin.</a:t>
-            </a:r>
-          </a:p>
-        </p:txBody>
-      </p:sp>
-      <p:sp>
-        <p:nvSpPr>
-          <p:cNvPr id="7" name="">
-            <a:extLst xmlns:a="http://schemas.openxmlformats.org/drawingml/2006/main">
-              <a:ext uri="{FF2B5EF4-FFF2-40B4-BE49-F238E27FC236}">
-                <a16:creationId xmlns:a16="http://schemas.microsoft.com/office/drawing/2014/main" id="{AF24A686-9EEC-4FAC-BB2C-EBD8850C1157}"/>
-              </a:ext>
-            </a:extLst>
-          </p:cNvPr>
-          <p:cNvSpPr>
-            <a:spLocks xmlns:a="http://schemas.openxmlformats.org/drawingml/2006/main" noGrp="1"/>
-          </p:cNvSpPr>
-          <p:nvPr/>
-        </p:nvSpPr>
-        <p:spPr>
-          <a:xfrm xmlns:a="http://schemas.openxmlformats.org/drawingml/2006/main">
-            <a:off x="628650" y="3000375"/>
-            <a:ext cx="571500" cy="571500"/>
-          </a:xfrm>
-          <a:prstGeom xmlns:a="http://schemas.openxmlformats.org/drawingml/2006/main" prst="rect">
-            <a:avLst/>
-          </a:prstGeom>
-          <a:noFill xmlns:a="http://schemas.openxmlformats.org/drawingml/2006/main"/>
-          <a:ln xmlns:a="http://schemas.openxmlformats.org/drawingml/2006/main" w="0">
-            <a:noFill/>
-          </a:ln>
-        </p:spPr>
-        <p:txBody>
-          <a:bodyPr xmlns:a="http://schemas.openxmlformats.org/drawingml/2006/main" lIns="0" tIns="0" rIns="0" bIns="0"/>
-          <a:lstStyle xmlns:a="http://schemas.openxmlformats.org/drawingml/2006/main"/>
-          <a:p xmlns:a="http://schemas.openxmlformats.org/drawingml/2006/main">
-            <a:r>
-              <a:rPr sz="3000" b="1">
-                <a:solidFill>
-                  <a:srgbClr val="086B93"/>
-                </a:solidFill>
-                <a:latin typeface="Arial"/>
-                <a:ea typeface="Arial"/>
-                <a:cs typeface="Arial"/>
-              </a:rPr>
-              <a:t>2</a:t>
-            </a:r>
-          </a:p>
-        </p:txBody>
-      </p:sp>
-      <p:sp>
-        <p:nvSpPr>
-          <p:cNvPr id="8" name="">
-            <a:extLst xmlns:a="http://schemas.openxmlformats.org/drawingml/2006/main">
-              <a:ext uri="{FF2B5EF4-FFF2-40B4-BE49-F238E27FC236}">
-                <a16:creationId xmlns:a16="http://schemas.microsoft.com/office/drawing/2014/main" id="{AAA565A7-980A-48D4-9D35-431B15588789}"/>
-              </a:ext>
-            </a:extLst>
-          </p:cNvPr>
-          <p:cNvSpPr>
-            <a:spLocks xmlns:a="http://schemas.openxmlformats.org/drawingml/2006/main" noGrp="1"/>
-          </p:cNvSpPr>
-          <p:nvPr/>
-        </p:nvSpPr>
-        <p:spPr>
-          <a:xfrm xmlns:a="http://schemas.openxmlformats.org/drawingml/2006/main">
-            <a:off x="1333500" y="3000375"/>
-            <a:ext cx="10001250" cy="457200"/>
-          </a:xfrm>
-          <a:prstGeom xmlns:a="http://schemas.openxmlformats.org/drawingml/2006/main" prst="rect">
-            <a:avLst/>
-          </a:prstGeom>
-          <a:noFill xmlns:a="http://schemas.openxmlformats.org/drawingml/2006/main"/>
-          <a:ln xmlns:a="http://schemas.openxmlformats.org/drawingml/2006/main" w="0">
-            <a:noFill/>
-          </a:ln>
-        </p:spPr>
-        <p:txBody>
-          <a:bodyPr xmlns:a="http://schemas.openxmlformats.org/drawingml/2006/main" lIns="0" tIns="0" rIns="0" bIns="0"/>
-          <a:lstStyle xmlns:a="http://schemas.openxmlformats.org/drawingml/2006/main"/>
-          <a:p xmlns:a="http://schemas.openxmlformats.org/drawingml/2006/main">
-            <a:r>
-              <a:rPr sz="2400" b="1">
-                <a:solidFill>
-                  <a:srgbClr val="152D43"/>
-                </a:solidFill>
-                <a:latin typeface="Arial"/>
-                <a:ea typeface="Arial"/>
-                <a:cs typeface="Arial"/>
-              </a:rPr>
-              <a:t>Implement budget-based ROI selection</a:t>
-            </a:r>
-          </a:p>
-        </p:txBody>
-      </p:sp>
-      <p:sp>
-        <p:nvSpPr>
-          <p:cNvPr id="9" name="">
-            <a:extLst xmlns:a="http://schemas.openxmlformats.org/drawingml/2006/main">
-              <a:ext uri="{FF2B5EF4-FFF2-40B4-BE49-F238E27FC236}">
-                <a16:creationId xmlns:a16="http://schemas.microsoft.com/office/drawing/2014/main" id="{77268D79-0BF4-489D-B449-E059BC7792FA}"/>
-              </a:ext>
-            </a:extLst>
-          </p:cNvPr>
-          <p:cNvSpPr>
-            <a:spLocks xmlns:a="http://schemas.openxmlformats.org/drawingml/2006/main" noGrp="1"/>
-          </p:cNvSpPr>
-          <p:nvPr/>
-        </p:nvSpPr>
-        <p:spPr>
-          <a:xfrm xmlns:a="http://schemas.openxmlformats.org/drawingml/2006/main">
-            <a:off x="1333500" y="3543300"/>
-            <a:ext cx="9953625" cy="457200"/>
-          </a:xfrm>
-          <a:prstGeom xmlns:a="http://schemas.openxmlformats.org/drawingml/2006/main" prst="rect">
-            <a:avLst/>
-          </a:prstGeom>
-          <a:noFill xmlns:a="http://schemas.openxmlformats.org/drawingml/2006/main"/>
-          <a:ln xmlns:a="http://schemas.openxmlformats.org/drawingml/2006/main" w="0">
-            <a:noFill/>
-          </a:ln>
-        </p:spPr>
-        <p:txBody>
-          <a:bodyPr xmlns:a="http://schemas.openxmlformats.org/drawingml/2006/main" lIns="0" tIns="0" rIns="0" bIns="0"/>
-          <a:lstStyle xmlns:a="http://schemas.openxmlformats.org/drawingml/2006/main"/>
-          <a:p xmlns:a="http://schemas.openxmlformats.org/drawingml/2006/main">
-            <a:r>
-              <a:rPr sz="2025" b="0">
-                <a:solidFill>
-                  <a:srgbClr val="536675"/>
-                </a:solidFill>
-                <a:latin typeface="Arial"/>
-                <a:ea typeface="Arial"/>
-                <a:cs typeface="Arial"/>
-              </a:rPr>
-              <a:t>Build a percentile-based profile. Define a fallback when no level fits the budget.</a:t>
-            </a:r>
-          </a:p>
-        </p:txBody>
-      </p:sp>
-      <p:sp>
-        <p:nvSpPr>
-          <p:cNvPr id="10" name="">
-            <a:extLst xmlns:a="http://schemas.openxmlformats.org/drawingml/2006/main">
-              <a:ext uri="{FF2B5EF4-FFF2-40B4-BE49-F238E27FC236}">
-                <a16:creationId xmlns:a16="http://schemas.microsoft.com/office/drawing/2014/main" id="{435D6491-AFD1-4196-8FDB-A4F72CE74A6A}"/>
-              </a:ext>
-            </a:extLst>
-          </p:cNvPr>
-          <p:cNvSpPr>
-            <a:spLocks xmlns:a="http://schemas.openxmlformats.org/drawingml/2006/main" noGrp="1"/>
-          </p:cNvSpPr>
-          <p:nvPr/>
-        </p:nvSpPr>
-        <p:spPr>
-          <a:xfrm xmlns:a="http://schemas.openxmlformats.org/drawingml/2006/main">
-            <a:off x="628650" y="4295775"/>
-            <a:ext cx="571500" cy="571500"/>
-          </a:xfrm>
-          <a:prstGeom xmlns:a="http://schemas.openxmlformats.org/drawingml/2006/main" prst="rect">
-            <a:avLst/>
-          </a:prstGeom>
-          <a:noFill xmlns:a="http://schemas.openxmlformats.org/drawingml/2006/main"/>
-          <a:ln xmlns:a="http://schemas.openxmlformats.org/drawingml/2006/main" w="0">
-            <a:noFill/>
-          </a:ln>
-        </p:spPr>
-        <p:txBody>
-          <a:bodyPr xmlns:a="http://schemas.openxmlformats.org/drawingml/2006/main" lIns="0" tIns="0" rIns="0" bIns="0"/>
-          <a:lstStyle xmlns:a="http://schemas.openxmlformats.org/drawingml/2006/main"/>
-          <a:p xmlns:a="http://schemas.openxmlformats.org/drawingml/2006/main">
-            <a:r>
-              <a:rPr sz="3000" b="1">
-                <a:solidFill>
-                  <a:srgbClr val="086B93"/>
-                </a:solidFill>
-                <a:latin typeface="Arial"/>
-                <a:ea typeface="Arial"/>
-                <a:cs typeface="Arial"/>
-              </a:rPr>
-              <a:t>3</a:t>
-            </a:r>
-          </a:p>
-        </p:txBody>
-      </p:sp>
-      <p:sp>
-        <p:nvSpPr>
-          <p:cNvPr id="11" name="">
-            <a:extLst xmlns:a="http://schemas.openxmlformats.org/drawingml/2006/main">
-              <a:ext uri="{FF2B5EF4-FFF2-40B4-BE49-F238E27FC236}">
-                <a16:creationId xmlns:a16="http://schemas.microsoft.com/office/drawing/2014/main" id="{7752B160-2CA6-4869-A7FF-FB96C326714F}"/>
-              </a:ext>
-            </a:extLst>
-          </p:cNvPr>
-          <p:cNvSpPr>
-            <a:spLocks xmlns:a="http://schemas.openxmlformats.org/drawingml/2006/main" noGrp="1"/>
-          </p:cNvSpPr>
-          <p:nvPr/>
-        </p:nvSpPr>
-        <p:spPr>
-          <a:xfrm xmlns:a="http://schemas.openxmlformats.org/drawingml/2006/main">
-            <a:off x="1333500" y="4295775"/>
-            <a:ext cx="10001250" cy="457200"/>
-          </a:xfrm>
-          <a:prstGeom xmlns:a="http://schemas.openxmlformats.org/drawingml/2006/main" prst="rect">
-            <a:avLst/>
-          </a:prstGeom>
-          <a:noFill xmlns:a="http://schemas.openxmlformats.org/drawingml/2006/main"/>
-          <a:ln xmlns:a="http://schemas.openxmlformats.org/drawingml/2006/main" w="0">
-            <a:noFill/>
-          </a:ln>
-        </p:spPr>
-        <p:txBody>
-          <a:bodyPr xmlns:a="http://schemas.openxmlformats.org/drawingml/2006/main" lIns="0" tIns="0" rIns="0" bIns="0"/>
-          <a:lstStyle xmlns:a="http://schemas.openxmlformats.org/drawingml/2006/main"/>
-          <a:p xmlns:a="http://schemas.openxmlformats.org/drawingml/2006/main">
-            <a:r>
-              <a:rPr sz="2400" b="1">
-                <a:solidFill>
-                  <a:srgbClr val="152D43"/>
-                </a:solidFill>
-                <a:latin typeface="Arial"/>
-                <a:ea typeface="Arial"/>
-                <a:cs typeface="Arial"/>
-              </a:rPr>
-              <a:t>Compare fixed and adaptive policies on the same trace</a:t>
-            </a:r>
-          </a:p>
-        </p:txBody>
-      </p:sp>
-      <p:sp>
-        <p:nvSpPr>
-          <p:cNvPr id="12" name="">
-            <a:extLst xmlns:a="http://schemas.openxmlformats.org/drawingml/2006/main">
-              <a:ext uri="{FF2B5EF4-FFF2-40B4-BE49-F238E27FC236}">
-                <a16:creationId xmlns:a16="http://schemas.microsoft.com/office/drawing/2014/main" id="{BE51B4C8-AB44-4ECB-BE8A-9A1F98961A92}"/>
-              </a:ext>
-            </a:extLst>
-          </p:cNvPr>
-          <p:cNvSpPr>
-            <a:spLocks xmlns:a="http://schemas.openxmlformats.org/drawingml/2006/main" noGrp="1"/>
-          </p:cNvSpPr>
-          <p:nvPr/>
-        </p:nvSpPr>
-        <p:spPr>
-          <a:xfrm xmlns:a="http://schemas.openxmlformats.org/drawingml/2006/main">
-            <a:off x="1333500" y="4838700"/>
-            <a:ext cx="9953625" cy="457200"/>
-          </a:xfrm>
-          <a:prstGeom xmlns:a="http://schemas.openxmlformats.org/drawingml/2006/main" prst="rect">
-            <a:avLst/>
-          </a:prstGeom>
-          <a:noFill xmlns:a="http://schemas.openxmlformats.org/drawingml/2006/main"/>
-          <a:ln xmlns:a="http://schemas.openxmlformats.org/drawingml/2006/main" w="0">
-            <a:noFill/>
-          </a:ln>
-        </p:spPr>
-        <p:txBody>
-          <a:bodyPr xmlns:a="http://schemas.openxmlformats.org/drawingml/2006/main" lIns="0" tIns="0" rIns="0" bIns="0"/>
-          <a:lstStyle xmlns:a="http://schemas.openxmlformats.org/drawingml/2006/main"/>
-          <a:p xmlns:a="http://schemas.openxmlformats.org/drawingml/2006/main">
-            <a:r>
-              <a:rPr sz="2025" b="0">
-                <a:solidFill>
-                  <a:srgbClr val="536675"/>
-                </a:solidFill>
-                <a:latin typeface="Arial"/>
-                <a:ea typeface="Arial"/>
-                <a:cs typeface="Arial"/>
-              </a:rPr>
-              <a:t>Report deadline-miss rate, tail latency, and quality. Repeat runs to check stability.</a:t>
-            </a:r>
-          </a:p>
-        </p:txBody>
-      </p:sp>
-      <p:sp>
-        <p:nvSpPr>
-          <p:cNvPr id="13" name="">
-            <a:extLst xmlns:a="http://schemas.openxmlformats.org/drawingml/2006/main">
-              <a:ext uri="{FF2B5EF4-FFF2-40B4-BE49-F238E27FC236}">
-                <a16:creationId xmlns:a16="http://schemas.microsoft.com/office/drawing/2014/main" id="{C104C9E1-CBC9-4C84-881E-2AB654BF59D4}"/>
-              </a:ext>
-            </a:extLst>
-          </p:cNvPr>
-          <p:cNvSpPr>
-            <a:spLocks xmlns:a="http://schemas.openxmlformats.org/drawingml/2006/main" noGrp="1"/>
-          </p:cNvSpPr>
-          <p:nvPr/>
-        </p:nvSpPr>
-        <p:spPr>
-          <a:xfrm xmlns:a="http://schemas.openxmlformats.org/drawingml/2006/main">
-            <a:off x="609600" y="5924550"/>
-            <a:ext cx="10715625" cy="457200"/>
-          </a:xfrm>
-          <a:prstGeom xmlns:a="http://schemas.openxmlformats.org/drawingml/2006/main" prst="rect">
-            <a:avLst/>
-          </a:prstGeom>
-          <a:noFill xmlns:a="http://schemas.openxmlformats.org/drawingml/2006/main"/>
-          <a:ln xmlns:a="http://schemas.openxmlformats.org/drawingml/2006/main" w="0">
-            <a:noFill/>
-          </a:ln>
-        </p:spPr>
-        <p:txBody>
-          <a:bodyPr xmlns:a="http://schemas.openxmlformats.org/drawingml/2006/main" lIns="0" tIns="0" rIns="0" bIns="0"/>
-          <a:lstStyle xmlns:a="http://schemas.openxmlformats.org/drawingml/2006/main"/>
-          <a:p xmlns:a="http://schemas.openxmlformats.org/drawingml/2006/main">
-            <a:r>
-              <a:rPr sz="1500" b="0">
-                <a:solidFill>
-                  <a:srgbClr val="536675"/>
-                </a:solidFill>
-                <a:latin typeface="Arial"/>
-                <a:ea typeface="Arial"/>
-                <a:cs typeface="Arial"/>
-              </a:rPr>
-              <a:t>Measured: fixed-center quality–latency levels. Adaptive scheduling and benefits under jitter still require validation.</a:t>
-            </a:r>
-          </a:p>
-        </p:txBody>
-      </p:sp>
-    </p:spTree>
-    <p:extLst>
-      <p:ext uri="{BB962C8B-B14F-4D97-AF65-F5344CB8AC3E}">
-        <p14:creationId xmlns:p14="http://schemas.microsoft.com/office/powerpoint/2010/main" val="326408459"/>
+        <p14:creationId xmlns:p14="http://schemas.microsoft.com/office/powerpoint/2010/main" val="1769713570"/>
       </p:ext>
     </p:extLst>
   </p:cSld>

</xml_diff>